<commit_message>
Match desktop permissions guide to Full access and Auto screenshots
</commit_message>
<xml_diff>
--- a/docs/job-search-guide.pptx
+++ b/docs/job-search-guide.pptx
@@ -2,23 +2,24 @@
 <file path=ppt/presentation.xml><?xml version="1.0" encoding="utf-8"?>
 <p:presentation xmlns:p="http://schemas.openxmlformats.org/presentationml/2006/main">
   <p:sldMasterIdLst>
-    <p:sldMasterId xmlns:r="http://schemas.openxmlformats.org/officeDocument/2006/relationships" id="2147483648" r:id="R8abff3a307ab4107"/>
+    <p:sldMasterId xmlns:r="http://schemas.openxmlformats.org/officeDocument/2006/relationships" id="2147483648" r:id="R9b863e83e9024369"/>
   </p:sldMasterIdLst>
   <p:notesMasterIdLst>
-    <p:notesMasterId xmlns:r="http://schemas.openxmlformats.org/officeDocument/2006/relationships" r:id="R4bf09b07081b4fe0"/>
+    <p:notesMasterId xmlns:r="http://schemas.openxmlformats.org/officeDocument/2006/relationships" r:id="R2d042347b3fa4aa1"/>
   </p:notesMasterIdLst>
   <p:sldIdLst>
-    <p:sldId xmlns:r="http://schemas.openxmlformats.org/officeDocument/2006/relationships" id="256" r:id="Re14bd334d4454f29"/>
-    <p:sldId xmlns:r="http://schemas.openxmlformats.org/officeDocument/2006/relationships" id="257" r:id="R49e51aa84f464766"/>
-    <p:sldId xmlns:r="http://schemas.openxmlformats.org/officeDocument/2006/relationships" id="258" r:id="R37219602f1c04cc0"/>
-    <p:sldId xmlns:r="http://schemas.openxmlformats.org/officeDocument/2006/relationships" id="259" r:id="R9652a2b1610f4e3f"/>
-    <p:sldId xmlns:r="http://schemas.openxmlformats.org/officeDocument/2006/relationships" id="260" r:id="Rf7a22a87e2ff4594"/>
-    <p:sldId xmlns:r="http://schemas.openxmlformats.org/officeDocument/2006/relationships" id="261" r:id="Rd18811ad23224291"/>
-    <p:sldId xmlns:r="http://schemas.openxmlformats.org/officeDocument/2006/relationships" id="262" r:id="Rdd1786d93e04464d"/>
-    <p:sldId xmlns:r="http://schemas.openxmlformats.org/officeDocument/2006/relationships" id="263" r:id="R2dfffb3172734a46"/>
-    <p:sldId xmlns:r="http://schemas.openxmlformats.org/officeDocument/2006/relationships" id="264" r:id="R1537002b9bdc4ebf"/>
-    <p:sldId xmlns:r="http://schemas.openxmlformats.org/officeDocument/2006/relationships" id="265" r:id="R7e483fbd1d114a37"/>
-    <p:sldId xmlns:r="http://schemas.openxmlformats.org/officeDocument/2006/relationships" id="266" r:id="R5f279a5cc4fa4cea"/>
+    <p:sldId xmlns:r="http://schemas.openxmlformats.org/officeDocument/2006/relationships" id="256" r:id="R73a96bba9de14c44"/>
+    <p:sldId xmlns:r="http://schemas.openxmlformats.org/officeDocument/2006/relationships" id="257" r:id="R09df6c3f644041cf"/>
+    <p:sldId xmlns:r="http://schemas.openxmlformats.org/officeDocument/2006/relationships" id="258" r:id="R4a94cdf16eea498f"/>
+    <p:sldId xmlns:r="http://schemas.openxmlformats.org/officeDocument/2006/relationships" id="259" r:id="R455b80a7e6c7453c"/>
+    <p:sldId xmlns:r="http://schemas.openxmlformats.org/officeDocument/2006/relationships" id="260" r:id="R244827bae3964145"/>
+    <p:sldId xmlns:r="http://schemas.openxmlformats.org/officeDocument/2006/relationships" id="261" r:id="R2d5014fccf5040f4"/>
+    <p:sldId xmlns:r="http://schemas.openxmlformats.org/officeDocument/2006/relationships" id="262" r:id="R00535d3b82634759"/>
+    <p:sldId xmlns:r="http://schemas.openxmlformats.org/officeDocument/2006/relationships" id="263" r:id="R030aa0021d164acb"/>
+    <p:sldId xmlns:r="http://schemas.openxmlformats.org/officeDocument/2006/relationships" id="264" r:id="R60318c25d96443ef"/>
+    <p:sldId xmlns:r="http://schemas.openxmlformats.org/officeDocument/2006/relationships" id="265" r:id="Rfa3962f9aca94706"/>
+    <p:sldId xmlns:r="http://schemas.openxmlformats.org/officeDocument/2006/relationships" id="266" r:id="R26856ed701dc4504"/>
+    <p:sldId xmlns:r="http://schemas.openxmlformats.org/officeDocument/2006/relationships" id="267" r:id="R8e85f092da0c40d1"/>
   </p:sldIdLst>
   <p:sldSz cx="12192000" cy="6858000"/>
   <p:notesSz cx="6858000" cy="9144000"/>
@@ -647,6 +648,86 @@
 </p:notes>
 </file>
 
+<file path=ppt/notesSlides/notesSlide12.xml><?xml version="1.0" encoding="utf-8"?>
+<p:notes xmlns:p="http://schemas.openxmlformats.org/presentationml/2006/main">
+  <p:cSld>
+    <p:spTree>
+      <p:nvGrpSpPr>
+        <p:cNvPr id="1" name=""/>
+        <p:cNvGrpSpPr/>
+        <p:nvPr/>
+      </p:nvGrpSpPr>
+      <p:grpSpPr>
+        <a:xfrm xmlns:a="http://schemas.openxmlformats.org/drawingml/2006/main"/>
+      </p:grpSpPr>
+      <p:sp>
+        <p:nvSpPr>
+          <p:cNvPr id="2" name="Slide Image Placeholder 1"/>
+          <p:cNvSpPr>
+            <a:spLocks xmlns:a="http://schemas.openxmlformats.org/drawingml/2006/main" noGrp="1"/>
+          </p:cNvSpPr>
+          <p:nvPr>
+            <p:ph type="sldImg" idx="0"/>
+          </p:nvPr>
+        </p:nvSpPr>
+        <p:spPr/>
+      </p:sp>
+      <p:sp>
+        <p:nvSpPr>
+          <p:cNvPr id="3" name="Notes Placeholder 2"/>
+          <p:cNvSpPr>
+            <a:spLocks xmlns:a="http://schemas.openxmlformats.org/drawingml/2006/main" noGrp="1"/>
+          </p:cNvSpPr>
+          <p:nvPr>
+            <p:ph type="body" idx="1"/>
+          </p:nvPr>
+        </p:nvSpPr>
+        <p:spPr/>
+        <p:txBody>
+          <a:bodyPr xmlns:a="http://schemas.openxmlformats.org/drawingml/2006/main"/>
+          <a:lstStyle xmlns:a="http://schemas.openxmlformats.org/drawingml/2006/main"/>
+          <a:p xmlns:a="http://schemas.openxmlformats.org/drawingml/2006/main">
+            <a:r>
+              <a:t/>
+            </a:r>
+          </a:p>
+          <a:p xmlns:a="http://schemas.openxmlformats.org/drawingml/2006/main">
+            <a:r>
+              <a:t>Workflow source: https://github.com/toughdave/job-search</a:t>
+            </a:r>
+          </a:p>
+          <a:p xmlns:a="http://schemas.openxmlformats.org/drawingml/2006/main">
+            <a:r>
+              <a:t>Guide checked 12 September 2026.</a:t>
+            </a:r>
+          </a:p>
+        </p:txBody>
+      </p:sp>
+      <p:sp>
+        <p:nvSpPr>
+          <p:cNvPr id="4" name="Slide Number Placeholder 3"/>
+          <p:cNvSpPr>
+            <a:spLocks xmlns:a="http://schemas.openxmlformats.org/drawingml/2006/main" noGrp="1"/>
+          </p:cNvSpPr>
+          <p:nvPr>
+            <p:ph type="sldNum" idx="5"/>
+          </p:nvPr>
+        </p:nvSpPr>
+        <p:spPr/>
+        <p:txBody>
+          <a:bodyPr xmlns:a="http://schemas.openxmlformats.org/drawingml/2006/main"/>
+          <a:lstStyle xmlns:a="http://schemas.openxmlformats.org/drawingml/2006/main"/>
+          <a:p xmlns:a="http://schemas.openxmlformats.org/drawingml/2006/main"/>
+        </p:txBody>
+      </p:sp>
+    </p:spTree>
+  </p:cSld>
+  <p:clrMapOvr>
+    <a:masterClrMapping xmlns:a="http://schemas.openxmlformats.org/drawingml/2006/main"/>
+  </p:clrMapOvr>
+</p:notes>
+</file>
+
 <file path=ppt/notesSlides/notesSlide2.xml><?xml version="1.0" encoding="utf-8"?>
 <p:notes xmlns:p="http://schemas.openxmlformats.org/presentationml/2006/main">
   <p:cSld>
@@ -952,12 +1033,7 @@
           </a:p>
           <a:p xmlns:a="http://schemas.openxmlformats.org/drawingml/2006/main">
             <a:r>
-              <a:t>https://code.claude.com/docs/en/desktop#choose-a-permission-mode</a:t>
-            </a:r>
-          </a:p>
-          <a:p xmlns:a="http://schemas.openxmlformats.org/drawingml/2006/main">
-            <a:r>
-              <a:t>https://learn.chatgpt.com/docs/windows/windows-app#download-the-chatgpt-desktop-app</a:t>
+              <a:t>Screenshot supplied by the repository owner: docs/images/codex-permissions.png</a:t>
             </a:r>
           </a:p>
           <a:p xmlns:a="http://schemas.openxmlformats.org/drawingml/2006/main">
@@ -1037,7 +1113,12 @@
           <a:lstStyle xmlns:a="http://schemas.openxmlformats.org/drawingml/2006/main"/>
           <a:p xmlns:a="http://schemas.openxmlformats.org/drawingml/2006/main">
             <a:r>
-              <a:t/>
+              <a:t>https://code.claude.com/docs/en/desktop#choose-a-permission-mode</a:t>
+            </a:r>
+          </a:p>
+          <a:p xmlns:a="http://schemas.openxmlformats.org/drawingml/2006/main">
+            <a:r>
+              <a:t>Screenshot supplied by the repository owner: docs/images/claude-permissions.png</a:t>
             </a:r>
           </a:p>
           <a:p xmlns:a="http://schemas.openxmlformats.org/drawingml/2006/main">
@@ -1355,7 +1436,7 @@
   </p:cSld>
   <p:clrMap bg1="lt1" tx1="dk1" bg2="lt2" tx2="dk2" accent1="accent1" accent2="accent2" accent3="accent3" accent4="accent4" accent5="accent5" accent6="accent6" hlink="hlink" folHlink="folHlink"/>
   <p:sldLayoutIdLst>
-    <p:sldLayoutId xmlns:r="http://schemas.openxmlformats.org/officeDocument/2006/relationships" id="2147483649" r:id="Re869708f10504d7c"/>
+    <p:sldLayoutId xmlns:r="http://schemas.openxmlformats.org/officeDocument/2006/relationships" id="2147483649" r:id="R83ff074c86904eff"/>
   </p:sldLayoutIdLst>
   <p:txStyles>
     <p:titleStyle>
@@ -1906,7 +1987,7 @@
           <p:cNvPr id="5" name="">
             <a:extLst xmlns:a="http://schemas.openxmlformats.org/drawingml/2006/main">
               <a:ext uri="{FF2B5EF4-FFF2-40B4-BE49-F238E27FC236}">
-                <a16:creationId xmlns:a16="http://schemas.microsoft.com/office/drawing/2014/main" id="{C9B19532-29B0-4839-8B7F-F148766ED776}"/>
+                <a16:creationId xmlns:a16="http://schemas.microsoft.com/office/drawing/2014/main" id="{8EF9DC22-1083-456E-B0A2-5154D879F56B}"/>
               </a:ext>
             </a:extLst>
           </p:cNvPr>
@@ -1963,7 +2044,7 @@
           <p:cNvPr id="2" name="">
             <a:extLst xmlns:a="http://schemas.openxmlformats.org/drawingml/2006/main">
               <a:ext uri="{FF2B5EF4-FFF2-40B4-BE49-F238E27FC236}">
-                <a16:creationId xmlns:a16="http://schemas.microsoft.com/office/drawing/2014/main" id="{CEA2F7F2-1996-43F2-8CC6-460EC947B8B7}"/>
+                <a16:creationId xmlns:a16="http://schemas.microsoft.com/office/drawing/2014/main" id="{AA246F9C-B72E-48F9-AB87-290BB1FACD8C}"/>
               </a:ext>
             </a:extLst>
           </p:cNvPr>
@@ -2020,7 +2101,7 @@
           <p:cNvPr id="3" name="">
             <a:extLst xmlns:a="http://schemas.openxmlformats.org/drawingml/2006/main">
               <a:ext uri="{FF2B5EF4-FFF2-40B4-BE49-F238E27FC236}">
-                <a16:creationId xmlns:a16="http://schemas.microsoft.com/office/drawing/2014/main" id="{BF5B07C8-1E03-4BC6-884D-A77B0F816BC0}"/>
+                <a16:creationId xmlns:a16="http://schemas.microsoft.com/office/drawing/2014/main" id="{107D48B1-3A5B-47F1-832F-8FFD21D9012B}"/>
               </a:ext>
             </a:extLst>
           </p:cNvPr>
@@ -2100,7 +2181,7 @@
           <p:cNvPr id="4" name="">
             <a:extLst xmlns:a="http://schemas.openxmlformats.org/drawingml/2006/main">
               <a:ext uri="{FF2B5EF4-FFF2-40B4-BE49-F238E27FC236}">
-                <a16:creationId xmlns:a16="http://schemas.microsoft.com/office/drawing/2014/main" id="{A9C76A22-07E6-4D6D-8429-FA1E6ABC9350}"/>
+                <a16:creationId xmlns:a16="http://schemas.microsoft.com/office/drawing/2014/main" id="{C64E9C3F-8956-4C51-B51A-A1593413340C}"/>
               </a:ext>
             </a:extLst>
           </p:cNvPr>
@@ -2146,7 +2227,7 @@
                 <a:latin typeface="Arial"/>
                 <a:ea typeface="Arial"/>
                 <a:cs typeface="Arial"/>
-                <a:hlinkClick xmlns:r="http://schemas.openxmlformats.org/officeDocument/2006/relationships" r:id="Reb075f18be1c4c3b"/>
+                <a:hlinkClick xmlns:r="http://schemas.openxmlformats.org/officeDocument/2006/relationships" r:id="R6101db6dc191453d"/>
               </a:rPr>
               <a:t>Open the GitHub guide</a:t>
             </a:r>
@@ -2156,7 +2237,7 @@
     </p:spTree>
     <p:extLst>
       <p:ext uri="{BB962C8B-B14F-4D97-AF65-F5344CB8AC3E}">
-        <p14:creationId xmlns:p14="http://schemas.microsoft.com/office/powerpoint/2010/main" val="1899013464"/>
+        <p14:creationId xmlns:p14="http://schemas.microsoft.com/office/powerpoint/2010/main" val="1968043505"/>
       </p:ext>
     </p:extLst>
   </p:cSld>
@@ -2187,7 +2268,7 @@
           <p:cNvPr id="7" name="">
             <a:extLst xmlns:a="http://schemas.openxmlformats.org/drawingml/2006/main">
               <a:ext uri="{FF2B5EF4-FFF2-40B4-BE49-F238E27FC236}">
-                <a16:creationId xmlns:a16="http://schemas.microsoft.com/office/drawing/2014/main" id="{AF854FFD-3035-425D-84AA-67160B02C3EF}"/>
+                <a16:creationId xmlns:a16="http://schemas.microsoft.com/office/drawing/2014/main" id="{9C9216BC-6A22-4CB6-8382-0AD2787CAE01}"/>
               </a:ext>
             </a:extLst>
           </p:cNvPr>
@@ -2234,7 +2315,7 @@
                 <a:ea typeface="Arial"/>
                 <a:cs typeface="Arial"/>
               </a:rPr>
-              <a:t>6. Next time</a:t>
+              <a:t>5. Your first draft</a:t>
             </a:r>
           </a:p>
         </p:txBody>
@@ -2244,7 +2325,7 @@
           <p:cNvPr id="2" name="">
             <a:extLst xmlns:a="http://schemas.openxmlformats.org/drawingml/2006/main">
               <a:ext uri="{FF2B5EF4-FFF2-40B4-BE49-F238E27FC236}">
-                <a16:creationId xmlns:a16="http://schemas.microsoft.com/office/drawing/2014/main" id="{656F0254-D682-4F8A-A85A-C78190CD0732}"/>
+                <a16:creationId xmlns:a16="http://schemas.microsoft.com/office/drawing/2014/main" id="{B1EE6C74-3C41-4428-ACBB-D4BCEFA81BBF}"/>
               </a:ext>
             </a:extLst>
           </p:cNvPr>
@@ -2301,7 +2382,7 @@
           <p:cNvPr id="3" name="">
             <a:extLst xmlns:a="http://schemas.openxmlformats.org/drawingml/2006/main">
               <a:ext uri="{FF2B5EF4-FFF2-40B4-BE49-F238E27FC236}">
-                <a16:creationId xmlns:a16="http://schemas.microsoft.com/office/drawing/2014/main" id="{CA342B9E-46D0-4D42-AC16-F2A23169F5CB}"/>
+                <a16:creationId xmlns:a16="http://schemas.microsoft.com/office/drawing/2014/main" id="{AB16394E-FF53-4E0E-A8CA-9CE24FD6A70B}"/>
               </a:ext>
             </a:extLst>
           </p:cNvPr>
@@ -2312,8 +2393,8 @@
         </p:nvSpPr>
         <p:spPr>
           <a:xfrm xmlns:a="http://schemas.openxmlformats.org/drawingml/2006/main">
-            <a:off x="609600" y="1466850"/>
-            <a:ext cx="10820400" cy="752475"/>
+            <a:off x="609600" y="1476375"/>
+            <a:ext cx="10820400" cy="1019175"/>
           </a:xfrm>
           <a:prstGeom xmlns:a="http://schemas.openxmlformats.org/drawingml/2006/main" prst="rect">
             <a:avLst/>
@@ -2348,7 +2429,30 @@
                 <a:ea typeface="Arial"/>
                 <a:cs typeface="Arial"/>
               </a:rPr>
-              <a:t>Reopen the same local project and conversation. Send:</a:t>
+              <a:t>When enough is known, the AI prepares useful documents</a:t>
+            </a:r>
+          </a:p>
+          <a:p xmlns:a="http://schemas.openxmlformats.org/drawingml/2006/main">
+            <a:pPr>
+              <a:defRPr sz="2250" b="0">
+                <a:solidFill>
+                  <a:srgbClr val="283A39"/>
+                </a:solidFill>
+                <a:latin typeface="Arial"/>
+                <a:ea typeface="Arial"/>
+                <a:cs typeface="Arial"/>
+              </a:defRPr>
+            </a:pPr>
+            <a:r>
+              <a:rPr sz="2250" b="0">
+                <a:solidFill>
+                  <a:srgbClr val="283A39"/>
+                </a:solidFill>
+                <a:latin typeface="Arial"/>
+                <a:ea typeface="Arial"/>
+                <a:cs typeface="Arial"/>
+              </a:rPr>
+              <a:t>and keeps your search records in a separate private location.</a:t>
             </a:r>
           </a:p>
         </p:txBody>
@@ -2358,7 +2462,7 @@
           <p:cNvPr id="4" name="">
             <a:extLst xmlns:a="http://schemas.openxmlformats.org/drawingml/2006/main">
               <a:ext uri="{FF2B5EF4-FFF2-40B4-BE49-F238E27FC236}">
-                <a16:creationId xmlns:a16="http://schemas.microsoft.com/office/drawing/2014/main" id="{8A4FDEA8-C7B2-4C49-B9F9-267C43E75B5D}"/>
+                <a16:creationId xmlns:a16="http://schemas.microsoft.com/office/drawing/2014/main" id="{D6D916EE-66C6-482C-A46D-10E1FF1BDBB8}"/>
               </a:ext>
             </a:extLst>
           </p:cNvPr>
@@ -2369,8 +2473,8 @@
         </p:nvSpPr>
         <p:spPr>
           <a:xfrm xmlns:a="http://schemas.openxmlformats.org/drawingml/2006/main">
-            <a:off x="609600" y="2828925"/>
-            <a:ext cx="10858500" cy="819150"/>
+            <a:off x="609600" y="3162300"/>
+            <a:ext cx="10820400" cy="1009650"/>
           </a:xfrm>
           <a:prstGeom xmlns:a="http://schemas.openxmlformats.org/drawingml/2006/main" prst="rect">
             <a:avLst/>
@@ -2387,25 +2491,48 @@
           <a:lstStyle xmlns:a="http://schemas.openxmlformats.org/drawingml/2006/main"/>
           <a:p xmlns:a="http://schemas.openxmlformats.org/drawingml/2006/main">
             <a:pPr>
-              <a:defRPr sz="3675" b="1">
-                <a:solidFill>
-                  <a:srgbClr val="183F3B"/>
-                </a:solidFill>
-                <a:latin typeface="Arial"/>
-                <a:ea typeface="Arial"/>
-                <a:cs typeface="Arial"/>
-              </a:defRPr>
-            </a:pPr>
-            <a:r>
-              <a:rPr sz="3675" b="1">
-                <a:solidFill>
-                  <a:srgbClr val="183F3B"/>
-                </a:solidFill>
-                <a:latin typeface="Arial"/>
-                <a:ea typeface="Arial"/>
-                <a:cs typeface="Arial"/>
-              </a:rPr>
-              <a:t>Continue my job search.</a:t>
+              <a:defRPr sz="2250" b="0">
+                <a:solidFill>
+                  <a:srgbClr val="283A39"/>
+                </a:solidFill>
+                <a:latin typeface="Arial"/>
+                <a:ea typeface="Arial"/>
+                <a:cs typeface="Arial"/>
+              </a:defRPr>
+            </a:pPr>
+            <a:r>
+              <a:rPr sz="2250" b="0">
+                <a:solidFill>
+                  <a:srgbClr val="283A39"/>
+                </a:solidFill>
+                <a:latin typeface="Arial"/>
+                <a:ea typeface="Arial"/>
+                <a:cs typeface="Arial"/>
+              </a:rPr>
+              <a:t>Open the files and check your experience, dates and contact details.</a:t>
+            </a:r>
+          </a:p>
+          <a:p xmlns:a="http://schemas.openxmlformats.org/drawingml/2006/main">
+            <a:pPr>
+              <a:defRPr sz="2250" b="0">
+                <a:solidFill>
+                  <a:srgbClr val="283A39"/>
+                </a:solidFill>
+                <a:latin typeface="Arial"/>
+                <a:ea typeface="Arial"/>
+                <a:cs typeface="Arial"/>
+              </a:defRPr>
+            </a:pPr>
+            <a:r>
+              <a:rPr sz="2250" b="0">
+                <a:solidFill>
+                  <a:srgbClr val="283A39"/>
+                </a:solidFill>
+                <a:latin typeface="Arial"/>
+                <a:ea typeface="Arial"/>
+                <a:cs typeface="Arial"/>
+              </a:rPr>
+              <a:t>Give corrections in the conversation.</a:t>
             </a:r>
           </a:p>
         </p:txBody>
@@ -2415,7 +2542,7 @@
           <p:cNvPr id="5" name="">
             <a:extLst xmlns:a="http://schemas.openxmlformats.org/drawingml/2006/main">
               <a:ext uri="{FF2B5EF4-FFF2-40B4-BE49-F238E27FC236}">
-                <a16:creationId xmlns:a16="http://schemas.microsoft.com/office/drawing/2014/main" id="{43DF58E3-798E-46C7-A714-7DCBC98D58E4}"/>
+                <a16:creationId xmlns:a16="http://schemas.microsoft.com/office/drawing/2014/main" id="{CE57F339-638E-4B61-A88D-6AC42053C01D}"/>
               </a:ext>
             </a:extLst>
           </p:cNvPr>
@@ -2426,8 +2553,8 @@
         </p:nvSpPr>
         <p:spPr>
           <a:xfrm xmlns:a="http://schemas.openxmlformats.org/drawingml/2006/main">
-            <a:off x="609600" y="4286250"/>
-            <a:ext cx="10858500" cy="952500"/>
+            <a:off x="609600" y="4714875"/>
+            <a:ext cx="10858500" cy="552450"/>
           </a:xfrm>
           <a:prstGeom xmlns:a="http://schemas.openxmlformats.org/drawingml/2006/main" prst="rect">
             <a:avLst/>
@@ -2444,48 +2571,25 @@
           <a:lstStyle xmlns:a="http://schemas.openxmlformats.org/drawingml/2006/main"/>
           <a:p xmlns:a="http://schemas.openxmlformats.org/drawingml/2006/main">
             <a:pPr>
-              <a:defRPr sz="2100" b="0">
-                <a:solidFill>
-                  <a:srgbClr val="283A39"/>
-                </a:solidFill>
-                <a:latin typeface="Arial"/>
-                <a:ea typeface="Arial"/>
-                <a:cs typeface="Arial"/>
-              </a:defRPr>
-            </a:pPr>
-            <a:r>
-              <a:rPr sz="2100" b="0">
-                <a:solidFill>
-                  <a:srgbClr val="283A39"/>
-                </a:solidFill>
-                <a:latin typeface="Arial"/>
-                <a:ea typeface="Arial"/>
-                <a:cs typeface="Arial"/>
-              </a:rPr>
-              <a:t>You usually do not reinstall or attach the same resume again.</a:t>
-            </a:r>
-          </a:p>
-          <a:p xmlns:a="http://schemas.openxmlformats.org/drawingml/2006/main">
-            <a:pPr>
-              <a:defRPr sz="2100" b="0">
-                <a:solidFill>
-                  <a:srgbClr val="283A39"/>
-                </a:solidFill>
-                <a:latin typeface="Arial"/>
-                <a:ea typeface="Arial"/>
-                <a:cs typeface="Arial"/>
-              </a:defRPr>
-            </a:pPr>
-            <a:r>
-              <a:rPr sz="2100" b="0">
-                <a:solidFill>
-                  <a:srgbClr val="283A39"/>
-                </a:solidFill>
-                <a:latin typeface="Arial"/>
-                <a:ea typeface="Arial"/>
-                <a:cs typeface="Arial"/>
-              </a:rPr>
-              <a:t>Supply an updated resume when it changes.</a:t>
+              <a:defRPr sz="2550" b="1">
+                <a:solidFill>
+                  <a:srgbClr val="183F3B"/>
+                </a:solidFill>
+                <a:latin typeface="Arial"/>
+                <a:ea typeface="Arial"/>
+                <a:cs typeface="Arial"/>
+              </a:defRPr>
+            </a:pPr>
+            <a:r>
+              <a:rPr sz="2550" b="1">
+                <a:solidFill>
+                  <a:srgbClr val="183F3B"/>
+                </a:solidFill>
+                <a:latin typeface="Arial"/>
+                <a:ea typeface="Arial"/>
+                <a:cs typeface="Arial"/>
+              </a:rPr>
+              <a:t>“That role was volunteering. Please correct it.”</a:t>
             </a:r>
           </a:p>
         </p:txBody>
@@ -2495,7 +2599,7 @@
           <p:cNvPr id="6" name="">
             <a:extLst xmlns:a="http://schemas.openxmlformats.org/drawingml/2006/main">
               <a:ext uri="{FF2B5EF4-FFF2-40B4-BE49-F238E27FC236}">
-                <a16:creationId xmlns:a16="http://schemas.microsoft.com/office/drawing/2014/main" id="{03832477-93A7-49D6-BF33-F509C862FE9D}"/>
+                <a16:creationId xmlns:a16="http://schemas.microsoft.com/office/drawing/2014/main" id="{D9501BD8-A216-4000-9AB0-442692F40FC3}"/>
               </a:ext>
             </a:extLst>
           </p:cNvPr>
@@ -2506,8 +2610,8 @@
         </p:nvSpPr>
         <p:spPr>
           <a:xfrm xmlns:a="http://schemas.openxmlformats.org/drawingml/2006/main">
-            <a:off x="609600" y="5781675"/>
-            <a:ext cx="10858500" cy="495300"/>
+            <a:off x="609600" y="5829300"/>
+            <a:ext cx="10858500" cy="400050"/>
           </a:xfrm>
           <a:prstGeom xmlns:a="http://schemas.openxmlformats.org/drawingml/2006/main" prst="rect">
             <a:avLst/>
@@ -2542,7 +2646,7 @@
                 <a:ea typeface="Arial"/>
                 <a:cs typeface="Arial"/>
               </a:rPr>
-              <a:t>For an independent occupation search, use a new project with separate records.</a:t>
+              <a:t>Review the employer and final documents before authorizing a submission.</a:t>
             </a:r>
           </a:p>
         </p:txBody>
@@ -2550,7 +2654,7 @@
     </p:spTree>
     <p:extLst>
       <p:ext uri="{BB962C8B-B14F-4D97-AF65-F5344CB8AC3E}">
-        <p14:creationId xmlns:p14="http://schemas.microsoft.com/office/powerpoint/2010/main" val="280143670"/>
+        <p14:creationId xmlns:p14="http://schemas.microsoft.com/office/powerpoint/2010/main" val="1806265174"/>
       </p:ext>
     </p:extLst>
   </p:cSld>
@@ -2578,10 +2682,10 @@
       </p:grpSpPr>
       <p:sp>
         <p:nvSpPr>
-          <p:cNvPr id="10" name="">
+          <p:cNvPr id="7" name="">
             <a:extLst xmlns:a="http://schemas.openxmlformats.org/drawingml/2006/main">
               <a:ext uri="{FF2B5EF4-FFF2-40B4-BE49-F238E27FC236}">
-                <a16:creationId xmlns:a16="http://schemas.microsoft.com/office/drawing/2014/main" id="{7BBEA3E9-D9EF-430A-A385-B9685B3BC401}"/>
+                <a16:creationId xmlns:a16="http://schemas.microsoft.com/office/drawing/2014/main" id="{F54C9276-686F-4092-82B1-D8E35D57CB89}"/>
               </a:ext>
             </a:extLst>
           </p:cNvPr>
@@ -2628,7 +2732,7 @@
                 <a:ea typeface="Arial"/>
                 <a:cs typeface="Arial"/>
               </a:rPr>
-              <a:t>If something stops you</a:t>
+              <a:t>6. Next time</a:t>
             </a:r>
           </a:p>
         </p:txBody>
@@ -2638,7 +2742,7 @@
           <p:cNvPr id="2" name="">
             <a:extLst xmlns:a="http://schemas.openxmlformats.org/drawingml/2006/main">
               <a:ext uri="{FF2B5EF4-FFF2-40B4-BE49-F238E27FC236}">
-                <a16:creationId xmlns:a16="http://schemas.microsoft.com/office/drawing/2014/main" id="{B302FF1B-B4C7-4FF8-9DD8-E925AED7B0EC}"/>
+                <a16:creationId xmlns:a16="http://schemas.microsoft.com/office/drawing/2014/main" id="{192D843F-1C8E-4805-9C8D-ACBD16057764}"/>
               </a:ext>
             </a:extLst>
           </p:cNvPr>
@@ -2695,7 +2799,7 @@
           <p:cNvPr id="3" name="">
             <a:extLst xmlns:a="http://schemas.openxmlformats.org/drawingml/2006/main">
               <a:ext uri="{FF2B5EF4-FFF2-40B4-BE49-F238E27FC236}">
-                <a16:creationId xmlns:a16="http://schemas.microsoft.com/office/drawing/2014/main" id="{1FB87F66-5696-4A81-AD15-EB70DBFFB5FE}"/>
+                <a16:creationId xmlns:a16="http://schemas.microsoft.com/office/drawing/2014/main" id="{87E85178-4AA1-404E-AB59-6B3FC3E63DC1}"/>
               </a:ext>
             </a:extLst>
           </p:cNvPr>
@@ -2706,8 +2810,8 @@
         </p:nvSpPr>
         <p:spPr>
           <a:xfrm xmlns:a="http://schemas.openxmlformats.org/drawingml/2006/main">
-            <a:off x="609600" y="1504950"/>
-            <a:ext cx="5048250" cy="428625"/>
+            <a:off x="609600" y="1466850"/>
+            <a:ext cx="10820400" cy="752475"/>
           </a:xfrm>
           <a:prstGeom xmlns:a="http://schemas.openxmlformats.org/drawingml/2006/main" prst="rect">
             <a:avLst/>
@@ -2724,25 +2828,25 @@
           <a:lstStyle xmlns:a="http://schemas.openxmlformats.org/drawingml/2006/main"/>
           <a:p xmlns:a="http://schemas.openxmlformats.org/drawingml/2006/main">
             <a:pPr>
-              <a:defRPr sz="2325" b="1">
-                <a:solidFill>
-                  <a:srgbClr val="183F3B"/>
-                </a:solidFill>
-                <a:latin typeface="Arial"/>
-                <a:ea typeface="Arial"/>
-                <a:cs typeface="Arial"/>
-              </a:defRPr>
-            </a:pPr>
-            <a:r>
-              <a:rPr sz="2325" b="1">
-                <a:solidFill>
-                  <a:srgbClr val="183F3B"/>
-                </a:solidFill>
-                <a:latin typeface="Arial"/>
-                <a:ea typeface="Arial"/>
-                <a:cs typeface="Arial"/>
-              </a:rPr>
-              <a:t>Skill missing?</a:t>
+              <a:defRPr sz="2250" b="0">
+                <a:solidFill>
+                  <a:srgbClr val="283A39"/>
+                </a:solidFill>
+                <a:latin typeface="Arial"/>
+                <a:ea typeface="Arial"/>
+                <a:cs typeface="Arial"/>
+              </a:defRPr>
+            </a:pPr>
+            <a:r>
+              <a:rPr sz="2250" b="0">
+                <a:solidFill>
+                  <a:srgbClr val="283A39"/>
+                </a:solidFill>
+                <a:latin typeface="Arial"/>
+                <a:ea typeface="Arial"/>
+                <a:cs typeface="Arial"/>
+              </a:rPr>
+              <a:t>Reopen the same local project and conversation. Send:</a:t>
             </a:r>
           </a:p>
         </p:txBody>
@@ -2752,7 +2856,7 @@
           <p:cNvPr id="4" name="">
             <a:extLst xmlns:a="http://schemas.openxmlformats.org/drawingml/2006/main">
               <a:ext uri="{FF2B5EF4-FFF2-40B4-BE49-F238E27FC236}">
-                <a16:creationId xmlns:a16="http://schemas.microsoft.com/office/drawing/2014/main" id="{5C20DB53-B196-42DD-9A0A-711C7AF28991}"/>
+                <a16:creationId xmlns:a16="http://schemas.microsoft.com/office/drawing/2014/main" id="{22784B8B-CB34-4915-A334-677A6D96F5EB}"/>
               </a:ext>
             </a:extLst>
           </p:cNvPr>
@@ -2763,8 +2867,8 @@
         </p:nvSpPr>
         <p:spPr>
           <a:xfrm xmlns:a="http://schemas.openxmlformats.org/drawingml/2006/main">
-            <a:off x="609600" y="2066925"/>
-            <a:ext cx="5191125" cy="1047750"/>
+            <a:off x="609600" y="2828925"/>
+            <a:ext cx="10858500" cy="819150"/>
           </a:xfrm>
           <a:prstGeom xmlns:a="http://schemas.openxmlformats.org/drawingml/2006/main" prst="rect">
             <a:avLst/>
@@ -2781,48 +2885,25 @@
           <a:lstStyle xmlns:a="http://schemas.openxmlformats.org/drawingml/2006/main"/>
           <a:p xmlns:a="http://schemas.openxmlformats.org/drawingml/2006/main">
             <a:pPr>
-              <a:defRPr sz="1950" b="0">
-                <a:solidFill>
-                  <a:srgbClr val="283A39"/>
-                </a:solidFill>
-                <a:latin typeface="Arial"/>
-                <a:ea typeface="Arial"/>
-                <a:cs typeface="Arial"/>
-              </a:defRPr>
-            </a:pPr>
-            <a:r>
-              <a:rPr sz="1950" b="0">
-                <a:solidFill>
-                  <a:srgbClr val="283A39"/>
-                </a:solidFill>
-                <a:latin typeface="Arial"/>
-                <a:ea typeface="Arial"/>
-                <a:cs typeface="Arial"/>
-              </a:rPr>
-              <a:t>“Check whether job-search is installed</a:t>
-            </a:r>
-          </a:p>
-          <a:p xmlns:a="http://schemas.openxmlformats.org/drawingml/2006/main">
-            <a:pPr>
-              <a:defRPr sz="1950" b="0">
-                <a:solidFill>
-                  <a:srgbClr val="283A39"/>
-                </a:solidFill>
-                <a:latin typeface="Arial"/>
-                <a:ea typeface="Arial"/>
-                <a:cs typeface="Arial"/>
-              </a:defRPr>
-            </a:pPr>
-            <a:r>
-              <a:rPr sz="1950" b="0">
-                <a:solidFill>
-                  <a:srgbClr val="283A39"/>
-                </a:solidFill>
-                <a:latin typeface="Arial"/>
-                <a:ea typeface="Arial"/>
-                <a:cs typeface="Arial"/>
-              </a:rPr>
-              <a:t>in this project and help me load it.”</a:t>
+              <a:defRPr sz="3675" b="1">
+                <a:solidFill>
+                  <a:srgbClr val="183F3B"/>
+                </a:solidFill>
+                <a:latin typeface="Arial"/>
+                <a:ea typeface="Arial"/>
+                <a:cs typeface="Arial"/>
+              </a:defRPr>
+            </a:pPr>
+            <a:r>
+              <a:rPr sz="3675" b="1">
+                <a:solidFill>
+                  <a:srgbClr val="183F3B"/>
+                </a:solidFill>
+                <a:latin typeface="Arial"/>
+                <a:ea typeface="Arial"/>
+                <a:cs typeface="Arial"/>
+              </a:rPr>
+              <a:t>Continue my job search.</a:t>
             </a:r>
           </a:p>
         </p:txBody>
@@ -2832,7 +2913,7 @@
           <p:cNvPr id="5" name="">
             <a:extLst xmlns:a="http://schemas.openxmlformats.org/drawingml/2006/main">
               <a:ext uri="{FF2B5EF4-FFF2-40B4-BE49-F238E27FC236}">
-                <a16:creationId xmlns:a16="http://schemas.microsoft.com/office/drawing/2014/main" id="{A7A27C38-637E-4B27-B0DD-061F73164D12}"/>
+                <a16:creationId xmlns:a16="http://schemas.microsoft.com/office/drawing/2014/main" id="{4D6A924D-6801-4C5F-8C23-B42519DB6B8E}"/>
               </a:ext>
             </a:extLst>
           </p:cNvPr>
@@ -2843,8 +2924,8 @@
         </p:nvSpPr>
         <p:spPr>
           <a:xfrm xmlns:a="http://schemas.openxmlformats.org/drawingml/2006/main">
-            <a:off x="6400800" y="1504950"/>
-            <a:ext cx="5048250" cy="428625"/>
+            <a:off x="609600" y="4286250"/>
+            <a:ext cx="10858500" cy="952500"/>
           </a:xfrm>
           <a:prstGeom xmlns:a="http://schemas.openxmlformats.org/drawingml/2006/main" prst="rect">
             <a:avLst/>
@@ -2861,25 +2942,48 @@
           <a:lstStyle xmlns:a="http://schemas.openxmlformats.org/drawingml/2006/main"/>
           <a:p xmlns:a="http://schemas.openxmlformats.org/drawingml/2006/main">
             <a:pPr>
-              <a:defRPr sz="2325" b="1">
-                <a:solidFill>
-                  <a:srgbClr val="183F3B"/>
-                </a:solidFill>
-                <a:latin typeface="Arial"/>
-                <a:ea typeface="Arial"/>
-                <a:cs typeface="Arial"/>
-              </a:defRPr>
-            </a:pPr>
-            <a:r>
-              <a:rPr sz="2325" b="1">
-                <a:solidFill>
-                  <a:srgbClr val="183F3B"/>
-                </a:solidFill>
-                <a:latin typeface="Arial"/>
-                <a:ea typeface="Arial"/>
-                <a:cs typeface="Arial"/>
-              </a:rPr>
-              <a:t>Cannot save?</a:t>
+              <a:defRPr sz="2100" b="0">
+                <a:solidFill>
+                  <a:srgbClr val="283A39"/>
+                </a:solidFill>
+                <a:latin typeface="Arial"/>
+                <a:ea typeface="Arial"/>
+                <a:cs typeface="Arial"/>
+              </a:defRPr>
+            </a:pPr>
+            <a:r>
+              <a:rPr sz="2100" b="0">
+                <a:solidFill>
+                  <a:srgbClr val="283A39"/>
+                </a:solidFill>
+                <a:latin typeface="Arial"/>
+                <a:ea typeface="Arial"/>
+                <a:cs typeface="Arial"/>
+              </a:rPr>
+              <a:t>You usually do not reinstall or attach the same resume again.</a:t>
+            </a:r>
+          </a:p>
+          <a:p xmlns:a="http://schemas.openxmlformats.org/drawingml/2006/main">
+            <a:pPr>
+              <a:defRPr sz="2100" b="0">
+                <a:solidFill>
+                  <a:srgbClr val="283A39"/>
+                </a:solidFill>
+                <a:latin typeface="Arial"/>
+                <a:ea typeface="Arial"/>
+                <a:cs typeface="Arial"/>
+              </a:defRPr>
+            </a:pPr>
+            <a:r>
+              <a:rPr sz="2100" b="0">
+                <a:solidFill>
+                  <a:srgbClr val="283A39"/>
+                </a:solidFill>
+                <a:latin typeface="Arial"/>
+                <a:ea typeface="Arial"/>
+                <a:cs typeface="Arial"/>
+              </a:rPr>
+              <a:t>Supply an updated resume when it changes.</a:t>
             </a:r>
           </a:p>
         </p:txBody>
@@ -2889,7 +2993,7 @@
           <p:cNvPr id="6" name="">
             <a:extLst xmlns:a="http://schemas.openxmlformats.org/drawingml/2006/main">
               <a:ext uri="{FF2B5EF4-FFF2-40B4-BE49-F238E27FC236}">
-                <a16:creationId xmlns:a16="http://schemas.microsoft.com/office/drawing/2014/main" id="{6D7BFEF7-4ABA-4044-87AE-15C0096CAA61}"/>
+                <a16:creationId xmlns:a16="http://schemas.microsoft.com/office/drawing/2014/main" id="{7F15A6AD-BF8A-4786-A8C1-6C10EBB49CFD}"/>
               </a:ext>
             </a:extLst>
           </p:cNvPr>
@@ -2900,8 +3004,8 @@
         </p:nvSpPr>
         <p:spPr>
           <a:xfrm xmlns:a="http://schemas.openxmlformats.org/drawingml/2006/main">
-            <a:off x="6400800" y="2066925"/>
-            <a:ext cx="5162550" cy="1257300"/>
+            <a:off x="609600" y="5781675"/>
+            <a:ext cx="10858500" cy="495300"/>
           </a:xfrm>
           <a:prstGeom xmlns:a="http://schemas.openxmlformats.org/drawingml/2006/main" prst="rect">
             <a:avLst/>
@@ -2918,81 +3022,64 @@
           <a:lstStyle xmlns:a="http://schemas.openxmlformats.org/drawingml/2006/main"/>
           <a:p xmlns:a="http://schemas.openxmlformats.org/drawingml/2006/main">
             <a:pPr>
-              <a:defRPr sz="1950" b="0">
-                <a:solidFill>
-                  <a:srgbClr val="283A39"/>
-                </a:solidFill>
-                <a:latin typeface="Arial"/>
-                <a:ea typeface="Arial"/>
-                <a:cs typeface="Arial"/>
-              </a:defRPr>
-            </a:pPr>
-            <a:r>
-              <a:rPr sz="1950" b="0">
-                <a:solidFill>
-                  <a:srgbClr val="283A39"/>
-                </a:solidFill>
-                <a:latin typeface="Arial"/>
-                <a:ea typeface="Arial"/>
-                <a:cs typeface="Arial"/>
-              </a:rPr>
-              <a:t>Check the selected folder and file</a:t>
-            </a:r>
-          </a:p>
-          <a:p xmlns:a="http://schemas.openxmlformats.org/drawingml/2006/main">
-            <a:pPr>
-              <a:defRPr sz="1950" b="0">
-                <a:solidFill>
-                  <a:srgbClr val="283A39"/>
-                </a:solidFill>
-                <a:latin typeface="Arial"/>
-                <a:ea typeface="Arial"/>
-                <a:cs typeface="Arial"/>
-              </a:defRPr>
-            </a:pPr>
-            <a:r>
-              <a:rPr sz="1950" b="0">
-                <a:solidFill>
-                  <a:srgbClr val="283A39"/>
-                </a:solidFill>
-                <a:latin typeface="Arial"/>
-                <a:ea typeface="Arial"/>
-                <a:cs typeface="Arial"/>
-              </a:rPr>
-              <a:t>permissions. Approve the specific</a:t>
-            </a:r>
-          </a:p>
-          <a:p xmlns:a="http://schemas.openxmlformats.org/drawingml/2006/main">
-            <a:pPr>
-              <a:defRPr sz="1950" b="0">
-                <a:solidFill>
-                  <a:srgbClr val="283A39"/>
-                </a:solidFill>
-                <a:latin typeface="Arial"/>
-                <a:ea typeface="Arial"/>
-                <a:cs typeface="Arial"/>
-              </a:defRPr>
-            </a:pPr>
-            <a:r>
-              <a:rPr sz="1950" b="0">
-                <a:solidFill>
-                  <a:srgbClr val="283A39"/>
-                </a:solidFill>
-                <a:latin typeface="Arial"/>
-                <a:ea typeface="Arial"/>
-                <a:cs typeface="Arial"/>
-              </a:rPr>
-              <a:t>access request if you want it to proceed.</a:t>
-            </a:r>
-          </a:p>
-        </p:txBody>
-      </p:sp>
-      <p:sp>
-        <p:nvSpPr>
-          <p:cNvPr id="7" name="">
+              <a:defRPr sz="1800" b="0">
+                <a:solidFill>
+                  <a:srgbClr val="607370"/>
+                </a:solidFill>
+                <a:latin typeface="Arial"/>
+                <a:ea typeface="Arial"/>
+                <a:cs typeface="Arial"/>
+              </a:defRPr>
+            </a:pPr>
+            <a:r>
+              <a:rPr sz="1800" b="0">
+                <a:solidFill>
+                  <a:srgbClr val="607370"/>
+                </a:solidFill>
+                <a:latin typeface="Arial"/>
+                <a:ea typeface="Arial"/>
+                <a:cs typeface="Arial"/>
+              </a:rPr>
+              <a:t>For an independent occupation search, use a new project with separate records.</a:t>
+            </a:r>
+          </a:p>
+        </p:txBody>
+      </p:sp>
+    </p:spTree>
+    <p:extLst>
+      <p:ext uri="{BB962C8B-B14F-4D97-AF65-F5344CB8AC3E}">
+        <p14:creationId xmlns:p14="http://schemas.microsoft.com/office/powerpoint/2010/main" val="2108912826"/>
+      </p:ext>
+    </p:extLst>
+  </p:cSld>
+</p:sld>
+</file>
+
+<file path=ppt/slides/slide12.xml><?xml version="1.0" encoding="utf-8"?>
+<p:sld xmlns:p="http://schemas.openxmlformats.org/presentationml/2006/main">
+  <p:cSld>
+    <p:bg>
+      <p:bgPr>
+        <a:solidFill xmlns:a="http://schemas.openxmlformats.org/drawingml/2006/main">
+          <a:srgbClr val="FAFCFA"/>
+        </a:solidFill>
+      </p:bgPr>
+    </p:bg>
+    <p:spTree>
+      <p:nvGrpSpPr>
+        <p:cNvPr id="1" name=""/>
+        <p:cNvGrpSpPr/>
+        <p:nvPr/>
+      </p:nvGrpSpPr>
+      <p:grpSpPr>
+        <a:xfrm xmlns:a="http://schemas.openxmlformats.org/drawingml/2006/main"/>
+      </p:grpSpPr>
+      <p:sp>
+        <p:nvSpPr>
+          <p:cNvPr id="10" name="">
             <a:extLst xmlns:a="http://schemas.openxmlformats.org/drawingml/2006/main">
               <a:ext uri="{FF2B5EF4-FFF2-40B4-BE49-F238E27FC236}">
-                <a16:creationId xmlns:a16="http://schemas.microsoft.com/office/drawing/2014/main" id="{1F126BC4-CE15-4DA5-9405-4BB553F21E66}"/>
+                <a16:creationId xmlns:a16="http://schemas.microsoft.com/office/drawing/2014/main" id="{33FCED88-0134-4238-B8E9-AD955EAA318F}"/>
               </a:ext>
             </a:extLst>
           </p:cNvPr>
@@ -3003,8 +3090,8 @@
         </p:nvSpPr>
         <p:spPr>
           <a:xfrm xmlns:a="http://schemas.openxmlformats.org/drawingml/2006/main">
-            <a:off x="609600" y="3810000"/>
-            <a:ext cx="10953750" cy="457200"/>
+            <a:off x="609600" y="457200"/>
+            <a:ext cx="10972800" cy="742950"/>
           </a:xfrm>
           <a:prstGeom xmlns:a="http://schemas.openxmlformats.org/drawingml/2006/main" prst="rect">
             <a:avLst/>
@@ -3021,7 +3108,7 @@
           <a:lstStyle xmlns:a="http://schemas.openxmlformats.org/drawingml/2006/main"/>
           <a:p xmlns:a="http://schemas.openxmlformats.org/drawingml/2006/main">
             <a:pPr>
-              <a:defRPr sz="2325" b="1">
+              <a:defRPr sz="3450" b="1">
                 <a:solidFill>
                   <a:srgbClr val="183F3B"/>
                 </a:solidFill>
@@ -3031,7 +3118,7 @@
               </a:defRPr>
             </a:pPr>
             <a:r>
-              <a:rPr sz="2325" b="1">
+              <a:rPr sz="3450" b="1">
                 <a:solidFill>
                   <a:srgbClr val="183F3B"/>
                 </a:solidFill>
@@ -3039,17 +3126,17 @@
                 <a:ea typeface="Arial"/>
                 <a:cs typeface="Arial"/>
               </a:rPr>
-              <a:t>New chat cannot find your records?</a:t>
-            </a:r>
-          </a:p>
-        </p:txBody>
-      </p:sp>
-      <p:sp>
-        <p:nvSpPr>
-          <p:cNvPr id="8" name="">
+              <a:t>If something stops you</a:t>
+            </a:r>
+          </a:p>
+        </p:txBody>
+      </p:sp>
+      <p:sp>
+        <p:nvSpPr>
+          <p:cNvPr id="2" name="">
             <a:extLst xmlns:a="http://schemas.openxmlformats.org/drawingml/2006/main">
               <a:ext uri="{FF2B5EF4-FFF2-40B4-BE49-F238E27FC236}">
-                <a16:creationId xmlns:a16="http://schemas.microsoft.com/office/drawing/2014/main" id="{E01EBACE-1F3C-4586-8C37-F8140653FE4F}"/>
+                <a16:creationId xmlns:a16="http://schemas.microsoft.com/office/drawing/2014/main" id="{A4CCD037-52B0-40D2-AB5A-BA123C52577D}"/>
               </a:ext>
             </a:extLst>
           </p:cNvPr>
@@ -3060,8 +3147,8 @@
         </p:nvSpPr>
         <p:spPr>
           <a:xfrm xmlns:a="http://schemas.openxmlformats.org/drawingml/2006/main">
-            <a:off x="609600" y="4400550"/>
-            <a:ext cx="10906125" cy="952500"/>
+            <a:off x="11049000" y="6334125"/>
+            <a:ext cx="533400" cy="266700"/>
           </a:xfrm>
           <a:prstGeom xmlns:a="http://schemas.openxmlformats.org/drawingml/2006/main" prst="rect">
             <a:avLst/>
@@ -3078,58 +3165,35 @@
           <a:lstStyle xmlns:a="http://schemas.openxmlformats.org/drawingml/2006/main"/>
           <a:p xmlns:a="http://schemas.openxmlformats.org/drawingml/2006/main">
             <a:pPr>
-              <a:defRPr sz="2100" b="0">
-                <a:solidFill>
-                  <a:srgbClr val="283A39"/>
-                </a:solidFill>
-                <a:latin typeface="Arial"/>
-                <a:ea typeface="Arial"/>
-                <a:cs typeface="Arial"/>
-              </a:defRPr>
-            </a:pPr>
-            <a:r>
-              <a:rPr sz="2100" b="0">
-                <a:solidFill>
-                  <a:srgbClr val="283A39"/>
-                </a:solidFill>
-                <a:latin typeface="Arial"/>
-                <a:ea typeface="Arial"/>
-                <a:cs typeface="Arial"/>
-              </a:rPr>
-              <a:t>Provide the private records location the AI gave you. Say:</a:t>
-            </a:r>
-          </a:p>
-          <a:p xmlns:a="http://schemas.openxmlformats.org/drawingml/2006/main">
-            <a:pPr>
-              <a:defRPr sz="2100" b="0">
-                <a:solidFill>
-                  <a:srgbClr val="283A39"/>
-                </a:solidFill>
-                <a:latin typeface="Arial"/>
-                <a:ea typeface="Arial"/>
-                <a:cs typeface="Arial"/>
-              </a:defRPr>
-            </a:pPr>
-            <a:r>
-              <a:rPr sz="2100" b="0">
-                <a:solidFill>
-                  <a:srgbClr val="283A39"/>
-                </a:solidFill>
-                <a:latin typeface="Arial"/>
-                <a:ea typeface="Arial"/>
-                <a:cs typeface="Arial"/>
-              </a:rPr>
-              <a:t>“Resume my existing search here; do not start over.”</a:t>
-            </a:r>
-          </a:p>
-        </p:txBody>
-      </p:sp>
-      <p:sp>
-        <p:nvSpPr>
-          <p:cNvPr id="9" name="">
+              <a:defRPr sz="1350" b="0">
+                <a:solidFill>
+                  <a:srgbClr val="607370"/>
+                </a:solidFill>
+                <a:latin typeface="Arial"/>
+                <a:ea typeface="Arial"/>
+                <a:cs typeface="Arial"/>
+              </a:defRPr>
+            </a:pPr>
+            <a:r>
+              <a:rPr sz="1350" b="0">
+                <a:solidFill>
+                  <a:srgbClr val="607370"/>
+                </a:solidFill>
+                <a:latin typeface="Arial"/>
+                <a:ea typeface="Arial"/>
+                <a:cs typeface="Arial"/>
+              </a:rPr>
+              <a:t>12</a:t>
+            </a:r>
+          </a:p>
+        </p:txBody>
+      </p:sp>
+      <p:sp>
+        <p:nvSpPr>
+          <p:cNvPr id="3" name="">
             <a:extLst xmlns:a="http://schemas.openxmlformats.org/drawingml/2006/main">
               <a:ext uri="{FF2B5EF4-FFF2-40B4-BE49-F238E27FC236}">
-                <a16:creationId xmlns:a16="http://schemas.microsoft.com/office/drawing/2014/main" id="{2E1F4743-32BC-429B-8F37-B60566775532}"/>
+                <a16:creationId xmlns:a16="http://schemas.microsoft.com/office/drawing/2014/main" id="{A461935A-A3B9-46BA-9231-61DC043F2303}"/>
               </a:ext>
             </a:extLst>
           </p:cNvPr>
@@ -3140,8 +3204,8 @@
         </p:nvSpPr>
         <p:spPr>
           <a:xfrm xmlns:a="http://schemas.openxmlformats.org/drawingml/2006/main">
-            <a:off x="609600" y="5810250"/>
-            <a:ext cx="9810750" cy="361950"/>
+            <a:off x="609600" y="1504950"/>
+            <a:ext cx="5048250" cy="428625"/>
           </a:xfrm>
           <a:prstGeom xmlns:a="http://schemas.openxmlformats.org/drawingml/2006/main" prst="rect">
             <a:avLst/>
@@ -3158,6 +3222,440 @@
           <a:lstStyle xmlns:a="http://schemas.openxmlformats.org/drawingml/2006/main"/>
           <a:p xmlns:a="http://schemas.openxmlformats.org/drawingml/2006/main">
             <a:pPr>
+              <a:defRPr sz="2325" b="1">
+                <a:solidFill>
+                  <a:srgbClr val="183F3B"/>
+                </a:solidFill>
+                <a:latin typeface="Arial"/>
+                <a:ea typeface="Arial"/>
+                <a:cs typeface="Arial"/>
+              </a:defRPr>
+            </a:pPr>
+            <a:r>
+              <a:rPr sz="2325" b="1">
+                <a:solidFill>
+                  <a:srgbClr val="183F3B"/>
+                </a:solidFill>
+                <a:latin typeface="Arial"/>
+                <a:ea typeface="Arial"/>
+                <a:cs typeface="Arial"/>
+              </a:rPr>
+              <a:t>Skill missing?</a:t>
+            </a:r>
+          </a:p>
+        </p:txBody>
+      </p:sp>
+      <p:sp>
+        <p:nvSpPr>
+          <p:cNvPr id="4" name="">
+            <a:extLst xmlns:a="http://schemas.openxmlformats.org/drawingml/2006/main">
+              <a:ext uri="{FF2B5EF4-FFF2-40B4-BE49-F238E27FC236}">
+                <a16:creationId xmlns:a16="http://schemas.microsoft.com/office/drawing/2014/main" id="{9DD37D5D-AABC-4ED0-BEF0-BA773542F506}"/>
+              </a:ext>
+            </a:extLst>
+          </p:cNvPr>
+          <p:cNvSpPr>
+            <a:spLocks xmlns:a="http://schemas.openxmlformats.org/drawingml/2006/main" noGrp="1"/>
+          </p:cNvSpPr>
+          <p:nvPr/>
+        </p:nvSpPr>
+        <p:spPr>
+          <a:xfrm xmlns:a="http://schemas.openxmlformats.org/drawingml/2006/main">
+            <a:off x="609600" y="2066925"/>
+            <a:ext cx="5191125" cy="1047750"/>
+          </a:xfrm>
+          <a:prstGeom xmlns:a="http://schemas.openxmlformats.org/drawingml/2006/main" prst="rect">
+            <a:avLst/>
+          </a:prstGeom>
+          <a:noFill xmlns:a="http://schemas.openxmlformats.org/drawingml/2006/main"/>
+          <a:ln xmlns:a="http://schemas.openxmlformats.org/drawingml/2006/main" w="0">
+            <a:noFill/>
+          </a:ln>
+        </p:spPr>
+        <p:txBody>
+          <a:bodyPr xmlns:a="http://schemas.openxmlformats.org/drawingml/2006/main">
+            <a:noAutofit/>
+          </a:bodyPr>
+          <a:lstStyle xmlns:a="http://schemas.openxmlformats.org/drawingml/2006/main"/>
+          <a:p xmlns:a="http://schemas.openxmlformats.org/drawingml/2006/main">
+            <a:pPr>
+              <a:defRPr sz="1950" b="0">
+                <a:solidFill>
+                  <a:srgbClr val="283A39"/>
+                </a:solidFill>
+                <a:latin typeface="Arial"/>
+                <a:ea typeface="Arial"/>
+                <a:cs typeface="Arial"/>
+              </a:defRPr>
+            </a:pPr>
+            <a:r>
+              <a:rPr sz="1950" b="0">
+                <a:solidFill>
+                  <a:srgbClr val="283A39"/>
+                </a:solidFill>
+                <a:latin typeface="Arial"/>
+                <a:ea typeface="Arial"/>
+                <a:cs typeface="Arial"/>
+              </a:rPr>
+              <a:t>“Check whether job-search is installed</a:t>
+            </a:r>
+          </a:p>
+          <a:p xmlns:a="http://schemas.openxmlformats.org/drawingml/2006/main">
+            <a:pPr>
+              <a:defRPr sz="1950" b="0">
+                <a:solidFill>
+                  <a:srgbClr val="283A39"/>
+                </a:solidFill>
+                <a:latin typeface="Arial"/>
+                <a:ea typeface="Arial"/>
+                <a:cs typeface="Arial"/>
+              </a:defRPr>
+            </a:pPr>
+            <a:r>
+              <a:rPr sz="1950" b="0">
+                <a:solidFill>
+                  <a:srgbClr val="283A39"/>
+                </a:solidFill>
+                <a:latin typeface="Arial"/>
+                <a:ea typeface="Arial"/>
+                <a:cs typeface="Arial"/>
+              </a:rPr>
+              <a:t>in this project and help me load it.”</a:t>
+            </a:r>
+          </a:p>
+        </p:txBody>
+      </p:sp>
+      <p:sp>
+        <p:nvSpPr>
+          <p:cNvPr id="5" name="">
+            <a:extLst xmlns:a="http://schemas.openxmlformats.org/drawingml/2006/main">
+              <a:ext uri="{FF2B5EF4-FFF2-40B4-BE49-F238E27FC236}">
+                <a16:creationId xmlns:a16="http://schemas.microsoft.com/office/drawing/2014/main" id="{01EFBEE0-DB46-4089-93EC-6D32199BA7A1}"/>
+              </a:ext>
+            </a:extLst>
+          </p:cNvPr>
+          <p:cNvSpPr>
+            <a:spLocks xmlns:a="http://schemas.openxmlformats.org/drawingml/2006/main" noGrp="1"/>
+          </p:cNvSpPr>
+          <p:nvPr/>
+        </p:nvSpPr>
+        <p:spPr>
+          <a:xfrm xmlns:a="http://schemas.openxmlformats.org/drawingml/2006/main">
+            <a:off x="6400800" y="1504950"/>
+            <a:ext cx="5048250" cy="428625"/>
+          </a:xfrm>
+          <a:prstGeom xmlns:a="http://schemas.openxmlformats.org/drawingml/2006/main" prst="rect">
+            <a:avLst/>
+          </a:prstGeom>
+          <a:noFill xmlns:a="http://schemas.openxmlformats.org/drawingml/2006/main"/>
+          <a:ln xmlns:a="http://schemas.openxmlformats.org/drawingml/2006/main" w="0">
+            <a:noFill/>
+          </a:ln>
+        </p:spPr>
+        <p:txBody>
+          <a:bodyPr xmlns:a="http://schemas.openxmlformats.org/drawingml/2006/main">
+            <a:noAutofit/>
+          </a:bodyPr>
+          <a:lstStyle xmlns:a="http://schemas.openxmlformats.org/drawingml/2006/main"/>
+          <a:p xmlns:a="http://schemas.openxmlformats.org/drawingml/2006/main">
+            <a:pPr>
+              <a:defRPr sz="2325" b="1">
+                <a:solidFill>
+                  <a:srgbClr val="183F3B"/>
+                </a:solidFill>
+                <a:latin typeface="Arial"/>
+                <a:ea typeface="Arial"/>
+                <a:cs typeface="Arial"/>
+              </a:defRPr>
+            </a:pPr>
+            <a:r>
+              <a:rPr sz="2325" b="1">
+                <a:solidFill>
+                  <a:srgbClr val="183F3B"/>
+                </a:solidFill>
+                <a:latin typeface="Arial"/>
+                <a:ea typeface="Arial"/>
+                <a:cs typeface="Arial"/>
+              </a:rPr>
+              <a:t>Cannot save?</a:t>
+            </a:r>
+          </a:p>
+        </p:txBody>
+      </p:sp>
+      <p:sp>
+        <p:nvSpPr>
+          <p:cNvPr id="6" name="">
+            <a:extLst xmlns:a="http://schemas.openxmlformats.org/drawingml/2006/main">
+              <a:ext uri="{FF2B5EF4-FFF2-40B4-BE49-F238E27FC236}">
+                <a16:creationId xmlns:a16="http://schemas.microsoft.com/office/drawing/2014/main" id="{0B98B804-5BAD-4103-A36F-5C2F2CB83FF3}"/>
+              </a:ext>
+            </a:extLst>
+          </p:cNvPr>
+          <p:cNvSpPr>
+            <a:spLocks xmlns:a="http://schemas.openxmlformats.org/drawingml/2006/main" noGrp="1"/>
+          </p:cNvSpPr>
+          <p:nvPr/>
+        </p:nvSpPr>
+        <p:spPr>
+          <a:xfrm xmlns:a="http://schemas.openxmlformats.org/drawingml/2006/main">
+            <a:off x="6400800" y="2066925"/>
+            <a:ext cx="5162550" cy="1257300"/>
+          </a:xfrm>
+          <a:prstGeom xmlns:a="http://schemas.openxmlformats.org/drawingml/2006/main" prst="rect">
+            <a:avLst/>
+          </a:prstGeom>
+          <a:noFill xmlns:a="http://schemas.openxmlformats.org/drawingml/2006/main"/>
+          <a:ln xmlns:a="http://schemas.openxmlformats.org/drawingml/2006/main" w="0">
+            <a:noFill/>
+          </a:ln>
+        </p:spPr>
+        <p:txBody>
+          <a:bodyPr xmlns:a="http://schemas.openxmlformats.org/drawingml/2006/main">
+            <a:noAutofit/>
+          </a:bodyPr>
+          <a:lstStyle xmlns:a="http://schemas.openxmlformats.org/drawingml/2006/main"/>
+          <a:p xmlns:a="http://schemas.openxmlformats.org/drawingml/2006/main">
+            <a:pPr>
+              <a:defRPr sz="1950" b="0">
+                <a:solidFill>
+                  <a:srgbClr val="283A39"/>
+                </a:solidFill>
+                <a:latin typeface="Arial"/>
+                <a:ea typeface="Arial"/>
+                <a:cs typeface="Arial"/>
+              </a:defRPr>
+            </a:pPr>
+            <a:r>
+              <a:rPr sz="1950" b="0">
+                <a:solidFill>
+                  <a:srgbClr val="283A39"/>
+                </a:solidFill>
+                <a:latin typeface="Arial"/>
+                <a:ea typeface="Arial"/>
+                <a:cs typeface="Arial"/>
+              </a:rPr>
+              <a:t>Check the selected folder and file</a:t>
+            </a:r>
+          </a:p>
+          <a:p xmlns:a="http://schemas.openxmlformats.org/drawingml/2006/main">
+            <a:pPr>
+              <a:defRPr sz="1950" b="0">
+                <a:solidFill>
+                  <a:srgbClr val="283A39"/>
+                </a:solidFill>
+                <a:latin typeface="Arial"/>
+                <a:ea typeface="Arial"/>
+                <a:cs typeface="Arial"/>
+              </a:defRPr>
+            </a:pPr>
+            <a:r>
+              <a:rPr sz="1950" b="0">
+                <a:solidFill>
+                  <a:srgbClr val="283A39"/>
+                </a:solidFill>
+                <a:latin typeface="Arial"/>
+                <a:ea typeface="Arial"/>
+                <a:cs typeface="Arial"/>
+              </a:rPr>
+              <a:t>permissions. Approve the specific</a:t>
+            </a:r>
+          </a:p>
+          <a:p xmlns:a="http://schemas.openxmlformats.org/drawingml/2006/main">
+            <a:pPr>
+              <a:defRPr sz="1950" b="0">
+                <a:solidFill>
+                  <a:srgbClr val="283A39"/>
+                </a:solidFill>
+                <a:latin typeface="Arial"/>
+                <a:ea typeface="Arial"/>
+                <a:cs typeface="Arial"/>
+              </a:defRPr>
+            </a:pPr>
+            <a:r>
+              <a:rPr sz="1950" b="0">
+                <a:solidFill>
+                  <a:srgbClr val="283A39"/>
+                </a:solidFill>
+                <a:latin typeface="Arial"/>
+                <a:ea typeface="Arial"/>
+                <a:cs typeface="Arial"/>
+              </a:rPr>
+              <a:t>access request if you want it to proceed.</a:t>
+            </a:r>
+          </a:p>
+        </p:txBody>
+      </p:sp>
+      <p:sp>
+        <p:nvSpPr>
+          <p:cNvPr id="7" name="">
+            <a:extLst xmlns:a="http://schemas.openxmlformats.org/drawingml/2006/main">
+              <a:ext uri="{FF2B5EF4-FFF2-40B4-BE49-F238E27FC236}">
+                <a16:creationId xmlns:a16="http://schemas.microsoft.com/office/drawing/2014/main" id="{9B13B433-2A8D-401A-9D5F-E1546ECA009A}"/>
+              </a:ext>
+            </a:extLst>
+          </p:cNvPr>
+          <p:cNvSpPr>
+            <a:spLocks xmlns:a="http://schemas.openxmlformats.org/drawingml/2006/main" noGrp="1"/>
+          </p:cNvSpPr>
+          <p:nvPr/>
+        </p:nvSpPr>
+        <p:spPr>
+          <a:xfrm xmlns:a="http://schemas.openxmlformats.org/drawingml/2006/main">
+            <a:off x="609600" y="3810000"/>
+            <a:ext cx="10953750" cy="457200"/>
+          </a:xfrm>
+          <a:prstGeom xmlns:a="http://schemas.openxmlformats.org/drawingml/2006/main" prst="rect">
+            <a:avLst/>
+          </a:prstGeom>
+          <a:noFill xmlns:a="http://schemas.openxmlformats.org/drawingml/2006/main"/>
+          <a:ln xmlns:a="http://schemas.openxmlformats.org/drawingml/2006/main" w="0">
+            <a:noFill/>
+          </a:ln>
+        </p:spPr>
+        <p:txBody>
+          <a:bodyPr xmlns:a="http://schemas.openxmlformats.org/drawingml/2006/main">
+            <a:noAutofit/>
+          </a:bodyPr>
+          <a:lstStyle xmlns:a="http://schemas.openxmlformats.org/drawingml/2006/main"/>
+          <a:p xmlns:a="http://schemas.openxmlformats.org/drawingml/2006/main">
+            <a:pPr>
+              <a:defRPr sz="2325" b="1">
+                <a:solidFill>
+                  <a:srgbClr val="183F3B"/>
+                </a:solidFill>
+                <a:latin typeface="Arial"/>
+                <a:ea typeface="Arial"/>
+                <a:cs typeface="Arial"/>
+              </a:defRPr>
+            </a:pPr>
+            <a:r>
+              <a:rPr sz="2325" b="1">
+                <a:solidFill>
+                  <a:srgbClr val="183F3B"/>
+                </a:solidFill>
+                <a:latin typeface="Arial"/>
+                <a:ea typeface="Arial"/>
+                <a:cs typeface="Arial"/>
+              </a:rPr>
+              <a:t>New chat cannot find your records?</a:t>
+            </a:r>
+          </a:p>
+        </p:txBody>
+      </p:sp>
+      <p:sp>
+        <p:nvSpPr>
+          <p:cNvPr id="8" name="">
+            <a:extLst xmlns:a="http://schemas.openxmlformats.org/drawingml/2006/main">
+              <a:ext uri="{FF2B5EF4-FFF2-40B4-BE49-F238E27FC236}">
+                <a16:creationId xmlns:a16="http://schemas.microsoft.com/office/drawing/2014/main" id="{B9D71F83-64C1-41A5-80D5-193751642076}"/>
+              </a:ext>
+            </a:extLst>
+          </p:cNvPr>
+          <p:cNvSpPr>
+            <a:spLocks xmlns:a="http://schemas.openxmlformats.org/drawingml/2006/main" noGrp="1"/>
+          </p:cNvSpPr>
+          <p:nvPr/>
+        </p:nvSpPr>
+        <p:spPr>
+          <a:xfrm xmlns:a="http://schemas.openxmlformats.org/drawingml/2006/main">
+            <a:off x="609600" y="4400550"/>
+            <a:ext cx="10906125" cy="952500"/>
+          </a:xfrm>
+          <a:prstGeom xmlns:a="http://schemas.openxmlformats.org/drawingml/2006/main" prst="rect">
+            <a:avLst/>
+          </a:prstGeom>
+          <a:noFill xmlns:a="http://schemas.openxmlformats.org/drawingml/2006/main"/>
+          <a:ln xmlns:a="http://schemas.openxmlformats.org/drawingml/2006/main" w="0">
+            <a:noFill/>
+          </a:ln>
+        </p:spPr>
+        <p:txBody>
+          <a:bodyPr xmlns:a="http://schemas.openxmlformats.org/drawingml/2006/main">
+            <a:noAutofit/>
+          </a:bodyPr>
+          <a:lstStyle xmlns:a="http://schemas.openxmlformats.org/drawingml/2006/main"/>
+          <a:p xmlns:a="http://schemas.openxmlformats.org/drawingml/2006/main">
+            <a:pPr>
+              <a:defRPr sz="2100" b="0">
+                <a:solidFill>
+                  <a:srgbClr val="283A39"/>
+                </a:solidFill>
+                <a:latin typeface="Arial"/>
+                <a:ea typeface="Arial"/>
+                <a:cs typeface="Arial"/>
+              </a:defRPr>
+            </a:pPr>
+            <a:r>
+              <a:rPr sz="2100" b="0">
+                <a:solidFill>
+                  <a:srgbClr val="283A39"/>
+                </a:solidFill>
+                <a:latin typeface="Arial"/>
+                <a:ea typeface="Arial"/>
+                <a:cs typeface="Arial"/>
+              </a:rPr>
+              <a:t>Provide the private records location the AI gave you. Say:</a:t>
+            </a:r>
+          </a:p>
+          <a:p xmlns:a="http://schemas.openxmlformats.org/drawingml/2006/main">
+            <a:pPr>
+              <a:defRPr sz="2100" b="0">
+                <a:solidFill>
+                  <a:srgbClr val="283A39"/>
+                </a:solidFill>
+                <a:latin typeface="Arial"/>
+                <a:ea typeface="Arial"/>
+                <a:cs typeface="Arial"/>
+              </a:defRPr>
+            </a:pPr>
+            <a:r>
+              <a:rPr sz="2100" b="0">
+                <a:solidFill>
+                  <a:srgbClr val="283A39"/>
+                </a:solidFill>
+                <a:latin typeface="Arial"/>
+                <a:ea typeface="Arial"/>
+                <a:cs typeface="Arial"/>
+              </a:rPr>
+              <a:t>“Resume my existing search here; do not start over.”</a:t>
+            </a:r>
+          </a:p>
+        </p:txBody>
+      </p:sp>
+      <p:sp>
+        <p:nvSpPr>
+          <p:cNvPr id="9" name="">
+            <a:extLst xmlns:a="http://schemas.openxmlformats.org/drawingml/2006/main">
+              <a:ext uri="{FF2B5EF4-FFF2-40B4-BE49-F238E27FC236}">
+                <a16:creationId xmlns:a16="http://schemas.microsoft.com/office/drawing/2014/main" id="{C035B68F-216E-4A36-AAEC-3450AFCFEAFE}"/>
+              </a:ext>
+            </a:extLst>
+          </p:cNvPr>
+          <p:cNvSpPr>
+            <a:spLocks xmlns:a="http://schemas.openxmlformats.org/drawingml/2006/main" noGrp="1"/>
+          </p:cNvSpPr>
+          <p:nvPr/>
+        </p:nvSpPr>
+        <p:spPr>
+          <a:xfrm xmlns:a="http://schemas.openxmlformats.org/drawingml/2006/main">
+            <a:off x="609600" y="5810250"/>
+            <a:ext cx="9810750" cy="361950"/>
+          </a:xfrm>
+          <a:prstGeom xmlns:a="http://schemas.openxmlformats.org/drawingml/2006/main" prst="rect">
+            <a:avLst/>
+          </a:prstGeom>
+          <a:noFill xmlns:a="http://schemas.openxmlformats.org/drawingml/2006/main"/>
+          <a:ln xmlns:a="http://schemas.openxmlformats.org/drawingml/2006/main" w="0">
+            <a:noFill/>
+          </a:ln>
+        </p:spPr>
+        <p:txBody>
+          <a:bodyPr xmlns:a="http://schemas.openxmlformats.org/drawingml/2006/main">
+            <a:noAutofit/>
+          </a:bodyPr>
+          <a:lstStyle xmlns:a="http://schemas.openxmlformats.org/drawingml/2006/main"/>
+          <a:p xmlns:a="http://schemas.openxmlformats.org/drawingml/2006/main">
+            <a:pPr>
               <a:defRPr sz="1875" b="0">
                 <a:solidFill>
                   <a:srgbClr val="087F73"/>
@@ -3175,7 +3673,7 @@
                 <a:latin typeface="Arial"/>
                 <a:ea typeface="Arial"/>
                 <a:cs typeface="Arial"/>
-                <a:hlinkClick xmlns:r="http://schemas.openxmlformats.org/officeDocument/2006/relationships" r:id="R6d36eb2197ee446e"/>
+                <a:hlinkClick xmlns:r="http://schemas.openxmlformats.org/officeDocument/2006/relationships" r:id="Rb83e9f62f28843c2"/>
               </a:rPr>
               <a:t>Full guide, downloads and troubleshooting</a:t>
             </a:r>
@@ -3185,7 +3683,7 @@
     </p:spTree>
     <p:extLst>
       <p:ext uri="{BB962C8B-B14F-4D97-AF65-F5344CB8AC3E}">
-        <p14:creationId xmlns:p14="http://schemas.microsoft.com/office/powerpoint/2010/main" val="1897927602"/>
+        <p14:creationId xmlns:p14="http://schemas.microsoft.com/office/powerpoint/2010/main" val="884505924"/>
       </p:ext>
     </p:extLst>
   </p:cSld>
@@ -3216,7 +3714,7 @@
           <p:cNvPr id="13" name="">
             <a:extLst xmlns:a="http://schemas.openxmlformats.org/drawingml/2006/main">
               <a:ext uri="{FF2B5EF4-FFF2-40B4-BE49-F238E27FC236}">
-                <a16:creationId xmlns:a16="http://schemas.microsoft.com/office/drawing/2014/main" id="{0CFB9130-595F-4C39-AF98-513933857199}"/>
+                <a16:creationId xmlns:a16="http://schemas.microsoft.com/office/drawing/2014/main" id="{FA1A5B35-9845-4F1D-9126-DD31E0D85E7F}"/>
               </a:ext>
             </a:extLst>
           </p:cNvPr>
@@ -3273,7 +3771,7 @@
           <p:cNvPr id="2" name="">
             <a:extLst xmlns:a="http://schemas.openxmlformats.org/drawingml/2006/main">
               <a:ext uri="{FF2B5EF4-FFF2-40B4-BE49-F238E27FC236}">
-                <a16:creationId xmlns:a16="http://schemas.microsoft.com/office/drawing/2014/main" id="{C584FE87-EC6E-47B7-98A7-59310241390A}"/>
+                <a16:creationId xmlns:a16="http://schemas.microsoft.com/office/drawing/2014/main" id="{943D6EED-2BF3-4FB6-8385-17EFAB2BAEFE}"/>
               </a:ext>
             </a:extLst>
           </p:cNvPr>
@@ -3330,7 +3828,7 @@
           <p:cNvPr id="3" name="">
             <a:extLst xmlns:a="http://schemas.openxmlformats.org/drawingml/2006/main">
               <a:ext uri="{FF2B5EF4-FFF2-40B4-BE49-F238E27FC236}">
-                <a16:creationId xmlns:a16="http://schemas.microsoft.com/office/drawing/2014/main" id="{7562687B-DBD5-4CE4-8A5B-D7811057D9B5}"/>
+                <a16:creationId xmlns:a16="http://schemas.microsoft.com/office/drawing/2014/main" id="{49738F20-FE95-4DA7-B7A4-1C63D02807A9}"/>
               </a:ext>
             </a:extLst>
           </p:cNvPr>
@@ -3387,7 +3885,7 @@
           <p:cNvPr id="4" name="">
             <a:extLst xmlns:a="http://schemas.openxmlformats.org/drawingml/2006/main">
               <a:ext uri="{FF2B5EF4-FFF2-40B4-BE49-F238E27FC236}">
-                <a16:creationId xmlns:a16="http://schemas.microsoft.com/office/drawing/2014/main" id="{98E5F66A-5392-4830-ACAB-1111CE6FA87B}"/>
+                <a16:creationId xmlns:a16="http://schemas.microsoft.com/office/drawing/2014/main" id="{41EBB51E-606E-4CB2-B4F8-F4CBBF46A679}"/>
               </a:ext>
             </a:extLst>
           </p:cNvPr>
@@ -3444,7 +3942,7 @@
           <p:cNvPr id="5" name="">
             <a:extLst xmlns:a="http://schemas.openxmlformats.org/drawingml/2006/main">
               <a:ext uri="{FF2B5EF4-FFF2-40B4-BE49-F238E27FC236}">
-                <a16:creationId xmlns:a16="http://schemas.microsoft.com/office/drawing/2014/main" id="{BFC497BC-DFC7-4E80-AC4D-7B24854019E7}"/>
+                <a16:creationId xmlns:a16="http://schemas.microsoft.com/office/drawing/2014/main" id="{6359B14A-1893-411F-B037-E723FF962014}"/>
               </a:ext>
             </a:extLst>
           </p:cNvPr>
@@ -3524,7 +4022,7 @@
           <p:cNvPr id="6" name="">
             <a:extLst xmlns:a="http://schemas.openxmlformats.org/drawingml/2006/main">
               <a:ext uri="{FF2B5EF4-FFF2-40B4-BE49-F238E27FC236}">
-                <a16:creationId xmlns:a16="http://schemas.microsoft.com/office/drawing/2014/main" id="{0771E9AE-E74C-40F7-B004-1B9B2971D4A9}"/>
+                <a16:creationId xmlns:a16="http://schemas.microsoft.com/office/drawing/2014/main" id="{6456F64A-207D-4E26-ABD5-55CE0837BD63}"/>
               </a:ext>
             </a:extLst>
           </p:cNvPr>
@@ -3570,7 +4068,7 @@
                 <a:latin typeface="Arial"/>
                 <a:ea typeface="Arial"/>
                 <a:cs typeface="Arial"/>
-                <a:hlinkClick xmlns:r="http://schemas.openxmlformats.org/officeDocument/2006/relationships" r:id="R4e0778f8642245b0"/>
+                <a:hlinkClick xmlns:r="http://schemas.openxmlformats.org/officeDocument/2006/relationships" r:id="Re2deeac3aa6e443b"/>
               </a:rPr>
               <a:t>Mac download page (Apple Silicon)</a:t>
             </a:r>
@@ -3582,7 +4080,7 @@
           <p:cNvPr id="7" name="">
             <a:extLst xmlns:a="http://schemas.openxmlformats.org/drawingml/2006/main">
               <a:ext uri="{FF2B5EF4-FFF2-40B4-BE49-F238E27FC236}">
-                <a16:creationId xmlns:a16="http://schemas.microsoft.com/office/drawing/2014/main" id="{2C1E3D82-E55F-4445-950C-834F4FBABE27}"/>
+                <a16:creationId xmlns:a16="http://schemas.microsoft.com/office/drawing/2014/main" id="{073D013A-24C9-4908-9013-7E173708F9FD}"/>
               </a:ext>
             </a:extLst>
           </p:cNvPr>
@@ -3628,7 +4126,7 @@
                 <a:latin typeface="Arial"/>
                 <a:ea typeface="Arial"/>
                 <a:cs typeface="Arial"/>
-                <a:hlinkClick xmlns:r="http://schemas.openxmlformats.org/officeDocument/2006/relationships" r:id="Rd1ab779e784d4f87"/>
+                <a:hlinkClick xmlns:r="http://schemas.openxmlformats.org/officeDocument/2006/relationships" r:id="Rd8fe176086a34ae1"/>
               </a:rPr>
               <a:t>Windows download page</a:t>
             </a:r>
@@ -3640,7 +4138,7 @@
           <p:cNvPr id="8" name="">
             <a:extLst xmlns:a="http://schemas.openxmlformats.org/drawingml/2006/main">
               <a:ext uri="{FF2B5EF4-FFF2-40B4-BE49-F238E27FC236}">
-                <a16:creationId xmlns:a16="http://schemas.microsoft.com/office/drawing/2014/main" id="{820ADBD1-6D98-4F4D-A316-F03418CE10E6}"/>
+                <a16:creationId xmlns:a16="http://schemas.microsoft.com/office/drawing/2014/main" id="{0A51F6EB-476A-4726-9512-DDFB6D818DC7}"/>
               </a:ext>
             </a:extLst>
           </p:cNvPr>
@@ -3697,7 +4195,7 @@
           <p:cNvPr id="9" name="">
             <a:extLst xmlns:a="http://schemas.openxmlformats.org/drawingml/2006/main">
               <a:ext uri="{FF2B5EF4-FFF2-40B4-BE49-F238E27FC236}">
-                <a16:creationId xmlns:a16="http://schemas.microsoft.com/office/drawing/2014/main" id="{411525ED-181C-4620-87DE-7DAF278743FF}"/>
+                <a16:creationId xmlns:a16="http://schemas.microsoft.com/office/drawing/2014/main" id="{1B5AD74B-FBD8-4D38-8CCA-1E40DCA21D48}"/>
               </a:ext>
             </a:extLst>
           </p:cNvPr>
@@ -3777,7 +4275,7 @@
           <p:cNvPr id="10" name="">
             <a:extLst xmlns:a="http://schemas.openxmlformats.org/drawingml/2006/main">
               <a:ext uri="{FF2B5EF4-FFF2-40B4-BE49-F238E27FC236}">
-                <a16:creationId xmlns:a16="http://schemas.microsoft.com/office/drawing/2014/main" id="{A388C4F4-A55A-417C-AAFF-B732C066492F}"/>
+                <a16:creationId xmlns:a16="http://schemas.microsoft.com/office/drawing/2014/main" id="{42C785D1-485B-4E0D-AEBE-7BE9FCA32AFD}"/>
               </a:ext>
             </a:extLst>
           </p:cNvPr>
@@ -3823,7 +4321,7 @@
                 <a:latin typeface="Arial"/>
                 <a:ea typeface="Arial"/>
                 <a:cs typeface="Arial"/>
-                <a:hlinkClick xmlns:r="http://schemas.openxmlformats.org/officeDocument/2006/relationships" r:id="R69c87b25904e4d3e"/>
+                <a:hlinkClick xmlns:r="http://schemas.openxmlformats.org/officeDocument/2006/relationships" r:id="R3032b6254e33481e"/>
               </a:rPr>
               <a:t>Mac or Windows downloads</a:t>
             </a:r>
@@ -3835,7 +4333,7 @@
           <p:cNvPr id="11" name="">
             <a:extLst xmlns:a="http://schemas.openxmlformats.org/drawingml/2006/main">
               <a:ext uri="{FF2B5EF4-FFF2-40B4-BE49-F238E27FC236}">
-                <a16:creationId xmlns:a16="http://schemas.microsoft.com/office/drawing/2014/main" id="{09BAB19A-5BA2-4DBB-B088-BE5F0F9721AB}"/>
+                <a16:creationId xmlns:a16="http://schemas.microsoft.com/office/drawing/2014/main" id="{AEBD717E-E2FF-465A-A12E-4DBD434E44C3}"/>
               </a:ext>
             </a:extLst>
           </p:cNvPr>
@@ -3881,7 +4379,7 @@
                 <a:latin typeface="Arial"/>
                 <a:ea typeface="Arial"/>
                 <a:cs typeface="Arial"/>
-                <a:hlinkClick xmlns:r="http://schemas.openxmlformats.org/officeDocument/2006/relationships" r:id="Rf05706d981bc4dd7"/>
+                <a:hlinkClick xmlns:r="http://schemas.openxmlformats.org/officeDocument/2006/relationships" r:id="Rcff9d67eed2a4f54"/>
               </a:rPr>
               <a:t>Claude Code setup and account requirements</a:t>
             </a:r>
@@ -3893,7 +4391,7 @@
           <p:cNvPr id="12" name="">
             <a:extLst xmlns:a="http://schemas.openxmlformats.org/drawingml/2006/main">
               <a:ext uri="{FF2B5EF4-FFF2-40B4-BE49-F238E27FC236}">
-                <a16:creationId xmlns:a16="http://schemas.microsoft.com/office/drawing/2014/main" id="{8B069E8F-1425-49F4-B3E2-0A52ADF05AD9}"/>
+                <a16:creationId xmlns:a16="http://schemas.microsoft.com/office/drawing/2014/main" id="{87B14738-5306-4875-A9A9-A6B845C50AC4}"/>
               </a:ext>
             </a:extLst>
           </p:cNvPr>
@@ -3948,7 +4446,7 @@
     </p:spTree>
     <p:extLst>
       <p:ext uri="{BB962C8B-B14F-4D97-AF65-F5344CB8AC3E}">
-        <p14:creationId xmlns:p14="http://schemas.microsoft.com/office/powerpoint/2010/main" val="197421951"/>
+        <p14:creationId xmlns:p14="http://schemas.microsoft.com/office/powerpoint/2010/main" val="2085387622"/>
       </p:ext>
     </p:extLst>
   </p:cSld>
@@ -3979,7 +4477,7 @@
           <p:cNvPr id="6" name="">
             <a:extLst xmlns:a="http://schemas.openxmlformats.org/drawingml/2006/main">
               <a:ext uri="{FF2B5EF4-FFF2-40B4-BE49-F238E27FC236}">
-                <a16:creationId xmlns:a16="http://schemas.microsoft.com/office/drawing/2014/main" id="{D0E55AE0-5BD9-444C-A9A5-1A7815DCB114}"/>
+                <a16:creationId xmlns:a16="http://schemas.microsoft.com/office/drawing/2014/main" id="{C1E477C7-A35A-43D6-BAAE-4D8677C4BFE5}"/>
               </a:ext>
             </a:extLst>
           </p:cNvPr>
@@ -4036,7 +4534,7 @@
           <p:cNvPr id="2" name="">
             <a:extLst xmlns:a="http://schemas.openxmlformats.org/drawingml/2006/main">
               <a:ext uri="{FF2B5EF4-FFF2-40B4-BE49-F238E27FC236}">
-                <a16:creationId xmlns:a16="http://schemas.microsoft.com/office/drawing/2014/main" id="{3B5B50EE-2174-4163-8FD9-0DD486EC151F}"/>
+                <a16:creationId xmlns:a16="http://schemas.microsoft.com/office/drawing/2014/main" id="{8DBE66EB-A5A8-435F-867C-A885119DE1F6}"/>
               </a:ext>
             </a:extLst>
           </p:cNvPr>
@@ -4093,7 +4591,7 @@
           <p:cNvPr id="3" name="">
             <a:extLst xmlns:a="http://schemas.openxmlformats.org/drawingml/2006/main">
               <a:ext uri="{FF2B5EF4-FFF2-40B4-BE49-F238E27FC236}">
-                <a16:creationId xmlns:a16="http://schemas.microsoft.com/office/drawing/2014/main" id="{125C624A-DE43-459C-B9DB-64D9807F7173}"/>
+                <a16:creationId xmlns:a16="http://schemas.microsoft.com/office/drawing/2014/main" id="{9287D3D0-B33F-4AFE-A444-3E17250B77FB}"/>
               </a:ext>
             </a:extLst>
           </p:cNvPr>
@@ -4154,7 +4652,7 @@
           <p:nvPr/>
         </p:nvPicPr>
         <p:blipFill>
-          <a:blip xmlns:r="http://schemas.openxmlformats.org/officeDocument/2006/relationships" xmlns:a="http://schemas.openxmlformats.org/drawingml/2006/main" r:embed="Ra3b7bba075514ebb"/>
+          <a:blip xmlns:r="http://schemas.openxmlformats.org/officeDocument/2006/relationships" xmlns:a="http://schemas.openxmlformats.org/drawingml/2006/main" r:embed="R9cd37d1804854025"/>
           <a:stretch xmlns:a="http://schemas.openxmlformats.org/drawingml/2006/main"/>
         </p:blipFill>
         <p:spPr>
@@ -4172,7 +4670,7 @@
           <p:cNvPr id="5" name="">
             <a:extLst xmlns:a="http://schemas.openxmlformats.org/drawingml/2006/main">
               <a:ext uri="{FF2B5EF4-FFF2-40B4-BE49-F238E27FC236}">
-                <a16:creationId xmlns:a16="http://schemas.microsoft.com/office/drawing/2014/main" id="{DAA8BAC5-A1A9-480F-988B-87B6ECA87F4D}"/>
+                <a16:creationId xmlns:a16="http://schemas.microsoft.com/office/drawing/2014/main" id="{27E1D591-CDAD-4D78-A7EF-844EDFD16D69}"/>
               </a:ext>
             </a:extLst>
           </p:cNvPr>
@@ -4250,7 +4748,7 @@
     </p:spTree>
     <p:extLst>
       <p:ext uri="{BB962C8B-B14F-4D97-AF65-F5344CB8AC3E}">
-        <p14:creationId xmlns:p14="http://schemas.microsoft.com/office/powerpoint/2010/main" val="1966675486"/>
+        <p14:creationId xmlns:p14="http://schemas.microsoft.com/office/powerpoint/2010/main" val="1976562936"/>
       </p:ext>
     </p:extLst>
   </p:cSld>
@@ -4281,7 +4779,7 @@
           <p:cNvPr id="8" name="">
             <a:extLst xmlns:a="http://schemas.openxmlformats.org/drawingml/2006/main">
               <a:ext uri="{FF2B5EF4-FFF2-40B4-BE49-F238E27FC236}">
-                <a16:creationId xmlns:a16="http://schemas.microsoft.com/office/drawing/2014/main" id="{D6452177-8B33-46D6-A578-86E9BF249660}"/>
+                <a16:creationId xmlns:a16="http://schemas.microsoft.com/office/drawing/2014/main" id="{B62D4190-CF08-43C5-97A2-7EBABD1ED2C0}"/>
               </a:ext>
             </a:extLst>
           </p:cNvPr>
@@ -4338,7 +4836,7 @@
           <p:cNvPr id="2" name="">
             <a:extLst xmlns:a="http://schemas.openxmlformats.org/drawingml/2006/main">
               <a:ext uri="{FF2B5EF4-FFF2-40B4-BE49-F238E27FC236}">
-                <a16:creationId xmlns:a16="http://schemas.microsoft.com/office/drawing/2014/main" id="{4A3C45C8-C52D-40E4-A8C0-BC5C2AB8A2D7}"/>
+                <a16:creationId xmlns:a16="http://schemas.microsoft.com/office/drawing/2014/main" id="{B50DF87F-4BB4-4E6D-85B0-E738E42F5904}"/>
               </a:ext>
             </a:extLst>
           </p:cNvPr>
@@ -4395,7 +4893,7 @@
           <p:cNvPr id="3" name="">
             <a:extLst xmlns:a="http://schemas.openxmlformats.org/drawingml/2006/main">
               <a:ext uri="{FF2B5EF4-FFF2-40B4-BE49-F238E27FC236}">
-                <a16:creationId xmlns:a16="http://schemas.microsoft.com/office/drawing/2014/main" id="{BD2DB070-5E23-4FED-B992-91F68C8F8D22}"/>
+                <a16:creationId xmlns:a16="http://schemas.microsoft.com/office/drawing/2014/main" id="{0EA3423B-1FC7-4AF1-ACF1-652F39EE2AEA}"/>
               </a:ext>
             </a:extLst>
           </p:cNvPr>
@@ -4452,7 +4950,7 @@
           <p:cNvPr id="4" name="">
             <a:extLst xmlns:a="http://schemas.openxmlformats.org/drawingml/2006/main">
               <a:ext uri="{FF2B5EF4-FFF2-40B4-BE49-F238E27FC236}">
-                <a16:creationId xmlns:a16="http://schemas.microsoft.com/office/drawing/2014/main" id="{855ED9CA-4F6A-48C0-8B7E-9F8CB76139AE}"/>
+                <a16:creationId xmlns:a16="http://schemas.microsoft.com/office/drawing/2014/main" id="{92CE86F9-8A75-403E-905F-15E441F9C4F2}"/>
               </a:ext>
             </a:extLst>
           </p:cNvPr>
@@ -4578,7 +5076,7 @@
           <p:cNvPr id="5" name="">
             <a:extLst xmlns:a="http://schemas.openxmlformats.org/drawingml/2006/main">
               <a:ext uri="{FF2B5EF4-FFF2-40B4-BE49-F238E27FC236}">
-                <a16:creationId xmlns:a16="http://schemas.microsoft.com/office/drawing/2014/main" id="{EAC1DED9-BB93-4218-9558-ECBFFCB5125B}"/>
+                <a16:creationId xmlns:a16="http://schemas.microsoft.com/office/drawing/2014/main" id="{5B7262EA-404F-4823-80C1-E5B2833A0F80}"/>
               </a:ext>
             </a:extLst>
           </p:cNvPr>
@@ -4685,7 +5183,7 @@
           <p:nvPr/>
         </p:nvPicPr>
         <p:blipFill>
-          <a:blip xmlns:r="http://schemas.openxmlformats.org/officeDocument/2006/relationships" xmlns:a="http://schemas.openxmlformats.org/drawingml/2006/main" r:embed="R6f9b6251e2dd422a"/>
+          <a:blip xmlns:r="http://schemas.openxmlformats.org/officeDocument/2006/relationships" xmlns:a="http://schemas.openxmlformats.org/drawingml/2006/main" r:embed="Rd0c47d3b039f421f"/>
           <a:stretch xmlns:a="http://schemas.openxmlformats.org/drawingml/2006/main"/>
         </p:blipFill>
         <p:spPr>
@@ -4703,7 +5201,7 @@
           <p:cNvPr id="7" name="">
             <a:extLst xmlns:a="http://schemas.openxmlformats.org/drawingml/2006/main">
               <a:ext uri="{FF2B5EF4-FFF2-40B4-BE49-F238E27FC236}">
-                <a16:creationId xmlns:a16="http://schemas.microsoft.com/office/drawing/2014/main" id="{C179298D-E812-4005-BF01-92118CA88DAE}"/>
+                <a16:creationId xmlns:a16="http://schemas.microsoft.com/office/drawing/2014/main" id="{0C1647D7-F89B-4543-A8B7-1CCFD25A5651}"/>
               </a:ext>
             </a:extLst>
           </p:cNvPr>
@@ -4758,7 +5256,7 @@
     </p:spTree>
     <p:extLst>
       <p:ext uri="{BB962C8B-B14F-4D97-AF65-F5344CB8AC3E}">
-        <p14:creationId xmlns:p14="http://schemas.microsoft.com/office/powerpoint/2010/main" val="21657087"/>
+        <p14:creationId xmlns:p14="http://schemas.microsoft.com/office/powerpoint/2010/main" val="503848494"/>
       </p:ext>
     </p:extLst>
   </p:cSld>
@@ -4786,10 +5284,10 @@
       </p:grpSpPr>
       <p:sp>
         <p:nvSpPr>
-          <p:cNvPr id="10" name="">
+          <p:cNvPr id="6" name="">
             <a:extLst xmlns:a="http://schemas.openxmlformats.org/drawingml/2006/main">
               <a:ext uri="{FF2B5EF4-FFF2-40B4-BE49-F238E27FC236}">
-                <a16:creationId xmlns:a16="http://schemas.microsoft.com/office/drawing/2014/main" id="{E0C606F3-3C15-453A-9E11-82ECEFB277EA}"/>
+                <a16:creationId xmlns:a16="http://schemas.microsoft.com/office/drawing/2014/main" id="{38C30F16-90B0-472D-AC66-21E0FA8BD101}"/>
               </a:ext>
             </a:extLst>
           </p:cNvPr>
@@ -4836,7 +5334,7 @@
                 <a:ea typeface="Arial"/>
                 <a:cs typeface="Arial"/>
               </a:rPr>
-              <a:t>1. Permission to save files</a:t>
+              <a:t>1. Codex: Full access</a:t>
             </a:r>
           </a:p>
         </p:txBody>
@@ -4846,7 +5344,7 @@
           <p:cNvPr id="2" name="">
             <a:extLst xmlns:a="http://schemas.openxmlformats.org/drawingml/2006/main">
               <a:ext uri="{FF2B5EF4-FFF2-40B4-BE49-F238E27FC236}">
-                <a16:creationId xmlns:a16="http://schemas.microsoft.com/office/drawing/2014/main" id="{BE70C8B4-9683-4370-BDDA-A3C929A69CD4}"/>
+                <a16:creationId xmlns:a16="http://schemas.microsoft.com/office/drawing/2014/main" id="{EE1EB67A-E094-4B3A-8031-F9F458138F5C}"/>
               </a:ext>
             </a:extLst>
           </p:cNvPr>
@@ -4903,7 +5401,7 @@
           <p:cNvPr id="3" name="">
             <a:extLst xmlns:a="http://schemas.openxmlformats.org/drawingml/2006/main">
               <a:ext uri="{FF2B5EF4-FFF2-40B4-BE49-F238E27FC236}">
-                <a16:creationId xmlns:a16="http://schemas.microsoft.com/office/drawing/2014/main" id="{EE5FBECC-E545-4356-8C97-129CDA1FCFCD}"/>
+                <a16:creationId xmlns:a16="http://schemas.microsoft.com/office/drawing/2014/main" id="{F517FA9A-260A-4853-A43E-BDDC88780F39}"/>
               </a:ext>
             </a:extLst>
           </p:cNvPr>
@@ -4914,8 +5412,8 @@
         </p:nvSpPr>
         <p:spPr>
           <a:xfrm xmlns:a="http://schemas.openxmlformats.org/drawingml/2006/main">
-            <a:off x="609600" y="1609725"/>
-            <a:ext cx="4857750" cy="457200"/>
+            <a:off x="609600" y="1381125"/>
+            <a:ext cx="10858500" cy="828675"/>
           </a:xfrm>
           <a:prstGeom xmlns:a="http://schemas.openxmlformats.org/drawingml/2006/main" prst="rect">
             <a:avLst/>
@@ -4932,35 +5430,80 @@
           <a:lstStyle xmlns:a="http://schemas.openxmlformats.org/drawingml/2006/main"/>
           <a:p xmlns:a="http://schemas.openxmlformats.org/drawingml/2006/main">
             <a:pPr>
-              <a:defRPr sz="2550" b="1">
-                <a:solidFill>
-                  <a:srgbClr val="183F3B"/>
-                </a:solidFill>
-                <a:latin typeface="Arial"/>
-                <a:ea typeface="Arial"/>
-                <a:cs typeface="Arial"/>
-              </a:defRPr>
-            </a:pPr>
-            <a:r>
-              <a:rPr sz="2550" b="1">
-                <a:solidFill>
-                  <a:srgbClr val="183F3B"/>
-                </a:solidFill>
-                <a:latin typeface="Arial"/>
-                <a:ea typeface="Arial"/>
-                <a:cs typeface="Arial"/>
-              </a:rPr>
-              <a:t>Codex</a:t>
-            </a:r>
-          </a:p>
-        </p:txBody>
-      </p:sp>
-      <p:sp>
-        <p:nvSpPr>
-          <p:cNvPr id="4" name="">
+              <a:defRPr sz="2175" b="0">
+                <a:solidFill>
+                  <a:srgbClr val="283A39"/>
+                </a:solidFill>
+                <a:latin typeface="Arial"/>
+                <a:ea typeface="Arial"/>
+                <a:cs typeface="Arial"/>
+              </a:defRPr>
+            </a:pPr>
+            <a:r>
+              <a:rPr sz="2175" b="0">
+                <a:solidFill>
+                  <a:srgbClr val="283A39"/>
+                </a:solidFill>
+                <a:latin typeface="Arial"/>
+                <a:ea typeface="Arial"/>
+                <a:cs typeface="Arial"/>
+              </a:rPr>
+              <a:t>Click the permission label below your message.</a:t>
+            </a:r>
+          </a:p>
+          <a:p xmlns:a="http://schemas.openxmlformats.org/drawingml/2006/main">
+            <a:pPr>
+              <a:defRPr sz="2175" b="0">
+                <a:solidFill>
+                  <a:srgbClr val="283A39"/>
+                </a:solidFill>
+                <a:latin typeface="Arial"/>
+                <a:ea typeface="Arial"/>
+                <a:cs typeface="Arial"/>
+              </a:defRPr>
+            </a:pPr>
+            <a:r>
+              <a:rPr sz="2175" b="0">
+                <a:solidFill>
+                  <a:srgbClr val="283A39"/>
+                </a:solidFill>
+                <a:latin typeface="Arial"/>
+                <a:ea typeface="Arial"/>
+                <a:cs typeface="Arial"/>
+              </a:rPr>
+              <a:t>Select Full access, as shown.</a:t>
+            </a:r>
+          </a:p>
+        </p:txBody>
+      </p:sp>
+      <p:pic>
+        <p:nvPicPr>
+          <p:cNvPr id="9" name=""/>
+          <p:cNvPicPr>
+            <a:picLocks xmlns:a="http://schemas.openxmlformats.org/drawingml/2006/main" noChangeAspect="1"/>
+          </p:cNvPicPr>
+          <p:nvPr/>
+        </p:nvPicPr>
+        <p:blipFill>
+          <a:blip xmlns:r="http://schemas.openxmlformats.org/officeDocument/2006/relationships" xmlns:a="http://schemas.openxmlformats.org/drawingml/2006/main" r:embed="Rd5fe6c7e275e4fc2"/>
+          <a:stretch xmlns:a="http://schemas.openxmlformats.org/drawingml/2006/main"/>
+        </p:blipFill>
+        <p:spPr>
+          <a:xfrm xmlns:a="http://schemas.openxmlformats.org/drawingml/2006/main">
+            <a:off x="616284" y="2362200"/>
+            <a:ext cx="10959433" cy="3114675"/>
+          </a:xfrm>
+          <a:prstGeom xmlns:a="http://schemas.openxmlformats.org/drawingml/2006/main" prst="rect">
+            <a:avLst/>
+          </a:prstGeom>
+        </p:spPr>
+      </p:pic>
+      <p:sp>
+        <p:nvSpPr>
+          <p:cNvPr id="5" name="">
             <a:extLst xmlns:a="http://schemas.openxmlformats.org/drawingml/2006/main">
               <a:ext uri="{FF2B5EF4-FFF2-40B4-BE49-F238E27FC236}">
-                <a16:creationId xmlns:a16="http://schemas.microsoft.com/office/drawing/2014/main" id="{16E9AB51-C31E-4871-9BCE-C0B417F9E331}"/>
+                <a16:creationId xmlns:a16="http://schemas.microsoft.com/office/drawing/2014/main" id="{C8EF5924-E5B6-4C50-951D-623C7D0E52E0}"/>
               </a:ext>
             </a:extLst>
           </p:cNvPr>
@@ -4971,8 +5514,8 @@
         </p:nvSpPr>
         <p:spPr>
           <a:xfrm xmlns:a="http://schemas.openxmlformats.org/drawingml/2006/main">
-            <a:off x="609600" y="2257425"/>
-            <a:ext cx="4905375" cy="933450"/>
+            <a:off x="609600" y="5724525"/>
+            <a:ext cx="10934700" cy="590550"/>
           </a:xfrm>
           <a:prstGeom xmlns:a="http://schemas.openxmlformats.org/drawingml/2006/main" prst="rect">
             <a:avLst/>
@@ -4989,452 +5532,6 @@
           <a:lstStyle xmlns:a="http://schemas.openxmlformats.org/drawingml/2006/main"/>
           <a:p xmlns:a="http://schemas.openxmlformats.org/drawingml/2006/main">
             <a:pPr>
-              <a:defRPr sz="2250" b="0">
-                <a:solidFill>
-                  <a:srgbClr val="283A39"/>
-                </a:solidFill>
-                <a:latin typeface="Arial"/>
-                <a:ea typeface="Arial"/>
-                <a:cs typeface="Arial"/>
-              </a:defRPr>
-            </a:pPr>
-            <a:r>
-              <a:rPr sz="2250" b="0">
-                <a:solidFill>
-                  <a:srgbClr val="283A39"/>
-                </a:solidFill>
-                <a:latin typeface="Arial"/>
-                <a:ea typeface="Arial"/>
-                <a:cs typeface="Arial"/>
-              </a:rPr>
-              <a:t>Use project read/write access</a:t>
-            </a:r>
-          </a:p>
-          <a:p xmlns:a="http://schemas.openxmlformats.org/drawingml/2006/main">
-            <a:pPr>
-              <a:defRPr sz="2250" b="0">
-                <a:solidFill>
-                  <a:srgbClr val="283A39"/>
-                </a:solidFill>
-                <a:latin typeface="Arial"/>
-                <a:ea typeface="Arial"/>
-                <a:cs typeface="Arial"/>
-              </a:defRPr>
-            </a:pPr>
-            <a:r>
-              <a:rPr sz="2250" b="0">
-                <a:solidFill>
-                  <a:srgbClr val="283A39"/>
-                </a:solidFill>
-                <a:latin typeface="Arial"/>
-                <a:ea typeface="Arial"/>
-                <a:cs typeface="Arial"/>
-              </a:rPr>
-              <a:t>with approvals when needed.</a:t>
-            </a:r>
-          </a:p>
-        </p:txBody>
-      </p:sp>
-      <p:sp>
-        <p:nvSpPr>
-          <p:cNvPr id="5" name="">
-            <a:extLst xmlns:a="http://schemas.openxmlformats.org/drawingml/2006/main">
-              <a:ext uri="{FF2B5EF4-FFF2-40B4-BE49-F238E27FC236}">
-                <a16:creationId xmlns:a16="http://schemas.microsoft.com/office/drawing/2014/main" id="{4A9D6C21-56D9-484C-92AC-52527897E4C6}"/>
-              </a:ext>
-            </a:extLst>
-          </p:cNvPr>
-          <p:cNvSpPr>
-            <a:spLocks xmlns:a="http://schemas.openxmlformats.org/drawingml/2006/main" noGrp="1"/>
-          </p:cNvSpPr>
-          <p:nvPr/>
-        </p:nvSpPr>
-        <p:spPr>
-          <a:xfrm xmlns:a="http://schemas.openxmlformats.org/drawingml/2006/main">
-            <a:off x="609600" y="3533775"/>
-            <a:ext cx="4905375" cy="1571625"/>
-          </a:xfrm>
-          <a:prstGeom xmlns:a="http://schemas.openxmlformats.org/drawingml/2006/main" prst="rect">
-            <a:avLst/>
-          </a:prstGeom>
-          <a:noFill xmlns:a="http://schemas.openxmlformats.org/drawingml/2006/main"/>
-          <a:ln xmlns:a="http://schemas.openxmlformats.org/drawingml/2006/main" w="0">
-            <a:noFill/>
-          </a:ln>
-        </p:spPr>
-        <p:txBody>
-          <a:bodyPr xmlns:a="http://schemas.openxmlformats.org/drawingml/2006/main">
-            <a:noAutofit/>
-          </a:bodyPr>
-          <a:lstStyle xmlns:a="http://schemas.openxmlformats.org/drawingml/2006/main"/>
-          <a:p xmlns:a="http://schemas.openxmlformats.org/drawingml/2006/main">
-            <a:pPr>
-              <a:defRPr sz="2100" b="0">
-                <a:solidFill>
-                  <a:srgbClr val="283A39"/>
-                </a:solidFill>
-                <a:latin typeface="Arial"/>
-                <a:ea typeface="Arial"/>
-                <a:cs typeface="Arial"/>
-              </a:defRPr>
-            </a:pPr>
-            <a:r>
-              <a:rPr sz="2100" b="0">
-                <a:solidFill>
-                  <a:srgbClr val="283A39"/>
-                </a:solidFill>
-                <a:latin typeface="Arial"/>
-                <a:ea typeface="Arial"/>
-                <a:cs typeface="Arial"/>
-              </a:rPr>
-              <a:t>Check the permission selector</a:t>
-            </a:r>
-          </a:p>
-          <a:p xmlns:a="http://schemas.openxmlformats.org/drawingml/2006/main">
-            <a:pPr>
-              <a:defRPr sz="2100" b="0">
-                <a:solidFill>
-                  <a:srgbClr val="283A39"/>
-                </a:solidFill>
-                <a:latin typeface="Arial"/>
-                <a:ea typeface="Arial"/>
-                <a:cs typeface="Arial"/>
-              </a:defRPr>
-            </a:pPr>
-            <a:r>
-              <a:rPr sz="2100" b="0">
-                <a:solidFill>
-                  <a:srgbClr val="283A39"/>
-                </a:solidFill>
-                <a:latin typeface="Arial"/>
-                <a:ea typeface="Arial"/>
-                <a:cs typeface="Arial"/>
-              </a:rPr>
-              <a:t>near the message box. Approve</a:t>
-            </a:r>
-          </a:p>
-          <a:p xmlns:a="http://schemas.openxmlformats.org/drawingml/2006/main">
-            <a:pPr>
-              <a:defRPr sz="2100" b="0">
-                <a:solidFill>
-                  <a:srgbClr val="283A39"/>
-                </a:solidFill>
-                <a:latin typeface="Arial"/>
-                <a:ea typeface="Arial"/>
-                <a:cs typeface="Arial"/>
-              </a:defRPr>
-            </a:pPr>
-            <a:r>
-              <a:rPr sz="2100" b="0">
-                <a:solidFill>
-                  <a:srgbClr val="283A39"/>
-                </a:solidFill>
-                <a:latin typeface="Arial"/>
-                <a:ea typeface="Arial"/>
-                <a:cs typeface="Arial"/>
-              </a:rPr>
-              <a:t>installation or extra folder access</a:t>
-            </a:r>
-          </a:p>
-          <a:p xmlns:a="http://schemas.openxmlformats.org/drawingml/2006/main">
-            <a:pPr>
-              <a:defRPr sz="2100" b="0">
-                <a:solidFill>
-                  <a:srgbClr val="283A39"/>
-                </a:solidFill>
-                <a:latin typeface="Arial"/>
-                <a:ea typeface="Arial"/>
-                <a:cs typeface="Arial"/>
-              </a:defRPr>
-            </a:pPr>
-            <a:r>
-              <a:rPr sz="2100" b="0">
-                <a:solidFill>
-                  <a:srgbClr val="283A39"/>
-                </a:solidFill>
-                <a:latin typeface="Arial"/>
-                <a:ea typeface="Arial"/>
-                <a:cs typeface="Arial"/>
-              </a:rPr>
-              <a:t>when requested.</a:t>
-            </a:r>
-          </a:p>
-        </p:txBody>
-      </p:sp>
-      <p:sp>
-        <p:nvSpPr>
-          <p:cNvPr id="6" name="">
-            <a:extLst xmlns:a="http://schemas.openxmlformats.org/drawingml/2006/main">
-              <a:ext uri="{FF2B5EF4-FFF2-40B4-BE49-F238E27FC236}">
-                <a16:creationId xmlns:a16="http://schemas.microsoft.com/office/drawing/2014/main" id="{BF2ADC9D-31D5-4223-9BB7-15F5B1A01529}"/>
-              </a:ext>
-            </a:extLst>
-          </p:cNvPr>
-          <p:cNvSpPr>
-            <a:spLocks xmlns:a="http://schemas.openxmlformats.org/drawingml/2006/main" noGrp="1"/>
-          </p:cNvSpPr>
-          <p:nvPr/>
-        </p:nvSpPr>
-        <p:spPr>
-          <a:xfrm xmlns:a="http://schemas.openxmlformats.org/drawingml/2006/main">
-            <a:off x="6381750" y="1609725"/>
-            <a:ext cx="5191125" cy="457200"/>
-          </a:xfrm>
-          <a:prstGeom xmlns:a="http://schemas.openxmlformats.org/drawingml/2006/main" prst="rect">
-            <a:avLst/>
-          </a:prstGeom>
-          <a:noFill xmlns:a="http://schemas.openxmlformats.org/drawingml/2006/main"/>
-          <a:ln xmlns:a="http://schemas.openxmlformats.org/drawingml/2006/main" w="0">
-            <a:noFill/>
-          </a:ln>
-        </p:spPr>
-        <p:txBody>
-          <a:bodyPr xmlns:a="http://schemas.openxmlformats.org/drawingml/2006/main">
-            <a:noAutofit/>
-          </a:bodyPr>
-          <a:lstStyle xmlns:a="http://schemas.openxmlformats.org/drawingml/2006/main"/>
-          <a:p xmlns:a="http://schemas.openxmlformats.org/drawingml/2006/main">
-            <a:pPr>
-              <a:defRPr sz="2550" b="1">
-                <a:solidFill>
-                  <a:srgbClr val="183F3B"/>
-                </a:solidFill>
-                <a:latin typeface="Arial"/>
-                <a:ea typeface="Arial"/>
-                <a:cs typeface="Arial"/>
-              </a:defRPr>
-            </a:pPr>
-            <a:r>
-              <a:rPr sz="2550" b="1">
-                <a:solidFill>
-                  <a:srgbClr val="183F3B"/>
-                </a:solidFill>
-                <a:latin typeface="Arial"/>
-                <a:ea typeface="Arial"/>
-                <a:cs typeface="Arial"/>
-              </a:rPr>
-              <a:t>Claude Code</a:t>
-            </a:r>
-          </a:p>
-        </p:txBody>
-      </p:sp>
-      <p:sp>
-        <p:nvSpPr>
-          <p:cNvPr id="7" name="">
-            <a:extLst xmlns:a="http://schemas.openxmlformats.org/drawingml/2006/main">
-              <a:ext uri="{FF2B5EF4-FFF2-40B4-BE49-F238E27FC236}">
-                <a16:creationId xmlns:a16="http://schemas.microsoft.com/office/drawing/2014/main" id="{1C1AF5BD-1D20-48E0-B69E-EDE9E7DCE6EB}"/>
-              </a:ext>
-            </a:extLst>
-          </p:cNvPr>
-          <p:cNvSpPr>
-            <a:spLocks xmlns:a="http://schemas.openxmlformats.org/drawingml/2006/main" noGrp="1"/>
-          </p:cNvSpPr>
-          <p:nvPr/>
-        </p:nvSpPr>
-        <p:spPr>
-          <a:xfrm xmlns:a="http://schemas.openxmlformats.org/drawingml/2006/main">
-            <a:off x="6381750" y="2257425"/>
-            <a:ext cx="5191125" cy="933450"/>
-          </a:xfrm>
-          <a:prstGeom xmlns:a="http://schemas.openxmlformats.org/drawingml/2006/main" prst="rect">
-            <a:avLst/>
-          </a:prstGeom>
-          <a:noFill xmlns:a="http://schemas.openxmlformats.org/drawingml/2006/main"/>
-          <a:ln xmlns:a="http://schemas.openxmlformats.org/drawingml/2006/main" w="0">
-            <a:noFill/>
-          </a:ln>
-        </p:spPr>
-        <p:txBody>
-          <a:bodyPr xmlns:a="http://schemas.openxmlformats.org/drawingml/2006/main">
-            <a:noAutofit/>
-          </a:bodyPr>
-          <a:lstStyle xmlns:a="http://schemas.openxmlformats.org/drawingml/2006/main"/>
-          <a:p xmlns:a="http://schemas.openxmlformats.org/drawingml/2006/main">
-            <a:pPr>
-              <a:defRPr sz="2250" b="0">
-                <a:solidFill>
-                  <a:srgbClr val="283A39"/>
-                </a:solidFill>
-                <a:latin typeface="Arial"/>
-                <a:ea typeface="Arial"/>
-                <a:cs typeface="Arial"/>
-              </a:defRPr>
-            </a:pPr>
-            <a:r>
-              <a:rPr sz="2250" b="0">
-                <a:solidFill>
-                  <a:srgbClr val="283A39"/>
-                </a:solidFill>
-                <a:latin typeface="Arial"/>
-                <a:ea typeface="Arial"/>
-                <a:cs typeface="Arial"/>
-              </a:rPr>
-              <a:t>Choose Accept edits.</a:t>
-            </a:r>
-          </a:p>
-          <a:p xmlns:a="http://schemas.openxmlformats.org/drawingml/2006/main">
-            <a:pPr>
-              <a:defRPr sz="2250" b="0">
-                <a:solidFill>
-                  <a:srgbClr val="283A39"/>
-                </a:solidFill>
-                <a:latin typeface="Arial"/>
-                <a:ea typeface="Arial"/>
-                <a:cs typeface="Arial"/>
-              </a:defRPr>
-            </a:pPr>
-            <a:r>
-              <a:rPr sz="2250" b="0">
-                <a:solidFill>
-                  <a:srgbClr val="283A39"/>
-                </a:solidFill>
-                <a:latin typeface="Arial"/>
-                <a:ea typeface="Arial"/>
-                <a:cs typeface="Arial"/>
-              </a:rPr>
-              <a:t>Manual works with your approvals.</a:t>
-            </a:r>
-          </a:p>
-        </p:txBody>
-      </p:sp>
-      <p:sp>
-        <p:nvSpPr>
-          <p:cNvPr id="8" name="">
-            <a:extLst xmlns:a="http://schemas.openxmlformats.org/drawingml/2006/main">
-              <a:ext uri="{FF2B5EF4-FFF2-40B4-BE49-F238E27FC236}">
-                <a16:creationId xmlns:a16="http://schemas.microsoft.com/office/drawing/2014/main" id="{0C33F1E0-2263-4A5D-BFF1-CAAA21A89221}"/>
-              </a:ext>
-            </a:extLst>
-          </p:cNvPr>
-          <p:cNvSpPr>
-            <a:spLocks xmlns:a="http://schemas.openxmlformats.org/drawingml/2006/main" noGrp="1"/>
-          </p:cNvSpPr>
-          <p:nvPr/>
-        </p:nvSpPr>
-        <p:spPr>
-          <a:xfrm xmlns:a="http://schemas.openxmlformats.org/drawingml/2006/main">
-            <a:off x="6381750" y="3533775"/>
-            <a:ext cx="5191125" cy="1428750"/>
-          </a:xfrm>
-          <a:prstGeom xmlns:a="http://schemas.openxmlformats.org/drawingml/2006/main" prst="rect">
-            <a:avLst/>
-          </a:prstGeom>
-          <a:noFill xmlns:a="http://schemas.openxmlformats.org/drawingml/2006/main"/>
-          <a:ln xmlns:a="http://schemas.openxmlformats.org/drawingml/2006/main" w="0">
-            <a:noFill/>
-          </a:ln>
-        </p:spPr>
-        <p:txBody>
-          <a:bodyPr xmlns:a="http://schemas.openxmlformats.org/drawingml/2006/main">
-            <a:noAutofit/>
-          </a:bodyPr>
-          <a:lstStyle xmlns:a="http://schemas.openxmlformats.org/drawingml/2006/main"/>
-          <a:p xmlns:a="http://schemas.openxmlformats.org/drawingml/2006/main">
-            <a:pPr>
-              <a:defRPr sz="2100" b="0">
-                <a:solidFill>
-                  <a:srgbClr val="283A39"/>
-                </a:solidFill>
-                <a:latin typeface="Arial"/>
-                <a:ea typeface="Arial"/>
-                <a:cs typeface="Arial"/>
-              </a:defRPr>
-            </a:pPr>
-            <a:r>
-              <a:rPr sz="2100" b="0">
-                <a:solidFill>
-                  <a:srgbClr val="283A39"/>
-                </a:solidFill>
-                <a:latin typeface="Arial"/>
-                <a:ea typeface="Arial"/>
-                <a:cs typeface="Arial"/>
-              </a:rPr>
-              <a:t>Leave Plan mode to install</a:t>
-            </a:r>
-          </a:p>
-          <a:p xmlns:a="http://schemas.openxmlformats.org/drawingml/2006/main">
-            <a:pPr>
-              <a:defRPr sz="2100" b="0">
-                <a:solidFill>
-                  <a:srgbClr val="283A39"/>
-                </a:solidFill>
-                <a:latin typeface="Arial"/>
-                <a:ea typeface="Arial"/>
-                <a:cs typeface="Arial"/>
-              </a:defRPr>
-            </a:pPr>
-            <a:r>
-              <a:rPr sz="2100" b="0">
-                <a:solidFill>
-                  <a:srgbClr val="283A39"/>
-                </a:solidFill>
-                <a:latin typeface="Arial"/>
-                <a:ea typeface="Arial"/>
-                <a:cs typeface="Arial"/>
-              </a:rPr>
-              <a:t>and save files. Some commands</a:t>
-            </a:r>
-          </a:p>
-          <a:p xmlns:a="http://schemas.openxmlformats.org/drawingml/2006/main">
-            <a:pPr>
-              <a:defRPr sz="2100" b="0">
-                <a:solidFill>
-                  <a:srgbClr val="283A39"/>
-                </a:solidFill>
-                <a:latin typeface="Arial"/>
-                <a:ea typeface="Arial"/>
-                <a:cs typeface="Arial"/>
-              </a:defRPr>
-            </a:pPr>
-            <a:r>
-              <a:rPr sz="2100" b="0">
-                <a:solidFill>
-                  <a:srgbClr val="283A39"/>
-                </a:solidFill>
-                <a:latin typeface="Arial"/>
-                <a:ea typeface="Arial"/>
-                <a:cs typeface="Arial"/>
-              </a:rPr>
-              <a:t>can still need approval.</a:t>
-            </a:r>
-          </a:p>
-        </p:txBody>
-      </p:sp>
-      <p:sp>
-        <p:nvSpPr>
-          <p:cNvPr id="9" name="">
-            <a:extLst xmlns:a="http://schemas.openxmlformats.org/drawingml/2006/main">
-              <a:ext uri="{FF2B5EF4-FFF2-40B4-BE49-F238E27FC236}">
-                <a16:creationId xmlns:a16="http://schemas.microsoft.com/office/drawing/2014/main" id="{BFB384D1-6718-4EF0-BE97-6A218C4C9E13}"/>
-              </a:ext>
-            </a:extLst>
-          </p:cNvPr>
-          <p:cNvSpPr>
-            <a:spLocks xmlns:a="http://schemas.openxmlformats.org/drawingml/2006/main" noGrp="1"/>
-          </p:cNvSpPr>
-          <p:nvPr/>
-        </p:nvSpPr>
-        <p:spPr>
-          <a:xfrm xmlns:a="http://schemas.openxmlformats.org/drawingml/2006/main">
-            <a:off x="609600" y="5648325"/>
-            <a:ext cx="10906125" cy="590550"/>
-          </a:xfrm>
-          <a:prstGeom xmlns:a="http://schemas.openxmlformats.org/drawingml/2006/main" prst="rect">
-            <a:avLst/>
-          </a:prstGeom>
-          <a:noFill xmlns:a="http://schemas.openxmlformats.org/drawingml/2006/main"/>
-          <a:ln xmlns:a="http://schemas.openxmlformats.org/drawingml/2006/main" w="0">
-            <a:noFill/>
-          </a:ln>
-        </p:spPr>
-        <p:txBody>
-          <a:bodyPr xmlns:a="http://schemas.openxmlformats.org/drawingml/2006/main">
-            <a:noAutofit/>
-          </a:bodyPr>
-          <a:lstStyle xmlns:a="http://schemas.openxmlformats.org/drawingml/2006/main"/>
-          <a:p xmlns:a="http://schemas.openxmlformats.org/drawingml/2006/main">
-            <a:pPr>
               <a:defRPr sz="1800" b="0">
                 <a:solidFill>
                   <a:srgbClr val="607370"/>
@@ -5453,7 +5550,30 @@
                 <a:ea typeface="Arial"/>
                 <a:cs typeface="Arial"/>
               </a:rPr>
-              <a:t>Full access and Bypass permissions are optional broader modes. The skill does not require them.</a:t>
+              <a:t>Full access allows internet and file access across your computer,</a:t>
+            </a:r>
+          </a:p>
+          <a:p xmlns:a="http://schemas.openxmlformats.org/drawingml/2006/main">
+            <a:pPr>
+              <a:defRPr sz="1800" b="0">
+                <a:solidFill>
+                  <a:srgbClr val="607370"/>
+                </a:solidFill>
+                <a:latin typeface="Arial"/>
+                <a:ea typeface="Arial"/>
+                <a:cs typeface="Arial"/>
+              </a:defRPr>
+            </a:pPr>
+            <a:r>
+              <a:rPr sz="1800" b="0">
+                <a:solidFill>
+                  <a:srgbClr val="607370"/>
+                </a:solidFill>
+                <a:latin typeface="Arial"/>
+                <a:ea typeface="Arial"/>
+                <a:cs typeface="Arial"/>
+              </a:rPr>
+              <a:t>including files outside the selected project.</a:t>
             </a:r>
           </a:p>
         </p:txBody>
@@ -5461,7 +5581,7 @@
     </p:spTree>
     <p:extLst>
       <p:ext uri="{BB962C8B-B14F-4D97-AF65-F5344CB8AC3E}">
-        <p14:creationId xmlns:p14="http://schemas.microsoft.com/office/powerpoint/2010/main" val="951964569"/>
+        <p14:creationId xmlns:p14="http://schemas.microsoft.com/office/powerpoint/2010/main" val="60857296"/>
       </p:ext>
     </p:extLst>
   </p:cSld>
@@ -5489,10 +5609,10 @@
       </p:grpSpPr>
       <p:sp>
         <p:nvSpPr>
-          <p:cNvPr id="8" name="">
+          <p:cNvPr id="6" name="">
             <a:extLst xmlns:a="http://schemas.openxmlformats.org/drawingml/2006/main">
               <a:ext uri="{FF2B5EF4-FFF2-40B4-BE49-F238E27FC236}">
-                <a16:creationId xmlns:a16="http://schemas.microsoft.com/office/drawing/2014/main" id="{D813A12F-D5E8-41D3-8AEA-AEF86E7B5245}"/>
+                <a16:creationId xmlns:a16="http://schemas.microsoft.com/office/drawing/2014/main" id="{49C52A71-A5FE-404F-B48E-FF80AAFDA165}"/>
               </a:ext>
             </a:extLst>
           </p:cNvPr>
@@ -5539,7 +5659,7 @@
                 <a:ea typeface="Arial"/>
                 <a:cs typeface="Arial"/>
               </a:rPr>
-              <a:t>2. Your resume</a:t>
+              <a:t>1. Claude Code: Auto</a:t>
             </a:r>
           </a:p>
         </p:txBody>
@@ -5549,7 +5669,7 @@
           <p:cNvPr id="2" name="">
             <a:extLst xmlns:a="http://schemas.openxmlformats.org/drawingml/2006/main">
               <a:ext uri="{FF2B5EF4-FFF2-40B4-BE49-F238E27FC236}">
-                <a16:creationId xmlns:a16="http://schemas.microsoft.com/office/drawing/2014/main" id="{7EFBF8FA-4B3D-4D44-9473-179439BA8E0C}"/>
+                <a16:creationId xmlns:a16="http://schemas.microsoft.com/office/drawing/2014/main" id="{25118A3D-352D-4D6C-9A03-7F82DD0BBFC4}"/>
               </a:ext>
             </a:extLst>
           </p:cNvPr>
@@ -5606,7 +5726,7 @@
           <p:cNvPr id="3" name="">
             <a:extLst xmlns:a="http://schemas.openxmlformats.org/drawingml/2006/main">
               <a:ext uri="{FF2B5EF4-FFF2-40B4-BE49-F238E27FC236}">
-                <a16:creationId xmlns:a16="http://schemas.microsoft.com/office/drawing/2014/main" id="{86B4390B-F361-4183-B46F-10250FE12D42}"/>
+                <a16:creationId xmlns:a16="http://schemas.microsoft.com/office/drawing/2014/main" id="{30E5398F-769D-4DD1-BCC4-D00C885B531C}"/>
               </a:ext>
             </a:extLst>
           </p:cNvPr>
@@ -5617,8 +5737,8 @@
         </p:nvSpPr>
         <p:spPr>
           <a:xfrm xmlns:a="http://schemas.openxmlformats.org/drawingml/2006/main">
-            <a:off x="609600" y="1524000"/>
-            <a:ext cx="10477500" cy="457200"/>
+            <a:off x="609600" y="1409700"/>
+            <a:ext cx="10858500" cy="590550"/>
           </a:xfrm>
           <a:prstGeom xmlns:a="http://schemas.openxmlformats.org/drawingml/2006/main" prst="rect">
             <a:avLst/>
@@ -5635,35 +5755,57 @@
           <a:lstStyle xmlns:a="http://schemas.openxmlformats.org/drawingml/2006/main"/>
           <a:p xmlns:a="http://schemas.openxmlformats.org/drawingml/2006/main">
             <a:pPr>
-              <a:defRPr sz="2550" b="1">
-                <a:solidFill>
-                  <a:srgbClr val="183F3B"/>
-                </a:solidFill>
-                <a:latin typeface="Arial"/>
-                <a:ea typeface="Arial"/>
-                <a:cs typeface="Arial"/>
-              </a:defRPr>
-            </a:pPr>
-            <a:r>
-              <a:rPr sz="2550" b="1">
-                <a:solidFill>
-                  <a:srgbClr val="183F3B"/>
-                </a:solidFill>
-                <a:latin typeface="Arial"/>
-                <a:ea typeface="Arial"/>
-                <a:cs typeface="Arial"/>
-              </a:rPr>
-              <a:t>If you have one</a:t>
-            </a:r>
-          </a:p>
-        </p:txBody>
-      </p:sp>
-      <p:sp>
-        <p:nvSpPr>
-          <p:cNvPr id="4" name="">
+              <a:defRPr sz="2175" b="0">
+                <a:solidFill>
+                  <a:srgbClr val="283A39"/>
+                </a:solidFill>
+                <a:latin typeface="Arial"/>
+                <a:ea typeface="Arial"/>
+                <a:cs typeface="Arial"/>
+              </a:defRPr>
+            </a:pPr>
+            <a:r>
+              <a:rPr sz="2175" b="0">
+                <a:solidFill>
+                  <a:srgbClr val="283A39"/>
+                </a:solidFill>
+                <a:latin typeface="Arial"/>
+                <a:ea typeface="Arial"/>
+                <a:cs typeface="Arial"/>
+              </a:rPr>
+              <a:t>Click the mode label below your message. Select Auto.</a:t>
+            </a:r>
+          </a:p>
+        </p:txBody>
+      </p:sp>
+      <p:pic>
+        <p:nvPicPr>
+          <p:cNvPr id="9" name=""/>
+          <p:cNvPicPr>
+            <a:picLocks xmlns:a="http://schemas.openxmlformats.org/drawingml/2006/main" noChangeAspect="1"/>
+          </p:cNvPicPr>
+          <p:nvPr/>
+        </p:nvPicPr>
+        <p:blipFill>
+          <a:blip xmlns:r="http://schemas.openxmlformats.org/officeDocument/2006/relationships" xmlns:a="http://schemas.openxmlformats.org/drawingml/2006/main" r:embed="R6e31c458a3cc4a6b"/>
+          <a:stretch xmlns:a="http://schemas.openxmlformats.org/drawingml/2006/main"/>
+        </p:blipFill>
+        <p:spPr>
+          <a:xfrm xmlns:a="http://schemas.openxmlformats.org/drawingml/2006/main">
+            <a:off x="1143000" y="2154114"/>
+            <a:ext cx="9906000" cy="3426072"/>
+          </a:xfrm>
+          <a:prstGeom xmlns:a="http://schemas.openxmlformats.org/drawingml/2006/main" prst="rect">
+            <a:avLst/>
+          </a:prstGeom>
+        </p:spPr>
+      </p:pic>
+      <p:sp>
+        <p:nvSpPr>
+          <p:cNvPr id="5" name="">
             <a:extLst xmlns:a="http://schemas.openxmlformats.org/drawingml/2006/main">
               <a:ext uri="{FF2B5EF4-FFF2-40B4-BE49-F238E27FC236}">
-                <a16:creationId xmlns:a16="http://schemas.microsoft.com/office/drawing/2014/main" id="{E8F14A33-2372-46EA-96C6-6CD9167249C6}"/>
+                <a16:creationId xmlns:a16="http://schemas.microsoft.com/office/drawing/2014/main" id="{7BAFA447-E449-4C96-984D-B994008A41E5}"/>
               </a:ext>
             </a:extLst>
           </p:cNvPr>
@@ -5674,8 +5816,8 @@
         </p:nvSpPr>
         <p:spPr>
           <a:xfrm xmlns:a="http://schemas.openxmlformats.org/drawingml/2006/main">
-            <a:off x="609600" y="2143125"/>
-            <a:ext cx="10820400" cy="1009650"/>
+            <a:off x="609600" y="5800725"/>
+            <a:ext cx="10934700" cy="590550"/>
           </a:xfrm>
           <a:prstGeom xmlns:a="http://schemas.openxmlformats.org/drawingml/2006/main" prst="rect">
             <a:avLst/>
@@ -5692,200 +5834,6 @@
           <a:lstStyle xmlns:a="http://schemas.openxmlformats.org/drawingml/2006/main"/>
           <a:p xmlns:a="http://schemas.openxmlformats.org/drawingml/2006/main">
             <a:pPr>
-              <a:defRPr sz="2250" b="0">
-                <a:solidFill>
-                  <a:srgbClr val="283A39"/>
-                </a:solidFill>
-                <a:latin typeface="Arial"/>
-                <a:ea typeface="Arial"/>
-                <a:cs typeface="Arial"/>
-              </a:defRPr>
-            </a:pPr>
-            <a:r>
-              <a:rPr sz="2250" b="0">
-                <a:solidFill>
-                  <a:srgbClr val="283A39"/>
-                </a:solidFill>
-                <a:latin typeface="Arial"/>
-                <a:ea typeface="Arial"/>
-                <a:cs typeface="Arial"/>
-              </a:rPr>
-              <a:t>Attach your PDF or Word file before sending the first message.</a:t>
-            </a:r>
-          </a:p>
-          <a:p xmlns:a="http://schemas.openxmlformats.org/drawingml/2006/main">
-            <a:pPr>
-              <a:defRPr sz="2250" b="0">
-                <a:solidFill>
-                  <a:srgbClr val="283A39"/>
-                </a:solidFill>
-                <a:latin typeface="Arial"/>
-                <a:ea typeface="Arial"/>
-                <a:cs typeface="Arial"/>
-              </a:defRPr>
-            </a:pPr>
-            <a:r>
-              <a:rPr sz="2250" b="0">
-                <a:solidFill>
-                  <a:srgbClr val="283A39"/>
-                </a:solidFill>
-                <a:latin typeface="Arial"/>
-                <a:ea typeface="Arial"/>
-                <a:cs typeface="Arial"/>
-              </a:rPr>
-              <a:t>If attachments are unavailable, paste its full file location.</a:t>
-            </a:r>
-          </a:p>
-        </p:txBody>
-      </p:sp>
-      <p:sp>
-        <p:nvSpPr>
-          <p:cNvPr id="5" name="">
-            <a:extLst xmlns:a="http://schemas.openxmlformats.org/drawingml/2006/main">
-              <a:ext uri="{FF2B5EF4-FFF2-40B4-BE49-F238E27FC236}">
-                <a16:creationId xmlns:a16="http://schemas.microsoft.com/office/drawing/2014/main" id="{1491C6DC-2AE7-4E5B-851E-5689106C80CA}"/>
-              </a:ext>
-            </a:extLst>
-          </p:cNvPr>
-          <p:cNvSpPr>
-            <a:spLocks xmlns:a="http://schemas.openxmlformats.org/drawingml/2006/main" noGrp="1"/>
-          </p:cNvSpPr>
-          <p:nvPr/>
-        </p:nvSpPr>
-        <p:spPr>
-          <a:xfrm xmlns:a="http://schemas.openxmlformats.org/drawingml/2006/main">
-            <a:off x="609600" y="3629025"/>
-            <a:ext cx="10477500" cy="457200"/>
-          </a:xfrm>
-          <a:prstGeom xmlns:a="http://schemas.openxmlformats.org/drawingml/2006/main" prst="rect">
-            <a:avLst/>
-          </a:prstGeom>
-          <a:noFill xmlns:a="http://schemas.openxmlformats.org/drawingml/2006/main"/>
-          <a:ln xmlns:a="http://schemas.openxmlformats.org/drawingml/2006/main" w="0">
-            <a:noFill/>
-          </a:ln>
-        </p:spPr>
-        <p:txBody>
-          <a:bodyPr xmlns:a="http://schemas.openxmlformats.org/drawingml/2006/main">
-            <a:noAutofit/>
-          </a:bodyPr>
-          <a:lstStyle xmlns:a="http://schemas.openxmlformats.org/drawingml/2006/main"/>
-          <a:p xmlns:a="http://schemas.openxmlformats.org/drawingml/2006/main">
-            <a:pPr>
-              <a:defRPr sz="2550" b="1">
-                <a:solidFill>
-                  <a:srgbClr val="183F3B"/>
-                </a:solidFill>
-                <a:latin typeface="Arial"/>
-                <a:ea typeface="Arial"/>
-                <a:cs typeface="Arial"/>
-              </a:defRPr>
-            </a:pPr>
-            <a:r>
-              <a:rPr sz="2550" b="1">
-                <a:solidFill>
-                  <a:srgbClr val="183F3B"/>
-                </a:solidFill>
-                <a:latin typeface="Arial"/>
-                <a:ea typeface="Arial"/>
-                <a:cs typeface="Arial"/>
-              </a:rPr>
-              <a:t>If you do not have one</a:t>
-            </a:r>
-          </a:p>
-        </p:txBody>
-      </p:sp>
-      <p:sp>
-        <p:nvSpPr>
-          <p:cNvPr id="6" name="">
-            <a:extLst xmlns:a="http://schemas.openxmlformats.org/drawingml/2006/main">
-              <a:ext uri="{FF2B5EF4-FFF2-40B4-BE49-F238E27FC236}">
-                <a16:creationId xmlns:a16="http://schemas.microsoft.com/office/drawing/2014/main" id="{EB740E82-93B4-4F2A-BDE5-D647D41FD8D3}"/>
-              </a:ext>
-            </a:extLst>
-          </p:cNvPr>
-          <p:cNvSpPr>
-            <a:spLocks xmlns:a="http://schemas.openxmlformats.org/drawingml/2006/main" noGrp="1"/>
-          </p:cNvSpPr>
-          <p:nvPr/>
-        </p:nvSpPr>
-        <p:spPr>
-          <a:xfrm xmlns:a="http://schemas.openxmlformats.org/drawingml/2006/main">
-            <a:off x="609600" y="4257675"/>
-            <a:ext cx="10820400" cy="695325"/>
-          </a:xfrm>
-          <a:prstGeom xmlns:a="http://schemas.openxmlformats.org/drawingml/2006/main" prst="rect">
-            <a:avLst/>
-          </a:prstGeom>
-          <a:noFill xmlns:a="http://schemas.openxmlformats.org/drawingml/2006/main"/>
-          <a:ln xmlns:a="http://schemas.openxmlformats.org/drawingml/2006/main" w="0">
-            <a:noFill/>
-          </a:ln>
-        </p:spPr>
-        <p:txBody>
-          <a:bodyPr xmlns:a="http://schemas.openxmlformats.org/drawingml/2006/main">
-            <a:noAutofit/>
-          </a:bodyPr>
-          <a:lstStyle xmlns:a="http://schemas.openxmlformats.org/drawingml/2006/main"/>
-          <a:p xmlns:a="http://schemas.openxmlformats.org/drawingml/2006/main">
-            <a:pPr>
-              <a:defRPr sz="2250" b="0">
-                <a:solidFill>
-                  <a:srgbClr val="283A39"/>
-                </a:solidFill>
-                <a:latin typeface="Arial"/>
-                <a:ea typeface="Arial"/>
-                <a:cs typeface="Arial"/>
-              </a:defRPr>
-            </a:pPr>
-            <a:r>
-              <a:rPr sz="2250" b="0">
-                <a:solidFill>
-                  <a:srgbClr val="283A39"/>
-                </a:solidFill>
-                <a:latin typeface="Arial"/>
-                <a:ea typeface="Arial"/>
-                <a:cs typeface="Arial"/>
-              </a:rPr>
-              <a:t>Add: “I do not have a resume yet. Help me build one.”</a:t>
-            </a:r>
-          </a:p>
-        </p:txBody>
-      </p:sp>
-      <p:sp>
-        <p:nvSpPr>
-          <p:cNvPr id="7" name="">
-            <a:extLst xmlns:a="http://schemas.openxmlformats.org/drawingml/2006/main">
-              <a:ext uri="{FF2B5EF4-FFF2-40B4-BE49-F238E27FC236}">
-                <a16:creationId xmlns:a16="http://schemas.microsoft.com/office/drawing/2014/main" id="{3ACB7B28-C012-4E8C-BDB7-126F2A735EBA}"/>
-              </a:ext>
-            </a:extLst>
-          </p:cNvPr>
-          <p:cNvSpPr>
-            <a:spLocks xmlns:a="http://schemas.openxmlformats.org/drawingml/2006/main" noGrp="1"/>
-          </p:cNvSpPr>
-          <p:nvPr/>
-        </p:nvSpPr>
-        <p:spPr>
-          <a:xfrm xmlns:a="http://schemas.openxmlformats.org/drawingml/2006/main">
-            <a:off x="609600" y="5629275"/>
-            <a:ext cx="10839450" cy="590550"/>
-          </a:xfrm>
-          <a:prstGeom xmlns:a="http://schemas.openxmlformats.org/drawingml/2006/main" prst="rect">
-            <a:avLst/>
-          </a:prstGeom>
-          <a:noFill xmlns:a="http://schemas.openxmlformats.org/drawingml/2006/main"/>
-          <a:ln xmlns:a="http://schemas.openxmlformats.org/drawingml/2006/main" w="0">
-            <a:noFill/>
-          </a:ln>
-        </p:spPr>
-        <p:txBody>
-          <a:bodyPr xmlns:a="http://schemas.openxmlformats.org/drawingml/2006/main">
-            <a:noAutofit/>
-          </a:bodyPr>
-          <a:lstStyle xmlns:a="http://schemas.openxmlformats.org/drawingml/2006/main"/>
-          <a:p xmlns:a="http://schemas.openxmlformats.org/drawingml/2006/main">
-            <a:pPr>
               <a:defRPr sz="1800" b="0">
                 <a:solidFill>
                   <a:srgbClr val="607370"/>
@@ -5904,7 +5852,30 @@
                 <a:ea typeface="Arial"/>
                 <a:cs typeface="Arial"/>
               </a:rPr>
-              <a:t>The AI checks that it can read the file. It can also build a resume from your real experience.</a:t>
+              <a:t>Claude handles permission decisions with background safety checks.</a:t>
+            </a:r>
+          </a:p>
+          <a:p xmlns:a="http://schemas.openxmlformats.org/drawingml/2006/main">
+            <a:pPr>
+              <a:defRPr sz="1800" b="0">
+                <a:solidFill>
+                  <a:srgbClr val="607370"/>
+                </a:solidFill>
+                <a:latin typeface="Arial"/>
+                <a:ea typeface="Arial"/>
+                <a:cs typeface="Arial"/>
+              </a:defRPr>
+            </a:pPr>
+            <a:r>
+              <a:rPr sz="1800" b="0">
+                <a:solidFill>
+                  <a:srgbClr val="607370"/>
+                </a:solidFill>
+                <a:latin typeface="Arial"/>
+                <a:ea typeface="Arial"/>
+                <a:cs typeface="Arial"/>
+              </a:rPr>
+              <a:t>Some actions can still require your input.</a:t>
             </a:r>
           </a:p>
         </p:txBody>
@@ -5912,7 +5883,7 @@
     </p:spTree>
     <p:extLst>
       <p:ext uri="{BB962C8B-B14F-4D97-AF65-F5344CB8AC3E}">
-        <p14:creationId xmlns:p14="http://schemas.microsoft.com/office/powerpoint/2010/main" val="2007955867"/>
+        <p14:creationId xmlns:p14="http://schemas.microsoft.com/office/powerpoint/2010/main" val="469894403"/>
       </p:ext>
     </p:extLst>
   </p:cSld>
@@ -5940,10 +5911,10 @@
       </p:grpSpPr>
       <p:sp>
         <p:nvSpPr>
-          <p:cNvPr id="7" name="">
+          <p:cNvPr id="8" name="">
             <a:extLst xmlns:a="http://schemas.openxmlformats.org/drawingml/2006/main">
               <a:ext uri="{FF2B5EF4-FFF2-40B4-BE49-F238E27FC236}">
-                <a16:creationId xmlns:a16="http://schemas.microsoft.com/office/drawing/2014/main" id="{A2D4058B-70C0-4A8F-8EF4-6D79B2C5E827}"/>
+                <a16:creationId xmlns:a16="http://schemas.microsoft.com/office/drawing/2014/main" id="{94FDED7C-9F5E-4541-B9E0-A1FE979D4586}"/>
               </a:ext>
             </a:extLst>
           </p:cNvPr>
@@ -5990,7 +5961,7 @@
                 <a:ea typeface="Arial"/>
                 <a:cs typeface="Arial"/>
               </a:rPr>
-              <a:t>3. Your first message</a:t>
+              <a:t>2. Your resume</a:t>
             </a:r>
           </a:p>
         </p:txBody>
@@ -6000,7 +5971,7 @@
           <p:cNvPr id="2" name="">
             <a:extLst xmlns:a="http://schemas.openxmlformats.org/drawingml/2006/main">
               <a:ext uri="{FF2B5EF4-FFF2-40B4-BE49-F238E27FC236}">
-                <a16:creationId xmlns:a16="http://schemas.microsoft.com/office/drawing/2014/main" id="{2090260A-DEC2-493C-BAFD-FEB4E258C801}"/>
+                <a16:creationId xmlns:a16="http://schemas.microsoft.com/office/drawing/2014/main" id="{2A8BD5DA-19B8-4AAB-8C47-996D00447431}"/>
               </a:ext>
             </a:extLst>
           </p:cNvPr>
@@ -6057,7 +6028,7 @@
           <p:cNvPr id="3" name="">
             <a:extLst xmlns:a="http://schemas.openxmlformats.org/drawingml/2006/main">
               <a:ext uri="{FF2B5EF4-FFF2-40B4-BE49-F238E27FC236}">
-                <a16:creationId xmlns:a16="http://schemas.microsoft.com/office/drawing/2014/main" id="{ADC7DCBA-A946-4B37-B111-D39C3915E7E2}"/>
+                <a16:creationId xmlns:a16="http://schemas.microsoft.com/office/drawing/2014/main" id="{24C79583-9948-4C50-9182-CD089D4D69C7}"/>
               </a:ext>
             </a:extLst>
           </p:cNvPr>
@@ -6068,8 +6039,8 @@
         </p:nvSpPr>
         <p:spPr>
           <a:xfrm xmlns:a="http://schemas.openxmlformats.org/drawingml/2006/main">
-            <a:off x="609600" y="1457325"/>
-            <a:ext cx="10858500" cy="590550"/>
+            <a:off x="609600" y="1524000"/>
+            <a:ext cx="10477500" cy="457200"/>
           </a:xfrm>
           <a:prstGeom xmlns:a="http://schemas.openxmlformats.org/drawingml/2006/main" prst="rect">
             <a:avLst/>
@@ -6086,25 +6057,25 @@
           <a:lstStyle xmlns:a="http://schemas.openxmlformats.org/drawingml/2006/main"/>
           <a:p xmlns:a="http://schemas.openxmlformats.org/drawingml/2006/main">
             <a:pPr>
-              <a:defRPr sz="2100" b="0">
-                <a:solidFill>
-                  <a:srgbClr val="283A39"/>
-                </a:solidFill>
-                <a:latin typeface="Arial"/>
-                <a:ea typeface="Arial"/>
-                <a:cs typeface="Arial"/>
-              </a:defRPr>
-            </a:pPr>
-            <a:r>
-              <a:rPr sz="2100" b="0">
-                <a:solidFill>
-                  <a:srgbClr val="283A39"/>
-                </a:solidFill>
-                <a:latin typeface="Arial"/>
-                <a:ea typeface="Arial"/>
-                <a:cs typeface="Arial"/>
-              </a:rPr>
-              <a:t>Copy both lines into the same message box as your resume:</a:t>
+              <a:defRPr sz="2550" b="1">
+                <a:solidFill>
+                  <a:srgbClr val="183F3B"/>
+                </a:solidFill>
+                <a:latin typeface="Arial"/>
+                <a:ea typeface="Arial"/>
+                <a:cs typeface="Arial"/>
+              </a:defRPr>
+            </a:pPr>
+            <a:r>
+              <a:rPr sz="2550" b="1">
+                <a:solidFill>
+                  <a:srgbClr val="183F3B"/>
+                </a:solidFill>
+                <a:latin typeface="Arial"/>
+                <a:ea typeface="Arial"/>
+                <a:cs typeface="Arial"/>
+              </a:rPr>
+              <a:t>If you have one</a:t>
             </a:r>
           </a:p>
         </p:txBody>
@@ -6114,7 +6085,7 @@
           <p:cNvPr id="4" name="">
             <a:extLst xmlns:a="http://schemas.openxmlformats.org/drawingml/2006/main">
               <a:ext uri="{FF2B5EF4-FFF2-40B4-BE49-F238E27FC236}">
-                <a16:creationId xmlns:a16="http://schemas.microsoft.com/office/drawing/2014/main" id="{33AF967D-D433-4D6D-9974-10BD7B060652}"/>
+                <a16:creationId xmlns:a16="http://schemas.microsoft.com/office/drawing/2014/main" id="{A4E918E6-73F5-4F97-B59F-5B34F1A8B31D}"/>
               </a:ext>
             </a:extLst>
           </p:cNvPr>
@@ -6125,8 +6096,8 @@
         </p:nvSpPr>
         <p:spPr>
           <a:xfrm xmlns:a="http://schemas.openxmlformats.org/drawingml/2006/main">
-            <a:off x="609600" y="2638425"/>
-            <a:ext cx="10972800" cy="1381125"/>
+            <a:off x="609600" y="2143125"/>
+            <a:ext cx="10820400" cy="1009650"/>
           </a:xfrm>
           <a:prstGeom xmlns:a="http://schemas.openxmlformats.org/drawingml/2006/main" prst="rect">
             <a:avLst/>
@@ -6143,48 +6114,48 @@
           <a:lstStyle xmlns:a="http://schemas.openxmlformats.org/drawingml/2006/main"/>
           <a:p xmlns:a="http://schemas.openxmlformats.org/drawingml/2006/main">
             <a:pPr>
-              <a:defRPr sz="2400" b="1">
-                <a:solidFill>
-                  <a:srgbClr val="183F3B"/>
-                </a:solidFill>
-                <a:latin typeface="Arial"/>
-                <a:ea typeface="Arial"/>
-                <a:cs typeface="Arial"/>
-              </a:defRPr>
-            </a:pPr>
-            <a:r>
-              <a:rPr sz="2400" b="1">
-                <a:solidFill>
-                  <a:srgbClr val="183F3B"/>
-                </a:solidFill>
-                <a:latin typeface="Arial"/>
-                <a:ea typeface="Arial"/>
-                <a:cs typeface="Arial"/>
-              </a:rPr>
-              <a:t>Install https://github.com/toughdave/job-search for this project.</a:t>
-            </a:r>
-          </a:p>
-          <a:p xmlns:a="http://schemas.openxmlformats.org/drawingml/2006/main">
-            <a:pPr>
-              <a:defRPr sz="2400" b="1">
-                <a:solidFill>
-                  <a:srgbClr val="183F3B"/>
-                </a:solidFill>
-                <a:latin typeface="Arial"/>
-                <a:ea typeface="Arial"/>
-                <a:cs typeface="Arial"/>
-              </a:defRPr>
-            </a:pPr>
-            <a:r>
-              <a:rPr sz="2400" b="1">
-                <a:solidFill>
-                  <a:srgbClr val="183F3B"/>
-                </a:solidFill>
-                <a:latin typeface="Arial"/>
-                <a:ea typeface="Arial"/>
-                <a:cs typeface="Arial"/>
-              </a:rPr>
-              <a:t>Then use job-search to start my search.</a:t>
+              <a:defRPr sz="2250" b="0">
+                <a:solidFill>
+                  <a:srgbClr val="283A39"/>
+                </a:solidFill>
+                <a:latin typeface="Arial"/>
+                <a:ea typeface="Arial"/>
+                <a:cs typeface="Arial"/>
+              </a:defRPr>
+            </a:pPr>
+            <a:r>
+              <a:rPr sz="2250" b="0">
+                <a:solidFill>
+                  <a:srgbClr val="283A39"/>
+                </a:solidFill>
+                <a:latin typeface="Arial"/>
+                <a:ea typeface="Arial"/>
+                <a:cs typeface="Arial"/>
+              </a:rPr>
+              <a:t>Attach your PDF or Word file before sending the first message.</a:t>
+            </a:r>
+          </a:p>
+          <a:p xmlns:a="http://schemas.openxmlformats.org/drawingml/2006/main">
+            <a:pPr>
+              <a:defRPr sz="2250" b="0">
+                <a:solidFill>
+                  <a:srgbClr val="283A39"/>
+                </a:solidFill>
+                <a:latin typeface="Arial"/>
+                <a:ea typeface="Arial"/>
+                <a:cs typeface="Arial"/>
+              </a:defRPr>
+            </a:pPr>
+            <a:r>
+              <a:rPr sz="2250" b="0">
+                <a:solidFill>
+                  <a:srgbClr val="283A39"/>
+                </a:solidFill>
+                <a:latin typeface="Arial"/>
+                <a:ea typeface="Arial"/>
+                <a:cs typeface="Arial"/>
+              </a:rPr>
+              <a:t>If attachments are unavailable, paste its full file location.</a:t>
             </a:r>
           </a:p>
         </p:txBody>
@@ -6194,7 +6165,7 @@
           <p:cNvPr id="5" name="">
             <a:extLst xmlns:a="http://schemas.openxmlformats.org/drawingml/2006/main">
               <a:ext uri="{FF2B5EF4-FFF2-40B4-BE49-F238E27FC236}">
-                <a16:creationId xmlns:a16="http://schemas.microsoft.com/office/drawing/2014/main" id="{76BE467C-67C0-4B07-BAAE-DCF97A7C9C19}"/>
+                <a16:creationId xmlns:a16="http://schemas.microsoft.com/office/drawing/2014/main" id="{692E73C0-1005-4CE2-BB67-9DB594361A86}"/>
               </a:ext>
             </a:extLst>
           </p:cNvPr>
@@ -6205,8 +6176,8 @@
         </p:nvSpPr>
         <p:spPr>
           <a:xfrm xmlns:a="http://schemas.openxmlformats.org/drawingml/2006/main">
-            <a:off x="609600" y="4562475"/>
-            <a:ext cx="10858500" cy="1019175"/>
+            <a:off x="609600" y="3629025"/>
+            <a:ext cx="10477500" cy="457200"/>
           </a:xfrm>
           <a:prstGeom xmlns:a="http://schemas.openxmlformats.org/drawingml/2006/main" prst="rect">
             <a:avLst/>
@@ -6223,48 +6194,25 @@
           <a:lstStyle xmlns:a="http://schemas.openxmlformats.org/drawingml/2006/main"/>
           <a:p xmlns:a="http://schemas.openxmlformats.org/drawingml/2006/main">
             <a:pPr>
-              <a:defRPr sz="2100" b="0">
-                <a:solidFill>
-                  <a:srgbClr val="283A39"/>
-                </a:solidFill>
-                <a:latin typeface="Arial"/>
-                <a:ea typeface="Arial"/>
-                <a:cs typeface="Arial"/>
-              </a:defRPr>
-            </a:pPr>
-            <a:r>
-              <a:rPr sz="2100" b="0">
-                <a:solidFill>
-                  <a:srgbClr val="283A39"/>
-                </a:solidFill>
-                <a:latin typeface="Arial"/>
-                <a:ea typeface="Arial"/>
-                <a:cs typeface="Arial"/>
-              </a:rPr>
-              <a:t>Add your resume location or no-resume sentence if needed.</a:t>
-            </a:r>
-          </a:p>
-          <a:p xmlns:a="http://schemas.openxmlformats.org/drawingml/2006/main">
-            <a:pPr>
-              <a:defRPr sz="2100" b="0">
-                <a:solidFill>
-                  <a:srgbClr val="283A39"/>
-                </a:solidFill>
-                <a:latin typeface="Arial"/>
-                <a:ea typeface="Arial"/>
-                <a:cs typeface="Arial"/>
-              </a:defRPr>
-            </a:pPr>
-            <a:r>
-              <a:rPr sz="2100" b="0">
-                <a:solidFill>
-                  <a:srgbClr val="283A39"/>
-                </a:solidFill>
-                <a:latin typeface="Arial"/>
-                <a:ea typeface="Arial"/>
-                <a:cs typeface="Arial"/>
-              </a:rPr>
-              <a:t>Press Send once. Follow any installation approval or restart request.</a:t>
+              <a:defRPr sz="2550" b="1">
+                <a:solidFill>
+                  <a:srgbClr val="183F3B"/>
+                </a:solidFill>
+                <a:latin typeface="Arial"/>
+                <a:ea typeface="Arial"/>
+                <a:cs typeface="Arial"/>
+              </a:defRPr>
+            </a:pPr>
+            <a:r>
+              <a:rPr sz="2550" b="1">
+                <a:solidFill>
+                  <a:srgbClr val="183F3B"/>
+                </a:solidFill>
+                <a:latin typeface="Arial"/>
+                <a:ea typeface="Arial"/>
+                <a:cs typeface="Arial"/>
+              </a:rPr>
+              <a:t>If you do not have one</a:t>
             </a:r>
           </a:p>
         </p:txBody>
@@ -6274,7 +6222,7 @@
           <p:cNvPr id="6" name="">
             <a:extLst xmlns:a="http://schemas.openxmlformats.org/drawingml/2006/main">
               <a:ext uri="{FF2B5EF4-FFF2-40B4-BE49-F238E27FC236}">
-                <a16:creationId xmlns:a16="http://schemas.microsoft.com/office/drawing/2014/main" id="{A8B017E7-9F49-4796-A175-4872A6A38069}"/>
+                <a16:creationId xmlns:a16="http://schemas.microsoft.com/office/drawing/2014/main" id="{6F108FEA-C193-475C-86C4-60B02624A1DB}"/>
               </a:ext>
             </a:extLst>
           </p:cNvPr>
@@ -6285,8 +6233,8 @@
         </p:nvSpPr>
         <p:spPr>
           <a:xfrm xmlns:a="http://schemas.openxmlformats.org/drawingml/2006/main">
-            <a:off x="609600" y="5781675"/>
-            <a:ext cx="5715000" cy="361950"/>
+            <a:off x="609600" y="4257675"/>
+            <a:ext cx="10820400" cy="695325"/>
           </a:xfrm>
           <a:prstGeom xmlns:a="http://schemas.openxmlformats.org/drawingml/2006/main" prst="rect">
             <a:avLst/>
@@ -6303,26 +6251,82 @@
           <a:lstStyle xmlns:a="http://schemas.openxmlformats.org/drawingml/2006/main"/>
           <a:p xmlns:a="http://schemas.openxmlformats.org/drawingml/2006/main">
             <a:pPr>
-              <a:defRPr sz="1875" b="0">
-                <a:solidFill>
-                  <a:srgbClr val="087F73"/>
-                </a:solidFill>
-                <a:latin typeface="Arial"/>
-                <a:ea typeface="Arial"/>
-                <a:cs typeface="Arial"/>
-              </a:defRPr>
-            </a:pPr>
-            <a:r>
-              <a:rPr sz="1875" b="0">
-                <a:solidFill>
-                  <a:srgbClr val="087F73"/>
-                </a:solidFill>
-                <a:latin typeface="Arial"/>
-                <a:ea typeface="Arial"/>
-                <a:cs typeface="Arial"/>
-                <a:hlinkClick xmlns:r="http://schemas.openxmlformats.org/officeDocument/2006/relationships" r:id="R85acd25721cb4537"/>
-              </a:rPr>
-              <a:t>Copy from the README</a:t>
+              <a:defRPr sz="2250" b="0">
+                <a:solidFill>
+                  <a:srgbClr val="283A39"/>
+                </a:solidFill>
+                <a:latin typeface="Arial"/>
+                <a:ea typeface="Arial"/>
+                <a:cs typeface="Arial"/>
+              </a:defRPr>
+            </a:pPr>
+            <a:r>
+              <a:rPr sz="2250" b="0">
+                <a:solidFill>
+                  <a:srgbClr val="283A39"/>
+                </a:solidFill>
+                <a:latin typeface="Arial"/>
+                <a:ea typeface="Arial"/>
+                <a:cs typeface="Arial"/>
+              </a:rPr>
+              <a:t>Add: “I do not have a resume yet. Help me build one.”</a:t>
+            </a:r>
+          </a:p>
+        </p:txBody>
+      </p:sp>
+      <p:sp>
+        <p:nvSpPr>
+          <p:cNvPr id="7" name="">
+            <a:extLst xmlns:a="http://schemas.openxmlformats.org/drawingml/2006/main">
+              <a:ext uri="{FF2B5EF4-FFF2-40B4-BE49-F238E27FC236}">
+                <a16:creationId xmlns:a16="http://schemas.microsoft.com/office/drawing/2014/main" id="{B24268BC-ED4A-4D53-A51E-9E48AC629A05}"/>
+              </a:ext>
+            </a:extLst>
+          </p:cNvPr>
+          <p:cNvSpPr>
+            <a:spLocks xmlns:a="http://schemas.openxmlformats.org/drawingml/2006/main" noGrp="1"/>
+          </p:cNvSpPr>
+          <p:nvPr/>
+        </p:nvSpPr>
+        <p:spPr>
+          <a:xfrm xmlns:a="http://schemas.openxmlformats.org/drawingml/2006/main">
+            <a:off x="609600" y="5629275"/>
+            <a:ext cx="10839450" cy="590550"/>
+          </a:xfrm>
+          <a:prstGeom xmlns:a="http://schemas.openxmlformats.org/drawingml/2006/main" prst="rect">
+            <a:avLst/>
+          </a:prstGeom>
+          <a:noFill xmlns:a="http://schemas.openxmlformats.org/drawingml/2006/main"/>
+          <a:ln xmlns:a="http://schemas.openxmlformats.org/drawingml/2006/main" w="0">
+            <a:noFill/>
+          </a:ln>
+        </p:spPr>
+        <p:txBody>
+          <a:bodyPr xmlns:a="http://schemas.openxmlformats.org/drawingml/2006/main">
+            <a:noAutofit/>
+          </a:bodyPr>
+          <a:lstStyle xmlns:a="http://schemas.openxmlformats.org/drawingml/2006/main"/>
+          <a:p xmlns:a="http://schemas.openxmlformats.org/drawingml/2006/main">
+            <a:pPr>
+              <a:defRPr sz="1800" b="0">
+                <a:solidFill>
+                  <a:srgbClr val="607370"/>
+                </a:solidFill>
+                <a:latin typeface="Arial"/>
+                <a:ea typeface="Arial"/>
+                <a:cs typeface="Arial"/>
+              </a:defRPr>
+            </a:pPr>
+            <a:r>
+              <a:rPr sz="1800" b="0">
+                <a:solidFill>
+                  <a:srgbClr val="607370"/>
+                </a:solidFill>
+                <a:latin typeface="Arial"/>
+                <a:ea typeface="Arial"/>
+                <a:cs typeface="Arial"/>
+              </a:rPr>
+              <a:t>The AI checks that it can read the file. It can also build a resume from your real experience.</a:t>
             </a:r>
           </a:p>
         </p:txBody>
@@ -6330,7 +6334,7 @@
     </p:spTree>
     <p:extLst>
       <p:ext uri="{BB962C8B-B14F-4D97-AF65-F5344CB8AC3E}">
-        <p14:creationId xmlns:p14="http://schemas.microsoft.com/office/powerpoint/2010/main" val="297230269"/>
+        <p14:creationId xmlns:p14="http://schemas.microsoft.com/office/powerpoint/2010/main" val="302529051"/>
       </p:ext>
     </p:extLst>
   </p:cSld>
@@ -6358,10 +6362,10 @@
       </p:grpSpPr>
       <p:sp>
         <p:nvSpPr>
-          <p:cNvPr id="8" name="">
+          <p:cNvPr id="7" name="">
             <a:extLst xmlns:a="http://schemas.openxmlformats.org/drawingml/2006/main">
               <a:ext uri="{FF2B5EF4-FFF2-40B4-BE49-F238E27FC236}">
-                <a16:creationId xmlns:a16="http://schemas.microsoft.com/office/drawing/2014/main" id="{A12B179E-A2A9-43AD-A4B6-BA99FD0AD98B}"/>
+                <a16:creationId xmlns:a16="http://schemas.microsoft.com/office/drawing/2014/main" id="{EF94DBC4-D341-4CEF-97A8-91D66C254822}"/>
               </a:ext>
             </a:extLst>
           </p:cNvPr>
@@ -6408,7 +6412,7 @@
                 <a:ea typeface="Arial"/>
                 <a:cs typeface="Arial"/>
               </a:rPr>
-              <a:t>4. A short conversation</a:t>
+              <a:t>3. Your first message</a:t>
             </a:r>
           </a:p>
         </p:txBody>
@@ -6418,7 +6422,7 @@
           <p:cNvPr id="2" name="">
             <a:extLst xmlns:a="http://schemas.openxmlformats.org/drawingml/2006/main">
               <a:ext uri="{FF2B5EF4-FFF2-40B4-BE49-F238E27FC236}">
-                <a16:creationId xmlns:a16="http://schemas.microsoft.com/office/drawing/2014/main" id="{128FC455-9749-42AE-B2A9-43F22C0D4770}"/>
+                <a16:creationId xmlns:a16="http://schemas.microsoft.com/office/drawing/2014/main" id="{D8E89AFD-FB8A-4B56-BE2F-8ADF5733DB00}"/>
               </a:ext>
             </a:extLst>
           </p:cNvPr>
@@ -6475,7 +6479,7 @@
           <p:cNvPr id="3" name="">
             <a:extLst xmlns:a="http://schemas.openxmlformats.org/drawingml/2006/main">
               <a:ext uri="{FF2B5EF4-FFF2-40B4-BE49-F238E27FC236}">
-                <a16:creationId xmlns:a16="http://schemas.microsoft.com/office/drawing/2014/main" id="{A180483F-2E35-4512-B174-5274DBF24B7E}"/>
+                <a16:creationId xmlns:a16="http://schemas.microsoft.com/office/drawing/2014/main" id="{65EDC46D-6826-41EB-9682-2EAE6AFB2C62}"/>
               </a:ext>
             </a:extLst>
           </p:cNvPr>
@@ -6486,8 +6490,8 @@
         </p:nvSpPr>
         <p:spPr>
           <a:xfrm xmlns:a="http://schemas.openxmlformats.org/drawingml/2006/main">
-            <a:off x="609600" y="1447800"/>
-            <a:ext cx="10820400" cy="647700"/>
+            <a:off x="609600" y="1457325"/>
+            <a:ext cx="10858500" cy="590550"/>
           </a:xfrm>
           <a:prstGeom xmlns:a="http://schemas.openxmlformats.org/drawingml/2006/main" prst="rect">
             <a:avLst/>
@@ -6504,25 +6508,25 @@
           <a:lstStyle xmlns:a="http://schemas.openxmlformats.org/drawingml/2006/main"/>
           <a:p xmlns:a="http://schemas.openxmlformats.org/drawingml/2006/main">
             <a:pPr>
-              <a:defRPr sz="2250" b="0">
-                <a:solidFill>
-                  <a:srgbClr val="283A39"/>
-                </a:solidFill>
-                <a:latin typeface="Arial"/>
-                <a:ea typeface="Arial"/>
-                <a:cs typeface="Arial"/>
-              </a:defRPr>
-            </a:pPr>
-            <a:r>
-              <a:rPr sz="2250" b="0">
-                <a:solidFill>
-                  <a:srgbClr val="283A39"/>
-                </a:solidFill>
-                <a:latin typeface="Arial"/>
-                <a:ea typeface="Arial"/>
-                <a:cs typeface="Arial"/>
-              </a:rPr>
-              <a:t>The AI asks one question, waits, and saves your answer.</a:t>
+              <a:defRPr sz="2100" b="0">
+                <a:solidFill>
+                  <a:srgbClr val="283A39"/>
+                </a:solidFill>
+                <a:latin typeface="Arial"/>
+                <a:ea typeface="Arial"/>
+                <a:cs typeface="Arial"/>
+              </a:defRPr>
+            </a:pPr>
+            <a:r>
+              <a:rPr sz="2100" b="0">
+                <a:solidFill>
+                  <a:srgbClr val="283A39"/>
+                </a:solidFill>
+                <a:latin typeface="Arial"/>
+                <a:ea typeface="Arial"/>
+                <a:cs typeface="Arial"/>
+              </a:rPr>
+              <a:t>Copy both lines into the same message box as your resume:</a:t>
             </a:r>
           </a:p>
         </p:txBody>
@@ -6532,7 +6536,7 @@
           <p:cNvPr id="4" name="">
             <a:extLst xmlns:a="http://schemas.openxmlformats.org/drawingml/2006/main">
               <a:ext uri="{FF2B5EF4-FFF2-40B4-BE49-F238E27FC236}">
-                <a16:creationId xmlns:a16="http://schemas.microsoft.com/office/drawing/2014/main" id="{54F85302-EC03-4128-B0AA-E46A3DDB22EC}"/>
+                <a16:creationId xmlns:a16="http://schemas.microsoft.com/office/drawing/2014/main" id="{B074F2FB-DBA8-4166-BCD1-C35592B1CF0F}"/>
               </a:ext>
             </a:extLst>
           </p:cNvPr>
@@ -6543,8 +6547,8 @@
         </p:nvSpPr>
         <p:spPr>
           <a:xfrm xmlns:a="http://schemas.openxmlformats.org/drawingml/2006/main">
-            <a:off x="609600" y="2524125"/>
-            <a:ext cx="10858500" cy="438150"/>
+            <a:off x="609600" y="2638425"/>
+            <a:ext cx="10972800" cy="1381125"/>
           </a:xfrm>
           <a:prstGeom xmlns:a="http://schemas.openxmlformats.org/drawingml/2006/main" prst="rect">
             <a:avLst/>
@@ -6561,25 +6565,48 @@
           <a:lstStyle xmlns:a="http://schemas.openxmlformats.org/drawingml/2006/main"/>
           <a:p xmlns:a="http://schemas.openxmlformats.org/drawingml/2006/main">
             <a:pPr>
-              <a:defRPr sz="1875" b="1">
-                <a:solidFill>
-                  <a:srgbClr val="087F73"/>
-                </a:solidFill>
-                <a:latin typeface="Arial"/>
-                <a:ea typeface="Arial"/>
-                <a:cs typeface="Arial"/>
-              </a:defRPr>
-            </a:pPr>
-            <a:r>
-              <a:rPr sz="1875" b="1">
-                <a:solidFill>
-                  <a:srgbClr val="087F73"/>
-                </a:solidFill>
-                <a:latin typeface="Arial"/>
-                <a:ea typeface="Arial"/>
-                <a:cs typeface="Arial"/>
-              </a:rPr>
-              <a:t>Example question</a:t>
+              <a:defRPr sz="2400" b="1">
+                <a:solidFill>
+                  <a:srgbClr val="183F3B"/>
+                </a:solidFill>
+                <a:latin typeface="Arial"/>
+                <a:ea typeface="Arial"/>
+                <a:cs typeface="Arial"/>
+              </a:defRPr>
+            </a:pPr>
+            <a:r>
+              <a:rPr sz="2400" b="1">
+                <a:solidFill>
+                  <a:srgbClr val="183F3B"/>
+                </a:solidFill>
+                <a:latin typeface="Arial"/>
+                <a:ea typeface="Arial"/>
+                <a:cs typeface="Arial"/>
+              </a:rPr>
+              <a:t>Install https://github.com/toughdave/job-search for this project.</a:t>
+            </a:r>
+          </a:p>
+          <a:p xmlns:a="http://schemas.openxmlformats.org/drawingml/2006/main">
+            <a:pPr>
+              <a:defRPr sz="2400" b="1">
+                <a:solidFill>
+                  <a:srgbClr val="183F3B"/>
+                </a:solidFill>
+                <a:latin typeface="Arial"/>
+                <a:ea typeface="Arial"/>
+                <a:cs typeface="Arial"/>
+              </a:defRPr>
+            </a:pPr>
+            <a:r>
+              <a:rPr sz="2400" b="1">
+                <a:solidFill>
+                  <a:srgbClr val="183F3B"/>
+                </a:solidFill>
+                <a:latin typeface="Arial"/>
+                <a:ea typeface="Arial"/>
+                <a:cs typeface="Arial"/>
+              </a:rPr>
+              <a:t>Then use job-search to start my search.</a:t>
             </a:r>
           </a:p>
         </p:txBody>
@@ -6589,7 +6616,7 @@
           <p:cNvPr id="5" name="">
             <a:extLst xmlns:a="http://schemas.openxmlformats.org/drawingml/2006/main">
               <a:ext uri="{FF2B5EF4-FFF2-40B4-BE49-F238E27FC236}">
-                <a16:creationId xmlns:a16="http://schemas.microsoft.com/office/drawing/2014/main" id="{1C4A40CD-5200-4BD1-9BB3-74109897E572}"/>
+                <a16:creationId xmlns:a16="http://schemas.microsoft.com/office/drawing/2014/main" id="{2B617F0B-2287-4FA8-A544-1FA6AECA5DC1}"/>
               </a:ext>
             </a:extLst>
           </p:cNvPr>
@@ -6600,8 +6627,8 @@
         </p:nvSpPr>
         <p:spPr>
           <a:xfrm xmlns:a="http://schemas.openxmlformats.org/drawingml/2006/main">
-            <a:off x="609600" y="3114675"/>
-            <a:ext cx="10858500" cy="1143000"/>
+            <a:off x="609600" y="4562475"/>
+            <a:ext cx="10858500" cy="1019175"/>
           </a:xfrm>
           <a:prstGeom xmlns:a="http://schemas.openxmlformats.org/drawingml/2006/main" prst="rect">
             <a:avLst/>
@@ -6618,48 +6645,48 @@
           <a:lstStyle xmlns:a="http://schemas.openxmlformats.org/drawingml/2006/main"/>
           <a:p xmlns:a="http://schemas.openxmlformats.org/drawingml/2006/main">
             <a:pPr>
-              <a:defRPr sz="2700" b="0">
-                <a:solidFill>
-                  <a:srgbClr val="183F3B"/>
-                </a:solidFill>
-                <a:latin typeface="Arial"/>
-                <a:ea typeface="Arial"/>
-                <a:cs typeface="Arial"/>
-              </a:defRPr>
-            </a:pPr>
-            <a:r>
-              <a:rPr sz="2700" b="0">
-                <a:solidFill>
-                  <a:srgbClr val="183F3B"/>
-                </a:solidFill>
-                <a:latin typeface="Arial"/>
-                <a:ea typeface="Arial"/>
-                <a:cs typeface="Arial"/>
-              </a:rPr>
-              <a:t>“Tell me about a time you solved a problem</a:t>
-            </a:r>
-          </a:p>
-          <a:p xmlns:a="http://schemas.openxmlformats.org/drawingml/2006/main">
-            <a:pPr>
-              <a:defRPr sz="2700" b="0">
-                <a:solidFill>
-                  <a:srgbClr val="183F3B"/>
-                </a:solidFill>
-                <a:latin typeface="Arial"/>
-                <a:ea typeface="Arial"/>
-                <a:cs typeface="Arial"/>
-              </a:defRPr>
-            </a:pPr>
-            <a:r>
-              <a:rPr sz="2700" b="0">
-                <a:solidFill>
-                  <a:srgbClr val="183F3B"/>
-                </a:solidFill>
-                <a:latin typeface="Arial"/>
-                <a:ea typeface="Arial"/>
-                <a:cs typeface="Arial"/>
-              </a:rPr>
-              <a:t>that matters for the work you want to do.”</a:t>
+              <a:defRPr sz="2100" b="0">
+                <a:solidFill>
+                  <a:srgbClr val="283A39"/>
+                </a:solidFill>
+                <a:latin typeface="Arial"/>
+                <a:ea typeface="Arial"/>
+                <a:cs typeface="Arial"/>
+              </a:defRPr>
+            </a:pPr>
+            <a:r>
+              <a:rPr sz="2100" b="0">
+                <a:solidFill>
+                  <a:srgbClr val="283A39"/>
+                </a:solidFill>
+                <a:latin typeface="Arial"/>
+                <a:ea typeface="Arial"/>
+                <a:cs typeface="Arial"/>
+              </a:rPr>
+              <a:t>Add your resume location or no-resume sentence if needed.</a:t>
+            </a:r>
+          </a:p>
+          <a:p xmlns:a="http://schemas.openxmlformats.org/drawingml/2006/main">
+            <a:pPr>
+              <a:defRPr sz="2100" b="0">
+                <a:solidFill>
+                  <a:srgbClr val="283A39"/>
+                </a:solidFill>
+                <a:latin typeface="Arial"/>
+                <a:ea typeface="Arial"/>
+                <a:cs typeface="Arial"/>
+              </a:defRPr>
+            </a:pPr>
+            <a:r>
+              <a:rPr sz="2100" b="0">
+                <a:solidFill>
+                  <a:srgbClr val="283A39"/>
+                </a:solidFill>
+                <a:latin typeface="Arial"/>
+                <a:ea typeface="Arial"/>
+                <a:cs typeface="Arial"/>
+              </a:rPr>
+              <a:t>Press Send once. Follow any installation approval or restart request.</a:t>
             </a:r>
           </a:p>
         </p:txBody>
@@ -6669,7 +6696,7 @@
           <p:cNvPr id="6" name="">
             <a:extLst xmlns:a="http://schemas.openxmlformats.org/drawingml/2006/main">
               <a:ext uri="{FF2B5EF4-FFF2-40B4-BE49-F238E27FC236}">
-                <a16:creationId xmlns:a16="http://schemas.microsoft.com/office/drawing/2014/main" id="{6F8E6B72-0927-4EB0-8E9A-524BA19BD4F6}"/>
+                <a16:creationId xmlns:a16="http://schemas.microsoft.com/office/drawing/2014/main" id="{89CAD7C0-EA1C-4F5C-9A42-64667240CF76}"/>
               </a:ext>
             </a:extLst>
           </p:cNvPr>
@@ -6680,8 +6707,8 @@
         </p:nvSpPr>
         <p:spPr>
           <a:xfrm xmlns:a="http://schemas.openxmlformats.org/drawingml/2006/main">
-            <a:off x="609600" y="4638675"/>
-            <a:ext cx="10858500" cy="981075"/>
+            <a:off x="609600" y="5781675"/>
+            <a:ext cx="5715000" cy="361950"/>
           </a:xfrm>
           <a:prstGeom xmlns:a="http://schemas.openxmlformats.org/drawingml/2006/main" prst="rect">
             <a:avLst/>
@@ -6698,105 +6725,26 @@
           <a:lstStyle xmlns:a="http://schemas.openxmlformats.org/drawingml/2006/main"/>
           <a:p xmlns:a="http://schemas.openxmlformats.org/drawingml/2006/main">
             <a:pPr>
-              <a:defRPr sz="2100" b="0">
-                <a:solidFill>
-                  <a:srgbClr val="283A39"/>
-                </a:solidFill>
-                <a:latin typeface="Arial"/>
-                <a:ea typeface="Arial"/>
-                <a:cs typeface="Arial"/>
-              </a:defRPr>
-            </a:pPr>
-            <a:r>
-              <a:rPr sz="2100" b="0">
-                <a:solidFill>
-                  <a:srgbClr val="283A39"/>
-                </a:solidFill>
-                <a:latin typeface="Arial"/>
-                <a:ea typeface="Arial"/>
-                <a:cs typeface="Arial"/>
-              </a:rPr>
-              <a:t>Explain what you did and what happened. Honest qualitative</a:t>
-            </a:r>
-          </a:p>
-          <a:p xmlns:a="http://schemas.openxmlformats.org/drawingml/2006/main">
-            <a:pPr>
-              <a:defRPr sz="2100" b="0">
-                <a:solidFill>
-                  <a:srgbClr val="283A39"/>
-                </a:solidFill>
-                <a:latin typeface="Arial"/>
-                <a:ea typeface="Arial"/>
-                <a:cs typeface="Arial"/>
-              </a:defRPr>
-            </a:pPr>
-            <a:r>
-              <a:rPr sz="2100" b="0">
-                <a:solidFill>
-                  <a:srgbClr val="283A39"/>
-                </a:solidFill>
-                <a:latin typeface="Arial"/>
-                <a:ea typeface="Arial"/>
-                <a:cs typeface="Arial"/>
-              </a:rPr>
-              <a:t>results are useful. The AI asks only for missing details.</a:t>
-            </a:r>
-          </a:p>
-        </p:txBody>
-      </p:sp>
-      <p:sp>
-        <p:nvSpPr>
-          <p:cNvPr id="7" name="">
-            <a:extLst xmlns:a="http://schemas.openxmlformats.org/drawingml/2006/main">
-              <a:ext uri="{FF2B5EF4-FFF2-40B4-BE49-F238E27FC236}">
-                <a16:creationId xmlns:a16="http://schemas.microsoft.com/office/drawing/2014/main" id="{98583CEE-C602-4D14-A7DF-B32B3A11FA8D}"/>
-              </a:ext>
-            </a:extLst>
-          </p:cNvPr>
-          <p:cNvSpPr>
-            <a:spLocks xmlns:a="http://schemas.openxmlformats.org/drawingml/2006/main" noGrp="1"/>
-          </p:cNvSpPr>
-          <p:nvPr/>
-        </p:nvSpPr>
-        <p:spPr>
-          <a:xfrm xmlns:a="http://schemas.openxmlformats.org/drawingml/2006/main">
-            <a:off x="609600" y="5819775"/>
-            <a:ext cx="10858500" cy="400050"/>
-          </a:xfrm>
-          <a:prstGeom xmlns:a="http://schemas.openxmlformats.org/drawingml/2006/main" prst="rect">
-            <a:avLst/>
-          </a:prstGeom>
-          <a:noFill xmlns:a="http://schemas.openxmlformats.org/drawingml/2006/main"/>
-          <a:ln xmlns:a="http://schemas.openxmlformats.org/drawingml/2006/main" w="0">
-            <a:noFill/>
-          </a:ln>
-        </p:spPr>
-        <p:txBody>
-          <a:bodyPr xmlns:a="http://schemas.openxmlformats.org/drawingml/2006/main">
-            <a:noAutofit/>
-          </a:bodyPr>
-          <a:lstStyle xmlns:a="http://schemas.openxmlformats.org/drawingml/2006/main"/>
-          <a:p xmlns:a="http://schemas.openxmlformats.org/drawingml/2006/main">
-            <a:pPr>
-              <a:defRPr sz="1800" b="0">
-                <a:solidFill>
-                  <a:srgbClr val="607370"/>
-                </a:solidFill>
-                <a:latin typeface="Arial"/>
-                <a:ea typeface="Arial"/>
-                <a:cs typeface="Arial"/>
-              </a:defRPr>
-            </a:pPr>
-            <a:r>
-              <a:rPr sz="1800" b="0">
-                <a:solidFill>
-                  <a:srgbClr val="607370"/>
-                </a:solidFill>
-                <a:latin typeface="Arial"/>
-                <a:ea typeface="Arial"/>
-                <a:cs typeface="Arial"/>
-              </a:rPr>
-              <a:t>You can pause, correct an answer, or decline the optional LinkedIn review.</a:t>
+              <a:defRPr sz="1875" b="0">
+                <a:solidFill>
+                  <a:srgbClr val="087F73"/>
+                </a:solidFill>
+                <a:latin typeface="Arial"/>
+                <a:ea typeface="Arial"/>
+                <a:cs typeface="Arial"/>
+              </a:defRPr>
+            </a:pPr>
+            <a:r>
+              <a:rPr sz="1875" b="0">
+                <a:solidFill>
+                  <a:srgbClr val="087F73"/>
+                </a:solidFill>
+                <a:latin typeface="Arial"/>
+                <a:ea typeface="Arial"/>
+                <a:cs typeface="Arial"/>
+                <a:hlinkClick xmlns:r="http://schemas.openxmlformats.org/officeDocument/2006/relationships" r:id="Rdecd1c4081a64b97"/>
+              </a:rPr>
+              <a:t>Copy from the README</a:t>
             </a:r>
           </a:p>
         </p:txBody>
@@ -6804,7 +6752,7 @@
     </p:spTree>
     <p:extLst>
       <p:ext uri="{BB962C8B-B14F-4D97-AF65-F5344CB8AC3E}">
-        <p14:creationId xmlns:p14="http://schemas.microsoft.com/office/powerpoint/2010/main" val="856901033"/>
+        <p14:creationId xmlns:p14="http://schemas.microsoft.com/office/powerpoint/2010/main" val="199932939"/>
       </p:ext>
     </p:extLst>
   </p:cSld>
@@ -6832,10 +6780,10 @@
       </p:grpSpPr>
       <p:sp>
         <p:nvSpPr>
-          <p:cNvPr id="7" name="">
+          <p:cNvPr id="8" name="">
             <a:extLst xmlns:a="http://schemas.openxmlformats.org/drawingml/2006/main">
               <a:ext uri="{FF2B5EF4-FFF2-40B4-BE49-F238E27FC236}">
-                <a16:creationId xmlns:a16="http://schemas.microsoft.com/office/drawing/2014/main" id="{4F30AEEF-27DC-4C91-82BF-49AEDBA54DC0}"/>
+                <a16:creationId xmlns:a16="http://schemas.microsoft.com/office/drawing/2014/main" id="{366F46D3-39CE-49F4-B4AF-41BB69D5CC4C}"/>
               </a:ext>
             </a:extLst>
           </p:cNvPr>
@@ -6882,7 +6830,7 @@
                 <a:ea typeface="Arial"/>
                 <a:cs typeface="Arial"/>
               </a:rPr>
-              <a:t>5. Your first draft</a:t>
+              <a:t>4. A short conversation</a:t>
             </a:r>
           </a:p>
         </p:txBody>
@@ -6892,7 +6840,7 @@
           <p:cNvPr id="2" name="">
             <a:extLst xmlns:a="http://schemas.openxmlformats.org/drawingml/2006/main">
               <a:ext uri="{FF2B5EF4-FFF2-40B4-BE49-F238E27FC236}">
-                <a16:creationId xmlns:a16="http://schemas.microsoft.com/office/drawing/2014/main" id="{E060427C-1EEF-49D8-9C37-EB322AF172DF}"/>
+                <a16:creationId xmlns:a16="http://schemas.microsoft.com/office/drawing/2014/main" id="{0C47AF63-618E-496D-8DCB-C4443EDF64C0}"/>
               </a:ext>
             </a:extLst>
           </p:cNvPr>
@@ -6949,7 +6897,7 @@
           <p:cNvPr id="3" name="">
             <a:extLst xmlns:a="http://schemas.openxmlformats.org/drawingml/2006/main">
               <a:ext uri="{FF2B5EF4-FFF2-40B4-BE49-F238E27FC236}">
-                <a16:creationId xmlns:a16="http://schemas.microsoft.com/office/drawing/2014/main" id="{DA4E4298-A4DA-4627-9037-E63C674F0650}"/>
+                <a16:creationId xmlns:a16="http://schemas.microsoft.com/office/drawing/2014/main" id="{05F6A6ED-C8DD-4D7B-BC0B-87E4D0464ABB}"/>
               </a:ext>
             </a:extLst>
           </p:cNvPr>
@@ -6960,8 +6908,8 @@
         </p:nvSpPr>
         <p:spPr>
           <a:xfrm xmlns:a="http://schemas.openxmlformats.org/drawingml/2006/main">
-            <a:off x="609600" y="1476375"/>
-            <a:ext cx="10820400" cy="1019175"/>
+            <a:off x="609600" y="1447800"/>
+            <a:ext cx="10820400" cy="647700"/>
           </a:xfrm>
           <a:prstGeom xmlns:a="http://schemas.openxmlformats.org/drawingml/2006/main" prst="rect">
             <a:avLst/>
@@ -6996,30 +6944,7 @@
                 <a:ea typeface="Arial"/>
                 <a:cs typeface="Arial"/>
               </a:rPr>
-              <a:t>When enough is known, the AI prepares useful documents</a:t>
-            </a:r>
-          </a:p>
-          <a:p xmlns:a="http://schemas.openxmlformats.org/drawingml/2006/main">
-            <a:pPr>
-              <a:defRPr sz="2250" b="0">
-                <a:solidFill>
-                  <a:srgbClr val="283A39"/>
-                </a:solidFill>
-                <a:latin typeface="Arial"/>
-                <a:ea typeface="Arial"/>
-                <a:cs typeface="Arial"/>
-              </a:defRPr>
-            </a:pPr>
-            <a:r>
-              <a:rPr sz="2250" b="0">
-                <a:solidFill>
-                  <a:srgbClr val="283A39"/>
-                </a:solidFill>
-                <a:latin typeface="Arial"/>
-                <a:ea typeface="Arial"/>
-                <a:cs typeface="Arial"/>
-              </a:rPr>
-              <a:t>and keeps your search records in a separate private location.</a:t>
+              <a:t>The AI asks one question, waits, and saves your answer.</a:t>
             </a:r>
           </a:p>
         </p:txBody>
@@ -7029,7 +6954,7 @@
           <p:cNvPr id="4" name="">
             <a:extLst xmlns:a="http://schemas.openxmlformats.org/drawingml/2006/main">
               <a:ext uri="{FF2B5EF4-FFF2-40B4-BE49-F238E27FC236}">
-                <a16:creationId xmlns:a16="http://schemas.microsoft.com/office/drawing/2014/main" id="{4C34B678-04D7-422A-BCD6-F1C95B701EC5}"/>
+                <a16:creationId xmlns:a16="http://schemas.microsoft.com/office/drawing/2014/main" id="{45C28B6E-9BCE-4716-AB78-A09F93BF629C}"/>
               </a:ext>
             </a:extLst>
           </p:cNvPr>
@@ -7040,8 +6965,8 @@
         </p:nvSpPr>
         <p:spPr>
           <a:xfrm xmlns:a="http://schemas.openxmlformats.org/drawingml/2006/main">
-            <a:off x="609600" y="3162300"/>
-            <a:ext cx="10820400" cy="1009650"/>
+            <a:off x="609600" y="2524125"/>
+            <a:ext cx="10858500" cy="438150"/>
           </a:xfrm>
           <a:prstGeom xmlns:a="http://schemas.openxmlformats.org/drawingml/2006/main" prst="rect">
             <a:avLst/>
@@ -7058,48 +6983,25 @@
           <a:lstStyle xmlns:a="http://schemas.openxmlformats.org/drawingml/2006/main"/>
           <a:p xmlns:a="http://schemas.openxmlformats.org/drawingml/2006/main">
             <a:pPr>
-              <a:defRPr sz="2250" b="0">
-                <a:solidFill>
-                  <a:srgbClr val="283A39"/>
-                </a:solidFill>
-                <a:latin typeface="Arial"/>
-                <a:ea typeface="Arial"/>
-                <a:cs typeface="Arial"/>
-              </a:defRPr>
-            </a:pPr>
-            <a:r>
-              <a:rPr sz="2250" b="0">
-                <a:solidFill>
-                  <a:srgbClr val="283A39"/>
-                </a:solidFill>
-                <a:latin typeface="Arial"/>
-                <a:ea typeface="Arial"/>
-                <a:cs typeface="Arial"/>
-              </a:rPr>
-              <a:t>Open the files and check your experience, dates and contact details.</a:t>
-            </a:r>
-          </a:p>
-          <a:p xmlns:a="http://schemas.openxmlformats.org/drawingml/2006/main">
-            <a:pPr>
-              <a:defRPr sz="2250" b="0">
-                <a:solidFill>
-                  <a:srgbClr val="283A39"/>
-                </a:solidFill>
-                <a:latin typeface="Arial"/>
-                <a:ea typeface="Arial"/>
-                <a:cs typeface="Arial"/>
-              </a:defRPr>
-            </a:pPr>
-            <a:r>
-              <a:rPr sz="2250" b="0">
-                <a:solidFill>
-                  <a:srgbClr val="283A39"/>
-                </a:solidFill>
-                <a:latin typeface="Arial"/>
-                <a:ea typeface="Arial"/>
-                <a:cs typeface="Arial"/>
-              </a:rPr>
-              <a:t>Give corrections in the conversation.</a:t>
+              <a:defRPr sz="1875" b="1">
+                <a:solidFill>
+                  <a:srgbClr val="087F73"/>
+                </a:solidFill>
+                <a:latin typeface="Arial"/>
+                <a:ea typeface="Arial"/>
+                <a:cs typeface="Arial"/>
+              </a:defRPr>
+            </a:pPr>
+            <a:r>
+              <a:rPr sz="1875" b="1">
+                <a:solidFill>
+                  <a:srgbClr val="087F73"/>
+                </a:solidFill>
+                <a:latin typeface="Arial"/>
+                <a:ea typeface="Arial"/>
+                <a:cs typeface="Arial"/>
+              </a:rPr>
+              <a:t>Example question</a:t>
             </a:r>
           </a:p>
         </p:txBody>
@@ -7109,7 +7011,7 @@
           <p:cNvPr id="5" name="">
             <a:extLst xmlns:a="http://schemas.openxmlformats.org/drawingml/2006/main">
               <a:ext uri="{FF2B5EF4-FFF2-40B4-BE49-F238E27FC236}">
-                <a16:creationId xmlns:a16="http://schemas.microsoft.com/office/drawing/2014/main" id="{229988CD-FEFC-4E0B-A93B-7679B947E7B2}"/>
+                <a16:creationId xmlns:a16="http://schemas.microsoft.com/office/drawing/2014/main" id="{3B9C1C43-5D65-4822-A1ED-F98F38DDA31C}"/>
               </a:ext>
             </a:extLst>
           </p:cNvPr>
@@ -7120,8 +7022,8 @@
         </p:nvSpPr>
         <p:spPr>
           <a:xfrm xmlns:a="http://schemas.openxmlformats.org/drawingml/2006/main">
-            <a:off x="609600" y="4714875"/>
-            <a:ext cx="10858500" cy="552450"/>
+            <a:off x="609600" y="3114675"/>
+            <a:ext cx="10858500" cy="1143000"/>
           </a:xfrm>
           <a:prstGeom xmlns:a="http://schemas.openxmlformats.org/drawingml/2006/main" prst="rect">
             <a:avLst/>
@@ -7138,7 +7040,7 @@
           <a:lstStyle xmlns:a="http://schemas.openxmlformats.org/drawingml/2006/main"/>
           <a:p xmlns:a="http://schemas.openxmlformats.org/drawingml/2006/main">
             <a:pPr>
-              <a:defRPr sz="2550" b="1">
+              <a:defRPr sz="2700" b="0">
                 <a:solidFill>
                   <a:srgbClr val="183F3B"/>
                 </a:solidFill>
@@ -7148,7 +7050,7 @@
               </a:defRPr>
             </a:pPr>
             <a:r>
-              <a:rPr sz="2550" b="1">
+              <a:rPr sz="2700" b="0">
                 <a:solidFill>
                   <a:srgbClr val="183F3B"/>
                 </a:solidFill>
@@ -7156,7 +7058,30 @@
                 <a:ea typeface="Arial"/>
                 <a:cs typeface="Arial"/>
               </a:rPr>
-              <a:t>“That role was volunteering. Please correct it.”</a:t>
+              <a:t>“Tell me about a time you solved a problem</a:t>
+            </a:r>
+          </a:p>
+          <a:p xmlns:a="http://schemas.openxmlformats.org/drawingml/2006/main">
+            <a:pPr>
+              <a:defRPr sz="2700" b="0">
+                <a:solidFill>
+                  <a:srgbClr val="183F3B"/>
+                </a:solidFill>
+                <a:latin typeface="Arial"/>
+                <a:ea typeface="Arial"/>
+                <a:cs typeface="Arial"/>
+              </a:defRPr>
+            </a:pPr>
+            <a:r>
+              <a:rPr sz="2700" b="0">
+                <a:solidFill>
+                  <a:srgbClr val="183F3B"/>
+                </a:solidFill>
+                <a:latin typeface="Arial"/>
+                <a:ea typeface="Arial"/>
+                <a:cs typeface="Arial"/>
+              </a:rPr>
+              <a:t>that matters for the work you want to do.”</a:t>
             </a:r>
           </a:p>
         </p:txBody>
@@ -7166,7 +7091,7 @@
           <p:cNvPr id="6" name="">
             <a:extLst xmlns:a="http://schemas.openxmlformats.org/drawingml/2006/main">
               <a:ext uri="{FF2B5EF4-FFF2-40B4-BE49-F238E27FC236}">
-                <a16:creationId xmlns:a16="http://schemas.microsoft.com/office/drawing/2014/main" id="{2D02A24D-3817-4FBB-A0B9-9070C4B87704}"/>
+                <a16:creationId xmlns:a16="http://schemas.microsoft.com/office/drawing/2014/main" id="{82039185-4680-481B-8B7D-FEA8223C6DCA}"/>
               </a:ext>
             </a:extLst>
           </p:cNvPr>
@@ -7177,8 +7102,8 @@
         </p:nvSpPr>
         <p:spPr>
           <a:xfrm xmlns:a="http://schemas.openxmlformats.org/drawingml/2006/main">
-            <a:off x="609600" y="5829300"/>
-            <a:ext cx="10858500" cy="400050"/>
+            <a:off x="609600" y="4638675"/>
+            <a:ext cx="10858500" cy="981075"/>
           </a:xfrm>
           <a:prstGeom xmlns:a="http://schemas.openxmlformats.org/drawingml/2006/main" prst="rect">
             <a:avLst/>
@@ -7195,6 +7120,86 @@
           <a:lstStyle xmlns:a="http://schemas.openxmlformats.org/drawingml/2006/main"/>
           <a:p xmlns:a="http://schemas.openxmlformats.org/drawingml/2006/main">
             <a:pPr>
+              <a:defRPr sz="2100" b="0">
+                <a:solidFill>
+                  <a:srgbClr val="283A39"/>
+                </a:solidFill>
+                <a:latin typeface="Arial"/>
+                <a:ea typeface="Arial"/>
+                <a:cs typeface="Arial"/>
+              </a:defRPr>
+            </a:pPr>
+            <a:r>
+              <a:rPr sz="2100" b="0">
+                <a:solidFill>
+                  <a:srgbClr val="283A39"/>
+                </a:solidFill>
+                <a:latin typeface="Arial"/>
+                <a:ea typeface="Arial"/>
+                <a:cs typeface="Arial"/>
+              </a:rPr>
+              <a:t>Explain what you did and what happened. Honest qualitative</a:t>
+            </a:r>
+          </a:p>
+          <a:p xmlns:a="http://schemas.openxmlformats.org/drawingml/2006/main">
+            <a:pPr>
+              <a:defRPr sz="2100" b="0">
+                <a:solidFill>
+                  <a:srgbClr val="283A39"/>
+                </a:solidFill>
+                <a:latin typeface="Arial"/>
+                <a:ea typeface="Arial"/>
+                <a:cs typeface="Arial"/>
+              </a:defRPr>
+            </a:pPr>
+            <a:r>
+              <a:rPr sz="2100" b="0">
+                <a:solidFill>
+                  <a:srgbClr val="283A39"/>
+                </a:solidFill>
+                <a:latin typeface="Arial"/>
+                <a:ea typeface="Arial"/>
+                <a:cs typeface="Arial"/>
+              </a:rPr>
+              <a:t>results are useful. The AI asks only for missing details.</a:t>
+            </a:r>
+          </a:p>
+        </p:txBody>
+      </p:sp>
+      <p:sp>
+        <p:nvSpPr>
+          <p:cNvPr id="7" name="">
+            <a:extLst xmlns:a="http://schemas.openxmlformats.org/drawingml/2006/main">
+              <a:ext uri="{FF2B5EF4-FFF2-40B4-BE49-F238E27FC236}">
+                <a16:creationId xmlns:a16="http://schemas.microsoft.com/office/drawing/2014/main" id="{69439691-1186-4C7E-A08A-F2EFB7AE5F00}"/>
+              </a:ext>
+            </a:extLst>
+          </p:cNvPr>
+          <p:cNvSpPr>
+            <a:spLocks xmlns:a="http://schemas.openxmlformats.org/drawingml/2006/main" noGrp="1"/>
+          </p:cNvSpPr>
+          <p:nvPr/>
+        </p:nvSpPr>
+        <p:spPr>
+          <a:xfrm xmlns:a="http://schemas.openxmlformats.org/drawingml/2006/main">
+            <a:off x="609600" y="5819775"/>
+            <a:ext cx="10858500" cy="400050"/>
+          </a:xfrm>
+          <a:prstGeom xmlns:a="http://schemas.openxmlformats.org/drawingml/2006/main" prst="rect">
+            <a:avLst/>
+          </a:prstGeom>
+          <a:noFill xmlns:a="http://schemas.openxmlformats.org/drawingml/2006/main"/>
+          <a:ln xmlns:a="http://schemas.openxmlformats.org/drawingml/2006/main" w="0">
+            <a:noFill/>
+          </a:ln>
+        </p:spPr>
+        <p:txBody>
+          <a:bodyPr xmlns:a="http://schemas.openxmlformats.org/drawingml/2006/main">
+            <a:noAutofit/>
+          </a:bodyPr>
+          <a:lstStyle xmlns:a="http://schemas.openxmlformats.org/drawingml/2006/main"/>
+          <a:p xmlns:a="http://schemas.openxmlformats.org/drawingml/2006/main">
+            <a:pPr>
               <a:defRPr sz="1800" b="0">
                 <a:solidFill>
                   <a:srgbClr val="607370"/>
@@ -7213,7 +7218,7 @@
                 <a:ea typeface="Arial"/>
                 <a:cs typeface="Arial"/>
               </a:rPr>
-              <a:t>Review the employer and final documents before authorizing a submission.</a:t>
+              <a:t>You can pause, correct an answer, or decline the optional LinkedIn review.</a:t>
             </a:r>
           </a:p>
         </p:txBody>
@@ -7221,7 +7226,7 @@
     </p:spTree>
     <p:extLst>
       <p:ext uri="{BB962C8B-B14F-4D97-AF65-F5344CB8AC3E}">
-        <p14:creationId xmlns:p14="http://schemas.microsoft.com/office/powerpoint/2010/main" val="954479412"/>
+        <p14:creationId xmlns:p14="http://schemas.microsoft.com/office/powerpoint/2010/main" val="1272416931"/>
       </p:ext>
     </p:extLst>
   </p:cSld>

</xml_diff>

<commit_message>
Clarify step hierarchy and make skill invocation visible
</commit_message>
<xml_diff>
--- a/docs/job-search-guide.pptx
+++ b/docs/job-search-guide.pptx
@@ -2,24 +2,25 @@
 <file path=ppt/presentation.xml><?xml version="1.0" encoding="utf-8"?>
 <p:presentation xmlns:p="http://schemas.openxmlformats.org/presentationml/2006/main">
   <p:sldMasterIdLst>
-    <p:sldMasterId xmlns:r="http://schemas.openxmlformats.org/officeDocument/2006/relationships" id="2147483648" r:id="R9b863e83e9024369"/>
+    <p:sldMasterId xmlns:r="http://schemas.openxmlformats.org/officeDocument/2006/relationships" id="2147483648" r:id="R447c6f4d8e7c41f4"/>
   </p:sldMasterIdLst>
   <p:notesMasterIdLst>
-    <p:notesMasterId xmlns:r="http://schemas.openxmlformats.org/officeDocument/2006/relationships" r:id="R2d042347b3fa4aa1"/>
+    <p:notesMasterId xmlns:r="http://schemas.openxmlformats.org/officeDocument/2006/relationships" r:id="R05c64d527ed3421d"/>
   </p:notesMasterIdLst>
   <p:sldIdLst>
-    <p:sldId xmlns:r="http://schemas.openxmlformats.org/officeDocument/2006/relationships" id="256" r:id="R73a96bba9de14c44"/>
-    <p:sldId xmlns:r="http://schemas.openxmlformats.org/officeDocument/2006/relationships" id="257" r:id="R09df6c3f644041cf"/>
-    <p:sldId xmlns:r="http://schemas.openxmlformats.org/officeDocument/2006/relationships" id="258" r:id="R4a94cdf16eea498f"/>
-    <p:sldId xmlns:r="http://schemas.openxmlformats.org/officeDocument/2006/relationships" id="259" r:id="R455b80a7e6c7453c"/>
-    <p:sldId xmlns:r="http://schemas.openxmlformats.org/officeDocument/2006/relationships" id="260" r:id="R244827bae3964145"/>
-    <p:sldId xmlns:r="http://schemas.openxmlformats.org/officeDocument/2006/relationships" id="261" r:id="R2d5014fccf5040f4"/>
-    <p:sldId xmlns:r="http://schemas.openxmlformats.org/officeDocument/2006/relationships" id="262" r:id="R00535d3b82634759"/>
-    <p:sldId xmlns:r="http://schemas.openxmlformats.org/officeDocument/2006/relationships" id="263" r:id="R030aa0021d164acb"/>
-    <p:sldId xmlns:r="http://schemas.openxmlformats.org/officeDocument/2006/relationships" id="264" r:id="R60318c25d96443ef"/>
-    <p:sldId xmlns:r="http://schemas.openxmlformats.org/officeDocument/2006/relationships" id="265" r:id="Rfa3962f9aca94706"/>
-    <p:sldId xmlns:r="http://schemas.openxmlformats.org/officeDocument/2006/relationships" id="266" r:id="R26856ed701dc4504"/>
-    <p:sldId xmlns:r="http://schemas.openxmlformats.org/officeDocument/2006/relationships" id="267" r:id="R8e85f092da0c40d1"/>
+    <p:sldId xmlns:r="http://schemas.openxmlformats.org/officeDocument/2006/relationships" id="256" r:id="Rd711b40d93e345da"/>
+    <p:sldId xmlns:r="http://schemas.openxmlformats.org/officeDocument/2006/relationships" id="257" r:id="Rc070b3f44a004fc1"/>
+    <p:sldId xmlns:r="http://schemas.openxmlformats.org/officeDocument/2006/relationships" id="258" r:id="Re4989ab6461f4ce0"/>
+    <p:sldId xmlns:r="http://schemas.openxmlformats.org/officeDocument/2006/relationships" id="259" r:id="Re4222a6d66404fa4"/>
+    <p:sldId xmlns:r="http://schemas.openxmlformats.org/officeDocument/2006/relationships" id="260" r:id="R1d36cab7690f4271"/>
+    <p:sldId xmlns:r="http://schemas.openxmlformats.org/officeDocument/2006/relationships" id="261" r:id="R2f68a8b3960841a1"/>
+    <p:sldId xmlns:r="http://schemas.openxmlformats.org/officeDocument/2006/relationships" id="262" r:id="R784a22507be840dd"/>
+    <p:sldId xmlns:r="http://schemas.openxmlformats.org/officeDocument/2006/relationships" id="263" r:id="Raed2aedeba6c4d88"/>
+    <p:sldId xmlns:r="http://schemas.openxmlformats.org/officeDocument/2006/relationships" id="264" r:id="R932733ca3efb4eb4"/>
+    <p:sldId xmlns:r="http://schemas.openxmlformats.org/officeDocument/2006/relationships" id="265" r:id="R1d4f18631c394f08"/>
+    <p:sldId xmlns:r="http://schemas.openxmlformats.org/officeDocument/2006/relationships" id="266" r:id="R654630a473a448b3"/>
+    <p:sldId xmlns:r="http://schemas.openxmlformats.org/officeDocument/2006/relationships" id="267" r:id="Rf02eaf7f81984f13"/>
+    <p:sldId xmlns:r="http://schemas.openxmlformats.org/officeDocument/2006/relationships" id="268" r:id="R77d2ecd75e3a47ec"/>
   </p:sldIdLst>
   <p:sldSz cx="12192000" cy="6858000"/>
   <p:notesSz cx="6858000" cy="9144000"/>
@@ -608,7 +609,12 @@
           <a:lstStyle xmlns:a="http://schemas.openxmlformats.org/drawingml/2006/main"/>
           <a:p xmlns:a="http://schemas.openxmlformats.org/drawingml/2006/main">
             <a:r>
-              <a:t/>
+              <a:t>Official invocation sources: https://learn.chatgpt.com/docs/build-skills#how-chatgpt-and-codex-use-skills</a:t>
+            </a:r>
+          </a:p>
+          <a:p xmlns:a="http://schemas.openxmlformats.org/drawingml/2006/main">
+            <a:r>
+              <a:t>https://code.claude.com/docs/en/skills</a:t>
             </a:r>
           </a:p>
           <a:p xmlns:a="http://schemas.openxmlformats.org/drawingml/2006/main">
@@ -649,6 +655,86 @@
 </file>
 
 <file path=ppt/notesSlides/notesSlide12.xml><?xml version="1.0" encoding="utf-8"?>
+<p:notes xmlns:p="http://schemas.openxmlformats.org/presentationml/2006/main">
+  <p:cSld>
+    <p:spTree>
+      <p:nvGrpSpPr>
+        <p:cNvPr id="1" name=""/>
+        <p:cNvGrpSpPr/>
+        <p:nvPr/>
+      </p:nvGrpSpPr>
+      <p:grpSpPr>
+        <a:xfrm xmlns:a="http://schemas.openxmlformats.org/drawingml/2006/main"/>
+      </p:grpSpPr>
+      <p:sp>
+        <p:nvSpPr>
+          <p:cNvPr id="2" name="Slide Image Placeholder 1"/>
+          <p:cNvSpPr>
+            <a:spLocks xmlns:a="http://schemas.openxmlformats.org/drawingml/2006/main" noGrp="1"/>
+          </p:cNvSpPr>
+          <p:nvPr>
+            <p:ph type="sldImg" idx="0"/>
+          </p:nvPr>
+        </p:nvSpPr>
+        <p:spPr/>
+      </p:sp>
+      <p:sp>
+        <p:nvSpPr>
+          <p:cNvPr id="3" name="Notes Placeholder 2"/>
+          <p:cNvSpPr>
+            <a:spLocks xmlns:a="http://schemas.openxmlformats.org/drawingml/2006/main" noGrp="1"/>
+          </p:cNvSpPr>
+          <p:nvPr>
+            <p:ph type="body" idx="1"/>
+          </p:nvPr>
+        </p:nvSpPr>
+        <p:spPr/>
+        <p:txBody>
+          <a:bodyPr xmlns:a="http://schemas.openxmlformats.org/drawingml/2006/main"/>
+          <a:lstStyle xmlns:a="http://schemas.openxmlformats.org/drawingml/2006/main"/>
+          <a:p xmlns:a="http://schemas.openxmlformats.org/drawingml/2006/main">
+            <a:r>
+              <a:t/>
+            </a:r>
+          </a:p>
+          <a:p xmlns:a="http://schemas.openxmlformats.org/drawingml/2006/main">
+            <a:r>
+              <a:t>Workflow source: https://github.com/toughdave/job-search</a:t>
+            </a:r>
+          </a:p>
+          <a:p xmlns:a="http://schemas.openxmlformats.org/drawingml/2006/main">
+            <a:r>
+              <a:t>Guide checked 12 September 2026.</a:t>
+            </a:r>
+          </a:p>
+        </p:txBody>
+      </p:sp>
+      <p:sp>
+        <p:nvSpPr>
+          <p:cNvPr id="4" name="Slide Number Placeholder 3"/>
+          <p:cNvSpPr>
+            <a:spLocks xmlns:a="http://schemas.openxmlformats.org/drawingml/2006/main" noGrp="1"/>
+          </p:cNvSpPr>
+          <p:nvPr>
+            <p:ph type="sldNum" idx="5"/>
+          </p:nvPr>
+        </p:nvSpPr>
+        <p:spPr/>
+        <p:txBody>
+          <a:bodyPr xmlns:a="http://schemas.openxmlformats.org/drawingml/2006/main"/>
+          <a:lstStyle xmlns:a="http://schemas.openxmlformats.org/drawingml/2006/main"/>
+          <a:p xmlns:a="http://schemas.openxmlformats.org/drawingml/2006/main"/>
+        </p:txBody>
+      </p:sp>
+    </p:spTree>
+  </p:cSld>
+  <p:clrMapOvr>
+    <a:masterClrMapping xmlns:a="http://schemas.openxmlformats.org/drawingml/2006/main"/>
+  </p:clrMapOvr>
+</p:notes>
+</file>
+
+<file path=ppt/notesSlides/notesSlide13.xml><?xml version="1.0" encoding="utf-8"?>
 <p:notes xmlns:p="http://schemas.openxmlformats.org/presentationml/2006/main">
   <p:cSld>
     <p:spTree>
@@ -1436,7 +1522,7 @@
   </p:cSld>
   <p:clrMap bg1="lt1" tx1="dk1" bg2="lt2" tx2="dk2" accent1="accent1" accent2="accent2" accent3="accent3" accent4="accent4" accent5="accent5" accent6="accent6" hlink="hlink" folHlink="folHlink"/>
   <p:sldLayoutIdLst>
-    <p:sldLayoutId xmlns:r="http://schemas.openxmlformats.org/officeDocument/2006/relationships" id="2147483649" r:id="R83ff074c86904eff"/>
+    <p:sldLayoutId xmlns:r="http://schemas.openxmlformats.org/officeDocument/2006/relationships" id="2147483649" r:id="R2c034fa69f4045fa"/>
   </p:sldLayoutIdLst>
   <p:txStyles>
     <p:titleStyle>
@@ -1987,7 +2073,7 @@
           <p:cNvPr id="5" name="">
             <a:extLst xmlns:a="http://schemas.openxmlformats.org/drawingml/2006/main">
               <a:ext uri="{FF2B5EF4-FFF2-40B4-BE49-F238E27FC236}">
-                <a16:creationId xmlns:a16="http://schemas.microsoft.com/office/drawing/2014/main" id="{8EF9DC22-1083-456E-B0A2-5154D879F56B}"/>
+                <a16:creationId xmlns:a16="http://schemas.microsoft.com/office/drawing/2014/main" id="{3CFD8572-2B1E-4214-8EF9-1339CD54B4D5}"/>
               </a:ext>
             </a:extLst>
           </p:cNvPr>
@@ -2044,7 +2130,7 @@
           <p:cNvPr id="2" name="">
             <a:extLst xmlns:a="http://schemas.openxmlformats.org/drawingml/2006/main">
               <a:ext uri="{FF2B5EF4-FFF2-40B4-BE49-F238E27FC236}">
-                <a16:creationId xmlns:a16="http://schemas.microsoft.com/office/drawing/2014/main" id="{AA246F9C-B72E-48F9-AB87-290BB1FACD8C}"/>
+                <a16:creationId xmlns:a16="http://schemas.microsoft.com/office/drawing/2014/main" id="{FA5E437F-8ECD-44E6-B463-195898A5B60D}"/>
               </a:ext>
             </a:extLst>
           </p:cNvPr>
@@ -2101,7 +2187,7 @@
           <p:cNvPr id="3" name="">
             <a:extLst xmlns:a="http://schemas.openxmlformats.org/drawingml/2006/main">
               <a:ext uri="{FF2B5EF4-FFF2-40B4-BE49-F238E27FC236}">
-                <a16:creationId xmlns:a16="http://schemas.microsoft.com/office/drawing/2014/main" id="{107D48B1-3A5B-47F1-832F-8FFD21D9012B}"/>
+                <a16:creationId xmlns:a16="http://schemas.microsoft.com/office/drawing/2014/main" id="{0C306B2E-B7C8-4922-A38C-3556C79BF1D7}"/>
               </a:ext>
             </a:extLst>
           </p:cNvPr>
@@ -2181,7 +2267,7 @@
           <p:cNvPr id="4" name="">
             <a:extLst xmlns:a="http://schemas.openxmlformats.org/drawingml/2006/main">
               <a:ext uri="{FF2B5EF4-FFF2-40B4-BE49-F238E27FC236}">
-                <a16:creationId xmlns:a16="http://schemas.microsoft.com/office/drawing/2014/main" id="{C64E9C3F-8956-4C51-B51A-A1593413340C}"/>
+                <a16:creationId xmlns:a16="http://schemas.microsoft.com/office/drawing/2014/main" id="{F043563B-09B2-4407-994F-9F2349DBFEB6}"/>
               </a:ext>
             </a:extLst>
           </p:cNvPr>
@@ -2227,7 +2313,7 @@
                 <a:latin typeface="Arial"/>
                 <a:ea typeface="Arial"/>
                 <a:cs typeface="Arial"/>
-                <a:hlinkClick xmlns:r="http://schemas.openxmlformats.org/officeDocument/2006/relationships" r:id="R6101db6dc191453d"/>
+                <a:hlinkClick xmlns:r="http://schemas.openxmlformats.org/officeDocument/2006/relationships" r:id="Rcad915c7e2a04e14"/>
               </a:rPr>
               <a:t>Open the GitHub guide</a:t>
             </a:r>
@@ -2237,7 +2323,7 @@
     </p:spTree>
     <p:extLst>
       <p:ext uri="{BB962C8B-B14F-4D97-AF65-F5344CB8AC3E}">
-        <p14:creationId xmlns:p14="http://schemas.microsoft.com/office/powerpoint/2010/main" val="1968043505"/>
+        <p14:creationId xmlns:p14="http://schemas.microsoft.com/office/powerpoint/2010/main" val="1874479654"/>
       </p:ext>
     </p:extLst>
   </p:cSld>
@@ -2268,7 +2354,7 @@
           <p:cNvPr id="7" name="">
             <a:extLst xmlns:a="http://schemas.openxmlformats.org/drawingml/2006/main">
               <a:ext uri="{FF2B5EF4-FFF2-40B4-BE49-F238E27FC236}">
-                <a16:creationId xmlns:a16="http://schemas.microsoft.com/office/drawing/2014/main" id="{9C9216BC-6A22-4CB6-8382-0AD2787CAE01}"/>
+                <a16:creationId xmlns:a16="http://schemas.microsoft.com/office/drawing/2014/main" id="{350241BA-8B3B-43B4-82C5-9870CEAE89D7}"/>
               </a:ext>
             </a:extLst>
           </p:cNvPr>
@@ -2325,7 +2411,7 @@
           <p:cNvPr id="2" name="">
             <a:extLst xmlns:a="http://schemas.openxmlformats.org/drawingml/2006/main">
               <a:ext uri="{FF2B5EF4-FFF2-40B4-BE49-F238E27FC236}">
-                <a16:creationId xmlns:a16="http://schemas.microsoft.com/office/drawing/2014/main" id="{B1EE6C74-3C41-4428-ACBB-D4BCEFA81BBF}"/>
+                <a16:creationId xmlns:a16="http://schemas.microsoft.com/office/drawing/2014/main" id="{7FEE3342-CC39-4418-B203-9D7EC8224EB4}"/>
               </a:ext>
             </a:extLst>
           </p:cNvPr>
@@ -2382,7 +2468,7 @@
           <p:cNvPr id="3" name="">
             <a:extLst xmlns:a="http://schemas.openxmlformats.org/drawingml/2006/main">
               <a:ext uri="{FF2B5EF4-FFF2-40B4-BE49-F238E27FC236}">
-                <a16:creationId xmlns:a16="http://schemas.microsoft.com/office/drawing/2014/main" id="{AB16394E-FF53-4E0E-A8CA-9CE24FD6A70B}"/>
+                <a16:creationId xmlns:a16="http://schemas.microsoft.com/office/drawing/2014/main" id="{AC649288-EFBF-42B1-A976-5C5D53F2ED48}"/>
               </a:ext>
             </a:extLst>
           </p:cNvPr>
@@ -2462,7 +2548,7 @@
           <p:cNvPr id="4" name="">
             <a:extLst xmlns:a="http://schemas.openxmlformats.org/drawingml/2006/main">
               <a:ext uri="{FF2B5EF4-FFF2-40B4-BE49-F238E27FC236}">
-                <a16:creationId xmlns:a16="http://schemas.microsoft.com/office/drawing/2014/main" id="{D6D916EE-66C6-482C-A46D-10E1FF1BDBB8}"/>
+                <a16:creationId xmlns:a16="http://schemas.microsoft.com/office/drawing/2014/main" id="{8D22CE55-A99C-4ACC-B393-4A806D8C29D1}"/>
               </a:ext>
             </a:extLst>
           </p:cNvPr>
@@ -2542,7 +2628,7 @@
           <p:cNvPr id="5" name="">
             <a:extLst xmlns:a="http://schemas.openxmlformats.org/drawingml/2006/main">
               <a:ext uri="{FF2B5EF4-FFF2-40B4-BE49-F238E27FC236}">
-                <a16:creationId xmlns:a16="http://schemas.microsoft.com/office/drawing/2014/main" id="{CE57F339-638E-4B61-A88D-6AC42053C01D}"/>
+                <a16:creationId xmlns:a16="http://schemas.microsoft.com/office/drawing/2014/main" id="{E44F2EA6-C1E2-49D3-AC39-9331FBE37E9D}"/>
               </a:ext>
             </a:extLst>
           </p:cNvPr>
@@ -2599,7 +2685,7 @@
           <p:cNvPr id="6" name="">
             <a:extLst xmlns:a="http://schemas.openxmlformats.org/drawingml/2006/main">
               <a:ext uri="{FF2B5EF4-FFF2-40B4-BE49-F238E27FC236}">
-                <a16:creationId xmlns:a16="http://schemas.microsoft.com/office/drawing/2014/main" id="{D9501BD8-A216-4000-9AB0-442692F40FC3}"/>
+                <a16:creationId xmlns:a16="http://schemas.microsoft.com/office/drawing/2014/main" id="{2B6E8193-12CE-4D81-867C-3940A1AF58E1}"/>
               </a:ext>
             </a:extLst>
           </p:cNvPr>
@@ -2654,7 +2740,7 @@
     </p:spTree>
     <p:extLst>
       <p:ext uri="{BB962C8B-B14F-4D97-AF65-F5344CB8AC3E}">
-        <p14:creationId xmlns:p14="http://schemas.microsoft.com/office/powerpoint/2010/main" val="1806265174"/>
+        <p14:creationId xmlns:p14="http://schemas.microsoft.com/office/powerpoint/2010/main" val="78834420"/>
       </p:ext>
     </p:extLst>
   </p:cSld>
@@ -2682,10 +2768,10 @@
       </p:grpSpPr>
       <p:sp>
         <p:nvSpPr>
-          <p:cNvPr id="7" name="">
-            <a:extLst xmlns:a="http://schemas.openxmlformats.org/drawingml/2006/main">
-              <a:ext uri="{FF2B5EF4-FFF2-40B4-BE49-F238E27FC236}">
-                <a16:creationId xmlns:a16="http://schemas.microsoft.com/office/drawing/2014/main" id="{F54C9276-686F-4092-82B1-D8E35D57CB89}"/>
+          <p:cNvPr id="9" name="">
+            <a:extLst xmlns:a="http://schemas.openxmlformats.org/drawingml/2006/main">
+              <a:ext uri="{FF2B5EF4-FFF2-40B4-BE49-F238E27FC236}">
+                <a16:creationId xmlns:a16="http://schemas.microsoft.com/office/drawing/2014/main" id="{0AED20B7-93BB-4EB8-8E68-E8EDEF319151}"/>
               </a:ext>
             </a:extLst>
           </p:cNvPr>
@@ -2732,7 +2818,7 @@
                 <a:ea typeface="Arial"/>
                 <a:cs typeface="Arial"/>
               </a:rPr>
-              <a:t>6. Next time</a:t>
+              <a:t>Summon the installed skill</a:t>
             </a:r>
           </a:p>
         </p:txBody>
@@ -2742,7 +2828,7 @@
           <p:cNvPr id="2" name="">
             <a:extLst xmlns:a="http://schemas.openxmlformats.org/drawingml/2006/main">
               <a:ext uri="{FF2B5EF4-FFF2-40B4-BE49-F238E27FC236}">
-                <a16:creationId xmlns:a16="http://schemas.microsoft.com/office/drawing/2014/main" id="{192D843F-1C8E-4805-9C8D-ACBD16057764}"/>
+                <a16:creationId xmlns:a16="http://schemas.microsoft.com/office/drawing/2014/main" id="{0240C919-039C-41A9-8CE4-CCB05BB54F67}"/>
               </a:ext>
             </a:extLst>
           </p:cNvPr>
@@ -2799,54 +2885,54 @@
           <p:cNvPr id="3" name="">
             <a:extLst xmlns:a="http://schemas.openxmlformats.org/drawingml/2006/main">
               <a:ext uri="{FF2B5EF4-FFF2-40B4-BE49-F238E27FC236}">
-                <a16:creationId xmlns:a16="http://schemas.microsoft.com/office/drawing/2014/main" id="{87E85178-4AA1-404E-AB59-6B3FC3E63DC1}"/>
-              </a:ext>
-            </a:extLst>
-          </p:cNvPr>
-          <p:cNvSpPr>
-            <a:spLocks xmlns:a="http://schemas.openxmlformats.org/drawingml/2006/main" noGrp="1"/>
-          </p:cNvSpPr>
-          <p:nvPr/>
-        </p:nvSpPr>
-        <p:spPr>
-          <a:xfrm xmlns:a="http://schemas.openxmlformats.org/drawingml/2006/main">
-            <a:off x="609600" y="1466850"/>
-            <a:ext cx="10820400" cy="752475"/>
-          </a:xfrm>
-          <a:prstGeom xmlns:a="http://schemas.openxmlformats.org/drawingml/2006/main" prst="rect">
-            <a:avLst/>
-          </a:prstGeom>
-          <a:noFill xmlns:a="http://schemas.openxmlformats.org/drawingml/2006/main"/>
-          <a:ln xmlns:a="http://schemas.openxmlformats.org/drawingml/2006/main" w="0">
-            <a:noFill/>
-          </a:ln>
-        </p:spPr>
-        <p:txBody>
-          <a:bodyPr xmlns:a="http://schemas.openxmlformats.org/drawingml/2006/main">
-            <a:noAutofit/>
-          </a:bodyPr>
-          <a:lstStyle xmlns:a="http://schemas.openxmlformats.org/drawingml/2006/main"/>
-          <a:p xmlns:a="http://schemas.openxmlformats.org/drawingml/2006/main">
-            <a:pPr>
-              <a:defRPr sz="2250" b="0">
-                <a:solidFill>
-                  <a:srgbClr val="283A39"/>
-                </a:solidFill>
-                <a:latin typeface="Arial"/>
-                <a:ea typeface="Arial"/>
-                <a:cs typeface="Arial"/>
-              </a:defRPr>
-            </a:pPr>
-            <a:r>
-              <a:rPr sz="2250" b="0">
-                <a:solidFill>
-                  <a:srgbClr val="283A39"/>
-                </a:solidFill>
-                <a:latin typeface="Arial"/>
-                <a:ea typeface="Arial"/>
-                <a:cs typeface="Arial"/>
-              </a:rPr>
-              <a:t>Reopen the same local project and conversation. Send:</a:t>
+                <a16:creationId xmlns:a16="http://schemas.microsoft.com/office/drawing/2014/main" id="{6CA5EF45-8922-483C-B830-3E232133E1B5}"/>
+              </a:ext>
+            </a:extLst>
+          </p:cNvPr>
+          <p:cNvSpPr>
+            <a:spLocks xmlns:a="http://schemas.openxmlformats.org/drawingml/2006/main" noGrp="1"/>
+          </p:cNvSpPr>
+          <p:nvPr/>
+        </p:nvSpPr>
+        <p:spPr>
+          <a:xfrm xmlns:a="http://schemas.openxmlformats.org/drawingml/2006/main">
+            <a:off x="609600" y="1514475"/>
+            <a:ext cx="10839450" cy="428625"/>
+          </a:xfrm>
+          <a:prstGeom xmlns:a="http://schemas.openxmlformats.org/drawingml/2006/main" prst="rect">
+            <a:avLst/>
+          </a:prstGeom>
+          <a:noFill xmlns:a="http://schemas.openxmlformats.org/drawingml/2006/main"/>
+          <a:ln xmlns:a="http://schemas.openxmlformats.org/drawingml/2006/main" w="0">
+            <a:noFill/>
+          </a:ln>
+        </p:spPr>
+        <p:txBody>
+          <a:bodyPr xmlns:a="http://schemas.openxmlformats.org/drawingml/2006/main">
+            <a:noAutofit/>
+          </a:bodyPr>
+          <a:lstStyle xmlns:a="http://schemas.openxmlformats.org/drawingml/2006/main"/>
+          <a:p xmlns:a="http://schemas.openxmlformats.org/drawingml/2006/main">
+            <a:pPr>
+              <a:defRPr sz="2250" b="1">
+                <a:solidFill>
+                  <a:srgbClr val="183F3B"/>
+                </a:solidFill>
+                <a:latin typeface="Arial"/>
+                <a:ea typeface="Arial"/>
+                <a:cs typeface="Arial"/>
+              </a:defRPr>
+            </a:pPr>
+            <a:r>
+              <a:rPr sz="2250" b="1">
+                <a:solidFill>
+                  <a:srgbClr val="183F3B"/>
+                </a:solidFill>
+                <a:latin typeface="Arial"/>
+                <a:ea typeface="Arial"/>
+                <a:cs typeface="Arial"/>
+              </a:rPr>
+              <a:t>Codex / ChatGPT desktop</a:t>
             </a:r>
           </a:p>
         </p:txBody>
@@ -2856,36 +2942,116 @@
           <p:cNvPr id="4" name="">
             <a:extLst xmlns:a="http://schemas.openxmlformats.org/drawingml/2006/main">
               <a:ext uri="{FF2B5EF4-FFF2-40B4-BE49-F238E27FC236}">
-                <a16:creationId xmlns:a16="http://schemas.microsoft.com/office/drawing/2014/main" id="{22784B8B-CB34-4915-A334-677A6D96F5EB}"/>
-              </a:ext>
-            </a:extLst>
-          </p:cNvPr>
-          <p:cNvSpPr>
-            <a:spLocks xmlns:a="http://schemas.openxmlformats.org/drawingml/2006/main" noGrp="1"/>
-          </p:cNvSpPr>
-          <p:nvPr/>
-        </p:nvSpPr>
-        <p:spPr>
-          <a:xfrm xmlns:a="http://schemas.openxmlformats.org/drawingml/2006/main">
-            <a:off x="609600" y="2828925"/>
-            <a:ext cx="10858500" cy="819150"/>
-          </a:xfrm>
-          <a:prstGeom xmlns:a="http://schemas.openxmlformats.org/drawingml/2006/main" prst="rect">
-            <a:avLst/>
-          </a:prstGeom>
-          <a:noFill xmlns:a="http://schemas.openxmlformats.org/drawingml/2006/main"/>
-          <a:ln xmlns:a="http://schemas.openxmlformats.org/drawingml/2006/main" w="0">
-            <a:noFill/>
-          </a:ln>
-        </p:spPr>
-        <p:txBody>
-          <a:bodyPr xmlns:a="http://schemas.openxmlformats.org/drawingml/2006/main">
-            <a:noAutofit/>
-          </a:bodyPr>
-          <a:lstStyle xmlns:a="http://schemas.openxmlformats.org/drawingml/2006/main"/>
-          <a:p xmlns:a="http://schemas.openxmlformats.org/drawingml/2006/main">
-            <a:pPr>
-              <a:defRPr sz="3675" b="1">
+                <a16:creationId xmlns:a16="http://schemas.microsoft.com/office/drawing/2014/main" id="{272AA754-72AD-4FF8-9C97-A057BDDCFE07}"/>
+              </a:ext>
+            </a:extLst>
+          </p:cNvPr>
+          <p:cNvSpPr>
+            <a:spLocks xmlns:a="http://schemas.openxmlformats.org/drawingml/2006/main" noGrp="1"/>
+          </p:cNvSpPr>
+          <p:nvPr/>
+        </p:nvSpPr>
+        <p:spPr>
+          <a:xfrm xmlns:a="http://schemas.openxmlformats.org/drawingml/2006/main">
+            <a:off x="609600" y="2047875"/>
+            <a:ext cx="10839450" cy="866775"/>
+          </a:xfrm>
+          <a:prstGeom xmlns:a="http://schemas.openxmlformats.org/drawingml/2006/main" prst="rect">
+            <a:avLst/>
+          </a:prstGeom>
+          <a:noFill xmlns:a="http://schemas.openxmlformats.org/drawingml/2006/main"/>
+          <a:ln xmlns:a="http://schemas.openxmlformats.org/drawingml/2006/main" w="0">
+            <a:noFill/>
+          </a:ln>
+        </p:spPr>
+        <p:txBody>
+          <a:bodyPr xmlns:a="http://schemas.openxmlformats.org/drawingml/2006/main">
+            <a:noAutofit/>
+          </a:bodyPr>
+          <a:lstStyle xmlns:a="http://schemas.openxmlformats.org/drawingml/2006/main"/>
+          <a:p xmlns:a="http://schemas.openxmlformats.org/drawingml/2006/main">
+            <a:pPr>
+              <a:defRPr sz="2100" b="0">
+                <a:solidFill>
+                  <a:srgbClr val="283A39"/>
+                </a:solidFill>
+                <a:latin typeface="Arial"/>
+                <a:ea typeface="Arial"/>
+                <a:cs typeface="Arial"/>
+              </a:defRPr>
+            </a:pPr>
+            <a:r>
+              <a:rPr sz="2100" b="0">
+                <a:solidFill>
+                  <a:srgbClr val="283A39"/>
+                </a:solidFill>
+                <a:latin typeface="Arial"/>
+                <a:ea typeface="Arial"/>
+                <a:cs typeface="Arial"/>
+              </a:rPr>
+              <a:t>Type @ and choose job-search. If your composer offers a $</a:t>
+            </a:r>
+          </a:p>
+          <a:p xmlns:a="http://schemas.openxmlformats.org/drawingml/2006/main">
+            <a:pPr>
+              <a:defRPr sz="2100" b="0">
+                <a:solidFill>
+                  <a:srgbClr val="283A39"/>
+                </a:solidFill>
+                <a:latin typeface="Arial"/>
+                <a:ea typeface="Arial"/>
+                <a:cs typeface="Arial"/>
+              </a:defRPr>
+            </a:pPr>
+            <a:r>
+              <a:rPr sz="2100" b="0">
+                <a:solidFill>
+                  <a:srgbClr val="283A39"/>
+                </a:solidFill>
+                <a:latin typeface="Arial"/>
+                <a:ea typeface="Arial"/>
+                <a:cs typeface="Arial"/>
+              </a:rPr>
+              <a:t>skill picker, choose job-search there.</a:t>
+            </a:r>
+          </a:p>
+        </p:txBody>
+      </p:sp>
+      <p:sp>
+        <p:nvSpPr>
+          <p:cNvPr id="5" name="">
+            <a:extLst xmlns:a="http://schemas.openxmlformats.org/drawingml/2006/main">
+              <a:ext uri="{FF2B5EF4-FFF2-40B4-BE49-F238E27FC236}">
+                <a16:creationId xmlns:a16="http://schemas.microsoft.com/office/drawing/2014/main" id="{198D4D4A-0062-43D7-8874-AB267B692E63}"/>
+              </a:ext>
+            </a:extLst>
+          </p:cNvPr>
+          <p:cNvSpPr>
+            <a:spLocks xmlns:a="http://schemas.openxmlformats.org/drawingml/2006/main" noGrp="1"/>
+          </p:cNvSpPr>
+          <p:nvPr/>
+        </p:nvSpPr>
+        <p:spPr>
+          <a:xfrm xmlns:a="http://schemas.openxmlformats.org/drawingml/2006/main">
+            <a:off x="609600" y="3276600"/>
+            <a:ext cx="10839450" cy="476250"/>
+          </a:xfrm>
+          <a:prstGeom xmlns:a="http://schemas.openxmlformats.org/drawingml/2006/main" prst="rect">
+            <a:avLst/>
+          </a:prstGeom>
+          <a:noFill xmlns:a="http://schemas.openxmlformats.org/drawingml/2006/main"/>
+          <a:ln xmlns:a="http://schemas.openxmlformats.org/drawingml/2006/main" w="0">
+            <a:noFill/>
+          </a:ln>
+        </p:spPr>
+        <p:txBody>
+          <a:bodyPr xmlns:a="http://schemas.openxmlformats.org/drawingml/2006/main">
+            <a:noAutofit/>
+          </a:bodyPr>
+          <a:lstStyle xmlns:a="http://schemas.openxmlformats.org/drawingml/2006/main"/>
+          <a:p xmlns:a="http://schemas.openxmlformats.org/drawingml/2006/main">
+            <a:pPr>
+              <a:defRPr sz="2400" b="1">
                 <a:solidFill>
                   <a:srgbClr val="183F3B"/>
                 </a:solidFill>
@@ -2895,7 +3061,7 @@
               </a:defRPr>
             </a:pPr>
             <a:r>
-              <a:rPr sz="3675" b="1">
+              <a:rPr sz="2400" b="1">
                 <a:solidFill>
                   <a:srgbClr val="183F3B"/>
                 </a:solidFill>
@@ -2903,87 +3069,7 @@
                 <a:ea typeface="Arial"/>
                 <a:cs typeface="Arial"/>
               </a:rPr>
-              <a:t>Continue my job search.</a:t>
-            </a:r>
-          </a:p>
-        </p:txBody>
-      </p:sp>
-      <p:sp>
-        <p:nvSpPr>
-          <p:cNvPr id="5" name="">
-            <a:extLst xmlns:a="http://schemas.openxmlformats.org/drawingml/2006/main">
-              <a:ext uri="{FF2B5EF4-FFF2-40B4-BE49-F238E27FC236}">
-                <a16:creationId xmlns:a16="http://schemas.microsoft.com/office/drawing/2014/main" id="{4D6A924D-6801-4C5F-8C23-B42519DB6B8E}"/>
-              </a:ext>
-            </a:extLst>
-          </p:cNvPr>
-          <p:cNvSpPr>
-            <a:spLocks xmlns:a="http://schemas.openxmlformats.org/drawingml/2006/main" noGrp="1"/>
-          </p:cNvSpPr>
-          <p:nvPr/>
-        </p:nvSpPr>
-        <p:spPr>
-          <a:xfrm xmlns:a="http://schemas.openxmlformats.org/drawingml/2006/main">
-            <a:off x="609600" y="4286250"/>
-            <a:ext cx="10858500" cy="952500"/>
-          </a:xfrm>
-          <a:prstGeom xmlns:a="http://schemas.openxmlformats.org/drawingml/2006/main" prst="rect">
-            <a:avLst/>
-          </a:prstGeom>
-          <a:noFill xmlns:a="http://schemas.openxmlformats.org/drawingml/2006/main"/>
-          <a:ln xmlns:a="http://schemas.openxmlformats.org/drawingml/2006/main" w="0">
-            <a:noFill/>
-          </a:ln>
-        </p:spPr>
-        <p:txBody>
-          <a:bodyPr xmlns:a="http://schemas.openxmlformats.org/drawingml/2006/main">
-            <a:noAutofit/>
-          </a:bodyPr>
-          <a:lstStyle xmlns:a="http://schemas.openxmlformats.org/drawingml/2006/main"/>
-          <a:p xmlns:a="http://schemas.openxmlformats.org/drawingml/2006/main">
-            <a:pPr>
-              <a:defRPr sz="2100" b="0">
-                <a:solidFill>
-                  <a:srgbClr val="283A39"/>
-                </a:solidFill>
-                <a:latin typeface="Arial"/>
-                <a:ea typeface="Arial"/>
-                <a:cs typeface="Arial"/>
-              </a:defRPr>
-            </a:pPr>
-            <a:r>
-              <a:rPr sz="2100" b="0">
-                <a:solidFill>
-                  <a:srgbClr val="283A39"/>
-                </a:solidFill>
-                <a:latin typeface="Arial"/>
-                <a:ea typeface="Arial"/>
-                <a:cs typeface="Arial"/>
-              </a:rPr>
-              <a:t>You usually do not reinstall or attach the same resume again.</a:t>
-            </a:r>
-          </a:p>
-          <a:p xmlns:a="http://schemas.openxmlformats.org/drawingml/2006/main">
-            <a:pPr>
-              <a:defRPr sz="2100" b="0">
-                <a:solidFill>
-                  <a:srgbClr val="283A39"/>
-                </a:solidFill>
-                <a:latin typeface="Arial"/>
-                <a:ea typeface="Arial"/>
-                <a:cs typeface="Arial"/>
-              </a:defRPr>
-            </a:pPr>
-            <a:r>
-              <a:rPr sz="2100" b="0">
-                <a:solidFill>
-                  <a:srgbClr val="283A39"/>
-                </a:solidFill>
-                <a:latin typeface="Arial"/>
-                <a:ea typeface="Arial"/>
-                <a:cs typeface="Arial"/>
-              </a:rPr>
-              <a:t>Supply an updated resume when it changes.</a:t>
+              <a:t>Codex CLI or IDE:  $job-search</a:t>
             </a:r>
           </a:p>
         </p:txBody>
@@ -2993,36 +3079,173 @@
           <p:cNvPr id="6" name="">
             <a:extLst xmlns:a="http://schemas.openxmlformats.org/drawingml/2006/main">
               <a:ext uri="{FF2B5EF4-FFF2-40B4-BE49-F238E27FC236}">
-                <a16:creationId xmlns:a16="http://schemas.microsoft.com/office/drawing/2014/main" id="{7F15A6AD-BF8A-4786-A8C1-6C10EBB49CFD}"/>
-              </a:ext>
-            </a:extLst>
-          </p:cNvPr>
-          <p:cNvSpPr>
-            <a:spLocks xmlns:a="http://schemas.openxmlformats.org/drawingml/2006/main" noGrp="1"/>
-          </p:cNvSpPr>
-          <p:nvPr/>
-        </p:nvSpPr>
-        <p:spPr>
-          <a:xfrm xmlns:a="http://schemas.openxmlformats.org/drawingml/2006/main">
-            <a:off x="609600" y="5781675"/>
-            <a:ext cx="10858500" cy="495300"/>
-          </a:xfrm>
-          <a:prstGeom xmlns:a="http://schemas.openxmlformats.org/drawingml/2006/main" prst="rect">
-            <a:avLst/>
-          </a:prstGeom>
-          <a:noFill xmlns:a="http://schemas.openxmlformats.org/drawingml/2006/main"/>
-          <a:ln xmlns:a="http://schemas.openxmlformats.org/drawingml/2006/main" w="0">
-            <a:noFill/>
-          </a:ln>
-        </p:spPr>
-        <p:txBody>
-          <a:bodyPr xmlns:a="http://schemas.openxmlformats.org/drawingml/2006/main">
-            <a:noAutofit/>
-          </a:bodyPr>
-          <a:lstStyle xmlns:a="http://schemas.openxmlformats.org/drawingml/2006/main"/>
-          <a:p xmlns:a="http://schemas.openxmlformats.org/drawingml/2006/main">
-            <a:pPr>
-              <a:defRPr sz="1800" b="0">
+                <a16:creationId xmlns:a16="http://schemas.microsoft.com/office/drawing/2014/main" id="{E6EF01D4-6C62-40A1-B485-3484E19CA2CF}"/>
+              </a:ext>
+            </a:extLst>
+          </p:cNvPr>
+          <p:cNvSpPr>
+            <a:spLocks xmlns:a="http://schemas.openxmlformats.org/drawingml/2006/main" noGrp="1"/>
+          </p:cNvSpPr>
+          <p:nvPr/>
+        </p:nvSpPr>
+        <p:spPr>
+          <a:xfrm xmlns:a="http://schemas.openxmlformats.org/drawingml/2006/main">
+            <a:off x="609600" y="4038600"/>
+            <a:ext cx="10839450" cy="476250"/>
+          </a:xfrm>
+          <a:prstGeom xmlns:a="http://schemas.openxmlformats.org/drawingml/2006/main" prst="rect">
+            <a:avLst/>
+          </a:prstGeom>
+          <a:noFill xmlns:a="http://schemas.openxmlformats.org/drawingml/2006/main"/>
+          <a:ln xmlns:a="http://schemas.openxmlformats.org/drawingml/2006/main" w="0">
+            <a:noFill/>
+          </a:ln>
+        </p:spPr>
+        <p:txBody>
+          <a:bodyPr xmlns:a="http://schemas.openxmlformats.org/drawingml/2006/main">
+            <a:noAutofit/>
+          </a:bodyPr>
+          <a:lstStyle xmlns:a="http://schemas.openxmlformats.org/drawingml/2006/main"/>
+          <a:p xmlns:a="http://schemas.openxmlformats.org/drawingml/2006/main">
+            <a:pPr>
+              <a:defRPr sz="2400" b="1">
+                <a:solidFill>
+                  <a:srgbClr val="183F3B"/>
+                </a:solidFill>
+                <a:latin typeface="Arial"/>
+                <a:ea typeface="Arial"/>
+                <a:cs typeface="Arial"/>
+              </a:defRPr>
+            </a:pPr>
+            <a:r>
+              <a:rPr sz="2400" b="1">
+                <a:solidFill>
+                  <a:srgbClr val="183F3B"/>
+                </a:solidFill>
+                <a:latin typeface="Arial"/>
+                <a:ea typeface="Arial"/>
+                <a:cs typeface="Arial"/>
+              </a:rPr>
+              <a:t>Claude Code:  /job-search</a:t>
+            </a:r>
+          </a:p>
+        </p:txBody>
+      </p:sp>
+      <p:sp>
+        <p:nvSpPr>
+          <p:cNvPr id="7" name="">
+            <a:extLst xmlns:a="http://schemas.openxmlformats.org/drawingml/2006/main">
+              <a:ext uri="{FF2B5EF4-FFF2-40B4-BE49-F238E27FC236}">
+                <a16:creationId xmlns:a16="http://schemas.microsoft.com/office/drawing/2014/main" id="{EC0C7C0B-13D5-4032-8460-0BDD8100E4E3}"/>
+              </a:ext>
+            </a:extLst>
+          </p:cNvPr>
+          <p:cNvSpPr>
+            <a:spLocks xmlns:a="http://schemas.openxmlformats.org/drawingml/2006/main" noGrp="1"/>
+          </p:cNvSpPr>
+          <p:nvPr/>
+        </p:nvSpPr>
+        <p:spPr>
+          <a:xfrm xmlns:a="http://schemas.openxmlformats.org/drawingml/2006/main">
+            <a:off x="609600" y="4981575"/>
+            <a:ext cx="10858500" cy="866775"/>
+          </a:xfrm>
+          <a:prstGeom xmlns:a="http://schemas.openxmlformats.org/drawingml/2006/main" prst="rect">
+            <a:avLst/>
+          </a:prstGeom>
+          <a:noFill xmlns:a="http://schemas.openxmlformats.org/drawingml/2006/main"/>
+          <a:ln xmlns:a="http://schemas.openxmlformats.org/drawingml/2006/main" w="0">
+            <a:noFill/>
+          </a:ln>
+        </p:spPr>
+        <p:txBody>
+          <a:bodyPr xmlns:a="http://schemas.openxmlformats.org/drawingml/2006/main">
+            <a:noAutofit/>
+          </a:bodyPr>
+          <a:lstStyle xmlns:a="http://schemas.openxmlformats.org/drawingml/2006/main"/>
+          <a:p xmlns:a="http://schemas.openxmlformats.org/drawingml/2006/main">
+            <a:pPr>
+              <a:defRPr sz="1950" b="0">
+                <a:solidFill>
+                  <a:srgbClr val="283A39"/>
+                </a:solidFill>
+                <a:latin typeface="Arial"/>
+                <a:ea typeface="Arial"/>
+                <a:cs typeface="Arial"/>
+              </a:defRPr>
+            </a:pPr>
+            <a:r>
+              <a:rPr sz="1950" b="0">
+                <a:solidFill>
+                  <a:srgbClr val="283A39"/>
+                </a:solidFill>
+                <a:latin typeface="Arial"/>
+                <a:ea typeface="Arial"/>
+                <a:cs typeface="Arial"/>
+              </a:rPr>
+              <a:t>Add “Start my search” or “Continue my job search”, then send.</a:t>
+            </a:r>
+          </a:p>
+          <a:p xmlns:a="http://schemas.openxmlformats.org/drawingml/2006/main">
+            <a:pPr>
+              <a:defRPr sz="1950" b="0">
+                <a:solidFill>
+                  <a:srgbClr val="283A39"/>
+                </a:solidFill>
+                <a:latin typeface="Arial"/>
+                <a:ea typeface="Arial"/>
+                <a:cs typeface="Arial"/>
+              </a:defRPr>
+            </a:pPr>
+            <a:r>
+              <a:rPr sz="1950" b="0">
+                <a:solidFill>
+                  <a:srgbClr val="283A39"/>
+                </a:solidFill>
+                <a:latin typeface="Arial"/>
+                <a:ea typeface="Arial"/>
+                <a:cs typeface="Arial"/>
+              </a:rPr>
+              <a:t>Use the AI message box after installation, in the same project.</a:t>
+            </a:r>
+          </a:p>
+        </p:txBody>
+      </p:sp>
+      <p:sp>
+        <p:nvSpPr>
+          <p:cNvPr id="8" name="">
+            <a:extLst xmlns:a="http://schemas.openxmlformats.org/drawingml/2006/main">
+              <a:ext uri="{FF2B5EF4-FFF2-40B4-BE49-F238E27FC236}">
+                <a16:creationId xmlns:a16="http://schemas.microsoft.com/office/drawing/2014/main" id="{5050E988-3CD4-41CB-8538-5ABCBAF0A86F}"/>
+              </a:ext>
+            </a:extLst>
+          </p:cNvPr>
+          <p:cNvSpPr>
+            <a:spLocks xmlns:a="http://schemas.openxmlformats.org/drawingml/2006/main" noGrp="1"/>
+          </p:cNvSpPr>
+          <p:nvPr/>
+        </p:nvSpPr>
+        <p:spPr>
+          <a:xfrm xmlns:a="http://schemas.openxmlformats.org/drawingml/2006/main">
+            <a:off x="609600" y="5981700"/>
+            <a:ext cx="10858500" cy="361950"/>
+          </a:xfrm>
+          <a:prstGeom xmlns:a="http://schemas.openxmlformats.org/drawingml/2006/main" prst="rect">
+            <a:avLst/>
+          </a:prstGeom>
+          <a:noFill xmlns:a="http://schemas.openxmlformats.org/drawingml/2006/main"/>
+          <a:ln xmlns:a="http://schemas.openxmlformats.org/drawingml/2006/main" w="0">
+            <a:noFill/>
+          </a:ln>
+        </p:spPr>
+        <p:txBody>
+          <a:bodyPr xmlns:a="http://schemas.openxmlformats.org/drawingml/2006/main">
+            <a:noAutofit/>
+          </a:bodyPr>
+          <a:lstStyle xmlns:a="http://schemas.openxmlformats.org/drawingml/2006/main"/>
+          <a:p xmlns:a="http://schemas.openxmlformats.org/drawingml/2006/main">
+            <a:pPr>
+              <a:defRPr sz="1650" b="0">
                 <a:solidFill>
                   <a:srgbClr val="607370"/>
                 </a:solidFill>
@@ -3032,7 +3255,7 @@
               </a:defRPr>
             </a:pPr>
             <a:r>
-              <a:rPr sz="1800" b="0">
+              <a:rPr sz="1650" b="0">
                 <a:solidFill>
                   <a:srgbClr val="607370"/>
                 </a:solidFill>
@@ -3040,7 +3263,7 @@
                 <a:ea typeface="Arial"/>
                 <a:cs typeface="Arial"/>
               </a:rPr>
-              <a:t>For an independent occupation search, use a new project with separate records.</a:t>
+              <a:t>If the picker cannot find it, send: “Use job-search.” Ask the AI to check installation if needed.</a:t>
             </a:r>
           </a:p>
         </p:txBody>
@@ -3048,7 +3271,7 @@
     </p:spTree>
     <p:extLst>
       <p:ext uri="{BB962C8B-B14F-4D97-AF65-F5344CB8AC3E}">
-        <p14:creationId xmlns:p14="http://schemas.microsoft.com/office/powerpoint/2010/main" val="2108912826"/>
+        <p14:creationId xmlns:p14="http://schemas.microsoft.com/office/powerpoint/2010/main" val="2067474245"/>
       </p:ext>
     </p:extLst>
   </p:cSld>
@@ -3076,10 +3299,10 @@
       </p:grpSpPr>
       <p:sp>
         <p:nvSpPr>
-          <p:cNvPr id="10" name="">
-            <a:extLst xmlns:a="http://schemas.openxmlformats.org/drawingml/2006/main">
-              <a:ext uri="{FF2B5EF4-FFF2-40B4-BE49-F238E27FC236}">
-                <a16:creationId xmlns:a16="http://schemas.microsoft.com/office/drawing/2014/main" id="{33FCED88-0134-4238-B8E9-AD955EAA318F}"/>
+          <p:cNvPr id="7" name="">
+            <a:extLst xmlns:a="http://schemas.openxmlformats.org/drawingml/2006/main">
+              <a:ext uri="{FF2B5EF4-FFF2-40B4-BE49-F238E27FC236}">
+                <a16:creationId xmlns:a16="http://schemas.microsoft.com/office/drawing/2014/main" id="{35B90193-37CF-4866-BAAB-DBDB56BF1A4C}"/>
               </a:ext>
             </a:extLst>
           </p:cNvPr>
@@ -3126,7 +3349,7 @@
                 <a:ea typeface="Arial"/>
                 <a:cs typeface="Arial"/>
               </a:rPr>
-              <a:t>If something stops you</a:t>
+              <a:t>6. Next time</a:t>
             </a:r>
           </a:p>
         </p:txBody>
@@ -3136,7 +3359,7 @@
           <p:cNvPr id="2" name="">
             <a:extLst xmlns:a="http://schemas.openxmlformats.org/drawingml/2006/main">
               <a:ext uri="{FF2B5EF4-FFF2-40B4-BE49-F238E27FC236}">
-                <a16:creationId xmlns:a16="http://schemas.microsoft.com/office/drawing/2014/main" id="{A4CCD037-52B0-40D2-AB5A-BA123C52577D}"/>
+                <a16:creationId xmlns:a16="http://schemas.microsoft.com/office/drawing/2014/main" id="{8416A3F8-DB4C-40A1-BF71-564F67B392AF}"/>
               </a:ext>
             </a:extLst>
           </p:cNvPr>
@@ -3193,36 +3416,116 @@
           <p:cNvPr id="3" name="">
             <a:extLst xmlns:a="http://schemas.openxmlformats.org/drawingml/2006/main">
               <a:ext uri="{FF2B5EF4-FFF2-40B4-BE49-F238E27FC236}">
-                <a16:creationId xmlns:a16="http://schemas.microsoft.com/office/drawing/2014/main" id="{A461935A-A3B9-46BA-9231-61DC043F2303}"/>
-              </a:ext>
-            </a:extLst>
-          </p:cNvPr>
-          <p:cNvSpPr>
-            <a:spLocks xmlns:a="http://schemas.openxmlformats.org/drawingml/2006/main" noGrp="1"/>
-          </p:cNvSpPr>
-          <p:nvPr/>
-        </p:nvSpPr>
-        <p:spPr>
-          <a:xfrm xmlns:a="http://schemas.openxmlformats.org/drawingml/2006/main">
-            <a:off x="609600" y="1504950"/>
-            <a:ext cx="5048250" cy="428625"/>
-          </a:xfrm>
-          <a:prstGeom xmlns:a="http://schemas.openxmlformats.org/drawingml/2006/main" prst="rect">
-            <a:avLst/>
-          </a:prstGeom>
-          <a:noFill xmlns:a="http://schemas.openxmlformats.org/drawingml/2006/main"/>
-          <a:ln xmlns:a="http://schemas.openxmlformats.org/drawingml/2006/main" w="0">
-            <a:noFill/>
-          </a:ln>
-        </p:spPr>
-        <p:txBody>
-          <a:bodyPr xmlns:a="http://schemas.openxmlformats.org/drawingml/2006/main">
-            <a:noAutofit/>
-          </a:bodyPr>
-          <a:lstStyle xmlns:a="http://schemas.openxmlformats.org/drawingml/2006/main"/>
-          <a:p xmlns:a="http://schemas.openxmlformats.org/drawingml/2006/main">
-            <a:pPr>
-              <a:defRPr sz="2325" b="1">
+                <a16:creationId xmlns:a16="http://schemas.microsoft.com/office/drawing/2014/main" id="{C20F840D-06AC-4DA6-AFC7-8EA8C1E1123A}"/>
+              </a:ext>
+            </a:extLst>
+          </p:cNvPr>
+          <p:cNvSpPr>
+            <a:spLocks xmlns:a="http://schemas.openxmlformats.org/drawingml/2006/main" noGrp="1"/>
+          </p:cNvSpPr>
+          <p:nvPr/>
+        </p:nvSpPr>
+        <p:spPr>
+          <a:xfrm xmlns:a="http://schemas.openxmlformats.org/drawingml/2006/main">
+            <a:off x="609600" y="1466850"/>
+            <a:ext cx="10820400" cy="752475"/>
+          </a:xfrm>
+          <a:prstGeom xmlns:a="http://schemas.openxmlformats.org/drawingml/2006/main" prst="rect">
+            <a:avLst/>
+          </a:prstGeom>
+          <a:noFill xmlns:a="http://schemas.openxmlformats.org/drawingml/2006/main"/>
+          <a:ln xmlns:a="http://schemas.openxmlformats.org/drawingml/2006/main" w="0">
+            <a:noFill/>
+          </a:ln>
+        </p:spPr>
+        <p:txBody>
+          <a:bodyPr xmlns:a="http://schemas.openxmlformats.org/drawingml/2006/main">
+            <a:noAutofit/>
+          </a:bodyPr>
+          <a:lstStyle xmlns:a="http://schemas.openxmlformats.org/drawingml/2006/main"/>
+          <a:p xmlns:a="http://schemas.openxmlformats.org/drawingml/2006/main">
+            <a:pPr>
+              <a:defRPr sz="2250" b="0">
+                <a:solidFill>
+                  <a:srgbClr val="283A39"/>
+                </a:solidFill>
+                <a:latin typeface="Arial"/>
+                <a:ea typeface="Arial"/>
+                <a:cs typeface="Arial"/>
+              </a:defRPr>
+            </a:pPr>
+            <a:r>
+              <a:rPr sz="2250" b="0">
+                <a:solidFill>
+                  <a:srgbClr val="283A39"/>
+                </a:solidFill>
+                <a:latin typeface="Arial"/>
+                <a:ea typeface="Arial"/>
+                <a:cs typeface="Arial"/>
+              </a:rPr>
+              <a:t>a. Reopen the same local project and conversation.</a:t>
+            </a:r>
+          </a:p>
+          <a:p xmlns:a="http://schemas.openxmlformats.org/drawingml/2006/main">
+            <a:pPr>
+              <a:defRPr sz="2250" b="0">
+                <a:solidFill>
+                  <a:srgbClr val="283A39"/>
+                </a:solidFill>
+                <a:latin typeface="Arial"/>
+                <a:ea typeface="Arial"/>
+                <a:cs typeface="Arial"/>
+              </a:defRPr>
+            </a:pPr>
+            <a:r>
+              <a:rPr sz="2250" b="0">
+                <a:solidFill>
+                  <a:srgbClr val="283A39"/>
+                </a:solidFill>
+                <a:latin typeface="Arial"/>
+                <a:ea typeface="Arial"/>
+                <a:cs typeface="Arial"/>
+              </a:rPr>
+              <a:t>b. Summon job-search, then send:</a:t>
+            </a:r>
+          </a:p>
+        </p:txBody>
+      </p:sp>
+      <p:sp>
+        <p:nvSpPr>
+          <p:cNvPr id="4" name="">
+            <a:extLst xmlns:a="http://schemas.openxmlformats.org/drawingml/2006/main">
+              <a:ext uri="{FF2B5EF4-FFF2-40B4-BE49-F238E27FC236}">
+                <a16:creationId xmlns:a16="http://schemas.microsoft.com/office/drawing/2014/main" id="{98756A7F-C9BF-4F52-A681-2212D2CA8853}"/>
+              </a:ext>
+            </a:extLst>
+          </p:cNvPr>
+          <p:cNvSpPr>
+            <a:spLocks xmlns:a="http://schemas.openxmlformats.org/drawingml/2006/main" noGrp="1"/>
+          </p:cNvSpPr>
+          <p:nvPr/>
+        </p:nvSpPr>
+        <p:spPr>
+          <a:xfrm xmlns:a="http://schemas.openxmlformats.org/drawingml/2006/main">
+            <a:off x="609600" y="2828925"/>
+            <a:ext cx="10858500" cy="819150"/>
+          </a:xfrm>
+          <a:prstGeom xmlns:a="http://schemas.openxmlformats.org/drawingml/2006/main" prst="rect">
+            <a:avLst/>
+          </a:prstGeom>
+          <a:noFill xmlns:a="http://schemas.openxmlformats.org/drawingml/2006/main"/>
+          <a:ln xmlns:a="http://schemas.openxmlformats.org/drawingml/2006/main" w="0">
+            <a:noFill/>
+          </a:ln>
+        </p:spPr>
+        <p:txBody>
+          <a:bodyPr xmlns:a="http://schemas.openxmlformats.org/drawingml/2006/main">
+            <a:noAutofit/>
+          </a:bodyPr>
+          <a:lstStyle xmlns:a="http://schemas.openxmlformats.org/drawingml/2006/main"/>
+          <a:p xmlns:a="http://schemas.openxmlformats.org/drawingml/2006/main">
+            <a:pPr>
+              <a:defRPr sz="3675" b="1">
                 <a:solidFill>
                   <a:srgbClr val="183F3B"/>
                 </a:solidFill>
@@ -3232,7 +3535,7 @@
               </a:defRPr>
             </a:pPr>
             <a:r>
-              <a:rPr sz="2325" b="1">
+              <a:rPr sz="3675" b="1">
                 <a:solidFill>
                   <a:srgbClr val="183F3B"/>
                 </a:solidFill>
@@ -3240,87 +3543,7 @@
                 <a:ea typeface="Arial"/>
                 <a:cs typeface="Arial"/>
               </a:rPr>
-              <a:t>Skill missing?</a:t>
-            </a:r>
-          </a:p>
-        </p:txBody>
-      </p:sp>
-      <p:sp>
-        <p:nvSpPr>
-          <p:cNvPr id="4" name="">
-            <a:extLst xmlns:a="http://schemas.openxmlformats.org/drawingml/2006/main">
-              <a:ext uri="{FF2B5EF4-FFF2-40B4-BE49-F238E27FC236}">
-                <a16:creationId xmlns:a16="http://schemas.microsoft.com/office/drawing/2014/main" id="{9DD37D5D-AABC-4ED0-BEF0-BA773542F506}"/>
-              </a:ext>
-            </a:extLst>
-          </p:cNvPr>
-          <p:cNvSpPr>
-            <a:spLocks xmlns:a="http://schemas.openxmlformats.org/drawingml/2006/main" noGrp="1"/>
-          </p:cNvSpPr>
-          <p:nvPr/>
-        </p:nvSpPr>
-        <p:spPr>
-          <a:xfrm xmlns:a="http://schemas.openxmlformats.org/drawingml/2006/main">
-            <a:off x="609600" y="2066925"/>
-            <a:ext cx="5191125" cy="1047750"/>
-          </a:xfrm>
-          <a:prstGeom xmlns:a="http://schemas.openxmlformats.org/drawingml/2006/main" prst="rect">
-            <a:avLst/>
-          </a:prstGeom>
-          <a:noFill xmlns:a="http://schemas.openxmlformats.org/drawingml/2006/main"/>
-          <a:ln xmlns:a="http://schemas.openxmlformats.org/drawingml/2006/main" w="0">
-            <a:noFill/>
-          </a:ln>
-        </p:spPr>
-        <p:txBody>
-          <a:bodyPr xmlns:a="http://schemas.openxmlformats.org/drawingml/2006/main">
-            <a:noAutofit/>
-          </a:bodyPr>
-          <a:lstStyle xmlns:a="http://schemas.openxmlformats.org/drawingml/2006/main"/>
-          <a:p xmlns:a="http://schemas.openxmlformats.org/drawingml/2006/main">
-            <a:pPr>
-              <a:defRPr sz="1950" b="0">
-                <a:solidFill>
-                  <a:srgbClr val="283A39"/>
-                </a:solidFill>
-                <a:latin typeface="Arial"/>
-                <a:ea typeface="Arial"/>
-                <a:cs typeface="Arial"/>
-              </a:defRPr>
-            </a:pPr>
-            <a:r>
-              <a:rPr sz="1950" b="0">
-                <a:solidFill>
-                  <a:srgbClr val="283A39"/>
-                </a:solidFill>
-                <a:latin typeface="Arial"/>
-                <a:ea typeface="Arial"/>
-                <a:cs typeface="Arial"/>
-              </a:rPr>
-              <a:t>“Check whether job-search is installed</a:t>
-            </a:r>
-          </a:p>
-          <a:p xmlns:a="http://schemas.openxmlformats.org/drawingml/2006/main">
-            <a:pPr>
-              <a:defRPr sz="1950" b="0">
-                <a:solidFill>
-                  <a:srgbClr val="283A39"/>
-                </a:solidFill>
-                <a:latin typeface="Arial"/>
-                <a:ea typeface="Arial"/>
-                <a:cs typeface="Arial"/>
-              </a:defRPr>
-            </a:pPr>
-            <a:r>
-              <a:rPr sz="1950" b="0">
-                <a:solidFill>
-                  <a:srgbClr val="283A39"/>
-                </a:solidFill>
-                <a:latin typeface="Arial"/>
-                <a:ea typeface="Arial"/>
-                <a:cs typeface="Arial"/>
-              </a:rPr>
-              <a:t>in this project and help me load it.”</a:t>
+              <a:t>Continue my job search.</a:t>
             </a:r>
           </a:p>
         </p:txBody>
@@ -3330,54 +3553,77 @@
           <p:cNvPr id="5" name="">
             <a:extLst xmlns:a="http://schemas.openxmlformats.org/drawingml/2006/main">
               <a:ext uri="{FF2B5EF4-FFF2-40B4-BE49-F238E27FC236}">
-                <a16:creationId xmlns:a16="http://schemas.microsoft.com/office/drawing/2014/main" id="{01EFBEE0-DB46-4089-93EC-6D32199BA7A1}"/>
-              </a:ext>
-            </a:extLst>
-          </p:cNvPr>
-          <p:cNvSpPr>
-            <a:spLocks xmlns:a="http://schemas.openxmlformats.org/drawingml/2006/main" noGrp="1"/>
-          </p:cNvSpPr>
-          <p:nvPr/>
-        </p:nvSpPr>
-        <p:spPr>
-          <a:xfrm xmlns:a="http://schemas.openxmlformats.org/drawingml/2006/main">
-            <a:off x="6400800" y="1504950"/>
-            <a:ext cx="5048250" cy="428625"/>
-          </a:xfrm>
-          <a:prstGeom xmlns:a="http://schemas.openxmlformats.org/drawingml/2006/main" prst="rect">
-            <a:avLst/>
-          </a:prstGeom>
-          <a:noFill xmlns:a="http://schemas.openxmlformats.org/drawingml/2006/main"/>
-          <a:ln xmlns:a="http://schemas.openxmlformats.org/drawingml/2006/main" w="0">
-            <a:noFill/>
-          </a:ln>
-        </p:spPr>
-        <p:txBody>
-          <a:bodyPr xmlns:a="http://schemas.openxmlformats.org/drawingml/2006/main">
-            <a:noAutofit/>
-          </a:bodyPr>
-          <a:lstStyle xmlns:a="http://schemas.openxmlformats.org/drawingml/2006/main"/>
-          <a:p xmlns:a="http://schemas.openxmlformats.org/drawingml/2006/main">
-            <a:pPr>
-              <a:defRPr sz="2325" b="1">
-                <a:solidFill>
-                  <a:srgbClr val="183F3B"/>
-                </a:solidFill>
-                <a:latin typeface="Arial"/>
-                <a:ea typeface="Arial"/>
-                <a:cs typeface="Arial"/>
-              </a:defRPr>
-            </a:pPr>
-            <a:r>
-              <a:rPr sz="2325" b="1">
-                <a:solidFill>
-                  <a:srgbClr val="183F3B"/>
-                </a:solidFill>
-                <a:latin typeface="Arial"/>
-                <a:ea typeface="Arial"/>
-                <a:cs typeface="Arial"/>
-              </a:rPr>
-              <a:t>Cannot save?</a:t>
+                <a16:creationId xmlns:a16="http://schemas.microsoft.com/office/drawing/2014/main" id="{C8F0FF98-EDBF-4E87-A7F3-30D41F9DC8BE}"/>
+              </a:ext>
+            </a:extLst>
+          </p:cNvPr>
+          <p:cNvSpPr>
+            <a:spLocks xmlns:a="http://schemas.openxmlformats.org/drawingml/2006/main" noGrp="1"/>
+          </p:cNvSpPr>
+          <p:nvPr/>
+        </p:nvSpPr>
+        <p:spPr>
+          <a:xfrm xmlns:a="http://schemas.openxmlformats.org/drawingml/2006/main">
+            <a:off x="609600" y="4286250"/>
+            <a:ext cx="10858500" cy="952500"/>
+          </a:xfrm>
+          <a:prstGeom xmlns:a="http://schemas.openxmlformats.org/drawingml/2006/main" prst="rect">
+            <a:avLst/>
+          </a:prstGeom>
+          <a:noFill xmlns:a="http://schemas.openxmlformats.org/drawingml/2006/main"/>
+          <a:ln xmlns:a="http://schemas.openxmlformats.org/drawingml/2006/main" w="0">
+            <a:noFill/>
+          </a:ln>
+        </p:spPr>
+        <p:txBody>
+          <a:bodyPr xmlns:a="http://schemas.openxmlformats.org/drawingml/2006/main">
+            <a:noAutofit/>
+          </a:bodyPr>
+          <a:lstStyle xmlns:a="http://schemas.openxmlformats.org/drawingml/2006/main"/>
+          <a:p xmlns:a="http://schemas.openxmlformats.org/drawingml/2006/main">
+            <a:pPr>
+              <a:defRPr sz="2100" b="0">
+                <a:solidFill>
+                  <a:srgbClr val="283A39"/>
+                </a:solidFill>
+                <a:latin typeface="Arial"/>
+                <a:ea typeface="Arial"/>
+                <a:cs typeface="Arial"/>
+              </a:defRPr>
+            </a:pPr>
+            <a:r>
+              <a:rPr sz="2100" b="0">
+                <a:solidFill>
+                  <a:srgbClr val="283A39"/>
+                </a:solidFill>
+                <a:latin typeface="Arial"/>
+                <a:ea typeface="Arial"/>
+                <a:cs typeface="Arial"/>
+              </a:rPr>
+              <a:t>c. Continue from your saved progress.</a:t>
+            </a:r>
+          </a:p>
+          <a:p xmlns:a="http://schemas.openxmlformats.org/drawingml/2006/main">
+            <a:pPr>
+              <a:defRPr sz="2100" b="0">
+                <a:solidFill>
+                  <a:srgbClr val="283A39"/>
+                </a:solidFill>
+                <a:latin typeface="Arial"/>
+                <a:ea typeface="Arial"/>
+                <a:cs typeface="Arial"/>
+              </a:defRPr>
+            </a:pPr>
+            <a:r>
+              <a:rPr sz="2100" b="0">
+                <a:solidFill>
+                  <a:srgbClr val="283A39"/>
+                </a:solidFill>
+                <a:latin typeface="Arial"/>
+                <a:ea typeface="Arial"/>
+                <a:cs typeface="Arial"/>
+              </a:rPr>
+              <a:t>Supply an updated resume when it changes.</a:t>
             </a:r>
           </a:p>
         </p:txBody>
@@ -3387,295 +3633,54 @@
           <p:cNvPr id="6" name="">
             <a:extLst xmlns:a="http://schemas.openxmlformats.org/drawingml/2006/main">
               <a:ext uri="{FF2B5EF4-FFF2-40B4-BE49-F238E27FC236}">
-                <a16:creationId xmlns:a16="http://schemas.microsoft.com/office/drawing/2014/main" id="{0B98B804-5BAD-4103-A36F-5C2F2CB83FF3}"/>
-              </a:ext>
-            </a:extLst>
-          </p:cNvPr>
-          <p:cNvSpPr>
-            <a:spLocks xmlns:a="http://schemas.openxmlformats.org/drawingml/2006/main" noGrp="1"/>
-          </p:cNvSpPr>
-          <p:nvPr/>
-        </p:nvSpPr>
-        <p:spPr>
-          <a:xfrm xmlns:a="http://schemas.openxmlformats.org/drawingml/2006/main">
-            <a:off x="6400800" y="2066925"/>
-            <a:ext cx="5162550" cy="1257300"/>
-          </a:xfrm>
-          <a:prstGeom xmlns:a="http://schemas.openxmlformats.org/drawingml/2006/main" prst="rect">
-            <a:avLst/>
-          </a:prstGeom>
-          <a:noFill xmlns:a="http://schemas.openxmlformats.org/drawingml/2006/main"/>
-          <a:ln xmlns:a="http://schemas.openxmlformats.org/drawingml/2006/main" w="0">
-            <a:noFill/>
-          </a:ln>
-        </p:spPr>
-        <p:txBody>
-          <a:bodyPr xmlns:a="http://schemas.openxmlformats.org/drawingml/2006/main">
-            <a:noAutofit/>
-          </a:bodyPr>
-          <a:lstStyle xmlns:a="http://schemas.openxmlformats.org/drawingml/2006/main"/>
-          <a:p xmlns:a="http://schemas.openxmlformats.org/drawingml/2006/main">
-            <a:pPr>
-              <a:defRPr sz="1950" b="0">
-                <a:solidFill>
-                  <a:srgbClr val="283A39"/>
-                </a:solidFill>
-                <a:latin typeface="Arial"/>
-                <a:ea typeface="Arial"/>
-                <a:cs typeface="Arial"/>
-              </a:defRPr>
-            </a:pPr>
-            <a:r>
-              <a:rPr sz="1950" b="0">
-                <a:solidFill>
-                  <a:srgbClr val="283A39"/>
-                </a:solidFill>
-                <a:latin typeface="Arial"/>
-                <a:ea typeface="Arial"/>
-                <a:cs typeface="Arial"/>
-              </a:rPr>
-              <a:t>Check the selected folder and file</a:t>
-            </a:r>
-          </a:p>
-          <a:p xmlns:a="http://schemas.openxmlformats.org/drawingml/2006/main">
-            <a:pPr>
-              <a:defRPr sz="1950" b="0">
-                <a:solidFill>
-                  <a:srgbClr val="283A39"/>
-                </a:solidFill>
-                <a:latin typeface="Arial"/>
-                <a:ea typeface="Arial"/>
-                <a:cs typeface="Arial"/>
-              </a:defRPr>
-            </a:pPr>
-            <a:r>
-              <a:rPr sz="1950" b="0">
-                <a:solidFill>
-                  <a:srgbClr val="283A39"/>
-                </a:solidFill>
-                <a:latin typeface="Arial"/>
-                <a:ea typeface="Arial"/>
-                <a:cs typeface="Arial"/>
-              </a:rPr>
-              <a:t>permissions. Approve the specific</a:t>
-            </a:r>
-          </a:p>
-          <a:p xmlns:a="http://schemas.openxmlformats.org/drawingml/2006/main">
-            <a:pPr>
-              <a:defRPr sz="1950" b="0">
-                <a:solidFill>
-                  <a:srgbClr val="283A39"/>
-                </a:solidFill>
-                <a:latin typeface="Arial"/>
-                <a:ea typeface="Arial"/>
-                <a:cs typeface="Arial"/>
-              </a:defRPr>
-            </a:pPr>
-            <a:r>
-              <a:rPr sz="1950" b="0">
-                <a:solidFill>
-                  <a:srgbClr val="283A39"/>
-                </a:solidFill>
-                <a:latin typeface="Arial"/>
-                <a:ea typeface="Arial"/>
-                <a:cs typeface="Arial"/>
-              </a:rPr>
-              <a:t>access request if you want it to proceed.</a:t>
-            </a:r>
-          </a:p>
-        </p:txBody>
-      </p:sp>
-      <p:sp>
-        <p:nvSpPr>
-          <p:cNvPr id="7" name="">
-            <a:extLst xmlns:a="http://schemas.openxmlformats.org/drawingml/2006/main">
-              <a:ext uri="{FF2B5EF4-FFF2-40B4-BE49-F238E27FC236}">
-                <a16:creationId xmlns:a16="http://schemas.microsoft.com/office/drawing/2014/main" id="{9B13B433-2A8D-401A-9D5F-E1546ECA009A}"/>
-              </a:ext>
-            </a:extLst>
-          </p:cNvPr>
-          <p:cNvSpPr>
-            <a:spLocks xmlns:a="http://schemas.openxmlformats.org/drawingml/2006/main" noGrp="1"/>
-          </p:cNvSpPr>
-          <p:nvPr/>
-        </p:nvSpPr>
-        <p:spPr>
-          <a:xfrm xmlns:a="http://schemas.openxmlformats.org/drawingml/2006/main">
-            <a:off x="609600" y="3810000"/>
-            <a:ext cx="10953750" cy="457200"/>
-          </a:xfrm>
-          <a:prstGeom xmlns:a="http://schemas.openxmlformats.org/drawingml/2006/main" prst="rect">
-            <a:avLst/>
-          </a:prstGeom>
-          <a:noFill xmlns:a="http://schemas.openxmlformats.org/drawingml/2006/main"/>
-          <a:ln xmlns:a="http://schemas.openxmlformats.org/drawingml/2006/main" w="0">
-            <a:noFill/>
-          </a:ln>
-        </p:spPr>
-        <p:txBody>
-          <a:bodyPr xmlns:a="http://schemas.openxmlformats.org/drawingml/2006/main">
-            <a:noAutofit/>
-          </a:bodyPr>
-          <a:lstStyle xmlns:a="http://schemas.openxmlformats.org/drawingml/2006/main"/>
-          <a:p xmlns:a="http://schemas.openxmlformats.org/drawingml/2006/main">
-            <a:pPr>
-              <a:defRPr sz="2325" b="1">
-                <a:solidFill>
-                  <a:srgbClr val="183F3B"/>
-                </a:solidFill>
-                <a:latin typeface="Arial"/>
-                <a:ea typeface="Arial"/>
-                <a:cs typeface="Arial"/>
-              </a:defRPr>
-            </a:pPr>
-            <a:r>
-              <a:rPr sz="2325" b="1">
-                <a:solidFill>
-                  <a:srgbClr val="183F3B"/>
-                </a:solidFill>
-                <a:latin typeface="Arial"/>
-                <a:ea typeface="Arial"/>
-                <a:cs typeface="Arial"/>
-              </a:rPr>
-              <a:t>New chat cannot find your records?</a:t>
-            </a:r>
-          </a:p>
-        </p:txBody>
-      </p:sp>
-      <p:sp>
-        <p:nvSpPr>
-          <p:cNvPr id="8" name="">
-            <a:extLst xmlns:a="http://schemas.openxmlformats.org/drawingml/2006/main">
-              <a:ext uri="{FF2B5EF4-FFF2-40B4-BE49-F238E27FC236}">
-                <a16:creationId xmlns:a16="http://schemas.microsoft.com/office/drawing/2014/main" id="{B9D71F83-64C1-41A5-80D5-193751642076}"/>
-              </a:ext>
-            </a:extLst>
-          </p:cNvPr>
-          <p:cNvSpPr>
-            <a:spLocks xmlns:a="http://schemas.openxmlformats.org/drawingml/2006/main" noGrp="1"/>
-          </p:cNvSpPr>
-          <p:nvPr/>
-        </p:nvSpPr>
-        <p:spPr>
-          <a:xfrm xmlns:a="http://schemas.openxmlformats.org/drawingml/2006/main">
-            <a:off x="609600" y="4400550"/>
-            <a:ext cx="10906125" cy="952500"/>
-          </a:xfrm>
-          <a:prstGeom xmlns:a="http://schemas.openxmlformats.org/drawingml/2006/main" prst="rect">
-            <a:avLst/>
-          </a:prstGeom>
-          <a:noFill xmlns:a="http://schemas.openxmlformats.org/drawingml/2006/main"/>
-          <a:ln xmlns:a="http://schemas.openxmlformats.org/drawingml/2006/main" w="0">
-            <a:noFill/>
-          </a:ln>
-        </p:spPr>
-        <p:txBody>
-          <a:bodyPr xmlns:a="http://schemas.openxmlformats.org/drawingml/2006/main">
-            <a:noAutofit/>
-          </a:bodyPr>
-          <a:lstStyle xmlns:a="http://schemas.openxmlformats.org/drawingml/2006/main"/>
-          <a:p xmlns:a="http://schemas.openxmlformats.org/drawingml/2006/main">
-            <a:pPr>
-              <a:defRPr sz="2100" b="0">
-                <a:solidFill>
-                  <a:srgbClr val="283A39"/>
-                </a:solidFill>
-                <a:latin typeface="Arial"/>
-                <a:ea typeface="Arial"/>
-                <a:cs typeface="Arial"/>
-              </a:defRPr>
-            </a:pPr>
-            <a:r>
-              <a:rPr sz="2100" b="0">
-                <a:solidFill>
-                  <a:srgbClr val="283A39"/>
-                </a:solidFill>
-                <a:latin typeface="Arial"/>
-                <a:ea typeface="Arial"/>
-                <a:cs typeface="Arial"/>
-              </a:rPr>
-              <a:t>Provide the private records location the AI gave you. Say:</a:t>
-            </a:r>
-          </a:p>
-          <a:p xmlns:a="http://schemas.openxmlformats.org/drawingml/2006/main">
-            <a:pPr>
-              <a:defRPr sz="2100" b="0">
-                <a:solidFill>
-                  <a:srgbClr val="283A39"/>
-                </a:solidFill>
-                <a:latin typeface="Arial"/>
-                <a:ea typeface="Arial"/>
-                <a:cs typeface="Arial"/>
-              </a:defRPr>
-            </a:pPr>
-            <a:r>
-              <a:rPr sz="2100" b="0">
-                <a:solidFill>
-                  <a:srgbClr val="283A39"/>
-                </a:solidFill>
-                <a:latin typeface="Arial"/>
-                <a:ea typeface="Arial"/>
-                <a:cs typeface="Arial"/>
-              </a:rPr>
-              <a:t>“Resume my existing search here; do not start over.”</a:t>
-            </a:r>
-          </a:p>
-        </p:txBody>
-      </p:sp>
-      <p:sp>
-        <p:nvSpPr>
-          <p:cNvPr id="9" name="">
-            <a:extLst xmlns:a="http://schemas.openxmlformats.org/drawingml/2006/main">
-              <a:ext uri="{FF2B5EF4-FFF2-40B4-BE49-F238E27FC236}">
-                <a16:creationId xmlns:a16="http://schemas.microsoft.com/office/drawing/2014/main" id="{C035B68F-216E-4A36-AAEC-3450AFCFEAFE}"/>
-              </a:ext>
-            </a:extLst>
-          </p:cNvPr>
-          <p:cNvSpPr>
-            <a:spLocks xmlns:a="http://schemas.openxmlformats.org/drawingml/2006/main" noGrp="1"/>
-          </p:cNvSpPr>
-          <p:nvPr/>
-        </p:nvSpPr>
-        <p:spPr>
-          <a:xfrm xmlns:a="http://schemas.openxmlformats.org/drawingml/2006/main">
-            <a:off x="609600" y="5810250"/>
-            <a:ext cx="9810750" cy="361950"/>
-          </a:xfrm>
-          <a:prstGeom xmlns:a="http://schemas.openxmlformats.org/drawingml/2006/main" prst="rect">
-            <a:avLst/>
-          </a:prstGeom>
-          <a:noFill xmlns:a="http://schemas.openxmlformats.org/drawingml/2006/main"/>
-          <a:ln xmlns:a="http://schemas.openxmlformats.org/drawingml/2006/main" w="0">
-            <a:noFill/>
-          </a:ln>
-        </p:spPr>
-        <p:txBody>
-          <a:bodyPr xmlns:a="http://schemas.openxmlformats.org/drawingml/2006/main">
-            <a:noAutofit/>
-          </a:bodyPr>
-          <a:lstStyle xmlns:a="http://schemas.openxmlformats.org/drawingml/2006/main"/>
-          <a:p xmlns:a="http://schemas.openxmlformats.org/drawingml/2006/main">
-            <a:pPr>
-              <a:defRPr sz="1875" b="0">
-                <a:solidFill>
-                  <a:srgbClr val="087F73"/>
-                </a:solidFill>
-                <a:latin typeface="Arial"/>
-                <a:ea typeface="Arial"/>
-                <a:cs typeface="Arial"/>
-              </a:defRPr>
-            </a:pPr>
-            <a:r>
-              <a:rPr sz="1875" b="0">
-                <a:solidFill>
-                  <a:srgbClr val="087F73"/>
-                </a:solidFill>
-                <a:latin typeface="Arial"/>
-                <a:ea typeface="Arial"/>
-                <a:cs typeface="Arial"/>
-                <a:hlinkClick xmlns:r="http://schemas.openxmlformats.org/officeDocument/2006/relationships" r:id="Rb83e9f62f28843c2"/>
-              </a:rPr>
-              <a:t>Full guide, downloads and troubleshooting</a:t>
+                <a16:creationId xmlns:a16="http://schemas.microsoft.com/office/drawing/2014/main" id="{DEA8BD44-03C4-42CE-9A82-ADC1D52D3EAF}"/>
+              </a:ext>
+            </a:extLst>
+          </p:cNvPr>
+          <p:cNvSpPr>
+            <a:spLocks xmlns:a="http://schemas.openxmlformats.org/drawingml/2006/main" noGrp="1"/>
+          </p:cNvSpPr>
+          <p:nvPr/>
+        </p:nvSpPr>
+        <p:spPr>
+          <a:xfrm xmlns:a="http://schemas.openxmlformats.org/drawingml/2006/main">
+            <a:off x="609600" y="5781675"/>
+            <a:ext cx="10858500" cy="495300"/>
+          </a:xfrm>
+          <a:prstGeom xmlns:a="http://schemas.openxmlformats.org/drawingml/2006/main" prst="rect">
+            <a:avLst/>
+          </a:prstGeom>
+          <a:noFill xmlns:a="http://schemas.openxmlformats.org/drawingml/2006/main"/>
+          <a:ln xmlns:a="http://schemas.openxmlformats.org/drawingml/2006/main" w="0">
+            <a:noFill/>
+          </a:ln>
+        </p:spPr>
+        <p:txBody>
+          <a:bodyPr xmlns:a="http://schemas.openxmlformats.org/drawingml/2006/main">
+            <a:noAutofit/>
+          </a:bodyPr>
+          <a:lstStyle xmlns:a="http://schemas.openxmlformats.org/drawingml/2006/main"/>
+          <a:p xmlns:a="http://schemas.openxmlformats.org/drawingml/2006/main">
+            <a:pPr>
+              <a:defRPr sz="1800" b="0">
+                <a:solidFill>
+                  <a:srgbClr val="607370"/>
+                </a:solidFill>
+                <a:latin typeface="Arial"/>
+                <a:ea typeface="Arial"/>
+                <a:cs typeface="Arial"/>
+              </a:defRPr>
+            </a:pPr>
+            <a:r>
+              <a:rPr sz="1800" b="0">
+                <a:solidFill>
+                  <a:srgbClr val="607370"/>
+                </a:solidFill>
+                <a:latin typeface="Arial"/>
+                <a:ea typeface="Arial"/>
+                <a:cs typeface="Arial"/>
+              </a:rPr>
+              <a:t>For an independent occupation search, use a new project with separate records.</a:t>
             </a:r>
           </a:p>
         </p:txBody>
@@ -3683,7 +3688,642 @@
     </p:spTree>
     <p:extLst>
       <p:ext uri="{BB962C8B-B14F-4D97-AF65-F5344CB8AC3E}">
-        <p14:creationId xmlns:p14="http://schemas.microsoft.com/office/powerpoint/2010/main" val="884505924"/>
+        <p14:creationId xmlns:p14="http://schemas.microsoft.com/office/powerpoint/2010/main" val="2053392650"/>
+      </p:ext>
+    </p:extLst>
+  </p:cSld>
+</p:sld>
+</file>
+
+<file path=ppt/slides/slide13.xml><?xml version="1.0" encoding="utf-8"?>
+<p:sld xmlns:p="http://schemas.openxmlformats.org/presentationml/2006/main">
+  <p:cSld>
+    <p:bg>
+      <p:bgPr>
+        <a:solidFill xmlns:a="http://schemas.openxmlformats.org/drawingml/2006/main">
+          <a:srgbClr val="FAFCFA"/>
+        </a:solidFill>
+      </p:bgPr>
+    </p:bg>
+    <p:spTree>
+      <p:nvGrpSpPr>
+        <p:cNvPr id="1" name=""/>
+        <p:cNvGrpSpPr/>
+        <p:nvPr/>
+      </p:nvGrpSpPr>
+      <p:grpSpPr>
+        <a:xfrm xmlns:a="http://schemas.openxmlformats.org/drawingml/2006/main"/>
+      </p:grpSpPr>
+      <p:sp>
+        <p:nvSpPr>
+          <p:cNvPr id="10" name="">
+            <a:extLst xmlns:a="http://schemas.openxmlformats.org/drawingml/2006/main">
+              <a:ext uri="{FF2B5EF4-FFF2-40B4-BE49-F238E27FC236}">
+                <a16:creationId xmlns:a16="http://schemas.microsoft.com/office/drawing/2014/main" id="{7572D228-7152-48C7-8BD4-FFB15416003C}"/>
+              </a:ext>
+            </a:extLst>
+          </p:cNvPr>
+          <p:cNvSpPr>
+            <a:spLocks xmlns:a="http://schemas.openxmlformats.org/drawingml/2006/main" noGrp="1"/>
+          </p:cNvSpPr>
+          <p:nvPr/>
+        </p:nvSpPr>
+        <p:spPr>
+          <a:xfrm xmlns:a="http://schemas.openxmlformats.org/drawingml/2006/main">
+            <a:off x="609600" y="457200"/>
+            <a:ext cx="10972800" cy="742950"/>
+          </a:xfrm>
+          <a:prstGeom xmlns:a="http://schemas.openxmlformats.org/drawingml/2006/main" prst="rect">
+            <a:avLst/>
+          </a:prstGeom>
+          <a:noFill xmlns:a="http://schemas.openxmlformats.org/drawingml/2006/main"/>
+          <a:ln xmlns:a="http://schemas.openxmlformats.org/drawingml/2006/main" w="0">
+            <a:noFill/>
+          </a:ln>
+        </p:spPr>
+        <p:txBody>
+          <a:bodyPr xmlns:a="http://schemas.openxmlformats.org/drawingml/2006/main">
+            <a:noAutofit/>
+          </a:bodyPr>
+          <a:lstStyle xmlns:a="http://schemas.openxmlformats.org/drawingml/2006/main"/>
+          <a:p xmlns:a="http://schemas.openxmlformats.org/drawingml/2006/main">
+            <a:pPr>
+              <a:defRPr sz="3450" b="1">
+                <a:solidFill>
+                  <a:srgbClr val="183F3B"/>
+                </a:solidFill>
+                <a:latin typeface="Arial"/>
+                <a:ea typeface="Arial"/>
+                <a:cs typeface="Arial"/>
+              </a:defRPr>
+            </a:pPr>
+            <a:r>
+              <a:rPr sz="3450" b="1">
+                <a:solidFill>
+                  <a:srgbClr val="183F3B"/>
+                </a:solidFill>
+                <a:latin typeface="Arial"/>
+                <a:ea typeface="Arial"/>
+                <a:cs typeface="Arial"/>
+              </a:rPr>
+              <a:t>If something stops you</a:t>
+            </a:r>
+          </a:p>
+        </p:txBody>
+      </p:sp>
+      <p:sp>
+        <p:nvSpPr>
+          <p:cNvPr id="2" name="">
+            <a:extLst xmlns:a="http://schemas.openxmlformats.org/drawingml/2006/main">
+              <a:ext uri="{FF2B5EF4-FFF2-40B4-BE49-F238E27FC236}">
+                <a16:creationId xmlns:a16="http://schemas.microsoft.com/office/drawing/2014/main" id="{6A41F988-2E52-4DC4-AD2A-242AFE3137D1}"/>
+              </a:ext>
+            </a:extLst>
+          </p:cNvPr>
+          <p:cNvSpPr>
+            <a:spLocks xmlns:a="http://schemas.openxmlformats.org/drawingml/2006/main" noGrp="1"/>
+          </p:cNvSpPr>
+          <p:nvPr/>
+        </p:nvSpPr>
+        <p:spPr>
+          <a:xfrm xmlns:a="http://schemas.openxmlformats.org/drawingml/2006/main">
+            <a:off x="11049000" y="6334125"/>
+            <a:ext cx="533400" cy="266700"/>
+          </a:xfrm>
+          <a:prstGeom xmlns:a="http://schemas.openxmlformats.org/drawingml/2006/main" prst="rect">
+            <a:avLst/>
+          </a:prstGeom>
+          <a:noFill xmlns:a="http://schemas.openxmlformats.org/drawingml/2006/main"/>
+          <a:ln xmlns:a="http://schemas.openxmlformats.org/drawingml/2006/main" w="0">
+            <a:noFill/>
+          </a:ln>
+        </p:spPr>
+        <p:txBody>
+          <a:bodyPr xmlns:a="http://schemas.openxmlformats.org/drawingml/2006/main">
+            <a:noAutofit/>
+          </a:bodyPr>
+          <a:lstStyle xmlns:a="http://schemas.openxmlformats.org/drawingml/2006/main"/>
+          <a:p xmlns:a="http://schemas.openxmlformats.org/drawingml/2006/main">
+            <a:pPr>
+              <a:defRPr sz="1350" b="0">
+                <a:solidFill>
+                  <a:srgbClr val="607370"/>
+                </a:solidFill>
+                <a:latin typeface="Arial"/>
+                <a:ea typeface="Arial"/>
+                <a:cs typeface="Arial"/>
+              </a:defRPr>
+            </a:pPr>
+            <a:r>
+              <a:rPr sz="1350" b="0">
+                <a:solidFill>
+                  <a:srgbClr val="607370"/>
+                </a:solidFill>
+                <a:latin typeface="Arial"/>
+                <a:ea typeface="Arial"/>
+                <a:cs typeface="Arial"/>
+              </a:rPr>
+              <a:t>13</a:t>
+            </a:r>
+          </a:p>
+        </p:txBody>
+      </p:sp>
+      <p:sp>
+        <p:nvSpPr>
+          <p:cNvPr id="3" name="">
+            <a:extLst xmlns:a="http://schemas.openxmlformats.org/drawingml/2006/main">
+              <a:ext uri="{FF2B5EF4-FFF2-40B4-BE49-F238E27FC236}">
+                <a16:creationId xmlns:a16="http://schemas.microsoft.com/office/drawing/2014/main" id="{F1C43A07-AABC-417B-B821-724B5D65C0F4}"/>
+              </a:ext>
+            </a:extLst>
+          </p:cNvPr>
+          <p:cNvSpPr>
+            <a:spLocks xmlns:a="http://schemas.openxmlformats.org/drawingml/2006/main" noGrp="1"/>
+          </p:cNvSpPr>
+          <p:nvPr/>
+        </p:nvSpPr>
+        <p:spPr>
+          <a:xfrm xmlns:a="http://schemas.openxmlformats.org/drawingml/2006/main">
+            <a:off x="609600" y="1504950"/>
+            <a:ext cx="5048250" cy="428625"/>
+          </a:xfrm>
+          <a:prstGeom xmlns:a="http://schemas.openxmlformats.org/drawingml/2006/main" prst="rect">
+            <a:avLst/>
+          </a:prstGeom>
+          <a:noFill xmlns:a="http://schemas.openxmlformats.org/drawingml/2006/main"/>
+          <a:ln xmlns:a="http://schemas.openxmlformats.org/drawingml/2006/main" w="0">
+            <a:noFill/>
+          </a:ln>
+        </p:spPr>
+        <p:txBody>
+          <a:bodyPr xmlns:a="http://schemas.openxmlformats.org/drawingml/2006/main">
+            <a:noAutofit/>
+          </a:bodyPr>
+          <a:lstStyle xmlns:a="http://schemas.openxmlformats.org/drawingml/2006/main"/>
+          <a:p xmlns:a="http://schemas.openxmlformats.org/drawingml/2006/main">
+            <a:pPr>
+              <a:defRPr sz="2325" b="1">
+                <a:solidFill>
+                  <a:srgbClr val="183F3B"/>
+                </a:solidFill>
+                <a:latin typeface="Arial"/>
+                <a:ea typeface="Arial"/>
+                <a:cs typeface="Arial"/>
+              </a:defRPr>
+            </a:pPr>
+            <a:r>
+              <a:rPr sz="2325" b="1">
+                <a:solidFill>
+                  <a:srgbClr val="183F3B"/>
+                </a:solidFill>
+                <a:latin typeface="Arial"/>
+                <a:ea typeface="Arial"/>
+                <a:cs typeface="Arial"/>
+              </a:rPr>
+              <a:t>Skill missing?</a:t>
+            </a:r>
+          </a:p>
+        </p:txBody>
+      </p:sp>
+      <p:sp>
+        <p:nvSpPr>
+          <p:cNvPr id="4" name="">
+            <a:extLst xmlns:a="http://schemas.openxmlformats.org/drawingml/2006/main">
+              <a:ext uri="{FF2B5EF4-FFF2-40B4-BE49-F238E27FC236}">
+                <a16:creationId xmlns:a16="http://schemas.microsoft.com/office/drawing/2014/main" id="{F82D097E-16D9-494E-A425-9748631150D1}"/>
+              </a:ext>
+            </a:extLst>
+          </p:cNvPr>
+          <p:cNvSpPr>
+            <a:spLocks xmlns:a="http://schemas.openxmlformats.org/drawingml/2006/main" noGrp="1"/>
+          </p:cNvSpPr>
+          <p:nvPr/>
+        </p:nvSpPr>
+        <p:spPr>
+          <a:xfrm xmlns:a="http://schemas.openxmlformats.org/drawingml/2006/main">
+            <a:off x="609600" y="2066925"/>
+            <a:ext cx="5191125" cy="1047750"/>
+          </a:xfrm>
+          <a:prstGeom xmlns:a="http://schemas.openxmlformats.org/drawingml/2006/main" prst="rect">
+            <a:avLst/>
+          </a:prstGeom>
+          <a:noFill xmlns:a="http://schemas.openxmlformats.org/drawingml/2006/main"/>
+          <a:ln xmlns:a="http://schemas.openxmlformats.org/drawingml/2006/main" w="0">
+            <a:noFill/>
+          </a:ln>
+        </p:spPr>
+        <p:txBody>
+          <a:bodyPr xmlns:a="http://schemas.openxmlformats.org/drawingml/2006/main">
+            <a:noAutofit/>
+          </a:bodyPr>
+          <a:lstStyle xmlns:a="http://schemas.openxmlformats.org/drawingml/2006/main"/>
+          <a:p xmlns:a="http://schemas.openxmlformats.org/drawingml/2006/main">
+            <a:pPr>
+              <a:defRPr sz="1950" b="0">
+                <a:solidFill>
+                  <a:srgbClr val="283A39"/>
+                </a:solidFill>
+                <a:latin typeface="Arial"/>
+                <a:ea typeface="Arial"/>
+                <a:cs typeface="Arial"/>
+              </a:defRPr>
+            </a:pPr>
+            <a:r>
+              <a:rPr sz="1950" b="0">
+                <a:solidFill>
+                  <a:srgbClr val="283A39"/>
+                </a:solidFill>
+                <a:latin typeface="Arial"/>
+                <a:ea typeface="Arial"/>
+                <a:cs typeface="Arial"/>
+              </a:rPr>
+              <a:t>“Check whether job-search is installed</a:t>
+            </a:r>
+          </a:p>
+          <a:p xmlns:a="http://schemas.openxmlformats.org/drawingml/2006/main">
+            <a:pPr>
+              <a:defRPr sz="1950" b="0">
+                <a:solidFill>
+                  <a:srgbClr val="283A39"/>
+                </a:solidFill>
+                <a:latin typeface="Arial"/>
+                <a:ea typeface="Arial"/>
+                <a:cs typeface="Arial"/>
+              </a:defRPr>
+            </a:pPr>
+            <a:r>
+              <a:rPr sz="1950" b="0">
+                <a:solidFill>
+                  <a:srgbClr val="283A39"/>
+                </a:solidFill>
+                <a:latin typeface="Arial"/>
+                <a:ea typeface="Arial"/>
+                <a:cs typeface="Arial"/>
+              </a:rPr>
+              <a:t>in this project and help me load it.”</a:t>
+            </a:r>
+          </a:p>
+        </p:txBody>
+      </p:sp>
+      <p:sp>
+        <p:nvSpPr>
+          <p:cNvPr id="5" name="">
+            <a:extLst xmlns:a="http://schemas.openxmlformats.org/drawingml/2006/main">
+              <a:ext uri="{FF2B5EF4-FFF2-40B4-BE49-F238E27FC236}">
+                <a16:creationId xmlns:a16="http://schemas.microsoft.com/office/drawing/2014/main" id="{2E29D74C-0DA4-4EC5-A66A-DDB9E1826672}"/>
+              </a:ext>
+            </a:extLst>
+          </p:cNvPr>
+          <p:cNvSpPr>
+            <a:spLocks xmlns:a="http://schemas.openxmlformats.org/drawingml/2006/main" noGrp="1"/>
+          </p:cNvSpPr>
+          <p:nvPr/>
+        </p:nvSpPr>
+        <p:spPr>
+          <a:xfrm xmlns:a="http://schemas.openxmlformats.org/drawingml/2006/main">
+            <a:off x="6400800" y="1504950"/>
+            <a:ext cx="5048250" cy="428625"/>
+          </a:xfrm>
+          <a:prstGeom xmlns:a="http://schemas.openxmlformats.org/drawingml/2006/main" prst="rect">
+            <a:avLst/>
+          </a:prstGeom>
+          <a:noFill xmlns:a="http://schemas.openxmlformats.org/drawingml/2006/main"/>
+          <a:ln xmlns:a="http://schemas.openxmlformats.org/drawingml/2006/main" w="0">
+            <a:noFill/>
+          </a:ln>
+        </p:spPr>
+        <p:txBody>
+          <a:bodyPr xmlns:a="http://schemas.openxmlformats.org/drawingml/2006/main">
+            <a:noAutofit/>
+          </a:bodyPr>
+          <a:lstStyle xmlns:a="http://schemas.openxmlformats.org/drawingml/2006/main"/>
+          <a:p xmlns:a="http://schemas.openxmlformats.org/drawingml/2006/main">
+            <a:pPr>
+              <a:defRPr sz="2325" b="1">
+                <a:solidFill>
+                  <a:srgbClr val="183F3B"/>
+                </a:solidFill>
+                <a:latin typeface="Arial"/>
+                <a:ea typeface="Arial"/>
+                <a:cs typeface="Arial"/>
+              </a:defRPr>
+            </a:pPr>
+            <a:r>
+              <a:rPr sz="2325" b="1">
+                <a:solidFill>
+                  <a:srgbClr val="183F3B"/>
+                </a:solidFill>
+                <a:latin typeface="Arial"/>
+                <a:ea typeface="Arial"/>
+                <a:cs typeface="Arial"/>
+              </a:rPr>
+              <a:t>Cannot save?</a:t>
+            </a:r>
+          </a:p>
+        </p:txBody>
+      </p:sp>
+      <p:sp>
+        <p:nvSpPr>
+          <p:cNvPr id="6" name="">
+            <a:extLst xmlns:a="http://schemas.openxmlformats.org/drawingml/2006/main">
+              <a:ext uri="{FF2B5EF4-FFF2-40B4-BE49-F238E27FC236}">
+                <a16:creationId xmlns:a16="http://schemas.microsoft.com/office/drawing/2014/main" id="{0EF5A486-B674-487A-81DF-D6D4FA59DE14}"/>
+              </a:ext>
+            </a:extLst>
+          </p:cNvPr>
+          <p:cNvSpPr>
+            <a:spLocks xmlns:a="http://schemas.openxmlformats.org/drawingml/2006/main" noGrp="1"/>
+          </p:cNvSpPr>
+          <p:nvPr/>
+        </p:nvSpPr>
+        <p:spPr>
+          <a:xfrm xmlns:a="http://schemas.openxmlformats.org/drawingml/2006/main">
+            <a:off x="6400800" y="2066925"/>
+            <a:ext cx="5162550" cy="1257300"/>
+          </a:xfrm>
+          <a:prstGeom xmlns:a="http://schemas.openxmlformats.org/drawingml/2006/main" prst="rect">
+            <a:avLst/>
+          </a:prstGeom>
+          <a:noFill xmlns:a="http://schemas.openxmlformats.org/drawingml/2006/main"/>
+          <a:ln xmlns:a="http://schemas.openxmlformats.org/drawingml/2006/main" w="0">
+            <a:noFill/>
+          </a:ln>
+        </p:spPr>
+        <p:txBody>
+          <a:bodyPr xmlns:a="http://schemas.openxmlformats.org/drawingml/2006/main">
+            <a:noAutofit/>
+          </a:bodyPr>
+          <a:lstStyle xmlns:a="http://schemas.openxmlformats.org/drawingml/2006/main"/>
+          <a:p xmlns:a="http://schemas.openxmlformats.org/drawingml/2006/main">
+            <a:pPr>
+              <a:defRPr sz="1950" b="0">
+                <a:solidFill>
+                  <a:srgbClr val="283A39"/>
+                </a:solidFill>
+                <a:latin typeface="Arial"/>
+                <a:ea typeface="Arial"/>
+                <a:cs typeface="Arial"/>
+              </a:defRPr>
+            </a:pPr>
+            <a:r>
+              <a:rPr sz="1950" b="0">
+                <a:solidFill>
+                  <a:srgbClr val="283A39"/>
+                </a:solidFill>
+                <a:latin typeface="Arial"/>
+                <a:ea typeface="Arial"/>
+                <a:cs typeface="Arial"/>
+              </a:rPr>
+              <a:t>Check the selected folder and file</a:t>
+            </a:r>
+          </a:p>
+          <a:p xmlns:a="http://schemas.openxmlformats.org/drawingml/2006/main">
+            <a:pPr>
+              <a:defRPr sz="1950" b="0">
+                <a:solidFill>
+                  <a:srgbClr val="283A39"/>
+                </a:solidFill>
+                <a:latin typeface="Arial"/>
+                <a:ea typeface="Arial"/>
+                <a:cs typeface="Arial"/>
+              </a:defRPr>
+            </a:pPr>
+            <a:r>
+              <a:rPr sz="1950" b="0">
+                <a:solidFill>
+                  <a:srgbClr val="283A39"/>
+                </a:solidFill>
+                <a:latin typeface="Arial"/>
+                <a:ea typeface="Arial"/>
+                <a:cs typeface="Arial"/>
+              </a:rPr>
+              <a:t>permissions. Approve the specific</a:t>
+            </a:r>
+          </a:p>
+          <a:p xmlns:a="http://schemas.openxmlformats.org/drawingml/2006/main">
+            <a:pPr>
+              <a:defRPr sz="1950" b="0">
+                <a:solidFill>
+                  <a:srgbClr val="283A39"/>
+                </a:solidFill>
+                <a:latin typeface="Arial"/>
+                <a:ea typeface="Arial"/>
+                <a:cs typeface="Arial"/>
+              </a:defRPr>
+            </a:pPr>
+            <a:r>
+              <a:rPr sz="1950" b="0">
+                <a:solidFill>
+                  <a:srgbClr val="283A39"/>
+                </a:solidFill>
+                <a:latin typeface="Arial"/>
+                <a:ea typeface="Arial"/>
+                <a:cs typeface="Arial"/>
+              </a:rPr>
+              <a:t>access request if you want it to proceed.</a:t>
+            </a:r>
+          </a:p>
+        </p:txBody>
+      </p:sp>
+      <p:sp>
+        <p:nvSpPr>
+          <p:cNvPr id="7" name="">
+            <a:extLst xmlns:a="http://schemas.openxmlformats.org/drawingml/2006/main">
+              <a:ext uri="{FF2B5EF4-FFF2-40B4-BE49-F238E27FC236}">
+                <a16:creationId xmlns:a16="http://schemas.microsoft.com/office/drawing/2014/main" id="{6A7B1D8D-6B38-4DEB-AB26-A87799949786}"/>
+              </a:ext>
+            </a:extLst>
+          </p:cNvPr>
+          <p:cNvSpPr>
+            <a:spLocks xmlns:a="http://schemas.openxmlformats.org/drawingml/2006/main" noGrp="1"/>
+          </p:cNvSpPr>
+          <p:nvPr/>
+        </p:nvSpPr>
+        <p:spPr>
+          <a:xfrm xmlns:a="http://schemas.openxmlformats.org/drawingml/2006/main">
+            <a:off x="609600" y="3810000"/>
+            <a:ext cx="10953750" cy="457200"/>
+          </a:xfrm>
+          <a:prstGeom xmlns:a="http://schemas.openxmlformats.org/drawingml/2006/main" prst="rect">
+            <a:avLst/>
+          </a:prstGeom>
+          <a:noFill xmlns:a="http://schemas.openxmlformats.org/drawingml/2006/main"/>
+          <a:ln xmlns:a="http://schemas.openxmlformats.org/drawingml/2006/main" w="0">
+            <a:noFill/>
+          </a:ln>
+        </p:spPr>
+        <p:txBody>
+          <a:bodyPr xmlns:a="http://schemas.openxmlformats.org/drawingml/2006/main">
+            <a:noAutofit/>
+          </a:bodyPr>
+          <a:lstStyle xmlns:a="http://schemas.openxmlformats.org/drawingml/2006/main"/>
+          <a:p xmlns:a="http://schemas.openxmlformats.org/drawingml/2006/main">
+            <a:pPr>
+              <a:defRPr sz="2325" b="1">
+                <a:solidFill>
+                  <a:srgbClr val="183F3B"/>
+                </a:solidFill>
+                <a:latin typeface="Arial"/>
+                <a:ea typeface="Arial"/>
+                <a:cs typeface="Arial"/>
+              </a:defRPr>
+            </a:pPr>
+            <a:r>
+              <a:rPr sz="2325" b="1">
+                <a:solidFill>
+                  <a:srgbClr val="183F3B"/>
+                </a:solidFill>
+                <a:latin typeface="Arial"/>
+                <a:ea typeface="Arial"/>
+                <a:cs typeface="Arial"/>
+              </a:rPr>
+              <a:t>New chat cannot find your records?</a:t>
+            </a:r>
+          </a:p>
+        </p:txBody>
+      </p:sp>
+      <p:sp>
+        <p:nvSpPr>
+          <p:cNvPr id="8" name="">
+            <a:extLst xmlns:a="http://schemas.openxmlformats.org/drawingml/2006/main">
+              <a:ext uri="{FF2B5EF4-FFF2-40B4-BE49-F238E27FC236}">
+                <a16:creationId xmlns:a16="http://schemas.microsoft.com/office/drawing/2014/main" id="{E8D1887B-1C6F-442B-9B7B-DDE8543A61B7}"/>
+              </a:ext>
+            </a:extLst>
+          </p:cNvPr>
+          <p:cNvSpPr>
+            <a:spLocks xmlns:a="http://schemas.openxmlformats.org/drawingml/2006/main" noGrp="1"/>
+          </p:cNvSpPr>
+          <p:nvPr/>
+        </p:nvSpPr>
+        <p:spPr>
+          <a:xfrm xmlns:a="http://schemas.openxmlformats.org/drawingml/2006/main">
+            <a:off x="609600" y="4400550"/>
+            <a:ext cx="10906125" cy="952500"/>
+          </a:xfrm>
+          <a:prstGeom xmlns:a="http://schemas.openxmlformats.org/drawingml/2006/main" prst="rect">
+            <a:avLst/>
+          </a:prstGeom>
+          <a:noFill xmlns:a="http://schemas.openxmlformats.org/drawingml/2006/main"/>
+          <a:ln xmlns:a="http://schemas.openxmlformats.org/drawingml/2006/main" w="0">
+            <a:noFill/>
+          </a:ln>
+        </p:spPr>
+        <p:txBody>
+          <a:bodyPr xmlns:a="http://schemas.openxmlformats.org/drawingml/2006/main">
+            <a:noAutofit/>
+          </a:bodyPr>
+          <a:lstStyle xmlns:a="http://schemas.openxmlformats.org/drawingml/2006/main"/>
+          <a:p xmlns:a="http://schemas.openxmlformats.org/drawingml/2006/main">
+            <a:pPr>
+              <a:defRPr sz="2100" b="0">
+                <a:solidFill>
+                  <a:srgbClr val="283A39"/>
+                </a:solidFill>
+                <a:latin typeface="Arial"/>
+                <a:ea typeface="Arial"/>
+                <a:cs typeface="Arial"/>
+              </a:defRPr>
+            </a:pPr>
+            <a:r>
+              <a:rPr sz="2100" b="0">
+                <a:solidFill>
+                  <a:srgbClr val="283A39"/>
+                </a:solidFill>
+                <a:latin typeface="Arial"/>
+                <a:ea typeface="Arial"/>
+                <a:cs typeface="Arial"/>
+              </a:rPr>
+              <a:t>Provide the private records location the AI gave you. Say:</a:t>
+            </a:r>
+          </a:p>
+          <a:p xmlns:a="http://schemas.openxmlformats.org/drawingml/2006/main">
+            <a:pPr>
+              <a:defRPr sz="2100" b="0">
+                <a:solidFill>
+                  <a:srgbClr val="283A39"/>
+                </a:solidFill>
+                <a:latin typeface="Arial"/>
+                <a:ea typeface="Arial"/>
+                <a:cs typeface="Arial"/>
+              </a:defRPr>
+            </a:pPr>
+            <a:r>
+              <a:rPr sz="2100" b="0">
+                <a:solidFill>
+                  <a:srgbClr val="283A39"/>
+                </a:solidFill>
+                <a:latin typeface="Arial"/>
+                <a:ea typeface="Arial"/>
+                <a:cs typeface="Arial"/>
+              </a:rPr>
+              <a:t>“Resume my existing search here; do not start over.”</a:t>
+            </a:r>
+          </a:p>
+        </p:txBody>
+      </p:sp>
+      <p:sp>
+        <p:nvSpPr>
+          <p:cNvPr id="9" name="">
+            <a:extLst xmlns:a="http://schemas.openxmlformats.org/drawingml/2006/main">
+              <a:ext uri="{FF2B5EF4-FFF2-40B4-BE49-F238E27FC236}">
+                <a16:creationId xmlns:a16="http://schemas.microsoft.com/office/drawing/2014/main" id="{A54622EF-DAA1-4454-969C-9C085B973208}"/>
+              </a:ext>
+            </a:extLst>
+          </p:cNvPr>
+          <p:cNvSpPr>
+            <a:spLocks xmlns:a="http://schemas.openxmlformats.org/drawingml/2006/main" noGrp="1"/>
+          </p:cNvSpPr>
+          <p:nvPr/>
+        </p:nvSpPr>
+        <p:spPr>
+          <a:xfrm xmlns:a="http://schemas.openxmlformats.org/drawingml/2006/main">
+            <a:off x="609600" y="5810250"/>
+            <a:ext cx="9810750" cy="361950"/>
+          </a:xfrm>
+          <a:prstGeom xmlns:a="http://schemas.openxmlformats.org/drawingml/2006/main" prst="rect">
+            <a:avLst/>
+          </a:prstGeom>
+          <a:noFill xmlns:a="http://schemas.openxmlformats.org/drawingml/2006/main"/>
+          <a:ln xmlns:a="http://schemas.openxmlformats.org/drawingml/2006/main" w="0">
+            <a:noFill/>
+          </a:ln>
+        </p:spPr>
+        <p:txBody>
+          <a:bodyPr xmlns:a="http://schemas.openxmlformats.org/drawingml/2006/main">
+            <a:noAutofit/>
+          </a:bodyPr>
+          <a:lstStyle xmlns:a="http://schemas.openxmlformats.org/drawingml/2006/main"/>
+          <a:p xmlns:a="http://schemas.openxmlformats.org/drawingml/2006/main">
+            <a:pPr>
+              <a:defRPr sz="1875" b="0">
+                <a:solidFill>
+                  <a:srgbClr val="087F73"/>
+                </a:solidFill>
+                <a:latin typeface="Arial"/>
+                <a:ea typeface="Arial"/>
+                <a:cs typeface="Arial"/>
+              </a:defRPr>
+            </a:pPr>
+            <a:r>
+              <a:rPr sz="1875" b="0">
+                <a:solidFill>
+                  <a:srgbClr val="087F73"/>
+                </a:solidFill>
+                <a:latin typeface="Arial"/>
+                <a:ea typeface="Arial"/>
+                <a:cs typeface="Arial"/>
+                <a:hlinkClick xmlns:r="http://schemas.openxmlformats.org/officeDocument/2006/relationships" r:id="R99fde2fc3ec64486"/>
+              </a:rPr>
+              <a:t>Full guide, downloads and troubleshooting</a:t>
+            </a:r>
+          </a:p>
+        </p:txBody>
+      </p:sp>
+    </p:spTree>
+    <p:extLst>
+      <p:ext uri="{BB962C8B-B14F-4D97-AF65-F5344CB8AC3E}">
+        <p14:creationId xmlns:p14="http://schemas.microsoft.com/office/powerpoint/2010/main" val="1512898486"/>
       </p:ext>
     </p:extLst>
   </p:cSld>
@@ -3714,7 +4354,7 @@
           <p:cNvPr id="13" name="">
             <a:extLst xmlns:a="http://schemas.openxmlformats.org/drawingml/2006/main">
               <a:ext uri="{FF2B5EF4-FFF2-40B4-BE49-F238E27FC236}">
-                <a16:creationId xmlns:a16="http://schemas.microsoft.com/office/drawing/2014/main" id="{FA1A5B35-9845-4F1D-9126-DD31E0D85E7F}"/>
+                <a16:creationId xmlns:a16="http://schemas.microsoft.com/office/drawing/2014/main" id="{FFF71075-4A09-49C1-A685-9A57C44BEDB7}"/>
               </a:ext>
             </a:extLst>
           </p:cNvPr>
@@ -3761,7 +4401,7 @@
                 <a:ea typeface="Arial"/>
                 <a:cs typeface="Arial"/>
               </a:rPr>
-              <a:t>Before you begin</a:t>
+              <a:t>1. Open your AI app</a:t>
             </a:r>
           </a:p>
         </p:txBody>
@@ -3771,7 +4411,7 @@
           <p:cNvPr id="2" name="">
             <a:extLst xmlns:a="http://schemas.openxmlformats.org/drawingml/2006/main">
               <a:ext uri="{FF2B5EF4-FFF2-40B4-BE49-F238E27FC236}">
-                <a16:creationId xmlns:a16="http://schemas.microsoft.com/office/drawing/2014/main" id="{943D6EED-2BF3-4FB6-8385-17EFAB2BAEFE}"/>
+                <a16:creationId xmlns:a16="http://schemas.microsoft.com/office/drawing/2014/main" id="{AAEAF727-E532-4728-B4DC-7667BB2E72B3}"/>
               </a:ext>
             </a:extLst>
           </p:cNvPr>
@@ -3828,7 +4468,7 @@
           <p:cNvPr id="3" name="">
             <a:extLst xmlns:a="http://schemas.openxmlformats.org/drawingml/2006/main">
               <a:ext uri="{FF2B5EF4-FFF2-40B4-BE49-F238E27FC236}">
-                <a16:creationId xmlns:a16="http://schemas.microsoft.com/office/drawing/2014/main" id="{49738F20-FE95-4DA7-B7A4-1C63D02807A9}"/>
+                <a16:creationId xmlns:a16="http://schemas.microsoft.com/office/drawing/2014/main" id="{67E58CF2-91D8-44A3-B0DB-01E4E5877A60}"/>
               </a:ext>
             </a:extLst>
           </p:cNvPr>
@@ -3885,7 +4525,7 @@
           <p:cNvPr id="4" name="">
             <a:extLst xmlns:a="http://schemas.openxmlformats.org/drawingml/2006/main">
               <a:ext uri="{FF2B5EF4-FFF2-40B4-BE49-F238E27FC236}">
-                <a16:creationId xmlns:a16="http://schemas.microsoft.com/office/drawing/2014/main" id="{41EBB51E-606E-4CB2-B4F8-F4CBBF46A679}"/>
+                <a16:creationId xmlns:a16="http://schemas.microsoft.com/office/drawing/2014/main" id="{651080E2-B2C1-4B8A-B3FD-0E99C7121D88}"/>
               </a:ext>
             </a:extLst>
           </p:cNvPr>
@@ -3942,7 +4582,7 @@
           <p:cNvPr id="5" name="">
             <a:extLst xmlns:a="http://schemas.openxmlformats.org/drawingml/2006/main">
               <a:ext uri="{FF2B5EF4-FFF2-40B4-BE49-F238E27FC236}">
-                <a16:creationId xmlns:a16="http://schemas.microsoft.com/office/drawing/2014/main" id="{6359B14A-1893-411F-B037-E723FF962014}"/>
+                <a16:creationId xmlns:a16="http://schemas.microsoft.com/office/drawing/2014/main" id="{81B02793-9EEB-42B0-A01C-812B179DD2D1}"/>
               </a:ext>
             </a:extLst>
           </p:cNvPr>
@@ -4022,7 +4662,7 @@
           <p:cNvPr id="6" name="">
             <a:extLst xmlns:a="http://schemas.openxmlformats.org/drawingml/2006/main">
               <a:ext uri="{FF2B5EF4-FFF2-40B4-BE49-F238E27FC236}">
-                <a16:creationId xmlns:a16="http://schemas.microsoft.com/office/drawing/2014/main" id="{6456F64A-207D-4E26-ABD5-55CE0837BD63}"/>
+                <a16:creationId xmlns:a16="http://schemas.microsoft.com/office/drawing/2014/main" id="{D5AC606F-BA5D-4575-9EDC-924D82B5E3F5}"/>
               </a:ext>
             </a:extLst>
           </p:cNvPr>
@@ -4068,7 +4708,7 @@
                 <a:latin typeface="Arial"/>
                 <a:ea typeface="Arial"/>
                 <a:cs typeface="Arial"/>
-                <a:hlinkClick xmlns:r="http://schemas.openxmlformats.org/officeDocument/2006/relationships" r:id="Re2deeac3aa6e443b"/>
+                <a:hlinkClick xmlns:r="http://schemas.openxmlformats.org/officeDocument/2006/relationships" r:id="Racc1165f5d9840aa"/>
               </a:rPr>
               <a:t>Mac download page (Apple Silicon)</a:t>
             </a:r>
@@ -4080,7 +4720,7 @@
           <p:cNvPr id="7" name="">
             <a:extLst xmlns:a="http://schemas.openxmlformats.org/drawingml/2006/main">
               <a:ext uri="{FF2B5EF4-FFF2-40B4-BE49-F238E27FC236}">
-                <a16:creationId xmlns:a16="http://schemas.microsoft.com/office/drawing/2014/main" id="{073D013A-24C9-4908-9013-7E173708F9FD}"/>
+                <a16:creationId xmlns:a16="http://schemas.microsoft.com/office/drawing/2014/main" id="{1566D904-3535-4982-882E-0A8D0F471261}"/>
               </a:ext>
             </a:extLst>
           </p:cNvPr>
@@ -4126,7 +4766,7 @@
                 <a:latin typeface="Arial"/>
                 <a:ea typeface="Arial"/>
                 <a:cs typeface="Arial"/>
-                <a:hlinkClick xmlns:r="http://schemas.openxmlformats.org/officeDocument/2006/relationships" r:id="Rd8fe176086a34ae1"/>
+                <a:hlinkClick xmlns:r="http://schemas.openxmlformats.org/officeDocument/2006/relationships" r:id="R0f5522e043de462d"/>
               </a:rPr>
               <a:t>Windows download page</a:t>
             </a:r>
@@ -4138,7 +4778,7 @@
           <p:cNvPr id="8" name="">
             <a:extLst xmlns:a="http://schemas.openxmlformats.org/drawingml/2006/main">
               <a:ext uri="{FF2B5EF4-FFF2-40B4-BE49-F238E27FC236}">
-                <a16:creationId xmlns:a16="http://schemas.microsoft.com/office/drawing/2014/main" id="{0A51F6EB-476A-4726-9512-DDFB6D818DC7}"/>
+                <a16:creationId xmlns:a16="http://schemas.microsoft.com/office/drawing/2014/main" id="{5443140E-5387-41E4-B848-3AF40EF484EF}"/>
               </a:ext>
             </a:extLst>
           </p:cNvPr>
@@ -4195,7 +4835,7 @@
           <p:cNvPr id="9" name="">
             <a:extLst xmlns:a="http://schemas.openxmlformats.org/drawingml/2006/main">
               <a:ext uri="{FF2B5EF4-FFF2-40B4-BE49-F238E27FC236}">
-                <a16:creationId xmlns:a16="http://schemas.microsoft.com/office/drawing/2014/main" id="{1B5AD74B-FBD8-4D38-8CCA-1E40DCA21D48}"/>
+                <a16:creationId xmlns:a16="http://schemas.microsoft.com/office/drawing/2014/main" id="{3368408F-9CF7-43AC-9A95-840DBAD2E71F}"/>
               </a:ext>
             </a:extLst>
           </p:cNvPr>
@@ -4275,7 +4915,7 @@
           <p:cNvPr id="10" name="">
             <a:extLst xmlns:a="http://schemas.openxmlformats.org/drawingml/2006/main">
               <a:ext uri="{FF2B5EF4-FFF2-40B4-BE49-F238E27FC236}">
-                <a16:creationId xmlns:a16="http://schemas.microsoft.com/office/drawing/2014/main" id="{42C785D1-485B-4E0D-AEBE-7BE9FCA32AFD}"/>
+                <a16:creationId xmlns:a16="http://schemas.microsoft.com/office/drawing/2014/main" id="{50570C37-6F93-4291-8761-049755246CC8}"/>
               </a:ext>
             </a:extLst>
           </p:cNvPr>
@@ -4321,7 +4961,7 @@
                 <a:latin typeface="Arial"/>
                 <a:ea typeface="Arial"/>
                 <a:cs typeface="Arial"/>
-                <a:hlinkClick xmlns:r="http://schemas.openxmlformats.org/officeDocument/2006/relationships" r:id="R3032b6254e33481e"/>
+                <a:hlinkClick xmlns:r="http://schemas.openxmlformats.org/officeDocument/2006/relationships" r:id="R0466d1e8addb4b10"/>
               </a:rPr>
               <a:t>Mac or Windows downloads</a:t>
             </a:r>
@@ -4333,7 +4973,7 @@
           <p:cNvPr id="11" name="">
             <a:extLst xmlns:a="http://schemas.openxmlformats.org/drawingml/2006/main">
               <a:ext uri="{FF2B5EF4-FFF2-40B4-BE49-F238E27FC236}">
-                <a16:creationId xmlns:a16="http://schemas.microsoft.com/office/drawing/2014/main" id="{AEBD717E-E2FF-465A-A12E-4DBD434E44C3}"/>
+                <a16:creationId xmlns:a16="http://schemas.microsoft.com/office/drawing/2014/main" id="{BEBE1DCB-1F7A-436A-B53F-0764E681B60F}"/>
               </a:ext>
             </a:extLst>
           </p:cNvPr>
@@ -4379,7 +5019,7 @@
                 <a:latin typeface="Arial"/>
                 <a:ea typeface="Arial"/>
                 <a:cs typeface="Arial"/>
-                <a:hlinkClick xmlns:r="http://schemas.openxmlformats.org/officeDocument/2006/relationships" r:id="Rcff9d67eed2a4f54"/>
+                <a:hlinkClick xmlns:r="http://schemas.openxmlformats.org/officeDocument/2006/relationships" r:id="R9d84cc246aba45a4"/>
               </a:rPr>
               <a:t>Claude Code setup and account requirements</a:t>
             </a:r>
@@ -4391,7 +5031,7 @@
           <p:cNvPr id="12" name="">
             <a:extLst xmlns:a="http://schemas.openxmlformats.org/drawingml/2006/main">
               <a:ext uri="{FF2B5EF4-FFF2-40B4-BE49-F238E27FC236}">
-                <a16:creationId xmlns:a16="http://schemas.microsoft.com/office/drawing/2014/main" id="{87B14738-5306-4875-A9A9-A6B845C50AC4}"/>
+                <a16:creationId xmlns:a16="http://schemas.microsoft.com/office/drawing/2014/main" id="{D5FC47EB-9697-4D71-B870-2259DBFBF2EA}"/>
               </a:ext>
             </a:extLst>
           </p:cNvPr>
@@ -4446,7 +5086,7 @@
     </p:spTree>
     <p:extLst>
       <p:ext uri="{BB962C8B-B14F-4D97-AF65-F5344CB8AC3E}">
-        <p14:creationId xmlns:p14="http://schemas.microsoft.com/office/powerpoint/2010/main" val="2085387622"/>
+        <p14:creationId xmlns:p14="http://schemas.microsoft.com/office/powerpoint/2010/main" val="279872602"/>
       </p:ext>
     </p:extLst>
   </p:cSld>
@@ -4477,7 +5117,7 @@
           <p:cNvPr id="6" name="">
             <a:extLst xmlns:a="http://schemas.openxmlformats.org/drawingml/2006/main">
               <a:ext uri="{FF2B5EF4-FFF2-40B4-BE49-F238E27FC236}">
-                <a16:creationId xmlns:a16="http://schemas.microsoft.com/office/drawing/2014/main" id="{C1E477C7-A35A-43D6-BAAE-4D8677C4BFE5}"/>
+                <a16:creationId xmlns:a16="http://schemas.microsoft.com/office/drawing/2014/main" id="{A98DB71F-C324-4273-82FE-A2F0EC4254E6}"/>
               </a:ext>
             </a:extLst>
           </p:cNvPr>
@@ -4524,7 +5164,7 @@
                 <a:ea typeface="Arial"/>
                 <a:cs typeface="Arial"/>
               </a:rPr>
-              <a:t>1. Your local project</a:t>
+              <a:t>a. Choose your project</a:t>
             </a:r>
           </a:p>
         </p:txBody>
@@ -4534,7 +5174,7 @@
           <p:cNvPr id="2" name="">
             <a:extLst xmlns:a="http://schemas.openxmlformats.org/drawingml/2006/main">
               <a:ext uri="{FF2B5EF4-FFF2-40B4-BE49-F238E27FC236}">
-                <a16:creationId xmlns:a16="http://schemas.microsoft.com/office/drawing/2014/main" id="{8DBE66EB-A5A8-435F-867C-A885119DE1F6}"/>
+                <a16:creationId xmlns:a16="http://schemas.microsoft.com/office/drawing/2014/main" id="{4B05B4BF-9432-4CF9-AB86-15B8930F5F18}"/>
               </a:ext>
             </a:extLst>
           </p:cNvPr>
@@ -4591,7 +5231,7 @@
           <p:cNvPr id="3" name="">
             <a:extLst xmlns:a="http://schemas.openxmlformats.org/drawingml/2006/main">
               <a:ext uri="{FF2B5EF4-FFF2-40B4-BE49-F238E27FC236}">
-                <a16:creationId xmlns:a16="http://schemas.microsoft.com/office/drawing/2014/main" id="{9287D3D0-B33F-4AFE-A444-3E17250B77FB}"/>
+                <a16:creationId xmlns:a16="http://schemas.microsoft.com/office/drawing/2014/main" id="{9A6F7B19-AD89-438C-849A-34286F87D159}"/>
               </a:ext>
             </a:extLst>
           </p:cNvPr>
@@ -4652,7 +5292,7 @@
           <p:nvPr/>
         </p:nvPicPr>
         <p:blipFill>
-          <a:blip xmlns:r="http://schemas.openxmlformats.org/officeDocument/2006/relationships" xmlns:a="http://schemas.openxmlformats.org/drawingml/2006/main" r:embed="R9cd37d1804854025"/>
+          <a:blip xmlns:r="http://schemas.openxmlformats.org/officeDocument/2006/relationships" xmlns:a="http://schemas.openxmlformats.org/drawingml/2006/main" r:embed="Rb71c2398fda14031"/>
           <a:stretch xmlns:a="http://schemas.openxmlformats.org/drawingml/2006/main"/>
         </p:blipFill>
         <p:spPr>
@@ -4670,7 +5310,7 @@
           <p:cNvPr id="5" name="">
             <a:extLst xmlns:a="http://schemas.openxmlformats.org/drawingml/2006/main">
               <a:ext uri="{FF2B5EF4-FFF2-40B4-BE49-F238E27FC236}">
-                <a16:creationId xmlns:a16="http://schemas.microsoft.com/office/drawing/2014/main" id="{27E1D591-CDAD-4D78-A7EF-844EDFD16D69}"/>
+                <a16:creationId xmlns:a16="http://schemas.microsoft.com/office/drawing/2014/main" id="{7C9C43B4-3FF1-4FC2-8DDF-2643D9ADB203}"/>
               </a:ext>
             </a:extLst>
           </p:cNvPr>
@@ -4748,7 +5388,7 @@
     </p:spTree>
     <p:extLst>
       <p:ext uri="{BB962C8B-B14F-4D97-AF65-F5344CB8AC3E}">
-        <p14:creationId xmlns:p14="http://schemas.microsoft.com/office/powerpoint/2010/main" val="1976562936"/>
+        <p14:creationId xmlns:p14="http://schemas.microsoft.com/office/powerpoint/2010/main" val="899392404"/>
       </p:ext>
     </p:extLst>
   </p:cSld>
@@ -4779,7 +5419,7 @@
           <p:cNvPr id="8" name="">
             <a:extLst xmlns:a="http://schemas.openxmlformats.org/drawingml/2006/main">
               <a:ext uri="{FF2B5EF4-FFF2-40B4-BE49-F238E27FC236}">
-                <a16:creationId xmlns:a16="http://schemas.microsoft.com/office/drawing/2014/main" id="{B62D4190-CF08-43C5-97A2-7EBABD1ED2C0}"/>
+                <a16:creationId xmlns:a16="http://schemas.microsoft.com/office/drawing/2014/main" id="{1C9E6CEC-B97E-4482-8654-0B1AFAB1DB8A}"/>
               </a:ext>
             </a:extLst>
           </p:cNvPr>
@@ -4826,7 +5466,7 @@
                 <a:ea typeface="Arial"/>
                 <a:cs typeface="Arial"/>
               </a:rPr>
-              <a:t>1. A folder for your search</a:t>
+              <a:t>b. Select or create your folder</a:t>
             </a:r>
           </a:p>
         </p:txBody>
@@ -4836,7 +5476,7 @@
           <p:cNvPr id="2" name="">
             <a:extLst xmlns:a="http://schemas.openxmlformats.org/drawingml/2006/main">
               <a:ext uri="{FF2B5EF4-FFF2-40B4-BE49-F238E27FC236}">
-                <a16:creationId xmlns:a16="http://schemas.microsoft.com/office/drawing/2014/main" id="{B50DF87F-4BB4-4E6D-85B0-E738E42F5904}"/>
+                <a16:creationId xmlns:a16="http://schemas.microsoft.com/office/drawing/2014/main" id="{B2AF31F8-4210-4243-B4E7-D37582DC49CF}"/>
               </a:ext>
             </a:extLst>
           </p:cNvPr>
@@ -4893,7 +5533,7 @@
           <p:cNvPr id="3" name="">
             <a:extLst xmlns:a="http://schemas.openxmlformats.org/drawingml/2006/main">
               <a:ext uri="{FF2B5EF4-FFF2-40B4-BE49-F238E27FC236}">
-                <a16:creationId xmlns:a16="http://schemas.microsoft.com/office/drawing/2014/main" id="{0EA3423B-1FC7-4AF1-ACF1-652F39EE2AEA}"/>
+                <a16:creationId xmlns:a16="http://schemas.microsoft.com/office/drawing/2014/main" id="{A3ACFF26-BD7D-4BBB-9812-4019ECA1F9CD}"/>
               </a:ext>
             </a:extLst>
           </p:cNvPr>
@@ -4950,7 +5590,7 @@
           <p:cNvPr id="4" name="">
             <a:extLst xmlns:a="http://schemas.openxmlformats.org/drawingml/2006/main">
               <a:ext uri="{FF2B5EF4-FFF2-40B4-BE49-F238E27FC236}">
-                <a16:creationId xmlns:a16="http://schemas.microsoft.com/office/drawing/2014/main" id="{92CE86F9-8A75-403E-905F-15E441F9C4F2}"/>
+                <a16:creationId xmlns:a16="http://schemas.microsoft.com/office/drawing/2014/main" id="{62535A5B-5F8E-4FF1-B633-01C732939581}"/>
               </a:ext>
             </a:extLst>
           </p:cNvPr>
@@ -5076,7 +5716,7 @@
           <p:cNvPr id="5" name="">
             <a:extLst xmlns:a="http://schemas.openxmlformats.org/drawingml/2006/main">
               <a:ext uri="{FF2B5EF4-FFF2-40B4-BE49-F238E27FC236}">
-                <a16:creationId xmlns:a16="http://schemas.microsoft.com/office/drawing/2014/main" id="{5B7262EA-404F-4823-80C1-E5B2833A0F80}"/>
+                <a16:creationId xmlns:a16="http://schemas.microsoft.com/office/drawing/2014/main" id="{E0254D8D-6547-40A2-814A-3BA05A5E3A6D}"/>
               </a:ext>
             </a:extLst>
           </p:cNvPr>
@@ -5183,7 +5823,7 @@
           <p:nvPr/>
         </p:nvPicPr>
         <p:blipFill>
-          <a:blip xmlns:r="http://schemas.openxmlformats.org/officeDocument/2006/relationships" xmlns:a="http://schemas.openxmlformats.org/drawingml/2006/main" r:embed="Rd0c47d3b039f421f"/>
+          <a:blip xmlns:r="http://schemas.openxmlformats.org/officeDocument/2006/relationships" xmlns:a="http://schemas.openxmlformats.org/drawingml/2006/main" r:embed="R73a1445dbf8e4c92"/>
           <a:stretch xmlns:a="http://schemas.openxmlformats.org/drawingml/2006/main"/>
         </p:blipFill>
         <p:spPr>
@@ -5201,7 +5841,7 @@
           <p:cNvPr id="7" name="">
             <a:extLst xmlns:a="http://schemas.openxmlformats.org/drawingml/2006/main">
               <a:ext uri="{FF2B5EF4-FFF2-40B4-BE49-F238E27FC236}">
-                <a16:creationId xmlns:a16="http://schemas.microsoft.com/office/drawing/2014/main" id="{0C1647D7-F89B-4543-A8B7-1CCFD25A5651}"/>
+                <a16:creationId xmlns:a16="http://schemas.microsoft.com/office/drawing/2014/main" id="{56BFDD46-C64E-41B5-B873-D9DEF9E9C9FC}"/>
               </a:ext>
             </a:extLst>
           </p:cNvPr>
@@ -5256,7 +5896,7 @@
     </p:spTree>
     <p:extLst>
       <p:ext uri="{BB962C8B-B14F-4D97-AF65-F5344CB8AC3E}">
-        <p14:creationId xmlns:p14="http://schemas.microsoft.com/office/powerpoint/2010/main" val="503848494"/>
+        <p14:creationId xmlns:p14="http://schemas.microsoft.com/office/powerpoint/2010/main" val="1818798225"/>
       </p:ext>
     </p:extLst>
   </p:cSld>
@@ -5287,7 +5927,7 @@
           <p:cNvPr id="6" name="">
             <a:extLst xmlns:a="http://schemas.openxmlformats.org/drawingml/2006/main">
               <a:ext uri="{FF2B5EF4-FFF2-40B4-BE49-F238E27FC236}">
-                <a16:creationId xmlns:a16="http://schemas.microsoft.com/office/drawing/2014/main" id="{38C30F16-90B0-472D-AC66-21E0FA8BD101}"/>
+                <a16:creationId xmlns:a16="http://schemas.microsoft.com/office/drawing/2014/main" id="{AEA2D538-202E-4BC8-A27C-792B95331372}"/>
               </a:ext>
             </a:extLst>
           </p:cNvPr>
@@ -5334,7 +5974,7 @@
                 <a:ea typeface="Arial"/>
                 <a:cs typeface="Arial"/>
               </a:rPr>
-              <a:t>1. Codex: Full access</a:t>
+              <a:t>c. Codex: Full access</a:t>
             </a:r>
           </a:p>
         </p:txBody>
@@ -5344,7 +5984,7 @@
           <p:cNvPr id="2" name="">
             <a:extLst xmlns:a="http://schemas.openxmlformats.org/drawingml/2006/main">
               <a:ext uri="{FF2B5EF4-FFF2-40B4-BE49-F238E27FC236}">
-                <a16:creationId xmlns:a16="http://schemas.microsoft.com/office/drawing/2014/main" id="{EE1EB67A-E094-4B3A-8031-F9F458138F5C}"/>
+                <a16:creationId xmlns:a16="http://schemas.microsoft.com/office/drawing/2014/main" id="{8C36C64F-8EE6-4136-935B-49B82E7AEC77}"/>
               </a:ext>
             </a:extLst>
           </p:cNvPr>
@@ -5401,7 +6041,7 @@
           <p:cNvPr id="3" name="">
             <a:extLst xmlns:a="http://schemas.openxmlformats.org/drawingml/2006/main">
               <a:ext uri="{FF2B5EF4-FFF2-40B4-BE49-F238E27FC236}">
-                <a16:creationId xmlns:a16="http://schemas.microsoft.com/office/drawing/2014/main" id="{F517FA9A-260A-4853-A43E-BDDC88780F39}"/>
+                <a16:creationId xmlns:a16="http://schemas.microsoft.com/office/drawing/2014/main" id="{1125432F-C4E0-4345-910A-2646062EB129}"/>
               </a:ext>
             </a:extLst>
           </p:cNvPr>
@@ -5485,7 +6125,7 @@
           <p:nvPr/>
         </p:nvPicPr>
         <p:blipFill>
-          <a:blip xmlns:r="http://schemas.openxmlformats.org/officeDocument/2006/relationships" xmlns:a="http://schemas.openxmlformats.org/drawingml/2006/main" r:embed="Rd5fe6c7e275e4fc2"/>
+          <a:blip xmlns:r="http://schemas.openxmlformats.org/officeDocument/2006/relationships" xmlns:a="http://schemas.openxmlformats.org/drawingml/2006/main" r:embed="Rd1387e4ccfcc4d72"/>
           <a:stretch xmlns:a="http://schemas.openxmlformats.org/drawingml/2006/main"/>
         </p:blipFill>
         <p:spPr>
@@ -5503,7 +6143,7 @@
           <p:cNvPr id="5" name="">
             <a:extLst xmlns:a="http://schemas.openxmlformats.org/drawingml/2006/main">
               <a:ext uri="{FF2B5EF4-FFF2-40B4-BE49-F238E27FC236}">
-                <a16:creationId xmlns:a16="http://schemas.microsoft.com/office/drawing/2014/main" id="{C8EF5924-E5B6-4C50-951D-623C7D0E52E0}"/>
+                <a16:creationId xmlns:a16="http://schemas.microsoft.com/office/drawing/2014/main" id="{11BC7A75-EFD6-40CA-AE7F-304A1DC3E3BE}"/>
               </a:ext>
             </a:extLst>
           </p:cNvPr>
@@ -5581,7 +6221,7 @@
     </p:spTree>
     <p:extLst>
       <p:ext uri="{BB962C8B-B14F-4D97-AF65-F5344CB8AC3E}">
-        <p14:creationId xmlns:p14="http://schemas.microsoft.com/office/powerpoint/2010/main" val="60857296"/>
+        <p14:creationId xmlns:p14="http://schemas.microsoft.com/office/powerpoint/2010/main" val="1368155152"/>
       </p:ext>
     </p:extLst>
   </p:cSld>
@@ -5612,7 +6252,7 @@
           <p:cNvPr id="6" name="">
             <a:extLst xmlns:a="http://schemas.openxmlformats.org/drawingml/2006/main">
               <a:ext uri="{FF2B5EF4-FFF2-40B4-BE49-F238E27FC236}">
-                <a16:creationId xmlns:a16="http://schemas.microsoft.com/office/drawing/2014/main" id="{49C52A71-A5FE-404F-B48E-FF80AAFDA165}"/>
+                <a16:creationId xmlns:a16="http://schemas.microsoft.com/office/drawing/2014/main" id="{84DB0E5B-7548-46F6-9D72-B588F6894C6F}"/>
               </a:ext>
             </a:extLst>
           </p:cNvPr>
@@ -5659,7 +6299,7 @@
                 <a:ea typeface="Arial"/>
                 <a:cs typeface="Arial"/>
               </a:rPr>
-              <a:t>1. Claude Code: Auto</a:t>
+              <a:t>d. Claude Code: Auto</a:t>
             </a:r>
           </a:p>
         </p:txBody>
@@ -5669,7 +6309,7 @@
           <p:cNvPr id="2" name="">
             <a:extLst xmlns:a="http://schemas.openxmlformats.org/drawingml/2006/main">
               <a:ext uri="{FF2B5EF4-FFF2-40B4-BE49-F238E27FC236}">
-                <a16:creationId xmlns:a16="http://schemas.microsoft.com/office/drawing/2014/main" id="{25118A3D-352D-4D6C-9A03-7F82DD0BBFC4}"/>
+                <a16:creationId xmlns:a16="http://schemas.microsoft.com/office/drawing/2014/main" id="{C88B1C40-AFEB-4A9A-82DD-735F22C1B62D}"/>
               </a:ext>
             </a:extLst>
           </p:cNvPr>
@@ -5726,7 +6366,7 @@
           <p:cNvPr id="3" name="">
             <a:extLst xmlns:a="http://schemas.openxmlformats.org/drawingml/2006/main">
               <a:ext uri="{FF2B5EF4-FFF2-40B4-BE49-F238E27FC236}">
-                <a16:creationId xmlns:a16="http://schemas.microsoft.com/office/drawing/2014/main" id="{30E5398F-769D-4DD1-BCC4-D00C885B531C}"/>
+                <a16:creationId xmlns:a16="http://schemas.microsoft.com/office/drawing/2014/main" id="{38512D05-CBFE-4FB8-8746-1966A6982282}"/>
               </a:ext>
             </a:extLst>
           </p:cNvPr>
@@ -5787,7 +6427,7 @@
           <p:nvPr/>
         </p:nvPicPr>
         <p:blipFill>
-          <a:blip xmlns:r="http://schemas.openxmlformats.org/officeDocument/2006/relationships" xmlns:a="http://schemas.openxmlformats.org/drawingml/2006/main" r:embed="R6e31c458a3cc4a6b"/>
+          <a:blip xmlns:r="http://schemas.openxmlformats.org/officeDocument/2006/relationships" xmlns:a="http://schemas.openxmlformats.org/drawingml/2006/main" r:embed="R8f8160ddc45248f9"/>
           <a:stretch xmlns:a="http://schemas.openxmlformats.org/drawingml/2006/main"/>
         </p:blipFill>
         <p:spPr>
@@ -5805,7 +6445,7 @@
           <p:cNvPr id="5" name="">
             <a:extLst xmlns:a="http://schemas.openxmlformats.org/drawingml/2006/main">
               <a:ext uri="{FF2B5EF4-FFF2-40B4-BE49-F238E27FC236}">
-                <a16:creationId xmlns:a16="http://schemas.microsoft.com/office/drawing/2014/main" id="{7BAFA447-E449-4C96-984D-B994008A41E5}"/>
+                <a16:creationId xmlns:a16="http://schemas.microsoft.com/office/drawing/2014/main" id="{F2F452F7-AACB-4DB3-85B7-3C294F389C7E}"/>
               </a:ext>
             </a:extLst>
           </p:cNvPr>
@@ -5883,7 +6523,7 @@
     </p:spTree>
     <p:extLst>
       <p:ext uri="{BB962C8B-B14F-4D97-AF65-F5344CB8AC3E}">
-        <p14:creationId xmlns:p14="http://schemas.microsoft.com/office/powerpoint/2010/main" val="469894403"/>
+        <p14:creationId xmlns:p14="http://schemas.microsoft.com/office/powerpoint/2010/main" val="1484708298"/>
       </p:ext>
     </p:extLst>
   </p:cSld>
@@ -5914,7 +6554,7 @@
           <p:cNvPr id="8" name="">
             <a:extLst xmlns:a="http://schemas.openxmlformats.org/drawingml/2006/main">
               <a:ext uri="{FF2B5EF4-FFF2-40B4-BE49-F238E27FC236}">
-                <a16:creationId xmlns:a16="http://schemas.microsoft.com/office/drawing/2014/main" id="{94FDED7C-9F5E-4541-B9E0-A1FE979D4586}"/>
+                <a16:creationId xmlns:a16="http://schemas.microsoft.com/office/drawing/2014/main" id="{18F59F86-41E3-43FB-AD1B-AB1EA8C0450D}"/>
               </a:ext>
             </a:extLst>
           </p:cNvPr>
@@ -5971,7 +6611,7 @@
           <p:cNvPr id="2" name="">
             <a:extLst xmlns:a="http://schemas.openxmlformats.org/drawingml/2006/main">
               <a:ext uri="{FF2B5EF4-FFF2-40B4-BE49-F238E27FC236}">
-                <a16:creationId xmlns:a16="http://schemas.microsoft.com/office/drawing/2014/main" id="{2A8BD5DA-19B8-4AAB-8C47-996D00447431}"/>
+                <a16:creationId xmlns:a16="http://schemas.microsoft.com/office/drawing/2014/main" id="{3231FDA9-5B8B-48A7-80F7-39542F23F26A}"/>
               </a:ext>
             </a:extLst>
           </p:cNvPr>
@@ -6028,7 +6668,7 @@
           <p:cNvPr id="3" name="">
             <a:extLst xmlns:a="http://schemas.openxmlformats.org/drawingml/2006/main">
               <a:ext uri="{FF2B5EF4-FFF2-40B4-BE49-F238E27FC236}">
-                <a16:creationId xmlns:a16="http://schemas.microsoft.com/office/drawing/2014/main" id="{24C79583-9948-4C50-9182-CD089D4D69C7}"/>
+                <a16:creationId xmlns:a16="http://schemas.microsoft.com/office/drawing/2014/main" id="{A9684426-DF03-4513-92DE-C60AA7964767}"/>
               </a:ext>
             </a:extLst>
           </p:cNvPr>
@@ -6085,7 +6725,7 @@
           <p:cNvPr id="4" name="">
             <a:extLst xmlns:a="http://schemas.openxmlformats.org/drawingml/2006/main">
               <a:ext uri="{FF2B5EF4-FFF2-40B4-BE49-F238E27FC236}">
-                <a16:creationId xmlns:a16="http://schemas.microsoft.com/office/drawing/2014/main" id="{A4E918E6-73F5-4F97-B59F-5B34F1A8B31D}"/>
+                <a16:creationId xmlns:a16="http://schemas.microsoft.com/office/drawing/2014/main" id="{D835E3E4-CA89-43DB-82DA-8132BB831A8C}"/>
               </a:ext>
             </a:extLst>
           </p:cNvPr>
@@ -6165,7 +6805,7 @@
           <p:cNvPr id="5" name="">
             <a:extLst xmlns:a="http://schemas.openxmlformats.org/drawingml/2006/main">
               <a:ext uri="{FF2B5EF4-FFF2-40B4-BE49-F238E27FC236}">
-                <a16:creationId xmlns:a16="http://schemas.microsoft.com/office/drawing/2014/main" id="{692E73C0-1005-4CE2-BB67-9DB594361A86}"/>
+                <a16:creationId xmlns:a16="http://schemas.microsoft.com/office/drawing/2014/main" id="{F1BDB6BC-447A-40B5-8E82-8555C8037AF2}"/>
               </a:ext>
             </a:extLst>
           </p:cNvPr>
@@ -6222,7 +6862,7 @@
           <p:cNvPr id="6" name="">
             <a:extLst xmlns:a="http://schemas.openxmlformats.org/drawingml/2006/main">
               <a:ext uri="{FF2B5EF4-FFF2-40B4-BE49-F238E27FC236}">
-                <a16:creationId xmlns:a16="http://schemas.microsoft.com/office/drawing/2014/main" id="{6F108FEA-C193-475C-86C4-60B02624A1DB}"/>
+                <a16:creationId xmlns:a16="http://schemas.microsoft.com/office/drawing/2014/main" id="{25B0E71A-BAB6-4996-BC29-327C7AF665BD}"/>
               </a:ext>
             </a:extLst>
           </p:cNvPr>
@@ -6279,7 +6919,7 @@
           <p:cNvPr id="7" name="">
             <a:extLst xmlns:a="http://schemas.openxmlformats.org/drawingml/2006/main">
               <a:ext uri="{FF2B5EF4-FFF2-40B4-BE49-F238E27FC236}">
-                <a16:creationId xmlns:a16="http://schemas.microsoft.com/office/drawing/2014/main" id="{B24268BC-ED4A-4D53-A51E-9E48AC629A05}"/>
+                <a16:creationId xmlns:a16="http://schemas.microsoft.com/office/drawing/2014/main" id="{70F7CCE0-0A3B-442B-8F9C-64E88CB2564F}"/>
               </a:ext>
             </a:extLst>
           </p:cNvPr>
@@ -6334,7 +6974,7 @@
     </p:spTree>
     <p:extLst>
       <p:ext uri="{BB962C8B-B14F-4D97-AF65-F5344CB8AC3E}">
-        <p14:creationId xmlns:p14="http://schemas.microsoft.com/office/powerpoint/2010/main" val="302529051"/>
+        <p14:creationId xmlns:p14="http://schemas.microsoft.com/office/powerpoint/2010/main" val="862324596"/>
       </p:ext>
     </p:extLst>
   </p:cSld>
@@ -6365,7 +7005,7 @@
           <p:cNvPr id="7" name="">
             <a:extLst xmlns:a="http://schemas.openxmlformats.org/drawingml/2006/main">
               <a:ext uri="{FF2B5EF4-FFF2-40B4-BE49-F238E27FC236}">
-                <a16:creationId xmlns:a16="http://schemas.microsoft.com/office/drawing/2014/main" id="{EF94DBC4-D341-4CEF-97A8-91D66C254822}"/>
+                <a16:creationId xmlns:a16="http://schemas.microsoft.com/office/drawing/2014/main" id="{F8B82DF0-C920-49B8-9691-C57BE6A6AE28}"/>
               </a:ext>
             </a:extLst>
           </p:cNvPr>
@@ -6422,7 +7062,7 @@
           <p:cNvPr id="2" name="">
             <a:extLst xmlns:a="http://schemas.openxmlformats.org/drawingml/2006/main">
               <a:ext uri="{FF2B5EF4-FFF2-40B4-BE49-F238E27FC236}">
-                <a16:creationId xmlns:a16="http://schemas.microsoft.com/office/drawing/2014/main" id="{D8E89AFD-FB8A-4B56-BE2F-8ADF5733DB00}"/>
+                <a16:creationId xmlns:a16="http://schemas.microsoft.com/office/drawing/2014/main" id="{0200D577-C1BC-463D-887A-DD542A8ABD03}"/>
               </a:ext>
             </a:extLst>
           </p:cNvPr>
@@ -6479,7 +7119,7 @@
           <p:cNvPr id="3" name="">
             <a:extLst xmlns:a="http://schemas.openxmlformats.org/drawingml/2006/main">
               <a:ext uri="{FF2B5EF4-FFF2-40B4-BE49-F238E27FC236}">
-                <a16:creationId xmlns:a16="http://schemas.microsoft.com/office/drawing/2014/main" id="{65EDC46D-6826-41EB-9682-2EAE6AFB2C62}"/>
+                <a16:creationId xmlns:a16="http://schemas.microsoft.com/office/drawing/2014/main" id="{1593F920-C76A-4CDC-BFB9-370B646AFFAD}"/>
               </a:ext>
             </a:extLst>
           </p:cNvPr>
@@ -6536,7 +7176,7 @@
           <p:cNvPr id="4" name="">
             <a:extLst xmlns:a="http://schemas.openxmlformats.org/drawingml/2006/main">
               <a:ext uri="{FF2B5EF4-FFF2-40B4-BE49-F238E27FC236}">
-                <a16:creationId xmlns:a16="http://schemas.microsoft.com/office/drawing/2014/main" id="{B074F2FB-DBA8-4166-BCD1-C35592B1CF0F}"/>
+                <a16:creationId xmlns:a16="http://schemas.microsoft.com/office/drawing/2014/main" id="{07B69F60-906A-4208-ADF7-30060DEF9AA2}"/>
               </a:ext>
             </a:extLst>
           </p:cNvPr>
@@ -6616,7 +7256,7 @@
           <p:cNvPr id="5" name="">
             <a:extLst xmlns:a="http://schemas.openxmlformats.org/drawingml/2006/main">
               <a:ext uri="{FF2B5EF4-FFF2-40B4-BE49-F238E27FC236}">
-                <a16:creationId xmlns:a16="http://schemas.microsoft.com/office/drawing/2014/main" id="{2B617F0B-2287-4FA8-A544-1FA6AECA5DC1}"/>
+                <a16:creationId xmlns:a16="http://schemas.microsoft.com/office/drawing/2014/main" id="{E83146A7-FEF5-4552-A15D-019F364990B0}"/>
               </a:ext>
             </a:extLst>
           </p:cNvPr>
@@ -6696,7 +7336,7 @@
           <p:cNvPr id="6" name="">
             <a:extLst xmlns:a="http://schemas.openxmlformats.org/drawingml/2006/main">
               <a:ext uri="{FF2B5EF4-FFF2-40B4-BE49-F238E27FC236}">
-                <a16:creationId xmlns:a16="http://schemas.microsoft.com/office/drawing/2014/main" id="{89CAD7C0-EA1C-4F5C-9A42-64667240CF76}"/>
+                <a16:creationId xmlns:a16="http://schemas.microsoft.com/office/drawing/2014/main" id="{0746BF55-6622-49D0-8701-BDFD57BCA851}"/>
               </a:ext>
             </a:extLst>
           </p:cNvPr>
@@ -6742,7 +7382,7 @@
                 <a:latin typeface="Arial"/>
                 <a:ea typeface="Arial"/>
                 <a:cs typeface="Arial"/>
-                <a:hlinkClick xmlns:r="http://schemas.openxmlformats.org/officeDocument/2006/relationships" r:id="Rdecd1c4081a64b97"/>
+                <a:hlinkClick xmlns:r="http://schemas.openxmlformats.org/officeDocument/2006/relationships" r:id="Re9a06c9c38f24d36"/>
               </a:rPr>
               <a:t>Copy from the README</a:t>
             </a:r>
@@ -6752,7 +7392,7 @@
     </p:spTree>
     <p:extLst>
       <p:ext uri="{BB962C8B-B14F-4D97-AF65-F5344CB8AC3E}">
-        <p14:creationId xmlns:p14="http://schemas.microsoft.com/office/powerpoint/2010/main" val="199932939"/>
+        <p14:creationId xmlns:p14="http://schemas.microsoft.com/office/powerpoint/2010/main" val="575787410"/>
       </p:ext>
     </p:extLst>
   </p:cSld>
@@ -6783,7 +7423,7 @@
           <p:cNvPr id="8" name="">
             <a:extLst xmlns:a="http://schemas.openxmlformats.org/drawingml/2006/main">
               <a:ext uri="{FF2B5EF4-FFF2-40B4-BE49-F238E27FC236}">
-                <a16:creationId xmlns:a16="http://schemas.microsoft.com/office/drawing/2014/main" id="{366F46D3-39CE-49F4-B4AF-41BB69D5CC4C}"/>
+                <a16:creationId xmlns:a16="http://schemas.microsoft.com/office/drawing/2014/main" id="{FE89CC4D-752A-4698-B4D1-183A1A91DA12}"/>
               </a:ext>
             </a:extLst>
           </p:cNvPr>
@@ -6840,7 +7480,7 @@
           <p:cNvPr id="2" name="">
             <a:extLst xmlns:a="http://schemas.openxmlformats.org/drawingml/2006/main">
               <a:ext uri="{FF2B5EF4-FFF2-40B4-BE49-F238E27FC236}">
-                <a16:creationId xmlns:a16="http://schemas.microsoft.com/office/drawing/2014/main" id="{0C47AF63-618E-496D-8DCB-C4443EDF64C0}"/>
+                <a16:creationId xmlns:a16="http://schemas.microsoft.com/office/drawing/2014/main" id="{77F4560B-DDB0-4210-BBC1-3074C9B9F46C}"/>
               </a:ext>
             </a:extLst>
           </p:cNvPr>
@@ -6897,7 +7537,7 @@
           <p:cNvPr id="3" name="">
             <a:extLst xmlns:a="http://schemas.openxmlformats.org/drawingml/2006/main">
               <a:ext uri="{FF2B5EF4-FFF2-40B4-BE49-F238E27FC236}">
-                <a16:creationId xmlns:a16="http://schemas.microsoft.com/office/drawing/2014/main" id="{05F6A6ED-C8DD-4D7B-BC0B-87E4D0464ABB}"/>
+                <a16:creationId xmlns:a16="http://schemas.microsoft.com/office/drawing/2014/main" id="{33215597-FF97-4F7B-AE50-27CC3C3330AF}"/>
               </a:ext>
             </a:extLst>
           </p:cNvPr>
@@ -6954,7 +7594,7 @@
           <p:cNvPr id="4" name="">
             <a:extLst xmlns:a="http://schemas.openxmlformats.org/drawingml/2006/main">
               <a:ext uri="{FF2B5EF4-FFF2-40B4-BE49-F238E27FC236}">
-                <a16:creationId xmlns:a16="http://schemas.microsoft.com/office/drawing/2014/main" id="{45C28B6E-9BCE-4716-AB78-A09F93BF629C}"/>
+                <a16:creationId xmlns:a16="http://schemas.microsoft.com/office/drawing/2014/main" id="{558D86CB-259E-44E1-AD31-6A25E0644DA5}"/>
               </a:ext>
             </a:extLst>
           </p:cNvPr>
@@ -7011,7 +7651,7 @@
           <p:cNvPr id="5" name="">
             <a:extLst xmlns:a="http://schemas.openxmlformats.org/drawingml/2006/main">
               <a:ext uri="{FF2B5EF4-FFF2-40B4-BE49-F238E27FC236}">
-                <a16:creationId xmlns:a16="http://schemas.microsoft.com/office/drawing/2014/main" id="{3B9C1C43-5D65-4822-A1ED-F98F38DDA31C}"/>
+                <a16:creationId xmlns:a16="http://schemas.microsoft.com/office/drawing/2014/main" id="{3B49FCF8-0DE0-4128-898C-FECABD636454}"/>
               </a:ext>
             </a:extLst>
           </p:cNvPr>
@@ -7091,7 +7731,7 @@
           <p:cNvPr id="6" name="">
             <a:extLst xmlns:a="http://schemas.openxmlformats.org/drawingml/2006/main">
               <a:ext uri="{FF2B5EF4-FFF2-40B4-BE49-F238E27FC236}">
-                <a16:creationId xmlns:a16="http://schemas.microsoft.com/office/drawing/2014/main" id="{82039185-4680-481B-8B7D-FEA8223C6DCA}"/>
+                <a16:creationId xmlns:a16="http://schemas.microsoft.com/office/drawing/2014/main" id="{7F9A0FBF-99C2-40CE-9B2F-D093E4164011}"/>
               </a:ext>
             </a:extLst>
           </p:cNvPr>
@@ -7171,7 +7811,7 @@
           <p:cNvPr id="7" name="">
             <a:extLst xmlns:a="http://schemas.openxmlformats.org/drawingml/2006/main">
               <a:ext uri="{FF2B5EF4-FFF2-40B4-BE49-F238E27FC236}">
-                <a16:creationId xmlns:a16="http://schemas.microsoft.com/office/drawing/2014/main" id="{69439691-1186-4C7E-A08A-F2EFB7AE5F00}"/>
+                <a16:creationId xmlns:a16="http://schemas.microsoft.com/office/drawing/2014/main" id="{A4530257-3B8E-40A1-B408-A3D3F6999C14}"/>
               </a:ext>
             </a:extLst>
           </p:cNvPr>
@@ -7226,7 +7866,7 @@
     </p:spTree>
     <p:extLst>
       <p:ext uri="{BB962C8B-B14F-4D97-AF65-F5344CB8AC3E}">
-        <p14:creationId xmlns:p14="http://schemas.microsoft.com/office/powerpoint/2010/main" val="1272416931"/>
+        <p14:creationId xmlns:p14="http://schemas.microsoft.com/office/powerpoint/2010/main" val="1555553690"/>
       </p:ext>
     </p:extLst>
   </p:cSld>

</xml_diff>

<commit_message>
Add employer-scoped evidence, complete profile intake and reusable form questions
</commit_message>
<xml_diff>
--- a/docs/job-search-guide.pptx
+++ b/docs/job-search-guide.pptx
@@ -2,25 +2,25 @@
 <file path=ppt/presentation.xml><?xml version="1.0" encoding="utf-8"?>
 <p:presentation xmlns:p="http://schemas.openxmlformats.org/presentationml/2006/main">
   <p:sldMasterIdLst>
-    <p:sldMasterId xmlns:r="http://schemas.openxmlformats.org/officeDocument/2006/relationships" id="2147483648" r:id="R447c6f4d8e7c41f4"/>
+    <p:sldMasterId xmlns:r="http://schemas.openxmlformats.org/officeDocument/2006/relationships" id="2147483648" r:id="R832aac82f2374df7"/>
   </p:sldMasterIdLst>
   <p:notesMasterIdLst>
-    <p:notesMasterId xmlns:r="http://schemas.openxmlformats.org/officeDocument/2006/relationships" r:id="R05c64d527ed3421d"/>
+    <p:notesMasterId xmlns:r="http://schemas.openxmlformats.org/officeDocument/2006/relationships" r:id="R36420e35c775429e"/>
   </p:notesMasterIdLst>
   <p:sldIdLst>
-    <p:sldId xmlns:r="http://schemas.openxmlformats.org/officeDocument/2006/relationships" id="256" r:id="Rd711b40d93e345da"/>
-    <p:sldId xmlns:r="http://schemas.openxmlformats.org/officeDocument/2006/relationships" id="257" r:id="Rc070b3f44a004fc1"/>
-    <p:sldId xmlns:r="http://schemas.openxmlformats.org/officeDocument/2006/relationships" id="258" r:id="Re4989ab6461f4ce0"/>
-    <p:sldId xmlns:r="http://schemas.openxmlformats.org/officeDocument/2006/relationships" id="259" r:id="Re4222a6d66404fa4"/>
-    <p:sldId xmlns:r="http://schemas.openxmlformats.org/officeDocument/2006/relationships" id="260" r:id="R1d36cab7690f4271"/>
-    <p:sldId xmlns:r="http://schemas.openxmlformats.org/officeDocument/2006/relationships" id="261" r:id="R2f68a8b3960841a1"/>
-    <p:sldId xmlns:r="http://schemas.openxmlformats.org/officeDocument/2006/relationships" id="262" r:id="R784a22507be840dd"/>
-    <p:sldId xmlns:r="http://schemas.openxmlformats.org/officeDocument/2006/relationships" id="263" r:id="Raed2aedeba6c4d88"/>
-    <p:sldId xmlns:r="http://schemas.openxmlformats.org/officeDocument/2006/relationships" id="264" r:id="R932733ca3efb4eb4"/>
-    <p:sldId xmlns:r="http://schemas.openxmlformats.org/officeDocument/2006/relationships" id="265" r:id="R1d4f18631c394f08"/>
-    <p:sldId xmlns:r="http://schemas.openxmlformats.org/officeDocument/2006/relationships" id="266" r:id="R654630a473a448b3"/>
-    <p:sldId xmlns:r="http://schemas.openxmlformats.org/officeDocument/2006/relationships" id="267" r:id="Rf02eaf7f81984f13"/>
-    <p:sldId xmlns:r="http://schemas.openxmlformats.org/officeDocument/2006/relationships" id="268" r:id="R77d2ecd75e3a47ec"/>
+    <p:sldId xmlns:r="http://schemas.openxmlformats.org/officeDocument/2006/relationships" id="256" r:id="R6fbdc4281e794894"/>
+    <p:sldId xmlns:r="http://schemas.openxmlformats.org/officeDocument/2006/relationships" id="257" r:id="R1112c659bed9448e"/>
+    <p:sldId xmlns:r="http://schemas.openxmlformats.org/officeDocument/2006/relationships" id="258" r:id="R5ac05cbd9305451a"/>
+    <p:sldId xmlns:r="http://schemas.openxmlformats.org/officeDocument/2006/relationships" id="259" r:id="R91104f771b084142"/>
+    <p:sldId xmlns:r="http://schemas.openxmlformats.org/officeDocument/2006/relationships" id="260" r:id="R2ed9465d31a14adf"/>
+    <p:sldId xmlns:r="http://schemas.openxmlformats.org/officeDocument/2006/relationships" id="261" r:id="Rc429d526f5784db1"/>
+    <p:sldId xmlns:r="http://schemas.openxmlformats.org/officeDocument/2006/relationships" id="262" r:id="R76d24d6dd9c249cd"/>
+    <p:sldId xmlns:r="http://schemas.openxmlformats.org/officeDocument/2006/relationships" id="263" r:id="Rbe2d629639954708"/>
+    <p:sldId xmlns:r="http://schemas.openxmlformats.org/officeDocument/2006/relationships" id="264" r:id="Re59055c83a984be7"/>
+    <p:sldId xmlns:r="http://schemas.openxmlformats.org/officeDocument/2006/relationships" id="265" r:id="Rfb398038f5f34986"/>
+    <p:sldId xmlns:r="http://schemas.openxmlformats.org/officeDocument/2006/relationships" id="266" r:id="R038e5d858ef2499f"/>
+    <p:sldId xmlns:r="http://schemas.openxmlformats.org/officeDocument/2006/relationships" id="267" r:id="Rd4bd69f284ea47f9"/>
+    <p:sldId xmlns:r="http://schemas.openxmlformats.org/officeDocument/2006/relationships" id="268" r:id="Rbc2c1cfa640746bb"/>
   </p:sldIdLst>
   <p:sldSz cx="12192000" cy="6858000"/>
   <p:notesSz cx="6858000" cy="9144000"/>
@@ -459,7 +459,7 @@
           </a:p>
           <a:p xmlns:a="http://schemas.openxmlformats.org/drawingml/2006/main">
             <a:r>
-              <a:t>A guide to skill version 1.1.0, checked 12 September 2026. The AI needs local file access and the candidate’s real answers.</a:t>
+              <a:t>A guide to skill version 1.2.0, checked 12 September 2026. The AI needs local file access and the candidate’s real answers.</a:t>
             </a:r>
           </a:p>
         </p:txBody>
@@ -1522,7 +1522,7 @@
   </p:cSld>
   <p:clrMap bg1="lt1" tx1="dk1" bg2="lt2" tx2="dk2" accent1="accent1" accent2="accent2" accent3="accent3" accent4="accent4" accent5="accent5" accent6="accent6" hlink="hlink" folHlink="folHlink"/>
   <p:sldLayoutIdLst>
-    <p:sldLayoutId xmlns:r="http://schemas.openxmlformats.org/officeDocument/2006/relationships" id="2147483649" r:id="R2c034fa69f4045fa"/>
+    <p:sldLayoutId xmlns:r="http://schemas.openxmlformats.org/officeDocument/2006/relationships" id="2147483649" r:id="R776779b3218e416c"/>
   </p:sldLayoutIdLst>
   <p:txStyles>
     <p:titleStyle>
@@ -2073,7 +2073,7 @@
           <p:cNvPr id="5" name="">
             <a:extLst xmlns:a="http://schemas.openxmlformats.org/drawingml/2006/main">
               <a:ext uri="{FF2B5EF4-FFF2-40B4-BE49-F238E27FC236}">
-                <a16:creationId xmlns:a16="http://schemas.microsoft.com/office/drawing/2014/main" id="{3CFD8572-2B1E-4214-8EF9-1339CD54B4D5}"/>
+                <a16:creationId xmlns:a16="http://schemas.microsoft.com/office/drawing/2014/main" id="{1161B0DB-776F-4D3A-96D7-034C549A78BF}"/>
               </a:ext>
             </a:extLst>
           </p:cNvPr>
@@ -2130,7 +2130,7 @@
           <p:cNvPr id="2" name="">
             <a:extLst xmlns:a="http://schemas.openxmlformats.org/drawingml/2006/main">
               <a:ext uri="{FF2B5EF4-FFF2-40B4-BE49-F238E27FC236}">
-                <a16:creationId xmlns:a16="http://schemas.microsoft.com/office/drawing/2014/main" id="{FA5E437F-8ECD-44E6-B463-195898A5B60D}"/>
+                <a16:creationId xmlns:a16="http://schemas.microsoft.com/office/drawing/2014/main" id="{6900462A-4D89-4F27-B195-4270CF31E76B}"/>
               </a:ext>
             </a:extLst>
           </p:cNvPr>
@@ -2187,7 +2187,7 @@
           <p:cNvPr id="3" name="">
             <a:extLst xmlns:a="http://schemas.openxmlformats.org/drawingml/2006/main">
               <a:ext uri="{FF2B5EF4-FFF2-40B4-BE49-F238E27FC236}">
-                <a16:creationId xmlns:a16="http://schemas.microsoft.com/office/drawing/2014/main" id="{0C306B2E-B7C8-4922-A38C-3556C79BF1D7}"/>
+                <a16:creationId xmlns:a16="http://schemas.microsoft.com/office/drawing/2014/main" id="{8B71851B-9003-4160-8D03-B80A68B76D5C}"/>
               </a:ext>
             </a:extLst>
           </p:cNvPr>
@@ -2267,7 +2267,7 @@
           <p:cNvPr id="4" name="">
             <a:extLst xmlns:a="http://schemas.openxmlformats.org/drawingml/2006/main">
               <a:ext uri="{FF2B5EF4-FFF2-40B4-BE49-F238E27FC236}">
-                <a16:creationId xmlns:a16="http://schemas.microsoft.com/office/drawing/2014/main" id="{F043563B-09B2-4407-994F-9F2349DBFEB6}"/>
+                <a16:creationId xmlns:a16="http://schemas.microsoft.com/office/drawing/2014/main" id="{DFFC0449-964D-41F2-A6A1-23F531856D4A}"/>
               </a:ext>
             </a:extLst>
           </p:cNvPr>
@@ -2313,7 +2313,7 @@
                 <a:latin typeface="Arial"/>
                 <a:ea typeface="Arial"/>
                 <a:cs typeface="Arial"/>
-                <a:hlinkClick xmlns:r="http://schemas.openxmlformats.org/officeDocument/2006/relationships" r:id="Rcad915c7e2a04e14"/>
+                <a:hlinkClick xmlns:r="http://schemas.openxmlformats.org/officeDocument/2006/relationships" r:id="R78067816ae794875"/>
               </a:rPr>
               <a:t>Open the GitHub guide</a:t>
             </a:r>
@@ -2323,7 +2323,7 @@
     </p:spTree>
     <p:extLst>
       <p:ext uri="{BB962C8B-B14F-4D97-AF65-F5344CB8AC3E}">
-        <p14:creationId xmlns:p14="http://schemas.microsoft.com/office/powerpoint/2010/main" val="1874479654"/>
+        <p14:creationId xmlns:p14="http://schemas.microsoft.com/office/powerpoint/2010/main" val="840131286"/>
       </p:ext>
     </p:extLst>
   </p:cSld>
@@ -2354,7 +2354,7 @@
           <p:cNvPr id="7" name="">
             <a:extLst xmlns:a="http://schemas.openxmlformats.org/drawingml/2006/main">
               <a:ext uri="{FF2B5EF4-FFF2-40B4-BE49-F238E27FC236}">
-                <a16:creationId xmlns:a16="http://schemas.microsoft.com/office/drawing/2014/main" id="{350241BA-8B3B-43B4-82C5-9870CEAE89D7}"/>
+                <a16:creationId xmlns:a16="http://schemas.microsoft.com/office/drawing/2014/main" id="{C2735F4D-9D93-45D0-A95C-A83DDDCF3CFC}"/>
               </a:ext>
             </a:extLst>
           </p:cNvPr>
@@ -2411,7 +2411,7 @@
           <p:cNvPr id="2" name="">
             <a:extLst xmlns:a="http://schemas.openxmlformats.org/drawingml/2006/main">
               <a:ext uri="{FF2B5EF4-FFF2-40B4-BE49-F238E27FC236}">
-                <a16:creationId xmlns:a16="http://schemas.microsoft.com/office/drawing/2014/main" id="{7FEE3342-CC39-4418-B203-9D7EC8224EB4}"/>
+                <a16:creationId xmlns:a16="http://schemas.microsoft.com/office/drawing/2014/main" id="{90536DA7-8774-40F7-A231-EE3F0676D5C0}"/>
               </a:ext>
             </a:extLst>
           </p:cNvPr>
@@ -2468,7 +2468,7 @@
           <p:cNvPr id="3" name="">
             <a:extLst xmlns:a="http://schemas.openxmlformats.org/drawingml/2006/main">
               <a:ext uri="{FF2B5EF4-FFF2-40B4-BE49-F238E27FC236}">
-                <a16:creationId xmlns:a16="http://schemas.microsoft.com/office/drawing/2014/main" id="{AC649288-EFBF-42B1-A976-5C5D53F2ED48}"/>
+                <a16:creationId xmlns:a16="http://schemas.microsoft.com/office/drawing/2014/main" id="{5BE65806-57F1-4E7C-A88B-9048A8344DD4}"/>
               </a:ext>
             </a:extLst>
           </p:cNvPr>
@@ -2548,7 +2548,7 @@
           <p:cNvPr id="4" name="">
             <a:extLst xmlns:a="http://schemas.openxmlformats.org/drawingml/2006/main">
               <a:ext uri="{FF2B5EF4-FFF2-40B4-BE49-F238E27FC236}">
-                <a16:creationId xmlns:a16="http://schemas.microsoft.com/office/drawing/2014/main" id="{8D22CE55-A99C-4ACC-B393-4A806D8C29D1}"/>
+                <a16:creationId xmlns:a16="http://schemas.microsoft.com/office/drawing/2014/main" id="{44B9C5DA-B21D-4B08-95EF-8B77F82AEF1E}"/>
               </a:ext>
             </a:extLst>
           </p:cNvPr>
@@ -2628,7 +2628,7 @@
           <p:cNvPr id="5" name="">
             <a:extLst xmlns:a="http://schemas.openxmlformats.org/drawingml/2006/main">
               <a:ext uri="{FF2B5EF4-FFF2-40B4-BE49-F238E27FC236}">
-                <a16:creationId xmlns:a16="http://schemas.microsoft.com/office/drawing/2014/main" id="{E44F2EA6-C1E2-49D3-AC39-9331FBE37E9D}"/>
+                <a16:creationId xmlns:a16="http://schemas.microsoft.com/office/drawing/2014/main" id="{6664D170-F928-450D-90F1-5BD4D470B46F}"/>
               </a:ext>
             </a:extLst>
           </p:cNvPr>
@@ -2685,7 +2685,7 @@
           <p:cNvPr id="6" name="">
             <a:extLst xmlns:a="http://schemas.openxmlformats.org/drawingml/2006/main">
               <a:ext uri="{FF2B5EF4-FFF2-40B4-BE49-F238E27FC236}">
-                <a16:creationId xmlns:a16="http://schemas.microsoft.com/office/drawing/2014/main" id="{2B6E8193-12CE-4D81-867C-3940A1AF58E1}"/>
+                <a16:creationId xmlns:a16="http://schemas.microsoft.com/office/drawing/2014/main" id="{82FF4BAD-5203-41A4-84A4-B4700204EBBC}"/>
               </a:ext>
             </a:extLst>
           </p:cNvPr>
@@ -2740,7 +2740,7 @@
     </p:spTree>
     <p:extLst>
       <p:ext uri="{BB962C8B-B14F-4D97-AF65-F5344CB8AC3E}">
-        <p14:creationId xmlns:p14="http://schemas.microsoft.com/office/powerpoint/2010/main" val="78834420"/>
+        <p14:creationId xmlns:p14="http://schemas.microsoft.com/office/powerpoint/2010/main" val="653133177"/>
       </p:ext>
     </p:extLst>
   </p:cSld>
@@ -2771,7 +2771,7 @@
           <p:cNvPr id="9" name="">
             <a:extLst xmlns:a="http://schemas.openxmlformats.org/drawingml/2006/main">
               <a:ext uri="{FF2B5EF4-FFF2-40B4-BE49-F238E27FC236}">
-                <a16:creationId xmlns:a16="http://schemas.microsoft.com/office/drawing/2014/main" id="{0AED20B7-93BB-4EB8-8E68-E8EDEF319151}"/>
+                <a16:creationId xmlns:a16="http://schemas.microsoft.com/office/drawing/2014/main" id="{169161BD-8AE9-46E2-8CC3-EFF379056029}"/>
               </a:ext>
             </a:extLst>
           </p:cNvPr>
@@ -2828,7 +2828,7 @@
           <p:cNvPr id="2" name="">
             <a:extLst xmlns:a="http://schemas.openxmlformats.org/drawingml/2006/main">
               <a:ext uri="{FF2B5EF4-FFF2-40B4-BE49-F238E27FC236}">
-                <a16:creationId xmlns:a16="http://schemas.microsoft.com/office/drawing/2014/main" id="{0240C919-039C-41A9-8CE4-CCB05BB54F67}"/>
+                <a16:creationId xmlns:a16="http://schemas.microsoft.com/office/drawing/2014/main" id="{9BF0956D-C550-4627-9279-6D7431F30A16}"/>
               </a:ext>
             </a:extLst>
           </p:cNvPr>
@@ -2885,7 +2885,7 @@
           <p:cNvPr id="3" name="">
             <a:extLst xmlns:a="http://schemas.openxmlformats.org/drawingml/2006/main">
               <a:ext uri="{FF2B5EF4-FFF2-40B4-BE49-F238E27FC236}">
-                <a16:creationId xmlns:a16="http://schemas.microsoft.com/office/drawing/2014/main" id="{6CA5EF45-8922-483C-B830-3E232133E1B5}"/>
+                <a16:creationId xmlns:a16="http://schemas.microsoft.com/office/drawing/2014/main" id="{C52C288E-FB11-4C26-840F-F19D1B652CD7}"/>
               </a:ext>
             </a:extLst>
           </p:cNvPr>
@@ -2942,7 +2942,7 @@
           <p:cNvPr id="4" name="">
             <a:extLst xmlns:a="http://schemas.openxmlformats.org/drawingml/2006/main">
               <a:ext uri="{FF2B5EF4-FFF2-40B4-BE49-F238E27FC236}">
-                <a16:creationId xmlns:a16="http://schemas.microsoft.com/office/drawing/2014/main" id="{272AA754-72AD-4FF8-9C97-A057BDDCFE07}"/>
+                <a16:creationId xmlns:a16="http://schemas.microsoft.com/office/drawing/2014/main" id="{DEDB0FC7-C28A-4BE3-9D7A-2922828705AF}"/>
               </a:ext>
             </a:extLst>
           </p:cNvPr>
@@ -3022,7 +3022,7 @@
           <p:cNvPr id="5" name="">
             <a:extLst xmlns:a="http://schemas.openxmlformats.org/drawingml/2006/main">
               <a:ext uri="{FF2B5EF4-FFF2-40B4-BE49-F238E27FC236}">
-                <a16:creationId xmlns:a16="http://schemas.microsoft.com/office/drawing/2014/main" id="{198D4D4A-0062-43D7-8874-AB267B692E63}"/>
+                <a16:creationId xmlns:a16="http://schemas.microsoft.com/office/drawing/2014/main" id="{CD2ACAD1-93DE-421C-AF8B-CD06CA8CB196}"/>
               </a:ext>
             </a:extLst>
           </p:cNvPr>
@@ -3079,7 +3079,7 @@
           <p:cNvPr id="6" name="">
             <a:extLst xmlns:a="http://schemas.openxmlformats.org/drawingml/2006/main">
               <a:ext uri="{FF2B5EF4-FFF2-40B4-BE49-F238E27FC236}">
-                <a16:creationId xmlns:a16="http://schemas.microsoft.com/office/drawing/2014/main" id="{E6EF01D4-6C62-40A1-B485-3484E19CA2CF}"/>
+                <a16:creationId xmlns:a16="http://schemas.microsoft.com/office/drawing/2014/main" id="{F0347A4A-FE4C-439F-954B-D90ABEB7AB45}"/>
               </a:ext>
             </a:extLst>
           </p:cNvPr>
@@ -3136,7 +3136,7 @@
           <p:cNvPr id="7" name="">
             <a:extLst xmlns:a="http://schemas.openxmlformats.org/drawingml/2006/main">
               <a:ext uri="{FF2B5EF4-FFF2-40B4-BE49-F238E27FC236}">
-                <a16:creationId xmlns:a16="http://schemas.microsoft.com/office/drawing/2014/main" id="{EC0C7C0B-13D5-4032-8460-0BDD8100E4E3}"/>
+                <a16:creationId xmlns:a16="http://schemas.microsoft.com/office/drawing/2014/main" id="{410D5645-0C3E-43F3-8332-8B8639A23D5A}"/>
               </a:ext>
             </a:extLst>
           </p:cNvPr>
@@ -3216,7 +3216,7 @@
           <p:cNvPr id="8" name="">
             <a:extLst xmlns:a="http://schemas.openxmlformats.org/drawingml/2006/main">
               <a:ext uri="{FF2B5EF4-FFF2-40B4-BE49-F238E27FC236}">
-                <a16:creationId xmlns:a16="http://schemas.microsoft.com/office/drawing/2014/main" id="{5050E988-3CD4-41CB-8538-5ABCBAF0A86F}"/>
+                <a16:creationId xmlns:a16="http://schemas.microsoft.com/office/drawing/2014/main" id="{6E9649C2-4853-4B39-86D0-1E3A8777B2B2}"/>
               </a:ext>
             </a:extLst>
           </p:cNvPr>
@@ -3271,7 +3271,7 @@
     </p:spTree>
     <p:extLst>
       <p:ext uri="{BB962C8B-B14F-4D97-AF65-F5344CB8AC3E}">
-        <p14:creationId xmlns:p14="http://schemas.microsoft.com/office/powerpoint/2010/main" val="2067474245"/>
+        <p14:creationId xmlns:p14="http://schemas.microsoft.com/office/powerpoint/2010/main" val="100367761"/>
       </p:ext>
     </p:extLst>
   </p:cSld>
@@ -3302,7 +3302,7 @@
           <p:cNvPr id="7" name="">
             <a:extLst xmlns:a="http://schemas.openxmlformats.org/drawingml/2006/main">
               <a:ext uri="{FF2B5EF4-FFF2-40B4-BE49-F238E27FC236}">
-                <a16:creationId xmlns:a16="http://schemas.microsoft.com/office/drawing/2014/main" id="{35B90193-37CF-4866-BAAB-DBDB56BF1A4C}"/>
+                <a16:creationId xmlns:a16="http://schemas.microsoft.com/office/drawing/2014/main" id="{BE83AD5A-6862-4372-962B-91B7C465EE2D}"/>
               </a:ext>
             </a:extLst>
           </p:cNvPr>
@@ -3359,7 +3359,7 @@
           <p:cNvPr id="2" name="">
             <a:extLst xmlns:a="http://schemas.openxmlformats.org/drawingml/2006/main">
               <a:ext uri="{FF2B5EF4-FFF2-40B4-BE49-F238E27FC236}">
-                <a16:creationId xmlns:a16="http://schemas.microsoft.com/office/drawing/2014/main" id="{8416A3F8-DB4C-40A1-BF71-564F67B392AF}"/>
+                <a16:creationId xmlns:a16="http://schemas.microsoft.com/office/drawing/2014/main" id="{37C92D8E-43E3-4C5B-82CE-50C06ACE45C4}"/>
               </a:ext>
             </a:extLst>
           </p:cNvPr>
@@ -3416,7 +3416,7 @@
           <p:cNvPr id="3" name="">
             <a:extLst xmlns:a="http://schemas.openxmlformats.org/drawingml/2006/main">
               <a:ext uri="{FF2B5EF4-FFF2-40B4-BE49-F238E27FC236}">
-                <a16:creationId xmlns:a16="http://schemas.microsoft.com/office/drawing/2014/main" id="{C20F840D-06AC-4DA6-AFC7-8EA8C1E1123A}"/>
+                <a16:creationId xmlns:a16="http://schemas.microsoft.com/office/drawing/2014/main" id="{EB546616-85DA-40E0-A49F-DA4A9108474C}"/>
               </a:ext>
             </a:extLst>
           </p:cNvPr>
@@ -3496,7 +3496,7 @@
           <p:cNvPr id="4" name="">
             <a:extLst xmlns:a="http://schemas.openxmlformats.org/drawingml/2006/main">
               <a:ext uri="{FF2B5EF4-FFF2-40B4-BE49-F238E27FC236}">
-                <a16:creationId xmlns:a16="http://schemas.microsoft.com/office/drawing/2014/main" id="{98756A7F-C9BF-4F52-A681-2212D2CA8853}"/>
+                <a16:creationId xmlns:a16="http://schemas.microsoft.com/office/drawing/2014/main" id="{892A0169-0750-468D-AAF0-92DC7635296F}"/>
               </a:ext>
             </a:extLst>
           </p:cNvPr>
@@ -3553,7 +3553,7 @@
           <p:cNvPr id="5" name="">
             <a:extLst xmlns:a="http://schemas.openxmlformats.org/drawingml/2006/main">
               <a:ext uri="{FF2B5EF4-FFF2-40B4-BE49-F238E27FC236}">
-                <a16:creationId xmlns:a16="http://schemas.microsoft.com/office/drawing/2014/main" id="{C8F0FF98-EDBF-4E87-A7F3-30D41F9DC8BE}"/>
+                <a16:creationId xmlns:a16="http://schemas.microsoft.com/office/drawing/2014/main" id="{C74FC4F5-F003-41F3-8BEF-B377C5A50547}"/>
               </a:ext>
             </a:extLst>
           </p:cNvPr>
@@ -3633,7 +3633,7 @@
           <p:cNvPr id="6" name="">
             <a:extLst xmlns:a="http://schemas.openxmlformats.org/drawingml/2006/main">
               <a:ext uri="{FF2B5EF4-FFF2-40B4-BE49-F238E27FC236}">
-                <a16:creationId xmlns:a16="http://schemas.microsoft.com/office/drawing/2014/main" id="{DEA8BD44-03C4-42CE-9A82-ADC1D52D3EAF}"/>
+                <a16:creationId xmlns:a16="http://schemas.microsoft.com/office/drawing/2014/main" id="{20027DA1-E989-4103-A213-08680969F71D}"/>
               </a:ext>
             </a:extLst>
           </p:cNvPr>
@@ -3688,7 +3688,7 @@
     </p:spTree>
     <p:extLst>
       <p:ext uri="{BB962C8B-B14F-4D97-AF65-F5344CB8AC3E}">
-        <p14:creationId xmlns:p14="http://schemas.microsoft.com/office/powerpoint/2010/main" val="2053392650"/>
+        <p14:creationId xmlns:p14="http://schemas.microsoft.com/office/powerpoint/2010/main" val="1377764577"/>
       </p:ext>
     </p:extLst>
   </p:cSld>
@@ -3719,7 +3719,7 @@
           <p:cNvPr id="10" name="">
             <a:extLst xmlns:a="http://schemas.openxmlformats.org/drawingml/2006/main">
               <a:ext uri="{FF2B5EF4-FFF2-40B4-BE49-F238E27FC236}">
-                <a16:creationId xmlns:a16="http://schemas.microsoft.com/office/drawing/2014/main" id="{7572D228-7152-48C7-8BD4-FFB15416003C}"/>
+                <a16:creationId xmlns:a16="http://schemas.microsoft.com/office/drawing/2014/main" id="{E6F1F580-4BC3-4770-924A-8C4F976444C5}"/>
               </a:ext>
             </a:extLst>
           </p:cNvPr>
@@ -3776,7 +3776,7 @@
           <p:cNvPr id="2" name="">
             <a:extLst xmlns:a="http://schemas.openxmlformats.org/drawingml/2006/main">
               <a:ext uri="{FF2B5EF4-FFF2-40B4-BE49-F238E27FC236}">
-                <a16:creationId xmlns:a16="http://schemas.microsoft.com/office/drawing/2014/main" id="{6A41F988-2E52-4DC4-AD2A-242AFE3137D1}"/>
+                <a16:creationId xmlns:a16="http://schemas.microsoft.com/office/drawing/2014/main" id="{5C77B327-D477-419E-B786-6ABB71AE1492}"/>
               </a:ext>
             </a:extLst>
           </p:cNvPr>
@@ -3833,7 +3833,7 @@
           <p:cNvPr id="3" name="">
             <a:extLst xmlns:a="http://schemas.openxmlformats.org/drawingml/2006/main">
               <a:ext uri="{FF2B5EF4-FFF2-40B4-BE49-F238E27FC236}">
-                <a16:creationId xmlns:a16="http://schemas.microsoft.com/office/drawing/2014/main" id="{F1C43A07-AABC-417B-B821-724B5D65C0F4}"/>
+                <a16:creationId xmlns:a16="http://schemas.microsoft.com/office/drawing/2014/main" id="{20A95B95-00D4-4FB5-B446-69FAB5ACAFA8}"/>
               </a:ext>
             </a:extLst>
           </p:cNvPr>
@@ -3890,7 +3890,7 @@
           <p:cNvPr id="4" name="">
             <a:extLst xmlns:a="http://schemas.openxmlformats.org/drawingml/2006/main">
               <a:ext uri="{FF2B5EF4-FFF2-40B4-BE49-F238E27FC236}">
-                <a16:creationId xmlns:a16="http://schemas.microsoft.com/office/drawing/2014/main" id="{F82D097E-16D9-494E-A425-9748631150D1}"/>
+                <a16:creationId xmlns:a16="http://schemas.microsoft.com/office/drawing/2014/main" id="{20865034-38E2-4CDA-8021-017F7BD8F001}"/>
               </a:ext>
             </a:extLst>
           </p:cNvPr>
@@ -3970,7 +3970,7 @@
           <p:cNvPr id="5" name="">
             <a:extLst xmlns:a="http://schemas.openxmlformats.org/drawingml/2006/main">
               <a:ext uri="{FF2B5EF4-FFF2-40B4-BE49-F238E27FC236}">
-                <a16:creationId xmlns:a16="http://schemas.microsoft.com/office/drawing/2014/main" id="{2E29D74C-0DA4-4EC5-A66A-DDB9E1826672}"/>
+                <a16:creationId xmlns:a16="http://schemas.microsoft.com/office/drawing/2014/main" id="{DF24FE3D-F169-48C8-8F08-054B9F3B6105}"/>
               </a:ext>
             </a:extLst>
           </p:cNvPr>
@@ -4027,7 +4027,7 @@
           <p:cNvPr id="6" name="">
             <a:extLst xmlns:a="http://schemas.openxmlformats.org/drawingml/2006/main">
               <a:ext uri="{FF2B5EF4-FFF2-40B4-BE49-F238E27FC236}">
-                <a16:creationId xmlns:a16="http://schemas.microsoft.com/office/drawing/2014/main" id="{0EF5A486-B674-487A-81DF-D6D4FA59DE14}"/>
+                <a16:creationId xmlns:a16="http://schemas.microsoft.com/office/drawing/2014/main" id="{003CC0B3-161C-44D3-9D40-4EED3231B9EB}"/>
               </a:ext>
             </a:extLst>
           </p:cNvPr>
@@ -4130,7 +4130,7 @@
           <p:cNvPr id="7" name="">
             <a:extLst xmlns:a="http://schemas.openxmlformats.org/drawingml/2006/main">
               <a:ext uri="{FF2B5EF4-FFF2-40B4-BE49-F238E27FC236}">
-                <a16:creationId xmlns:a16="http://schemas.microsoft.com/office/drawing/2014/main" id="{6A7B1D8D-6B38-4DEB-AB26-A87799949786}"/>
+                <a16:creationId xmlns:a16="http://schemas.microsoft.com/office/drawing/2014/main" id="{0E9B263E-FC01-49BE-B2BA-C26D45998050}"/>
               </a:ext>
             </a:extLst>
           </p:cNvPr>
@@ -4187,7 +4187,7 @@
           <p:cNvPr id="8" name="">
             <a:extLst xmlns:a="http://schemas.openxmlformats.org/drawingml/2006/main">
               <a:ext uri="{FF2B5EF4-FFF2-40B4-BE49-F238E27FC236}">
-                <a16:creationId xmlns:a16="http://schemas.microsoft.com/office/drawing/2014/main" id="{E8D1887B-1C6F-442B-9B7B-DDE8543A61B7}"/>
+                <a16:creationId xmlns:a16="http://schemas.microsoft.com/office/drawing/2014/main" id="{D7E41856-6EE7-448A-A5B0-4E88BD2CEF4A}"/>
               </a:ext>
             </a:extLst>
           </p:cNvPr>
@@ -4267,7 +4267,7 @@
           <p:cNvPr id="9" name="">
             <a:extLst xmlns:a="http://schemas.openxmlformats.org/drawingml/2006/main">
               <a:ext uri="{FF2B5EF4-FFF2-40B4-BE49-F238E27FC236}">
-                <a16:creationId xmlns:a16="http://schemas.microsoft.com/office/drawing/2014/main" id="{A54622EF-DAA1-4454-969C-9C085B973208}"/>
+                <a16:creationId xmlns:a16="http://schemas.microsoft.com/office/drawing/2014/main" id="{6E4D2406-48CF-4F5D-BC8E-CA87EB99416C}"/>
               </a:ext>
             </a:extLst>
           </p:cNvPr>
@@ -4313,7 +4313,7 @@
                 <a:latin typeface="Arial"/>
                 <a:ea typeface="Arial"/>
                 <a:cs typeface="Arial"/>
-                <a:hlinkClick xmlns:r="http://schemas.openxmlformats.org/officeDocument/2006/relationships" r:id="R99fde2fc3ec64486"/>
+                <a:hlinkClick xmlns:r="http://schemas.openxmlformats.org/officeDocument/2006/relationships" r:id="R1e113b9a8ae4475c"/>
               </a:rPr>
               <a:t>Full guide, downloads and troubleshooting</a:t>
             </a:r>
@@ -4323,7 +4323,7 @@
     </p:spTree>
     <p:extLst>
       <p:ext uri="{BB962C8B-B14F-4D97-AF65-F5344CB8AC3E}">
-        <p14:creationId xmlns:p14="http://schemas.microsoft.com/office/powerpoint/2010/main" val="1512898486"/>
+        <p14:creationId xmlns:p14="http://schemas.microsoft.com/office/powerpoint/2010/main" val="670026719"/>
       </p:ext>
     </p:extLst>
   </p:cSld>
@@ -4354,7 +4354,7 @@
           <p:cNvPr id="13" name="">
             <a:extLst xmlns:a="http://schemas.openxmlformats.org/drawingml/2006/main">
               <a:ext uri="{FF2B5EF4-FFF2-40B4-BE49-F238E27FC236}">
-                <a16:creationId xmlns:a16="http://schemas.microsoft.com/office/drawing/2014/main" id="{FFF71075-4A09-49C1-A685-9A57C44BEDB7}"/>
+                <a16:creationId xmlns:a16="http://schemas.microsoft.com/office/drawing/2014/main" id="{F2C71C29-E22E-4DB6-9730-26FC6DAFD8A3}"/>
               </a:ext>
             </a:extLst>
           </p:cNvPr>
@@ -4411,7 +4411,7 @@
           <p:cNvPr id="2" name="">
             <a:extLst xmlns:a="http://schemas.openxmlformats.org/drawingml/2006/main">
               <a:ext uri="{FF2B5EF4-FFF2-40B4-BE49-F238E27FC236}">
-                <a16:creationId xmlns:a16="http://schemas.microsoft.com/office/drawing/2014/main" id="{AAEAF727-E532-4728-B4DC-7667BB2E72B3}"/>
+                <a16:creationId xmlns:a16="http://schemas.microsoft.com/office/drawing/2014/main" id="{89C42A7C-060D-4601-9F57-EFDB13A5B96E}"/>
               </a:ext>
             </a:extLst>
           </p:cNvPr>
@@ -4468,7 +4468,7 @@
           <p:cNvPr id="3" name="">
             <a:extLst xmlns:a="http://schemas.openxmlformats.org/drawingml/2006/main">
               <a:ext uri="{FF2B5EF4-FFF2-40B4-BE49-F238E27FC236}">
-                <a16:creationId xmlns:a16="http://schemas.microsoft.com/office/drawing/2014/main" id="{67E58CF2-91D8-44A3-B0DB-01E4E5877A60}"/>
+                <a16:creationId xmlns:a16="http://schemas.microsoft.com/office/drawing/2014/main" id="{DBFE9919-825A-4E8E-89C4-02386501C42D}"/>
               </a:ext>
             </a:extLst>
           </p:cNvPr>
@@ -4525,7 +4525,7 @@
           <p:cNvPr id="4" name="">
             <a:extLst xmlns:a="http://schemas.openxmlformats.org/drawingml/2006/main">
               <a:ext uri="{FF2B5EF4-FFF2-40B4-BE49-F238E27FC236}">
-                <a16:creationId xmlns:a16="http://schemas.microsoft.com/office/drawing/2014/main" id="{651080E2-B2C1-4B8A-B3FD-0E99C7121D88}"/>
+                <a16:creationId xmlns:a16="http://schemas.microsoft.com/office/drawing/2014/main" id="{8D03D047-7530-4EA5-9B5A-E90B0B91BCE4}"/>
               </a:ext>
             </a:extLst>
           </p:cNvPr>
@@ -4582,7 +4582,7 @@
           <p:cNvPr id="5" name="">
             <a:extLst xmlns:a="http://schemas.openxmlformats.org/drawingml/2006/main">
               <a:ext uri="{FF2B5EF4-FFF2-40B4-BE49-F238E27FC236}">
-                <a16:creationId xmlns:a16="http://schemas.microsoft.com/office/drawing/2014/main" id="{81B02793-9EEB-42B0-A01C-812B179DD2D1}"/>
+                <a16:creationId xmlns:a16="http://schemas.microsoft.com/office/drawing/2014/main" id="{33D0AA91-AA76-4A0C-89F6-8AA5E8BEEE90}"/>
               </a:ext>
             </a:extLst>
           </p:cNvPr>
@@ -4662,7 +4662,7 @@
           <p:cNvPr id="6" name="">
             <a:extLst xmlns:a="http://schemas.openxmlformats.org/drawingml/2006/main">
               <a:ext uri="{FF2B5EF4-FFF2-40B4-BE49-F238E27FC236}">
-                <a16:creationId xmlns:a16="http://schemas.microsoft.com/office/drawing/2014/main" id="{D5AC606F-BA5D-4575-9EDC-924D82B5E3F5}"/>
+                <a16:creationId xmlns:a16="http://schemas.microsoft.com/office/drawing/2014/main" id="{157ADF9E-4690-4B8C-BC69-AEEA650F847D}"/>
               </a:ext>
             </a:extLst>
           </p:cNvPr>
@@ -4708,7 +4708,7 @@
                 <a:latin typeface="Arial"/>
                 <a:ea typeface="Arial"/>
                 <a:cs typeface="Arial"/>
-                <a:hlinkClick xmlns:r="http://schemas.openxmlformats.org/officeDocument/2006/relationships" r:id="Racc1165f5d9840aa"/>
+                <a:hlinkClick xmlns:r="http://schemas.openxmlformats.org/officeDocument/2006/relationships" r:id="Rd1ba2e79599f4e3f"/>
               </a:rPr>
               <a:t>Mac download page (Apple Silicon)</a:t>
             </a:r>
@@ -4720,7 +4720,7 @@
           <p:cNvPr id="7" name="">
             <a:extLst xmlns:a="http://schemas.openxmlformats.org/drawingml/2006/main">
               <a:ext uri="{FF2B5EF4-FFF2-40B4-BE49-F238E27FC236}">
-                <a16:creationId xmlns:a16="http://schemas.microsoft.com/office/drawing/2014/main" id="{1566D904-3535-4982-882E-0A8D0F471261}"/>
+                <a16:creationId xmlns:a16="http://schemas.microsoft.com/office/drawing/2014/main" id="{15B533F7-88D8-4A30-9D4A-B583BC042ABE}"/>
               </a:ext>
             </a:extLst>
           </p:cNvPr>
@@ -4766,7 +4766,7 @@
                 <a:latin typeface="Arial"/>
                 <a:ea typeface="Arial"/>
                 <a:cs typeface="Arial"/>
-                <a:hlinkClick xmlns:r="http://schemas.openxmlformats.org/officeDocument/2006/relationships" r:id="R0f5522e043de462d"/>
+                <a:hlinkClick xmlns:r="http://schemas.openxmlformats.org/officeDocument/2006/relationships" r:id="R11ad97dede53403c"/>
               </a:rPr>
               <a:t>Windows download page</a:t>
             </a:r>
@@ -4778,7 +4778,7 @@
           <p:cNvPr id="8" name="">
             <a:extLst xmlns:a="http://schemas.openxmlformats.org/drawingml/2006/main">
               <a:ext uri="{FF2B5EF4-FFF2-40B4-BE49-F238E27FC236}">
-                <a16:creationId xmlns:a16="http://schemas.microsoft.com/office/drawing/2014/main" id="{5443140E-5387-41E4-B848-3AF40EF484EF}"/>
+                <a16:creationId xmlns:a16="http://schemas.microsoft.com/office/drawing/2014/main" id="{1FED8D43-899D-4357-B708-1BA88975232E}"/>
               </a:ext>
             </a:extLst>
           </p:cNvPr>
@@ -4835,7 +4835,7 @@
           <p:cNvPr id="9" name="">
             <a:extLst xmlns:a="http://schemas.openxmlformats.org/drawingml/2006/main">
               <a:ext uri="{FF2B5EF4-FFF2-40B4-BE49-F238E27FC236}">
-                <a16:creationId xmlns:a16="http://schemas.microsoft.com/office/drawing/2014/main" id="{3368408F-9CF7-43AC-9A95-840DBAD2E71F}"/>
+                <a16:creationId xmlns:a16="http://schemas.microsoft.com/office/drawing/2014/main" id="{F0B44F8A-E220-4223-AEEA-B3280C22A52A}"/>
               </a:ext>
             </a:extLst>
           </p:cNvPr>
@@ -4915,7 +4915,7 @@
           <p:cNvPr id="10" name="">
             <a:extLst xmlns:a="http://schemas.openxmlformats.org/drawingml/2006/main">
               <a:ext uri="{FF2B5EF4-FFF2-40B4-BE49-F238E27FC236}">
-                <a16:creationId xmlns:a16="http://schemas.microsoft.com/office/drawing/2014/main" id="{50570C37-6F93-4291-8761-049755246CC8}"/>
+                <a16:creationId xmlns:a16="http://schemas.microsoft.com/office/drawing/2014/main" id="{116F762C-228C-4EF6-90CE-88928FA17234}"/>
               </a:ext>
             </a:extLst>
           </p:cNvPr>
@@ -4961,7 +4961,7 @@
                 <a:latin typeface="Arial"/>
                 <a:ea typeface="Arial"/>
                 <a:cs typeface="Arial"/>
-                <a:hlinkClick xmlns:r="http://schemas.openxmlformats.org/officeDocument/2006/relationships" r:id="R0466d1e8addb4b10"/>
+                <a:hlinkClick xmlns:r="http://schemas.openxmlformats.org/officeDocument/2006/relationships" r:id="R222706335aa74c5a"/>
               </a:rPr>
               <a:t>Mac or Windows downloads</a:t>
             </a:r>
@@ -4973,7 +4973,7 @@
           <p:cNvPr id="11" name="">
             <a:extLst xmlns:a="http://schemas.openxmlformats.org/drawingml/2006/main">
               <a:ext uri="{FF2B5EF4-FFF2-40B4-BE49-F238E27FC236}">
-                <a16:creationId xmlns:a16="http://schemas.microsoft.com/office/drawing/2014/main" id="{BEBE1DCB-1F7A-436A-B53F-0764E681B60F}"/>
+                <a16:creationId xmlns:a16="http://schemas.microsoft.com/office/drawing/2014/main" id="{65A73262-9172-4336-ABAD-4587E17E1D7B}"/>
               </a:ext>
             </a:extLst>
           </p:cNvPr>
@@ -5019,7 +5019,7 @@
                 <a:latin typeface="Arial"/>
                 <a:ea typeface="Arial"/>
                 <a:cs typeface="Arial"/>
-                <a:hlinkClick xmlns:r="http://schemas.openxmlformats.org/officeDocument/2006/relationships" r:id="R9d84cc246aba45a4"/>
+                <a:hlinkClick xmlns:r="http://schemas.openxmlformats.org/officeDocument/2006/relationships" r:id="R18ac0459f4594e5f"/>
               </a:rPr>
               <a:t>Claude Code setup and account requirements</a:t>
             </a:r>
@@ -5031,7 +5031,7 @@
           <p:cNvPr id="12" name="">
             <a:extLst xmlns:a="http://schemas.openxmlformats.org/drawingml/2006/main">
               <a:ext uri="{FF2B5EF4-FFF2-40B4-BE49-F238E27FC236}">
-                <a16:creationId xmlns:a16="http://schemas.microsoft.com/office/drawing/2014/main" id="{D5FC47EB-9697-4D71-B870-2259DBFBF2EA}"/>
+                <a16:creationId xmlns:a16="http://schemas.microsoft.com/office/drawing/2014/main" id="{F6486A5C-99E0-44F3-BB56-F30D269F637A}"/>
               </a:ext>
             </a:extLst>
           </p:cNvPr>
@@ -5086,7 +5086,7 @@
     </p:spTree>
     <p:extLst>
       <p:ext uri="{BB962C8B-B14F-4D97-AF65-F5344CB8AC3E}">
-        <p14:creationId xmlns:p14="http://schemas.microsoft.com/office/powerpoint/2010/main" val="279872602"/>
+        <p14:creationId xmlns:p14="http://schemas.microsoft.com/office/powerpoint/2010/main" val="267553724"/>
       </p:ext>
     </p:extLst>
   </p:cSld>
@@ -5117,7 +5117,7 @@
           <p:cNvPr id="6" name="">
             <a:extLst xmlns:a="http://schemas.openxmlformats.org/drawingml/2006/main">
               <a:ext uri="{FF2B5EF4-FFF2-40B4-BE49-F238E27FC236}">
-                <a16:creationId xmlns:a16="http://schemas.microsoft.com/office/drawing/2014/main" id="{A98DB71F-C324-4273-82FE-A2F0EC4254E6}"/>
+                <a16:creationId xmlns:a16="http://schemas.microsoft.com/office/drawing/2014/main" id="{79D03DED-923F-4A55-883F-B3601F0ECA1E}"/>
               </a:ext>
             </a:extLst>
           </p:cNvPr>
@@ -5174,7 +5174,7 @@
           <p:cNvPr id="2" name="">
             <a:extLst xmlns:a="http://schemas.openxmlformats.org/drawingml/2006/main">
               <a:ext uri="{FF2B5EF4-FFF2-40B4-BE49-F238E27FC236}">
-                <a16:creationId xmlns:a16="http://schemas.microsoft.com/office/drawing/2014/main" id="{4B05B4BF-9432-4CF9-AB86-15B8930F5F18}"/>
+                <a16:creationId xmlns:a16="http://schemas.microsoft.com/office/drawing/2014/main" id="{46C24BC0-8142-4183-A12B-2CEBFDA4AD27}"/>
               </a:ext>
             </a:extLst>
           </p:cNvPr>
@@ -5231,7 +5231,7 @@
           <p:cNvPr id="3" name="">
             <a:extLst xmlns:a="http://schemas.openxmlformats.org/drawingml/2006/main">
               <a:ext uri="{FF2B5EF4-FFF2-40B4-BE49-F238E27FC236}">
-                <a16:creationId xmlns:a16="http://schemas.microsoft.com/office/drawing/2014/main" id="{9A6F7B19-AD89-438C-849A-34286F87D159}"/>
+                <a16:creationId xmlns:a16="http://schemas.microsoft.com/office/drawing/2014/main" id="{DC87CC8D-A813-4A94-BB36-204F2551E275}"/>
               </a:ext>
             </a:extLst>
           </p:cNvPr>
@@ -5292,7 +5292,7 @@
           <p:nvPr/>
         </p:nvPicPr>
         <p:blipFill>
-          <a:blip xmlns:r="http://schemas.openxmlformats.org/officeDocument/2006/relationships" xmlns:a="http://schemas.openxmlformats.org/drawingml/2006/main" r:embed="Rb71c2398fda14031"/>
+          <a:blip xmlns:r="http://schemas.openxmlformats.org/officeDocument/2006/relationships" xmlns:a="http://schemas.openxmlformats.org/drawingml/2006/main" r:embed="Ra7377327abdb4a1a"/>
           <a:stretch xmlns:a="http://schemas.openxmlformats.org/drawingml/2006/main"/>
         </p:blipFill>
         <p:spPr>
@@ -5310,7 +5310,7 @@
           <p:cNvPr id="5" name="">
             <a:extLst xmlns:a="http://schemas.openxmlformats.org/drawingml/2006/main">
               <a:ext uri="{FF2B5EF4-FFF2-40B4-BE49-F238E27FC236}">
-                <a16:creationId xmlns:a16="http://schemas.microsoft.com/office/drawing/2014/main" id="{7C9C43B4-3FF1-4FC2-8DDF-2643D9ADB203}"/>
+                <a16:creationId xmlns:a16="http://schemas.microsoft.com/office/drawing/2014/main" id="{E9DC2180-4F7D-4C09-9565-1D60960CEDBD}"/>
               </a:ext>
             </a:extLst>
           </p:cNvPr>
@@ -5388,7 +5388,7 @@
     </p:spTree>
     <p:extLst>
       <p:ext uri="{BB962C8B-B14F-4D97-AF65-F5344CB8AC3E}">
-        <p14:creationId xmlns:p14="http://schemas.microsoft.com/office/powerpoint/2010/main" val="899392404"/>
+        <p14:creationId xmlns:p14="http://schemas.microsoft.com/office/powerpoint/2010/main" val="673747755"/>
       </p:ext>
     </p:extLst>
   </p:cSld>
@@ -5419,7 +5419,7 @@
           <p:cNvPr id="8" name="">
             <a:extLst xmlns:a="http://schemas.openxmlformats.org/drawingml/2006/main">
               <a:ext uri="{FF2B5EF4-FFF2-40B4-BE49-F238E27FC236}">
-                <a16:creationId xmlns:a16="http://schemas.microsoft.com/office/drawing/2014/main" id="{1C9E6CEC-B97E-4482-8654-0B1AFAB1DB8A}"/>
+                <a16:creationId xmlns:a16="http://schemas.microsoft.com/office/drawing/2014/main" id="{89DE8CC6-7DCF-4BFF-B978-0451912A5473}"/>
               </a:ext>
             </a:extLst>
           </p:cNvPr>
@@ -5476,7 +5476,7 @@
           <p:cNvPr id="2" name="">
             <a:extLst xmlns:a="http://schemas.openxmlformats.org/drawingml/2006/main">
               <a:ext uri="{FF2B5EF4-FFF2-40B4-BE49-F238E27FC236}">
-                <a16:creationId xmlns:a16="http://schemas.microsoft.com/office/drawing/2014/main" id="{B2AF31F8-4210-4243-B4E7-D37582DC49CF}"/>
+                <a16:creationId xmlns:a16="http://schemas.microsoft.com/office/drawing/2014/main" id="{7CFE3722-D942-438D-A261-AFA3645034F7}"/>
               </a:ext>
             </a:extLst>
           </p:cNvPr>
@@ -5533,7 +5533,7 @@
           <p:cNvPr id="3" name="">
             <a:extLst xmlns:a="http://schemas.openxmlformats.org/drawingml/2006/main">
               <a:ext uri="{FF2B5EF4-FFF2-40B4-BE49-F238E27FC236}">
-                <a16:creationId xmlns:a16="http://schemas.microsoft.com/office/drawing/2014/main" id="{A3ACFF26-BD7D-4BBB-9812-4019ECA1F9CD}"/>
+                <a16:creationId xmlns:a16="http://schemas.microsoft.com/office/drawing/2014/main" id="{70C7667F-1A93-489F-AA9C-363183EAF8A1}"/>
               </a:ext>
             </a:extLst>
           </p:cNvPr>
@@ -5590,7 +5590,7 @@
           <p:cNvPr id="4" name="">
             <a:extLst xmlns:a="http://schemas.openxmlformats.org/drawingml/2006/main">
               <a:ext uri="{FF2B5EF4-FFF2-40B4-BE49-F238E27FC236}">
-                <a16:creationId xmlns:a16="http://schemas.microsoft.com/office/drawing/2014/main" id="{62535A5B-5F8E-4FF1-B633-01C732939581}"/>
+                <a16:creationId xmlns:a16="http://schemas.microsoft.com/office/drawing/2014/main" id="{0B86EA6F-A2EA-4412-AF76-C3A072F148E3}"/>
               </a:ext>
             </a:extLst>
           </p:cNvPr>
@@ -5716,7 +5716,7 @@
           <p:cNvPr id="5" name="">
             <a:extLst xmlns:a="http://schemas.openxmlformats.org/drawingml/2006/main">
               <a:ext uri="{FF2B5EF4-FFF2-40B4-BE49-F238E27FC236}">
-                <a16:creationId xmlns:a16="http://schemas.microsoft.com/office/drawing/2014/main" id="{E0254D8D-6547-40A2-814A-3BA05A5E3A6D}"/>
+                <a16:creationId xmlns:a16="http://schemas.microsoft.com/office/drawing/2014/main" id="{ECD01095-6A98-4649-8334-A17683ECCF19}"/>
               </a:ext>
             </a:extLst>
           </p:cNvPr>
@@ -5823,7 +5823,7 @@
           <p:nvPr/>
         </p:nvPicPr>
         <p:blipFill>
-          <a:blip xmlns:r="http://schemas.openxmlformats.org/officeDocument/2006/relationships" xmlns:a="http://schemas.openxmlformats.org/drawingml/2006/main" r:embed="R73a1445dbf8e4c92"/>
+          <a:blip xmlns:r="http://schemas.openxmlformats.org/officeDocument/2006/relationships" xmlns:a="http://schemas.openxmlformats.org/drawingml/2006/main" r:embed="Raf5db7dd2e474caf"/>
           <a:stretch xmlns:a="http://schemas.openxmlformats.org/drawingml/2006/main"/>
         </p:blipFill>
         <p:spPr>
@@ -5841,7 +5841,7 @@
           <p:cNvPr id="7" name="">
             <a:extLst xmlns:a="http://schemas.openxmlformats.org/drawingml/2006/main">
               <a:ext uri="{FF2B5EF4-FFF2-40B4-BE49-F238E27FC236}">
-                <a16:creationId xmlns:a16="http://schemas.microsoft.com/office/drawing/2014/main" id="{56BFDD46-C64E-41B5-B873-D9DEF9E9C9FC}"/>
+                <a16:creationId xmlns:a16="http://schemas.microsoft.com/office/drawing/2014/main" id="{F94B6D2C-EBA1-438B-952B-34AAD464541A}"/>
               </a:ext>
             </a:extLst>
           </p:cNvPr>
@@ -5896,7 +5896,7 @@
     </p:spTree>
     <p:extLst>
       <p:ext uri="{BB962C8B-B14F-4D97-AF65-F5344CB8AC3E}">
-        <p14:creationId xmlns:p14="http://schemas.microsoft.com/office/powerpoint/2010/main" val="1818798225"/>
+        <p14:creationId xmlns:p14="http://schemas.microsoft.com/office/powerpoint/2010/main" val="190540888"/>
       </p:ext>
     </p:extLst>
   </p:cSld>
@@ -5927,7 +5927,7 @@
           <p:cNvPr id="6" name="">
             <a:extLst xmlns:a="http://schemas.openxmlformats.org/drawingml/2006/main">
               <a:ext uri="{FF2B5EF4-FFF2-40B4-BE49-F238E27FC236}">
-                <a16:creationId xmlns:a16="http://schemas.microsoft.com/office/drawing/2014/main" id="{AEA2D538-202E-4BC8-A27C-792B95331372}"/>
+                <a16:creationId xmlns:a16="http://schemas.microsoft.com/office/drawing/2014/main" id="{75B1D08B-73E6-4D72-8E4A-EA2DFDD08FE9}"/>
               </a:ext>
             </a:extLst>
           </p:cNvPr>
@@ -5984,7 +5984,7 @@
           <p:cNvPr id="2" name="">
             <a:extLst xmlns:a="http://schemas.openxmlformats.org/drawingml/2006/main">
               <a:ext uri="{FF2B5EF4-FFF2-40B4-BE49-F238E27FC236}">
-                <a16:creationId xmlns:a16="http://schemas.microsoft.com/office/drawing/2014/main" id="{8C36C64F-8EE6-4136-935B-49B82E7AEC77}"/>
+                <a16:creationId xmlns:a16="http://schemas.microsoft.com/office/drawing/2014/main" id="{AB97D43E-AB7B-4025-91D4-9751847B3C5B}"/>
               </a:ext>
             </a:extLst>
           </p:cNvPr>
@@ -6041,7 +6041,7 @@
           <p:cNvPr id="3" name="">
             <a:extLst xmlns:a="http://schemas.openxmlformats.org/drawingml/2006/main">
               <a:ext uri="{FF2B5EF4-FFF2-40B4-BE49-F238E27FC236}">
-                <a16:creationId xmlns:a16="http://schemas.microsoft.com/office/drawing/2014/main" id="{1125432F-C4E0-4345-910A-2646062EB129}"/>
+                <a16:creationId xmlns:a16="http://schemas.microsoft.com/office/drawing/2014/main" id="{F44C6D47-8AE4-4085-8C70-E3BC6A918F16}"/>
               </a:ext>
             </a:extLst>
           </p:cNvPr>
@@ -6125,7 +6125,7 @@
           <p:nvPr/>
         </p:nvPicPr>
         <p:blipFill>
-          <a:blip xmlns:r="http://schemas.openxmlformats.org/officeDocument/2006/relationships" xmlns:a="http://schemas.openxmlformats.org/drawingml/2006/main" r:embed="Rd1387e4ccfcc4d72"/>
+          <a:blip xmlns:r="http://schemas.openxmlformats.org/officeDocument/2006/relationships" xmlns:a="http://schemas.openxmlformats.org/drawingml/2006/main" r:embed="R8bca409d3a3240fa"/>
           <a:stretch xmlns:a="http://schemas.openxmlformats.org/drawingml/2006/main"/>
         </p:blipFill>
         <p:spPr>
@@ -6143,7 +6143,7 @@
           <p:cNvPr id="5" name="">
             <a:extLst xmlns:a="http://schemas.openxmlformats.org/drawingml/2006/main">
               <a:ext uri="{FF2B5EF4-FFF2-40B4-BE49-F238E27FC236}">
-                <a16:creationId xmlns:a16="http://schemas.microsoft.com/office/drawing/2014/main" id="{11BC7A75-EFD6-40CA-AE7F-304A1DC3E3BE}"/>
+                <a16:creationId xmlns:a16="http://schemas.microsoft.com/office/drawing/2014/main" id="{A18431D6-A087-4D7D-83FD-1C55F1B0A50C}"/>
               </a:ext>
             </a:extLst>
           </p:cNvPr>
@@ -6221,7 +6221,7 @@
     </p:spTree>
     <p:extLst>
       <p:ext uri="{BB962C8B-B14F-4D97-AF65-F5344CB8AC3E}">
-        <p14:creationId xmlns:p14="http://schemas.microsoft.com/office/powerpoint/2010/main" val="1368155152"/>
+        <p14:creationId xmlns:p14="http://schemas.microsoft.com/office/powerpoint/2010/main" val="2032136883"/>
       </p:ext>
     </p:extLst>
   </p:cSld>
@@ -6252,7 +6252,7 @@
           <p:cNvPr id="6" name="">
             <a:extLst xmlns:a="http://schemas.openxmlformats.org/drawingml/2006/main">
               <a:ext uri="{FF2B5EF4-FFF2-40B4-BE49-F238E27FC236}">
-                <a16:creationId xmlns:a16="http://schemas.microsoft.com/office/drawing/2014/main" id="{84DB0E5B-7548-46F6-9D72-B588F6894C6F}"/>
+                <a16:creationId xmlns:a16="http://schemas.microsoft.com/office/drawing/2014/main" id="{C1A3298E-93F2-4134-A389-41F46F1CA733}"/>
               </a:ext>
             </a:extLst>
           </p:cNvPr>
@@ -6309,7 +6309,7 @@
           <p:cNvPr id="2" name="">
             <a:extLst xmlns:a="http://schemas.openxmlformats.org/drawingml/2006/main">
               <a:ext uri="{FF2B5EF4-FFF2-40B4-BE49-F238E27FC236}">
-                <a16:creationId xmlns:a16="http://schemas.microsoft.com/office/drawing/2014/main" id="{C88B1C40-AFEB-4A9A-82DD-735F22C1B62D}"/>
+                <a16:creationId xmlns:a16="http://schemas.microsoft.com/office/drawing/2014/main" id="{059A974E-A363-48AB-940F-C1A08BDC21BC}"/>
               </a:ext>
             </a:extLst>
           </p:cNvPr>
@@ -6366,7 +6366,7 @@
           <p:cNvPr id="3" name="">
             <a:extLst xmlns:a="http://schemas.openxmlformats.org/drawingml/2006/main">
               <a:ext uri="{FF2B5EF4-FFF2-40B4-BE49-F238E27FC236}">
-                <a16:creationId xmlns:a16="http://schemas.microsoft.com/office/drawing/2014/main" id="{38512D05-CBFE-4FB8-8746-1966A6982282}"/>
+                <a16:creationId xmlns:a16="http://schemas.microsoft.com/office/drawing/2014/main" id="{E72DD0AA-2EBE-4C16-948C-8D4F5168D2C6}"/>
               </a:ext>
             </a:extLst>
           </p:cNvPr>
@@ -6427,7 +6427,7 @@
           <p:nvPr/>
         </p:nvPicPr>
         <p:blipFill>
-          <a:blip xmlns:r="http://schemas.openxmlformats.org/officeDocument/2006/relationships" xmlns:a="http://schemas.openxmlformats.org/drawingml/2006/main" r:embed="R8f8160ddc45248f9"/>
+          <a:blip xmlns:r="http://schemas.openxmlformats.org/officeDocument/2006/relationships" xmlns:a="http://schemas.openxmlformats.org/drawingml/2006/main" r:embed="R42756619e77b4bf0"/>
           <a:stretch xmlns:a="http://schemas.openxmlformats.org/drawingml/2006/main"/>
         </p:blipFill>
         <p:spPr>
@@ -6445,7 +6445,7 @@
           <p:cNvPr id="5" name="">
             <a:extLst xmlns:a="http://schemas.openxmlformats.org/drawingml/2006/main">
               <a:ext uri="{FF2B5EF4-FFF2-40B4-BE49-F238E27FC236}">
-                <a16:creationId xmlns:a16="http://schemas.microsoft.com/office/drawing/2014/main" id="{F2F452F7-AACB-4DB3-85B7-3C294F389C7E}"/>
+                <a16:creationId xmlns:a16="http://schemas.microsoft.com/office/drawing/2014/main" id="{35B848A2-5BE6-40AA-8F4F-3A2A60D1BD63}"/>
               </a:ext>
             </a:extLst>
           </p:cNvPr>
@@ -6523,7 +6523,7 @@
     </p:spTree>
     <p:extLst>
       <p:ext uri="{BB962C8B-B14F-4D97-AF65-F5344CB8AC3E}">
-        <p14:creationId xmlns:p14="http://schemas.microsoft.com/office/powerpoint/2010/main" val="1484708298"/>
+        <p14:creationId xmlns:p14="http://schemas.microsoft.com/office/powerpoint/2010/main" val="577427104"/>
       </p:ext>
     </p:extLst>
   </p:cSld>
@@ -6554,7 +6554,7 @@
           <p:cNvPr id="8" name="">
             <a:extLst xmlns:a="http://schemas.openxmlformats.org/drawingml/2006/main">
               <a:ext uri="{FF2B5EF4-FFF2-40B4-BE49-F238E27FC236}">
-                <a16:creationId xmlns:a16="http://schemas.microsoft.com/office/drawing/2014/main" id="{18F59F86-41E3-43FB-AD1B-AB1EA8C0450D}"/>
+                <a16:creationId xmlns:a16="http://schemas.microsoft.com/office/drawing/2014/main" id="{10445EBD-F04E-4808-A20A-94986F329B7D}"/>
               </a:ext>
             </a:extLst>
           </p:cNvPr>
@@ -6611,7 +6611,7 @@
           <p:cNvPr id="2" name="">
             <a:extLst xmlns:a="http://schemas.openxmlformats.org/drawingml/2006/main">
               <a:ext uri="{FF2B5EF4-FFF2-40B4-BE49-F238E27FC236}">
-                <a16:creationId xmlns:a16="http://schemas.microsoft.com/office/drawing/2014/main" id="{3231FDA9-5B8B-48A7-80F7-39542F23F26A}"/>
+                <a16:creationId xmlns:a16="http://schemas.microsoft.com/office/drawing/2014/main" id="{49F6911C-C79D-4D55-97BF-97018EB097AF}"/>
               </a:ext>
             </a:extLst>
           </p:cNvPr>
@@ -6668,7 +6668,7 @@
           <p:cNvPr id="3" name="">
             <a:extLst xmlns:a="http://schemas.openxmlformats.org/drawingml/2006/main">
               <a:ext uri="{FF2B5EF4-FFF2-40B4-BE49-F238E27FC236}">
-                <a16:creationId xmlns:a16="http://schemas.microsoft.com/office/drawing/2014/main" id="{A9684426-DF03-4513-92DE-C60AA7964767}"/>
+                <a16:creationId xmlns:a16="http://schemas.microsoft.com/office/drawing/2014/main" id="{C687C0E5-D22C-46B5-8079-E64F09239FB0}"/>
               </a:ext>
             </a:extLst>
           </p:cNvPr>
@@ -6725,7 +6725,7 @@
           <p:cNvPr id="4" name="">
             <a:extLst xmlns:a="http://schemas.openxmlformats.org/drawingml/2006/main">
               <a:ext uri="{FF2B5EF4-FFF2-40B4-BE49-F238E27FC236}">
-                <a16:creationId xmlns:a16="http://schemas.microsoft.com/office/drawing/2014/main" id="{D835E3E4-CA89-43DB-82DA-8132BB831A8C}"/>
+                <a16:creationId xmlns:a16="http://schemas.microsoft.com/office/drawing/2014/main" id="{4449BFC2-14E1-4A34-806D-BE4C438F80C2}"/>
               </a:ext>
             </a:extLst>
           </p:cNvPr>
@@ -6805,7 +6805,7 @@
           <p:cNvPr id="5" name="">
             <a:extLst xmlns:a="http://schemas.openxmlformats.org/drawingml/2006/main">
               <a:ext uri="{FF2B5EF4-FFF2-40B4-BE49-F238E27FC236}">
-                <a16:creationId xmlns:a16="http://schemas.microsoft.com/office/drawing/2014/main" id="{F1BDB6BC-447A-40B5-8E82-8555C8037AF2}"/>
+                <a16:creationId xmlns:a16="http://schemas.microsoft.com/office/drawing/2014/main" id="{46BCC760-3DB7-48D8-B455-37FE30E5AF1C}"/>
               </a:ext>
             </a:extLst>
           </p:cNvPr>
@@ -6862,7 +6862,7 @@
           <p:cNvPr id="6" name="">
             <a:extLst xmlns:a="http://schemas.openxmlformats.org/drawingml/2006/main">
               <a:ext uri="{FF2B5EF4-FFF2-40B4-BE49-F238E27FC236}">
-                <a16:creationId xmlns:a16="http://schemas.microsoft.com/office/drawing/2014/main" id="{25B0E71A-BAB6-4996-BC29-327C7AF665BD}"/>
+                <a16:creationId xmlns:a16="http://schemas.microsoft.com/office/drawing/2014/main" id="{BABA9B37-065D-4AFB-B363-A621C087552C}"/>
               </a:ext>
             </a:extLst>
           </p:cNvPr>
@@ -6919,7 +6919,7 @@
           <p:cNvPr id="7" name="">
             <a:extLst xmlns:a="http://schemas.openxmlformats.org/drawingml/2006/main">
               <a:ext uri="{FF2B5EF4-FFF2-40B4-BE49-F238E27FC236}">
-                <a16:creationId xmlns:a16="http://schemas.microsoft.com/office/drawing/2014/main" id="{70F7CCE0-0A3B-442B-8F9C-64E88CB2564F}"/>
+                <a16:creationId xmlns:a16="http://schemas.microsoft.com/office/drawing/2014/main" id="{D4FD2918-5F54-4174-8337-AD2347D91388}"/>
               </a:ext>
             </a:extLst>
           </p:cNvPr>
@@ -6974,7 +6974,7 @@
     </p:spTree>
     <p:extLst>
       <p:ext uri="{BB962C8B-B14F-4D97-AF65-F5344CB8AC3E}">
-        <p14:creationId xmlns:p14="http://schemas.microsoft.com/office/powerpoint/2010/main" val="862324596"/>
+        <p14:creationId xmlns:p14="http://schemas.microsoft.com/office/powerpoint/2010/main" val="924309464"/>
       </p:ext>
     </p:extLst>
   </p:cSld>
@@ -7005,7 +7005,7 @@
           <p:cNvPr id="7" name="">
             <a:extLst xmlns:a="http://schemas.openxmlformats.org/drawingml/2006/main">
               <a:ext uri="{FF2B5EF4-FFF2-40B4-BE49-F238E27FC236}">
-                <a16:creationId xmlns:a16="http://schemas.microsoft.com/office/drawing/2014/main" id="{F8B82DF0-C920-49B8-9691-C57BE6A6AE28}"/>
+                <a16:creationId xmlns:a16="http://schemas.microsoft.com/office/drawing/2014/main" id="{21AB082F-EC96-408F-973C-CD6461BBF7B7}"/>
               </a:ext>
             </a:extLst>
           </p:cNvPr>
@@ -7062,7 +7062,7 @@
           <p:cNvPr id="2" name="">
             <a:extLst xmlns:a="http://schemas.openxmlformats.org/drawingml/2006/main">
               <a:ext uri="{FF2B5EF4-FFF2-40B4-BE49-F238E27FC236}">
-                <a16:creationId xmlns:a16="http://schemas.microsoft.com/office/drawing/2014/main" id="{0200D577-C1BC-463D-887A-DD542A8ABD03}"/>
+                <a16:creationId xmlns:a16="http://schemas.microsoft.com/office/drawing/2014/main" id="{D8034656-DC12-4119-ACDC-F8D9FEF6C1B6}"/>
               </a:ext>
             </a:extLst>
           </p:cNvPr>
@@ -7119,7 +7119,7 @@
           <p:cNvPr id="3" name="">
             <a:extLst xmlns:a="http://schemas.openxmlformats.org/drawingml/2006/main">
               <a:ext uri="{FF2B5EF4-FFF2-40B4-BE49-F238E27FC236}">
-                <a16:creationId xmlns:a16="http://schemas.microsoft.com/office/drawing/2014/main" id="{1593F920-C76A-4CDC-BFB9-370B646AFFAD}"/>
+                <a16:creationId xmlns:a16="http://schemas.microsoft.com/office/drawing/2014/main" id="{5262556F-5778-49F0-A66D-3F7840F5784A}"/>
               </a:ext>
             </a:extLst>
           </p:cNvPr>
@@ -7176,7 +7176,7 @@
           <p:cNvPr id="4" name="">
             <a:extLst xmlns:a="http://schemas.openxmlformats.org/drawingml/2006/main">
               <a:ext uri="{FF2B5EF4-FFF2-40B4-BE49-F238E27FC236}">
-                <a16:creationId xmlns:a16="http://schemas.microsoft.com/office/drawing/2014/main" id="{07B69F60-906A-4208-ADF7-30060DEF9AA2}"/>
+                <a16:creationId xmlns:a16="http://schemas.microsoft.com/office/drawing/2014/main" id="{EED00C55-6220-42F3-8935-1588509D1F39}"/>
               </a:ext>
             </a:extLst>
           </p:cNvPr>
@@ -7256,7 +7256,7 @@
           <p:cNvPr id="5" name="">
             <a:extLst xmlns:a="http://schemas.openxmlformats.org/drawingml/2006/main">
               <a:ext uri="{FF2B5EF4-FFF2-40B4-BE49-F238E27FC236}">
-                <a16:creationId xmlns:a16="http://schemas.microsoft.com/office/drawing/2014/main" id="{E83146A7-FEF5-4552-A15D-019F364990B0}"/>
+                <a16:creationId xmlns:a16="http://schemas.microsoft.com/office/drawing/2014/main" id="{6E87F8F2-E1A7-4471-A4C8-E5395E21457A}"/>
               </a:ext>
             </a:extLst>
           </p:cNvPr>
@@ -7336,7 +7336,7 @@
           <p:cNvPr id="6" name="">
             <a:extLst xmlns:a="http://schemas.openxmlformats.org/drawingml/2006/main">
               <a:ext uri="{FF2B5EF4-FFF2-40B4-BE49-F238E27FC236}">
-                <a16:creationId xmlns:a16="http://schemas.microsoft.com/office/drawing/2014/main" id="{0746BF55-6622-49D0-8701-BDFD57BCA851}"/>
+                <a16:creationId xmlns:a16="http://schemas.microsoft.com/office/drawing/2014/main" id="{28403172-4C8A-4ED4-A247-A822C8D2B350}"/>
               </a:ext>
             </a:extLst>
           </p:cNvPr>
@@ -7382,7 +7382,7 @@
                 <a:latin typeface="Arial"/>
                 <a:ea typeface="Arial"/>
                 <a:cs typeface="Arial"/>
-                <a:hlinkClick xmlns:r="http://schemas.openxmlformats.org/officeDocument/2006/relationships" r:id="Re9a06c9c38f24d36"/>
+                <a:hlinkClick xmlns:r="http://schemas.openxmlformats.org/officeDocument/2006/relationships" r:id="R502e32cf091e4dea"/>
               </a:rPr>
               <a:t>Copy from the README</a:t>
             </a:r>
@@ -7392,7 +7392,7 @@
     </p:spTree>
     <p:extLst>
       <p:ext uri="{BB962C8B-B14F-4D97-AF65-F5344CB8AC3E}">
-        <p14:creationId xmlns:p14="http://schemas.microsoft.com/office/powerpoint/2010/main" val="575787410"/>
+        <p14:creationId xmlns:p14="http://schemas.microsoft.com/office/powerpoint/2010/main" val="1909632200"/>
       </p:ext>
     </p:extLst>
   </p:cSld>
@@ -7423,7 +7423,7 @@
           <p:cNvPr id="8" name="">
             <a:extLst xmlns:a="http://schemas.openxmlformats.org/drawingml/2006/main">
               <a:ext uri="{FF2B5EF4-FFF2-40B4-BE49-F238E27FC236}">
-                <a16:creationId xmlns:a16="http://schemas.microsoft.com/office/drawing/2014/main" id="{FE89CC4D-752A-4698-B4D1-183A1A91DA12}"/>
+                <a16:creationId xmlns:a16="http://schemas.microsoft.com/office/drawing/2014/main" id="{0EA35182-8B72-4563-9247-AD6140B945E1}"/>
               </a:ext>
             </a:extLst>
           </p:cNvPr>
@@ -7480,7 +7480,7 @@
           <p:cNvPr id="2" name="">
             <a:extLst xmlns:a="http://schemas.openxmlformats.org/drawingml/2006/main">
               <a:ext uri="{FF2B5EF4-FFF2-40B4-BE49-F238E27FC236}">
-                <a16:creationId xmlns:a16="http://schemas.microsoft.com/office/drawing/2014/main" id="{77F4560B-DDB0-4210-BBC1-3074C9B9F46C}"/>
+                <a16:creationId xmlns:a16="http://schemas.microsoft.com/office/drawing/2014/main" id="{70EC2347-AD21-4CDE-B8C7-F08C0500F349}"/>
               </a:ext>
             </a:extLst>
           </p:cNvPr>
@@ -7537,7 +7537,7 @@
           <p:cNvPr id="3" name="">
             <a:extLst xmlns:a="http://schemas.openxmlformats.org/drawingml/2006/main">
               <a:ext uri="{FF2B5EF4-FFF2-40B4-BE49-F238E27FC236}">
-                <a16:creationId xmlns:a16="http://schemas.microsoft.com/office/drawing/2014/main" id="{33215597-FF97-4F7B-AE50-27CC3C3330AF}"/>
+                <a16:creationId xmlns:a16="http://schemas.microsoft.com/office/drawing/2014/main" id="{9D4649D6-9FE5-4C14-B196-890BD7582E7A}"/>
               </a:ext>
             </a:extLst>
           </p:cNvPr>
@@ -7584,7 +7584,7 @@
                 <a:ea typeface="Arial"/>
                 <a:cs typeface="Arial"/>
               </a:rPr>
-              <a:t>The AI asks one question, waits, and saves your answer.</a:t>
+              <a:t>The AI asks about one employer and role at a time.</a:t>
             </a:r>
           </a:p>
         </p:txBody>
@@ -7594,7 +7594,7 @@
           <p:cNvPr id="4" name="">
             <a:extLst xmlns:a="http://schemas.openxmlformats.org/drawingml/2006/main">
               <a:ext uri="{FF2B5EF4-FFF2-40B4-BE49-F238E27FC236}">
-                <a16:creationId xmlns:a16="http://schemas.microsoft.com/office/drawing/2014/main" id="{558D86CB-259E-44E1-AD31-6A25E0644DA5}"/>
+                <a16:creationId xmlns:a16="http://schemas.microsoft.com/office/drawing/2014/main" id="{28DB3BC5-6C98-43AA-9E4F-B31F0A8A42C9}"/>
               </a:ext>
             </a:extLst>
           </p:cNvPr>
@@ -7641,7 +7641,7 @@
                 <a:ea typeface="Arial"/>
                 <a:cs typeface="Arial"/>
               </a:rPr>
-              <a:t>Example question</a:t>
+              <a:t>Example: Cedar Clinic, Office Assistant, 2022-2024</a:t>
             </a:r>
           </a:p>
         </p:txBody>
@@ -7651,7 +7651,7 @@
           <p:cNvPr id="5" name="">
             <a:extLst xmlns:a="http://schemas.openxmlformats.org/drawingml/2006/main">
               <a:ext uri="{FF2B5EF4-FFF2-40B4-BE49-F238E27FC236}">
-                <a16:creationId xmlns:a16="http://schemas.microsoft.com/office/drawing/2014/main" id="{3B49FCF8-0DE0-4128-898C-FECABD636454}"/>
+                <a16:creationId xmlns:a16="http://schemas.microsoft.com/office/drawing/2014/main" id="{D969D217-0C07-47A7-91BE-6939AC6C11E7}"/>
               </a:ext>
             </a:extLst>
           </p:cNvPr>
@@ -7698,7 +7698,7 @@
                 <a:ea typeface="Arial"/>
                 <a:cs typeface="Arial"/>
               </a:rPr>
-              <a:t>“Tell me about a time you solved a problem</a:t>
+              <a:t>“At Cedar Clinic, tell me about one scheduling</a:t>
             </a:r>
           </a:p>
           <a:p xmlns:a="http://schemas.openxmlformats.org/drawingml/2006/main">
@@ -7721,7 +7721,7 @@
                 <a:ea typeface="Arial"/>
                 <a:cs typeface="Arial"/>
               </a:rPr>
-              <a:t>that matters for the work you want to do.”</a:t>
+              <a:t>problem you handled as an office assistant.”</a:t>
             </a:r>
           </a:p>
         </p:txBody>
@@ -7731,7 +7731,7 @@
           <p:cNvPr id="6" name="">
             <a:extLst xmlns:a="http://schemas.openxmlformats.org/drawingml/2006/main">
               <a:ext uri="{FF2B5EF4-FFF2-40B4-BE49-F238E27FC236}">
-                <a16:creationId xmlns:a16="http://schemas.microsoft.com/office/drawing/2014/main" id="{7F9A0FBF-99C2-40CE-9B2F-D093E4164011}"/>
+                <a16:creationId xmlns:a16="http://schemas.microsoft.com/office/drawing/2014/main" id="{D1460E3E-76CD-4DB6-9DEE-664CD683E3D8}"/>
               </a:ext>
             </a:extLst>
           </p:cNvPr>
@@ -7811,7 +7811,7 @@
           <p:cNvPr id="7" name="">
             <a:extLst xmlns:a="http://schemas.openxmlformats.org/drawingml/2006/main">
               <a:ext uri="{FF2B5EF4-FFF2-40B4-BE49-F238E27FC236}">
-                <a16:creationId xmlns:a16="http://schemas.microsoft.com/office/drawing/2014/main" id="{A4530257-3B8E-40A1-B408-A3D3F6999C14}"/>
+                <a16:creationId xmlns:a16="http://schemas.microsoft.com/office/drawing/2014/main" id="{6B91696A-E701-43BC-8EE8-BD3A9E28A3CA}"/>
               </a:ext>
             </a:extLst>
           </p:cNvPr>
@@ -7858,7 +7858,7 @@
                 <a:ea typeface="Arial"/>
                 <a:cs typeface="Arial"/>
               </a:rPr>
-              <a:t>You can pause, correct an answer, or decline the optional LinkedIn review.</a:t>
+              <a:t>No resume? It builds your work history with you and checks for any other employers.</a:t>
             </a:r>
           </a:p>
         </p:txBody>
@@ -7866,7 +7866,7 @@
     </p:spTree>
     <p:extLst>
       <p:ext uri="{BB962C8B-B14F-4D97-AF65-F5344CB8AC3E}">
-        <p14:creationId xmlns:p14="http://schemas.microsoft.com/office/powerpoint/2010/main" val="1555553690"/>
+        <p14:creationId xmlns:p14="http://schemas.microsoft.com/office/powerpoint/2010/main" val="1808846681"/>
       </p:ext>
     </p:extLst>
   </p:cSld>

</xml_diff>

<commit_message>
Add guided weekday search routines and durable daily run checks
</commit_message>
<xml_diff>
--- a/docs/job-search-guide.pptx
+++ b/docs/job-search-guide.pptx
@@ -2,25 +2,27 @@
 <file path=ppt/presentation.xml><?xml version="1.0" encoding="utf-8"?>
 <p:presentation xmlns:p="http://schemas.openxmlformats.org/presentationml/2006/main">
   <p:sldMasterIdLst>
-    <p:sldMasterId xmlns:r="http://schemas.openxmlformats.org/officeDocument/2006/relationships" id="2147483648" r:id="R832aac82f2374df7"/>
+    <p:sldMasterId xmlns:r="http://schemas.openxmlformats.org/officeDocument/2006/relationships" id="2147483648" r:id="Ra467bdd5a03b45e1"/>
   </p:sldMasterIdLst>
   <p:notesMasterIdLst>
-    <p:notesMasterId xmlns:r="http://schemas.openxmlformats.org/officeDocument/2006/relationships" r:id="R36420e35c775429e"/>
+    <p:notesMasterId xmlns:r="http://schemas.openxmlformats.org/officeDocument/2006/relationships" r:id="R8c1d93c700d34b58"/>
   </p:notesMasterIdLst>
   <p:sldIdLst>
-    <p:sldId xmlns:r="http://schemas.openxmlformats.org/officeDocument/2006/relationships" id="256" r:id="R6fbdc4281e794894"/>
-    <p:sldId xmlns:r="http://schemas.openxmlformats.org/officeDocument/2006/relationships" id="257" r:id="R1112c659bed9448e"/>
-    <p:sldId xmlns:r="http://schemas.openxmlformats.org/officeDocument/2006/relationships" id="258" r:id="R5ac05cbd9305451a"/>
-    <p:sldId xmlns:r="http://schemas.openxmlformats.org/officeDocument/2006/relationships" id="259" r:id="R91104f771b084142"/>
-    <p:sldId xmlns:r="http://schemas.openxmlformats.org/officeDocument/2006/relationships" id="260" r:id="R2ed9465d31a14adf"/>
-    <p:sldId xmlns:r="http://schemas.openxmlformats.org/officeDocument/2006/relationships" id="261" r:id="Rc429d526f5784db1"/>
-    <p:sldId xmlns:r="http://schemas.openxmlformats.org/officeDocument/2006/relationships" id="262" r:id="R76d24d6dd9c249cd"/>
-    <p:sldId xmlns:r="http://schemas.openxmlformats.org/officeDocument/2006/relationships" id="263" r:id="Rbe2d629639954708"/>
-    <p:sldId xmlns:r="http://schemas.openxmlformats.org/officeDocument/2006/relationships" id="264" r:id="Re59055c83a984be7"/>
-    <p:sldId xmlns:r="http://schemas.openxmlformats.org/officeDocument/2006/relationships" id="265" r:id="Rfb398038f5f34986"/>
-    <p:sldId xmlns:r="http://schemas.openxmlformats.org/officeDocument/2006/relationships" id="266" r:id="R038e5d858ef2499f"/>
-    <p:sldId xmlns:r="http://schemas.openxmlformats.org/officeDocument/2006/relationships" id="267" r:id="Rd4bd69f284ea47f9"/>
-    <p:sldId xmlns:r="http://schemas.openxmlformats.org/officeDocument/2006/relationships" id="268" r:id="Rbc2c1cfa640746bb"/>
+    <p:sldId xmlns:r="http://schemas.openxmlformats.org/officeDocument/2006/relationships" id="256" r:id="R88dad09a9a084830"/>
+    <p:sldId xmlns:r="http://schemas.openxmlformats.org/officeDocument/2006/relationships" id="257" r:id="Rcce94e4bda014717"/>
+    <p:sldId xmlns:r="http://schemas.openxmlformats.org/officeDocument/2006/relationships" id="258" r:id="R887ea07edd8d4ef7"/>
+    <p:sldId xmlns:r="http://schemas.openxmlformats.org/officeDocument/2006/relationships" id="259" r:id="R89cb7ca5718e4938"/>
+    <p:sldId xmlns:r="http://schemas.openxmlformats.org/officeDocument/2006/relationships" id="260" r:id="R1b36576034a040f3"/>
+    <p:sldId xmlns:r="http://schemas.openxmlformats.org/officeDocument/2006/relationships" id="261" r:id="Rc4e40ee398c84ddb"/>
+    <p:sldId xmlns:r="http://schemas.openxmlformats.org/officeDocument/2006/relationships" id="262" r:id="R4ea1651e865e45bc"/>
+    <p:sldId xmlns:r="http://schemas.openxmlformats.org/officeDocument/2006/relationships" id="263" r:id="R5a6e79ae6e6d4c48"/>
+    <p:sldId xmlns:r="http://schemas.openxmlformats.org/officeDocument/2006/relationships" id="264" r:id="R64955491c92f47b2"/>
+    <p:sldId xmlns:r="http://schemas.openxmlformats.org/officeDocument/2006/relationships" id="265" r:id="Ree9713eab9064472"/>
+    <p:sldId xmlns:r="http://schemas.openxmlformats.org/officeDocument/2006/relationships" id="266" r:id="Rbfe9bb008d5e4370"/>
+    <p:sldId xmlns:r="http://schemas.openxmlformats.org/officeDocument/2006/relationships" id="267" r:id="R9078ace1ec0b4c45"/>
+    <p:sldId xmlns:r="http://schemas.openxmlformats.org/officeDocument/2006/relationships" id="268" r:id="Re8a3c34bf71749ff"/>
+    <p:sldId xmlns:r="http://schemas.openxmlformats.org/officeDocument/2006/relationships" id="269" r:id="R65cfa819b5ec49f3"/>
+    <p:sldId xmlns:r="http://schemas.openxmlformats.org/officeDocument/2006/relationships" id="270" r:id="R4f75485084c54eb2"/>
   </p:sldIdLst>
   <p:sldSz cx="12192000" cy="6858000"/>
   <p:notesSz cx="6858000" cy="9144000"/>
@@ -459,7 +461,7 @@
           </a:p>
           <a:p xmlns:a="http://schemas.openxmlformats.org/drawingml/2006/main">
             <a:r>
-              <a:t>A guide to skill version 1.2.0, checked 12 September 2026. The AI needs local file access and the candidate’s real answers.</a:t>
+              <a:t>A guide to skill version 1.3.0, checked 12 September 2026. The AI needs local file access and the candidate’s real answers.</a:t>
             </a:r>
           </a:p>
         </p:txBody>
@@ -529,7 +531,12 @@
           <a:lstStyle xmlns:a="http://schemas.openxmlformats.org/drawingml/2006/main"/>
           <a:p xmlns:a="http://schemas.openxmlformats.org/drawingml/2006/main">
             <a:r>
-              <a:t/>
+              <a:t>Scheduling sources: https://learn.chatgpt.com/docs/automations</a:t>
+            </a:r>
+          </a:p>
+          <a:p xmlns:a="http://schemas.openxmlformats.org/drawingml/2006/main">
+            <a:r>
+              <a:t>https://code.claude.com/docs/en/desktop-scheduled-tasks</a:t>
             </a:r>
           </a:p>
           <a:p xmlns:a="http://schemas.openxmlformats.org/drawingml/2006/main">
@@ -609,12 +616,17 @@
           <a:lstStyle xmlns:a="http://schemas.openxmlformats.org/drawingml/2006/main"/>
           <a:p xmlns:a="http://schemas.openxmlformats.org/drawingml/2006/main">
             <a:r>
-              <a:t>Official invocation sources: https://learn.chatgpt.com/docs/build-skills#how-chatgpt-and-codex-use-skills</a:t>
-            </a:r>
-          </a:p>
-          <a:p xmlns:a="http://schemas.openxmlformats.org/drawingml/2006/main">
-            <a:r>
-              <a:t>https://code.claude.com/docs/en/skills</a:t>
+              <a:t>Scheduling sources: https://learn.chatgpt.com/docs/automations</a:t>
+            </a:r>
+          </a:p>
+          <a:p xmlns:a="http://schemas.openxmlformats.org/drawingml/2006/main">
+            <a:r>
+              <a:t>https://code.claude.com/docs/en/desktop-scheduled-tasks</a:t>
+            </a:r>
+          </a:p>
+          <a:p xmlns:a="http://schemas.openxmlformats.org/drawingml/2006/main">
+            <a:r>
+              <a:t>https://code.claude.com/docs/en/scheduled-tasks</a:t>
             </a:r>
           </a:p>
           <a:p xmlns:a="http://schemas.openxmlformats.org/drawingml/2006/main">
@@ -735,6 +747,171 @@
 </file>
 
 <file path=ppt/notesSlides/notesSlide13.xml><?xml version="1.0" encoding="utf-8"?>
+<p:notes xmlns:p="http://schemas.openxmlformats.org/presentationml/2006/main">
+  <p:cSld>
+    <p:spTree>
+      <p:nvGrpSpPr>
+        <p:cNvPr id="1" name=""/>
+        <p:cNvGrpSpPr/>
+        <p:nvPr/>
+      </p:nvGrpSpPr>
+      <p:grpSpPr>
+        <a:xfrm xmlns:a="http://schemas.openxmlformats.org/drawingml/2006/main"/>
+      </p:grpSpPr>
+      <p:sp>
+        <p:nvSpPr>
+          <p:cNvPr id="2" name="Slide Image Placeholder 1"/>
+          <p:cNvSpPr>
+            <a:spLocks xmlns:a="http://schemas.openxmlformats.org/drawingml/2006/main" noGrp="1"/>
+          </p:cNvSpPr>
+          <p:nvPr>
+            <p:ph type="sldImg" idx="0"/>
+          </p:nvPr>
+        </p:nvSpPr>
+        <p:spPr/>
+      </p:sp>
+      <p:sp>
+        <p:nvSpPr>
+          <p:cNvPr id="3" name="Notes Placeholder 2"/>
+          <p:cNvSpPr>
+            <a:spLocks xmlns:a="http://schemas.openxmlformats.org/drawingml/2006/main" noGrp="1"/>
+          </p:cNvSpPr>
+          <p:nvPr>
+            <p:ph type="body" idx="1"/>
+          </p:nvPr>
+        </p:nvSpPr>
+        <p:spPr/>
+        <p:txBody>
+          <a:bodyPr xmlns:a="http://schemas.openxmlformats.org/drawingml/2006/main"/>
+          <a:lstStyle xmlns:a="http://schemas.openxmlformats.org/drawingml/2006/main"/>
+          <a:p xmlns:a="http://schemas.openxmlformats.org/drawingml/2006/main">
+            <a:r>
+              <a:t>Official invocation sources: https://learn.chatgpt.com/docs/build-skills#how-chatgpt-and-codex-use-skills</a:t>
+            </a:r>
+          </a:p>
+          <a:p xmlns:a="http://schemas.openxmlformats.org/drawingml/2006/main">
+            <a:r>
+              <a:t>https://code.claude.com/docs/en/skills</a:t>
+            </a:r>
+          </a:p>
+          <a:p xmlns:a="http://schemas.openxmlformats.org/drawingml/2006/main">
+            <a:r>
+              <a:t>Workflow source: https://github.com/toughdave/job-search</a:t>
+            </a:r>
+          </a:p>
+          <a:p xmlns:a="http://schemas.openxmlformats.org/drawingml/2006/main">
+            <a:r>
+              <a:t>Guide checked 12 September 2026.</a:t>
+            </a:r>
+          </a:p>
+        </p:txBody>
+      </p:sp>
+      <p:sp>
+        <p:nvSpPr>
+          <p:cNvPr id="4" name="Slide Number Placeholder 3"/>
+          <p:cNvSpPr>
+            <a:spLocks xmlns:a="http://schemas.openxmlformats.org/drawingml/2006/main" noGrp="1"/>
+          </p:cNvSpPr>
+          <p:nvPr>
+            <p:ph type="sldNum" idx="5"/>
+          </p:nvPr>
+        </p:nvSpPr>
+        <p:spPr/>
+        <p:txBody>
+          <a:bodyPr xmlns:a="http://schemas.openxmlformats.org/drawingml/2006/main"/>
+          <a:lstStyle xmlns:a="http://schemas.openxmlformats.org/drawingml/2006/main"/>
+          <a:p xmlns:a="http://schemas.openxmlformats.org/drawingml/2006/main"/>
+        </p:txBody>
+      </p:sp>
+    </p:spTree>
+  </p:cSld>
+  <p:clrMapOvr>
+    <a:masterClrMapping xmlns:a="http://schemas.openxmlformats.org/drawingml/2006/main"/>
+  </p:clrMapOvr>
+</p:notes>
+</file>
+
+<file path=ppt/notesSlides/notesSlide14.xml><?xml version="1.0" encoding="utf-8"?>
+<p:notes xmlns:p="http://schemas.openxmlformats.org/presentationml/2006/main">
+  <p:cSld>
+    <p:spTree>
+      <p:nvGrpSpPr>
+        <p:cNvPr id="1" name=""/>
+        <p:cNvGrpSpPr/>
+        <p:nvPr/>
+      </p:nvGrpSpPr>
+      <p:grpSpPr>
+        <a:xfrm xmlns:a="http://schemas.openxmlformats.org/drawingml/2006/main"/>
+      </p:grpSpPr>
+      <p:sp>
+        <p:nvSpPr>
+          <p:cNvPr id="2" name="Slide Image Placeholder 1"/>
+          <p:cNvSpPr>
+            <a:spLocks xmlns:a="http://schemas.openxmlformats.org/drawingml/2006/main" noGrp="1"/>
+          </p:cNvSpPr>
+          <p:nvPr>
+            <p:ph type="sldImg" idx="0"/>
+          </p:nvPr>
+        </p:nvSpPr>
+        <p:spPr/>
+      </p:sp>
+      <p:sp>
+        <p:nvSpPr>
+          <p:cNvPr id="3" name="Notes Placeholder 2"/>
+          <p:cNvSpPr>
+            <a:spLocks xmlns:a="http://schemas.openxmlformats.org/drawingml/2006/main" noGrp="1"/>
+          </p:cNvSpPr>
+          <p:nvPr>
+            <p:ph type="body" idx="1"/>
+          </p:nvPr>
+        </p:nvSpPr>
+        <p:spPr/>
+        <p:txBody>
+          <a:bodyPr xmlns:a="http://schemas.openxmlformats.org/drawingml/2006/main"/>
+          <a:lstStyle xmlns:a="http://schemas.openxmlformats.org/drawingml/2006/main"/>
+          <a:p xmlns:a="http://schemas.openxmlformats.org/drawingml/2006/main">
+            <a:r>
+              <a:t/>
+            </a:r>
+          </a:p>
+          <a:p xmlns:a="http://schemas.openxmlformats.org/drawingml/2006/main">
+            <a:r>
+              <a:t>Workflow source: https://github.com/toughdave/job-search</a:t>
+            </a:r>
+          </a:p>
+          <a:p xmlns:a="http://schemas.openxmlformats.org/drawingml/2006/main">
+            <a:r>
+              <a:t>Guide checked 12 September 2026.</a:t>
+            </a:r>
+          </a:p>
+        </p:txBody>
+      </p:sp>
+      <p:sp>
+        <p:nvSpPr>
+          <p:cNvPr id="4" name="Slide Number Placeholder 3"/>
+          <p:cNvSpPr>
+            <a:spLocks xmlns:a="http://schemas.openxmlformats.org/drawingml/2006/main" noGrp="1"/>
+          </p:cNvSpPr>
+          <p:nvPr>
+            <p:ph type="sldNum" idx="5"/>
+          </p:nvPr>
+        </p:nvSpPr>
+        <p:spPr/>
+        <p:txBody>
+          <a:bodyPr xmlns:a="http://schemas.openxmlformats.org/drawingml/2006/main"/>
+          <a:lstStyle xmlns:a="http://schemas.openxmlformats.org/drawingml/2006/main"/>
+          <a:p xmlns:a="http://schemas.openxmlformats.org/drawingml/2006/main"/>
+        </p:txBody>
+      </p:sp>
+    </p:spTree>
+  </p:cSld>
+  <p:clrMapOvr>
+    <a:masterClrMapping xmlns:a="http://schemas.openxmlformats.org/drawingml/2006/main"/>
+  </p:clrMapOvr>
+</p:notes>
+</file>
+
+<file path=ppt/notesSlides/notesSlide15.xml><?xml version="1.0" encoding="utf-8"?>
 <p:notes xmlns:p="http://schemas.openxmlformats.org/presentationml/2006/main">
   <p:cSld>
     <p:spTree>
@@ -1522,7 +1699,7 @@
   </p:cSld>
   <p:clrMap bg1="lt1" tx1="dk1" bg2="lt2" tx2="dk2" accent1="accent1" accent2="accent2" accent3="accent3" accent4="accent4" accent5="accent5" accent6="accent6" hlink="hlink" folHlink="folHlink"/>
   <p:sldLayoutIdLst>
-    <p:sldLayoutId xmlns:r="http://schemas.openxmlformats.org/officeDocument/2006/relationships" id="2147483649" r:id="R776779b3218e416c"/>
+    <p:sldLayoutId xmlns:r="http://schemas.openxmlformats.org/officeDocument/2006/relationships" id="2147483649" r:id="R2a9afcc6f4a3403d"/>
   </p:sldLayoutIdLst>
   <p:txStyles>
     <p:titleStyle>
@@ -2073,7 +2250,7 @@
           <p:cNvPr id="5" name="">
             <a:extLst xmlns:a="http://schemas.openxmlformats.org/drawingml/2006/main">
               <a:ext uri="{FF2B5EF4-FFF2-40B4-BE49-F238E27FC236}">
-                <a16:creationId xmlns:a16="http://schemas.microsoft.com/office/drawing/2014/main" id="{1161B0DB-776F-4D3A-96D7-034C549A78BF}"/>
+                <a16:creationId xmlns:a16="http://schemas.microsoft.com/office/drawing/2014/main" id="{02F19EB6-3023-4C48-AA62-A2CD0F63DD3C}"/>
               </a:ext>
             </a:extLst>
           </p:cNvPr>
@@ -2130,7 +2307,7 @@
           <p:cNvPr id="2" name="">
             <a:extLst xmlns:a="http://schemas.openxmlformats.org/drawingml/2006/main">
               <a:ext uri="{FF2B5EF4-FFF2-40B4-BE49-F238E27FC236}">
-                <a16:creationId xmlns:a16="http://schemas.microsoft.com/office/drawing/2014/main" id="{6900462A-4D89-4F27-B195-4270CF31E76B}"/>
+                <a16:creationId xmlns:a16="http://schemas.microsoft.com/office/drawing/2014/main" id="{4FBBA667-9C2F-4322-B77B-51F56D1A6A45}"/>
               </a:ext>
             </a:extLst>
           </p:cNvPr>
@@ -2187,7 +2364,7 @@
           <p:cNvPr id="3" name="">
             <a:extLst xmlns:a="http://schemas.openxmlformats.org/drawingml/2006/main">
               <a:ext uri="{FF2B5EF4-FFF2-40B4-BE49-F238E27FC236}">
-                <a16:creationId xmlns:a16="http://schemas.microsoft.com/office/drawing/2014/main" id="{8B71851B-9003-4160-8D03-B80A68B76D5C}"/>
+                <a16:creationId xmlns:a16="http://schemas.microsoft.com/office/drawing/2014/main" id="{926AFEF0-0EF1-4B51-A861-C249D2728DCB}"/>
               </a:ext>
             </a:extLst>
           </p:cNvPr>
@@ -2267,7 +2444,7 @@
           <p:cNvPr id="4" name="">
             <a:extLst xmlns:a="http://schemas.openxmlformats.org/drawingml/2006/main">
               <a:ext uri="{FF2B5EF4-FFF2-40B4-BE49-F238E27FC236}">
-                <a16:creationId xmlns:a16="http://schemas.microsoft.com/office/drawing/2014/main" id="{DFFC0449-964D-41F2-A6A1-23F531856D4A}"/>
+                <a16:creationId xmlns:a16="http://schemas.microsoft.com/office/drawing/2014/main" id="{DFF1CED1-88CC-4647-80CC-DBD6E632885A}"/>
               </a:ext>
             </a:extLst>
           </p:cNvPr>
@@ -2313,7 +2490,7 @@
                 <a:latin typeface="Arial"/>
                 <a:ea typeface="Arial"/>
                 <a:cs typeface="Arial"/>
-                <a:hlinkClick xmlns:r="http://schemas.openxmlformats.org/officeDocument/2006/relationships" r:id="R78067816ae794875"/>
+                <a:hlinkClick xmlns:r="http://schemas.openxmlformats.org/officeDocument/2006/relationships" r:id="R2b621cd4bafa4a1c"/>
               </a:rPr>
               <a:t>Open the GitHub guide</a:t>
             </a:r>
@@ -2323,7 +2500,7 @@
     </p:spTree>
     <p:extLst>
       <p:ext uri="{BB962C8B-B14F-4D97-AF65-F5344CB8AC3E}">
-        <p14:creationId xmlns:p14="http://schemas.microsoft.com/office/powerpoint/2010/main" val="840131286"/>
+        <p14:creationId xmlns:p14="http://schemas.microsoft.com/office/powerpoint/2010/main" val="656525787"/>
       </p:ext>
     </p:extLst>
   </p:cSld>
@@ -2354,7 +2531,7 @@
           <p:cNvPr id="7" name="">
             <a:extLst xmlns:a="http://schemas.openxmlformats.org/drawingml/2006/main">
               <a:ext uri="{FF2B5EF4-FFF2-40B4-BE49-F238E27FC236}">
-                <a16:creationId xmlns:a16="http://schemas.microsoft.com/office/drawing/2014/main" id="{C2735F4D-9D93-45D0-A95C-A83DDDCF3CFC}"/>
+                <a16:creationId xmlns:a16="http://schemas.microsoft.com/office/drawing/2014/main" id="{29BE425E-C784-42B3-9398-58A16CFDE0FE}"/>
               </a:ext>
             </a:extLst>
           </p:cNvPr>
@@ -2401,7 +2578,7 @@
                 <a:ea typeface="Arial"/>
                 <a:cs typeface="Arial"/>
               </a:rPr>
-              <a:t>5. Your first draft</a:t>
+              <a:t>Your weekday morning search</a:t>
             </a:r>
           </a:p>
         </p:txBody>
@@ -2411,7 +2588,7 @@
           <p:cNvPr id="2" name="">
             <a:extLst xmlns:a="http://schemas.openxmlformats.org/drawingml/2006/main">
               <a:ext uri="{FF2B5EF4-FFF2-40B4-BE49-F238E27FC236}">
-                <a16:creationId xmlns:a16="http://schemas.microsoft.com/office/drawing/2014/main" id="{90536DA7-8774-40F7-A231-EE3F0676D5C0}"/>
+                <a16:creationId xmlns:a16="http://schemas.microsoft.com/office/drawing/2014/main" id="{1BFF10B8-0A11-4E69-9DAC-222B996B0FEA}"/>
               </a:ext>
             </a:extLst>
           </p:cNvPr>
@@ -2468,19 +2645,19 @@
           <p:cNvPr id="3" name="">
             <a:extLst xmlns:a="http://schemas.openxmlformats.org/drawingml/2006/main">
               <a:ext uri="{FF2B5EF4-FFF2-40B4-BE49-F238E27FC236}">
-                <a16:creationId xmlns:a16="http://schemas.microsoft.com/office/drawing/2014/main" id="{5BE65806-57F1-4E7C-A88B-9048A8344DD4}"/>
-              </a:ext>
-            </a:extLst>
-          </p:cNvPr>
-          <p:cNvSpPr>
-            <a:spLocks xmlns:a="http://schemas.openxmlformats.org/drawingml/2006/main" noGrp="1"/>
-          </p:cNvSpPr>
-          <p:nvPr/>
-        </p:nvSpPr>
-        <p:spPr>
-          <a:xfrm xmlns:a="http://schemas.openxmlformats.org/drawingml/2006/main">
-            <a:off x="609600" y="1476375"/>
-            <a:ext cx="10820400" cy="1019175"/>
+                <a16:creationId xmlns:a16="http://schemas.microsoft.com/office/drawing/2014/main" id="{7268FA7A-571C-43BB-8638-B04754BA5CF4}"/>
+              </a:ext>
+            </a:extLst>
+          </p:cNvPr>
+          <p:cNvSpPr>
+            <a:spLocks xmlns:a="http://schemas.openxmlformats.org/drawingml/2006/main" noGrp="1"/>
+          </p:cNvSpPr>
+          <p:nvPr/>
+        </p:nvSpPr>
+        <p:spPr>
+          <a:xfrm xmlns:a="http://schemas.openxmlformats.org/drawingml/2006/main">
+            <a:off x="609600" y="1504950"/>
+            <a:ext cx="10820400" cy="685800"/>
           </a:xfrm>
           <a:prstGeom xmlns:a="http://schemas.openxmlformats.org/drawingml/2006/main" prst="rect">
             <a:avLst/>
@@ -2515,9 +2692,43 @@
                 <a:ea typeface="Arial"/>
                 <a:cs typeface="Arial"/>
               </a:rPr>
-              <a:t>When enough is known, the AI prepares useful documents</a:t>
-            </a:r>
-          </a:p>
+              <a:t>a. Review the job titles and search sites the AI suggests.</a:t>
+            </a:r>
+          </a:p>
+        </p:txBody>
+      </p:sp>
+      <p:sp>
+        <p:nvSpPr>
+          <p:cNvPr id="4" name="">
+            <a:extLst xmlns:a="http://schemas.openxmlformats.org/drawingml/2006/main">
+              <a:ext uri="{FF2B5EF4-FFF2-40B4-BE49-F238E27FC236}">
+                <a16:creationId xmlns:a16="http://schemas.microsoft.com/office/drawing/2014/main" id="{DC3A586F-7ACF-45C6-BCA4-A879BA945DBE}"/>
+              </a:ext>
+            </a:extLst>
+          </p:cNvPr>
+          <p:cNvSpPr>
+            <a:spLocks xmlns:a="http://schemas.openxmlformats.org/drawingml/2006/main" noGrp="1"/>
+          </p:cNvSpPr>
+          <p:nvPr/>
+        </p:nvSpPr>
+        <p:spPr>
+          <a:xfrm xmlns:a="http://schemas.openxmlformats.org/drawingml/2006/main">
+            <a:off x="609600" y="2571750"/>
+            <a:ext cx="10820400" cy="1047750"/>
+          </a:xfrm>
+          <a:prstGeom xmlns:a="http://schemas.openxmlformats.org/drawingml/2006/main" prst="rect">
+            <a:avLst/>
+          </a:prstGeom>
+          <a:noFill xmlns:a="http://schemas.openxmlformats.org/drawingml/2006/main"/>
+          <a:ln xmlns:a="http://schemas.openxmlformats.org/drawingml/2006/main" w="0">
+            <a:noFill/>
+          </a:ln>
+        </p:spPr>
+        <p:txBody>
+          <a:bodyPr xmlns:a="http://schemas.openxmlformats.org/drawingml/2006/main">
+            <a:noAutofit/>
+          </a:bodyPr>
+          <a:lstStyle xmlns:a="http://schemas.openxmlformats.org/drawingml/2006/main"/>
           <a:p xmlns:a="http://schemas.openxmlformats.org/drawingml/2006/main">
             <a:pPr>
               <a:defRPr sz="2250" b="0">
@@ -2538,43 +2749,9 @@
                 <a:ea typeface="Arial"/>
                 <a:cs typeface="Arial"/>
               </a:rPr>
-              <a:t>and keeps your search records in a separate private location.</a:t>
-            </a:r>
-          </a:p>
-        </p:txBody>
-      </p:sp>
-      <p:sp>
-        <p:nvSpPr>
-          <p:cNvPr id="4" name="">
-            <a:extLst xmlns:a="http://schemas.openxmlformats.org/drawingml/2006/main">
-              <a:ext uri="{FF2B5EF4-FFF2-40B4-BE49-F238E27FC236}">
-                <a16:creationId xmlns:a16="http://schemas.microsoft.com/office/drawing/2014/main" id="{44B9C5DA-B21D-4B08-95EF-8B77F82AEF1E}"/>
-              </a:ext>
-            </a:extLst>
-          </p:cNvPr>
-          <p:cNvSpPr>
-            <a:spLocks xmlns:a="http://schemas.openxmlformats.org/drawingml/2006/main" noGrp="1"/>
-          </p:cNvSpPr>
-          <p:nvPr/>
-        </p:nvSpPr>
-        <p:spPr>
-          <a:xfrm xmlns:a="http://schemas.openxmlformats.org/drawingml/2006/main">
-            <a:off x="609600" y="3162300"/>
-            <a:ext cx="10820400" cy="1009650"/>
-          </a:xfrm>
-          <a:prstGeom xmlns:a="http://schemas.openxmlformats.org/drawingml/2006/main" prst="rect">
-            <a:avLst/>
-          </a:prstGeom>
-          <a:noFill xmlns:a="http://schemas.openxmlformats.org/drawingml/2006/main"/>
-          <a:ln xmlns:a="http://schemas.openxmlformats.org/drawingml/2006/main" w="0">
-            <a:noFill/>
-          </a:ln>
-        </p:spPr>
-        <p:txBody>
-          <a:bodyPr xmlns:a="http://schemas.openxmlformats.org/drawingml/2006/main">
-            <a:noAutofit/>
-          </a:bodyPr>
-          <a:lstStyle xmlns:a="http://schemas.openxmlformats.org/drawingml/2006/main"/>
+              <a:t>b. Choose a schedule. The starting suggestion is</a:t>
+            </a:r>
+          </a:p>
           <a:p xmlns:a="http://schemas.openxmlformats.org/drawingml/2006/main">
             <a:pPr>
               <a:defRPr sz="2250" b="0">
@@ -2595,9 +2772,43 @@
                 <a:ea typeface="Arial"/>
                 <a:cs typeface="Arial"/>
               </a:rPr>
-              <a:t>Open the files and check your experience, dates and contact details.</a:t>
-            </a:r>
-          </a:p>
+              <a:t>    weekdays at 9 a.m. in your confirmed timezone.</a:t>
+            </a:r>
+          </a:p>
+        </p:txBody>
+      </p:sp>
+      <p:sp>
+        <p:nvSpPr>
+          <p:cNvPr id="5" name="">
+            <a:extLst xmlns:a="http://schemas.openxmlformats.org/drawingml/2006/main">
+              <a:ext uri="{FF2B5EF4-FFF2-40B4-BE49-F238E27FC236}">
+                <a16:creationId xmlns:a16="http://schemas.microsoft.com/office/drawing/2014/main" id="{D6871139-C802-4362-8264-7559AE73A17A}"/>
+              </a:ext>
+            </a:extLst>
+          </p:cNvPr>
+          <p:cNvSpPr>
+            <a:spLocks xmlns:a="http://schemas.openxmlformats.org/drawingml/2006/main" noGrp="1"/>
+          </p:cNvSpPr>
+          <p:nvPr/>
+        </p:nvSpPr>
+        <p:spPr>
+          <a:xfrm xmlns:a="http://schemas.openxmlformats.org/drawingml/2006/main">
+            <a:off x="609600" y="4114800"/>
+            <a:ext cx="10820400" cy="1047750"/>
+          </a:xfrm>
+          <a:prstGeom xmlns:a="http://schemas.openxmlformats.org/drawingml/2006/main" prst="rect">
+            <a:avLst/>
+          </a:prstGeom>
+          <a:noFill xmlns:a="http://schemas.openxmlformats.org/drawingml/2006/main"/>
+          <a:ln xmlns:a="http://schemas.openxmlformats.org/drawingml/2006/main" w="0">
+            <a:noFill/>
+          </a:ln>
+        </p:spPr>
+        <p:txBody>
+          <a:bodyPr xmlns:a="http://schemas.openxmlformats.org/drawingml/2006/main">
+            <a:noAutofit/>
+          </a:bodyPr>
+          <a:lstStyle xmlns:a="http://schemas.openxmlformats.org/drawingml/2006/main"/>
           <a:p xmlns:a="http://schemas.openxmlformats.org/drawingml/2006/main">
             <a:pPr>
               <a:defRPr sz="2250" b="0">
@@ -2618,64 +2829,30 @@
                 <a:ea typeface="Arial"/>
                 <a:cs typeface="Arial"/>
               </a:rPr>
-              <a:t>Give corrections in the conversation.</a:t>
-            </a:r>
-          </a:p>
-        </p:txBody>
-      </p:sp>
-      <p:sp>
-        <p:nvSpPr>
-          <p:cNvPr id="5" name="">
-            <a:extLst xmlns:a="http://schemas.openxmlformats.org/drawingml/2006/main">
-              <a:ext uri="{FF2B5EF4-FFF2-40B4-BE49-F238E27FC236}">
-                <a16:creationId xmlns:a16="http://schemas.microsoft.com/office/drawing/2014/main" id="{6664D170-F928-450D-90F1-5BD4D470B46F}"/>
-              </a:ext>
-            </a:extLst>
-          </p:cNvPr>
-          <p:cNvSpPr>
-            <a:spLocks xmlns:a="http://schemas.openxmlformats.org/drawingml/2006/main" noGrp="1"/>
-          </p:cNvSpPr>
-          <p:nvPr/>
-        </p:nvSpPr>
-        <p:spPr>
-          <a:xfrm xmlns:a="http://schemas.openxmlformats.org/drawingml/2006/main">
-            <a:off x="609600" y="4714875"/>
-            <a:ext cx="10858500" cy="552450"/>
-          </a:xfrm>
-          <a:prstGeom xmlns:a="http://schemas.openxmlformats.org/drawingml/2006/main" prst="rect">
-            <a:avLst/>
-          </a:prstGeom>
-          <a:noFill xmlns:a="http://schemas.openxmlformats.org/drawingml/2006/main"/>
-          <a:ln xmlns:a="http://schemas.openxmlformats.org/drawingml/2006/main" w="0">
-            <a:noFill/>
-          </a:ln>
-        </p:spPr>
-        <p:txBody>
-          <a:bodyPr xmlns:a="http://schemas.openxmlformats.org/drawingml/2006/main">
-            <a:noAutofit/>
-          </a:bodyPr>
-          <a:lstStyle xmlns:a="http://schemas.openxmlformats.org/drawingml/2006/main"/>
-          <a:p xmlns:a="http://schemas.openxmlformats.org/drawingml/2006/main">
-            <a:pPr>
-              <a:defRPr sz="2550" b="1">
-                <a:solidFill>
-                  <a:srgbClr val="183F3B"/>
-                </a:solidFill>
-                <a:latin typeface="Arial"/>
-                <a:ea typeface="Arial"/>
-                <a:cs typeface="Arial"/>
-              </a:defRPr>
-            </a:pPr>
-            <a:r>
-              <a:rPr sz="2550" b="1">
-                <a:solidFill>
-                  <a:srgbClr val="183F3B"/>
-                </a:solidFill>
-                <a:latin typeface="Arial"/>
-                <a:ea typeface="Arial"/>
-                <a:cs typeface="Arial"/>
-              </a:rPr>
-              <a:t>“That role was volunteering. Please correct it.”</a:t>
+              <a:t>c. Let the AI save the instructions and set up the task.</a:t>
+            </a:r>
+          </a:p>
+          <a:p xmlns:a="http://schemas.openxmlformats.org/drawingml/2006/main">
+            <a:pPr>
+              <a:defRPr sz="2250" b="0">
+                <a:solidFill>
+                  <a:srgbClr val="283A39"/>
+                </a:solidFill>
+                <a:latin typeface="Arial"/>
+                <a:ea typeface="Arial"/>
+                <a:cs typeface="Arial"/>
+              </a:defRPr>
+            </a:pPr>
+            <a:r>
+              <a:rPr sz="2250" b="0">
+                <a:solidFill>
+                  <a:srgbClr val="283A39"/>
+                </a:solidFill>
+                <a:latin typeface="Arial"/>
+                <a:ea typeface="Arial"/>
+                <a:cs typeface="Arial"/>
+              </a:rPr>
+              <a:t>    You can change the time or keep searches manual.</a:t>
             </a:r>
           </a:p>
         </p:txBody>
@@ -2685,19 +2862,19 @@
           <p:cNvPr id="6" name="">
             <a:extLst xmlns:a="http://schemas.openxmlformats.org/drawingml/2006/main">
               <a:ext uri="{FF2B5EF4-FFF2-40B4-BE49-F238E27FC236}">
-                <a16:creationId xmlns:a16="http://schemas.microsoft.com/office/drawing/2014/main" id="{82FF4BAD-5203-41A4-84A4-B4700204EBBC}"/>
-              </a:ext>
-            </a:extLst>
-          </p:cNvPr>
-          <p:cNvSpPr>
-            <a:spLocks xmlns:a="http://schemas.openxmlformats.org/drawingml/2006/main" noGrp="1"/>
-          </p:cNvSpPr>
-          <p:nvPr/>
-        </p:nvSpPr>
-        <p:spPr>
-          <a:xfrm xmlns:a="http://schemas.openxmlformats.org/drawingml/2006/main">
-            <a:off x="609600" y="5829300"/>
-            <a:ext cx="10858500" cy="400050"/>
+                <a16:creationId xmlns:a16="http://schemas.microsoft.com/office/drawing/2014/main" id="{11DFC218-ACFA-4026-A381-AC57216729F0}"/>
+              </a:ext>
+            </a:extLst>
+          </p:cNvPr>
+          <p:cNvSpPr>
+            <a:spLocks xmlns:a="http://schemas.openxmlformats.org/drawingml/2006/main" noGrp="1"/>
+          </p:cNvSpPr>
+          <p:nvPr/>
+        </p:nvSpPr>
+        <p:spPr>
+          <a:xfrm xmlns:a="http://schemas.openxmlformats.org/drawingml/2006/main">
+            <a:off x="609600" y="5781675"/>
+            <a:ext cx="10858500" cy="495300"/>
           </a:xfrm>
           <a:prstGeom xmlns:a="http://schemas.openxmlformats.org/drawingml/2006/main" prst="rect">
             <a:avLst/>
@@ -2732,7 +2909,7 @@
                 <a:ea typeface="Arial"/>
                 <a:cs typeface="Arial"/>
               </a:rPr>
-              <a:t>Review the employer and final documents before authorizing a submission.</a:t>
+              <a:t>Keep your computer awake and the desktop app running for local searches.</a:t>
             </a:r>
           </a:p>
         </p:txBody>
@@ -2740,7 +2917,7 @@
     </p:spTree>
     <p:extLst>
       <p:ext uri="{BB962C8B-B14F-4D97-AF65-F5344CB8AC3E}">
-        <p14:creationId xmlns:p14="http://schemas.microsoft.com/office/powerpoint/2010/main" val="653133177"/>
+        <p14:creationId xmlns:p14="http://schemas.microsoft.com/office/powerpoint/2010/main" val="264956109"/>
       </p:ext>
     </p:extLst>
   </p:cSld>
@@ -2768,10 +2945,10 @@
       </p:grpSpPr>
       <p:sp>
         <p:nvSpPr>
-          <p:cNvPr id="9" name="">
-            <a:extLst xmlns:a="http://schemas.openxmlformats.org/drawingml/2006/main">
-              <a:ext uri="{FF2B5EF4-FFF2-40B4-BE49-F238E27FC236}">
-                <a16:creationId xmlns:a16="http://schemas.microsoft.com/office/drawing/2014/main" id="{169161BD-8AE9-46E2-8CC3-EFF379056029}"/>
+          <p:cNvPr id="8" name="">
+            <a:extLst xmlns:a="http://schemas.openxmlformats.org/drawingml/2006/main">
+              <a:ext uri="{FF2B5EF4-FFF2-40B4-BE49-F238E27FC236}">
+                <a16:creationId xmlns:a16="http://schemas.microsoft.com/office/drawing/2014/main" id="{C0C47EFA-C30A-4C64-A56D-BD2941DDDB13}"/>
               </a:ext>
             </a:extLst>
           </p:cNvPr>
@@ -2818,7 +2995,7 @@
                 <a:ea typeface="Arial"/>
                 <a:cs typeface="Arial"/>
               </a:rPr>
-              <a:t>Summon the installed skill</a:t>
+              <a:t>Review and change your routine</a:t>
             </a:r>
           </a:p>
         </p:txBody>
@@ -2828,7 +3005,7 @@
           <p:cNvPr id="2" name="">
             <a:extLst xmlns:a="http://schemas.openxmlformats.org/drawingml/2006/main">
               <a:ext uri="{FF2B5EF4-FFF2-40B4-BE49-F238E27FC236}">
-                <a16:creationId xmlns:a16="http://schemas.microsoft.com/office/drawing/2014/main" id="{9BF0956D-C550-4627-9279-6D7431F30A16}"/>
+                <a16:creationId xmlns:a16="http://schemas.microsoft.com/office/drawing/2014/main" id="{A01AA34D-2B12-4838-960E-53B1CDD62B65}"/>
               </a:ext>
             </a:extLst>
           </p:cNvPr>
@@ -2885,36 +3062,36 @@
           <p:cNvPr id="3" name="">
             <a:extLst xmlns:a="http://schemas.openxmlformats.org/drawingml/2006/main">
               <a:ext uri="{FF2B5EF4-FFF2-40B4-BE49-F238E27FC236}">
-                <a16:creationId xmlns:a16="http://schemas.microsoft.com/office/drawing/2014/main" id="{C52C288E-FB11-4C26-840F-F19D1B652CD7}"/>
-              </a:ext>
-            </a:extLst>
-          </p:cNvPr>
-          <p:cNvSpPr>
-            <a:spLocks xmlns:a="http://schemas.openxmlformats.org/drawingml/2006/main" noGrp="1"/>
-          </p:cNvSpPr>
-          <p:nvPr/>
-        </p:nvSpPr>
-        <p:spPr>
-          <a:xfrm xmlns:a="http://schemas.openxmlformats.org/drawingml/2006/main">
-            <a:off x="609600" y="1514475"/>
-            <a:ext cx="10839450" cy="428625"/>
-          </a:xfrm>
-          <a:prstGeom xmlns:a="http://schemas.openxmlformats.org/drawingml/2006/main" prst="rect">
-            <a:avLst/>
-          </a:prstGeom>
-          <a:noFill xmlns:a="http://schemas.openxmlformats.org/drawingml/2006/main"/>
-          <a:ln xmlns:a="http://schemas.openxmlformats.org/drawingml/2006/main" w="0">
-            <a:noFill/>
-          </a:ln>
-        </p:spPr>
-        <p:txBody>
-          <a:bodyPr xmlns:a="http://schemas.openxmlformats.org/drawingml/2006/main">
-            <a:noAutofit/>
-          </a:bodyPr>
-          <a:lstStyle xmlns:a="http://schemas.openxmlformats.org/drawingml/2006/main"/>
-          <a:p xmlns:a="http://schemas.openxmlformats.org/drawingml/2006/main">
-            <a:pPr>
-              <a:defRPr sz="2250" b="1">
+                <a16:creationId xmlns:a16="http://schemas.microsoft.com/office/drawing/2014/main" id="{B650DF74-6BC6-49DD-A60E-59A1BE6EDF07}"/>
+              </a:ext>
+            </a:extLst>
+          </p:cNvPr>
+          <p:cNvSpPr>
+            <a:spLocks xmlns:a="http://schemas.openxmlformats.org/drawingml/2006/main" noGrp="1"/>
+          </p:cNvSpPr>
+          <p:nvPr/>
+        </p:nvSpPr>
+        <p:spPr>
+          <a:xfrm xmlns:a="http://schemas.openxmlformats.org/drawingml/2006/main">
+            <a:off x="609600" y="1504950"/>
+            <a:ext cx="10839450" cy="457200"/>
+          </a:xfrm>
+          <a:prstGeom xmlns:a="http://schemas.openxmlformats.org/drawingml/2006/main" prst="rect">
+            <a:avLst/>
+          </a:prstGeom>
+          <a:noFill xmlns:a="http://schemas.openxmlformats.org/drawingml/2006/main"/>
+          <a:ln xmlns:a="http://schemas.openxmlformats.org/drawingml/2006/main" w="0">
+            <a:noFill/>
+          </a:ln>
+        </p:spPr>
+        <p:txBody>
+          <a:bodyPr xmlns:a="http://schemas.openxmlformats.org/drawingml/2006/main">
+            <a:noAutofit/>
+          </a:bodyPr>
+          <a:lstStyle xmlns:a="http://schemas.openxmlformats.org/drawingml/2006/main"/>
+          <a:p xmlns:a="http://schemas.openxmlformats.org/drawingml/2006/main">
+            <a:pPr>
+              <a:defRPr sz="2400" b="1">
                 <a:solidFill>
                   <a:srgbClr val="183F3B"/>
                 </a:solidFill>
@@ -2924,7 +3101,7 @@
               </a:defRPr>
             </a:pPr>
             <a:r>
-              <a:rPr sz="2250" b="1">
+              <a:rPr sz="2400" b="1">
                 <a:solidFill>
                   <a:srgbClr val="183F3B"/>
                 </a:solidFill>
@@ -2932,7 +3109,7 @@
                 <a:ea typeface="Arial"/>
                 <a:cs typeface="Arial"/>
               </a:rPr>
-              <a:t>Codex / ChatGPT desktop</a:t>
+              <a:t>Codex desktop: Scheduled</a:t>
             </a:r>
           </a:p>
         </p:txBody>
@@ -2942,77 +3119,54 @@
           <p:cNvPr id="4" name="">
             <a:extLst xmlns:a="http://schemas.openxmlformats.org/drawingml/2006/main">
               <a:ext uri="{FF2B5EF4-FFF2-40B4-BE49-F238E27FC236}">
-                <a16:creationId xmlns:a16="http://schemas.microsoft.com/office/drawing/2014/main" id="{DEDB0FC7-C28A-4BE3-9D7A-2922828705AF}"/>
-              </a:ext>
-            </a:extLst>
-          </p:cNvPr>
-          <p:cNvSpPr>
-            <a:spLocks xmlns:a="http://schemas.openxmlformats.org/drawingml/2006/main" noGrp="1"/>
-          </p:cNvSpPr>
-          <p:nvPr/>
-        </p:nvSpPr>
-        <p:spPr>
-          <a:xfrm xmlns:a="http://schemas.openxmlformats.org/drawingml/2006/main">
-            <a:off x="609600" y="2047875"/>
-            <a:ext cx="10839450" cy="866775"/>
-          </a:xfrm>
-          <a:prstGeom xmlns:a="http://schemas.openxmlformats.org/drawingml/2006/main" prst="rect">
-            <a:avLst/>
-          </a:prstGeom>
-          <a:noFill xmlns:a="http://schemas.openxmlformats.org/drawingml/2006/main"/>
-          <a:ln xmlns:a="http://schemas.openxmlformats.org/drawingml/2006/main" w="0">
-            <a:noFill/>
-          </a:ln>
-        </p:spPr>
-        <p:txBody>
-          <a:bodyPr xmlns:a="http://schemas.openxmlformats.org/drawingml/2006/main">
-            <a:noAutofit/>
-          </a:bodyPr>
-          <a:lstStyle xmlns:a="http://schemas.openxmlformats.org/drawingml/2006/main"/>
-          <a:p xmlns:a="http://schemas.openxmlformats.org/drawingml/2006/main">
-            <a:pPr>
-              <a:defRPr sz="2100" b="0">
-                <a:solidFill>
-                  <a:srgbClr val="283A39"/>
-                </a:solidFill>
-                <a:latin typeface="Arial"/>
-                <a:ea typeface="Arial"/>
-                <a:cs typeface="Arial"/>
-              </a:defRPr>
-            </a:pPr>
-            <a:r>
-              <a:rPr sz="2100" b="0">
-                <a:solidFill>
-                  <a:srgbClr val="283A39"/>
-                </a:solidFill>
-                <a:latin typeface="Arial"/>
-                <a:ea typeface="Arial"/>
-                <a:cs typeface="Arial"/>
-              </a:rPr>
-              <a:t>Type @ and choose job-search. If your composer offers a $</a:t>
-            </a:r>
-          </a:p>
-          <a:p xmlns:a="http://schemas.openxmlformats.org/drawingml/2006/main">
-            <a:pPr>
-              <a:defRPr sz="2100" b="0">
-                <a:solidFill>
-                  <a:srgbClr val="283A39"/>
-                </a:solidFill>
-                <a:latin typeface="Arial"/>
-                <a:ea typeface="Arial"/>
-                <a:cs typeface="Arial"/>
-              </a:defRPr>
-            </a:pPr>
-            <a:r>
-              <a:rPr sz="2100" b="0">
-                <a:solidFill>
-                  <a:srgbClr val="283A39"/>
-                </a:solidFill>
-                <a:latin typeface="Arial"/>
-                <a:ea typeface="Arial"/>
-                <a:cs typeface="Arial"/>
-              </a:rPr>
-              <a:t>skill picker, choose job-search there.</a:t>
+                <a16:creationId xmlns:a16="http://schemas.microsoft.com/office/drawing/2014/main" id="{F2CA4C90-52B3-466A-9899-BDD440C153AF}"/>
+              </a:ext>
+            </a:extLst>
+          </p:cNvPr>
+          <p:cNvSpPr>
+            <a:spLocks xmlns:a="http://schemas.openxmlformats.org/drawingml/2006/main" noGrp="1"/>
+          </p:cNvSpPr>
+          <p:nvPr/>
+        </p:nvSpPr>
+        <p:spPr>
+          <a:xfrm xmlns:a="http://schemas.openxmlformats.org/drawingml/2006/main">
+            <a:off x="609600" y="2257425"/>
+            <a:ext cx="10839450" cy="457200"/>
+          </a:xfrm>
+          <a:prstGeom xmlns:a="http://schemas.openxmlformats.org/drawingml/2006/main" prst="rect">
+            <a:avLst/>
+          </a:prstGeom>
+          <a:noFill xmlns:a="http://schemas.openxmlformats.org/drawingml/2006/main"/>
+          <a:ln xmlns:a="http://schemas.openxmlformats.org/drawingml/2006/main" w="0">
+            <a:noFill/>
+          </a:ln>
+        </p:spPr>
+        <p:txBody>
+          <a:bodyPr xmlns:a="http://schemas.openxmlformats.org/drawingml/2006/main">
+            <a:noAutofit/>
+          </a:bodyPr>
+          <a:lstStyle xmlns:a="http://schemas.openxmlformats.org/drawingml/2006/main"/>
+          <a:p xmlns:a="http://schemas.openxmlformats.org/drawingml/2006/main">
+            <a:pPr>
+              <a:defRPr sz="2400" b="1">
+                <a:solidFill>
+                  <a:srgbClr val="183F3B"/>
+                </a:solidFill>
+                <a:latin typeface="Arial"/>
+                <a:ea typeface="Arial"/>
+                <a:cs typeface="Arial"/>
+              </a:defRPr>
+            </a:pPr>
+            <a:r>
+              <a:rPr sz="2400" b="1">
+                <a:solidFill>
+                  <a:srgbClr val="183F3B"/>
+                </a:solidFill>
+                <a:latin typeface="Arial"/>
+                <a:ea typeface="Arial"/>
+                <a:cs typeface="Arial"/>
+              </a:rPr>
+              <a:t>Claude Code Desktop: Code → Routines</a:t>
             </a:r>
           </a:p>
         </p:txBody>
@@ -3022,19 +3176,99 @@
           <p:cNvPr id="5" name="">
             <a:extLst xmlns:a="http://schemas.openxmlformats.org/drawingml/2006/main">
               <a:ext uri="{FF2B5EF4-FFF2-40B4-BE49-F238E27FC236}">
-                <a16:creationId xmlns:a16="http://schemas.microsoft.com/office/drawing/2014/main" id="{CD2ACAD1-93DE-421C-AF8B-CD06CA8CB196}"/>
-              </a:ext>
-            </a:extLst>
-          </p:cNvPr>
-          <p:cNvSpPr>
-            <a:spLocks xmlns:a="http://schemas.openxmlformats.org/drawingml/2006/main" noGrp="1"/>
-          </p:cNvSpPr>
-          <p:nvPr/>
-        </p:nvSpPr>
-        <p:spPr>
-          <a:xfrm xmlns:a="http://schemas.openxmlformats.org/drawingml/2006/main">
-            <a:off x="609600" y="3276600"/>
-            <a:ext cx="10839450" cy="476250"/>
+                <a16:creationId xmlns:a16="http://schemas.microsoft.com/office/drawing/2014/main" id="{DC5D503E-897D-46BA-A7D7-FF52891323A8}"/>
+              </a:ext>
+            </a:extLst>
+          </p:cNvPr>
+          <p:cNvSpPr>
+            <a:spLocks xmlns:a="http://schemas.openxmlformats.org/drawingml/2006/main" noGrp="1"/>
+          </p:cNvSpPr>
+          <p:nvPr/>
+        </p:nvSpPr>
+        <p:spPr>
+          <a:xfrm xmlns:a="http://schemas.openxmlformats.org/drawingml/2006/main">
+            <a:off x="609600" y="3181350"/>
+            <a:ext cx="10858500" cy="981075"/>
+          </a:xfrm>
+          <a:prstGeom xmlns:a="http://schemas.openxmlformats.org/drawingml/2006/main" prst="rect">
+            <a:avLst/>
+          </a:prstGeom>
+          <a:noFill xmlns:a="http://schemas.openxmlformats.org/drawingml/2006/main"/>
+          <a:ln xmlns:a="http://schemas.openxmlformats.org/drawingml/2006/main" w="0">
+            <a:noFill/>
+          </a:ln>
+        </p:spPr>
+        <p:txBody>
+          <a:bodyPr xmlns:a="http://schemas.openxmlformats.org/drawingml/2006/main">
+            <a:noAutofit/>
+          </a:bodyPr>
+          <a:lstStyle xmlns:a="http://schemas.openxmlformats.org/drawingml/2006/main"/>
+          <a:p xmlns:a="http://schemas.openxmlformats.org/drawingml/2006/main">
+            <a:pPr>
+              <a:defRPr sz="2175" b="0">
+                <a:solidFill>
+                  <a:srgbClr val="283A39"/>
+                </a:solidFill>
+                <a:latin typeface="Arial"/>
+                <a:ea typeface="Arial"/>
+                <a:cs typeface="Arial"/>
+              </a:defRPr>
+            </a:pPr>
+            <a:r>
+              <a:rPr sz="2175" b="0">
+                <a:solidFill>
+                  <a:srgbClr val="283A39"/>
+                </a:solidFill>
+                <a:latin typeface="Arial"/>
+                <a:ea typeface="Arial"/>
+                <a:cs typeface="Arial"/>
+              </a:rPr>
+              <a:t>The AI checks unfinished applications and new listings,</a:t>
+            </a:r>
+          </a:p>
+          <a:p xmlns:a="http://schemas.openxmlformats.org/drawingml/2006/main">
+            <a:pPr>
+              <a:defRPr sz="2175" b="0">
+                <a:solidFill>
+                  <a:srgbClr val="283A39"/>
+                </a:solidFill>
+                <a:latin typeface="Arial"/>
+                <a:ea typeface="Arial"/>
+                <a:cs typeface="Arial"/>
+              </a:defRPr>
+            </a:pPr>
+            <a:r>
+              <a:rPr sz="2175" b="0">
+                <a:solidFill>
+                  <a:srgbClr val="283A39"/>
+                </a:solidFill>
+                <a:latin typeface="Arial"/>
+                <a:ea typeface="Arial"/>
+                <a:cs typeface="Arial"/>
+              </a:rPr>
+              <a:t>then prepares suitable drafts for your review.</a:t>
+            </a:r>
+          </a:p>
+        </p:txBody>
+      </p:sp>
+      <p:sp>
+        <p:nvSpPr>
+          <p:cNvPr id="6" name="">
+            <a:extLst xmlns:a="http://schemas.openxmlformats.org/drawingml/2006/main">
+              <a:ext uri="{FF2B5EF4-FFF2-40B4-BE49-F238E27FC236}">
+                <a16:creationId xmlns:a16="http://schemas.microsoft.com/office/drawing/2014/main" id="{E76C4458-62F0-49F1-8B91-07F3C17DFC57}"/>
+              </a:ext>
+            </a:extLst>
+          </p:cNvPr>
+          <p:cNvSpPr>
+            <a:spLocks xmlns:a="http://schemas.openxmlformats.org/drawingml/2006/main" noGrp="1"/>
+          </p:cNvSpPr>
+          <p:nvPr/>
+        </p:nvSpPr>
+        <p:spPr>
+          <a:xfrm xmlns:a="http://schemas.openxmlformats.org/drawingml/2006/main">
+            <a:off x="609600" y="4600575"/>
+            <a:ext cx="10858500" cy="904875"/>
           </a:xfrm>
           <a:prstGeom xmlns:a="http://schemas.openxmlformats.org/drawingml/2006/main" prst="rect">
             <a:avLst/>
@@ -3069,43 +3303,9 @@
                 <a:ea typeface="Arial"/>
                 <a:cs typeface="Arial"/>
               </a:rPr>
-              <a:t>Codex CLI or IDE:  $job-search</a:t>
-            </a:r>
-          </a:p>
-        </p:txBody>
-      </p:sp>
-      <p:sp>
-        <p:nvSpPr>
-          <p:cNvPr id="6" name="">
-            <a:extLst xmlns:a="http://schemas.openxmlformats.org/drawingml/2006/main">
-              <a:ext uri="{FF2B5EF4-FFF2-40B4-BE49-F238E27FC236}">
-                <a16:creationId xmlns:a16="http://schemas.microsoft.com/office/drawing/2014/main" id="{F0347A4A-FE4C-439F-954B-D90ABEB7AB45}"/>
-              </a:ext>
-            </a:extLst>
-          </p:cNvPr>
-          <p:cNvSpPr>
-            <a:spLocks xmlns:a="http://schemas.openxmlformats.org/drawingml/2006/main" noGrp="1"/>
-          </p:cNvSpPr>
-          <p:nvPr/>
-        </p:nvSpPr>
-        <p:spPr>
-          <a:xfrm xmlns:a="http://schemas.openxmlformats.org/drawingml/2006/main">
-            <a:off x="609600" y="4038600"/>
-            <a:ext cx="10839450" cy="476250"/>
-          </a:xfrm>
-          <a:prstGeom xmlns:a="http://schemas.openxmlformats.org/drawingml/2006/main" prst="rect">
-            <a:avLst/>
-          </a:prstGeom>
-          <a:noFill xmlns:a="http://schemas.openxmlformats.org/drawingml/2006/main"/>
-          <a:ln xmlns:a="http://schemas.openxmlformats.org/drawingml/2006/main" w="0">
-            <a:noFill/>
-          </a:ln>
-        </p:spPr>
-        <p:txBody>
-          <a:bodyPr xmlns:a="http://schemas.openxmlformats.org/drawingml/2006/main">
-            <a:noAutofit/>
-          </a:bodyPr>
-          <a:lstStyle xmlns:a="http://schemas.openxmlformats.org/drawingml/2006/main"/>
+              <a:t>“Move my daily search to 8 a.m.”</a:t>
+            </a:r>
+          </a:p>
           <a:p xmlns:a="http://schemas.openxmlformats.org/drawingml/2006/main">
             <a:pPr>
               <a:defRPr sz="2400" b="1">
@@ -3126,7 +3326,7 @@
                 <a:ea typeface="Arial"/>
                 <a:cs typeface="Arial"/>
               </a:rPr>
-              <a:t>Claude Code:  /job-search</a:t>
+              <a:t>“Pause my scheduled search.”</a:t>
             </a:r>
           </a:p>
         </p:txBody>
@@ -3136,134 +3336,55 @@
           <p:cNvPr id="7" name="">
             <a:extLst xmlns:a="http://schemas.openxmlformats.org/drawingml/2006/main">
               <a:ext uri="{FF2B5EF4-FFF2-40B4-BE49-F238E27FC236}">
-                <a16:creationId xmlns:a16="http://schemas.microsoft.com/office/drawing/2014/main" id="{410D5645-0C3E-43F3-8332-8B8639A23D5A}"/>
-              </a:ext>
-            </a:extLst>
-          </p:cNvPr>
-          <p:cNvSpPr>
-            <a:spLocks xmlns:a="http://schemas.openxmlformats.org/drawingml/2006/main" noGrp="1"/>
-          </p:cNvSpPr>
-          <p:nvPr/>
-        </p:nvSpPr>
-        <p:spPr>
-          <a:xfrm xmlns:a="http://schemas.openxmlformats.org/drawingml/2006/main">
-            <a:off x="609600" y="4981575"/>
-            <a:ext cx="10858500" cy="866775"/>
-          </a:xfrm>
-          <a:prstGeom xmlns:a="http://schemas.openxmlformats.org/drawingml/2006/main" prst="rect">
-            <a:avLst/>
-          </a:prstGeom>
-          <a:noFill xmlns:a="http://schemas.openxmlformats.org/drawingml/2006/main"/>
-          <a:ln xmlns:a="http://schemas.openxmlformats.org/drawingml/2006/main" w="0">
-            <a:noFill/>
-          </a:ln>
-        </p:spPr>
-        <p:txBody>
-          <a:bodyPr xmlns:a="http://schemas.openxmlformats.org/drawingml/2006/main">
-            <a:noAutofit/>
-          </a:bodyPr>
-          <a:lstStyle xmlns:a="http://schemas.openxmlformats.org/drawingml/2006/main"/>
-          <a:p xmlns:a="http://schemas.openxmlformats.org/drawingml/2006/main">
-            <a:pPr>
-              <a:defRPr sz="1950" b="0">
-                <a:solidFill>
-                  <a:srgbClr val="283A39"/>
-                </a:solidFill>
-                <a:latin typeface="Arial"/>
-                <a:ea typeface="Arial"/>
-                <a:cs typeface="Arial"/>
-              </a:defRPr>
-            </a:pPr>
-            <a:r>
-              <a:rPr sz="1950" b="0">
-                <a:solidFill>
-                  <a:srgbClr val="283A39"/>
-                </a:solidFill>
-                <a:latin typeface="Arial"/>
-                <a:ea typeface="Arial"/>
-                <a:cs typeface="Arial"/>
-              </a:rPr>
-              <a:t>Add “Start my search” or “Continue my job search”, then send.</a:t>
-            </a:r>
-          </a:p>
-          <a:p xmlns:a="http://schemas.openxmlformats.org/drawingml/2006/main">
-            <a:pPr>
-              <a:defRPr sz="1950" b="0">
-                <a:solidFill>
-                  <a:srgbClr val="283A39"/>
-                </a:solidFill>
-                <a:latin typeface="Arial"/>
-                <a:ea typeface="Arial"/>
-                <a:cs typeface="Arial"/>
-              </a:defRPr>
-            </a:pPr>
-            <a:r>
-              <a:rPr sz="1950" b="0">
-                <a:solidFill>
-                  <a:srgbClr val="283A39"/>
-                </a:solidFill>
-                <a:latin typeface="Arial"/>
-                <a:ea typeface="Arial"/>
-                <a:cs typeface="Arial"/>
-              </a:rPr>
-              <a:t>Use the AI message box after installation, in the same project.</a:t>
-            </a:r>
-          </a:p>
-        </p:txBody>
-      </p:sp>
-      <p:sp>
-        <p:nvSpPr>
-          <p:cNvPr id="8" name="">
-            <a:extLst xmlns:a="http://schemas.openxmlformats.org/drawingml/2006/main">
-              <a:ext uri="{FF2B5EF4-FFF2-40B4-BE49-F238E27FC236}">
-                <a16:creationId xmlns:a16="http://schemas.microsoft.com/office/drawing/2014/main" id="{6E9649C2-4853-4B39-86D0-1E3A8777B2B2}"/>
-              </a:ext>
-            </a:extLst>
-          </p:cNvPr>
-          <p:cNvSpPr>
-            <a:spLocks xmlns:a="http://schemas.openxmlformats.org/drawingml/2006/main" noGrp="1"/>
-          </p:cNvSpPr>
-          <p:nvPr/>
-        </p:nvSpPr>
-        <p:spPr>
-          <a:xfrm xmlns:a="http://schemas.openxmlformats.org/drawingml/2006/main">
-            <a:off x="609600" y="5981700"/>
-            <a:ext cx="10858500" cy="361950"/>
-          </a:xfrm>
-          <a:prstGeom xmlns:a="http://schemas.openxmlformats.org/drawingml/2006/main" prst="rect">
-            <a:avLst/>
-          </a:prstGeom>
-          <a:noFill xmlns:a="http://schemas.openxmlformats.org/drawingml/2006/main"/>
-          <a:ln xmlns:a="http://schemas.openxmlformats.org/drawingml/2006/main" w="0">
-            <a:noFill/>
-          </a:ln>
-        </p:spPr>
-        <p:txBody>
-          <a:bodyPr xmlns:a="http://schemas.openxmlformats.org/drawingml/2006/main">
-            <a:noAutofit/>
-          </a:bodyPr>
-          <a:lstStyle xmlns:a="http://schemas.openxmlformats.org/drawingml/2006/main"/>
-          <a:p xmlns:a="http://schemas.openxmlformats.org/drawingml/2006/main">
-            <a:pPr>
-              <a:defRPr sz="1650" b="0">
-                <a:solidFill>
-                  <a:srgbClr val="607370"/>
-                </a:solidFill>
-                <a:latin typeface="Arial"/>
-                <a:ea typeface="Arial"/>
-                <a:cs typeface="Arial"/>
-              </a:defRPr>
-            </a:pPr>
-            <a:r>
-              <a:rPr sz="1650" b="0">
-                <a:solidFill>
-                  <a:srgbClr val="607370"/>
-                </a:solidFill>
-                <a:latin typeface="Arial"/>
-                <a:ea typeface="Arial"/>
-                <a:cs typeface="Arial"/>
-              </a:rPr>
-              <a:t>If the picker cannot find it, send: “Use job-search.” Ask the AI to check installation if needed.</a:t>
+                <a16:creationId xmlns:a16="http://schemas.microsoft.com/office/drawing/2014/main" id="{3CF30B73-F7E3-48F4-A654-0F6F064C073E}"/>
+              </a:ext>
+            </a:extLst>
+          </p:cNvPr>
+          <p:cNvSpPr>
+            <a:spLocks xmlns:a="http://schemas.openxmlformats.org/drawingml/2006/main" noGrp="1"/>
+          </p:cNvSpPr>
+          <p:nvPr/>
+        </p:nvSpPr>
+        <p:spPr>
+          <a:xfrm xmlns:a="http://schemas.openxmlformats.org/drawingml/2006/main">
+            <a:off x="609600" y="5867400"/>
+            <a:ext cx="9906000" cy="361950"/>
+          </a:xfrm>
+          <a:prstGeom xmlns:a="http://schemas.openxmlformats.org/drawingml/2006/main" prst="rect">
+            <a:avLst/>
+          </a:prstGeom>
+          <a:noFill xmlns:a="http://schemas.openxmlformats.org/drawingml/2006/main"/>
+          <a:ln xmlns:a="http://schemas.openxmlformats.org/drawingml/2006/main" w="0">
+            <a:noFill/>
+          </a:ln>
+        </p:spPr>
+        <p:txBody>
+          <a:bodyPr xmlns:a="http://schemas.openxmlformats.org/drawingml/2006/main">
+            <a:noAutofit/>
+          </a:bodyPr>
+          <a:lstStyle xmlns:a="http://schemas.openxmlformats.org/drawingml/2006/main"/>
+          <a:p xmlns:a="http://schemas.openxmlformats.org/drawingml/2006/main">
+            <a:pPr>
+              <a:defRPr sz="1875" b="0">
+                <a:solidFill>
+                  <a:srgbClr val="087F73"/>
+                </a:solidFill>
+                <a:latin typeface="Arial"/>
+                <a:ea typeface="Arial"/>
+                <a:cs typeface="Arial"/>
+              </a:defRPr>
+            </a:pPr>
+            <a:r>
+              <a:rPr sz="1875" b="0">
+                <a:solidFill>
+                  <a:srgbClr val="087F73"/>
+                </a:solidFill>
+                <a:latin typeface="Arial"/>
+                <a:ea typeface="Arial"/>
+                <a:cs typeface="Arial"/>
+                <a:hlinkClick xmlns:r="http://schemas.openxmlformats.org/officeDocument/2006/relationships" r:id="R8b203203730d4914"/>
+              </a:rPr>
+              <a:t>Read the daily-search guide</a:t>
             </a:r>
           </a:p>
         </p:txBody>
@@ -3271,7 +3392,7 @@
     </p:spTree>
     <p:extLst>
       <p:ext uri="{BB962C8B-B14F-4D97-AF65-F5344CB8AC3E}">
-        <p14:creationId xmlns:p14="http://schemas.microsoft.com/office/powerpoint/2010/main" val="100367761"/>
+        <p14:creationId xmlns:p14="http://schemas.microsoft.com/office/powerpoint/2010/main" val="831724952"/>
       </p:ext>
     </p:extLst>
   </p:cSld>
@@ -3302,7 +3423,7 @@
           <p:cNvPr id="7" name="">
             <a:extLst xmlns:a="http://schemas.openxmlformats.org/drawingml/2006/main">
               <a:ext uri="{FF2B5EF4-FFF2-40B4-BE49-F238E27FC236}">
-                <a16:creationId xmlns:a16="http://schemas.microsoft.com/office/drawing/2014/main" id="{BE83AD5A-6862-4372-962B-91B7C465EE2D}"/>
+                <a16:creationId xmlns:a16="http://schemas.microsoft.com/office/drawing/2014/main" id="{4C3B55E5-2C0A-473F-8D27-DA190EDEE447}"/>
               </a:ext>
             </a:extLst>
           </p:cNvPr>
@@ -3349,7 +3470,7 @@
                 <a:ea typeface="Arial"/>
                 <a:cs typeface="Arial"/>
               </a:rPr>
-              <a:t>6. Next time</a:t>
+              <a:t>5. Your first draft</a:t>
             </a:r>
           </a:p>
         </p:txBody>
@@ -3359,7 +3480,7 @@
           <p:cNvPr id="2" name="">
             <a:extLst xmlns:a="http://schemas.openxmlformats.org/drawingml/2006/main">
               <a:ext uri="{FF2B5EF4-FFF2-40B4-BE49-F238E27FC236}">
-                <a16:creationId xmlns:a16="http://schemas.microsoft.com/office/drawing/2014/main" id="{37C92D8E-43E3-4C5B-82CE-50C06ACE45C4}"/>
+                <a16:creationId xmlns:a16="http://schemas.microsoft.com/office/drawing/2014/main" id="{E5FBDBAC-7116-4D27-B32C-B863100A199F}"/>
               </a:ext>
             </a:extLst>
           </p:cNvPr>
@@ -3416,19 +3537,19 @@
           <p:cNvPr id="3" name="">
             <a:extLst xmlns:a="http://schemas.openxmlformats.org/drawingml/2006/main">
               <a:ext uri="{FF2B5EF4-FFF2-40B4-BE49-F238E27FC236}">
-                <a16:creationId xmlns:a16="http://schemas.microsoft.com/office/drawing/2014/main" id="{EB546616-85DA-40E0-A49F-DA4A9108474C}"/>
-              </a:ext>
-            </a:extLst>
-          </p:cNvPr>
-          <p:cNvSpPr>
-            <a:spLocks xmlns:a="http://schemas.openxmlformats.org/drawingml/2006/main" noGrp="1"/>
-          </p:cNvSpPr>
-          <p:nvPr/>
-        </p:nvSpPr>
-        <p:spPr>
-          <a:xfrm xmlns:a="http://schemas.openxmlformats.org/drawingml/2006/main">
-            <a:off x="609600" y="1466850"/>
-            <a:ext cx="10820400" cy="752475"/>
+                <a16:creationId xmlns:a16="http://schemas.microsoft.com/office/drawing/2014/main" id="{F1B13E13-A78A-48B5-9D08-B1851B9F9711}"/>
+              </a:ext>
+            </a:extLst>
+          </p:cNvPr>
+          <p:cNvSpPr>
+            <a:spLocks xmlns:a="http://schemas.openxmlformats.org/drawingml/2006/main" noGrp="1"/>
+          </p:cNvSpPr>
+          <p:nvPr/>
+        </p:nvSpPr>
+        <p:spPr>
+          <a:xfrm xmlns:a="http://schemas.openxmlformats.org/drawingml/2006/main">
+            <a:off x="609600" y="1476375"/>
+            <a:ext cx="10820400" cy="1019175"/>
           </a:xfrm>
           <a:prstGeom xmlns:a="http://schemas.openxmlformats.org/drawingml/2006/main" prst="rect">
             <a:avLst/>
@@ -3463,7 +3584,7 @@
                 <a:ea typeface="Arial"/>
                 <a:cs typeface="Arial"/>
               </a:rPr>
-              <a:t>a. Reopen the same local project and conversation.</a:t>
+              <a:t>When enough is known, the AI prepares useful documents</a:t>
             </a:r>
           </a:p>
           <a:p xmlns:a="http://schemas.openxmlformats.org/drawingml/2006/main">
@@ -3486,7 +3607,7 @@
                 <a:ea typeface="Arial"/>
                 <a:cs typeface="Arial"/>
               </a:rPr>
-              <a:t>b. Summon job-search, then send:</a:t>
+              <a:t>and keeps your search records in a separate private location.</a:t>
             </a:r>
           </a:p>
         </p:txBody>
@@ -3496,36 +3617,116 @@
           <p:cNvPr id="4" name="">
             <a:extLst xmlns:a="http://schemas.openxmlformats.org/drawingml/2006/main">
               <a:ext uri="{FF2B5EF4-FFF2-40B4-BE49-F238E27FC236}">
-                <a16:creationId xmlns:a16="http://schemas.microsoft.com/office/drawing/2014/main" id="{892A0169-0750-468D-AAF0-92DC7635296F}"/>
-              </a:ext>
-            </a:extLst>
-          </p:cNvPr>
-          <p:cNvSpPr>
-            <a:spLocks xmlns:a="http://schemas.openxmlformats.org/drawingml/2006/main" noGrp="1"/>
-          </p:cNvSpPr>
-          <p:nvPr/>
-        </p:nvSpPr>
-        <p:spPr>
-          <a:xfrm xmlns:a="http://schemas.openxmlformats.org/drawingml/2006/main">
-            <a:off x="609600" y="2828925"/>
-            <a:ext cx="10858500" cy="819150"/>
-          </a:xfrm>
-          <a:prstGeom xmlns:a="http://schemas.openxmlformats.org/drawingml/2006/main" prst="rect">
-            <a:avLst/>
-          </a:prstGeom>
-          <a:noFill xmlns:a="http://schemas.openxmlformats.org/drawingml/2006/main"/>
-          <a:ln xmlns:a="http://schemas.openxmlformats.org/drawingml/2006/main" w="0">
-            <a:noFill/>
-          </a:ln>
-        </p:spPr>
-        <p:txBody>
-          <a:bodyPr xmlns:a="http://schemas.openxmlformats.org/drawingml/2006/main">
-            <a:noAutofit/>
-          </a:bodyPr>
-          <a:lstStyle xmlns:a="http://schemas.openxmlformats.org/drawingml/2006/main"/>
-          <a:p xmlns:a="http://schemas.openxmlformats.org/drawingml/2006/main">
-            <a:pPr>
-              <a:defRPr sz="3675" b="1">
+                <a16:creationId xmlns:a16="http://schemas.microsoft.com/office/drawing/2014/main" id="{D174E504-4CEB-4706-9A5A-A30758A0EC94}"/>
+              </a:ext>
+            </a:extLst>
+          </p:cNvPr>
+          <p:cNvSpPr>
+            <a:spLocks xmlns:a="http://schemas.openxmlformats.org/drawingml/2006/main" noGrp="1"/>
+          </p:cNvSpPr>
+          <p:nvPr/>
+        </p:nvSpPr>
+        <p:spPr>
+          <a:xfrm xmlns:a="http://schemas.openxmlformats.org/drawingml/2006/main">
+            <a:off x="609600" y="3162300"/>
+            <a:ext cx="10820400" cy="1009650"/>
+          </a:xfrm>
+          <a:prstGeom xmlns:a="http://schemas.openxmlformats.org/drawingml/2006/main" prst="rect">
+            <a:avLst/>
+          </a:prstGeom>
+          <a:noFill xmlns:a="http://schemas.openxmlformats.org/drawingml/2006/main"/>
+          <a:ln xmlns:a="http://schemas.openxmlformats.org/drawingml/2006/main" w="0">
+            <a:noFill/>
+          </a:ln>
+        </p:spPr>
+        <p:txBody>
+          <a:bodyPr xmlns:a="http://schemas.openxmlformats.org/drawingml/2006/main">
+            <a:noAutofit/>
+          </a:bodyPr>
+          <a:lstStyle xmlns:a="http://schemas.openxmlformats.org/drawingml/2006/main"/>
+          <a:p xmlns:a="http://schemas.openxmlformats.org/drawingml/2006/main">
+            <a:pPr>
+              <a:defRPr sz="2250" b="0">
+                <a:solidFill>
+                  <a:srgbClr val="283A39"/>
+                </a:solidFill>
+                <a:latin typeface="Arial"/>
+                <a:ea typeface="Arial"/>
+                <a:cs typeface="Arial"/>
+              </a:defRPr>
+            </a:pPr>
+            <a:r>
+              <a:rPr sz="2250" b="0">
+                <a:solidFill>
+                  <a:srgbClr val="283A39"/>
+                </a:solidFill>
+                <a:latin typeface="Arial"/>
+                <a:ea typeface="Arial"/>
+                <a:cs typeface="Arial"/>
+              </a:rPr>
+              <a:t>Open the files and check your experience, dates and contact details.</a:t>
+            </a:r>
+          </a:p>
+          <a:p xmlns:a="http://schemas.openxmlformats.org/drawingml/2006/main">
+            <a:pPr>
+              <a:defRPr sz="2250" b="0">
+                <a:solidFill>
+                  <a:srgbClr val="283A39"/>
+                </a:solidFill>
+                <a:latin typeface="Arial"/>
+                <a:ea typeface="Arial"/>
+                <a:cs typeface="Arial"/>
+              </a:defRPr>
+            </a:pPr>
+            <a:r>
+              <a:rPr sz="2250" b="0">
+                <a:solidFill>
+                  <a:srgbClr val="283A39"/>
+                </a:solidFill>
+                <a:latin typeface="Arial"/>
+                <a:ea typeface="Arial"/>
+                <a:cs typeface="Arial"/>
+              </a:rPr>
+              <a:t>Give corrections in the conversation.</a:t>
+            </a:r>
+          </a:p>
+        </p:txBody>
+      </p:sp>
+      <p:sp>
+        <p:nvSpPr>
+          <p:cNvPr id="5" name="">
+            <a:extLst xmlns:a="http://schemas.openxmlformats.org/drawingml/2006/main">
+              <a:ext uri="{FF2B5EF4-FFF2-40B4-BE49-F238E27FC236}">
+                <a16:creationId xmlns:a16="http://schemas.microsoft.com/office/drawing/2014/main" id="{B404BBEF-034B-471C-A2C0-FD8A8A8D8E64}"/>
+              </a:ext>
+            </a:extLst>
+          </p:cNvPr>
+          <p:cNvSpPr>
+            <a:spLocks xmlns:a="http://schemas.openxmlformats.org/drawingml/2006/main" noGrp="1"/>
+          </p:cNvSpPr>
+          <p:nvPr/>
+        </p:nvSpPr>
+        <p:spPr>
+          <a:xfrm xmlns:a="http://schemas.openxmlformats.org/drawingml/2006/main">
+            <a:off x="609600" y="4714875"/>
+            <a:ext cx="10858500" cy="552450"/>
+          </a:xfrm>
+          <a:prstGeom xmlns:a="http://schemas.openxmlformats.org/drawingml/2006/main" prst="rect">
+            <a:avLst/>
+          </a:prstGeom>
+          <a:noFill xmlns:a="http://schemas.openxmlformats.org/drawingml/2006/main"/>
+          <a:ln xmlns:a="http://schemas.openxmlformats.org/drawingml/2006/main" w="0">
+            <a:noFill/>
+          </a:ln>
+        </p:spPr>
+        <p:txBody>
+          <a:bodyPr xmlns:a="http://schemas.openxmlformats.org/drawingml/2006/main">
+            <a:noAutofit/>
+          </a:bodyPr>
+          <a:lstStyle xmlns:a="http://schemas.openxmlformats.org/drawingml/2006/main"/>
+          <a:p xmlns:a="http://schemas.openxmlformats.org/drawingml/2006/main">
+            <a:pPr>
+              <a:defRPr sz="2550" b="1">
                 <a:solidFill>
                   <a:srgbClr val="183F3B"/>
                 </a:solidFill>
@@ -3535,7 +3736,7 @@
               </a:defRPr>
             </a:pPr>
             <a:r>
-              <a:rPr sz="3675" b="1">
+              <a:rPr sz="2550" b="1">
                 <a:solidFill>
                   <a:srgbClr val="183F3B"/>
                 </a:solidFill>
@@ -3543,87 +3744,7 @@
                 <a:ea typeface="Arial"/>
                 <a:cs typeface="Arial"/>
               </a:rPr>
-              <a:t>Continue my job search.</a:t>
-            </a:r>
-          </a:p>
-        </p:txBody>
-      </p:sp>
-      <p:sp>
-        <p:nvSpPr>
-          <p:cNvPr id="5" name="">
-            <a:extLst xmlns:a="http://schemas.openxmlformats.org/drawingml/2006/main">
-              <a:ext uri="{FF2B5EF4-FFF2-40B4-BE49-F238E27FC236}">
-                <a16:creationId xmlns:a16="http://schemas.microsoft.com/office/drawing/2014/main" id="{C74FC4F5-F003-41F3-8BEF-B377C5A50547}"/>
-              </a:ext>
-            </a:extLst>
-          </p:cNvPr>
-          <p:cNvSpPr>
-            <a:spLocks xmlns:a="http://schemas.openxmlformats.org/drawingml/2006/main" noGrp="1"/>
-          </p:cNvSpPr>
-          <p:nvPr/>
-        </p:nvSpPr>
-        <p:spPr>
-          <a:xfrm xmlns:a="http://schemas.openxmlformats.org/drawingml/2006/main">
-            <a:off x="609600" y="4286250"/>
-            <a:ext cx="10858500" cy="952500"/>
-          </a:xfrm>
-          <a:prstGeom xmlns:a="http://schemas.openxmlformats.org/drawingml/2006/main" prst="rect">
-            <a:avLst/>
-          </a:prstGeom>
-          <a:noFill xmlns:a="http://schemas.openxmlformats.org/drawingml/2006/main"/>
-          <a:ln xmlns:a="http://schemas.openxmlformats.org/drawingml/2006/main" w="0">
-            <a:noFill/>
-          </a:ln>
-        </p:spPr>
-        <p:txBody>
-          <a:bodyPr xmlns:a="http://schemas.openxmlformats.org/drawingml/2006/main">
-            <a:noAutofit/>
-          </a:bodyPr>
-          <a:lstStyle xmlns:a="http://schemas.openxmlformats.org/drawingml/2006/main"/>
-          <a:p xmlns:a="http://schemas.openxmlformats.org/drawingml/2006/main">
-            <a:pPr>
-              <a:defRPr sz="2100" b="0">
-                <a:solidFill>
-                  <a:srgbClr val="283A39"/>
-                </a:solidFill>
-                <a:latin typeface="Arial"/>
-                <a:ea typeface="Arial"/>
-                <a:cs typeface="Arial"/>
-              </a:defRPr>
-            </a:pPr>
-            <a:r>
-              <a:rPr sz="2100" b="0">
-                <a:solidFill>
-                  <a:srgbClr val="283A39"/>
-                </a:solidFill>
-                <a:latin typeface="Arial"/>
-                <a:ea typeface="Arial"/>
-                <a:cs typeface="Arial"/>
-              </a:rPr>
-              <a:t>c. Continue from your saved progress.</a:t>
-            </a:r>
-          </a:p>
-          <a:p xmlns:a="http://schemas.openxmlformats.org/drawingml/2006/main">
-            <a:pPr>
-              <a:defRPr sz="2100" b="0">
-                <a:solidFill>
-                  <a:srgbClr val="283A39"/>
-                </a:solidFill>
-                <a:latin typeface="Arial"/>
-                <a:ea typeface="Arial"/>
-                <a:cs typeface="Arial"/>
-              </a:defRPr>
-            </a:pPr>
-            <a:r>
-              <a:rPr sz="2100" b="0">
-                <a:solidFill>
-                  <a:srgbClr val="283A39"/>
-                </a:solidFill>
-                <a:latin typeface="Arial"/>
-                <a:ea typeface="Arial"/>
-                <a:cs typeface="Arial"/>
-              </a:rPr>
-              <a:t>Supply an updated resume when it changes.</a:t>
+              <a:t>“That role was volunteering. Please correct it.”</a:t>
             </a:r>
           </a:p>
         </p:txBody>
@@ -3633,19 +3754,19 @@
           <p:cNvPr id="6" name="">
             <a:extLst xmlns:a="http://schemas.openxmlformats.org/drawingml/2006/main">
               <a:ext uri="{FF2B5EF4-FFF2-40B4-BE49-F238E27FC236}">
-                <a16:creationId xmlns:a16="http://schemas.microsoft.com/office/drawing/2014/main" id="{20027DA1-E989-4103-A213-08680969F71D}"/>
-              </a:ext>
-            </a:extLst>
-          </p:cNvPr>
-          <p:cNvSpPr>
-            <a:spLocks xmlns:a="http://schemas.openxmlformats.org/drawingml/2006/main" noGrp="1"/>
-          </p:cNvSpPr>
-          <p:nvPr/>
-        </p:nvSpPr>
-        <p:spPr>
-          <a:xfrm xmlns:a="http://schemas.openxmlformats.org/drawingml/2006/main">
-            <a:off x="609600" y="5781675"/>
-            <a:ext cx="10858500" cy="495300"/>
+                <a16:creationId xmlns:a16="http://schemas.microsoft.com/office/drawing/2014/main" id="{105A9E9D-959B-4F82-BBC2-2F087C46CE77}"/>
+              </a:ext>
+            </a:extLst>
+          </p:cNvPr>
+          <p:cNvSpPr>
+            <a:spLocks xmlns:a="http://schemas.openxmlformats.org/drawingml/2006/main" noGrp="1"/>
+          </p:cNvSpPr>
+          <p:nvPr/>
+        </p:nvSpPr>
+        <p:spPr>
+          <a:xfrm xmlns:a="http://schemas.openxmlformats.org/drawingml/2006/main">
+            <a:off x="609600" y="5829300"/>
+            <a:ext cx="10858500" cy="400050"/>
           </a:xfrm>
           <a:prstGeom xmlns:a="http://schemas.openxmlformats.org/drawingml/2006/main" prst="rect">
             <a:avLst/>
@@ -3680,7 +3801,7 @@
                 <a:ea typeface="Arial"/>
                 <a:cs typeface="Arial"/>
               </a:rPr>
-              <a:t>For an independent occupation search, use a new project with separate records.</a:t>
+              <a:t>Review the employer and final documents before authorizing a submission.</a:t>
             </a:r>
           </a:p>
         </p:txBody>
@@ -3688,7 +3809,7 @@
     </p:spTree>
     <p:extLst>
       <p:ext uri="{BB962C8B-B14F-4D97-AF65-F5344CB8AC3E}">
-        <p14:creationId xmlns:p14="http://schemas.microsoft.com/office/powerpoint/2010/main" val="1377764577"/>
+        <p14:creationId xmlns:p14="http://schemas.microsoft.com/office/powerpoint/2010/main" val="820330269"/>
       </p:ext>
     </p:extLst>
   </p:cSld>
@@ -3716,10 +3837,10 @@
       </p:grpSpPr>
       <p:sp>
         <p:nvSpPr>
-          <p:cNvPr id="10" name="">
-            <a:extLst xmlns:a="http://schemas.openxmlformats.org/drawingml/2006/main">
-              <a:ext uri="{FF2B5EF4-FFF2-40B4-BE49-F238E27FC236}">
-                <a16:creationId xmlns:a16="http://schemas.microsoft.com/office/drawing/2014/main" id="{E6F1F580-4BC3-4770-924A-8C4F976444C5}"/>
+          <p:cNvPr id="9" name="">
+            <a:extLst xmlns:a="http://schemas.openxmlformats.org/drawingml/2006/main">
+              <a:ext uri="{FF2B5EF4-FFF2-40B4-BE49-F238E27FC236}">
+                <a16:creationId xmlns:a16="http://schemas.microsoft.com/office/drawing/2014/main" id="{4E1C4BAF-81EE-497D-9838-A2D00B556023}"/>
               </a:ext>
             </a:extLst>
           </p:cNvPr>
@@ -3766,7 +3887,7 @@
                 <a:ea typeface="Arial"/>
                 <a:cs typeface="Arial"/>
               </a:rPr>
-              <a:t>If something stops you</a:t>
+              <a:t>Summon the installed skill</a:t>
             </a:r>
           </a:p>
         </p:txBody>
@@ -3776,7 +3897,7 @@
           <p:cNvPr id="2" name="">
             <a:extLst xmlns:a="http://schemas.openxmlformats.org/drawingml/2006/main">
               <a:ext uri="{FF2B5EF4-FFF2-40B4-BE49-F238E27FC236}">
-                <a16:creationId xmlns:a16="http://schemas.microsoft.com/office/drawing/2014/main" id="{5C77B327-D477-419E-B786-6ABB71AE1492}"/>
+                <a16:creationId xmlns:a16="http://schemas.microsoft.com/office/drawing/2014/main" id="{BE27B121-9986-4E3E-B245-3624DB89AA92}"/>
               </a:ext>
             </a:extLst>
           </p:cNvPr>
@@ -3833,36 +3954,36 @@
           <p:cNvPr id="3" name="">
             <a:extLst xmlns:a="http://schemas.openxmlformats.org/drawingml/2006/main">
               <a:ext uri="{FF2B5EF4-FFF2-40B4-BE49-F238E27FC236}">
-                <a16:creationId xmlns:a16="http://schemas.microsoft.com/office/drawing/2014/main" id="{20A95B95-00D4-4FB5-B446-69FAB5ACAFA8}"/>
-              </a:ext>
-            </a:extLst>
-          </p:cNvPr>
-          <p:cNvSpPr>
-            <a:spLocks xmlns:a="http://schemas.openxmlformats.org/drawingml/2006/main" noGrp="1"/>
-          </p:cNvSpPr>
-          <p:nvPr/>
-        </p:nvSpPr>
-        <p:spPr>
-          <a:xfrm xmlns:a="http://schemas.openxmlformats.org/drawingml/2006/main">
-            <a:off x="609600" y="1504950"/>
-            <a:ext cx="5048250" cy="428625"/>
-          </a:xfrm>
-          <a:prstGeom xmlns:a="http://schemas.openxmlformats.org/drawingml/2006/main" prst="rect">
-            <a:avLst/>
-          </a:prstGeom>
-          <a:noFill xmlns:a="http://schemas.openxmlformats.org/drawingml/2006/main"/>
-          <a:ln xmlns:a="http://schemas.openxmlformats.org/drawingml/2006/main" w="0">
-            <a:noFill/>
-          </a:ln>
-        </p:spPr>
-        <p:txBody>
-          <a:bodyPr xmlns:a="http://schemas.openxmlformats.org/drawingml/2006/main">
-            <a:noAutofit/>
-          </a:bodyPr>
-          <a:lstStyle xmlns:a="http://schemas.openxmlformats.org/drawingml/2006/main"/>
-          <a:p xmlns:a="http://schemas.openxmlformats.org/drawingml/2006/main">
-            <a:pPr>
-              <a:defRPr sz="2325" b="1">
+                <a16:creationId xmlns:a16="http://schemas.microsoft.com/office/drawing/2014/main" id="{FCFDED98-7E73-4586-8C9A-000107F231DB}"/>
+              </a:ext>
+            </a:extLst>
+          </p:cNvPr>
+          <p:cNvSpPr>
+            <a:spLocks xmlns:a="http://schemas.openxmlformats.org/drawingml/2006/main" noGrp="1"/>
+          </p:cNvSpPr>
+          <p:nvPr/>
+        </p:nvSpPr>
+        <p:spPr>
+          <a:xfrm xmlns:a="http://schemas.openxmlformats.org/drawingml/2006/main">
+            <a:off x="609600" y="1514475"/>
+            <a:ext cx="10839450" cy="428625"/>
+          </a:xfrm>
+          <a:prstGeom xmlns:a="http://schemas.openxmlformats.org/drawingml/2006/main" prst="rect">
+            <a:avLst/>
+          </a:prstGeom>
+          <a:noFill xmlns:a="http://schemas.openxmlformats.org/drawingml/2006/main"/>
+          <a:ln xmlns:a="http://schemas.openxmlformats.org/drawingml/2006/main" w="0">
+            <a:noFill/>
+          </a:ln>
+        </p:spPr>
+        <p:txBody>
+          <a:bodyPr xmlns:a="http://schemas.openxmlformats.org/drawingml/2006/main">
+            <a:noAutofit/>
+          </a:bodyPr>
+          <a:lstStyle xmlns:a="http://schemas.openxmlformats.org/drawingml/2006/main"/>
+          <a:p xmlns:a="http://schemas.openxmlformats.org/drawingml/2006/main">
+            <a:pPr>
+              <a:defRPr sz="2250" b="1">
                 <a:solidFill>
                   <a:srgbClr val="183F3B"/>
                 </a:solidFill>
@@ -3872,7 +3993,7 @@
               </a:defRPr>
             </a:pPr>
             <a:r>
-              <a:rPr sz="2325" b="1">
+              <a:rPr sz="2250" b="1">
                 <a:solidFill>
                   <a:srgbClr val="183F3B"/>
                 </a:solidFill>
@@ -3880,7 +4001,7 @@
                 <a:ea typeface="Arial"/>
                 <a:cs typeface="Arial"/>
               </a:rPr>
-              <a:t>Skill missing?</a:t>
+              <a:t>Codex / ChatGPT desktop</a:t>
             </a:r>
           </a:p>
         </p:txBody>
@@ -3890,19 +4011,213 @@
           <p:cNvPr id="4" name="">
             <a:extLst xmlns:a="http://schemas.openxmlformats.org/drawingml/2006/main">
               <a:ext uri="{FF2B5EF4-FFF2-40B4-BE49-F238E27FC236}">
-                <a16:creationId xmlns:a16="http://schemas.microsoft.com/office/drawing/2014/main" id="{20865034-38E2-4CDA-8021-017F7BD8F001}"/>
-              </a:ext>
-            </a:extLst>
-          </p:cNvPr>
-          <p:cNvSpPr>
-            <a:spLocks xmlns:a="http://schemas.openxmlformats.org/drawingml/2006/main" noGrp="1"/>
-          </p:cNvSpPr>
-          <p:nvPr/>
-        </p:nvSpPr>
-        <p:spPr>
-          <a:xfrm xmlns:a="http://schemas.openxmlformats.org/drawingml/2006/main">
-            <a:off x="609600" y="2066925"/>
-            <a:ext cx="5191125" cy="1047750"/>
+                <a16:creationId xmlns:a16="http://schemas.microsoft.com/office/drawing/2014/main" id="{7F8ED386-8DC9-4E5D-9B82-5AD357BCA660}"/>
+              </a:ext>
+            </a:extLst>
+          </p:cNvPr>
+          <p:cNvSpPr>
+            <a:spLocks xmlns:a="http://schemas.openxmlformats.org/drawingml/2006/main" noGrp="1"/>
+          </p:cNvSpPr>
+          <p:nvPr/>
+        </p:nvSpPr>
+        <p:spPr>
+          <a:xfrm xmlns:a="http://schemas.openxmlformats.org/drawingml/2006/main">
+            <a:off x="609600" y="2047875"/>
+            <a:ext cx="10839450" cy="866775"/>
+          </a:xfrm>
+          <a:prstGeom xmlns:a="http://schemas.openxmlformats.org/drawingml/2006/main" prst="rect">
+            <a:avLst/>
+          </a:prstGeom>
+          <a:noFill xmlns:a="http://schemas.openxmlformats.org/drawingml/2006/main"/>
+          <a:ln xmlns:a="http://schemas.openxmlformats.org/drawingml/2006/main" w="0">
+            <a:noFill/>
+          </a:ln>
+        </p:spPr>
+        <p:txBody>
+          <a:bodyPr xmlns:a="http://schemas.openxmlformats.org/drawingml/2006/main">
+            <a:noAutofit/>
+          </a:bodyPr>
+          <a:lstStyle xmlns:a="http://schemas.openxmlformats.org/drawingml/2006/main"/>
+          <a:p xmlns:a="http://schemas.openxmlformats.org/drawingml/2006/main">
+            <a:pPr>
+              <a:defRPr sz="2100" b="0">
+                <a:solidFill>
+                  <a:srgbClr val="283A39"/>
+                </a:solidFill>
+                <a:latin typeface="Arial"/>
+                <a:ea typeface="Arial"/>
+                <a:cs typeface="Arial"/>
+              </a:defRPr>
+            </a:pPr>
+            <a:r>
+              <a:rPr sz="2100" b="0">
+                <a:solidFill>
+                  <a:srgbClr val="283A39"/>
+                </a:solidFill>
+                <a:latin typeface="Arial"/>
+                <a:ea typeface="Arial"/>
+                <a:cs typeface="Arial"/>
+              </a:rPr>
+              <a:t>Type @ and choose job-search. If your composer offers a $</a:t>
+            </a:r>
+          </a:p>
+          <a:p xmlns:a="http://schemas.openxmlformats.org/drawingml/2006/main">
+            <a:pPr>
+              <a:defRPr sz="2100" b="0">
+                <a:solidFill>
+                  <a:srgbClr val="283A39"/>
+                </a:solidFill>
+                <a:latin typeface="Arial"/>
+                <a:ea typeface="Arial"/>
+                <a:cs typeface="Arial"/>
+              </a:defRPr>
+            </a:pPr>
+            <a:r>
+              <a:rPr sz="2100" b="0">
+                <a:solidFill>
+                  <a:srgbClr val="283A39"/>
+                </a:solidFill>
+                <a:latin typeface="Arial"/>
+                <a:ea typeface="Arial"/>
+                <a:cs typeface="Arial"/>
+              </a:rPr>
+              <a:t>skill picker, choose job-search there.</a:t>
+            </a:r>
+          </a:p>
+        </p:txBody>
+      </p:sp>
+      <p:sp>
+        <p:nvSpPr>
+          <p:cNvPr id="5" name="">
+            <a:extLst xmlns:a="http://schemas.openxmlformats.org/drawingml/2006/main">
+              <a:ext uri="{FF2B5EF4-FFF2-40B4-BE49-F238E27FC236}">
+                <a16:creationId xmlns:a16="http://schemas.microsoft.com/office/drawing/2014/main" id="{0D511985-081B-483C-998F-B74223E0B1A7}"/>
+              </a:ext>
+            </a:extLst>
+          </p:cNvPr>
+          <p:cNvSpPr>
+            <a:spLocks xmlns:a="http://schemas.openxmlformats.org/drawingml/2006/main" noGrp="1"/>
+          </p:cNvSpPr>
+          <p:nvPr/>
+        </p:nvSpPr>
+        <p:spPr>
+          <a:xfrm xmlns:a="http://schemas.openxmlformats.org/drawingml/2006/main">
+            <a:off x="609600" y="3276600"/>
+            <a:ext cx="10839450" cy="476250"/>
+          </a:xfrm>
+          <a:prstGeom xmlns:a="http://schemas.openxmlformats.org/drawingml/2006/main" prst="rect">
+            <a:avLst/>
+          </a:prstGeom>
+          <a:noFill xmlns:a="http://schemas.openxmlformats.org/drawingml/2006/main"/>
+          <a:ln xmlns:a="http://schemas.openxmlformats.org/drawingml/2006/main" w="0">
+            <a:noFill/>
+          </a:ln>
+        </p:spPr>
+        <p:txBody>
+          <a:bodyPr xmlns:a="http://schemas.openxmlformats.org/drawingml/2006/main">
+            <a:noAutofit/>
+          </a:bodyPr>
+          <a:lstStyle xmlns:a="http://schemas.openxmlformats.org/drawingml/2006/main"/>
+          <a:p xmlns:a="http://schemas.openxmlformats.org/drawingml/2006/main">
+            <a:pPr>
+              <a:defRPr sz="2400" b="1">
+                <a:solidFill>
+                  <a:srgbClr val="183F3B"/>
+                </a:solidFill>
+                <a:latin typeface="Arial"/>
+                <a:ea typeface="Arial"/>
+                <a:cs typeface="Arial"/>
+              </a:defRPr>
+            </a:pPr>
+            <a:r>
+              <a:rPr sz="2400" b="1">
+                <a:solidFill>
+                  <a:srgbClr val="183F3B"/>
+                </a:solidFill>
+                <a:latin typeface="Arial"/>
+                <a:ea typeface="Arial"/>
+                <a:cs typeface="Arial"/>
+              </a:rPr>
+              <a:t>Codex CLI or IDE:  $job-search</a:t>
+            </a:r>
+          </a:p>
+        </p:txBody>
+      </p:sp>
+      <p:sp>
+        <p:nvSpPr>
+          <p:cNvPr id="6" name="">
+            <a:extLst xmlns:a="http://schemas.openxmlformats.org/drawingml/2006/main">
+              <a:ext uri="{FF2B5EF4-FFF2-40B4-BE49-F238E27FC236}">
+                <a16:creationId xmlns:a16="http://schemas.microsoft.com/office/drawing/2014/main" id="{CE843088-657B-44D3-936A-6169C7F0EF2E}"/>
+              </a:ext>
+            </a:extLst>
+          </p:cNvPr>
+          <p:cNvSpPr>
+            <a:spLocks xmlns:a="http://schemas.openxmlformats.org/drawingml/2006/main" noGrp="1"/>
+          </p:cNvSpPr>
+          <p:nvPr/>
+        </p:nvSpPr>
+        <p:spPr>
+          <a:xfrm xmlns:a="http://schemas.openxmlformats.org/drawingml/2006/main">
+            <a:off x="609600" y="4038600"/>
+            <a:ext cx="10839450" cy="476250"/>
+          </a:xfrm>
+          <a:prstGeom xmlns:a="http://schemas.openxmlformats.org/drawingml/2006/main" prst="rect">
+            <a:avLst/>
+          </a:prstGeom>
+          <a:noFill xmlns:a="http://schemas.openxmlformats.org/drawingml/2006/main"/>
+          <a:ln xmlns:a="http://schemas.openxmlformats.org/drawingml/2006/main" w="0">
+            <a:noFill/>
+          </a:ln>
+        </p:spPr>
+        <p:txBody>
+          <a:bodyPr xmlns:a="http://schemas.openxmlformats.org/drawingml/2006/main">
+            <a:noAutofit/>
+          </a:bodyPr>
+          <a:lstStyle xmlns:a="http://schemas.openxmlformats.org/drawingml/2006/main"/>
+          <a:p xmlns:a="http://schemas.openxmlformats.org/drawingml/2006/main">
+            <a:pPr>
+              <a:defRPr sz="2400" b="1">
+                <a:solidFill>
+                  <a:srgbClr val="183F3B"/>
+                </a:solidFill>
+                <a:latin typeface="Arial"/>
+                <a:ea typeface="Arial"/>
+                <a:cs typeface="Arial"/>
+              </a:defRPr>
+            </a:pPr>
+            <a:r>
+              <a:rPr sz="2400" b="1">
+                <a:solidFill>
+                  <a:srgbClr val="183F3B"/>
+                </a:solidFill>
+                <a:latin typeface="Arial"/>
+                <a:ea typeface="Arial"/>
+                <a:cs typeface="Arial"/>
+              </a:rPr>
+              <a:t>Claude Code:  /job-search</a:t>
+            </a:r>
+          </a:p>
+        </p:txBody>
+      </p:sp>
+      <p:sp>
+        <p:nvSpPr>
+          <p:cNvPr id="7" name="">
+            <a:extLst xmlns:a="http://schemas.openxmlformats.org/drawingml/2006/main">
+              <a:ext uri="{FF2B5EF4-FFF2-40B4-BE49-F238E27FC236}">
+                <a16:creationId xmlns:a16="http://schemas.microsoft.com/office/drawing/2014/main" id="{9C7E36DE-B427-45EB-9ECF-4A053B432ED9}"/>
+              </a:ext>
+            </a:extLst>
+          </p:cNvPr>
+          <p:cNvSpPr>
+            <a:spLocks xmlns:a="http://schemas.openxmlformats.org/drawingml/2006/main" noGrp="1"/>
+          </p:cNvSpPr>
+          <p:nvPr/>
+        </p:nvSpPr>
+        <p:spPr>
+          <a:xfrm xmlns:a="http://schemas.openxmlformats.org/drawingml/2006/main">
+            <a:off x="609600" y="4981575"/>
+            <a:ext cx="10858500" cy="866775"/>
           </a:xfrm>
           <a:prstGeom xmlns:a="http://schemas.openxmlformats.org/drawingml/2006/main" prst="rect">
             <a:avLst/>
@@ -3937,7 +4252,7 @@
                 <a:ea typeface="Arial"/>
                 <a:cs typeface="Arial"/>
               </a:rPr>
-              <a:t>“Check whether job-search is installed</a:t>
+              <a:t>Add “Start my search” or “Continue my job search”, then send.</a:t>
             </a:r>
           </a:p>
           <a:p xmlns:a="http://schemas.openxmlformats.org/drawingml/2006/main">
@@ -3960,224 +4275,7 @@
                 <a:ea typeface="Arial"/>
                 <a:cs typeface="Arial"/>
               </a:rPr>
-              <a:t>in this project and help me load it.”</a:t>
-            </a:r>
-          </a:p>
-        </p:txBody>
-      </p:sp>
-      <p:sp>
-        <p:nvSpPr>
-          <p:cNvPr id="5" name="">
-            <a:extLst xmlns:a="http://schemas.openxmlformats.org/drawingml/2006/main">
-              <a:ext uri="{FF2B5EF4-FFF2-40B4-BE49-F238E27FC236}">
-                <a16:creationId xmlns:a16="http://schemas.microsoft.com/office/drawing/2014/main" id="{DF24FE3D-F169-48C8-8F08-054B9F3B6105}"/>
-              </a:ext>
-            </a:extLst>
-          </p:cNvPr>
-          <p:cNvSpPr>
-            <a:spLocks xmlns:a="http://schemas.openxmlformats.org/drawingml/2006/main" noGrp="1"/>
-          </p:cNvSpPr>
-          <p:nvPr/>
-        </p:nvSpPr>
-        <p:spPr>
-          <a:xfrm xmlns:a="http://schemas.openxmlformats.org/drawingml/2006/main">
-            <a:off x="6400800" y="1504950"/>
-            <a:ext cx="5048250" cy="428625"/>
-          </a:xfrm>
-          <a:prstGeom xmlns:a="http://schemas.openxmlformats.org/drawingml/2006/main" prst="rect">
-            <a:avLst/>
-          </a:prstGeom>
-          <a:noFill xmlns:a="http://schemas.openxmlformats.org/drawingml/2006/main"/>
-          <a:ln xmlns:a="http://schemas.openxmlformats.org/drawingml/2006/main" w="0">
-            <a:noFill/>
-          </a:ln>
-        </p:spPr>
-        <p:txBody>
-          <a:bodyPr xmlns:a="http://schemas.openxmlformats.org/drawingml/2006/main">
-            <a:noAutofit/>
-          </a:bodyPr>
-          <a:lstStyle xmlns:a="http://schemas.openxmlformats.org/drawingml/2006/main"/>
-          <a:p xmlns:a="http://schemas.openxmlformats.org/drawingml/2006/main">
-            <a:pPr>
-              <a:defRPr sz="2325" b="1">
-                <a:solidFill>
-                  <a:srgbClr val="183F3B"/>
-                </a:solidFill>
-                <a:latin typeface="Arial"/>
-                <a:ea typeface="Arial"/>
-                <a:cs typeface="Arial"/>
-              </a:defRPr>
-            </a:pPr>
-            <a:r>
-              <a:rPr sz="2325" b="1">
-                <a:solidFill>
-                  <a:srgbClr val="183F3B"/>
-                </a:solidFill>
-                <a:latin typeface="Arial"/>
-                <a:ea typeface="Arial"/>
-                <a:cs typeface="Arial"/>
-              </a:rPr>
-              <a:t>Cannot save?</a:t>
-            </a:r>
-          </a:p>
-        </p:txBody>
-      </p:sp>
-      <p:sp>
-        <p:nvSpPr>
-          <p:cNvPr id="6" name="">
-            <a:extLst xmlns:a="http://schemas.openxmlformats.org/drawingml/2006/main">
-              <a:ext uri="{FF2B5EF4-FFF2-40B4-BE49-F238E27FC236}">
-                <a16:creationId xmlns:a16="http://schemas.microsoft.com/office/drawing/2014/main" id="{003CC0B3-161C-44D3-9D40-4EED3231B9EB}"/>
-              </a:ext>
-            </a:extLst>
-          </p:cNvPr>
-          <p:cNvSpPr>
-            <a:spLocks xmlns:a="http://schemas.openxmlformats.org/drawingml/2006/main" noGrp="1"/>
-          </p:cNvSpPr>
-          <p:nvPr/>
-        </p:nvSpPr>
-        <p:spPr>
-          <a:xfrm xmlns:a="http://schemas.openxmlformats.org/drawingml/2006/main">
-            <a:off x="6400800" y="2066925"/>
-            <a:ext cx="5162550" cy="1257300"/>
-          </a:xfrm>
-          <a:prstGeom xmlns:a="http://schemas.openxmlformats.org/drawingml/2006/main" prst="rect">
-            <a:avLst/>
-          </a:prstGeom>
-          <a:noFill xmlns:a="http://schemas.openxmlformats.org/drawingml/2006/main"/>
-          <a:ln xmlns:a="http://schemas.openxmlformats.org/drawingml/2006/main" w="0">
-            <a:noFill/>
-          </a:ln>
-        </p:spPr>
-        <p:txBody>
-          <a:bodyPr xmlns:a="http://schemas.openxmlformats.org/drawingml/2006/main">
-            <a:noAutofit/>
-          </a:bodyPr>
-          <a:lstStyle xmlns:a="http://schemas.openxmlformats.org/drawingml/2006/main"/>
-          <a:p xmlns:a="http://schemas.openxmlformats.org/drawingml/2006/main">
-            <a:pPr>
-              <a:defRPr sz="1950" b="0">
-                <a:solidFill>
-                  <a:srgbClr val="283A39"/>
-                </a:solidFill>
-                <a:latin typeface="Arial"/>
-                <a:ea typeface="Arial"/>
-                <a:cs typeface="Arial"/>
-              </a:defRPr>
-            </a:pPr>
-            <a:r>
-              <a:rPr sz="1950" b="0">
-                <a:solidFill>
-                  <a:srgbClr val="283A39"/>
-                </a:solidFill>
-                <a:latin typeface="Arial"/>
-                <a:ea typeface="Arial"/>
-                <a:cs typeface="Arial"/>
-              </a:rPr>
-              <a:t>Check the selected folder and file</a:t>
-            </a:r>
-          </a:p>
-          <a:p xmlns:a="http://schemas.openxmlformats.org/drawingml/2006/main">
-            <a:pPr>
-              <a:defRPr sz="1950" b="0">
-                <a:solidFill>
-                  <a:srgbClr val="283A39"/>
-                </a:solidFill>
-                <a:latin typeface="Arial"/>
-                <a:ea typeface="Arial"/>
-                <a:cs typeface="Arial"/>
-              </a:defRPr>
-            </a:pPr>
-            <a:r>
-              <a:rPr sz="1950" b="0">
-                <a:solidFill>
-                  <a:srgbClr val="283A39"/>
-                </a:solidFill>
-                <a:latin typeface="Arial"/>
-                <a:ea typeface="Arial"/>
-                <a:cs typeface="Arial"/>
-              </a:rPr>
-              <a:t>permissions. Approve the specific</a:t>
-            </a:r>
-          </a:p>
-          <a:p xmlns:a="http://schemas.openxmlformats.org/drawingml/2006/main">
-            <a:pPr>
-              <a:defRPr sz="1950" b="0">
-                <a:solidFill>
-                  <a:srgbClr val="283A39"/>
-                </a:solidFill>
-                <a:latin typeface="Arial"/>
-                <a:ea typeface="Arial"/>
-                <a:cs typeface="Arial"/>
-              </a:defRPr>
-            </a:pPr>
-            <a:r>
-              <a:rPr sz="1950" b="0">
-                <a:solidFill>
-                  <a:srgbClr val="283A39"/>
-                </a:solidFill>
-                <a:latin typeface="Arial"/>
-                <a:ea typeface="Arial"/>
-                <a:cs typeface="Arial"/>
-              </a:rPr>
-              <a:t>access request if you want it to proceed.</a:t>
-            </a:r>
-          </a:p>
-        </p:txBody>
-      </p:sp>
-      <p:sp>
-        <p:nvSpPr>
-          <p:cNvPr id="7" name="">
-            <a:extLst xmlns:a="http://schemas.openxmlformats.org/drawingml/2006/main">
-              <a:ext uri="{FF2B5EF4-FFF2-40B4-BE49-F238E27FC236}">
-                <a16:creationId xmlns:a16="http://schemas.microsoft.com/office/drawing/2014/main" id="{0E9B263E-FC01-49BE-B2BA-C26D45998050}"/>
-              </a:ext>
-            </a:extLst>
-          </p:cNvPr>
-          <p:cNvSpPr>
-            <a:spLocks xmlns:a="http://schemas.openxmlformats.org/drawingml/2006/main" noGrp="1"/>
-          </p:cNvSpPr>
-          <p:nvPr/>
-        </p:nvSpPr>
-        <p:spPr>
-          <a:xfrm xmlns:a="http://schemas.openxmlformats.org/drawingml/2006/main">
-            <a:off x="609600" y="3810000"/>
-            <a:ext cx="10953750" cy="457200"/>
-          </a:xfrm>
-          <a:prstGeom xmlns:a="http://schemas.openxmlformats.org/drawingml/2006/main" prst="rect">
-            <a:avLst/>
-          </a:prstGeom>
-          <a:noFill xmlns:a="http://schemas.openxmlformats.org/drawingml/2006/main"/>
-          <a:ln xmlns:a="http://schemas.openxmlformats.org/drawingml/2006/main" w="0">
-            <a:noFill/>
-          </a:ln>
-        </p:spPr>
-        <p:txBody>
-          <a:bodyPr xmlns:a="http://schemas.openxmlformats.org/drawingml/2006/main">
-            <a:noAutofit/>
-          </a:bodyPr>
-          <a:lstStyle xmlns:a="http://schemas.openxmlformats.org/drawingml/2006/main"/>
-          <a:p xmlns:a="http://schemas.openxmlformats.org/drawingml/2006/main">
-            <a:pPr>
-              <a:defRPr sz="2325" b="1">
-                <a:solidFill>
-                  <a:srgbClr val="183F3B"/>
-                </a:solidFill>
-                <a:latin typeface="Arial"/>
-                <a:ea typeface="Arial"/>
-                <a:cs typeface="Arial"/>
-              </a:defRPr>
-            </a:pPr>
-            <a:r>
-              <a:rPr sz="2325" b="1">
-                <a:solidFill>
-                  <a:srgbClr val="183F3B"/>
-                </a:solidFill>
-                <a:latin typeface="Arial"/>
-                <a:ea typeface="Arial"/>
-                <a:cs typeface="Arial"/>
-              </a:rPr>
-              <a:t>New chat cannot find your records?</a:t>
+              <a:t>Use the AI message box after installation, in the same project.</a:t>
             </a:r>
           </a:p>
         </p:txBody>
@@ -4187,135 +4285,54 @@
           <p:cNvPr id="8" name="">
             <a:extLst xmlns:a="http://schemas.openxmlformats.org/drawingml/2006/main">
               <a:ext uri="{FF2B5EF4-FFF2-40B4-BE49-F238E27FC236}">
-                <a16:creationId xmlns:a16="http://schemas.microsoft.com/office/drawing/2014/main" id="{D7E41856-6EE7-448A-A5B0-4E88BD2CEF4A}"/>
-              </a:ext>
-            </a:extLst>
-          </p:cNvPr>
-          <p:cNvSpPr>
-            <a:spLocks xmlns:a="http://schemas.openxmlformats.org/drawingml/2006/main" noGrp="1"/>
-          </p:cNvSpPr>
-          <p:nvPr/>
-        </p:nvSpPr>
-        <p:spPr>
-          <a:xfrm xmlns:a="http://schemas.openxmlformats.org/drawingml/2006/main">
-            <a:off x="609600" y="4400550"/>
-            <a:ext cx="10906125" cy="952500"/>
-          </a:xfrm>
-          <a:prstGeom xmlns:a="http://schemas.openxmlformats.org/drawingml/2006/main" prst="rect">
-            <a:avLst/>
-          </a:prstGeom>
-          <a:noFill xmlns:a="http://schemas.openxmlformats.org/drawingml/2006/main"/>
-          <a:ln xmlns:a="http://schemas.openxmlformats.org/drawingml/2006/main" w="0">
-            <a:noFill/>
-          </a:ln>
-        </p:spPr>
-        <p:txBody>
-          <a:bodyPr xmlns:a="http://schemas.openxmlformats.org/drawingml/2006/main">
-            <a:noAutofit/>
-          </a:bodyPr>
-          <a:lstStyle xmlns:a="http://schemas.openxmlformats.org/drawingml/2006/main"/>
-          <a:p xmlns:a="http://schemas.openxmlformats.org/drawingml/2006/main">
-            <a:pPr>
-              <a:defRPr sz="2100" b="0">
-                <a:solidFill>
-                  <a:srgbClr val="283A39"/>
-                </a:solidFill>
-                <a:latin typeface="Arial"/>
-                <a:ea typeface="Arial"/>
-                <a:cs typeface="Arial"/>
-              </a:defRPr>
-            </a:pPr>
-            <a:r>
-              <a:rPr sz="2100" b="0">
-                <a:solidFill>
-                  <a:srgbClr val="283A39"/>
-                </a:solidFill>
-                <a:latin typeface="Arial"/>
-                <a:ea typeface="Arial"/>
-                <a:cs typeface="Arial"/>
-              </a:rPr>
-              <a:t>Provide the private records location the AI gave you. Say:</a:t>
-            </a:r>
-          </a:p>
-          <a:p xmlns:a="http://schemas.openxmlformats.org/drawingml/2006/main">
-            <a:pPr>
-              <a:defRPr sz="2100" b="0">
-                <a:solidFill>
-                  <a:srgbClr val="283A39"/>
-                </a:solidFill>
-                <a:latin typeface="Arial"/>
-                <a:ea typeface="Arial"/>
-                <a:cs typeface="Arial"/>
-              </a:defRPr>
-            </a:pPr>
-            <a:r>
-              <a:rPr sz="2100" b="0">
-                <a:solidFill>
-                  <a:srgbClr val="283A39"/>
-                </a:solidFill>
-                <a:latin typeface="Arial"/>
-                <a:ea typeface="Arial"/>
-                <a:cs typeface="Arial"/>
-              </a:rPr>
-              <a:t>“Resume my existing search here; do not start over.”</a:t>
-            </a:r>
-          </a:p>
-        </p:txBody>
-      </p:sp>
-      <p:sp>
-        <p:nvSpPr>
-          <p:cNvPr id="9" name="">
-            <a:extLst xmlns:a="http://schemas.openxmlformats.org/drawingml/2006/main">
-              <a:ext uri="{FF2B5EF4-FFF2-40B4-BE49-F238E27FC236}">
-                <a16:creationId xmlns:a16="http://schemas.microsoft.com/office/drawing/2014/main" id="{6E4D2406-48CF-4F5D-BC8E-CA87EB99416C}"/>
-              </a:ext>
-            </a:extLst>
-          </p:cNvPr>
-          <p:cNvSpPr>
-            <a:spLocks xmlns:a="http://schemas.openxmlformats.org/drawingml/2006/main" noGrp="1"/>
-          </p:cNvSpPr>
-          <p:nvPr/>
-        </p:nvSpPr>
-        <p:spPr>
-          <a:xfrm xmlns:a="http://schemas.openxmlformats.org/drawingml/2006/main">
-            <a:off x="609600" y="5810250"/>
-            <a:ext cx="9810750" cy="361950"/>
-          </a:xfrm>
-          <a:prstGeom xmlns:a="http://schemas.openxmlformats.org/drawingml/2006/main" prst="rect">
-            <a:avLst/>
-          </a:prstGeom>
-          <a:noFill xmlns:a="http://schemas.openxmlformats.org/drawingml/2006/main"/>
-          <a:ln xmlns:a="http://schemas.openxmlformats.org/drawingml/2006/main" w="0">
-            <a:noFill/>
-          </a:ln>
-        </p:spPr>
-        <p:txBody>
-          <a:bodyPr xmlns:a="http://schemas.openxmlformats.org/drawingml/2006/main">
-            <a:noAutofit/>
-          </a:bodyPr>
-          <a:lstStyle xmlns:a="http://schemas.openxmlformats.org/drawingml/2006/main"/>
-          <a:p xmlns:a="http://schemas.openxmlformats.org/drawingml/2006/main">
-            <a:pPr>
-              <a:defRPr sz="1875" b="0">
-                <a:solidFill>
-                  <a:srgbClr val="087F73"/>
-                </a:solidFill>
-                <a:latin typeface="Arial"/>
-                <a:ea typeface="Arial"/>
-                <a:cs typeface="Arial"/>
-              </a:defRPr>
-            </a:pPr>
-            <a:r>
-              <a:rPr sz="1875" b="0">
-                <a:solidFill>
-                  <a:srgbClr val="087F73"/>
-                </a:solidFill>
-                <a:latin typeface="Arial"/>
-                <a:ea typeface="Arial"/>
-                <a:cs typeface="Arial"/>
-                <a:hlinkClick xmlns:r="http://schemas.openxmlformats.org/officeDocument/2006/relationships" r:id="R1e113b9a8ae4475c"/>
-              </a:rPr>
-              <a:t>Full guide, downloads and troubleshooting</a:t>
+                <a16:creationId xmlns:a16="http://schemas.microsoft.com/office/drawing/2014/main" id="{4FBED212-69DD-4893-8337-A207C56A294C}"/>
+              </a:ext>
+            </a:extLst>
+          </p:cNvPr>
+          <p:cNvSpPr>
+            <a:spLocks xmlns:a="http://schemas.openxmlformats.org/drawingml/2006/main" noGrp="1"/>
+          </p:cNvSpPr>
+          <p:nvPr/>
+        </p:nvSpPr>
+        <p:spPr>
+          <a:xfrm xmlns:a="http://schemas.openxmlformats.org/drawingml/2006/main">
+            <a:off x="609600" y="5981700"/>
+            <a:ext cx="10858500" cy="361950"/>
+          </a:xfrm>
+          <a:prstGeom xmlns:a="http://schemas.openxmlformats.org/drawingml/2006/main" prst="rect">
+            <a:avLst/>
+          </a:prstGeom>
+          <a:noFill xmlns:a="http://schemas.openxmlformats.org/drawingml/2006/main"/>
+          <a:ln xmlns:a="http://schemas.openxmlformats.org/drawingml/2006/main" w="0">
+            <a:noFill/>
+          </a:ln>
+        </p:spPr>
+        <p:txBody>
+          <a:bodyPr xmlns:a="http://schemas.openxmlformats.org/drawingml/2006/main">
+            <a:noAutofit/>
+          </a:bodyPr>
+          <a:lstStyle xmlns:a="http://schemas.openxmlformats.org/drawingml/2006/main"/>
+          <a:p xmlns:a="http://schemas.openxmlformats.org/drawingml/2006/main">
+            <a:pPr>
+              <a:defRPr sz="1650" b="0">
+                <a:solidFill>
+                  <a:srgbClr val="607370"/>
+                </a:solidFill>
+                <a:latin typeface="Arial"/>
+                <a:ea typeface="Arial"/>
+                <a:cs typeface="Arial"/>
+              </a:defRPr>
+            </a:pPr>
+            <a:r>
+              <a:rPr sz="1650" b="0">
+                <a:solidFill>
+                  <a:srgbClr val="607370"/>
+                </a:solidFill>
+                <a:latin typeface="Arial"/>
+                <a:ea typeface="Arial"/>
+                <a:cs typeface="Arial"/>
+              </a:rPr>
+              <a:t>If the picker cannot find it, send: “Use job-search.” Ask the AI to check installation if needed.</a:t>
             </a:r>
           </a:p>
         </p:txBody>
@@ -4323,7 +4340,1059 @@
     </p:spTree>
     <p:extLst>
       <p:ext uri="{BB962C8B-B14F-4D97-AF65-F5344CB8AC3E}">
-        <p14:creationId xmlns:p14="http://schemas.microsoft.com/office/powerpoint/2010/main" val="670026719"/>
+        <p14:creationId xmlns:p14="http://schemas.microsoft.com/office/powerpoint/2010/main" val="1781052117"/>
+      </p:ext>
+    </p:extLst>
+  </p:cSld>
+</p:sld>
+</file>
+
+<file path=ppt/slides/slide14.xml><?xml version="1.0" encoding="utf-8"?>
+<p:sld xmlns:p="http://schemas.openxmlformats.org/presentationml/2006/main">
+  <p:cSld>
+    <p:bg>
+      <p:bgPr>
+        <a:solidFill xmlns:a="http://schemas.openxmlformats.org/drawingml/2006/main">
+          <a:srgbClr val="FAFCFA"/>
+        </a:solidFill>
+      </p:bgPr>
+    </p:bg>
+    <p:spTree>
+      <p:nvGrpSpPr>
+        <p:cNvPr id="1" name=""/>
+        <p:cNvGrpSpPr/>
+        <p:nvPr/>
+      </p:nvGrpSpPr>
+      <p:grpSpPr>
+        <a:xfrm xmlns:a="http://schemas.openxmlformats.org/drawingml/2006/main"/>
+      </p:grpSpPr>
+      <p:sp>
+        <p:nvSpPr>
+          <p:cNvPr id="7" name="">
+            <a:extLst xmlns:a="http://schemas.openxmlformats.org/drawingml/2006/main">
+              <a:ext uri="{FF2B5EF4-FFF2-40B4-BE49-F238E27FC236}">
+                <a16:creationId xmlns:a16="http://schemas.microsoft.com/office/drawing/2014/main" id="{73FD58BF-F86D-4705-8654-463A36E6520D}"/>
+              </a:ext>
+            </a:extLst>
+          </p:cNvPr>
+          <p:cNvSpPr>
+            <a:spLocks xmlns:a="http://schemas.openxmlformats.org/drawingml/2006/main" noGrp="1"/>
+          </p:cNvSpPr>
+          <p:nvPr/>
+        </p:nvSpPr>
+        <p:spPr>
+          <a:xfrm xmlns:a="http://schemas.openxmlformats.org/drawingml/2006/main">
+            <a:off x="609600" y="457200"/>
+            <a:ext cx="10972800" cy="742950"/>
+          </a:xfrm>
+          <a:prstGeom xmlns:a="http://schemas.openxmlformats.org/drawingml/2006/main" prst="rect">
+            <a:avLst/>
+          </a:prstGeom>
+          <a:noFill xmlns:a="http://schemas.openxmlformats.org/drawingml/2006/main"/>
+          <a:ln xmlns:a="http://schemas.openxmlformats.org/drawingml/2006/main" w="0">
+            <a:noFill/>
+          </a:ln>
+        </p:spPr>
+        <p:txBody>
+          <a:bodyPr xmlns:a="http://schemas.openxmlformats.org/drawingml/2006/main">
+            <a:noAutofit/>
+          </a:bodyPr>
+          <a:lstStyle xmlns:a="http://schemas.openxmlformats.org/drawingml/2006/main"/>
+          <a:p xmlns:a="http://schemas.openxmlformats.org/drawingml/2006/main">
+            <a:pPr>
+              <a:defRPr sz="3450" b="1">
+                <a:solidFill>
+                  <a:srgbClr val="183F3B"/>
+                </a:solidFill>
+                <a:latin typeface="Arial"/>
+                <a:ea typeface="Arial"/>
+                <a:cs typeface="Arial"/>
+              </a:defRPr>
+            </a:pPr>
+            <a:r>
+              <a:rPr sz="3450" b="1">
+                <a:solidFill>
+                  <a:srgbClr val="183F3B"/>
+                </a:solidFill>
+                <a:latin typeface="Arial"/>
+                <a:ea typeface="Arial"/>
+                <a:cs typeface="Arial"/>
+              </a:rPr>
+              <a:t>6. Next time</a:t>
+            </a:r>
+          </a:p>
+        </p:txBody>
+      </p:sp>
+      <p:sp>
+        <p:nvSpPr>
+          <p:cNvPr id="2" name="">
+            <a:extLst xmlns:a="http://schemas.openxmlformats.org/drawingml/2006/main">
+              <a:ext uri="{FF2B5EF4-FFF2-40B4-BE49-F238E27FC236}">
+                <a16:creationId xmlns:a16="http://schemas.microsoft.com/office/drawing/2014/main" id="{37ED0DF1-CF29-4998-B55D-FBB49E8A556E}"/>
+              </a:ext>
+            </a:extLst>
+          </p:cNvPr>
+          <p:cNvSpPr>
+            <a:spLocks xmlns:a="http://schemas.openxmlformats.org/drawingml/2006/main" noGrp="1"/>
+          </p:cNvSpPr>
+          <p:nvPr/>
+        </p:nvSpPr>
+        <p:spPr>
+          <a:xfrm xmlns:a="http://schemas.openxmlformats.org/drawingml/2006/main">
+            <a:off x="11049000" y="6334125"/>
+            <a:ext cx="533400" cy="266700"/>
+          </a:xfrm>
+          <a:prstGeom xmlns:a="http://schemas.openxmlformats.org/drawingml/2006/main" prst="rect">
+            <a:avLst/>
+          </a:prstGeom>
+          <a:noFill xmlns:a="http://schemas.openxmlformats.org/drawingml/2006/main"/>
+          <a:ln xmlns:a="http://schemas.openxmlformats.org/drawingml/2006/main" w="0">
+            <a:noFill/>
+          </a:ln>
+        </p:spPr>
+        <p:txBody>
+          <a:bodyPr xmlns:a="http://schemas.openxmlformats.org/drawingml/2006/main">
+            <a:noAutofit/>
+          </a:bodyPr>
+          <a:lstStyle xmlns:a="http://schemas.openxmlformats.org/drawingml/2006/main"/>
+          <a:p xmlns:a="http://schemas.openxmlformats.org/drawingml/2006/main">
+            <a:pPr>
+              <a:defRPr sz="1350" b="0">
+                <a:solidFill>
+                  <a:srgbClr val="607370"/>
+                </a:solidFill>
+                <a:latin typeface="Arial"/>
+                <a:ea typeface="Arial"/>
+                <a:cs typeface="Arial"/>
+              </a:defRPr>
+            </a:pPr>
+            <a:r>
+              <a:rPr sz="1350" b="0">
+                <a:solidFill>
+                  <a:srgbClr val="607370"/>
+                </a:solidFill>
+                <a:latin typeface="Arial"/>
+                <a:ea typeface="Arial"/>
+                <a:cs typeface="Arial"/>
+              </a:rPr>
+              <a:t>14</a:t>
+            </a:r>
+          </a:p>
+        </p:txBody>
+      </p:sp>
+      <p:sp>
+        <p:nvSpPr>
+          <p:cNvPr id="3" name="">
+            <a:extLst xmlns:a="http://schemas.openxmlformats.org/drawingml/2006/main">
+              <a:ext uri="{FF2B5EF4-FFF2-40B4-BE49-F238E27FC236}">
+                <a16:creationId xmlns:a16="http://schemas.microsoft.com/office/drawing/2014/main" id="{CAFD4512-5C26-4CEE-858E-A463EB371CDE}"/>
+              </a:ext>
+            </a:extLst>
+          </p:cNvPr>
+          <p:cNvSpPr>
+            <a:spLocks xmlns:a="http://schemas.openxmlformats.org/drawingml/2006/main" noGrp="1"/>
+          </p:cNvSpPr>
+          <p:nvPr/>
+        </p:nvSpPr>
+        <p:spPr>
+          <a:xfrm xmlns:a="http://schemas.openxmlformats.org/drawingml/2006/main">
+            <a:off x="609600" y="1466850"/>
+            <a:ext cx="10820400" cy="752475"/>
+          </a:xfrm>
+          <a:prstGeom xmlns:a="http://schemas.openxmlformats.org/drawingml/2006/main" prst="rect">
+            <a:avLst/>
+          </a:prstGeom>
+          <a:noFill xmlns:a="http://schemas.openxmlformats.org/drawingml/2006/main"/>
+          <a:ln xmlns:a="http://schemas.openxmlformats.org/drawingml/2006/main" w="0">
+            <a:noFill/>
+          </a:ln>
+        </p:spPr>
+        <p:txBody>
+          <a:bodyPr xmlns:a="http://schemas.openxmlformats.org/drawingml/2006/main">
+            <a:noAutofit/>
+          </a:bodyPr>
+          <a:lstStyle xmlns:a="http://schemas.openxmlformats.org/drawingml/2006/main"/>
+          <a:p xmlns:a="http://schemas.openxmlformats.org/drawingml/2006/main">
+            <a:pPr>
+              <a:defRPr sz="2250" b="0">
+                <a:solidFill>
+                  <a:srgbClr val="283A39"/>
+                </a:solidFill>
+                <a:latin typeface="Arial"/>
+                <a:ea typeface="Arial"/>
+                <a:cs typeface="Arial"/>
+              </a:defRPr>
+            </a:pPr>
+            <a:r>
+              <a:rPr sz="2250" b="0">
+                <a:solidFill>
+                  <a:srgbClr val="283A39"/>
+                </a:solidFill>
+                <a:latin typeface="Arial"/>
+                <a:ea typeface="Arial"/>
+                <a:cs typeface="Arial"/>
+              </a:rPr>
+              <a:t>a. Reopen the same local project and conversation.</a:t>
+            </a:r>
+          </a:p>
+          <a:p xmlns:a="http://schemas.openxmlformats.org/drawingml/2006/main">
+            <a:pPr>
+              <a:defRPr sz="2250" b="0">
+                <a:solidFill>
+                  <a:srgbClr val="283A39"/>
+                </a:solidFill>
+                <a:latin typeface="Arial"/>
+                <a:ea typeface="Arial"/>
+                <a:cs typeface="Arial"/>
+              </a:defRPr>
+            </a:pPr>
+            <a:r>
+              <a:rPr sz="2250" b="0">
+                <a:solidFill>
+                  <a:srgbClr val="283A39"/>
+                </a:solidFill>
+                <a:latin typeface="Arial"/>
+                <a:ea typeface="Arial"/>
+                <a:cs typeface="Arial"/>
+              </a:rPr>
+              <a:t>b. Summon job-search, then send:</a:t>
+            </a:r>
+          </a:p>
+        </p:txBody>
+      </p:sp>
+      <p:sp>
+        <p:nvSpPr>
+          <p:cNvPr id="4" name="">
+            <a:extLst xmlns:a="http://schemas.openxmlformats.org/drawingml/2006/main">
+              <a:ext uri="{FF2B5EF4-FFF2-40B4-BE49-F238E27FC236}">
+                <a16:creationId xmlns:a16="http://schemas.microsoft.com/office/drawing/2014/main" id="{B262F711-197F-4AB4-BBAD-78CBF2918C6F}"/>
+              </a:ext>
+            </a:extLst>
+          </p:cNvPr>
+          <p:cNvSpPr>
+            <a:spLocks xmlns:a="http://schemas.openxmlformats.org/drawingml/2006/main" noGrp="1"/>
+          </p:cNvSpPr>
+          <p:nvPr/>
+        </p:nvSpPr>
+        <p:spPr>
+          <a:xfrm xmlns:a="http://schemas.openxmlformats.org/drawingml/2006/main">
+            <a:off x="609600" y="2828925"/>
+            <a:ext cx="10858500" cy="819150"/>
+          </a:xfrm>
+          <a:prstGeom xmlns:a="http://schemas.openxmlformats.org/drawingml/2006/main" prst="rect">
+            <a:avLst/>
+          </a:prstGeom>
+          <a:noFill xmlns:a="http://schemas.openxmlformats.org/drawingml/2006/main"/>
+          <a:ln xmlns:a="http://schemas.openxmlformats.org/drawingml/2006/main" w="0">
+            <a:noFill/>
+          </a:ln>
+        </p:spPr>
+        <p:txBody>
+          <a:bodyPr xmlns:a="http://schemas.openxmlformats.org/drawingml/2006/main">
+            <a:noAutofit/>
+          </a:bodyPr>
+          <a:lstStyle xmlns:a="http://schemas.openxmlformats.org/drawingml/2006/main"/>
+          <a:p xmlns:a="http://schemas.openxmlformats.org/drawingml/2006/main">
+            <a:pPr>
+              <a:defRPr sz="3675" b="1">
+                <a:solidFill>
+                  <a:srgbClr val="183F3B"/>
+                </a:solidFill>
+                <a:latin typeface="Arial"/>
+                <a:ea typeface="Arial"/>
+                <a:cs typeface="Arial"/>
+              </a:defRPr>
+            </a:pPr>
+            <a:r>
+              <a:rPr sz="3675" b="1">
+                <a:solidFill>
+                  <a:srgbClr val="183F3B"/>
+                </a:solidFill>
+                <a:latin typeface="Arial"/>
+                <a:ea typeface="Arial"/>
+                <a:cs typeface="Arial"/>
+              </a:rPr>
+              <a:t>Continue my job search.</a:t>
+            </a:r>
+          </a:p>
+        </p:txBody>
+      </p:sp>
+      <p:sp>
+        <p:nvSpPr>
+          <p:cNvPr id="5" name="">
+            <a:extLst xmlns:a="http://schemas.openxmlformats.org/drawingml/2006/main">
+              <a:ext uri="{FF2B5EF4-FFF2-40B4-BE49-F238E27FC236}">
+                <a16:creationId xmlns:a16="http://schemas.microsoft.com/office/drawing/2014/main" id="{71B3FAB8-8D0D-4354-BF43-DAE04D89E01C}"/>
+              </a:ext>
+            </a:extLst>
+          </p:cNvPr>
+          <p:cNvSpPr>
+            <a:spLocks xmlns:a="http://schemas.openxmlformats.org/drawingml/2006/main" noGrp="1"/>
+          </p:cNvSpPr>
+          <p:nvPr/>
+        </p:nvSpPr>
+        <p:spPr>
+          <a:xfrm xmlns:a="http://schemas.openxmlformats.org/drawingml/2006/main">
+            <a:off x="609600" y="4286250"/>
+            <a:ext cx="10858500" cy="952500"/>
+          </a:xfrm>
+          <a:prstGeom xmlns:a="http://schemas.openxmlformats.org/drawingml/2006/main" prst="rect">
+            <a:avLst/>
+          </a:prstGeom>
+          <a:noFill xmlns:a="http://schemas.openxmlformats.org/drawingml/2006/main"/>
+          <a:ln xmlns:a="http://schemas.openxmlformats.org/drawingml/2006/main" w="0">
+            <a:noFill/>
+          </a:ln>
+        </p:spPr>
+        <p:txBody>
+          <a:bodyPr xmlns:a="http://schemas.openxmlformats.org/drawingml/2006/main">
+            <a:noAutofit/>
+          </a:bodyPr>
+          <a:lstStyle xmlns:a="http://schemas.openxmlformats.org/drawingml/2006/main"/>
+          <a:p xmlns:a="http://schemas.openxmlformats.org/drawingml/2006/main">
+            <a:pPr>
+              <a:defRPr sz="2100" b="0">
+                <a:solidFill>
+                  <a:srgbClr val="283A39"/>
+                </a:solidFill>
+                <a:latin typeface="Arial"/>
+                <a:ea typeface="Arial"/>
+                <a:cs typeface="Arial"/>
+              </a:defRPr>
+            </a:pPr>
+            <a:r>
+              <a:rPr sz="2100" b="0">
+                <a:solidFill>
+                  <a:srgbClr val="283A39"/>
+                </a:solidFill>
+                <a:latin typeface="Arial"/>
+                <a:ea typeface="Arial"/>
+                <a:cs typeface="Arial"/>
+              </a:rPr>
+              <a:t>c. Continue from your saved progress.</a:t>
+            </a:r>
+          </a:p>
+          <a:p xmlns:a="http://schemas.openxmlformats.org/drawingml/2006/main">
+            <a:pPr>
+              <a:defRPr sz="2100" b="0">
+                <a:solidFill>
+                  <a:srgbClr val="283A39"/>
+                </a:solidFill>
+                <a:latin typeface="Arial"/>
+                <a:ea typeface="Arial"/>
+                <a:cs typeface="Arial"/>
+              </a:defRPr>
+            </a:pPr>
+            <a:r>
+              <a:rPr sz="2100" b="0">
+                <a:solidFill>
+                  <a:srgbClr val="283A39"/>
+                </a:solidFill>
+                <a:latin typeface="Arial"/>
+                <a:ea typeface="Arial"/>
+                <a:cs typeface="Arial"/>
+              </a:rPr>
+              <a:t>Supply an updated resume when it changes.</a:t>
+            </a:r>
+          </a:p>
+        </p:txBody>
+      </p:sp>
+      <p:sp>
+        <p:nvSpPr>
+          <p:cNvPr id="6" name="">
+            <a:extLst xmlns:a="http://schemas.openxmlformats.org/drawingml/2006/main">
+              <a:ext uri="{FF2B5EF4-FFF2-40B4-BE49-F238E27FC236}">
+                <a16:creationId xmlns:a16="http://schemas.microsoft.com/office/drawing/2014/main" id="{22ED202C-F301-45D8-A472-A566367DA6B6}"/>
+              </a:ext>
+            </a:extLst>
+          </p:cNvPr>
+          <p:cNvSpPr>
+            <a:spLocks xmlns:a="http://schemas.openxmlformats.org/drawingml/2006/main" noGrp="1"/>
+          </p:cNvSpPr>
+          <p:nvPr/>
+        </p:nvSpPr>
+        <p:spPr>
+          <a:xfrm xmlns:a="http://schemas.openxmlformats.org/drawingml/2006/main">
+            <a:off x="609600" y="5781675"/>
+            <a:ext cx="10858500" cy="495300"/>
+          </a:xfrm>
+          <a:prstGeom xmlns:a="http://schemas.openxmlformats.org/drawingml/2006/main" prst="rect">
+            <a:avLst/>
+          </a:prstGeom>
+          <a:noFill xmlns:a="http://schemas.openxmlformats.org/drawingml/2006/main"/>
+          <a:ln xmlns:a="http://schemas.openxmlformats.org/drawingml/2006/main" w="0">
+            <a:noFill/>
+          </a:ln>
+        </p:spPr>
+        <p:txBody>
+          <a:bodyPr xmlns:a="http://schemas.openxmlformats.org/drawingml/2006/main">
+            <a:noAutofit/>
+          </a:bodyPr>
+          <a:lstStyle xmlns:a="http://schemas.openxmlformats.org/drawingml/2006/main"/>
+          <a:p xmlns:a="http://schemas.openxmlformats.org/drawingml/2006/main">
+            <a:pPr>
+              <a:defRPr sz="1800" b="0">
+                <a:solidFill>
+                  <a:srgbClr val="607370"/>
+                </a:solidFill>
+                <a:latin typeface="Arial"/>
+                <a:ea typeface="Arial"/>
+                <a:cs typeface="Arial"/>
+              </a:defRPr>
+            </a:pPr>
+            <a:r>
+              <a:rPr sz="1800" b="0">
+                <a:solidFill>
+                  <a:srgbClr val="607370"/>
+                </a:solidFill>
+                <a:latin typeface="Arial"/>
+                <a:ea typeface="Arial"/>
+                <a:cs typeface="Arial"/>
+              </a:rPr>
+              <a:t>For an independent occupation search, use a new project with separate records.</a:t>
+            </a:r>
+          </a:p>
+        </p:txBody>
+      </p:sp>
+    </p:spTree>
+    <p:extLst>
+      <p:ext uri="{BB962C8B-B14F-4D97-AF65-F5344CB8AC3E}">
+        <p14:creationId xmlns:p14="http://schemas.microsoft.com/office/powerpoint/2010/main" val="406658693"/>
+      </p:ext>
+    </p:extLst>
+  </p:cSld>
+</p:sld>
+</file>
+
+<file path=ppt/slides/slide15.xml><?xml version="1.0" encoding="utf-8"?>
+<p:sld xmlns:p="http://schemas.openxmlformats.org/presentationml/2006/main">
+  <p:cSld>
+    <p:bg>
+      <p:bgPr>
+        <a:solidFill xmlns:a="http://schemas.openxmlformats.org/drawingml/2006/main">
+          <a:srgbClr val="FAFCFA"/>
+        </a:solidFill>
+      </p:bgPr>
+    </p:bg>
+    <p:spTree>
+      <p:nvGrpSpPr>
+        <p:cNvPr id="1" name=""/>
+        <p:cNvGrpSpPr/>
+        <p:nvPr/>
+      </p:nvGrpSpPr>
+      <p:grpSpPr>
+        <a:xfrm xmlns:a="http://schemas.openxmlformats.org/drawingml/2006/main"/>
+      </p:grpSpPr>
+      <p:sp>
+        <p:nvSpPr>
+          <p:cNvPr id="10" name="">
+            <a:extLst xmlns:a="http://schemas.openxmlformats.org/drawingml/2006/main">
+              <a:ext uri="{FF2B5EF4-FFF2-40B4-BE49-F238E27FC236}">
+                <a16:creationId xmlns:a16="http://schemas.microsoft.com/office/drawing/2014/main" id="{67466188-F260-4374-8CDE-135E8ED567AD}"/>
+              </a:ext>
+            </a:extLst>
+          </p:cNvPr>
+          <p:cNvSpPr>
+            <a:spLocks xmlns:a="http://schemas.openxmlformats.org/drawingml/2006/main" noGrp="1"/>
+          </p:cNvSpPr>
+          <p:nvPr/>
+        </p:nvSpPr>
+        <p:spPr>
+          <a:xfrm xmlns:a="http://schemas.openxmlformats.org/drawingml/2006/main">
+            <a:off x="609600" y="457200"/>
+            <a:ext cx="10972800" cy="742950"/>
+          </a:xfrm>
+          <a:prstGeom xmlns:a="http://schemas.openxmlformats.org/drawingml/2006/main" prst="rect">
+            <a:avLst/>
+          </a:prstGeom>
+          <a:noFill xmlns:a="http://schemas.openxmlformats.org/drawingml/2006/main"/>
+          <a:ln xmlns:a="http://schemas.openxmlformats.org/drawingml/2006/main" w="0">
+            <a:noFill/>
+          </a:ln>
+        </p:spPr>
+        <p:txBody>
+          <a:bodyPr xmlns:a="http://schemas.openxmlformats.org/drawingml/2006/main">
+            <a:noAutofit/>
+          </a:bodyPr>
+          <a:lstStyle xmlns:a="http://schemas.openxmlformats.org/drawingml/2006/main"/>
+          <a:p xmlns:a="http://schemas.openxmlformats.org/drawingml/2006/main">
+            <a:pPr>
+              <a:defRPr sz="3450" b="1">
+                <a:solidFill>
+                  <a:srgbClr val="183F3B"/>
+                </a:solidFill>
+                <a:latin typeface="Arial"/>
+                <a:ea typeface="Arial"/>
+                <a:cs typeface="Arial"/>
+              </a:defRPr>
+            </a:pPr>
+            <a:r>
+              <a:rPr sz="3450" b="1">
+                <a:solidFill>
+                  <a:srgbClr val="183F3B"/>
+                </a:solidFill>
+                <a:latin typeface="Arial"/>
+                <a:ea typeface="Arial"/>
+                <a:cs typeface="Arial"/>
+              </a:rPr>
+              <a:t>If something stops you</a:t>
+            </a:r>
+          </a:p>
+        </p:txBody>
+      </p:sp>
+      <p:sp>
+        <p:nvSpPr>
+          <p:cNvPr id="2" name="">
+            <a:extLst xmlns:a="http://schemas.openxmlformats.org/drawingml/2006/main">
+              <a:ext uri="{FF2B5EF4-FFF2-40B4-BE49-F238E27FC236}">
+                <a16:creationId xmlns:a16="http://schemas.microsoft.com/office/drawing/2014/main" id="{617BBB54-1070-4406-8B69-848F7CF37E16}"/>
+              </a:ext>
+            </a:extLst>
+          </p:cNvPr>
+          <p:cNvSpPr>
+            <a:spLocks xmlns:a="http://schemas.openxmlformats.org/drawingml/2006/main" noGrp="1"/>
+          </p:cNvSpPr>
+          <p:nvPr/>
+        </p:nvSpPr>
+        <p:spPr>
+          <a:xfrm xmlns:a="http://schemas.openxmlformats.org/drawingml/2006/main">
+            <a:off x="11049000" y="6334125"/>
+            <a:ext cx="533400" cy="266700"/>
+          </a:xfrm>
+          <a:prstGeom xmlns:a="http://schemas.openxmlformats.org/drawingml/2006/main" prst="rect">
+            <a:avLst/>
+          </a:prstGeom>
+          <a:noFill xmlns:a="http://schemas.openxmlformats.org/drawingml/2006/main"/>
+          <a:ln xmlns:a="http://schemas.openxmlformats.org/drawingml/2006/main" w="0">
+            <a:noFill/>
+          </a:ln>
+        </p:spPr>
+        <p:txBody>
+          <a:bodyPr xmlns:a="http://schemas.openxmlformats.org/drawingml/2006/main">
+            <a:noAutofit/>
+          </a:bodyPr>
+          <a:lstStyle xmlns:a="http://schemas.openxmlformats.org/drawingml/2006/main"/>
+          <a:p xmlns:a="http://schemas.openxmlformats.org/drawingml/2006/main">
+            <a:pPr>
+              <a:defRPr sz="1350" b="0">
+                <a:solidFill>
+                  <a:srgbClr val="607370"/>
+                </a:solidFill>
+                <a:latin typeface="Arial"/>
+                <a:ea typeface="Arial"/>
+                <a:cs typeface="Arial"/>
+              </a:defRPr>
+            </a:pPr>
+            <a:r>
+              <a:rPr sz="1350" b="0">
+                <a:solidFill>
+                  <a:srgbClr val="607370"/>
+                </a:solidFill>
+                <a:latin typeface="Arial"/>
+                <a:ea typeface="Arial"/>
+                <a:cs typeface="Arial"/>
+              </a:rPr>
+              <a:t>15</a:t>
+            </a:r>
+          </a:p>
+        </p:txBody>
+      </p:sp>
+      <p:sp>
+        <p:nvSpPr>
+          <p:cNvPr id="3" name="">
+            <a:extLst xmlns:a="http://schemas.openxmlformats.org/drawingml/2006/main">
+              <a:ext uri="{FF2B5EF4-FFF2-40B4-BE49-F238E27FC236}">
+                <a16:creationId xmlns:a16="http://schemas.microsoft.com/office/drawing/2014/main" id="{008A2FAD-50FD-47EE-994C-890146382458}"/>
+              </a:ext>
+            </a:extLst>
+          </p:cNvPr>
+          <p:cNvSpPr>
+            <a:spLocks xmlns:a="http://schemas.openxmlformats.org/drawingml/2006/main" noGrp="1"/>
+          </p:cNvSpPr>
+          <p:nvPr/>
+        </p:nvSpPr>
+        <p:spPr>
+          <a:xfrm xmlns:a="http://schemas.openxmlformats.org/drawingml/2006/main">
+            <a:off x="609600" y="1504950"/>
+            <a:ext cx="5048250" cy="428625"/>
+          </a:xfrm>
+          <a:prstGeom xmlns:a="http://schemas.openxmlformats.org/drawingml/2006/main" prst="rect">
+            <a:avLst/>
+          </a:prstGeom>
+          <a:noFill xmlns:a="http://schemas.openxmlformats.org/drawingml/2006/main"/>
+          <a:ln xmlns:a="http://schemas.openxmlformats.org/drawingml/2006/main" w="0">
+            <a:noFill/>
+          </a:ln>
+        </p:spPr>
+        <p:txBody>
+          <a:bodyPr xmlns:a="http://schemas.openxmlformats.org/drawingml/2006/main">
+            <a:noAutofit/>
+          </a:bodyPr>
+          <a:lstStyle xmlns:a="http://schemas.openxmlformats.org/drawingml/2006/main"/>
+          <a:p xmlns:a="http://schemas.openxmlformats.org/drawingml/2006/main">
+            <a:pPr>
+              <a:defRPr sz="2325" b="1">
+                <a:solidFill>
+                  <a:srgbClr val="183F3B"/>
+                </a:solidFill>
+                <a:latin typeface="Arial"/>
+                <a:ea typeface="Arial"/>
+                <a:cs typeface="Arial"/>
+              </a:defRPr>
+            </a:pPr>
+            <a:r>
+              <a:rPr sz="2325" b="1">
+                <a:solidFill>
+                  <a:srgbClr val="183F3B"/>
+                </a:solidFill>
+                <a:latin typeface="Arial"/>
+                <a:ea typeface="Arial"/>
+                <a:cs typeface="Arial"/>
+              </a:rPr>
+              <a:t>Skill missing?</a:t>
+            </a:r>
+          </a:p>
+        </p:txBody>
+      </p:sp>
+      <p:sp>
+        <p:nvSpPr>
+          <p:cNvPr id="4" name="">
+            <a:extLst xmlns:a="http://schemas.openxmlformats.org/drawingml/2006/main">
+              <a:ext uri="{FF2B5EF4-FFF2-40B4-BE49-F238E27FC236}">
+                <a16:creationId xmlns:a16="http://schemas.microsoft.com/office/drawing/2014/main" id="{60CE1827-FD2D-4620-AAF6-F9EC69D99F3D}"/>
+              </a:ext>
+            </a:extLst>
+          </p:cNvPr>
+          <p:cNvSpPr>
+            <a:spLocks xmlns:a="http://schemas.openxmlformats.org/drawingml/2006/main" noGrp="1"/>
+          </p:cNvSpPr>
+          <p:nvPr/>
+        </p:nvSpPr>
+        <p:spPr>
+          <a:xfrm xmlns:a="http://schemas.openxmlformats.org/drawingml/2006/main">
+            <a:off x="609600" y="2066925"/>
+            <a:ext cx="5191125" cy="1047750"/>
+          </a:xfrm>
+          <a:prstGeom xmlns:a="http://schemas.openxmlformats.org/drawingml/2006/main" prst="rect">
+            <a:avLst/>
+          </a:prstGeom>
+          <a:noFill xmlns:a="http://schemas.openxmlformats.org/drawingml/2006/main"/>
+          <a:ln xmlns:a="http://schemas.openxmlformats.org/drawingml/2006/main" w="0">
+            <a:noFill/>
+          </a:ln>
+        </p:spPr>
+        <p:txBody>
+          <a:bodyPr xmlns:a="http://schemas.openxmlformats.org/drawingml/2006/main">
+            <a:noAutofit/>
+          </a:bodyPr>
+          <a:lstStyle xmlns:a="http://schemas.openxmlformats.org/drawingml/2006/main"/>
+          <a:p xmlns:a="http://schemas.openxmlformats.org/drawingml/2006/main">
+            <a:pPr>
+              <a:defRPr sz="1950" b="0">
+                <a:solidFill>
+                  <a:srgbClr val="283A39"/>
+                </a:solidFill>
+                <a:latin typeface="Arial"/>
+                <a:ea typeface="Arial"/>
+                <a:cs typeface="Arial"/>
+              </a:defRPr>
+            </a:pPr>
+            <a:r>
+              <a:rPr sz="1950" b="0">
+                <a:solidFill>
+                  <a:srgbClr val="283A39"/>
+                </a:solidFill>
+                <a:latin typeface="Arial"/>
+                <a:ea typeface="Arial"/>
+                <a:cs typeface="Arial"/>
+              </a:rPr>
+              <a:t>“Check whether job-search is installed</a:t>
+            </a:r>
+          </a:p>
+          <a:p xmlns:a="http://schemas.openxmlformats.org/drawingml/2006/main">
+            <a:pPr>
+              <a:defRPr sz="1950" b="0">
+                <a:solidFill>
+                  <a:srgbClr val="283A39"/>
+                </a:solidFill>
+                <a:latin typeface="Arial"/>
+                <a:ea typeface="Arial"/>
+                <a:cs typeface="Arial"/>
+              </a:defRPr>
+            </a:pPr>
+            <a:r>
+              <a:rPr sz="1950" b="0">
+                <a:solidFill>
+                  <a:srgbClr val="283A39"/>
+                </a:solidFill>
+                <a:latin typeface="Arial"/>
+                <a:ea typeface="Arial"/>
+                <a:cs typeface="Arial"/>
+              </a:rPr>
+              <a:t>in this project and help me load it.”</a:t>
+            </a:r>
+          </a:p>
+        </p:txBody>
+      </p:sp>
+      <p:sp>
+        <p:nvSpPr>
+          <p:cNvPr id="5" name="">
+            <a:extLst xmlns:a="http://schemas.openxmlformats.org/drawingml/2006/main">
+              <a:ext uri="{FF2B5EF4-FFF2-40B4-BE49-F238E27FC236}">
+                <a16:creationId xmlns:a16="http://schemas.microsoft.com/office/drawing/2014/main" id="{20BC2229-52E5-485A-85D5-3DB0794E869E}"/>
+              </a:ext>
+            </a:extLst>
+          </p:cNvPr>
+          <p:cNvSpPr>
+            <a:spLocks xmlns:a="http://schemas.openxmlformats.org/drawingml/2006/main" noGrp="1"/>
+          </p:cNvSpPr>
+          <p:nvPr/>
+        </p:nvSpPr>
+        <p:spPr>
+          <a:xfrm xmlns:a="http://schemas.openxmlformats.org/drawingml/2006/main">
+            <a:off x="6400800" y="1504950"/>
+            <a:ext cx="5048250" cy="428625"/>
+          </a:xfrm>
+          <a:prstGeom xmlns:a="http://schemas.openxmlformats.org/drawingml/2006/main" prst="rect">
+            <a:avLst/>
+          </a:prstGeom>
+          <a:noFill xmlns:a="http://schemas.openxmlformats.org/drawingml/2006/main"/>
+          <a:ln xmlns:a="http://schemas.openxmlformats.org/drawingml/2006/main" w="0">
+            <a:noFill/>
+          </a:ln>
+        </p:spPr>
+        <p:txBody>
+          <a:bodyPr xmlns:a="http://schemas.openxmlformats.org/drawingml/2006/main">
+            <a:noAutofit/>
+          </a:bodyPr>
+          <a:lstStyle xmlns:a="http://schemas.openxmlformats.org/drawingml/2006/main"/>
+          <a:p xmlns:a="http://schemas.openxmlformats.org/drawingml/2006/main">
+            <a:pPr>
+              <a:defRPr sz="2325" b="1">
+                <a:solidFill>
+                  <a:srgbClr val="183F3B"/>
+                </a:solidFill>
+                <a:latin typeface="Arial"/>
+                <a:ea typeface="Arial"/>
+                <a:cs typeface="Arial"/>
+              </a:defRPr>
+            </a:pPr>
+            <a:r>
+              <a:rPr sz="2325" b="1">
+                <a:solidFill>
+                  <a:srgbClr val="183F3B"/>
+                </a:solidFill>
+                <a:latin typeface="Arial"/>
+                <a:ea typeface="Arial"/>
+                <a:cs typeface="Arial"/>
+              </a:rPr>
+              <a:t>Cannot save?</a:t>
+            </a:r>
+          </a:p>
+        </p:txBody>
+      </p:sp>
+      <p:sp>
+        <p:nvSpPr>
+          <p:cNvPr id="6" name="">
+            <a:extLst xmlns:a="http://schemas.openxmlformats.org/drawingml/2006/main">
+              <a:ext uri="{FF2B5EF4-FFF2-40B4-BE49-F238E27FC236}">
+                <a16:creationId xmlns:a16="http://schemas.microsoft.com/office/drawing/2014/main" id="{78B69EE7-CB31-4FF3-BA6B-0DE86E132D7B}"/>
+              </a:ext>
+            </a:extLst>
+          </p:cNvPr>
+          <p:cNvSpPr>
+            <a:spLocks xmlns:a="http://schemas.openxmlformats.org/drawingml/2006/main" noGrp="1"/>
+          </p:cNvSpPr>
+          <p:nvPr/>
+        </p:nvSpPr>
+        <p:spPr>
+          <a:xfrm xmlns:a="http://schemas.openxmlformats.org/drawingml/2006/main">
+            <a:off x="6400800" y="2066925"/>
+            <a:ext cx="5162550" cy="1257300"/>
+          </a:xfrm>
+          <a:prstGeom xmlns:a="http://schemas.openxmlformats.org/drawingml/2006/main" prst="rect">
+            <a:avLst/>
+          </a:prstGeom>
+          <a:noFill xmlns:a="http://schemas.openxmlformats.org/drawingml/2006/main"/>
+          <a:ln xmlns:a="http://schemas.openxmlformats.org/drawingml/2006/main" w="0">
+            <a:noFill/>
+          </a:ln>
+        </p:spPr>
+        <p:txBody>
+          <a:bodyPr xmlns:a="http://schemas.openxmlformats.org/drawingml/2006/main">
+            <a:noAutofit/>
+          </a:bodyPr>
+          <a:lstStyle xmlns:a="http://schemas.openxmlformats.org/drawingml/2006/main"/>
+          <a:p xmlns:a="http://schemas.openxmlformats.org/drawingml/2006/main">
+            <a:pPr>
+              <a:defRPr sz="1950" b="0">
+                <a:solidFill>
+                  <a:srgbClr val="283A39"/>
+                </a:solidFill>
+                <a:latin typeface="Arial"/>
+                <a:ea typeface="Arial"/>
+                <a:cs typeface="Arial"/>
+              </a:defRPr>
+            </a:pPr>
+            <a:r>
+              <a:rPr sz="1950" b="0">
+                <a:solidFill>
+                  <a:srgbClr val="283A39"/>
+                </a:solidFill>
+                <a:latin typeface="Arial"/>
+                <a:ea typeface="Arial"/>
+                <a:cs typeface="Arial"/>
+              </a:rPr>
+              <a:t>Check the selected folder and file</a:t>
+            </a:r>
+          </a:p>
+          <a:p xmlns:a="http://schemas.openxmlformats.org/drawingml/2006/main">
+            <a:pPr>
+              <a:defRPr sz="1950" b="0">
+                <a:solidFill>
+                  <a:srgbClr val="283A39"/>
+                </a:solidFill>
+                <a:latin typeface="Arial"/>
+                <a:ea typeface="Arial"/>
+                <a:cs typeface="Arial"/>
+              </a:defRPr>
+            </a:pPr>
+            <a:r>
+              <a:rPr sz="1950" b="0">
+                <a:solidFill>
+                  <a:srgbClr val="283A39"/>
+                </a:solidFill>
+                <a:latin typeface="Arial"/>
+                <a:ea typeface="Arial"/>
+                <a:cs typeface="Arial"/>
+              </a:rPr>
+              <a:t>permissions. Approve the specific</a:t>
+            </a:r>
+          </a:p>
+          <a:p xmlns:a="http://schemas.openxmlformats.org/drawingml/2006/main">
+            <a:pPr>
+              <a:defRPr sz="1950" b="0">
+                <a:solidFill>
+                  <a:srgbClr val="283A39"/>
+                </a:solidFill>
+                <a:latin typeface="Arial"/>
+                <a:ea typeface="Arial"/>
+                <a:cs typeface="Arial"/>
+              </a:defRPr>
+            </a:pPr>
+            <a:r>
+              <a:rPr sz="1950" b="0">
+                <a:solidFill>
+                  <a:srgbClr val="283A39"/>
+                </a:solidFill>
+                <a:latin typeface="Arial"/>
+                <a:ea typeface="Arial"/>
+                <a:cs typeface="Arial"/>
+              </a:rPr>
+              <a:t>access request if you want it to proceed.</a:t>
+            </a:r>
+          </a:p>
+        </p:txBody>
+      </p:sp>
+      <p:sp>
+        <p:nvSpPr>
+          <p:cNvPr id="7" name="">
+            <a:extLst xmlns:a="http://schemas.openxmlformats.org/drawingml/2006/main">
+              <a:ext uri="{FF2B5EF4-FFF2-40B4-BE49-F238E27FC236}">
+                <a16:creationId xmlns:a16="http://schemas.microsoft.com/office/drawing/2014/main" id="{65E77509-673C-4C3C-B8E6-FC8F19AF7324}"/>
+              </a:ext>
+            </a:extLst>
+          </p:cNvPr>
+          <p:cNvSpPr>
+            <a:spLocks xmlns:a="http://schemas.openxmlformats.org/drawingml/2006/main" noGrp="1"/>
+          </p:cNvSpPr>
+          <p:nvPr/>
+        </p:nvSpPr>
+        <p:spPr>
+          <a:xfrm xmlns:a="http://schemas.openxmlformats.org/drawingml/2006/main">
+            <a:off x="609600" y="3810000"/>
+            <a:ext cx="10953750" cy="457200"/>
+          </a:xfrm>
+          <a:prstGeom xmlns:a="http://schemas.openxmlformats.org/drawingml/2006/main" prst="rect">
+            <a:avLst/>
+          </a:prstGeom>
+          <a:noFill xmlns:a="http://schemas.openxmlformats.org/drawingml/2006/main"/>
+          <a:ln xmlns:a="http://schemas.openxmlformats.org/drawingml/2006/main" w="0">
+            <a:noFill/>
+          </a:ln>
+        </p:spPr>
+        <p:txBody>
+          <a:bodyPr xmlns:a="http://schemas.openxmlformats.org/drawingml/2006/main">
+            <a:noAutofit/>
+          </a:bodyPr>
+          <a:lstStyle xmlns:a="http://schemas.openxmlformats.org/drawingml/2006/main"/>
+          <a:p xmlns:a="http://schemas.openxmlformats.org/drawingml/2006/main">
+            <a:pPr>
+              <a:defRPr sz="2325" b="1">
+                <a:solidFill>
+                  <a:srgbClr val="183F3B"/>
+                </a:solidFill>
+                <a:latin typeface="Arial"/>
+                <a:ea typeface="Arial"/>
+                <a:cs typeface="Arial"/>
+              </a:defRPr>
+            </a:pPr>
+            <a:r>
+              <a:rPr sz="2325" b="1">
+                <a:solidFill>
+                  <a:srgbClr val="183F3B"/>
+                </a:solidFill>
+                <a:latin typeface="Arial"/>
+                <a:ea typeface="Arial"/>
+                <a:cs typeface="Arial"/>
+              </a:rPr>
+              <a:t>New chat cannot find your records?</a:t>
+            </a:r>
+          </a:p>
+        </p:txBody>
+      </p:sp>
+      <p:sp>
+        <p:nvSpPr>
+          <p:cNvPr id="8" name="">
+            <a:extLst xmlns:a="http://schemas.openxmlformats.org/drawingml/2006/main">
+              <a:ext uri="{FF2B5EF4-FFF2-40B4-BE49-F238E27FC236}">
+                <a16:creationId xmlns:a16="http://schemas.microsoft.com/office/drawing/2014/main" id="{D1ED06C3-E6E8-4F06-80B6-078AF56141F8}"/>
+              </a:ext>
+            </a:extLst>
+          </p:cNvPr>
+          <p:cNvSpPr>
+            <a:spLocks xmlns:a="http://schemas.openxmlformats.org/drawingml/2006/main" noGrp="1"/>
+          </p:cNvSpPr>
+          <p:nvPr/>
+        </p:nvSpPr>
+        <p:spPr>
+          <a:xfrm xmlns:a="http://schemas.openxmlformats.org/drawingml/2006/main">
+            <a:off x="609600" y="4400550"/>
+            <a:ext cx="10906125" cy="952500"/>
+          </a:xfrm>
+          <a:prstGeom xmlns:a="http://schemas.openxmlformats.org/drawingml/2006/main" prst="rect">
+            <a:avLst/>
+          </a:prstGeom>
+          <a:noFill xmlns:a="http://schemas.openxmlformats.org/drawingml/2006/main"/>
+          <a:ln xmlns:a="http://schemas.openxmlformats.org/drawingml/2006/main" w="0">
+            <a:noFill/>
+          </a:ln>
+        </p:spPr>
+        <p:txBody>
+          <a:bodyPr xmlns:a="http://schemas.openxmlformats.org/drawingml/2006/main">
+            <a:noAutofit/>
+          </a:bodyPr>
+          <a:lstStyle xmlns:a="http://schemas.openxmlformats.org/drawingml/2006/main"/>
+          <a:p xmlns:a="http://schemas.openxmlformats.org/drawingml/2006/main">
+            <a:pPr>
+              <a:defRPr sz="2100" b="0">
+                <a:solidFill>
+                  <a:srgbClr val="283A39"/>
+                </a:solidFill>
+                <a:latin typeface="Arial"/>
+                <a:ea typeface="Arial"/>
+                <a:cs typeface="Arial"/>
+              </a:defRPr>
+            </a:pPr>
+            <a:r>
+              <a:rPr sz="2100" b="0">
+                <a:solidFill>
+                  <a:srgbClr val="283A39"/>
+                </a:solidFill>
+                <a:latin typeface="Arial"/>
+                <a:ea typeface="Arial"/>
+                <a:cs typeface="Arial"/>
+              </a:rPr>
+              <a:t>Provide the private records location the AI gave you. Say:</a:t>
+            </a:r>
+          </a:p>
+          <a:p xmlns:a="http://schemas.openxmlformats.org/drawingml/2006/main">
+            <a:pPr>
+              <a:defRPr sz="2100" b="0">
+                <a:solidFill>
+                  <a:srgbClr val="283A39"/>
+                </a:solidFill>
+                <a:latin typeface="Arial"/>
+                <a:ea typeface="Arial"/>
+                <a:cs typeface="Arial"/>
+              </a:defRPr>
+            </a:pPr>
+            <a:r>
+              <a:rPr sz="2100" b="0">
+                <a:solidFill>
+                  <a:srgbClr val="283A39"/>
+                </a:solidFill>
+                <a:latin typeface="Arial"/>
+                <a:ea typeface="Arial"/>
+                <a:cs typeface="Arial"/>
+              </a:rPr>
+              <a:t>“Resume my existing search here; do not start over.”</a:t>
+            </a:r>
+          </a:p>
+        </p:txBody>
+      </p:sp>
+      <p:sp>
+        <p:nvSpPr>
+          <p:cNvPr id="9" name="">
+            <a:extLst xmlns:a="http://schemas.openxmlformats.org/drawingml/2006/main">
+              <a:ext uri="{FF2B5EF4-FFF2-40B4-BE49-F238E27FC236}">
+                <a16:creationId xmlns:a16="http://schemas.microsoft.com/office/drawing/2014/main" id="{245D5E1D-04CF-4F86-8957-A569435B295A}"/>
+              </a:ext>
+            </a:extLst>
+          </p:cNvPr>
+          <p:cNvSpPr>
+            <a:spLocks xmlns:a="http://schemas.openxmlformats.org/drawingml/2006/main" noGrp="1"/>
+          </p:cNvSpPr>
+          <p:nvPr/>
+        </p:nvSpPr>
+        <p:spPr>
+          <a:xfrm xmlns:a="http://schemas.openxmlformats.org/drawingml/2006/main">
+            <a:off x="609600" y="5810250"/>
+            <a:ext cx="9810750" cy="361950"/>
+          </a:xfrm>
+          <a:prstGeom xmlns:a="http://schemas.openxmlformats.org/drawingml/2006/main" prst="rect">
+            <a:avLst/>
+          </a:prstGeom>
+          <a:noFill xmlns:a="http://schemas.openxmlformats.org/drawingml/2006/main"/>
+          <a:ln xmlns:a="http://schemas.openxmlformats.org/drawingml/2006/main" w="0">
+            <a:noFill/>
+          </a:ln>
+        </p:spPr>
+        <p:txBody>
+          <a:bodyPr xmlns:a="http://schemas.openxmlformats.org/drawingml/2006/main">
+            <a:noAutofit/>
+          </a:bodyPr>
+          <a:lstStyle xmlns:a="http://schemas.openxmlformats.org/drawingml/2006/main"/>
+          <a:p xmlns:a="http://schemas.openxmlformats.org/drawingml/2006/main">
+            <a:pPr>
+              <a:defRPr sz="1875" b="0">
+                <a:solidFill>
+                  <a:srgbClr val="087F73"/>
+                </a:solidFill>
+                <a:latin typeface="Arial"/>
+                <a:ea typeface="Arial"/>
+                <a:cs typeface="Arial"/>
+              </a:defRPr>
+            </a:pPr>
+            <a:r>
+              <a:rPr sz="1875" b="0">
+                <a:solidFill>
+                  <a:srgbClr val="087F73"/>
+                </a:solidFill>
+                <a:latin typeface="Arial"/>
+                <a:ea typeface="Arial"/>
+                <a:cs typeface="Arial"/>
+                <a:hlinkClick xmlns:r="http://schemas.openxmlformats.org/officeDocument/2006/relationships" r:id="Rf89fcbd7eb5e4f7a"/>
+              </a:rPr>
+              <a:t>Full guide, downloads and troubleshooting</a:t>
+            </a:r>
+          </a:p>
+        </p:txBody>
+      </p:sp>
+    </p:spTree>
+    <p:extLst>
+      <p:ext uri="{BB962C8B-B14F-4D97-AF65-F5344CB8AC3E}">
+        <p14:creationId xmlns:p14="http://schemas.microsoft.com/office/powerpoint/2010/main" val="760885182"/>
       </p:ext>
     </p:extLst>
   </p:cSld>
@@ -4354,7 +5423,7 @@
           <p:cNvPr id="13" name="">
             <a:extLst xmlns:a="http://schemas.openxmlformats.org/drawingml/2006/main">
               <a:ext uri="{FF2B5EF4-FFF2-40B4-BE49-F238E27FC236}">
-                <a16:creationId xmlns:a16="http://schemas.microsoft.com/office/drawing/2014/main" id="{F2C71C29-E22E-4DB6-9730-26FC6DAFD8A3}"/>
+                <a16:creationId xmlns:a16="http://schemas.microsoft.com/office/drawing/2014/main" id="{73CA8F52-08C9-4E7C-B1CA-1E6137D4BB84}"/>
               </a:ext>
             </a:extLst>
           </p:cNvPr>
@@ -4411,7 +5480,7 @@
           <p:cNvPr id="2" name="">
             <a:extLst xmlns:a="http://schemas.openxmlformats.org/drawingml/2006/main">
               <a:ext uri="{FF2B5EF4-FFF2-40B4-BE49-F238E27FC236}">
-                <a16:creationId xmlns:a16="http://schemas.microsoft.com/office/drawing/2014/main" id="{89C42A7C-060D-4601-9F57-EFDB13A5B96E}"/>
+                <a16:creationId xmlns:a16="http://schemas.microsoft.com/office/drawing/2014/main" id="{C8B80E00-68BC-40CE-B0B9-A1E634801173}"/>
               </a:ext>
             </a:extLst>
           </p:cNvPr>
@@ -4468,7 +5537,7 @@
           <p:cNvPr id="3" name="">
             <a:extLst xmlns:a="http://schemas.openxmlformats.org/drawingml/2006/main">
               <a:ext uri="{FF2B5EF4-FFF2-40B4-BE49-F238E27FC236}">
-                <a16:creationId xmlns:a16="http://schemas.microsoft.com/office/drawing/2014/main" id="{DBFE9919-825A-4E8E-89C4-02386501C42D}"/>
+                <a16:creationId xmlns:a16="http://schemas.microsoft.com/office/drawing/2014/main" id="{5E28ECFA-03DC-45A8-A021-245B3B7DCA1D}"/>
               </a:ext>
             </a:extLst>
           </p:cNvPr>
@@ -4525,7 +5594,7 @@
           <p:cNvPr id="4" name="">
             <a:extLst xmlns:a="http://schemas.openxmlformats.org/drawingml/2006/main">
               <a:ext uri="{FF2B5EF4-FFF2-40B4-BE49-F238E27FC236}">
-                <a16:creationId xmlns:a16="http://schemas.microsoft.com/office/drawing/2014/main" id="{8D03D047-7530-4EA5-9B5A-E90B0B91BCE4}"/>
+                <a16:creationId xmlns:a16="http://schemas.microsoft.com/office/drawing/2014/main" id="{5B9DA8A0-D4FA-484A-8842-3A1A93A40960}"/>
               </a:ext>
             </a:extLst>
           </p:cNvPr>
@@ -4582,7 +5651,7 @@
           <p:cNvPr id="5" name="">
             <a:extLst xmlns:a="http://schemas.openxmlformats.org/drawingml/2006/main">
               <a:ext uri="{FF2B5EF4-FFF2-40B4-BE49-F238E27FC236}">
-                <a16:creationId xmlns:a16="http://schemas.microsoft.com/office/drawing/2014/main" id="{33D0AA91-AA76-4A0C-89F6-8AA5E8BEEE90}"/>
+                <a16:creationId xmlns:a16="http://schemas.microsoft.com/office/drawing/2014/main" id="{182D224E-FA80-4DF6-B48A-A1A84B835727}"/>
               </a:ext>
             </a:extLst>
           </p:cNvPr>
@@ -4662,7 +5731,7 @@
           <p:cNvPr id="6" name="">
             <a:extLst xmlns:a="http://schemas.openxmlformats.org/drawingml/2006/main">
               <a:ext uri="{FF2B5EF4-FFF2-40B4-BE49-F238E27FC236}">
-                <a16:creationId xmlns:a16="http://schemas.microsoft.com/office/drawing/2014/main" id="{157ADF9E-4690-4B8C-BC69-AEEA650F847D}"/>
+                <a16:creationId xmlns:a16="http://schemas.microsoft.com/office/drawing/2014/main" id="{1D25592B-ACA2-4031-AACB-F08395D2F796}"/>
               </a:ext>
             </a:extLst>
           </p:cNvPr>
@@ -4708,7 +5777,7 @@
                 <a:latin typeface="Arial"/>
                 <a:ea typeface="Arial"/>
                 <a:cs typeface="Arial"/>
-                <a:hlinkClick xmlns:r="http://schemas.openxmlformats.org/officeDocument/2006/relationships" r:id="Rd1ba2e79599f4e3f"/>
+                <a:hlinkClick xmlns:r="http://schemas.openxmlformats.org/officeDocument/2006/relationships" r:id="R48567a9a37254066"/>
               </a:rPr>
               <a:t>Mac download page (Apple Silicon)</a:t>
             </a:r>
@@ -4720,7 +5789,7 @@
           <p:cNvPr id="7" name="">
             <a:extLst xmlns:a="http://schemas.openxmlformats.org/drawingml/2006/main">
               <a:ext uri="{FF2B5EF4-FFF2-40B4-BE49-F238E27FC236}">
-                <a16:creationId xmlns:a16="http://schemas.microsoft.com/office/drawing/2014/main" id="{15B533F7-88D8-4A30-9D4A-B583BC042ABE}"/>
+                <a16:creationId xmlns:a16="http://schemas.microsoft.com/office/drawing/2014/main" id="{6626AF31-D242-417E-AE58-972693C79B7C}"/>
               </a:ext>
             </a:extLst>
           </p:cNvPr>
@@ -4766,7 +5835,7 @@
                 <a:latin typeface="Arial"/>
                 <a:ea typeface="Arial"/>
                 <a:cs typeface="Arial"/>
-                <a:hlinkClick xmlns:r="http://schemas.openxmlformats.org/officeDocument/2006/relationships" r:id="R11ad97dede53403c"/>
+                <a:hlinkClick xmlns:r="http://schemas.openxmlformats.org/officeDocument/2006/relationships" r:id="R3819cfa2e4be4c07"/>
               </a:rPr>
               <a:t>Windows download page</a:t>
             </a:r>
@@ -4778,7 +5847,7 @@
           <p:cNvPr id="8" name="">
             <a:extLst xmlns:a="http://schemas.openxmlformats.org/drawingml/2006/main">
               <a:ext uri="{FF2B5EF4-FFF2-40B4-BE49-F238E27FC236}">
-                <a16:creationId xmlns:a16="http://schemas.microsoft.com/office/drawing/2014/main" id="{1FED8D43-899D-4357-B708-1BA88975232E}"/>
+                <a16:creationId xmlns:a16="http://schemas.microsoft.com/office/drawing/2014/main" id="{B973B3B9-1ACD-4693-BF1A-7ABF120A62F7}"/>
               </a:ext>
             </a:extLst>
           </p:cNvPr>
@@ -4835,7 +5904,7 @@
           <p:cNvPr id="9" name="">
             <a:extLst xmlns:a="http://schemas.openxmlformats.org/drawingml/2006/main">
               <a:ext uri="{FF2B5EF4-FFF2-40B4-BE49-F238E27FC236}">
-                <a16:creationId xmlns:a16="http://schemas.microsoft.com/office/drawing/2014/main" id="{F0B44F8A-E220-4223-AEEA-B3280C22A52A}"/>
+                <a16:creationId xmlns:a16="http://schemas.microsoft.com/office/drawing/2014/main" id="{EFF1E460-A8D9-4E3A-9959-E8D654C045F4}"/>
               </a:ext>
             </a:extLst>
           </p:cNvPr>
@@ -4915,7 +5984,7 @@
           <p:cNvPr id="10" name="">
             <a:extLst xmlns:a="http://schemas.openxmlformats.org/drawingml/2006/main">
               <a:ext uri="{FF2B5EF4-FFF2-40B4-BE49-F238E27FC236}">
-                <a16:creationId xmlns:a16="http://schemas.microsoft.com/office/drawing/2014/main" id="{116F762C-228C-4EF6-90CE-88928FA17234}"/>
+                <a16:creationId xmlns:a16="http://schemas.microsoft.com/office/drawing/2014/main" id="{115BB5D7-1FE8-48DD-A8BA-47ACD094AFB9}"/>
               </a:ext>
             </a:extLst>
           </p:cNvPr>
@@ -4961,7 +6030,7 @@
                 <a:latin typeface="Arial"/>
                 <a:ea typeface="Arial"/>
                 <a:cs typeface="Arial"/>
-                <a:hlinkClick xmlns:r="http://schemas.openxmlformats.org/officeDocument/2006/relationships" r:id="R222706335aa74c5a"/>
+                <a:hlinkClick xmlns:r="http://schemas.openxmlformats.org/officeDocument/2006/relationships" r:id="Rab735c6791414244"/>
               </a:rPr>
               <a:t>Mac or Windows downloads</a:t>
             </a:r>
@@ -4973,7 +6042,7 @@
           <p:cNvPr id="11" name="">
             <a:extLst xmlns:a="http://schemas.openxmlformats.org/drawingml/2006/main">
               <a:ext uri="{FF2B5EF4-FFF2-40B4-BE49-F238E27FC236}">
-                <a16:creationId xmlns:a16="http://schemas.microsoft.com/office/drawing/2014/main" id="{65A73262-9172-4336-ABAD-4587E17E1D7B}"/>
+                <a16:creationId xmlns:a16="http://schemas.microsoft.com/office/drawing/2014/main" id="{0B53BA8D-EBE8-40AD-9CAD-184EE9BD6506}"/>
               </a:ext>
             </a:extLst>
           </p:cNvPr>
@@ -5019,7 +6088,7 @@
                 <a:latin typeface="Arial"/>
                 <a:ea typeface="Arial"/>
                 <a:cs typeface="Arial"/>
-                <a:hlinkClick xmlns:r="http://schemas.openxmlformats.org/officeDocument/2006/relationships" r:id="R18ac0459f4594e5f"/>
+                <a:hlinkClick xmlns:r="http://schemas.openxmlformats.org/officeDocument/2006/relationships" r:id="Ra6e20e033b8b490a"/>
               </a:rPr>
               <a:t>Claude Code setup and account requirements</a:t>
             </a:r>
@@ -5031,7 +6100,7 @@
           <p:cNvPr id="12" name="">
             <a:extLst xmlns:a="http://schemas.openxmlformats.org/drawingml/2006/main">
               <a:ext uri="{FF2B5EF4-FFF2-40B4-BE49-F238E27FC236}">
-                <a16:creationId xmlns:a16="http://schemas.microsoft.com/office/drawing/2014/main" id="{F6486A5C-99E0-44F3-BB56-F30D269F637A}"/>
+                <a16:creationId xmlns:a16="http://schemas.microsoft.com/office/drawing/2014/main" id="{4155A108-909D-4D81-940F-332B86DF9A0F}"/>
               </a:ext>
             </a:extLst>
           </p:cNvPr>
@@ -5086,7 +6155,7 @@
     </p:spTree>
     <p:extLst>
       <p:ext uri="{BB962C8B-B14F-4D97-AF65-F5344CB8AC3E}">
-        <p14:creationId xmlns:p14="http://schemas.microsoft.com/office/powerpoint/2010/main" val="267553724"/>
+        <p14:creationId xmlns:p14="http://schemas.microsoft.com/office/powerpoint/2010/main" val="1687323505"/>
       </p:ext>
     </p:extLst>
   </p:cSld>
@@ -5117,7 +6186,7 @@
           <p:cNvPr id="6" name="">
             <a:extLst xmlns:a="http://schemas.openxmlformats.org/drawingml/2006/main">
               <a:ext uri="{FF2B5EF4-FFF2-40B4-BE49-F238E27FC236}">
-                <a16:creationId xmlns:a16="http://schemas.microsoft.com/office/drawing/2014/main" id="{79D03DED-923F-4A55-883F-B3601F0ECA1E}"/>
+                <a16:creationId xmlns:a16="http://schemas.microsoft.com/office/drawing/2014/main" id="{84B22F57-8AC4-4B65-B6F4-BA08041C6253}"/>
               </a:ext>
             </a:extLst>
           </p:cNvPr>
@@ -5174,7 +6243,7 @@
           <p:cNvPr id="2" name="">
             <a:extLst xmlns:a="http://schemas.openxmlformats.org/drawingml/2006/main">
               <a:ext uri="{FF2B5EF4-FFF2-40B4-BE49-F238E27FC236}">
-                <a16:creationId xmlns:a16="http://schemas.microsoft.com/office/drawing/2014/main" id="{46C24BC0-8142-4183-A12B-2CEBFDA4AD27}"/>
+                <a16:creationId xmlns:a16="http://schemas.microsoft.com/office/drawing/2014/main" id="{51843606-E2B0-493E-A0FE-BAA7725D40F2}"/>
               </a:ext>
             </a:extLst>
           </p:cNvPr>
@@ -5231,7 +6300,7 @@
           <p:cNvPr id="3" name="">
             <a:extLst xmlns:a="http://schemas.openxmlformats.org/drawingml/2006/main">
               <a:ext uri="{FF2B5EF4-FFF2-40B4-BE49-F238E27FC236}">
-                <a16:creationId xmlns:a16="http://schemas.microsoft.com/office/drawing/2014/main" id="{DC87CC8D-A813-4A94-BB36-204F2551E275}"/>
+                <a16:creationId xmlns:a16="http://schemas.microsoft.com/office/drawing/2014/main" id="{59D36835-C121-4E0E-998A-3FECBD2A07AE}"/>
               </a:ext>
             </a:extLst>
           </p:cNvPr>
@@ -5292,7 +6361,7 @@
           <p:nvPr/>
         </p:nvPicPr>
         <p:blipFill>
-          <a:blip xmlns:r="http://schemas.openxmlformats.org/officeDocument/2006/relationships" xmlns:a="http://schemas.openxmlformats.org/drawingml/2006/main" r:embed="Ra7377327abdb4a1a"/>
+          <a:blip xmlns:r="http://schemas.openxmlformats.org/officeDocument/2006/relationships" xmlns:a="http://schemas.openxmlformats.org/drawingml/2006/main" r:embed="R4af1ba4d79f44a64"/>
           <a:stretch xmlns:a="http://schemas.openxmlformats.org/drawingml/2006/main"/>
         </p:blipFill>
         <p:spPr>
@@ -5310,7 +6379,7 @@
           <p:cNvPr id="5" name="">
             <a:extLst xmlns:a="http://schemas.openxmlformats.org/drawingml/2006/main">
               <a:ext uri="{FF2B5EF4-FFF2-40B4-BE49-F238E27FC236}">
-                <a16:creationId xmlns:a16="http://schemas.microsoft.com/office/drawing/2014/main" id="{E9DC2180-4F7D-4C09-9565-1D60960CEDBD}"/>
+                <a16:creationId xmlns:a16="http://schemas.microsoft.com/office/drawing/2014/main" id="{077EE390-79C7-4346-88F5-A51D430164E0}"/>
               </a:ext>
             </a:extLst>
           </p:cNvPr>
@@ -5388,7 +6457,7 @@
     </p:spTree>
     <p:extLst>
       <p:ext uri="{BB962C8B-B14F-4D97-AF65-F5344CB8AC3E}">
-        <p14:creationId xmlns:p14="http://schemas.microsoft.com/office/powerpoint/2010/main" val="673747755"/>
+        <p14:creationId xmlns:p14="http://schemas.microsoft.com/office/powerpoint/2010/main" val="1039363836"/>
       </p:ext>
     </p:extLst>
   </p:cSld>
@@ -5419,7 +6488,7 @@
           <p:cNvPr id="8" name="">
             <a:extLst xmlns:a="http://schemas.openxmlformats.org/drawingml/2006/main">
               <a:ext uri="{FF2B5EF4-FFF2-40B4-BE49-F238E27FC236}">
-                <a16:creationId xmlns:a16="http://schemas.microsoft.com/office/drawing/2014/main" id="{89DE8CC6-7DCF-4BFF-B978-0451912A5473}"/>
+                <a16:creationId xmlns:a16="http://schemas.microsoft.com/office/drawing/2014/main" id="{87C6FC88-5CBE-43C1-9268-595420D61E4E}"/>
               </a:ext>
             </a:extLst>
           </p:cNvPr>
@@ -5476,7 +6545,7 @@
           <p:cNvPr id="2" name="">
             <a:extLst xmlns:a="http://schemas.openxmlformats.org/drawingml/2006/main">
               <a:ext uri="{FF2B5EF4-FFF2-40B4-BE49-F238E27FC236}">
-                <a16:creationId xmlns:a16="http://schemas.microsoft.com/office/drawing/2014/main" id="{7CFE3722-D942-438D-A261-AFA3645034F7}"/>
+                <a16:creationId xmlns:a16="http://schemas.microsoft.com/office/drawing/2014/main" id="{2F001D6C-21B8-4107-A5CB-65948131AC70}"/>
               </a:ext>
             </a:extLst>
           </p:cNvPr>
@@ -5533,7 +6602,7 @@
           <p:cNvPr id="3" name="">
             <a:extLst xmlns:a="http://schemas.openxmlformats.org/drawingml/2006/main">
               <a:ext uri="{FF2B5EF4-FFF2-40B4-BE49-F238E27FC236}">
-                <a16:creationId xmlns:a16="http://schemas.microsoft.com/office/drawing/2014/main" id="{70C7667F-1A93-489F-AA9C-363183EAF8A1}"/>
+                <a16:creationId xmlns:a16="http://schemas.microsoft.com/office/drawing/2014/main" id="{2901C74B-FD0D-4908-9C89-34A6FDD4E512}"/>
               </a:ext>
             </a:extLst>
           </p:cNvPr>
@@ -5590,7 +6659,7 @@
           <p:cNvPr id="4" name="">
             <a:extLst xmlns:a="http://schemas.openxmlformats.org/drawingml/2006/main">
               <a:ext uri="{FF2B5EF4-FFF2-40B4-BE49-F238E27FC236}">
-                <a16:creationId xmlns:a16="http://schemas.microsoft.com/office/drawing/2014/main" id="{0B86EA6F-A2EA-4412-AF76-C3A072F148E3}"/>
+                <a16:creationId xmlns:a16="http://schemas.microsoft.com/office/drawing/2014/main" id="{29930B79-4848-4BF0-A6B7-3762962C8437}"/>
               </a:ext>
             </a:extLst>
           </p:cNvPr>
@@ -5716,7 +6785,7 @@
           <p:cNvPr id="5" name="">
             <a:extLst xmlns:a="http://schemas.openxmlformats.org/drawingml/2006/main">
               <a:ext uri="{FF2B5EF4-FFF2-40B4-BE49-F238E27FC236}">
-                <a16:creationId xmlns:a16="http://schemas.microsoft.com/office/drawing/2014/main" id="{ECD01095-6A98-4649-8334-A17683ECCF19}"/>
+                <a16:creationId xmlns:a16="http://schemas.microsoft.com/office/drawing/2014/main" id="{1A3F281F-0CA9-4B45-8340-60C5808A8938}"/>
               </a:ext>
             </a:extLst>
           </p:cNvPr>
@@ -5823,7 +6892,7 @@
           <p:nvPr/>
         </p:nvPicPr>
         <p:blipFill>
-          <a:blip xmlns:r="http://schemas.openxmlformats.org/officeDocument/2006/relationships" xmlns:a="http://schemas.openxmlformats.org/drawingml/2006/main" r:embed="Raf5db7dd2e474caf"/>
+          <a:blip xmlns:r="http://schemas.openxmlformats.org/officeDocument/2006/relationships" xmlns:a="http://schemas.openxmlformats.org/drawingml/2006/main" r:embed="R21ff2aa66512460a"/>
           <a:stretch xmlns:a="http://schemas.openxmlformats.org/drawingml/2006/main"/>
         </p:blipFill>
         <p:spPr>
@@ -5841,7 +6910,7 @@
           <p:cNvPr id="7" name="">
             <a:extLst xmlns:a="http://schemas.openxmlformats.org/drawingml/2006/main">
               <a:ext uri="{FF2B5EF4-FFF2-40B4-BE49-F238E27FC236}">
-                <a16:creationId xmlns:a16="http://schemas.microsoft.com/office/drawing/2014/main" id="{F94B6D2C-EBA1-438B-952B-34AAD464541A}"/>
+                <a16:creationId xmlns:a16="http://schemas.microsoft.com/office/drawing/2014/main" id="{72FE2901-5110-4D91-A895-95C9D9DE67AB}"/>
               </a:ext>
             </a:extLst>
           </p:cNvPr>
@@ -5896,7 +6965,7 @@
     </p:spTree>
     <p:extLst>
       <p:ext uri="{BB962C8B-B14F-4D97-AF65-F5344CB8AC3E}">
-        <p14:creationId xmlns:p14="http://schemas.microsoft.com/office/powerpoint/2010/main" val="190540888"/>
+        <p14:creationId xmlns:p14="http://schemas.microsoft.com/office/powerpoint/2010/main" val="1955263578"/>
       </p:ext>
     </p:extLst>
   </p:cSld>
@@ -5927,7 +6996,7 @@
           <p:cNvPr id="6" name="">
             <a:extLst xmlns:a="http://schemas.openxmlformats.org/drawingml/2006/main">
               <a:ext uri="{FF2B5EF4-FFF2-40B4-BE49-F238E27FC236}">
-                <a16:creationId xmlns:a16="http://schemas.microsoft.com/office/drawing/2014/main" id="{75B1D08B-73E6-4D72-8E4A-EA2DFDD08FE9}"/>
+                <a16:creationId xmlns:a16="http://schemas.microsoft.com/office/drawing/2014/main" id="{654B3DFD-37BA-4887-A601-81FCDAE8CD4F}"/>
               </a:ext>
             </a:extLst>
           </p:cNvPr>
@@ -5984,7 +7053,7 @@
           <p:cNvPr id="2" name="">
             <a:extLst xmlns:a="http://schemas.openxmlformats.org/drawingml/2006/main">
               <a:ext uri="{FF2B5EF4-FFF2-40B4-BE49-F238E27FC236}">
-                <a16:creationId xmlns:a16="http://schemas.microsoft.com/office/drawing/2014/main" id="{AB97D43E-AB7B-4025-91D4-9751847B3C5B}"/>
+                <a16:creationId xmlns:a16="http://schemas.microsoft.com/office/drawing/2014/main" id="{5DFF1F12-B108-41A2-A146-D72177BF7896}"/>
               </a:ext>
             </a:extLst>
           </p:cNvPr>
@@ -6041,7 +7110,7 @@
           <p:cNvPr id="3" name="">
             <a:extLst xmlns:a="http://schemas.openxmlformats.org/drawingml/2006/main">
               <a:ext uri="{FF2B5EF4-FFF2-40B4-BE49-F238E27FC236}">
-                <a16:creationId xmlns:a16="http://schemas.microsoft.com/office/drawing/2014/main" id="{F44C6D47-8AE4-4085-8C70-E3BC6A918F16}"/>
+                <a16:creationId xmlns:a16="http://schemas.microsoft.com/office/drawing/2014/main" id="{FEE433A5-2A30-4DC2-89B3-CD21F7F71563}"/>
               </a:ext>
             </a:extLst>
           </p:cNvPr>
@@ -6125,7 +7194,7 @@
           <p:nvPr/>
         </p:nvPicPr>
         <p:blipFill>
-          <a:blip xmlns:r="http://schemas.openxmlformats.org/officeDocument/2006/relationships" xmlns:a="http://schemas.openxmlformats.org/drawingml/2006/main" r:embed="R8bca409d3a3240fa"/>
+          <a:blip xmlns:r="http://schemas.openxmlformats.org/officeDocument/2006/relationships" xmlns:a="http://schemas.openxmlformats.org/drawingml/2006/main" r:embed="Rba62139f4d5c405b"/>
           <a:stretch xmlns:a="http://schemas.openxmlformats.org/drawingml/2006/main"/>
         </p:blipFill>
         <p:spPr>
@@ -6143,7 +7212,7 @@
           <p:cNvPr id="5" name="">
             <a:extLst xmlns:a="http://schemas.openxmlformats.org/drawingml/2006/main">
               <a:ext uri="{FF2B5EF4-FFF2-40B4-BE49-F238E27FC236}">
-                <a16:creationId xmlns:a16="http://schemas.microsoft.com/office/drawing/2014/main" id="{A18431D6-A087-4D7D-83FD-1C55F1B0A50C}"/>
+                <a16:creationId xmlns:a16="http://schemas.microsoft.com/office/drawing/2014/main" id="{13849C82-D899-4FB4-B055-2CEA734C22CD}"/>
               </a:ext>
             </a:extLst>
           </p:cNvPr>
@@ -6221,7 +7290,7 @@
     </p:spTree>
     <p:extLst>
       <p:ext uri="{BB962C8B-B14F-4D97-AF65-F5344CB8AC3E}">
-        <p14:creationId xmlns:p14="http://schemas.microsoft.com/office/powerpoint/2010/main" val="2032136883"/>
+        <p14:creationId xmlns:p14="http://schemas.microsoft.com/office/powerpoint/2010/main" val="646599135"/>
       </p:ext>
     </p:extLst>
   </p:cSld>
@@ -6252,7 +7321,7 @@
           <p:cNvPr id="6" name="">
             <a:extLst xmlns:a="http://schemas.openxmlformats.org/drawingml/2006/main">
               <a:ext uri="{FF2B5EF4-FFF2-40B4-BE49-F238E27FC236}">
-                <a16:creationId xmlns:a16="http://schemas.microsoft.com/office/drawing/2014/main" id="{C1A3298E-93F2-4134-A389-41F46F1CA733}"/>
+                <a16:creationId xmlns:a16="http://schemas.microsoft.com/office/drawing/2014/main" id="{0444154C-D067-480A-90B6-5B0C33C3B106}"/>
               </a:ext>
             </a:extLst>
           </p:cNvPr>
@@ -6309,7 +7378,7 @@
           <p:cNvPr id="2" name="">
             <a:extLst xmlns:a="http://schemas.openxmlformats.org/drawingml/2006/main">
               <a:ext uri="{FF2B5EF4-FFF2-40B4-BE49-F238E27FC236}">
-                <a16:creationId xmlns:a16="http://schemas.microsoft.com/office/drawing/2014/main" id="{059A974E-A363-48AB-940F-C1A08BDC21BC}"/>
+                <a16:creationId xmlns:a16="http://schemas.microsoft.com/office/drawing/2014/main" id="{EC59C3FC-4B01-4300-9AC8-8DBD3A15862F}"/>
               </a:ext>
             </a:extLst>
           </p:cNvPr>
@@ -6366,7 +7435,7 @@
           <p:cNvPr id="3" name="">
             <a:extLst xmlns:a="http://schemas.openxmlformats.org/drawingml/2006/main">
               <a:ext uri="{FF2B5EF4-FFF2-40B4-BE49-F238E27FC236}">
-                <a16:creationId xmlns:a16="http://schemas.microsoft.com/office/drawing/2014/main" id="{E72DD0AA-2EBE-4C16-948C-8D4F5168D2C6}"/>
+                <a16:creationId xmlns:a16="http://schemas.microsoft.com/office/drawing/2014/main" id="{19D0D0BB-8176-4FB4-B2A2-7BAD8C328311}"/>
               </a:ext>
             </a:extLst>
           </p:cNvPr>
@@ -6427,7 +7496,7 @@
           <p:nvPr/>
         </p:nvPicPr>
         <p:blipFill>
-          <a:blip xmlns:r="http://schemas.openxmlformats.org/officeDocument/2006/relationships" xmlns:a="http://schemas.openxmlformats.org/drawingml/2006/main" r:embed="R42756619e77b4bf0"/>
+          <a:blip xmlns:r="http://schemas.openxmlformats.org/officeDocument/2006/relationships" xmlns:a="http://schemas.openxmlformats.org/drawingml/2006/main" r:embed="R8fee520822184073"/>
           <a:stretch xmlns:a="http://schemas.openxmlformats.org/drawingml/2006/main"/>
         </p:blipFill>
         <p:spPr>
@@ -6445,7 +7514,7 @@
           <p:cNvPr id="5" name="">
             <a:extLst xmlns:a="http://schemas.openxmlformats.org/drawingml/2006/main">
               <a:ext uri="{FF2B5EF4-FFF2-40B4-BE49-F238E27FC236}">
-                <a16:creationId xmlns:a16="http://schemas.microsoft.com/office/drawing/2014/main" id="{35B848A2-5BE6-40AA-8F4F-3A2A60D1BD63}"/>
+                <a16:creationId xmlns:a16="http://schemas.microsoft.com/office/drawing/2014/main" id="{3F47E985-1DDF-4EC0-8DAB-E414C238B506}"/>
               </a:ext>
             </a:extLst>
           </p:cNvPr>
@@ -6523,7 +7592,7 @@
     </p:spTree>
     <p:extLst>
       <p:ext uri="{BB962C8B-B14F-4D97-AF65-F5344CB8AC3E}">
-        <p14:creationId xmlns:p14="http://schemas.microsoft.com/office/powerpoint/2010/main" val="577427104"/>
+        <p14:creationId xmlns:p14="http://schemas.microsoft.com/office/powerpoint/2010/main" val="1803607922"/>
       </p:ext>
     </p:extLst>
   </p:cSld>
@@ -6554,7 +7623,7 @@
           <p:cNvPr id="8" name="">
             <a:extLst xmlns:a="http://schemas.openxmlformats.org/drawingml/2006/main">
               <a:ext uri="{FF2B5EF4-FFF2-40B4-BE49-F238E27FC236}">
-                <a16:creationId xmlns:a16="http://schemas.microsoft.com/office/drawing/2014/main" id="{10445EBD-F04E-4808-A20A-94986F329B7D}"/>
+                <a16:creationId xmlns:a16="http://schemas.microsoft.com/office/drawing/2014/main" id="{2D5E5514-C150-43F6-B4EC-376F37CAC040}"/>
               </a:ext>
             </a:extLst>
           </p:cNvPr>
@@ -6611,7 +7680,7 @@
           <p:cNvPr id="2" name="">
             <a:extLst xmlns:a="http://schemas.openxmlformats.org/drawingml/2006/main">
               <a:ext uri="{FF2B5EF4-FFF2-40B4-BE49-F238E27FC236}">
-                <a16:creationId xmlns:a16="http://schemas.microsoft.com/office/drawing/2014/main" id="{49F6911C-C79D-4D55-97BF-97018EB097AF}"/>
+                <a16:creationId xmlns:a16="http://schemas.microsoft.com/office/drawing/2014/main" id="{38A17D0D-8D3B-4AAD-8140-36AAF6E933C2}"/>
               </a:ext>
             </a:extLst>
           </p:cNvPr>
@@ -6668,7 +7737,7 @@
           <p:cNvPr id="3" name="">
             <a:extLst xmlns:a="http://schemas.openxmlformats.org/drawingml/2006/main">
               <a:ext uri="{FF2B5EF4-FFF2-40B4-BE49-F238E27FC236}">
-                <a16:creationId xmlns:a16="http://schemas.microsoft.com/office/drawing/2014/main" id="{C687C0E5-D22C-46B5-8079-E64F09239FB0}"/>
+                <a16:creationId xmlns:a16="http://schemas.microsoft.com/office/drawing/2014/main" id="{BDC19E51-6A91-4818-89E5-F2A7128E78A6}"/>
               </a:ext>
             </a:extLst>
           </p:cNvPr>
@@ -6725,7 +7794,7 @@
           <p:cNvPr id="4" name="">
             <a:extLst xmlns:a="http://schemas.openxmlformats.org/drawingml/2006/main">
               <a:ext uri="{FF2B5EF4-FFF2-40B4-BE49-F238E27FC236}">
-                <a16:creationId xmlns:a16="http://schemas.microsoft.com/office/drawing/2014/main" id="{4449BFC2-14E1-4A34-806D-BE4C438F80C2}"/>
+                <a16:creationId xmlns:a16="http://schemas.microsoft.com/office/drawing/2014/main" id="{62631BE1-9AE7-4B06-B138-093E30E749BE}"/>
               </a:ext>
             </a:extLst>
           </p:cNvPr>
@@ -6805,7 +7874,7 @@
           <p:cNvPr id="5" name="">
             <a:extLst xmlns:a="http://schemas.openxmlformats.org/drawingml/2006/main">
               <a:ext uri="{FF2B5EF4-FFF2-40B4-BE49-F238E27FC236}">
-                <a16:creationId xmlns:a16="http://schemas.microsoft.com/office/drawing/2014/main" id="{46BCC760-3DB7-48D8-B455-37FE30E5AF1C}"/>
+                <a16:creationId xmlns:a16="http://schemas.microsoft.com/office/drawing/2014/main" id="{109048E4-6C52-4928-A394-CC72939A2F59}"/>
               </a:ext>
             </a:extLst>
           </p:cNvPr>
@@ -6862,7 +7931,7 @@
           <p:cNvPr id="6" name="">
             <a:extLst xmlns:a="http://schemas.openxmlformats.org/drawingml/2006/main">
               <a:ext uri="{FF2B5EF4-FFF2-40B4-BE49-F238E27FC236}">
-                <a16:creationId xmlns:a16="http://schemas.microsoft.com/office/drawing/2014/main" id="{BABA9B37-065D-4AFB-B363-A621C087552C}"/>
+                <a16:creationId xmlns:a16="http://schemas.microsoft.com/office/drawing/2014/main" id="{84CBF909-369E-454F-85E8-E622E3CA7C2E}"/>
               </a:ext>
             </a:extLst>
           </p:cNvPr>
@@ -6919,7 +7988,7 @@
           <p:cNvPr id="7" name="">
             <a:extLst xmlns:a="http://schemas.openxmlformats.org/drawingml/2006/main">
               <a:ext uri="{FF2B5EF4-FFF2-40B4-BE49-F238E27FC236}">
-                <a16:creationId xmlns:a16="http://schemas.microsoft.com/office/drawing/2014/main" id="{D4FD2918-5F54-4174-8337-AD2347D91388}"/>
+                <a16:creationId xmlns:a16="http://schemas.microsoft.com/office/drawing/2014/main" id="{8894F9CA-22D4-4B6B-B1AF-7FC2F3CE5011}"/>
               </a:ext>
             </a:extLst>
           </p:cNvPr>
@@ -6974,7 +8043,7 @@
     </p:spTree>
     <p:extLst>
       <p:ext uri="{BB962C8B-B14F-4D97-AF65-F5344CB8AC3E}">
-        <p14:creationId xmlns:p14="http://schemas.microsoft.com/office/powerpoint/2010/main" val="924309464"/>
+        <p14:creationId xmlns:p14="http://schemas.microsoft.com/office/powerpoint/2010/main" val="1513431853"/>
       </p:ext>
     </p:extLst>
   </p:cSld>
@@ -7005,7 +8074,7 @@
           <p:cNvPr id="7" name="">
             <a:extLst xmlns:a="http://schemas.openxmlformats.org/drawingml/2006/main">
               <a:ext uri="{FF2B5EF4-FFF2-40B4-BE49-F238E27FC236}">
-                <a16:creationId xmlns:a16="http://schemas.microsoft.com/office/drawing/2014/main" id="{21AB082F-EC96-408F-973C-CD6461BBF7B7}"/>
+                <a16:creationId xmlns:a16="http://schemas.microsoft.com/office/drawing/2014/main" id="{CAC55B05-B236-427A-A2E8-DD837E9D436D}"/>
               </a:ext>
             </a:extLst>
           </p:cNvPr>
@@ -7062,7 +8131,7 @@
           <p:cNvPr id="2" name="">
             <a:extLst xmlns:a="http://schemas.openxmlformats.org/drawingml/2006/main">
               <a:ext uri="{FF2B5EF4-FFF2-40B4-BE49-F238E27FC236}">
-                <a16:creationId xmlns:a16="http://schemas.microsoft.com/office/drawing/2014/main" id="{D8034656-DC12-4119-ACDC-F8D9FEF6C1B6}"/>
+                <a16:creationId xmlns:a16="http://schemas.microsoft.com/office/drawing/2014/main" id="{913B6C67-967F-4A0A-82D4-233D57FF22B9}"/>
               </a:ext>
             </a:extLst>
           </p:cNvPr>
@@ -7119,7 +8188,7 @@
           <p:cNvPr id="3" name="">
             <a:extLst xmlns:a="http://schemas.openxmlformats.org/drawingml/2006/main">
               <a:ext uri="{FF2B5EF4-FFF2-40B4-BE49-F238E27FC236}">
-                <a16:creationId xmlns:a16="http://schemas.microsoft.com/office/drawing/2014/main" id="{5262556F-5778-49F0-A66D-3F7840F5784A}"/>
+                <a16:creationId xmlns:a16="http://schemas.microsoft.com/office/drawing/2014/main" id="{7BDAEEE2-B4CD-419D-9C5E-21730E039950}"/>
               </a:ext>
             </a:extLst>
           </p:cNvPr>
@@ -7176,7 +8245,7 @@
           <p:cNvPr id="4" name="">
             <a:extLst xmlns:a="http://schemas.openxmlformats.org/drawingml/2006/main">
               <a:ext uri="{FF2B5EF4-FFF2-40B4-BE49-F238E27FC236}">
-                <a16:creationId xmlns:a16="http://schemas.microsoft.com/office/drawing/2014/main" id="{EED00C55-6220-42F3-8935-1588509D1F39}"/>
+                <a16:creationId xmlns:a16="http://schemas.microsoft.com/office/drawing/2014/main" id="{9CBEE114-B592-40EB-92F4-55EFFC164A92}"/>
               </a:ext>
             </a:extLst>
           </p:cNvPr>
@@ -7256,7 +8325,7 @@
           <p:cNvPr id="5" name="">
             <a:extLst xmlns:a="http://schemas.openxmlformats.org/drawingml/2006/main">
               <a:ext uri="{FF2B5EF4-FFF2-40B4-BE49-F238E27FC236}">
-                <a16:creationId xmlns:a16="http://schemas.microsoft.com/office/drawing/2014/main" id="{6E87F8F2-E1A7-4471-A4C8-E5395E21457A}"/>
+                <a16:creationId xmlns:a16="http://schemas.microsoft.com/office/drawing/2014/main" id="{43F150C7-7CB9-44D2-8254-AE6F3B0AC3F0}"/>
               </a:ext>
             </a:extLst>
           </p:cNvPr>
@@ -7336,7 +8405,7 @@
           <p:cNvPr id="6" name="">
             <a:extLst xmlns:a="http://schemas.openxmlformats.org/drawingml/2006/main">
               <a:ext uri="{FF2B5EF4-FFF2-40B4-BE49-F238E27FC236}">
-                <a16:creationId xmlns:a16="http://schemas.microsoft.com/office/drawing/2014/main" id="{28403172-4C8A-4ED4-A247-A822C8D2B350}"/>
+                <a16:creationId xmlns:a16="http://schemas.microsoft.com/office/drawing/2014/main" id="{92F326FF-E159-4355-B1AD-10309822C25F}"/>
               </a:ext>
             </a:extLst>
           </p:cNvPr>
@@ -7382,7 +8451,7 @@
                 <a:latin typeface="Arial"/>
                 <a:ea typeface="Arial"/>
                 <a:cs typeface="Arial"/>
-                <a:hlinkClick xmlns:r="http://schemas.openxmlformats.org/officeDocument/2006/relationships" r:id="R502e32cf091e4dea"/>
+                <a:hlinkClick xmlns:r="http://schemas.openxmlformats.org/officeDocument/2006/relationships" r:id="R2e9f20d3368b480c"/>
               </a:rPr>
               <a:t>Copy from the README</a:t>
             </a:r>
@@ -7392,7 +8461,7 @@
     </p:spTree>
     <p:extLst>
       <p:ext uri="{BB962C8B-B14F-4D97-AF65-F5344CB8AC3E}">
-        <p14:creationId xmlns:p14="http://schemas.microsoft.com/office/powerpoint/2010/main" val="1909632200"/>
+        <p14:creationId xmlns:p14="http://schemas.microsoft.com/office/powerpoint/2010/main" val="439925846"/>
       </p:ext>
     </p:extLst>
   </p:cSld>
@@ -7423,7 +8492,7 @@
           <p:cNvPr id="8" name="">
             <a:extLst xmlns:a="http://schemas.openxmlformats.org/drawingml/2006/main">
               <a:ext uri="{FF2B5EF4-FFF2-40B4-BE49-F238E27FC236}">
-                <a16:creationId xmlns:a16="http://schemas.microsoft.com/office/drawing/2014/main" id="{0EA35182-8B72-4563-9247-AD6140B945E1}"/>
+                <a16:creationId xmlns:a16="http://schemas.microsoft.com/office/drawing/2014/main" id="{EFF18607-28B3-49DC-B69D-63EAD04A96BE}"/>
               </a:ext>
             </a:extLst>
           </p:cNvPr>
@@ -7480,7 +8549,7 @@
           <p:cNvPr id="2" name="">
             <a:extLst xmlns:a="http://schemas.openxmlformats.org/drawingml/2006/main">
               <a:ext uri="{FF2B5EF4-FFF2-40B4-BE49-F238E27FC236}">
-                <a16:creationId xmlns:a16="http://schemas.microsoft.com/office/drawing/2014/main" id="{70EC2347-AD21-4CDE-B8C7-F08C0500F349}"/>
+                <a16:creationId xmlns:a16="http://schemas.microsoft.com/office/drawing/2014/main" id="{C91FCB08-02C4-4187-9258-794C5C0C0CA0}"/>
               </a:ext>
             </a:extLst>
           </p:cNvPr>
@@ -7537,7 +8606,7 @@
           <p:cNvPr id="3" name="">
             <a:extLst xmlns:a="http://schemas.openxmlformats.org/drawingml/2006/main">
               <a:ext uri="{FF2B5EF4-FFF2-40B4-BE49-F238E27FC236}">
-                <a16:creationId xmlns:a16="http://schemas.microsoft.com/office/drawing/2014/main" id="{9D4649D6-9FE5-4C14-B196-890BD7582E7A}"/>
+                <a16:creationId xmlns:a16="http://schemas.microsoft.com/office/drawing/2014/main" id="{5EE30E11-69AF-4F65-9D35-FA9DCD1B9E89}"/>
               </a:ext>
             </a:extLst>
           </p:cNvPr>
@@ -7594,7 +8663,7 @@
           <p:cNvPr id="4" name="">
             <a:extLst xmlns:a="http://schemas.openxmlformats.org/drawingml/2006/main">
               <a:ext uri="{FF2B5EF4-FFF2-40B4-BE49-F238E27FC236}">
-                <a16:creationId xmlns:a16="http://schemas.microsoft.com/office/drawing/2014/main" id="{28DB3BC5-6C98-43AA-9E4F-B31F0A8A42C9}"/>
+                <a16:creationId xmlns:a16="http://schemas.microsoft.com/office/drawing/2014/main" id="{ECD94436-77F0-4D79-B2EA-3091770C4DB1}"/>
               </a:ext>
             </a:extLst>
           </p:cNvPr>
@@ -7651,7 +8720,7 @@
           <p:cNvPr id="5" name="">
             <a:extLst xmlns:a="http://schemas.openxmlformats.org/drawingml/2006/main">
               <a:ext uri="{FF2B5EF4-FFF2-40B4-BE49-F238E27FC236}">
-                <a16:creationId xmlns:a16="http://schemas.microsoft.com/office/drawing/2014/main" id="{D969D217-0C07-47A7-91BE-6939AC6C11E7}"/>
+                <a16:creationId xmlns:a16="http://schemas.microsoft.com/office/drawing/2014/main" id="{305CD66B-EE68-4768-9751-DD84207AC5DB}"/>
               </a:ext>
             </a:extLst>
           </p:cNvPr>
@@ -7731,7 +8800,7 @@
           <p:cNvPr id="6" name="">
             <a:extLst xmlns:a="http://schemas.openxmlformats.org/drawingml/2006/main">
               <a:ext uri="{FF2B5EF4-FFF2-40B4-BE49-F238E27FC236}">
-                <a16:creationId xmlns:a16="http://schemas.microsoft.com/office/drawing/2014/main" id="{D1460E3E-76CD-4DB6-9DEE-664CD683E3D8}"/>
+                <a16:creationId xmlns:a16="http://schemas.microsoft.com/office/drawing/2014/main" id="{506133B0-1088-40D1-AA45-428EA61AAC16}"/>
               </a:ext>
             </a:extLst>
           </p:cNvPr>
@@ -7811,7 +8880,7 @@
           <p:cNvPr id="7" name="">
             <a:extLst xmlns:a="http://schemas.openxmlformats.org/drawingml/2006/main">
               <a:ext uri="{FF2B5EF4-FFF2-40B4-BE49-F238E27FC236}">
-                <a16:creationId xmlns:a16="http://schemas.microsoft.com/office/drawing/2014/main" id="{6B91696A-E701-43BC-8EE8-BD3A9E28A3CA}"/>
+                <a16:creationId xmlns:a16="http://schemas.microsoft.com/office/drawing/2014/main" id="{37EF14EC-F753-4717-88C7-B55565A43EC1}"/>
               </a:ext>
             </a:extLst>
           </p:cNvPr>
@@ -7866,7 +8935,7 @@
     </p:spTree>
     <p:extLst>
       <p:ext uri="{BB962C8B-B14F-4D97-AF65-F5344CB8AC3E}">
-        <p14:creationId xmlns:p14="http://schemas.microsoft.com/office/powerpoint/2010/main" val="1808846681"/>
+        <p14:creationId xmlns:p14="http://schemas.microsoft.com/office/powerpoint/2010/main" val="1929094501"/>
       </p:ext>
     </p:extLst>
   </p:cSld>

</xml_diff>

<commit_message>
Simplify the README and reconcile LinkedIn with career evidence
</commit_message>
<xml_diff>
--- a/docs/job-search-guide.pptx
+++ b/docs/job-search-guide.pptx
@@ -2,27 +2,27 @@
 <file path=ppt/presentation.xml><?xml version="1.0" encoding="utf-8"?>
 <p:presentation xmlns:p="http://schemas.openxmlformats.org/presentationml/2006/main">
   <p:sldMasterIdLst>
-    <p:sldMasterId xmlns:r="http://schemas.openxmlformats.org/officeDocument/2006/relationships" id="2147483648" r:id="Ra467bdd5a03b45e1"/>
+    <p:sldMasterId xmlns:r="http://schemas.openxmlformats.org/officeDocument/2006/relationships" id="2147483648" r:id="Ra8977158f73648aa"/>
   </p:sldMasterIdLst>
   <p:notesMasterIdLst>
-    <p:notesMasterId xmlns:r="http://schemas.openxmlformats.org/officeDocument/2006/relationships" r:id="R8c1d93c700d34b58"/>
+    <p:notesMasterId xmlns:r="http://schemas.openxmlformats.org/officeDocument/2006/relationships" r:id="Rd4440e6cdc374f57"/>
   </p:notesMasterIdLst>
   <p:sldIdLst>
-    <p:sldId xmlns:r="http://schemas.openxmlformats.org/officeDocument/2006/relationships" id="256" r:id="R88dad09a9a084830"/>
-    <p:sldId xmlns:r="http://schemas.openxmlformats.org/officeDocument/2006/relationships" id="257" r:id="Rcce94e4bda014717"/>
-    <p:sldId xmlns:r="http://schemas.openxmlformats.org/officeDocument/2006/relationships" id="258" r:id="R887ea07edd8d4ef7"/>
-    <p:sldId xmlns:r="http://schemas.openxmlformats.org/officeDocument/2006/relationships" id="259" r:id="R89cb7ca5718e4938"/>
-    <p:sldId xmlns:r="http://schemas.openxmlformats.org/officeDocument/2006/relationships" id="260" r:id="R1b36576034a040f3"/>
-    <p:sldId xmlns:r="http://schemas.openxmlformats.org/officeDocument/2006/relationships" id="261" r:id="Rc4e40ee398c84ddb"/>
-    <p:sldId xmlns:r="http://schemas.openxmlformats.org/officeDocument/2006/relationships" id="262" r:id="R4ea1651e865e45bc"/>
-    <p:sldId xmlns:r="http://schemas.openxmlformats.org/officeDocument/2006/relationships" id="263" r:id="R5a6e79ae6e6d4c48"/>
-    <p:sldId xmlns:r="http://schemas.openxmlformats.org/officeDocument/2006/relationships" id="264" r:id="R64955491c92f47b2"/>
-    <p:sldId xmlns:r="http://schemas.openxmlformats.org/officeDocument/2006/relationships" id="265" r:id="Ree9713eab9064472"/>
-    <p:sldId xmlns:r="http://schemas.openxmlformats.org/officeDocument/2006/relationships" id="266" r:id="Rbfe9bb008d5e4370"/>
-    <p:sldId xmlns:r="http://schemas.openxmlformats.org/officeDocument/2006/relationships" id="267" r:id="R9078ace1ec0b4c45"/>
-    <p:sldId xmlns:r="http://schemas.openxmlformats.org/officeDocument/2006/relationships" id="268" r:id="Re8a3c34bf71749ff"/>
-    <p:sldId xmlns:r="http://schemas.openxmlformats.org/officeDocument/2006/relationships" id="269" r:id="R65cfa819b5ec49f3"/>
-    <p:sldId xmlns:r="http://schemas.openxmlformats.org/officeDocument/2006/relationships" id="270" r:id="R4f75485084c54eb2"/>
+    <p:sldId xmlns:r="http://schemas.openxmlformats.org/officeDocument/2006/relationships" id="256" r:id="R26960a04793347a3"/>
+    <p:sldId xmlns:r="http://schemas.openxmlformats.org/officeDocument/2006/relationships" id="257" r:id="Rd416025064924e85"/>
+    <p:sldId xmlns:r="http://schemas.openxmlformats.org/officeDocument/2006/relationships" id="258" r:id="R8f7810c24c304fc4"/>
+    <p:sldId xmlns:r="http://schemas.openxmlformats.org/officeDocument/2006/relationships" id="259" r:id="R51b424e49c214308"/>
+    <p:sldId xmlns:r="http://schemas.openxmlformats.org/officeDocument/2006/relationships" id="260" r:id="Rb85d0e7cf3c44568"/>
+    <p:sldId xmlns:r="http://schemas.openxmlformats.org/officeDocument/2006/relationships" id="261" r:id="R8be938c4d8314248"/>
+    <p:sldId xmlns:r="http://schemas.openxmlformats.org/officeDocument/2006/relationships" id="262" r:id="Rd7e8cb4b9acf459b"/>
+    <p:sldId xmlns:r="http://schemas.openxmlformats.org/officeDocument/2006/relationships" id="263" r:id="R35c56a0921344b05"/>
+    <p:sldId xmlns:r="http://schemas.openxmlformats.org/officeDocument/2006/relationships" id="264" r:id="R97081abd0b79413d"/>
+    <p:sldId xmlns:r="http://schemas.openxmlformats.org/officeDocument/2006/relationships" id="265" r:id="R4517b3ba60e94180"/>
+    <p:sldId xmlns:r="http://schemas.openxmlformats.org/officeDocument/2006/relationships" id="266" r:id="R37ed7c812c4f40eb"/>
+    <p:sldId xmlns:r="http://schemas.openxmlformats.org/officeDocument/2006/relationships" id="267" r:id="Rca68f23fdb1a41c6"/>
+    <p:sldId xmlns:r="http://schemas.openxmlformats.org/officeDocument/2006/relationships" id="268" r:id="R25e2f0eb5dc34396"/>
+    <p:sldId xmlns:r="http://schemas.openxmlformats.org/officeDocument/2006/relationships" id="269" r:id="R7d9633ff1f9b439b"/>
+    <p:sldId xmlns:r="http://schemas.openxmlformats.org/officeDocument/2006/relationships" id="270" r:id="R2ba9eb4a605847b1"/>
   </p:sldIdLst>
   <p:sldSz cx="12192000" cy="6858000"/>
   <p:notesSz cx="6858000" cy="9144000"/>
@@ -461,7 +461,7 @@
           </a:p>
           <a:p xmlns:a="http://schemas.openxmlformats.org/drawingml/2006/main">
             <a:r>
-              <a:t>A guide to skill version 1.3.0, checked 12 September 2026. The AI needs local file access and the candidate’s real answers.</a:t>
+              <a:t>A guide to skill version 1.4.0, checked 12 September 2026. The AI needs local file access and the candidate’s real answers.</a:t>
             </a:r>
           </a:p>
         </p:txBody>
@@ -1699,7 +1699,7 @@
   </p:cSld>
   <p:clrMap bg1="lt1" tx1="dk1" bg2="lt2" tx2="dk2" accent1="accent1" accent2="accent2" accent3="accent3" accent4="accent4" accent5="accent5" accent6="accent6" hlink="hlink" folHlink="folHlink"/>
   <p:sldLayoutIdLst>
-    <p:sldLayoutId xmlns:r="http://schemas.openxmlformats.org/officeDocument/2006/relationships" id="2147483649" r:id="R2a9afcc6f4a3403d"/>
+    <p:sldLayoutId xmlns:r="http://schemas.openxmlformats.org/officeDocument/2006/relationships" id="2147483649" r:id="R2ad7894780884986"/>
   </p:sldLayoutIdLst>
   <p:txStyles>
     <p:titleStyle>
@@ -2250,7 +2250,7 @@
           <p:cNvPr id="5" name="">
             <a:extLst xmlns:a="http://schemas.openxmlformats.org/drawingml/2006/main">
               <a:ext uri="{FF2B5EF4-FFF2-40B4-BE49-F238E27FC236}">
-                <a16:creationId xmlns:a16="http://schemas.microsoft.com/office/drawing/2014/main" id="{02F19EB6-3023-4C48-AA62-A2CD0F63DD3C}"/>
+                <a16:creationId xmlns:a16="http://schemas.microsoft.com/office/drawing/2014/main" id="{6B404907-B2A8-4ADD-958B-AA50CE2215D6}"/>
               </a:ext>
             </a:extLst>
           </p:cNvPr>
@@ -2307,7 +2307,7 @@
           <p:cNvPr id="2" name="">
             <a:extLst xmlns:a="http://schemas.openxmlformats.org/drawingml/2006/main">
               <a:ext uri="{FF2B5EF4-FFF2-40B4-BE49-F238E27FC236}">
-                <a16:creationId xmlns:a16="http://schemas.microsoft.com/office/drawing/2014/main" id="{4FBBA667-9C2F-4322-B77B-51F56D1A6A45}"/>
+                <a16:creationId xmlns:a16="http://schemas.microsoft.com/office/drawing/2014/main" id="{B74BD242-287D-46BC-B7C7-DF9216C869CD}"/>
               </a:ext>
             </a:extLst>
           </p:cNvPr>
@@ -2364,7 +2364,7 @@
           <p:cNvPr id="3" name="">
             <a:extLst xmlns:a="http://schemas.openxmlformats.org/drawingml/2006/main">
               <a:ext uri="{FF2B5EF4-FFF2-40B4-BE49-F238E27FC236}">
-                <a16:creationId xmlns:a16="http://schemas.microsoft.com/office/drawing/2014/main" id="{926AFEF0-0EF1-4B51-A861-C249D2728DCB}"/>
+                <a16:creationId xmlns:a16="http://schemas.microsoft.com/office/drawing/2014/main" id="{D595FE4A-088C-466D-A72C-C7AD2ECE9AF8}"/>
               </a:ext>
             </a:extLst>
           </p:cNvPr>
@@ -2444,7 +2444,7 @@
           <p:cNvPr id="4" name="">
             <a:extLst xmlns:a="http://schemas.openxmlformats.org/drawingml/2006/main">
               <a:ext uri="{FF2B5EF4-FFF2-40B4-BE49-F238E27FC236}">
-                <a16:creationId xmlns:a16="http://schemas.microsoft.com/office/drawing/2014/main" id="{DFF1CED1-88CC-4647-80CC-DBD6E632885A}"/>
+                <a16:creationId xmlns:a16="http://schemas.microsoft.com/office/drawing/2014/main" id="{441CE51E-F9C1-43E1-BCF3-1EA6F06D6CF6}"/>
               </a:ext>
             </a:extLst>
           </p:cNvPr>
@@ -2490,7 +2490,7 @@
                 <a:latin typeface="Arial"/>
                 <a:ea typeface="Arial"/>
                 <a:cs typeface="Arial"/>
-                <a:hlinkClick xmlns:r="http://schemas.openxmlformats.org/officeDocument/2006/relationships" r:id="R2b621cd4bafa4a1c"/>
+                <a:hlinkClick xmlns:r="http://schemas.openxmlformats.org/officeDocument/2006/relationships" r:id="Rea7ef6d8788b4cb3"/>
               </a:rPr>
               <a:t>Open the GitHub guide</a:t>
             </a:r>
@@ -2500,7 +2500,7 @@
     </p:spTree>
     <p:extLst>
       <p:ext uri="{BB962C8B-B14F-4D97-AF65-F5344CB8AC3E}">
-        <p14:creationId xmlns:p14="http://schemas.microsoft.com/office/powerpoint/2010/main" val="656525787"/>
+        <p14:creationId xmlns:p14="http://schemas.microsoft.com/office/powerpoint/2010/main" val="1922523792"/>
       </p:ext>
     </p:extLst>
   </p:cSld>
@@ -2531,7 +2531,7 @@
           <p:cNvPr id="7" name="">
             <a:extLst xmlns:a="http://schemas.openxmlformats.org/drawingml/2006/main">
               <a:ext uri="{FF2B5EF4-FFF2-40B4-BE49-F238E27FC236}">
-                <a16:creationId xmlns:a16="http://schemas.microsoft.com/office/drawing/2014/main" id="{29BE425E-C784-42B3-9398-58A16CFDE0FE}"/>
+                <a16:creationId xmlns:a16="http://schemas.microsoft.com/office/drawing/2014/main" id="{F3E027FE-16D0-47C6-9651-E05CB667BACE}"/>
               </a:ext>
             </a:extLst>
           </p:cNvPr>
@@ -2588,7 +2588,7 @@
           <p:cNvPr id="2" name="">
             <a:extLst xmlns:a="http://schemas.openxmlformats.org/drawingml/2006/main">
               <a:ext uri="{FF2B5EF4-FFF2-40B4-BE49-F238E27FC236}">
-                <a16:creationId xmlns:a16="http://schemas.microsoft.com/office/drawing/2014/main" id="{1BFF10B8-0A11-4E69-9DAC-222B996B0FEA}"/>
+                <a16:creationId xmlns:a16="http://schemas.microsoft.com/office/drawing/2014/main" id="{27EC8A31-6E71-4A83-828D-0C05973455BD}"/>
               </a:ext>
             </a:extLst>
           </p:cNvPr>
@@ -2645,7 +2645,7 @@
           <p:cNvPr id="3" name="">
             <a:extLst xmlns:a="http://schemas.openxmlformats.org/drawingml/2006/main">
               <a:ext uri="{FF2B5EF4-FFF2-40B4-BE49-F238E27FC236}">
-                <a16:creationId xmlns:a16="http://schemas.microsoft.com/office/drawing/2014/main" id="{7268FA7A-571C-43BB-8638-B04754BA5CF4}"/>
+                <a16:creationId xmlns:a16="http://schemas.microsoft.com/office/drawing/2014/main" id="{EE3D4FE9-D433-4233-B584-B5E621DD373E}"/>
               </a:ext>
             </a:extLst>
           </p:cNvPr>
@@ -2702,7 +2702,7 @@
           <p:cNvPr id="4" name="">
             <a:extLst xmlns:a="http://schemas.openxmlformats.org/drawingml/2006/main">
               <a:ext uri="{FF2B5EF4-FFF2-40B4-BE49-F238E27FC236}">
-                <a16:creationId xmlns:a16="http://schemas.microsoft.com/office/drawing/2014/main" id="{DC3A586F-7ACF-45C6-BCA4-A879BA945DBE}"/>
+                <a16:creationId xmlns:a16="http://schemas.microsoft.com/office/drawing/2014/main" id="{A10349BD-4860-4BC6-B013-8BDEA38BCD66}"/>
               </a:ext>
             </a:extLst>
           </p:cNvPr>
@@ -2782,7 +2782,7 @@
           <p:cNvPr id="5" name="">
             <a:extLst xmlns:a="http://schemas.openxmlformats.org/drawingml/2006/main">
               <a:ext uri="{FF2B5EF4-FFF2-40B4-BE49-F238E27FC236}">
-                <a16:creationId xmlns:a16="http://schemas.microsoft.com/office/drawing/2014/main" id="{D6871139-C802-4362-8264-7559AE73A17A}"/>
+                <a16:creationId xmlns:a16="http://schemas.microsoft.com/office/drawing/2014/main" id="{8143FFE5-7AC4-46CB-82D1-2CE72DA27B3C}"/>
               </a:ext>
             </a:extLst>
           </p:cNvPr>
@@ -2862,7 +2862,7 @@
           <p:cNvPr id="6" name="">
             <a:extLst xmlns:a="http://schemas.openxmlformats.org/drawingml/2006/main">
               <a:ext uri="{FF2B5EF4-FFF2-40B4-BE49-F238E27FC236}">
-                <a16:creationId xmlns:a16="http://schemas.microsoft.com/office/drawing/2014/main" id="{11DFC218-ACFA-4026-A381-AC57216729F0}"/>
+                <a16:creationId xmlns:a16="http://schemas.microsoft.com/office/drawing/2014/main" id="{68EE40B5-DA3F-46C2-A2DD-2A0250D441C3}"/>
               </a:ext>
             </a:extLst>
           </p:cNvPr>
@@ -2917,7 +2917,7 @@
     </p:spTree>
     <p:extLst>
       <p:ext uri="{BB962C8B-B14F-4D97-AF65-F5344CB8AC3E}">
-        <p14:creationId xmlns:p14="http://schemas.microsoft.com/office/powerpoint/2010/main" val="264956109"/>
+        <p14:creationId xmlns:p14="http://schemas.microsoft.com/office/powerpoint/2010/main" val="1749528375"/>
       </p:ext>
     </p:extLst>
   </p:cSld>
@@ -2948,7 +2948,7 @@
           <p:cNvPr id="8" name="">
             <a:extLst xmlns:a="http://schemas.openxmlformats.org/drawingml/2006/main">
               <a:ext uri="{FF2B5EF4-FFF2-40B4-BE49-F238E27FC236}">
-                <a16:creationId xmlns:a16="http://schemas.microsoft.com/office/drawing/2014/main" id="{C0C47EFA-C30A-4C64-A56D-BD2941DDDB13}"/>
+                <a16:creationId xmlns:a16="http://schemas.microsoft.com/office/drawing/2014/main" id="{C14BD5C1-A8FD-4953-AC41-5DE2E3AB308E}"/>
               </a:ext>
             </a:extLst>
           </p:cNvPr>
@@ -3005,7 +3005,7 @@
           <p:cNvPr id="2" name="">
             <a:extLst xmlns:a="http://schemas.openxmlformats.org/drawingml/2006/main">
               <a:ext uri="{FF2B5EF4-FFF2-40B4-BE49-F238E27FC236}">
-                <a16:creationId xmlns:a16="http://schemas.microsoft.com/office/drawing/2014/main" id="{A01AA34D-2B12-4838-960E-53B1CDD62B65}"/>
+                <a16:creationId xmlns:a16="http://schemas.microsoft.com/office/drawing/2014/main" id="{40597877-AD22-4813-B6F6-5993D41D517D}"/>
               </a:ext>
             </a:extLst>
           </p:cNvPr>
@@ -3062,7 +3062,7 @@
           <p:cNvPr id="3" name="">
             <a:extLst xmlns:a="http://schemas.openxmlformats.org/drawingml/2006/main">
               <a:ext uri="{FF2B5EF4-FFF2-40B4-BE49-F238E27FC236}">
-                <a16:creationId xmlns:a16="http://schemas.microsoft.com/office/drawing/2014/main" id="{B650DF74-6BC6-49DD-A60E-59A1BE6EDF07}"/>
+                <a16:creationId xmlns:a16="http://schemas.microsoft.com/office/drawing/2014/main" id="{8C839746-4652-426C-B9B9-1590FA5160C4}"/>
               </a:ext>
             </a:extLst>
           </p:cNvPr>
@@ -3119,7 +3119,7 @@
           <p:cNvPr id="4" name="">
             <a:extLst xmlns:a="http://schemas.openxmlformats.org/drawingml/2006/main">
               <a:ext uri="{FF2B5EF4-FFF2-40B4-BE49-F238E27FC236}">
-                <a16:creationId xmlns:a16="http://schemas.microsoft.com/office/drawing/2014/main" id="{F2CA4C90-52B3-466A-9899-BDD440C153AF}"/>
+                <a16:creationId xmlns:a16="http://schemas.microsoft.com/office/drawing/2014/main" id="{82DD90C3-5058-44D0-8AC9-3F556E1E0377}"/>
               </a:ext>
             </a:extLst>
           </p:cNvPr>
@@ -3176,7 +3176,7 @@
           <p:cNvPr id="5" name="">
             <a:extLst xmlns:a="http://schemas.openxmlformats.org/drawingml/2006/main">
               <a:ext uri="{FF2B5EF4-FFF2-40B4-BE49-F238E27FC236}">
-                <a16:creationId xmlns:a16="http://schemas.microsoft.com/office/drawing/2014/main" id="{DC5D503E-897D-46BA-A7D7-FF52891323A8}"/>
+                <a16:creationId xmlns:a16="http://schemas.microsoft.com/office/drawing/2014/main" id="{F16D8155-4BB8-432A-945E-F78C91D6E64C}"/>
               </a:ext>
             </a:extLst>
           </p:cNvPr>
@@ -3256,7 +3256,7 @@
           <p:cNvPr id="6" name="">
             <a:extLst xmlns:a="http://schemas.openxmlformats.org/drawingml/2006/main">
               <a:ext uri="{FF2B5EF4-FFF2-40B4-BE49-F238E27FC236}">
-                <a16:creationId xmlns:a16="http://schemas.microsoft.com/office/drawing/2014/main" id="{E76C4458-62F0-49F1-8B91-07F3C17DFC57}"/>
+                <a16:creationId xmlns:a16="http://schemas.microsoft.com/office/drawing/2014/main" id="{AD6728A6-841B-4D27-9373-5F8FD0B914AC}"/>
               </a:ext>
             </a:extLst>
           </p:cNvPr>
@@ -3336,7 +3336,7 @@
           <p:cNvPr id="7" name="">
             <a:extLst xmlns:a="http://schemas.openxmlformats.org/drawingml/2006/main">
               <a:ext uri="{FF2B5EF4-FFF2-40B4-BE49-F238E27FC236}">
-                <a16:creationId xmlns:a16="http://schemas.microsoft.com/office/drawing/2014/main" id="{3CF30B73-F7E3-48F4-A654-0F6F064C073E}"/>
+                <a16:creationId xmlns:a16="http://schemas.microsoft.com/office/drawing/2014/main" id="{B940CC60-B5F9-4E9A-B434-DE3A27CD24AE}"/>
               </a:ext>
             </a:extLst>
           </p:cNvPr>
@@ -3382,7 +3382,7 @@
                 <a:latin typeface="Arial"/>
                 <a:ea typeface="Arial"/>
                 <a:cs typeface="Arial"/>
-                <a:hlinkClick xmlns:r="http://schemas.openxmlformats.org/officeDocument/2006/relationships" r:id="R8b203203730d4914"/>
+                <a:hlinkClick xmlns:r="http://schemas.openxmlformats.org/officeDocument/2006/relationships" r:id="Ra96c01ccb7e8453f"/>
               </a:rPr>
               <a:t>Read the daily-search guide</a:t>
             </a:r>
@@ -3392,7 +3392,7 @@
     </p:spTree>
     <p:extLst>
       <p:ext uri="{BB962C8B-B14F-4D97-AF65-F5344CB8AC3E}">
-        <p14:creationId xmlns:p14="http://schemas.microsoft.com/office/powerpoint/2010/main" val="831724952"/>
+        <p14:creationId xmlns:p14="http://schemas.microsoft.com/office/powerpoint/2010/main" val="1398244332"/>
       </p:ext>
     </p:extLst>
   </p:cSld>
@@ -3423,7 +3423,7 @@
           <p:cNvPr id="7" name="">
             <a:extLst xmlns:a="http://schemas.openxmlformats.org/drawingml/2006/main">
               <a:ext uri="{FF2B5EF4-FFF2-40B4-BE49-F238E27FC236}">
-                <a16:creationId xmlns:a16="http://schemas.microsoft.com/office/drawing/2014/main" id="{4C3B55E5-2C0A-473F-8D27-DA190EDEE447}"/>
+                <a16:creationId xmlns:a16="http://schemas.microsoft.com/office/drawing/2014/main" id="{2F66FF20-BC4F-4AB6-A476-D93DE7DFDA98}"/>
               </a:ext>
             </a:extLst>
           </p:cNvPr>
@@ -3480,7 +3480,7 @@
           <p:cNvPr id="2" name="">
             <a:extLst xmlns:a="http://schemas.openxmlformats.org/drawingml/2006/main">
               <a:ext uri="{FF2B5EF4-FFF2-40B4-BE49-F238E27FC236}">
-                <a16:creationId xmlns:a16="http://schemas.microsoft.com/office/drawing/2014/main" id="{E5FBDBAC-7116-4D27-B32C-B863100A199F}"/>
+                <a16:creationId xmlns:a16="http://schemas.microsoft.com/office/drawing/2014/main" id="{2E880C2E-5BA4-49E2-AC01-6861DB6B58EC}"/>
               </a:ext>
             </a:extLst>
           </p:cNvPr>
@@ -3537,7 +3537,7 @@
           <p:cNvPr id="3" name="">
             <a:extLst xmlns:a="http://schemas.openxmlformats.org/drawingml/2006/main">
               <a:ext uri="{FF2B5EF4-FFF2-40B4-BE49-F238E27FC236}">
-                <a16:creationId xmlns:a16="http://schemas.microsoft.com/office/drawing/2014/main" id="{F1B13E13-A78A-48B5-9D08-B1851B9F9711}"/>
+                <a16:creationId xmlns:a16="http://schemas.microsoft.com/office/drawing/2014/main" id="{851C5D4C-A9FF-4DFC-A2DD-613F46EC3ACF}"/>
               </a:ext>
             </a:extLst>
           </p:cNvPr>
@@ -3617,7 +3617,7 @@
           <p:cNvPr id="4" name="">
             <a:extLst xmlns:a="http://schemas.openxmlformats.org/drawingml/2006/main">
               <a:ext uri="{FF2B5EF4-FFF2-40B4-BE49-F238E27FC236}">
-                <a16:creationId xmlns:a16="http://schemas.microsoft.com/office/drawing/2014/main" id="{D174E504-4CEB-4706-9A5A-A30758A0EC94}"/>
+                <a16:creationId xmlns:a16="http://schemas.microsoft.com/office/drawing/2014/main" id="{5CE982AC-36DD-4F34-9F6C-FB325EF278DA}"/>
               </a:ext>
             </a:extLst>
           </p:cNvPr>
@@ -3697,7 +3697,7 @@
           <p:cNvPr id="5" name="">
             <a:extLst xmlns:a="http://schemas.openxmlformats.org/drawingml/2006/main">
               <a:ext uri="{FF2B5EF4-FFF2-40B4-BE49-F238E27FC236}">
-                <a16:creationId xmlns:a16="http://schemas.microsoft.com/office/drawing/2014/main" id="{B404BBEF-034B-471C-A2C0-FD8A8A8D8E64}"/>
+                <a16:creationId xmlns:a16="http://schemas.microsoft.com/office/drawing/2014/main" id="{F62C2C42-677E-4E7C-A9B4-D41813564ADB}"/>
               </a:ext>
             </a:extLst>
           </p:cNvPr>
@@ -3754,7 +3754,7 @@
           <p:cNvPr id="6" name="">
             <a:extLst xmlns:a="http://schemas.openxmlformats.org/drawingml/2006/main">
               <a:ext uri="{FF2B5EF4-FFF2-40B4-BE49-F238E27FC236}">
-                <a16:creationId xmlns:a16="http://schemas.microsoft.com/office/drawing/2014/main" id="{105A9E9D-959B-4F82-BBC2-2F087C46CE77}"/>
+                <a16:creationId xmlns:a16="http://schemas.microsoft.com/office/drawing/2014/main" id="{E6034E27-504E-4178-9EAC-03EC7B60F5DD}"/>
               </a:ext>
             </a:extLst>
           </p:cNvPr>
@@ -3809,7 +3809,7 @@
     </p:spTree>
     <p:extLst>
       <p:ext uri="{BB962C8B-B14F-4D97-AF65-F5344CB8AC3E}">
-        <p14:creationId xmlns:p14="http://schemas.microsoft.com/office/powerpoint/2010/main" val="820330269"/>
+        <p14:creationId xmlns:p14="http://schemas.microsoft.com/office/powerpoint/2010/main" val="1119454450"/>
       </p:ext>
     </p:extLst>
   </p:cSld>
@@ -3840,7 +3840,7 @@
           <p:cNvPr id="9" name="">
             <a:extLst xmlns:a="http://schemas.openxmlformats.org/drawingml/2006/main">
               <a:ext uri="{FF2B5EF4-FFF2-40B4-BE49-F238E27FC236}">
-                <a16:creationId xmlns:a16="http://schemas.microsoft.com/office/drawing/2014/main" id="{4E1C4BAF-81EE-497D-9838-A2D00B556023}"/>
+                <a16:creationId xmlns:a16="http://schemas.microsoft.com/office/drawing/2014/main" id="{2A062370-BA4B-4D31-93F4-AF326E0A26FB}"/>
               </a:ext>
             </a:extLst>
           </p:cNvPr>
@@ -3897,7 +3897,7 @@
           <p:cNvPr id="2" name="">
             <a:extLst xmlns:a="http://schemas.openxmlformats.org/drawingml/2006/main">
               <a:ext uri="{FF2B5EF4-FFF2-40B4-BE49-F238E27FC236}">
-                <a16:creationId xmlns:a16="http://schemas.microsoft.com/office/drawing/2014/main" id="{BE27B121-9986-4E3E-B245-3624DB89AA92}"/>
+                <a16:creationId xmlns:a16="http://schemas.microsoft.com/office/drawing/2014/main" id="{EB42D7E3-D406-4693-88DD-C0CD9A24667B}"/>
               </a:ext>
             </a:extLst>
           </p:cNvPr>
@@ -3954,7 +3954,7 @@
           <p:cNvPr id="3" name="">
             <a:extLst xmlns:a="http://schemas.openxmlformats.org/drawingml/2006/main">
               <a:ext uri="{FF2B5EF4-FFF2-40B4-BE49-F238E27FC236}">
-                <a16:creationId xmlns:a16="http://schemas.microsoft.com/office/drawing/2014/main" id="{FCFDED98-7E73-4586-8C9A-000107F231DB}"/>
+                <a16:creationId xmlns:a16="http://schemas.microsoft.com/office/drawing/2014/main" id="{CDCDA268-36D0-473A-9069-E71EE9A06AA6}"/>
               </a:ext>
             </a:extLst>
           </p:cNvPr>
@@ -4011,7 +4011,7 @@
           <p:cNvPr id="4" name="">
             <a:extLst xmlns:a="http://schemas.openxmlformats.org/drawingml/2006/main">
               <a:ext uri="{FF2B5EF4-FFF2-40B4-BE49-F238E27FC236}">
-                <a16:creationId xmlns:a16="http://schemas.microsoft.com/office/drawing/2014/main" id="{7F8ED386-8DC9-4E5D-9B82-5AD357BCA660}"/>
+                <a16:creationId xmlns:a16="http://schemas.microsoft.com/office/drawing/2014/main" id="{9B3F3F08-8472-422B-AE8F-32202650C21B}"/>
               </a:ext>
             </a:extLst>
           </p:cNvPr>
@@ -4091,7 +4091,7 @@
           <p:cNvPr id="5" name="">
             <a:extLst xmlns:a="http://schemas.openxmlformats.org/drawingml/2006/main">
               <a:ext uri="{FF2B5EF4-FFF2-40B4-BE49-F238E27FC236}">
-                <a16:creationId xmlns:a16="http://schemas.microsoft.com/office/drawing/2014/main" id="{0D511985-081B-483C-998F-B74223E0B1A7}"/>
+                <a16:creationId xmlns:a16="http://schemas.microsoft.com/office/drawing/2014/main" id="{6962B092-3204-43BD-BC6A-6920E4C22F0B}"/>
               </a:ext>
             </a:extLst>
           </p:cNvPr>
@@ -4148,7 +4148,7 @@
           <p:cNvPr id="6" name="">
             <a:extLst xmlns:a="http://schemas.openxmlformats.org/drawingml/2006/main">
               <a:ext uri="{FF2B5EF4-FFF2-40B4-BE49-F238E27FC236}">
-                <a16:creationId xmlns:a16="http://schemas.microsoft.com/office/drawing/2014/main" id="{CE843088-657B-44D3-936A-6169C7F0EF2E}"/>
+                <a16:creationId xmlns:a16="http://schemas.microsoft.com/office/drawing/2014/main" id="{6885BB09-B075-419C-A746-EB1CFE77B28A}"/>
               </a:ext>
             </a:extLst>
           </p:cNvPr>
@@ -4205,7 +4205,7 @@
           <p:cNvPr id="7" name="">
             <a:extLst xmlns:a="http://schemas.openxmlformats.org/drawingml/2006/main">
               <a:ext uri="{FF2B5EF4-FFF2-40B4-BE49-F238E27FC236}">
-                <a16:creationId xmlns:a16="http://schemas.microsoft.com/office/drawing/2014/main" id="{9C7E36DE-B427-45EB-9ECF-4A053B432ED9}"/>
+                <a16:creationId xmlns:a16="http://schemas.microsoft.com/office/drawing/2014/main" id="{526B87D4-6FCE-4C7E-8F5A-E6613C33EDD1}"/>
               </a:ext>
             </a:extLst>
           </p:cNvPr>
@@ -4285,7 +4285,7 @@
           <p:cNvPr id="8" name="">
             <a:extLst xmlns:a="http://schemas.openxmlformats.org/drawingml/2006/main">
               <a:ext uri="{FF2B5EF4-FFF2-40B4-BE49-F238E27FC236}">
-                <a16:creationId xmlns:a16="http://schemas.microsoft.com/office/drawing/2014/main" id="{4FBED212-69DD-4893-8337-A207C56A294C}"/>
+                <a16:creationId xmlns:a16="http://schemas.microsoft.com/office/drawing/2014/main" id="{6A78EB3E-F135-45F0-88B8-CA146F9928B0}"/>
               </a:ext>
             </a:extLst>
           </p:cNvPr>
@@ -4340,7 +4340,7 @@
     </p:spTree>
     <p:extLst>
       <p:ext uri="{BB962C8B-B14F-4D97-AF65-F5344CB8AC3E}">
-        <p14:creationId xmlns:p14="http://schemas.microsoft.com/office/powerpoint/2010/main" val="1781052117"/>
+        <p14:creationId xmlns:p14="http://schemas.microsoft.com/office/powerpoint/2010/main" val="1736121836"/>
       </p:ext>
     </p:extLst>
   </p:cSld>
@@ -4371,7 +4371,7 @@
           <p:cNvPr id="7" name="">
             <a:extLst xmlns:a="http://schemas.openxmlformats.org/drawingml/2006/main">
               <a:ext uri="{FF2B5EF4-FFF2-40B4-BE49-F238E27FC236}">
-                <a16:creationId xmlns:a16="http://schemas.microsoft.com/office/drawing/2014/main" id="{73FD58BF-F86D-4705-8654-463A36E6520D}"/>
+                <a16:creationId xmlns:a16="http://schemas.microsoft.com/office/drawing/2014/main" id="{5DD59564-1F8E-45D8-8908-8296D8B25498}"/>
               </a:ext>
             </a:extLst>
           </p:cNvPr>
@@ -4428,7 +4428,7 @@
           <p:cNvPr id="2" name="">
             <a:extLst xmlns:a="http://schemas.openxmlformats.org/drawingml/2006/main">
               <a:ext uri="{FF2B5EF4-FFF2-40B4-BE49-F238E27FC236}">
-                <a16:creationId xmlns:a16="http://schemas.microsoft.com/office/drawing/2014/main" id="{37ED0DF1-CF29-4998-B55D-FBB49E8A556E}"/>
+                <a16:creationId xmlns:a16="http://schemas.microsoft.com/office/drawing/2014/main" id="{29ECCDD0-3621-4FEA-86BA-99F95FA00055}"/>
               </a:ext>
             </a:extLst>
           </p:cNvPr>
@@ -4485,7 +4485,7 @@
           <p:cNvPr id="3" name="">
             <a:extLst xmlns:a="http://schemas.openxmlformats.org/drawingml/2006/main">
               <a:ext uri="{FF2B5EF4-FFF2-40B4-BE49-F238E27FC236}">
-                <a16:creationId xmlns:a16="http://schemas.microsoft.com/office/drawing/2014/main" id="{CAFD4512-5C26-4CEE-858E-A463EB371CDE}"/>
+                <a16:creationId xmlns:a16="http://schemas.microsoft.com/office/drawing/2014/main" id="{15B265D8-348D-4306-8841-31D6963F2616}"/>
               </a:ext>
             </a:extLst>
           </p:cNvPr>
@@ -4565,7 +4565,7 @@
           <p:cNvPr id="4" name="">
             <a:extLst xmlns:a="http://schemas.openxmlformats.org/drawingml/2006/main">
               <a:ext uri="{FF2B5EF4-FFF2-40B4-BE49-F238E27FC236}">
-                <a16:creationId xmlns:a16="http://schemas.microsoft.com/office/drawing/2014/main" id="{B262F711-197F-4AB4-BBAD-78CBF2918C6F}"/>
+                <a16:creationId xmlns:a16="http://schemas.microsoft.com/office/drawing/2014/main" id="{318051EC-F210-43FB-AED8-33381DDCE3D0}"/>
               </a:ext>
             </a:extLst>
           </p:cNvPr>
@@ -4622,7 +4622,7 @@
           <p:cNvPr id="5" name="">
             <a:extLst xmlns:a="http://schemas.openxmlformats.org/drawingml/2006/main">
               <a:ext uri="{FF2B5EF4-FFF2-40B4-BE49-F238E27FC236}">
-                <a16:creationId xmlns:a16="http://schemas.microsoft.com/office/drawing/2014/main" id="{71B3FAB8-8D0D-4354-BF43-DAE04D89E01C}"/>
+                <a16:creationId xmlns:a16="http://schemas.microsoft.com/office/drawing/2014/main" id="{79617BB1-14CE-498D-B7FA-E75860BB4FFF}"/>
               </a:ext>
             </a:extLst>
           </p:cNvPr>
@@ -4702,7 +4702,7 @@
           <p:cNvPr id="6" name="">
             <a:extLst xmlns:a="http://schemas.openxmlformats.org/drawingml/2006/main">
               <a:ext uri="{FF2B5EF4-FFF2-40B4-BE49-F238E27FC236}">
-                <a16:creationId xmlns:a16="http://schemas.microsoft.com/office/drawing/2014/main" id="{22ED202C-F301-45D8-A472-A566367DA6B6}"/>
+                <a16:creationId xmlns:a16="http://schemas.microsoft.com/office/drawing/2014/main" id="{EF5F0B19-2522-4A70-95F8-41294A5D5842}"/>
               </a:ext>
             </a:extLst>
           </p:cNvPr>
@@ -4757,7 +4757,7 @@
     </p:spTree>
     <p:extLst>
       <p:ext uri="{BB962C8B-B14F-4D97-AF65-F5344CB8AC3E}">
-        <p14:creationId xmlns:p14="http://schemas.microsoft.com/office/powerpoint/2010/main" val="406658693"/>
+        <p14:creationId xmlns:p14="http://schemas.microsoft.com/office/powerpoint/2010/main" val="52950605"/>
       </p:ext>
     </p:extLst>
   </p:cSld>
@@ -4788,7 +4788,7 @@
           <p:cNvPr id="10" name="">
             <a:extLst xmlns:a="http://schemas.openxmlformats.org/drawingml/2006/main">
               <a:ext uri="{FF2B5EF4-FFF2-40B4-BE49-F238E27FC236}">
-                <a16:creationId xmlns:a16="http://schemas.microsoft.com/office/drawing/2014/main" id="{67466188-F260-4374-8CDE-135E8ED567AD}"/>
+                <a16:creationId xmlns:a16="http://schemas.microsoft.com/office/drawing/2014/main" id="{1BD83CD2-56ED-4719-ABBF-6F0C5CA7FF3E}"/>
               </a:ext>
             </a:extLst>
           </p:cNvPr>
@@ -4845,7 +4845,7 @@
           <p:cNvPr id="2" name="">
             <a:extLst xmlns:a="http://schemas.openxmlformats.org/drawingml/2006/main">
               <a:ext uri="{FF2B5EF4-FFF2-40B4-BE49-F238E27FC236}">
-                <a16:creationId xmlns:a16="http://schemas.microsoft.com/office/drawing/2014/main" id="{617BBB54-1070-4406-8B69-848F7CF37E16}"/>
+                <a16:creationId xmlns:a16="http://schemas.microsoft.com/office/drawing/2014/main" id="{1D77CFC2-404F-4B1C-BD1F-9B013804223B}"/>
               </a:ext>
             </a:extLst>
           </p:cNvPr>
@@ -4902,7 +4902,7 @@
           <p:cNvPr id="3" name="">
             <a:extLst xmlns:a="http://schemas.openxmlformats.org/drawingml/2006/main">
               <a:ext uri="{FF2B5EF4-FFF2-40B4-BE49-F238E27FC236}">
-                <a16:creationId xmlns:a16="http://schemas.microsoft.com/office/drawing/2014/main" id="{008A2FAD-50FD-47EE-994C-890146382458}"/>
+                <a16:creationId xmlns:a16="http://schemas.microsoft.com/office/drawing/2014/main" id="{497E7765-EE1E-43F6-9F86-9F2ED6FEF300}"/>
               </a:ext>
             </a:extLst>
           </p:cNvPr>
@@ -4959,7 +4959,7 @@
           <p:cNvPr id="4" name="">
             <a:extLst xmlns:a="http://schemas.openxmlformats.org/drawingml/2006/main">
               <a:ext uri="{FF2B5EF4-FFF2-40B4-BE49-F238E27FC236}">
-                <a16:creationId xmlns:a16="http://schemas.microsoft.com/office/drawing/2014/main" id="{60CE1827-FD2D-4620-AAF6-F9EC69D99F3D}"/>
+                <a16:creationId xmlns:a16="http://schemas.microsoft.com/office/drawing/2014/main" id="{B6703E44-B32F-4002-976C-3CB0169FE4BB}"/>
               </a:ext>
             </a:extLst>
           </p:cNvPr>
@@ -5039,7 +5039,7 @@
           <p:cNvPr id="5" name="">
             <a:extLst xmlns:a="http://schemas.openxmlformats.org/drawingml/2006/main">
               <a:ext uri="{FF2B5EF4-FFF2-40B4-BE49-F238E27FC236}">
-                <a16:creationId xmlns:a16="http://schemas.microsoft.com/office/drawing/2014/main" id="{20BC2229-52E5-485A-85D5-3DB0794E869E}"/>
+                <a16:creationId xmlns:a16="http://schemas.microsoft.com/office/drawing/2014/main" id="{04AEA57B-5ED1-4ED3-9D18-C98E56747321}"/>
               </a:ext>
             </a:extLst>
           </p:cNvPr>
@@ -5096,7 +5096,7 @@
           <p:cNvPr id="6" name="">
             <a:extLst xmlns:a="http://schemas.openxmlformats.org/drawingml/2006/main">
               <a:ext uri="{FF2B5EF4-FFF2-40B4-BE49-F238E27FC236}">
-                <a16:creationId xmlns:a16="http://schemas.microsoft.com/office/drawing/2014/main" id="{78B69EE7-CB31-4FF3-BA6B-0DE86E132D7B}"/>
+                <a16:creationId xmlns:a16="http://schemas.microsoft.com/office/drawing/2014/main" id="{D03C0AFC-C740-4935-90B2-12BF5BFE0E78}"/>
               </a:ext>
             </a:extLst>
           </p:cNvPr>
@@ -5199,7 +5199,7 @@
           <p:cNvPr id="7" name="">
             <a:extLst xmlns:a="http://schemas.openxmlformats.org/drawingml/2006/main">
               <a:ext uri="{FF2B5EF4-FFF2-40B4-BE49-F238E27FC236}">
-                <a16:creationId xmlns:a16="http://schemas.microsoft.com/office/drawing/2014/main" id="{65E77509-673C-4C3C-B8E6-FC8F19AF7324}"/>
+                <a16:creationId xmlns:a16="http://schemas.microsoft.com/office/drawing/2014/main" id="{C3CB14A9-0D7A-429B-A473-09E734148366}"/>
               </a:ext>
             </a:extLst>
           </p:cNvPr>
@@ -5256,7 +5256,7 @@
           <p:cNvPr id="8" name="">
             <a:extLst xmlns:a="http://schemas.openxmlformats.org/drawingml/2006/main">
               <a:ext uri="{FF2B5EF4-FFF2-40B4-BE49-F238E27FC236}">
-                <a16:creationId xmlns:a16="http://schemas.microsoft.com/office/drawing/2014/main" id="{D1ED06C3-E6E8-4F06-80B6-078AF56141F8}"/>
+                <a16:creationId xmlns:a16="http://schemas.microsoft.com/office/drawing/2014/main" id="{51513285-3463-407C-B11C-421E69F44C83}"/>
               </a:ext>
             </a:extLst>
           </p:cNvPr>
@@ -5336,7 +5336,7 @@
           <p:cNvPr id="9" name="">
             <a:extLst xmlns:a="http://schemas.openxmlformats.org/drawingml/2006/main">
               <a:ext uri="{FF2B5EF4-FFF2-40B4-BE49-F238E27FC236}">
-                <a16:creationId xmlns:a16="http://schemas.microsoft.com/office/drawing/2014/main" id="{245D5E1D-04CF-4F86-8957-A569435B295A}"/>
+                <a16:creationId xmlns:a16="http://schemas.microsoft.com/office/drawing/2014/main" id="{092B3A80-8CC9-43EF-A951-87DCDA10611D}"/>
               </a:ext>
             </a:extLst>
           </p:cNvPr>
@@ -5382,7 +5382,7 @@
                 <a:latin typeface="Arial"/>
                 <a:ea typeface="Arial"/>
                 <a:cs typeface="Arial"/>
-                <a:hlinkClick xmlns:r="http://schemas.openxmlformats.org/officeDocument/2006/relationships" r:id="Rf89fcbd7eb5e4f7a"/>
+                <a:hlinkClick xmlns:r="http://schemas.openxmlformats.org/officeDocument/2006/relationships" r:id="R17962d8df6e24f15"/>
               </a:rPr>
               <a:t>Full guide, downloads and troubleshooting</a:t>
             </a:r>
@@ -5392,7 +5392,7 @@
     </p:spTree>
     <p:extLst>
       <p:ext uri="{BB962C8B-B14F-4D97-AF65-F5344CB8AC3E}">
-        <p14:creationId xmlns:p14="http://schemas.microsoft.com/office/powerpoint/2010/main" val="760885182"/>
+        <p14:creationId xmlns:p14="http://schemas.microsoft.com/office/powerpoint/2010/main" val="1353861993"/>
       </p:ext>
     </p:extLst>
   </p:cSld>
@@ -5423,7 +5423,7 @@
           <p:cNvPr id="13" name="">
             <a:extLst xmlns:a="http://schemas.openxmlformats.org/drawingml/2006/main">
               <a:ext uri="{FF2B5EF4-FFF2-40B4-BE49-F238E27FC236}">
-                <a16:creationId xmlns:a16="http://schemas.microsoft.com/office/drawing/2014/main" id="{73CA8F52-08C9-4E7C-B1CA-1E6137D4BB84}"/>
+                <a16:creationId xmlns:a16="http://schemas.microsoft.com/office/drawing/2014/main" id="{BB228F53-2C38-45C4-BEA0-C80ED7C47B3F}"/>
               </a:ext>
             </a:extLst>
           </p:cNvPr>
@@ -5480,7 +5480,7 @@
           <p:cNvPr id="2" name="">
             <a:extLst xmlns:a="http://schemas.openxmlformats.org/drawingml/2006/main">
               <a:ext uri="{FF2B5EF4-FFF2-40B4-BE49-F238E27FC236}">
-                <a16:creationId xmlns:a16="http://schemas.microsoft.com/office/drawing/2014/main" id="{C8B80E00-68BC-40CE-B0B9-A1E634801173}"/>
+                <a16:creationId xmlns:a16="http://schemas.microsoft.com/office/drawing/2014/main" id="{577FE57E-EA2C-4335-AEFF-7E829B81ACBA}"/>
               </a:ext>
             </a:extLst>
           </p:cNvPr>
@@ -5537,7 +5537,7 @@
           <p:cNvPr id="3" name="">
             <a:extLst xmlns:a="http://schemas.openxmlformats.org/drawingml/2006/main">
               <a:ext uri="{FF2B5EF4-FFF2-40B4-BE49-F238E27FC236}">
-                <a16:creationId xmlns:a16="http://schemas.microsoft.com/office/drawing/2014/main" id="{5E28ECFA-03DC-45A8-A021-245B3B7DCA1D}"/>
+                <a16:creationId xmlns:a16="http://schemas.microsoft.com/office/drawing/2014/main" id="{266817B8-761A-47A4-96EA-13EB7AB00998}"/>
               </a:ext>
             </a:extLst>
           </p:cNvPr>
@@ -5594,7 +5594,7 @@
           <p:cNvPr id="4" name="">
             <a:extLst xmlns:a="http://schemas.openxmlformats.org/drawingml/2006/main">
               <a:ext uri="{FF2B5EF4-FFF2-40B4-BE49-F238E27FC236}">
-                <a16:creationId xmlns:a16="http://schemas.microsoft.com/office/drawing/2014/main" id="{5B9DA8A0-D4FA-484A-8842-3A1A93A40960}"/>
+                <a16:creationId xmlns:a16="http://schemas.microsoft.com/office/drawing/2014/main" id="{4BA1C606-F286-4881-B866-CA232EEF80A3}"/>
               </a:ext>
             </a:extLst>
           </p:cNvPr>
@@ -5651,7 +5651,7 @@
           <p:cNvPr id="5" name="">
             <a:extLst xmlns:a="http://schemas.openxmlformats.org/drawingml/2006/main">
               <a:ext uri="{FF2B5EF4-FFF2-40B4-BE49-F238E27FC236}">
-                <a16:creationId xmlns:a16="http://schemas.microsoft.com/office/drawing/2014/main" id="{182D224E-FA80-4DF6-B48A-A1A84B835727}"/>
+                <a16:creationId xmlns:a16="http://schemas.microsoft.com/office/drawing/2014/main" id="{66FCEB7E-B649-4DFF-8DE0-DF322FAFC693}"/>
               </a:ext>
             </a:extLst>
           </p:cNvPr>
@@ -5731,7 +5731,7 @@
           <p:cNvPr id="6" name="">
             <a:extLst xmlns:a="http://schemas.openxmlformats.org/drawingml/2006/main">
               <a:ext uri="{FF2B5EF4-FFF2-40B4-BE49-F238E27FC236}">
-                <a16:creationId xmlns:a16="http://schemas.microsoft.com/office/drawing/2014/main" id="{1D25592B-ACA2-4031-AACB-F08395D2F796}"/>
+                <a16:creationId xmlns:a16="http://schemas.microsoft.com/office/drawing/2014/main" id="{C872A819-A131-44D0-9B29-56046CCA92B3}"/>
               </a:ext>
             </a:extLst>
           </p:cNvPr>
@@ -5777,7 +5777,7 @@
                 <a:latin typeface="Arial"/>
                 <a:ea typeface="Arial"/>
                 <a:cs typeface="Arial"/>
-                <a:hlinkClick xmlns:r="http://schemas.openxmlformats.org/officeDocument/2006/relationships" r:id="R48567a9a37254066"/>
+                <a:hlinkClick xmlns:r="http://schemas.openxmlformats.org/officeDocument/2006/relationships" r:id="Rdb1faea3de994af4"/>
               </a:rPr>
               <a:t>Mac download page (Apple Silicon)</a:t>
             </a:r>
@@ -5789,7 +5789,7 @@
           <p:cNvPr id="7" name="">
             <a:extLst xmlns:a="http://schemas.openxmlformats.org/drawingml/2006/main">
               <a:ext uri="{FF2B5EF4-FFF2-40B4-BE49-F238E27FC236}">
-                <a16:creationId xmlns:a16="http://schemas.microsoft.com/office/drawing/2014/main" id="{6626AF31-D242-417E-AE58-972693C79B7C}"/>
+                <a16:creationId xmlns:a16="http://schemas.microsoft.com/office/drawing/2014/main" id="{4E15BB48-48E4-4DC4-95DE-AAC810E7ACCD}"/>
               </a:ext>
             </a:extLst>
           </p:cNvPr>
@@ -5835,7 +5835,7 @@
                 <a:latin typeface="Arial"/>
                 <a:ea typeface="Arial"/>
                 <a:cs typeface="Arial"/>
-                <a:hlinkClick xmlns:r="http://schemas.openxmlformats.org/officeDocument/2006/relationships" r:id="R3819cfa2e4be4c07"/>
+                <a:hlinkClick xmlns:r="http://schemas.openxmlformats.org/officeDocument/2006/relationships" r:id="R391c08e88b36418a"/>
               </a:rPr>
               <a:t>Windows download page</a:t>
             </a:r>
@@ -5847,7 +5847,7 @@
           <p:cNvPr id="8" name="">
             <a:extLst xmlns:a="http://schemas.openxmlformats.org/drawingml/2006/main">
               <a:ext uri="{FF2B5EF4-FFF2-40B4-BE49-F238E27FC236}">
-                <a16:creationId xmlns:a16="http://schemas.microsoft.com/office/drawing/2014/main" id="{B973B3B9-1ACD-4693-BF1A-7ABF120A62F7}"/>
+                <a16:creationId xmlns:a16="http://schemas.microsoft.com/office/drawing/2014/main" id="{0FB771EF-A279-4708-8C20-CD339E7BE0CA}"/>
               </a:ext>
             </a:extLst>
           </p:cNvPr>
@@ -5904,7 +5904,7 @@
           <p:cNvPr id="9" name="">
             <a:extLst xmlns:a="http://schemas.openxmlformats.org/drawingml/2006/main">
               <a:ext uri="{FF2B5EF4-FFF2-40B4-BE49-F238E27FC236}">
-                <a16:creationId xmlns:a16="http://schemas.microsoft.com/office/drawing/2014/main" id="{EFF1E460-A8D9-4E3A-9959-E8D654C045F4}"/>
+                <a16:creationId xmlns:a16="http://schemas.microsoft.com/office/drawing/2014/main" id="{00B9B629-4107-46C7-9174-2FE3C1B084A6}"/>
               </a:ext>
             </a:extLst>
           </p:cNvPr>
@@ -5984,7 +5984,7 @@
           <p:cNvPr id="10" name="">
             <a:extLst xmlns:a="http://schemas.openxmlformats.org/drawingml/2006/main">
               <a:ext uri="{FF2B5EF4-FFF2-40B4-BE49-F238E27FC236}">
-                <a16:creationId xmlns:a16="http://schemas.microsoft.com/office/drawing/2014/main" id="{115BB5D7-1FE8-48DD-A8BA-47ACD094AFB9}"/>
+                <a16:creationId xmlns:a16="http://schemas.microsoft.com/office/drawing/2014/main" id="{31F05D02-7E84-49F2-8C84-954D6CB6DF1E}"/>
               </a:ext>
             </a:extLst>
           </p:cNvPr>
@@ -6030,7 +6030,7 @@
                 <a:latin typeface="Arial"/>
                 <a:ea typeface="Arial"/>
                 <a:cs typeface="Arial"/>
-                <a:hlinkClick xmlns:r="http://schemas.openxmlformats.org/officeDocument/2006/relationships" r:id="Rab735c6791414244"/>
+                <a:hlinkClick xmlns:r="http://schemas.openxmlformats.org/officeDocument/2006/relationships" r:id="R0953dcabc59a4aba"/>
               </a:rPr>
               <a:t>Mac or Windows downloads</a:t>
             </a:r>
@@ -6042,7 +6042,7 @@
           <p:cNvPr id="11" name="">
             <a:extLst xmlns:a="http://schemas.openxmlformats.org/drawingml/2006/main">
               <a:ext uri="{FF2B5EF4-FFF2-40B4-BE49-F238E27FC236}">
-                <a16:creationId xmlns:a16="http://schemas.microsoft.com/office/drawing/2014/main" id="{0B53BA8D-EBE8-40AD-9CAD-184EE9BD6506}"/>
+                <a16:creationId xmlns:a16="http://schemas.microsoft.com/office/drawing/2014/main" id="{694CBCB5-E514-4430-AEC5-C8A8147FA688}"/>
               </a:ext>
             </a:extLst>
           </p:cNvPr>
@@ -6088,7 +6088,7 @@
                 <a:latin typeface="Arial"/>
                 <a:ea typeface="Arial"/>
                 <a:cs typeface="Arial"/>
-                <a:hlinkClick xmlns:r="http://schemas.openxmlformats.org/officeDocument/2006/relationships" r:id="Ra6e20e033b8b490a"/>
+                <a:hlinkClick xmlns:r="http://schemas.openxmlformats.org/officeDocument/2006/relationships" r:id="R27ff7b93c20e45b2"/>
               </a:rPr>
               <a:t>Claude Code setup and account requirements</a:t>
             </a:r>
@@ -6100,7 +6100,7 @@
           <p:cNvPr id="12" name="">
             <a:extLst xmlns:a="http://schemas.openxmlformats.org/drawingml/2006/main">
               <a:ext uri="{FF2B5EF4-FFF2-40B4-BE49-F238E27FC236}">
-                <a16:creationId xmlns:a16="http://schemas.microsoft.com/office/drawing/2014/main" id="{4155A108-909D-4D81-940F-332B86DF9A0F}"/>
+                <a16:creationId xmlns:a16="http://schemas.microsoft.com/office/drawing/2014/main" id="{BCE968CB-FD5B-464A-8E63-ED0C9E25F97A}"/>
               </a:ext>
             </a:extLst>
           </p:cNvPr>
@@ -6155,7 +6155,7 @@
     </p:spTree>
     <p:extLst>
       <p:ext uri="{BB962C8B-B14F-4D97-AF65-F5344CB8AC3E}">
-        <p14:creationId xmlns:p14="http://schemas.microsoft.com/office/powerpoint/2010/main" val="1687323505"/>
+        <p14:creationId xmlns:p14="http://schemas.microsoft.com/office/powerpoint/2010/main" val="1921287759"/>
       </p:ext>
     </p:extLst>
   </p:cSld>
@@ -6186,7 +6186,7 @@
           <p:cNvPr id="6" name="">
             <a:extLst xmlns:a="http://schemas.openxmlformats.org/drawingml/2006/main">
               <a:ext uri="{FF2B5EF4-FFF2-40B4-BE49-F238E27FC236}">
-                <a16:creationId xmlns:a16="http://schemas.microsoft.com/office/drawing/2014/main" id="{84B22F57-8AC4-4B65-B6F4-BA08041C6253}"/>
+                <a16:creationId xmlns:a16="http://schemas.microsoft.com/office/drawing/2014/main" id="{BA9D3AA1-6D5F-4B75-B221-43E2605978A0}"/>
               </a:ext>
             </a:extLst>
           </p:cNvPr>
@@ -6243,7 +6243,7 @@
           <p:cNvPr id="2" name="">
             <a:extLst xmlns:a="http://schemas.openxmlformats.org/drawingml/2006/main">
               <a:ext uri="{FF2B5EF4-FFF2-40B4-BE49-F238E27FC236}">
-                <a16:creationId xmlns:a16="http://schemas.microsoft.com/office/drawing/2014/main" id="{51843606-E2B0-493E-A0FE-BAA7725D40F2}"/>
+                <a16:creationId xmlns:a16="http://schemas.microsoft.com/office/drawing/2014/main" id="{F81D59EC-4DA1-4A31-90FA-45C4C2AE0CDC}"/>
               </a:ext>
             </a:extLst>
           </p:cNvPr>
@@ -6300,7 +6300,7 @@
           <p:cNvPr id="3" name="">
             <a:extLst xmlns:a="http://schemas.openxmlformats.org/drawingml/2006/main">
               <a:ext uri="{FF2B5EF4-FFF2-40B4-BE49-F238E27FC236}">
-                <a16:creationId xmlns:a16="http://schemas.microsoft.com/office/drawing/2014/main" id="{59D36835-C121-4E0E-998A-3FECBD2A07AE}"/>
+                <a16:creationId xmlns:a16="http://schemas.microsoft.com/office/drawing/2014/main" id="{220028C5-B582-4AE2-9238-162ECEDF49B3}"/>
               </a:ext>
             </a:extLst>
           </p:cNvPr>
@@ -6361,7 +6361,7 @@
           <p:nvPr/>
         </p:nvPicPr>
         <p:blipFill>
-          <a:blip xmlns:r="http://schemas.openxmlformats.org/officeDocument/2006/relationships" xmlns:a="http://schemas.openxmlformats.org/drawingml/2006/main" r:embed="R4af1ba4d79f44a64"/>
+          <a:blip xmlns:r="http://schemas.openxmlformats.org/officeDocument/2006/relationships" xmlns:a="http://schemas.openxmlformats.org/drawingml/2006/main" r:embed="R2c9b4ec006134c13"/>
           <a:stretch xmlns:a="http://schemas.openxmlformats.org/drawingml/2006/main"/>
         </p:blipFill>
         <p:spPr>
@@ -6379,7 +6379,7 @@
           <p:cNvPr id="5" name="">
             <a:extLst xmlns:a="http://schemas.openxmlformats.org/drawingml/2006/main">
               <a:ext uri="{FF2B5EF4-FFF2-40B4-BE49-F238E27FC236}">
-                <a16:creationId xmlns:a16="http://schemas.microsoft.com/office/drawing/2014/main" id="{077EE390-79C7-4346-88F5-A51D430164E0}"/>
+                <a16:creationId xmlns:a16="http://schemas.microsoft.com/office/drawing/2014/main" id="{19B2B2C4-C936-40F3-A8D3-5E2C69600E7D}"/>
               </a:ext>
             </a:extLst>
           </p:cNvPr>
@@ -6457,7 +6457,7 @@
     </p:spTree>
     <p:extLst>
       <p:ext uri="{BB962C8B-B14F-4D97-AF65-F5344CB8AC3E}">
-        <p14:creationId xmlns:p14="http://schemas.microsoft.com/office/powerpoint/2010/main" val="1039363836"/>
+        <p14:creationId xmlns:p14="http://schemas.microsoft.com/office/powerpoint/2010/main" val="301049123"/>
       </p:ext>
     </p:extLst>
   </p:cSld>
@@ -6488,7 +6488,7 @@
           <p:cNvPr id="8" name="">
             <a:extLst xmlns:a="http://schemas.openxmlformats.org/drawingml/2006/main">
               <a:ext uri="{FF2B5EF4-FFF2-40B4-BE49-F238E27FC236}">
-                <a16:creationId xmlns:a16="http://schemas.microsoft.com/office/drawing/2014/main" id="{87C6FC88-5CBE-43C1-9268-595420D61E4E}"/>
+                <a16:creationId xmlns:a16="http://schemas.microsoft.com/office/drawing/2014/main" id="{E1C34819-0EE8-41C1-8145-ECBE6A17E2B3}"/>
               </a:ext>
             </a:extLst>
           </p:cNvPr>
@@ -6545,7 +6545,7 @@
           <p:cNvPr id="2" name="">
             <a:extLst xmlns:a="http://schemas.openxmlformats.org/drawingml/2006/main">
               <a:ext uri="{FF2B5EF4-FFF2-40B4-BE49-F238E27FC236}">
-                <a16:creationId xmlns:a16="http://schemas.microsoft.com/office/drawing/2014/main" id="{2F001D6C-21B8-4107-A5CB-65948131AC70}"/>
+                <a16:creationId xmlns:a16="http://schemas.microsoft.com/office/drawing/2014/main" id="{EBABF7D7-E5CA-41B3-9370-448EC5BA9590}"/>
               </a:ext>
             </a:extLst>
           </p:cNvPr>
@@ -6602,7 +6602,7 @@
           <p:cNvPr id="3" name="">
             <a:extLst xmlns:a="http://schemas.openxmlformats.org/drawingml/2006/main">
               <a:ext uri="{FF2B5EF4-FFF2-40B4-BE49-F238E27FC236}">
-                <a16:creationId xmlns:a16="http://schemas.microsoft.com/office/drawing/2014/main" id="{2901C74B-FD0D-4908-9C89-34A6FDD4E512}"/>
+                <a16:creationId xmlns:a16="http://schemas.microsoft.com/office/drawing/2014/main" id="{FA496778-3D23-41A7-B36A-3294BA477DB5}"/>
               </a:ext>
             </a:extLst>
           </p:cNvPr>
@@ -6659,7 +6659,7 @@
           <p:cNvPr id="4" name="">
             <a:extLst xmlns:a="http://schemas.openxmlformats.org/drawingml/2006/main">
               <a:ext uri="{FF2B5EF4-FFF2-40B4-BE49-F238E27FC236}">
-                <a16:creationId xmlns:a16="http://schemas.microsoft.com/office/drawing/2014/main" id="{29930B79-4848-4BF0-A6B7-3762962C8437}"/>
+                <a16:creationId xmlns:a16="http://schemas.microsoft.com/office/drawing/2014/main" id="{797BA979-39F9-4528-A8CC-4DC063539F1B}"/>
               </a:ext>
             </a:extLst>
           </p:cNvPr>
@@ -6785,7 +6785,7 @@
           <p:cNvPr id="5" name="">
             <a:extLst xmlns:a="http://schemas.openxmlformats.org/drawingml/2006/main">
               <a:ext uri="{FF2B5EF4-FFF2-40B4-BE49-F238E27FC236}">
-                <a16:creationId xmlns:a16="http://schemas.microsoft.com/office/drawing/2014/main" id="{1A3F281F-0CA9-4B45-8340-60C5808A8938}"/>
+                <a16:creationId xmlns:a16="http://schemas.microsoft.com/office/drawing/2014/main" id="{5960DB2D-A508-4A39-8F61-D931312BF670}"/>
               </a:ext>
             </a:extLst>
           </p:cNvPr>
@@ -6892,7 +6892,7 @@
           <p:nvPr/>
         </p:nvPicPr>
         <p:blipFill>
-          <a:blip xmlns:r="http://schemas.openxmlformats.org/officeDocument/2006/relationships" xmlns:a="http://schemas.openxmlformats.org/drawingml/2006/main" r:embed="R21ff2aa66512460a"/>
+          <a:blip xmlns:r="http://schemas.openxmlformats.org/officeDocument/2006/relationships" xmlns:a="http://schemas.openxmlformats.org/drawingml/2006/main" r:embed="R921f09dbe4c34b9d"/>
           <a:stretch xmlns:a="http://schemas.openxmlformats.org/drawingml/2006/main"/>
         </p:blipFill>
         <p:spPr>
@@ -6910,7 +6910,7 @@
           <p:cNvPr id="7" name="">
             <a:extLst xmlns:a="http://schemas.openxmlformats.org/drawingml/2006/main">
               <a:ext uri="{FF2B5EF4-FFF2-40B4-BE49-F238E27FC236}">
-                <a16:creationId xmlns:a16="http://schemas.microsoft.com/office/drawing/2014/main" id="{72FE2901-5110-4D91-A895-95C9D9DE67AB}"/>
+                <a16:creationId xmlns:a16="http://schemas.microsoft.com/office/drawing/2014/main" id="{C7180632-EEA8-4B60-AC78-D2F8BB96696B}"/>
               </a:ext>
             </a:extLst>
           </p:cNvPr>
@@ -6965,7 +6965,7 @@
     </p:spTree>
     <p:extLst>
       <p:ext uri="{BB962C8B-B14F-4D97-AF65-F5344CB8AC3E}">
-        <p14:creationId xmlns:p14="http://schemas.microsoft.com/office/powerpoint/2010/main" val="1955263578"/>
+        <p14:creationId xmlns:p14="http://schemas.microsoft.com/office/powerpoint/2010/main" val="389959400"/>
       </p:ext>
     </p:extLst>
   </p:cSld>
@@ -6996,7 +6996,7 @@
           <p:cNvPr id="6" name="">
             <a:extLst xmlns:a="http://schemas.openxmlformats.org/drawingml/2006/main">
               <a:ext uri="{FF2B5EF4-FFF2-40B4-BE49-F238E27FC236}">
-                <a16:creationId xmlns:a16="http://schemas.microsoft.com/office/drawing/2014/main" id="{654B3DFD-37BA-4887-A601-81FCDAE8CD4F}"/>
+                <a16:creationId xmlns:a16="http://schemas.microsoft.com/office/drawing/2014/main" id="{819B5501-EECD-4EB1-B783-6F22F1D1443C}"/>
               </a:ext>
             </a:extLst>
           </p:cNvPr>
@@ -7053,7 +7053,7 @@
           <p:cNvPr id="2" name="">
             <a:extLst xmlns:a="http://schemas.openxmlformats.org/drawingml/2006/main">
               <a:ext uri="{FF2B5EF4-FFF2-40B4-BE49-F238E27FC236}">
-                <a16:creationId xmlns:a16="http://schemas.microsoft.com/office/drawing/2014/main" id="{5DFF1F12-B108-41A2-A146-D72177BF7896}"/>
+                <a16:creationId xmlns:a16="http://schemas.microsoft.com/office/drawing/2014/main" id="{2C64E738-20EB-42AE-B2E1-B3A8A372B6DC}"/>
               </a:ext>
             </a:extLst>
           </p:cNvPr>
@@ -7110,7 +7110,7 @@
           <p:cNvPr id="3" name="">
             <a:extLst xmlns:a="http://schemas.openxmlformats.org/drawingml/2006/main">
               <a:ext uri="{FF2B5EF4-FFF2-40B4-BE49-F238E27FC236}">
-                <a16:creationId xmlns:a16="http://schemas.microsoft.com/office/drawing/2014/main" id="{FEE433A5-2A30-4DC2-89B3-CD21F7F71563}"/>
+                <a16:creationId xmlns:a16="http://schemas.microsoft.com/office/drawing/2014/main" id="{8C7BDE0C-0EEF-4ED2-8875-2B92B4388541}"/>
               </a:ext>
             </a:extLst>
           </p:cNvPr>
@@ -7194,7 +7194,7 @@
           <p:nvPr/>
         </p:nvPicPr>
         <p:blipFill>
-          <a:blip xmlns:r="http://schemas.openxmlformats.org/officeDocument/2006/relationships" xmlns:a="http://schemas.openxmlformats.org/drawingml/2006/main" r:embed="Rba62139f4d5c405b"/>
+          <a:blip xmlns:r="http://schemas.openxmlformats.org/officeDocument/2006/relationships" xmlns:a="http://schemas.openxmlformats.org/drawingml/2006/main" r:embed="R5e234561ed274431"/>
           <a:stretch xmlns:a="http://schemas.openxmlformats.org/drawingml/2006/main"/>
         </p:blipFill>
         <p:spPr>
@@ -7212,7 +7212,7 @@
           <p:cNvPr id="5" name="">
             <a:extLst xmlns:a="http://schemas.openxmlformats.org/drawingml/2006/main">
               <a:ext uri="{FF2B5EF4-FFF2-40B4-BE49-F238E27FC236}">
-                <a16:creationId xmlns:a16="http://schemas.microsoft.com/office/drawing/2014/main" id="{13849C82-D899-4FB4-B055-2CEA734C22CD}"/>
+                <a16:creationId xmlns:a16="http://schemas.microsoft.com/office/drawing/2014/main" id="{5E75542F-0D8C-46E9-A276-25490CF05706}"/>
               </a:ext>
             </a:extLst>
           </p:cNvPr>
@@ -7290,7 +7290,7 @@
     </p:spTree>
     <p:extLst>
       <p:ext uri="{BB962C8B-B14F-4D97-AF65-F5344CB8AC3E}">
-        <p14:creationId xmlns:p14="http://schemas.microsoft.com/office/powerpoint/2010/main" val="646599135"/>
+        <p14:creationId xmlns:p14="http://schemas.microsoft.com/office/powerpoint/2010/main" val="2025084668"/>
       </p:ext>
     </p:extLst>
   </p:cSld>
@@ -7321,7 +7321,7 @@
           <p:cNvPr id="6" name="">
             <a:extLst xmlns:a="http://schemas.openxmlformats.org/drawingml/2006/main">
               <a:ext uri="{FF2B5EF4-FFF2-40B4-BE49-F238E27FC236}">
-                <a16:creationId xmlns:a16="http://schemas.microsoft.com/office/drawing/2014/main" id="{0444154C-D067-480A-90B6-5B0C33C3B106}"/>
+                <a16:creationId xmlns:a16="http://schemas.microsoft.com/office/drawing/2014/main" id="{2370B76E-DD49-4DFB-B2F5-237100AB2F1B}"/>
               </a:ext>
             </a:extLst>
           </p:cNvPr>
@@ -7378,7 +7378,7 @@
           <p:cNvPr id="2" name="">
             <a:extLst xmlns:a="http://schemas.openxmlformats.org/drawingml/2006/main">
               <a:ext uri="{FF2B5EF4-FFF2-40B4-BE49-F238E27FC236}">
-                <a16:creationId xmlns:a16="http://schemas.microsoft.com/office/drawing/2014/main" id="{EC59C3FC-4B01-4300-9AC8-8DBD3A15862F}"/>
+                <a16:creationId xmlns:a16="http://schemas.microsoft.com/office/drawing/2014/main" id="{3CB77A22-C5C8-495C-AAC4-116C49B83247}"/>
               </a:ext>
             </a:extLst>
           </p:cNvPr>
@@ -7435,7 +7435,7 @@
           <p:cNvPr id="3" name="">
             <a:extLst xmlns:a="http://schemas.openxmlformats.org/drawingml/2006/main">
               <a:ext uri="{FF2B5EF4-FFF2-40B4-BE49-F238E27FC236}">
-                <a16:creationId xmlns:a16="http://schemas.microsoft.com/office/drawing/2014/main" id="{19D0D0BB-8176-4FB4-B2A2-7BAD8C328311}"/>
+                <a16:creationId xmlns:a16="http://schemas.microsoft.com/office/drawing/2014/main" id="{AAA85112-206C-4156-8A2F-876A0F505EA7}"/>
               </a:ext>
             </a:extLst>
           </p:cNvPr>
@@ -7496,7 +7496,7 @@
           <p:nvPr/>
         </p:nvPicPr>
         <p:blipFill>
-          <a:blip xmlns:r="http://schemas.openxmlformats.org/officeDocument/2006/relationships" xmlns:a="http://schemas.openxmlformats.org/drawingml/2006/main" r:embed="R8fee520822184073"/>
+          <a:blip xmlns:r="http://schemas.openxmlformats.org/officeDocument/2006/relationships" xmlns:a="http://schemas.openxmlformats.org/drawingml/2006/main" r:embed="R8a6421071f44420c"/>
           <a:stretch xmlns:a="http://schemas.openxmlformats.org/drawingml/2006/main"/>
         </p:blipFill>
         <p:spPr>
@@ -7514,7 +7514,7 @@
           <p:cNvPr id="5" name="">
             <a:extLst xmlns:a="http://schemas.openxmlformats.org/drawingml/2006/main">
               <a:ext uri="{FF2B5EF4-FFF2-40B4-BE49-F238E27FC236}">
-                <a16:creationId xmlns:a16="http://schemas.microsoft.com/office/drawing/2014/main" id="{3F47E985-1DDF-4EC0-8DAB-E414C238B506}"/>
+                <a16:creationId xmlns:a16="http://schemas.microsoft.com/office/drawing/2014/main" id="{D7C9D948-94E4-42B4-AE28-149A9E92AFEE}"/>
               </a:ext>
             </a:extLst>
           </p:cNvPr>
@@ -7592,7 +7592,7 @@
     </p:spTree>
     <p:extLst>
       <p:ext uri="{BB962C8B-B14F-4D97-AF65-F5344CB8AC3E}">
-        <p14:creationId xmlns:p14="http://schemas.microsoft.com/office/powerpoint/2010/main" val="1803607922"/>
+        <p14:creationId xmlns:p14="http://schemas.microsoft.com/office/powerpoint/2010/main" val="882644149"/>
       </p:ext>
     </p:extLst>
   </p:cSld>
@@ -7623,7 +7623,7 @@
           <p:cNvPr id="8" name="">
             <a:extLst xmlns:a="http://schemas.openxmlformats.org/drawingml/2006/main">
               <a:ext uri="{FF2B5EF4-FFF2-40B4-BE49-F238E27FC236}">
-                <a16:creationId xmlns:a16="http://schemas.microsoft.com/office/drawing/2014/main" id="{2D5E5514-C150-43F6-B4EC-376F37CAC040}"/>
+                <a16:creationId xmlns:a16="http://schemas.microsoft.com/office/drawing/2014/main" id="{899873CB-E3FF-4A32-8D3D-52B39D02A7B1}"/>
               </a:ext>
             </a:extLst>
           </p:cNvPr>
@@ -7680,7 +7680,7 @@
           <p:cNvPr id="2" name="">
             <a:extLst xmlns:a="http://schemas.openxmlformats.org/drawingml/2006/main">
               <a:ext uri="{FF2B5EF4-FFF2-40B4-BE49-F238E27FC236}">
-                <a16:creationId xmlns:a16="http://schemas.microsoft.com/office/drawing/2014/main" id="{38A17D0D-8D3B-4AAD-8140-36AAF6E933C2}"/>
+                <a16:creationId xmlns:a16="http://schemas.microsoft.com/office/drawing/2014/main" id="{FE647B76-A8C3-4FC0-B7CB-B5330DDAADA8}"/>
               </a:ext>
             </a:extLst>
           </p:cNvPr>
@@ -7737,7 +7737,7 @@
           <p:cNvPr id="3" name="">
             <a:extLst xmlns:a="http://schemas.openxmlformats.org/drawingml/2006/main">
               <a:ext uri="{FF2B5EF4-FFF2-40B4-BE49-F238E27FC236}">
-                <a16:creationId xmlns:a16="http://schemas.microsoft.com/office/drawing/2014/main" id="{BDC19E51-6A91-4818-89E5-F2A7128E78A6}"/>
+                <a16:creationId xmlns:a16="http://schemas.microsoft.com/office/drawing/2014/main" id="{7A5FD4D7-2672-4A13-9C62-3CC32FC98263}"/>
               </a:ext>
             </a:extLst>
           </p:cNvPr>
@@ -7794,7 +7794,7 @@
           <p:cNvPr id="4" name="">
             <a:extLst xmlns:a="http://schemas.openxmlformats.org/drawingml/2006/main">
               <a:ext uri="{FF2B5EF4-FFF2-40B4-BE49-F238E27FC236}">
-                <a16:creationId xmlns:a16="http://schemas.microsoft.com/office/drawing/2014/main" id="{62631BE1-9AE7-4B06-B138-093E30E749BE}"/>
+                <a16:creationId xmlns:a16="http://schemas.microsoft.com/office/drawing/2014/main" id="{0D657920-D854-4952-9E1D-9972983AD8D3}"/>
               </a:ext>
             </a:extLst>
           </p:cNvPr>
@@ -7874,7 +7874,7 @@
           <p:cNvPr id="5" name="">
             <a:extLst xmlns:a="http://schemas.openxmlformats.org/drawingml/2006/main">
               <a:ext uri="{FF2B5EF4-FFF2-40B4-BE49-F238E27FC236}">
-                <a16:creationId xmlns:a16="http://schemas.microsoft.com/office/drawing/2014/main" id="{109048E4-6C52-4928-A394-CC72939A2F59}"/>
+                <a16:creationId xmlns:a16="http://schemas.microsoft.com/office/drawing/2014/main" id="{5D69E659-22D0-424F-A2AB-7559C211B7ED}"/>
               </a:ext>
             </a:extLst>
           </p:cNvPr>
@@ -7931,7 +7931,7 @@
           <p:cNvPr id="6" name="">
             <a:extLst xmlns:a="http://schemas.openxmlformats.org/drawingml/2006/main">
               <a:ext uri="{FF2B5EF4-FFF2-40B4-BE49-F238E27FC236}">
-                <a16:creationId xmlns:a16="http://schemas.microsoft.com/office/drawing/2014/main" id="{84CBF909-369E-454F-85E8-E622E3CA7C2E}"/>
+                <a16:creationId xmlns:a16="http://schemas.microsoft.com/office/drawing/2014/main" id="{643B98FC-5BC8-4EEC-94EC-156C8DB127C2}"/>
               </a:ext>
             </a:extLst>
           </p:cNvPr>
@@ -7988,7 +7988,7 @@
           <p:cNvPr id="7" name="">
             <a:extLst xmlns:a="http://schemas.openxmlformats.org/drawingml/2006/main">
               <a:ext uri="{FF2B5EF4-FFF2-40B4-BE49-F238E27FC236}">
-                <a16:creationId xmlns:a16="http://schemas.microsoft.com/office/drawing/2014/main" id="{8894F9CA-22D4-4B6B-B1AF-7FC2F3CE5011}"/>
+                <a16:creationId xmlns:a16="http://schemas.microsoft.com/office/drawing/2014/main" id="{0D5E6C64-5B77-479E-93A9-BC935C0E00CE}"/>
               </a:ext>
             </a:extLst>
           </p:cNvPr>
@@ -8035,7 +8035,7 @@
                 <a:ea typeface="Arial"/>
                 <a:cs typeface="Arial"/>
               </a:rPr>
-              <a:t>The AI checks that it can read the file. It can also build a resume from your real experience.</a:t>
+              <a:t>Add your LinkedIn URL too. The AI can reconcile profile details with your records.</a:t>
             </a:r>
           </a:p>
         </p:txBody>
@@ -8043,7 +8043,7 @@
     </p:spTree>
     <p:extLst>
       <p:ext uri="{BB962C8B-B14F-4D97-AF65-F5344CB8AC3E}">
-        <p14:creationId xmlns:p14="http://schemas.microsoft.com/office/powerpoint/2010/main" val="1513431853"/>
+        <p14:creationId xmlns:p14="http://schemas.microsoft.com/office/powerpoint/2010/main" val="1092458265"/>
       </p:ext>
     </p:extLst>
   </p:cSld>
@@ -8074,7 +8074,7 @@
           <p:cNvPr id="7" name="">
             <a:extLst xmlns:a="http://schemas.openxmlformats.org/drawingml/2006/main">
               <a:ext uri="{FF2B5EF4-FFF2-40B4-BE49-F238E27FC236}">
-                <a16:creationId xmlns:a16="http://schemas.microsoft.com/office/drawing/2014/main" id="{CAC55B05-B236-427A-A2E8-DD837E9D436D}"/>
+                <a16:creationId xmlns:a16="http://schemas.microsoft.com/office/drawing/2014/main" id="{3C7191AB-EE0A-4D06-8E69-83C29F342388}"/>
               </a:ext>
             </a:extLst>
           </p:cNvPr>
@@ -8131,7 +8131,7 @@
           <p:cNvPr id="2" name="">
             <a:extLst xmlns:a="http://schemas.openxmlformats.org/drawingml/2006/main">
               <a:ext uri="{FF2B5EF4-FFF2-40B4-BE49-F238E27FC236}">
-                <a16:creationId xmlns:a16="http://schemas.microsoft.com/office/drawing/2014/main" id="{913B6C67-967F-4A0A-82D4-233D57FF22B9}"/>
+                <a16:creationId xmlns:a16="http://schemas.microsoft.com/office/drawing/2014/main" id="{55AEF1AA-FAC2-49F8-8E83-90F174788113}"/>
               </a:ext>
             </a:extLst>
           </p:cNvPr>
@@ -8188,7 +8188,7 @@
           <p:cNvPr id="3" name="">
             <a:extLst xmlns:a="http://schemas.openxmlformats.org/drawingml/2006/main">
               <a:ext uri="{FF2B5EF4-FFF2-40B4-BE49-F238E27FC236}">
-                <a16:creationId xmlns:a16="http://schemas.microsoft.com/office/drawing/2014/main" id="{7BDAEEE2-B4CD-419D-9C5E-21730E039950}"/>
+                <a16:creationId xmlns:a16="http://schemas.microsoft.com/office/drawing/2014/main" id="{6605A233-C7CC-4E3B-B13D-E8DC1B02226B}"/>
               </a:ext>
             </a:extLst>
           </p:cNvPr>
@@ -8245,7 +8245,7 @@
           <p:cNvPr id="4" name="">
             <a:extLst xmlns:a="http://schemas.openxmlformats.org/drawingml/2006/main">
               <a:ext uri="{FF2B5EF4-FFF2-40B4-BE49-F238E27FC236}">
-                <a16:creationId xmlns:a16="http://schemas.microsoft.com/office/drawing/2014/main" id="{9CBEE114-B592-40EB-92F4-55EFFC164A92}"/>
+                <a16:creationId xmlns:a16="http://schemas.microsoft.com/office/drawing/2014/main" id="{A83616AC-F1BB-4CD7-BA84-4EE26B811920}"/>
               </a:ext>
             </a:extLst>
           </p:cNvPr>
@@ -8325,7 +8325,7 @@
           <p:cNvPr id="5" name="">
             <a:extLst xmlns:a="http://schemas.openxmlformats.org/drawingml/2006/main">
               <a:ext uri="{FF2B5EF4-FFF2-40B4-BE49-F238E27FC236}">
-                <a16:creationId xmlns:a16="http://schemas.microsoft.com/office/drawing/2014/main" id="{43F150C7-7CB9-44D2-8254-AE6F3B0AC3F0}"/>
+                <a16:creationId xmlns:a16="http://schemas.microsoft.com/office/drawing/2014/main" id="{7B4A3C50-E8F9-4624-925E-4E928FA4FEC9}"/>
               </a:ext>
             </a:extLst>
           </p:cNvPr>
@@ -8405,7 +8405,7 @@
           <p:cNvPr id="6" name="">
             <a:extLst xmlns:a="http://schemas.openxmlformats.org/drawingml/2006/main">
               <a:ext uri="{FF2B5EF4-FFF2-40B4-BE49-F238E27FC236}">
-                <a16:creationId xmlns:a16="http://schemas.microsoft.com/office/drawing/2014/main" id="{92F326FF-E159-4355-B1AD-10309822C25F}"/>
+                <a16:creationId xmlns:a16="http://schemas.microsoft.com/office/drawing/2014/main" id="{85AFAACC-D536-4186-B98C-BC589C94E5EE}"/>
               </a:ext>
             </a:extLst>
           </p:cNvPr>
@@ -8451,7 +8451,7 @@
                 <a:latin typeface="Arial"/>
                 <a:ea typeface="Arial"/>
                 <a:cs typeface="Arial"/>
-                <a:hlinkClick xmlns:r="http://schemas.openxmlformats.org/officeDocument/2006/relationships" r:id="R2e9f20d3368b480c"/>
+                <a:hlinkClick xmlns:r="http://schemas.openxmlformats.org/officeDocument/2006/relationships" r:id="R37240b7581044d04"/>
               </a:rPr>
               <a:t>Copy from the README</a:t>
             </a:r>
@@ -8461,7 +8461,7 @@
     </p:spTree>
     <p:extLst>
       <p:ext uri="{BB962C8B-B14F-4D97-AF65-F5344CB8AC3E}">
-        <p14:creationId xmlns:p14="http://schemas.microsoft.com/office/powerpoint/2010/main" val="439925846"/>
+        <p14:creationId xmlns:p14="http://schemas.microsoft.com/office/powerpoint/2010/main" val="967384215"/>
       </p:ext>
     </p:extLst>
   </p:cSld>
@@ -8492,7 +8492,7 @@
           <p:cNvPr id="8" name="">
             <a:extLst xmlns:a="http://schemas.openxmlformats.org/drawingml/2006/main">
               <a:ext uri="{FF2B5EF4-FFF2-40B4-BE49-F238E27FC236}">
-                <a16:creationId xmlns:a16="http://schemas.microsoft.com/office/drawing/2014/main" id="{EFF18607-28B3-49DC-B69D-63EAD04A96BE}"/>
+                <a16:creationId xmlns:a16="http://schemas.microsoft.com/office/drawing/2014/main" id="{27C103AD-EB4D-434A-B73C-419B7563C70C}"/>
               </a:ext>
             </a:extLst>
           </p:cNvPr>
@@ -8549,7 +8549,7 @@
           <p:cNvPr id="2" name="">
             <a:extLst xmlns:a="http://schemas.openxmlformats.org/drawingml/2006/main">
               <a:ext uri="{FF2B5EF4-FFF2-40B4-BE49-F238E27FC236}">
-                <a16:creationId xmlns:a16="http://schemas.microsoft.com/office/drawing/2014/main" id="{C91FCB08-02C4-4187-9258-794C5C0C0CA0}"/>
+                <a16:creationId xmlns:a16="http://schemas.microsoft.com/office/drawing/2014/main" id="{232FA5F9-A6A3-477B-9EBA-BBF63463BB4A}"/>
               </a:ext>
             </a:extLst>
           </p:cNvPr>
@@ -8606,7 +8606,7 @@
           <p:cNvPr id="3" name="">
             <a:extLst xmlns:a="http://schemas.openxmlformats.org/drawingml/2006/main">
               <a:ext uri="{FF2B5EF4-FFF2-40B4-BE49-F238E27FC236}">
-                <a16:creationId xmlns:a16="http://schemas.microsoft.com/office/drawing/2014/main" id="{5EE30E11-69AF-4F65-9D35-FA9DCD1B9E89}"/>
+                <a16:creationId xmlns:a16="http://schemas.microsoft.com/office/drawing/2014/main" id="{BF0FE3D5-F5A3-4B6A-AB57-61921D531F29}"/>
               </a:ext>
             </a:extLst>
           </p:cNvPr>
@@ -8663,7 +8663,7 @@
           <p:cNvPr id="4" name="">
             <a:extLst xmlns:a="http://schemas.openxmlformats.org/drawingml/2006/main">
               <a:ext uri="{FF2B5EF4-FFF2-40B4-BE49-F238E27FC236}">
-                <a16:creationId xmlns:a16="http://schemas.microsoft.com/office/drawing/2014/main" id="{ECD94436-77F0-4D79-B2EA-3091770C4DB1}"/>
+                <a16:creationId xmlns:a16="http://schemas.microsoft.com/office/drawing/2014/main" id="{57106B18-7355-4368-A961-3F52136F9D3D}"/>
               </a:ext>
             </a:extLst>
           </p:cNvPr>
@@ -8720,7 +8720,7 @@
           <p:cNvPr id="5" name="">
             <a:extLst xmlns:a="http://schemas.openxmlformats.org/drawingml/2006/main">
               <a:ext uri="{FF2B5EF4-FFF2-40B4-BE49-F238E27FC236}">
-                <a16:creationId xmlns:a16="http://schemas.microsoft.com/office/drawing/2014/main" id="{305CD66B-EE68-4768-9751-DD84207AC5DB}"/>
+                <a16:creationId xmlns:a16="http://schemas.microsoft.com/office/drawing/2014/main" id="{8C3397D8-E2CE-4211-93DF-B7218A1DCBA6}"/>
               </a:ext>
             </a:extLst>
           </p:cNvPr>
@@ -8800,7 +8800,7 @@
           <p:cNvPr id="6" name="">
             <a:extLst xmlns:a="http://schemas.openxmlformats.org/drawingml/2006/main">
               <a:ext uri="{FF2B5EF4-FFF2-40B4-BE49-F238E27FC236}">
-                <a16:creationId xmlns:a16="http://schemas.microsoft.com/office/drawing/2014/main" id="{506133B0-1088-40D1-AA45-428EA61AAC16}"/>
+                <a16:creationId xmlns:a16="http://schemas.microsoft.com/office/drawing/2014/main" id="{EE024433-C6B9-4E56-BAE9-138F61C2F76E}"/>
               </a:ext>
             </a:extLst>
           </p:cNvPr>
@@ -8880,7 +8880,7 @@
           <p:cNvPr id="7" name="">
             <a:extLst xmlns:a="http://schemas.openxmlformats.org/drawingml/2006/main">
               <a:ext uri="{FF2B5EF4-FFF2-40B4-BE49-F238E27FC236}">
-                <a16:creationId xmlns:a16="http://schemas.microsoft.com/office/drawing/2014/main" id="{37EF14EC-F753-4717-88C7-B55565A43EC1}"/>
+                <a16:creationId xmlns:a16="http://schemas.microsoft.com/office/drawing/2014/main" id="{67D2DE36-1511-4D12-803A-8078E16A52DA}"/>
               </a:ext>
             </a:extLst>
           </p:cNvPr>
@@ -8927,7 +8927,7 @@
                 <a:ea typeface="Arial"/>
                 <a:cs typeface="Arial"/>
               </a:rPr>
-              <a:t>No resume? It builds your work history with you and checks for any other employers.</a:t>
+              <a:t>LinkedIn review follows the fuller interview. Public edits need your approval.</a:t>
             </a:r>
           </a:p>
         </p:txBody>
@@ -8935,7 +8935,7 @@
     </p:spTree>
     <p:extLst>
       <p:ext uri="{BB962C8B-B14F-4D97-AF65-F5344CB8AC3E}">
-        <p14:creationId xmlns:p14="http://schemas.microsoft.com/office/powerpoint/2010/main" val="1929094501"/>
+        <p14:creationId xmlns:p14="http://schemas.microsoft.com/office/powerpoint/2010/main" val="1304459114"/>
       </p:ext>
     </p:extLst>
   </p:cSld>

</xml_diff>

<commit_message>
Improve onboarding checks and require visual resume review before upload
</commit_message>
<xml_diff>
--- a/docs/job-search-guide.pptx
+++ b/docs/job-search-guide.pptx
@@ -2,29 +2,29 @@
 <file path=ppt/presentation.xml><?xml version="1.0" encoding="utf-8"?>
 <p:presentation xmlns:p="http://schemas.openxmlformats.org/presentationml/2006/main">
   <p:sldMasterIdLst>
-    <p:sldMasterId xmlns:r="http://schemas.openxmlformats.org/officeDocument/2006/relationships" id="2147483648" r:id="Rf77a045c1e1244e7"/>
+    <p:sldMasterId xmlns:r="http://schemas.openxmlformats.org/officeDocument/2006/relationships" id="2147483648" r:id="R385a01833c4e4933"/>
   </p:sldMasterIdLst>
   <p:notesMasterIdLst>
-    <p:notesMasterId xmlns:r="http://schemas.openxmlformats.org/officeDocument/2006/relationships" r:id="R932b7509f8ad4362"/>
+    <p:notesMasterId xmlns:r="http://schemas.openxmlformats.org/officeDocument/2006/relationships" r:id="R684c479afda44563"/>
   </p:notesMasterIdLst>
   <p:sldIdLst>
-    <p:sldId xmlns:r="http://schemas.openxmlformats.org/officeDocument/2006/relationships" id="256" r:id="Re85e361435eb436c"/>
-    <p:sldId xmlns:r="http://schemas.openxmlformats.org/officeDocument/2006/relationships" id="257" r:id="R7b026d05a24049a9"/>
-    <p:sldId xmlns:r="http://schemas.openxmlformats.org/officeDocument/2006/relationships" id="258" r:id="Rb1f3904bfff04042"/>
-    <p:sldId xmlns:r="http://schemas.openxmlformats.org/officeDocument/2006/relationships" id="259" r:id="R9c168ce838184863"/>
-    <p:sldId xmlns:r="http://schemas.openxmlformats.org/officeDocument/2006/relationships" id="260" r:id="R0e15b45aa48a4ce6"/>
-    <p:sldId xmlns:r="http://schemas.openxmlformats.org/officeDocument/2006/relationships" id="261" r:id="R40920dbd8df34899"/>
-    <p:sldId xmlns:r="http://schemas.openxmlformats.org/officeDocument/2006/relationships" id="262" r:id="R3521c4dc1c6d4c29"/>
-    <p:sldId xmlns:r="http://schemas.openxmlformats.org/officeDocument/2006/relationships" id="263" r:id="R1a08189e1e274fa7"/>
-    <p:sldId xmlns:r="http://schemas.openxmlformats.org/officeDocument/2006/relationships" id="264" r:id="R825f0d8c89bc4fc2"/>
-    <p:sldId xmlns:r="http://schemas.openxmlformats.org/officeDocument/2006/relationships" id="265" r:id="R60fd5947afc24611"/>
-    <p:sldId xmlns:r="http://schemas.openxmlformats.org/officeDocument/2006/relationships" id="266" r:id="R1b16acfed1d84413"/>
-    <p:sldId xmlns:r="http://schemas.openxmlformats.org/officeDocument/2006/relationships" id="267" r:id="Rc906ddea096c41ce"/>
-    <p:sldId xmlns:r="http://schemas.openxmlformats.org/officeDocument/2006/relationships" id="268" r:id="R33afe0c4a97c4743"/>
-    <p:sldId xmlns:r="http://schemas.openxmlformats.org/officeDocument/2006/relationships" id="269" r:id="Rf2d1a06cc6ac48f6"/>
-    <p:sldId xmlns:r="http://schemas.openxmlformats.org/officeDocument/2006/relationships" id="270" r:id="R66d6e2faa9ee4617"/>
-    <p:sldId xmlns:r="http://schemas.openxmlformats.org/officeDocument/2006/relationships" id="271" r:id="Rb647222be5194462"/>
-    <p:sldId xmlns:r="http://schemas.openxmlformats.org/officeDocument/2006/relationships" id="272" r:id="Rcc8a6327b8954014"/>
+    <p:sldId xmlns:r="http://schemas.openxmlformats.org/officeDocument/2006/relationships" id="256" r:id="R7b8685e7b72a4eff"/>
+    <p:sldId xmlns:r="http://schemas.openxmlformats.org/officeDocument/2006/relationships" id="257" r:id="R1c6c2473bcb24b0c"/>
+    <p:sldId xmlns:r="http://schemas.openxmlformats.org/officeDocument/2006/relationships" id="258" r:id="R2e075763d44244a0"/>
+    <p:sldId xmlns:r="http://schemas.openxmlformats.org/officeDocument/2006/relationships" id="259" r:id="R4b28aa6fa33846c8"/>
+    <p:sldId xmlns:r="http://schemas.openxmlformats.org/officeDocument/2006/relationships" id="260" r:id="R9febb4ea6d63474d"/>
+    <p:sldId xmlns:r="http://schemas.openxmlformats.org/officeDocument/2006/relationships" id="261" r:id="R8a0e62788b5b4a43"/>
+    <p:sldId xmlns:r="http://schemas.openxmlformats.org/officeDocument/2006/relationships" id="262" r:id="Re99f759ba4864aa7"/>
+    <p:sldId xmlns:r="http://schemas.openxmlformats.org/officeDocument/2006/relationships" id="263" r:id="R8668ada33e944956"/>
+    <p:sldId xmlns:r="http://schemas.openxmlformats.org/officeDocument/2006/relationships" id="264" r:id="Rafc0e36405b944c2"/>
+    <p:sldId xmlns:r="http://schemas.openxmlformats.org/officeDocument/2006/relationships" id="265" r:id="R1e2f2eecfe994445"/>
+    <p:sldId xmlns:r="http://schemas.openxmlformats.org/officeDocument/2006/relationships" id="266" r:id="R2762af4d6a8a4b20"/>
+    <p:sldId xmlns:r="http://schemas.openxmlformats.org/officeDocument/2006/relationships" id="267" r:id="R7b205f235ac848d6"/>
+    <p:sldId xmlns:r="http://schemas.openxmlformats.org/officeDocument/2006/relationships" id="268" r:id="Rd3ae3b3b435f4115"/>
+    <p:sldId xmlns:r="http://schemas.openxmlformats.org/officeDocument/2006/relationships" id="269" r:id="R08c01aafac3a4e38"/>
+    <p:sldId xmlns:r="http://schemas.openxmlformats.org/officeDocument/2006/relationships" id="270" r:id="R8d7c16006a3c43d1"/>
+    <p:sldId xmlns:r="http://schemas.openxmlformats.org/officeDocument/2006/relationships" id="271" r:id="Rd44e0e02449442f8"/>
+    <p:sldId xmlns:r="http://schemas.openxmlformats.org/officeDocument/2006/relationships" id="272" r:id="R399f08f4e18b427f"/>
   </p:sldIdLst>
   <p:sldSz cx="12192000" cy="6858000"/>
   <p:notesSz cx="6858000" cy="9144000"/>
@@ -858,17 +858,7 @@
           <a:lstStyle xmlns:a="http://schemas.openxmlformats.org/drawingml/2006/main"/>
           <a:p xmlns:a="http://schemas.openxmlformats.org/drawingml/2006/main">
             <a:r>
-              <a:t/>
-            </a:r>
-          </a:p>
-          <a:p xmlns:a="http://schemas.openxmlformats.org/drawingml/2006/main">
-            <a:r>
-              <a:t>Workflow source: https://github.com/toughdave/job-search</a:t>
-            </a:r>
-          </a:p>
-          <a:p xmlns:a="http://schemas.openxmlformats.org/drawingml/2006/main">
-            <a:r>
-              <a:t>Guide checked 12 September 2026.</a:t>
+              <a:t>Source: https://github.com/toughdave/job-search/blob/main/skills/job-search/references/documents.md#quality-gate. Review the exact upload format before upload, including every page, and save its hash. Corrected files need a new review. The separately generated PDF does not prove DOCX pagination.</a:t>
             </a:r>
           </a:p>
         </p:txBody>
@@ -1773,7 +1763,7 @@
           <a:lstStyle xmlns:a="http://schemas.openxmlformats.org/drawingml/2006/main"/>
           <a:p xmlns:a="http://schemas.openxmlformats.org/drawingml/2006/main">
             <a:r>
-              <a:t>Source: https://github.com/toughdave/job-search/blob/main/skills/job-search/references/runtime.md. Runtime setup is performed by the AI after the skill is copied; there is no universal automatic install hook.</a:t>
+              <a:t>Source: https://github.com/toughdave/job-search/blob/main/docs/setup.md#prerequisites-and-dependencies. The AI prefers a maintained Python 3.12+ for new setup. Packages: python-docx, ReportLab, pypdf, pypdfium2 and tzdata. Download-and-copy does not require Node or Git. Cleanup requires a preview and candidate approval.</a:t>
             </a:r>
           </a:p>
         </p:txBody>
@@ -1841,7 +1831,7 @@
   </p:cSld>
   <p:clrMap bg1="lt1" tx1="dk1" bg2="lt2" tx2="dk2" accent1="accent1" accent2="accent2" accent3="accent3" accent4="accent4" accent5="accent5" accent6="accent6" hlink="hlink" folHlink="folHlink"/>
   <p:sldLayoutIdLst>
-    <p:sldLayoutId xmlns:r="http://schemas.openxmlformats.org/officeDocument/2006/relationships" id="2147483649" r:id="Rdf32f820d2064a0a"/>
+    <p:sldLayoutId xmlns:r="http://schemas.openxmlformats.org/officeDocument/2006/relationships" id="2147483649" r:id="Ra8c566757f4744dd"/>
   </p:sldLayoutIdLst>
   <p:txStyles>
     <p:titleStyle>
@@ -2637,7 +2627,7 @@
                 <a:latin typeface="Arial"/>
                 <a:ea typeface="Arial"/>
                 <a:cs typeface="Arial"/>
-                <a:hlinkClick xmlns:r="http://schemas.openxmlformats.org/officeDocument/2006/relationships" r:id="R0b4d341b45bf49c8"/>
+                <a:hlinkClick xmlns:r="http://schemas.openxmlformats.org/officeDocument/2006/relationships" r:id="R9e2a4fe41fc14917"/>
               </a:rPr>
               <a:t>Open the GitHub guide</a:t>
             </a:r>
@@ -4029,7 +4019,7 @@
                 <a:latin typeface="Arial"/>
                 <a:ea typeface="Arial"/>
                 <a:cs typeface="Arial"/>
-                <a:hlinkClick xmlns:r="http://schemas.openxmlformats.org/officeDocument/2006/relationships" r:id="Rb242b2f94d5a4f5e"/>
+                <a:hlinkClick xmlns:r="http://schemas.openxmlformats.org/officeDocument/2006/relationships" r:id="Rb802430e98674ee2"/>
               </a:rPr>
               <a:t>Read the daily-search guide</a:t>
             </a:r>
@@ -4099,6 +4089,7 @@
           <a:lstStyle xmlns:a="http://schemas.openxmlformats.org/drawingml/2006/main"/>
           <a:p xmlns:a="http://schemas.openxmlformats.org/drawingml/2006/main">
             <a:pPr>
+              <a:buNone/>
               <a:defRPr sz="3450" b="1">
                 <a:solidFill>
                   <a:srgbClr val="183F3B"/>
@@ -4156,6 +4147,7 @@
           <a:lstStyle xmlns:a="http://schemas.openxmlformats.org/drawingml/2006/main"/>
           <a:p xmlns:a="http://schemas.openxmlformats.org/drawingml/2006/main">
             <a:pPr>
+              <a:buNone/>
               <a:defRPr sz="1350" b="0">
                 <a:solidFill>
                   <a:srgbClr val="607370"/>
@@ -4213,6 +4205,7 @@
           <a:lstStyle xmlns:a="http://schemas.openxmlformats.org/drawingml/2006/main"/>
           <a:p xmlns:a="http://schemas.openxmlformats.org/drawingml/2006/main">
             <a:pPr>
+              <a:buNone/>
               <a:defRPr sz="2250" b="0">
                 <a:solidFill>
                   <a:srgbClr val="283A39"/>
@@ -4236,6 +4229,7 @@
           </a:p>
           <a:p xmlns:a="http://schemas.openxmlformats.org/drawingml/2006/main">
             <a:pPr>
+              <a:buNone/>
               <a:defRPr sz="2250" b="0">
                 <a:solidFill>
                   <a:srgbClr val="283A39"/>
@@ -4293,6 +4287,7 @@
           <a:lstStyle xmlns:a="http://schemas.openxmlformats.org/drawingml/2006/main"/>
           <a:p xmlns:a="http://schemas.openxmlformats.org/drawingml/2006/main">
             <a:pPr>
+              <a:buNone/>
               <a:defRPr sz="2550" b="1">
                 <a:solidFill>
                   <a:srgbClr val="183F3B"/>
@@ -4350,6 +4345,7 @@
           <a:lstStyle xmlns:a="http://schemas.openxmlformats.org/drawingml/2006/main"/>
           <a:p xmlns:a="http://schemas.openxmlformats.org/drawingml/2006/main">
             <a:pPr>
+              <a:buNone/>
               <a:defRPr sz="2250" b="0">
                 <a:solidFill>
                   <a:srgbClr val="283A39"/>
@@ -4373,6 +4369,7 @@
           </a:p>
           <a:p xmlns:a="http://schemas.openxmlformats.org/drawingml/2006/main">
             <a:pPr>
+              <a:buNone/>
               <a:defRPr sz="2250" b="0">
                 <a:solidFill>
                   <a:srgbClr val="283A39"/>
@@ -4430,6 +4427,7 @@
           <a:lstStyle xmlns:a="http://schemas.openxmlformats.org/drawingml/2006/main"/>
           <a:p xmlns:a="http://schemas.openxmlformats.org/drawingml/2006/main">
             <a:pPr>
+              <a:buNone/>
               <a:defRPr sz="1800" b="0">
                 <a:solidFill>
                   <a:srgbClr val="607370"/>
@@ -4651,7 +4649,7 @@
                 <a:ea typeface="Arial"/>
                 <a:cs typeface="Arial"/>
               </a:rPr>
-              <a:t>The AI saves documents with your private search records, usually</a:t>
+              <a:t>Before any upload, the AI visually inspects every page of the actual file.</a:t>
             </a:r>
           </a:p>
           <a:p xmlns:a="http://schemas.openxmlformats.org/drawingml/2006/main">
@@ -4675,7 +4673,7 @@
                 <a:ea typeface="Arial"/>
                 <a:cs typeface="Arial"/>
               </a:rPr>
-              <a:t>in a records folder inside the local project you chose.</a:t>
+              <a:t>It checks spacing, alignment, clipping and page breaks.</a:t>
             </a:r>
           </a:p>
         </p:txBody>
@@ -4733,7 +4731,7 @@
                 <a:ea typeface="Arial"/>
                 <a:cs typeface="Arial"/>
               </a:rPr>
-              <a:t>Open the files and check your experience, dates and contact details.</a:t>
+              <a:t>A Word upload needs a preview rendered from that exact DOCX.</a:t>
             </a:r>
           </a:p>
           <a:p xmlns:a="http://schemas.openxmlformats.org/drawingml/2006/main">
@@ -4757,7 +4755,7 @@
                 <a:ea typeface="Arial"/>
                 <a:cs typeface="Arial"/>
               </a:rPr>
-              <a:t>Give corrections in the conversation.</a:t>
+              <a:t>If visual review is unavailable, the file stays a draft and upload waits.</a:t>
             </a:r>
           </a:p>
         </p:txBody>
@@ -4873,7 +4871,7 @@
                 <a:ea typeface="Arial"/>
                 <a:cs typeface="Arial"/>
               </a:rPr>
-              <a:t>Review the employer and final documents before authorizing a submission.</a:t>
+              <a:t>After corrections, the AI checks the new file again. You approve final submission.</a:t>
             </a:r>
           </a:p>
         </p:txBody>
@@ -6509,7 +6507,7 @@
                 <a:latin typeface="Arial"/>
                 <a:ea typeface="Arial"/>
                 <a:cs typeface="Arial"/>
-                <a:hlinkClick xmlns:r="http://schemas.openxmlformats.org/officeDocument/2006/relationships" r:id="R672781d9331d4439"/>
+                <a:hlinkClick xmlns:r="http://schemas.openxmlformats.org/officeDocument/2006/relationships" r:id="R76e37349315f492c"/>
               </a:rPr>
               <a:t>Full guide, downloads and troubleshooting</a:t>
             </a:r>
@@ -6911,7 +6909,7 @@
                 <a:latin typeface="Arial"/>
                 <a:ea typeface="Arial"/>
                 <a:cs typeface="Arial"/>
-                <a:hlinkClick xmlns:r="http://schemas.openxmlformats.org/officeDocument/2006/relationships" r:id="R054ed365b0b24f18"/>
+                <a:hlinkClick xmlns:r="http://schemas.openxmlformats.org/officeDocument/2006/relationships" r:id="Rd1f2fdde84ce41f4"/>
               </a:rPr>
               <a:t>Mac download page (Apple Silicon)</a:t>
             </a:r>
@@ -6970,7 +6968,7 @@
                 <a:latin typeface="Arial"/>
                 <a:ea typeface="Arial"/>
                 <a:cs typeface="Arial"/>
-                <a:hlinkClick xmlns:r="http://schemas.openxmlformats.org/officeDocument/2006/relationships" r:id="Rdb27ced90aa44bb1"/>
+                <a:hlinkClick xmlns:r="http://schemas.openxmlformats.org/officeDocument/2006/relationships" r:id="R5624178ab78f43b9"/>
               </a:rPr>
               <a:t>Windows download page</a:t>
             </a:r>
@@ -7169,7 +7167,7 @@
                 <a:latin typeface="Arial"/>
                 <a:ea typeface="Arial"/>
                 <a:cs typeface="Arial"/>
-                <a:hlinkClick xmlns:r="http://schemas.openxmlformats.org/officeDocument/2006/relationships" r:id="R15bea6f7c7794268"/>
+                <a:hlinkClick xmlns:r="http://schemas.openxmlformats.org/officeDocument/2006/relationships" r:id="R8b228d2de2a24033"/>
               </a:rPr>
               <a:t>Mac or Windows downloads</a:t>
             </a:r>
@@ -7228,7 +7226,7 @@
                 <a:latin typeface="Arial"/>
                 <a:ea typeface="Arial"/>
                 <a:cs typeface="Arial"/>
-                <a:hlinkClick xmlns:r="http://schemas.openxmlformats.org/officeDocument/2006/relationships" r:id="Rfb092fb4bd554f42"/>
+                <a:hlinkClick xmlns:r="http://schemas.openxmlformats.org/officeDocument/2006/relationships" r:id="R10ae087796db4560"/>
               </a:rPr>
               <a:t>Claude Code setup and account requirements</a:t>
             </a:r>
@@ -7505,7 +7503,7 @@
           <p:nvPr/>
         </p:nvPicPr>
         <p:blipFill>
-          <a:blip xmlns:r="http://schemas.openxmlformats.org/officeDocument/2006/relationships" xmlns:a="http://schemas.openxmlformats.org/drawingml/2006/main" r:embed="Ra73b02213ede4f14"/>
+          <a:blip xmlns:r="http://schemas.openxmlformats.org/officeDocument/2006/relationships" xmlns:a="http://schemas.openxmlformats.org/drawingml/2006/main" r:embed="R08355b9e8c104107"/>
           <a:stretch xmlns:a="http://schemas.openxmlformats.org/drawingml/2006/main"/>
         </p:blipFill>
         <p:spPr>
@@ -8048,7 +8046,7 @@
           <p:nvPr/>
         </p:nvPicPr>
         <p:blipFill>
-          <a:blip xmlns:r="http://schemas.openxmlformats.org/officeDocument/2006/relationships" xmlns:a="http://schemas.openxmlformats.org/drawingml/2006/main" r:embed="Rdea9a61792724698"/>
+          <a:blip xmlns:r="http://schemas.openxmlformats.org/officeDocument/2006/relationships" xmlns:a="http://schemas.openxmlformats.org/drawingml/2006/main" r:embed="R0d0dd6e0a14a4e84"/>
           <a:stretch xmlns:a="http://schemas.openxmlformats.org/drawingml/2006/main"/>
         </p:blipFill>
         <p:spPr>
@@ -8355,7 +8353,7 @@
           <p:nvPr/>
         </p:nvPicPr>
         <p:blipFill>
-          <a:blip xmlns:r="http://schemas.openxmlformats.org/officeDocument/2006/relationships" xmlns:a="http://schemas.openxmlformats.org/drawingml/2006/main" r:embed="Rc9991c827e974a6d"/>
+          <a:blip xmlns:r="http://schemas.openxmlformats.org/officeDocument/2006/relationships" xmlns:a="http://schemas.openxmlformats.org/drawingml/2006/main" r:embed="Re72c652631e9468f"/>
           <a:stretch xmlns:a="http://schemas.openxmlformats.org/drawingml/2006/main"/>
         </p:blipFill>
         <p:spPr>
@@ -8662,7 +8660,7 @@
           <p:nvPr/>
         </p:nvPicPr>
         <p:blipFill>
-          <a:blip xmlns:r="http://schemas.openxmlformats.org/officeDocument/2006/relationships" xmlns:a="http://schemas.openxmlformats.org/drawingml/2006/main" r:embed="Re82b20f5799a4f24"/>
+          <a:blip xmlns:r="http://schemas.openxmlformats.org/officeDocument/2006/relationships" xmlns:a="http://schemas.openxmlformats.org/drawingml/2006/main" r:embed="R46b5359a9bbd4fd3"/>
           <a:stretch xmlns:a="http://schemas.openxmlformats.org/drawingml/2006/main"/>
         </p:blipFill>
         <p:spPr>
@@ -9635,7 +9633,7 @@
                 <a:latin typeface="Arial"/>
                 <a:ea typeface="Arial"/>
                 <a:cs typeface="Arial"/>
-                <a:hlinkClick xmlns:r="http://schemas.openxmlformats.org/officeDocument/2006/relationships" r:id="R94ba08387f4d4337"/>
+                <a:hlinkClick xmlns:r="http://schemas.openxmlformats.org/officeDocument/2006/relationships" r:id="Rb873a99858bf4cc8"/>
               </a:rPr>
               <a:t>Copy from the README</a:t>
             </a:r>
@@ -9705,6 +9703,7 @@
           <a:lstStyle xmlns:a="http://schemas.openxmlformats.org/drawingml/2006/main"/>
           <a:p xmlns:a="http://schemas.openxmlformats.org/drawingml/2006/main">
             <a:pPr>
+              <a:buNone/>
               <a:defRPr sz="3450" b="1">
                 <a:solidFill>
                   <a:srgbClr val="183F3B"/>
@@ -9723,7 +9722,7 @@
                 <a:ea typeface="Arial"/>
                 <a:cs typeface="Arial"/>
               </a:rPr>
-              <a:t>Software setup and your records</a:t>
+              <a:t>Software prerequisites</a:t>
             </a:r>
           </a:p>
         </p:txBody>
@@ -9762,6 +9761,7 @@
           <a:lstStyle xmlns:a="http://schemas.openxmlformats.org/drawingml/2006/main"/>
           <a:p xmlns:a="http://schemas.openxmlformats.org/drawingml/2006/main">
             <a:pPr>
+              <a:buNone/>
               <a:defRPr sz="1350" b="0">
                 <a:solidFill>
                   <a:srgbClr val="607370"/>
@@ -9819,6 +9819,7 @@
           <a:lstStyle xmlns:a="http://schemas.openxmlformats.org/drawingml/2006/main"/>
           <a:p xmlns:a="http://schemas.openxmlformats.org/drawingml/2006/main">
             <a:pPr>
+              <a:buNone/>
               <a:defRPr sz="2250" b="0">
                 <a:solidFill>
                   <a:srgbClr val="283A39"/>
@@ -9837,11 +9838,12 @@
                 <a:ea typeface="Arial"/>
                 <a:cs typeface="Arial"/>
               </a:rPr>
-              <a:t>The AI checks Python and installs the document tools it needs.</a:t>
-            </a:r>
-          </a:p>
-          <a:p xmlns:a="http://schemas.openxmlformats.org/drawingml/2006/main">
-            <a:pPr>
+              <a:t>Use a local project with file access and an internet connection.</a:t>
+            </a:r>
+          </a:p>
+          <a:p xmlns:a="http://schemas.openxmlformats.org/drawingml/2006/main">
+            <a:pPr>
+              <a:buNone/>
               <a:defRPr sz="2250" b="0">
                 <a:solidFill>
                   <a:srgbClr val="283A39"/>
@@ -9860,7 +9862,7 @@
                 <a:ea typeface="Arial"/>
                 <a:cs typeface="Arial"/>
               </a:rPr>
-              <a:t>You may see a download or a specific approval request.</a:t>
+              <a:t>Your AI app needs an account that can use local projects.</a:t>
             </a:r>
           </a:p>
         </p:txBody>
@@ -9899,6 +9901,7 @@
           <a:lstStyle xmlns:a="http://schemas.openxmlformats.org/drawingml/2006/main"/>
           <a:p xmlns:a="http://schemas.openxmlformats.org/drawingml/2006/main">
             <a:pPr>
+              <a:buNone/>
               <a:defRPr sz="2250" b="0">
                 <a:solidFill>
                   <a:srgbClr val="283A39"/>
@@ -9917,11 +9920,12 @@
                 <a:ea typeface="Arial"/>
                 <a:cs typeface="Arial"/>
               </a:rPr>
-              <a:t>Your answers and documents stay in your private records folder.</a:t>
-            </a:r>
-          </a:p>
-          <a:p xmlns:a="http://schemas.openxmlformats.org/drawingml/2006/main">
-            <a:pPr>
+              <a:t>The AI checks Python 3.9+ and installs the document packages.</a:t>
+            </a:r>
+          </a:p>
+          <a:p xmlns:a="http://schemas.openxmlformats.org/drawingml/2006/main">
+            <a:pPr>
+              <a:buNone/>
               <a:defRPr sz="2250" b="0">
                 <a:solidFill>
                   <a:srgbClr val="283A39"/>
@@ -9940,7 +9944,7 @@
                 <a:ea typeface="Arial"/>
                 <a:cs typeface="Arial"/>
               </a:rPr>
-              <a:t>The AI tells you where it saved them.</a:t>
+              <a:t>Node.js 22.20+ is only needed for the optional terminal installer.</a:t>
             </a:r>
           </a:p>
         </p:txBody>
@@ -9979,6 +9983,7 @@
           <a:lstStyle xmlns:a="http://schemas.openxmlformats.org/drawingml/2006/main"/>
           <a:p xmlns:a="http://schemas.openxmlformats.org/drawingml/2006/main">
             <a:pPr>
+              <a:buNone/>
               <a:defRPr sz="2250" b="0">
                 <a:solidFill>
                   <a:srgbClr val="283A39"/>
@@ -9997,11 +10002,12 @@
                 <a:ea typeface="Arial"/>
                 <a:cs typeface="Arial"/>
               </a:rPr>
-              <a:t>Large software packages stay in a local cache on your computer.</a:t>
-            </a:r>
-          </a:p>
-          <a:p xmlns:a="http://schemas.openxmlformats.org/drawingml/2006/main">
-            <a:pPr>
+              <a:t>Your records stay in the project. Software stays in a local cache.</a:t>
+            </a:r>
+          </a:p>
+          <a:p xmlns:a="http://schemas.openxmlformats.org/drawingml/2006/main">
+            <a:pPr>
+              <a:buNone/>
               <a:defRPr sz="2250" b="0">
                 <a:solidFill>
                   <a:srgbClr val="283A39"/>
@@ -10020,7 +10026,7 @@
                 <a:ea typeface="Arial"/>
                 <a:cs typeface="Arial"/>
               </a:rPr>
-              <a:t>The AI checks these tools again when a new session resumes.</a:t>
+              <a:t>Ask the AI to preview that cache if you want to remove it.</a:t>
             </a:r>
           </a:p>
         </p:txBody>
@@ -10059,6 +10065,7 @@
           <a:lstStyle xmlns:a="http://schemas.openxmlformats.org/drawingml/2006/main"/>
           <a:p xmlns:a="http://schemas.openxmlformats.org/drawingml/2006/main">
             <a:pPr>
+              <a:buNone/>
               <a:defRPr sz="1800" b="0">
                 <a:solidFill>
                   <a:srgbClr val="607370"/>
@@ -10077,7 +10084,7 @@
                 <a:ea typeface="Arial"/>
                 <a:cs typeface="Arial"/>
               </a:rPr>
-              <a:t>You can begin the interview while a missing export capability is being resolved.</a:t>
+              <a:t>Word uploads also need a DOCX renderer, such as Word or LibreOffice.</a:t>
             </a:r>
           </a:p>
         </p:txBody>

</xml_diff>

<commit_message>
Verify optional inbox accounts and preserve complete reply turns
</commit_message>
<xml_diff>
--- a/docs/job-search-guide.pptx
+++ b/docs/job-search-guide.pptx
@@ -2,29 +2,30 @@
 <file path=ppt/presentation.xml><?xml version="1.0" encoding="utf-8"?>
 <p:presentation xmlns:p="http://schemas.openxmlformats.org/presentationml/2006/main">
   <p:sldMasterIdLst>
-    <p:sldMasterId xmlns:r="http://schemas.openxmlformats.org/officeDocument/2006/relationships" id="2147483648" r:id="R385a01833c4e4933"/>
+    <p:sldMasterId xmlns:r="http://schemas.openxmlformats.org/officeDocument/2006/relationships" id="2147483648" r:id="R1bb659f9b30d4f08"/>
   </p:sldMasterIdLst>
   <p:notesMasterIdLst>
-    <p:notesMasterId xmlns:r="http://schemas.openxmlformats.org/officeDocument/2006/relationships" r:id="R684c479afda44563"/>
+    <p:notesMasterId xmlns:r="http://schemas.openxmlformats.org/officeDocument/2006/relationships" r:id="Ra9b9f0e904cd4d7b"/>
   </p:notesMasterIdLst>
   <p:sldIdLst>
-    <p:sldId xmlns:r="http://schemas.openxmlformats.org/officeDocument/2006/relationships" id="256" r:id="R7b8685e7b72a4eff"/>
-    <p:sldId xmlns:r="http://schemas.openxmlformats.org/officeDocument/2006/relationships" id="257" r:id="R1c6c2473bcb24b0c"/>
-    <p:sldId xmlns:r="http://schemas.openxmlformats.org/officeDocument/2006/relationships" id="258" r:id="R2e075763d44244a0"/>
-    <p:sldId xmlns:r="http://schemas.openxmlformats.org/officeDocument/2006/relationships" id="259" r:id="R4b28aa6fa33846c8"/>
-    <p:sldId xmlns:r="http://schemas.openxmlformats.org/officeDocument/2006/relationships" id="260" r:id="R9febb4ea6d63474d"/>
-    <p:sldId xmlns:r="http://schemas.openxmlformats.org/officeDocument/2006/relationships" id="261" r:id="R8a0e62788b5b4a43"/>
-    <p:sldId xmlns:r="http://schemas.openxmlformats.org/officeDocument/2006/relationships" id="262" r:id="Re99f759ba4864aa7"/>
-    <p:sldId xmlns:r="http://schemas.openxmlformats.org/officeDocument/2006/relationships" id="263" r:id="R8668ada33e944956"/>
-    <p:sldId xmlns:r="http://schemas.openxmlformats.org/officeDocument/2006/relationships" id="264" r:id="Rafc0e36405b944c2"/>
-    <p:sldId xmlns:r="http://schemas.openxmlformats.org/officeDocument/2006/relationships" id="265" r:id="R1e2f2eecfe994445"/>
-    <p:sldId xmlns:r="http://schemas.openxmlformats.org/officeDocument/2006/relationships" id="266" r:id="R2762af4d6a8a4b20"/>
-    <p:sldId xmlns:r="http://schemas.openxmlformats.org/officeDocument/2006/relationships" id="267" r:id="R7b205f235ac848d6"/>
-    <p:sldId xmlns:r="http://schemas.openxmlformats.org/officeDocument/2006/relationships" id="268" r:id="Rd3ae3b3b435f4115"/>
-    <p:sldId xmlns:r="http://schemas.openxmlformats.org/officeDocument/2006/relationships" id="269" r:id="R08c01aafac3a4e38"/>
-    <p:sldId xmlns:r="http://schemas.openxmlformats.org/officeDocument/2006/relationships" id="270" r:id="R8d7c16006a3c43d1"/>
-    <p:sldId xmlns:r="http://schemas.openxmlformats.org/officeDocument/2006/relationships" id="271" r:id="Rd44e0e02449442f8"/>
-    <p:sldId xmlns:r="http://schemas.openxmlformats.org/officeDocument/2006/relationships" id="272" r:id="R399f08f4e18b427f"/>
+    <p:sldId xmlns:r="http://schemas.openxmlformats.org/officeDocument/2006/relationships" id="256" r:id="R7e701d9a1cac4a88"/>
+    <p:sldId xmlns:r="http://schemas.openxmlformats.org/officeDocument/2006/relationships" id="257" r:id="R24e0e1d9b14e48a1"/>
+    <p:sldId xmlns:r="http://schemas.openxmlformats.org/officeDocument/2006/relationships" id="258" r:id="R044b24acd7804129"/>
+    <p:sldId xmlns:r="http://schemas.openxmlformats.org/officeDocument/2006/relationships" id="259" r:id="Rd8fa7c8e54a44193"/>
+    <p:sldId xmlns:r="http://schemas.openxmlformats.org/officeDocument/2006/relationships" id="260" r:id="R377fb9f920c44e03"/>
+    <p:sldId xmlns:r="http://schemas.openxmlformats.org/officeDocument/2006/relationships" id="261" r:id="R37c147de3c334027"/>
+    <p:sldId xmlns:r="http://schemas.openxmlformats.org/officeDocument/2006/relationships" id="262" r:id="R30d6b4f98a5c4382"/>
+    <p:sldId xmlns:r="http://schemas.openxmlformats.org/officeDocument/2006/relationships" id="263" r:id="R077a186a74a4409e"/>
+    <p:sldId xmlns:r="http://schemas.openxmlformats.org/officeDocument/2006/relationships" id="264" r:id="Rbbd9ccf3ba664c88"/>
+    <p:sldId xmlns:r="http://schemas.openxmlformats.org/officeDocument/2006/relationships" id="265" r:id="R6e5bca785d794bee"/>
+    <p:sldId xmlns:r="http://schemas.openxmlformats.org/officeDocument/2006/relationships" id="266" r:id="R6e7dc035f66a485d"/>
+    <p:sldId xmlns:r="http://schemas.openxmlformats.org/officeDocument/2006/relationships" id="267" r:id="Rdde67953d3b24914"/>
+    <p:sldId xmlns:r="http://schemas.openxmlformats.org/officeDocument/2006/relationships" id="268" r:id="R702b8d1e8cb94ddb"/>
+    <p:sldId xmlns:r="http://schemas.openxmlformats.org/officeDocument/2006/relationships" id="269" r:id="R579dabd68f2a460f"/>
+    <p:sldId xmlns:r="http://schemas.openxmlformats.org/officeDocument/2006/relationships" id="270" r:id="R2639f3497d9c41bf"/>
+    <p:sldId xmlns:r="http://schemas.openxmlformats.org/officeDocument/2006/relationships" id="271" r:id="R39189add30e7491c"/>
+    <p:sldId xmlns:r="http://schemas.openxmlformats.org/officeDocument/2006/relationships" id="272" r:id="Rde2047f4ef9c498a"/>
+    <p:sldId xmlns:r="http://schemas.openxmlformats.org/officeDocument/2006/relationships" id="273" r:id="Rf373847a3a484dcf"/>
   </p:sldIdLst>
   <p:sldSz cx="12192000" cy="6858000"/>
   <p:notesSz cx="6858000" cy="9144000"/>
@@ -1133,6 +1134,76 @@
 </p:notes>
 </file>
 
+<file path=ppt/notesSlides/notesSlide18.xml><?xml version="1.0" encoding="utf-8"?>
+<p:notes xmlns:p="http://schemas.openxmlformats.org/presentationml/2006/main">
+  <p:cSld>
+    <p:spTree>
+      <p:nvGrpSpPr>
+        <p:cNvPr id="1" name=""/>
+        <p:cNvGrpSpPr/>
+        <p:nvPr/>
+      </p:nvGrpSpPr>
+      <p:grpSpPr>
+        <a:xfrm xmlns:a="http://schemas.openxmlformats.org/drawingml/2006/main"/>
+      </p:grpSpPr>
+      <p:sp>
+        <p:nvSpPr>
+          <p:cNvPr id="2" name="Slide Image Placeholder 1"/>
+          <p:cNvSpPr>
+            <a:spLocks xmlns:a="http://schemas.openxmlformats.org/drawingml/2006/main" noGrp="1"/>
+          </p:cNvSpPr>
+          <p:nvPr>
+            <p:ph type="sldImg" idx="0"/>
+          </p:nvPr>
+        </p:nvSpPr>
+        <p:spPr/>
+      </p:sp>
+      <p:sp>
+        <p:nvSpPr>
+          <p:cNvPr id="3" name="Notes Placeholder 2"/>
+          <p:cNvSpPr>
+            <a:spLocks xmlns:a="http://schemas.openxmlformats.org/drawingml/2006/main" noGrp="1"/>
+          </p:cNvSpPr>
+          <p:nvPr>
+            <p:ph type="body" idx="1"/>
+          </p:nvPr>
+        </p:nvSpPr>
+        <p:spPr/>
+        <p:txBody>
+          <a:bodyPr xmlns:a="http://schemas.openxmlformats.org/drawingml/2006/main"/>
+          <a:lstStyle xmlns:a="http://schemas.openxmlformats.org/drawingml/2006/main"/>
+          <a:p xmlns:a="http://schemas.openxmlformats.org/drawingml/2006/main">
+            <a:r>
+              <a:t>Sources: https://github.com/toughdave/job-search/blob/main/skills/job-search/references/mail.md ; https://code.claude.com/docs/en/desktop ; https://support.claude.com/en/articles/10166901-use-google-workspace-connectors ; https://learn.chatgpt.com/docs/plugins . Setup saves the chosen application mailbox and read scope. The candidate completes sign-in. The AI checks the actual authenticated identity and performs a bounded read before claiming readiness. Codex and Claude connections are verified independently.</a:t>
+            </a:r>
+          </a:p>
+        </p:txBody>
+      </p:sp>
+      <p:sp>
+        <p:nvSpPr>
+          <p:cNvPr id="4" name="Slide Number Placeholder 3"/>
+          <p:cNvSpPr>
+            <a:spLocks xmlns:a="http://schemas.openxmlformats.org/drawingml/2006/main" noGrp="1"/>
+          </p:cNvSpPr>
+          <p:nvPr>
+            <p:ph type="sldNum" idx="5"/>
+          </p:nvPr>
+        </p:nvSpPr>
+        <p:spPr/>
+        <p:txBody>
+          <a:bodyPr xmlns:a="http://schemas.openxmlformats.org/drawingml/2006/main"/>
+          <a:lstStyle xmlns:a="http://schemas.openxmlformats.org/drawingml/2006/main"/>
+          <a:p xmlns:a="http://schemas.openxmlformats.org/drawingml/2006/main"/>
+        </p:txBody>
+      </p:sp>
+    </p:spTree>
+  </p:cSld>
+  <p:clrMapOvr>
+    <a:masterClrMapping xmlns:a="http://schemas.openxmlformats.org/drawingml/2006/main"/>
+  </p:clrMapOvr>
+</p:notes>
+</file>
+
 <file path=ppt/notesSlides/notesSlide2.xml><?xml version="1.0" encoding="utf-8"?>
 <p:notes xmlns:p="http://schemas.openxmlformats.org/presentationml/2006/main">
   <p:cSld>
@@ -1831,7 +1902,7 @@
   </p:cSld>
   <p:clrMap bg1="lt1" tx1="dk1" bg2="lt2" tx2="dk2" accent1="accent1" accent2="accent2" accent3="accent3" accent4="accent4" accent5="accent5" accent6="accent6" hlink="hlink" folHlink="folHlink"/>
   <p:sldLayoutIdLst>
-    <p:sldLayoutId xmlns:r="http://schemas.openxmlformats.org/officeDocument/2006/relationships" id="2147483649" r:id="Ra8c566757f4744dd"/>
+    <p:sldLayoutId xmlns:r="http://schemas.openxmlformats.org/officeDocument/2006/relationships" id="2147483649" r:id="R3fa602ef77bf446f"/>
   </p:sldLayoutIdLst>
   <p:txStyles>
     <p:titleStyle>
@@ -2627,7 +2698,7 @@
                 <a:latin typeface="Arial"/>
                 <a:ea typeface="Arial"/>
                 <a:cs typeface="Arial"/>
-                <a:hlinkClick xmlns:r="http://schemas.openxmlformats.org/officeDocument/2006/relationships" r:id="R9e2a4fe41fc14917"/>
+                <a:hlinkClick xmlns:r="http://schemas.openxmlformats.org/officeDocument/2006/relationships" r:id="Rbdf47d184a7842f8"/>
               </a:rPr>
               <a:t>Open the GitHub guide</a:t>
             </a:r>
@@ -4019,7 +4090,7 @@
                 <a:latin typeface="Arial"/>
                 <a:ea typeface="Arial"/>
                 <a:cs typeface="Arial"/>
-                <a:hlinkClick xmlns:r="http://schemas.openxmlformats.org/officeDocument/2006/relationships" r:id="Rb802430e98674ee2"/>
+                <a:hlinkClick xmlns:r="http://schemas.openxmlformats.org/officeDocument/2006/relationships" r:id="Re1e0d3fe41a9444d"/>
               </a:rPr>
               <a:t>Read the daily-search guide</a:t>
             </a:r>
@@ -6507,7 +6578,7 @@
                 <a:latin typeface="Arial"/>
                 <a:ea typeface="Arial"/>
                 <a:cs typeface="Arial"/>
-                <a:hlinkClick xmlns:r="http://schemas.openxmlformats.org/officeDocument/2006/relationships" r:id="R76e37349315f492c"/>
+                <a:hlinkClick xmlns:r="http://schemas.openxmlformats.org/officeDocument/2006/relationships" r:id="R4cd4d2efe0214bc8"/>
               </a:rPr>
               <a:t>Full guide, downloads and troubleshooting</a:t>
             </a:r>
@@ -6518,6 +6589,527 @@
     <p:extLst>
       <p:ext uri="{BB962C8B-B14F-4D97-AF65-F5344CB8AC3E}">
         <p14:creationId xmlns:p14="http://schemas.microsoft.com/office/powerpoint/2010/main" val="1353861993"/>
+      </p:ext>
+    </p:extLst>
+  </p:cSld>
+</p:sld>
+</file>
+
+<file path=ppt/slides/slide18.xml><?xml version="1.0" encoding="utf-8"?>
+<p:sld xmlns:p="http://schemas.openxmlformats.org/presentationml/2006/main">
+  <p:cSld>
+    <p:bg>
+      <p:bgPr>
+        <a:solidFill xmlns:a="http://schemas.openxmlformats.org/drawingml/2006/main">
+          <a:srgbClr val="FAFCFA"/>
+        </a:solidFill>
+      </p:bgPr>
+    </p:bg>
+    <p:spTree>
+      <p:nvGrpSpPr>
+        <p:cNvPr id="1" name=""/>
+        <p:cNvGrpSpPr/>
+        <p:nvPr/>
+      </p:nvGrpSpPr>
+      <p:grpSpPr>
+        <a:xfrm xmlns:a="http://schemas.openxmlformats.org/drawingml/2006/main"/>
+      </p:grpSpPr>
+      <p:sp>
+        <p:nvSpPr>
+          <p:cNvPr id="8" name="">
+            <a:extLst xmlns:a="http://schemas.openxmlformats.org/drawingml/2006/main">
+              <a:ext uri="{FF2B5EF4-FFF2-40B4-BE49-F238E27FC236}">
+                <a16:creationId xmlns:a16="http://schemas.microsoft.com/office/drawing/2014/main" id="{D1632CCC-FD71-4504-853A-C9EB9DAE7B5F}"/>
+              </a:ext>
+            </a:extLst>
+          </p:cNvPr>
+          <p:cNvSpPr>
+            <a:spLocks xmlns:a="http://schemas.openxmlformats.org/drawingml/2006/main" noGrp="1"/>
+          </p:cNvSpPr>
+          <p:nvPr/>
+        </p:nvSpPr>
+        <p:spPr>
+          <a:xfrm xmlns:a="http://schemas.openxmlformats.org/drawingml/2006/main">
+            <a:off x="609600" y="457200"/>
+            <a:ext cx="10972800" cy="742950"/>
+          </a:xfrm>
+          <a:prstGeom xmlns:a="http://schemas.openxmlformats.org/drawingml/2006/main" prst="rect">
+            <a:avLst/>
+          </a:prstGeom>
+          <a:noFill xmlns:a="http://schemas.openxmlformats.org/drawingml/2006/main"/>
+          <a:ln xmlns:a="http://schemas.openxmlformats.org/drawingml/2006/main" w="0">
+            <a:noFill/>
+          </a:ln>
+        </p:spPr>
+        <p:txBody>
+          <a:bodyPr xmlns:a="http://schemas.openxmlformats.org/drawingml/2006/main">
+            <a:noAutofit/>
+          </a:bodyPr>
+          <a:lstStyle xmlns:a="http://schemas.openxmlformats.org/drawingml/2006/main"/>
+          <a:p xmlns:a="http://schemas.openxmlformats.org/drawingml/2006/main">
+            <a:pPr>
+              <a:defRPr sz="3450" b="1">
+                <a:solidFill>
+                  <a:srgbClr val="183F3B"/>
+                </a:solidFill>
+                <a:latin typeface="Arial"/>
+                <a:ea typeface="Arial"/>
+                <a:cs typeface="Arial"/>
+              </a:defRPr>
+            </a:pPr>
+            <a:r>
+              <a:rPr sz="3450" b="1">
+                <a:solidFill>
+                  <a:srgbClr val="183F3B"/>
+                </a:solidFill>
+                <a:latin typeface="Arial"/>
+                <a:ea typeface="Arial"/>
+                <a:cs typeface="Arial"/>
+              </a:rPr>
+              <a:t>Optional inbox connection</a:t>
+            </a:r>
+          </a:p>
+        </p:txBody>
+      </p:sp>
+      <p:sp>
+        <p:nvSpPr>
+          <p:cNvPr id="2" name="">
+            <a:extLst xmlns:a="http://schemas.openxmlformats.org/drawingml/2006/main">
+              <a:ext uri="{FF2B5EF4-FFF2-40B4-BE49-F238E27FC236}">
+                <a16:creationId xmlns:a16="http://schemas.microsoft.com/office/drawing/2014/main" id="{29EFFDE2-4509-4A3D-A72F-FA6BA1B867D1}"/>
+              </a:ext>
+            </a:extLst>
+          </p:cNvPr>
+          <p:cNvSpPr>
+            <a:spLocks xmlns:a="http://schemas.openxmlformats.org/drawingml/2006/main" noGrp="1"/>
+          </p:cNvSpPr>
+          <p:nvPr/>
+        </p:nvSpPr>
+        <p:spPr>
+          <a:xfrm xmlns:a="http://schemas.openxmlformats.org/drawingml/2006/main">
+            <a:off x="11049000" y="6334125"/>
+            <a:ext cx="533400" cy="266700"/>
+          </a:xfrm>
+          <a:prstGeom xmlns:a="http://schemas.openxmlformats.org/drawingml/2006/main" prst="rect">
+            <a:avLst/>
+          </a:prstGeom>
+          <a:noFill xmlns:a="http://schemas.openxmlformats.org/drawingml/2006/main"/>
+          <a:ln xmlns:a="http://schemas.openxmlformats.org/drawingml/2006/main" w="0">
+            <a:noFill/>
+          </a:ln>
+        </p:spPr>
+        <p:txBody>
+          <a:bodyPr xmlns:a="http://schemas.openxmlformats.org/drawingml/2006/main">
+            <a:noAutofit/>
+          </a:bodyPr>
+          <a:lstStyle xmlns:a="http://schemas.openxmlformats.org/drawingml/2006/main"/>
+          <a:p xmlns:a="http://schemas.openxmlformats.org/drawingml/2006/main">
+            <a:pPr>
+              <a:defRPr sz="1350" b="0">
+                <a:solidFill>
+                  <a:srgbClr val="607370"/>
+                </a:solidFill>
+                <a:latin typeface="Arial"/>
+                <a:ea typeface="Arial"/>
+                <a:cs typeface="Arial"/>
+              </a:defRPr>
+            </a:pPr>
+            <a:r>
+              <a:rPr sz="1350" b="0">
+                <a:solidFill>
+                  <a:srgbClr val="607370"/>
+                </a:solidFill>
+                <a:latin typeface="Arial"/>
+                <a:ea typeface="Arial"/>
+                <a:cs typeface="Arial"/>
+              </a:rPr>
+              <a:t>18</a:t>
+            </a:r>
+          </a:p>
+        </p:txBody>
+      </p:sp>
+      <p:sp>
+        <p:nvSpPr>
+          <p:cNvPr id="3" name="">
+            <a:extLst xmlns:a="http://schemas.openxmlformats.org/drawingml/2006/main">
+              <a:ext uri="{FF2B5EF4-FFF2-40B4-BE49-F238E27FC236}">
+                <a16:creationId xmlns:a16="http://schemas.microsoft.com/office/drawing/2014/main" id="{1612BF25-0EE9-4613-BBAC-00A0BC3C8C6B}"/>
+              </a:ext>
+            </a:extLst>
+          </p:cNvPr>
+          <p:cNvSpPr>
+            <a:spLocks xmlns:a="http://schemas.openxmlformats.org/drawingml/2006/main" noGrp="1"/>
+          </p:cNvSpPr>
+          <p:nvPr/>
+        </p:nvSpPr>
+        <p:spPr>
+          <a:xfrm xmlns:a="http://schemas.openxmlformats.org/drawingml/2006/main">
+            <a:off x="609600" y="1447800"/>
+            <a:ext cx="10820400" cy="857250"/>
+          </a:xfrm>
+          <a:prstGeom xmlns:a="http://schemas.openxmlformats.org/drawingml/2006/main" prst="rect">
+            <a:avLst/>
+          </a:prstGeom>
+          <a:noFill xmlns:a="http://schemas.openxmlformats.org/drawingml/2006/main"/>
+          <a:ln xmlns:a="http://schemas.openxmlformats.org/drawingml/2006/main" w="0">
+            <a:noFill/>
+          </a:ln>
+        </p:spPr>
+        <p:txBody>
+          <a:bodyPr xmlns:a="http://schemas.openxmlformats.org/drawingml/2006/main">
+            <a:noAutofit/>
+          </a:bodyPr>
+          <a:lstStyle xmlns:a="http://schemas.openxmlformats.org/drawingml/2006/main"/>
+          <a:p xmlns:a="http://schemas.openxmlformats.org/drawingml/2006/main">
+            <a:pPr>
+              <a:defRPr sz="2250" b="0">
+                <a:solidFill>
+                  <a:srgbClr val="283A39"/>
+                </a:solidFill>
+                <a:latin typeface="Arial"/>
+                <a:ea typeface="Arial"/>
+                <a:cs typeface="Arial"/>
+              </a:defRPr>
+            </a:pPr>
+            <a:r>
+              <a:rPr sz="2250" b="0">
+                <a:solidFill>
+                  <a:srgbClr val="283A39"/>
+                </a:solidFill>
+                <a:latin typeface="Arial"/>
+                <a:ea typeface="Arial"/>
+                <a:cs typeface="Arial"/>
+              </a:rPr>
+              <a:t>a. Confirm the email you use for applications.</a:t>
+            </a:r>
+          </a:p>
+          <a:p xmlns:a="http://schemas.openxmlformats.org/drawingml/2006/main">
+            <a:pPr>
+              <a:defRPr sz="2250" b="0">
+                <a:solidFill>
+                  <a:srgbClr val="283A39"/>
+                </a:solidFill>
+                <a:latin typeface="Arial"/>
+                <a:ea typeface="Arial"/>
+                <a:cs typeface="Arial"/>
+              </a:defRPr>
+            </a:pPr>
+            <a:r>
+              <a:rPr sz="2250" b="0">
+                <a:solidFill>
+                  <a:srgbClr val="283A39"/>
+                </a:solidFill>
+                <a:latin typeface="Arial"/>
+                <a:ea typeface="Arial"/>
+                <a:cs typeface="Arial"/>
+              </a:rPr>
+              <a:t>    Choose whether the AI may check job-related replies.</a:t>
+            </a:r>
+          </a:p>
+        </p:txBody>
+      </p:sp>
+      <p:sp>
+        <p:nvSpPr>
+          <p:cNvPr id="4" name="">
+            <a:extLst xmlns:a="http://schemas.openxmlformats.org/drawingml/2006/main">
+              <a:ext uri="{FF2B5EF4-FFF2-40B4-BE49-F238E27FC236}">
+                <a16:creationId xmlns:a16="http://schemas.microsoft.com/office/drawing/2014/main" id="{D93E2548-3FF7-4C80-83C0-4FDDB420C0C6}"/>
+              </a:ext>
+            </a:extLst>
+          </p:cNvPr>
+          <p:cNvSpPr>
+            <a:spLocks xmlns:a="http://schemas.openxmlformats.org/drawingml/2006/main" noGrp="1"/>
+          </p:cNvSpPr>
+          <p:nvPr/>
+        </p:nvSpPr>
+        <p:spPr>
+          <a:xfrm xmlns:a="http://schemas.openxmlformats.org/drawingml/2006/main">
+            <a:off x="609600" y="2686050"/>
+            <a:ext cx="10820400" cy="857250"/>
+          </a:xfrm>
+          <a:prstGeom xmlns:a="http://schemas.openxmlformats.org/drawingml/2006/main" prst="rect">
+            <a:avLst/>
+          </a:prstGeom>
+          <a:noFill xmlns:a="http://schemas.openxmlformats.org/drawingml/2006/main"/>
+          <a:ln xmlns:a="http://schemas.openxmlformats.org/drawingml/2006/main" w="0">
+            <a:noFill/>
+          </a:ln>
+        </p:spPr>
+        <p:txBody>
+          <a:bodyPr xmlns:a="http://schemas.openxmlformats.org/drawingml/2006/main">
+            <a:noAutofit/>
+          </a:bodyPr>
+          <a:lstStyle xmlns:a="http://schemas.openxmlformats.org/drawingml/2006/main"/>
+          <a:p xmlns:a="http://schemas.openxmlformats.org/drawingml/2006/main">
+            <a:pPr>
+              <a:defRPr sz="2250" b="0">
+                <a:solidFill>
+                  <a:srgbClr val="283A39"/>
+                </a:solidFill>
+                <a:latin typeface="Arial"/>
+                <a:ea typeface="Arial"/>
+                <a:cs typeface="Arial"/>
+              </a:defRPr>
+            </a:pPr>
+            <a:r>
+              <a:rPr sz="2250" b="0">
+                <a:solidFill>
+                  <a:srgbClr val="283A39"/>
+                </a:solidFill>
+                <a:latin typeface="Arial"/>
+                <a:ea typeface="Arial"/>
+                <a:cs typeface="Arial"/>
+              </a:rPr>
+              <a:t>b. When prompted, connect Gmail in your AI app.</a:t>
+            </a:r>
+          </a:p>
+          <a:p xmlns:a="http://schemas.openxmlformats.org/drawingml/2006/main">
+            <a:pPr>
+              <a:defRPr sz="2250" b="0">
+                <a:solidFill>
+                  <a:srgbClr val="283A39"/>
+                </a:solidFill>
+                <a:latin typeface="Arial"/>
+                <a:ea typeface="Arial"/>
+                <a:cs typeface="Arial"/>
+              </a:defRPr>
+            </a:pPr>
+            <a:r>
+              <a:rPr sz="2250" b="0">
+                <a:solidFill>
+                  <a:srgbClr val="283A39"/>
+                </a:solidFill>
+                <a:latin typeface="Arial"/>
+                <a:ea typeface="Arial"/>
+                <a:cs typeface="Arial"/>
+              </a:rPr>
+              <a:t>    Sign in to the Google account you chose.</a:t>
+            </a:r>
+          </a:p>
+        </p:txBody>
+      </p:sp>
+      <p:sp>
+        <p:nvSpPr>
+          <p:cNvPr id="5" name="">
+            <a:extLst xmlns:a="http://schemas.openxmlformats.org/drawingml/2006/main">
+              <a:ext uri="{FF2B5EF4-FFF2-40B4-BE49-F238E27FC236}">
+                <a16:creationId xmlns:a16="http://schemas.microsoft.com/office/drawing/2014/main" id="{15D3C5B8-3795-4CC8-8FA5-368D64F42A0D}"/>
+              </a:ext>
+            </a:extLst>
+          </p:cNvPr>
+          <p:cNvSpPr>
+            <a:spLocks xmlns:a="http://schemas.openxmlformats.org/drawingml/2006/main" noGrp="1"/>
+          </p:cNvSpPr>
+          <p:nvPr/>
+        </p:nvSpPr>
+        <p:spPr>
+          <a:xfrm xmlns:a="http://schemas.openxmlformats.org/drawingml/2006/main">
+            <a:off x="609600" y="3924300"/>
+            <a:ext cx="10820400" cy="857250"/>
+          </a:xfrm>
+          <a:prstGeom xmlns:a="http://schemas.openxmlformats.org/drawingml/2006/main" prst="rect">
+            <a:avLst/>
+          </a:prstGeom>
+          <a:noFill xmlns:a="http://schemas.openxmlformats.org/drawingml/2006/main"/>
+          <a:ln xmlns:a="http://schemas.openxmlformats.org/drawingml/2006/main" w="0">
+            <a:noFill/>
+          </a:ln>
+        </p:spPr>
+        <p:txBody>
+          <a:bodyPr xmlns:a="http://schemas.openxmlformats.org/drawingml/2006/main">
+            <a:noAutofit/>
+          </a:bodyPr>
+          <a:lstStyle xmlns:a="http://schemas.openxmlformats.org/drawingml/2006/main"/>
+          <a:p xmlns:a="http://schemas.openxmlformats.org/drawingml/2006/main">
+            <a:pPr>
+              <a:defRPr sz="2250" b="0">
+                <a:solidFill>
+                  <a:srgbClr val="283A39"/>
+                </a:solidFill>
+                <a:latin typeface="Arial"/>
+                <a:ea typeface="Arial"/>
+                <a:cs typeface="Arial"/>
+              </a:defRPr>
+            </a:pPr>
+            <a:r>
+              <a:rPr sz="2250" b="0">
+                <a:solidFill>
+                  <a:srgbClr val="283A39"/>
+                </a:solidFill>
+                <a:latin typeface="Arial"/>
+                <a:ea typeface="Arial"/>
+                <a:cs typeface="Arial"/>
+              </a:rPr>
+              <a:t>c. The AI checks the connected address and read access.</a:t>
+            </a:r>
+          </a:p>
+          <a:p xmlns:a="http://schemas.openxmlformats.org/drawingml/2006/main">
+            <a:pPr>
+              <a:defRPr sz="2250" b="0">
+                <a:solidFill>
+                  <a:srgbClr val="283A39"/>
+                </a:solidFill>
+                <a:latin typeface="Arial"/>
+                <a:ea typeface="Arial"/>
+                <a:cs typeface="Arial"/>
+              </a:defRPr>
+            </a:pPr>
+            <a:r>
+              <a:rPr sz="2250" b="0">
+                <a:solidFill>
+                  <a:srgbClr val="283A39"/>
+                </a:solidFill>
+                <a:latin typeface="Arial"/>
+                <a:ea typeface="Arial"/>
+                <a:cs typeface="Arial"/>
+              </a:rPr>
+              <a:t>    It waits if the account is wrong or unavailable.</a:t>
+            </a:r>
+          </a:p>
+        </p:txBody>
+      </p:sp>
+      <p:sp>
+        <p:nvSpPr>
+          <p:cNvPr id="6" name="">
+            <a:extLst xmlns:a="http://schemas.openxmlformats.org/drawingml/2006/main">
+              <a:ext uri="{FF2B5EF4-FFF2-40B4-BE49-F238E27FC236}">
+                <a16:creationId xmlns:a16="http://schemas.microsoft.com/office/drawing/2014/main" id="{499F2DAF-5D76-4075-B729-3E8C8ADD43E1}"/>
+              </a:ext>
+            </a:extLst>
+          </p:cNvPr>
+          <p:cNvSpPr>
+            <a:spLocks xmlns:a="http://schemas.openxmlformats.org/drawingml/2006/main" noGrp="1"/>
+          </p:cNvSpPr>
+          <p:nvPr/>
+        </p:nvSpPr>
+        <p:spPr>
+          <a:xfrm xmlns:a="http://schemas.openxmlformats.org/drawingml/2006/main">
+            <a:off x="609600" y="5219700"/>
+            <a:ext cx="10820400" cy="723900"/>
+          </a:xfrm>
+          <a:prstGeom xmlns:a="http://schemas.openxmlformats.org/drawingml/2006/main" prst="rect">
+            <a:avLst/>
+          </a:prstGeom>
+          <a:noFill xmlns:a="http://schemas.openxmlformats.org/drawingml/2006/main"/>
+          <a:ln xmlns:a="http://schemas.openxmlformats.org/drawingml/2006/main" w="0">
+            <a:noFill/>
+          </a:ln>
+        </p:spPr>
+        <p:txBody>
+          <a:bodyPr xmlns:a="http://schemas.openxmlformats.org/drawingml/2006/main">
+            <a:noAutofit/>
+          </a:bodyPr>
+          <a:lstStyle xmlns:a="http://schemas.openxmlformats.org/drawingml/2006/main"/>
+          <a:p xmlns:a="http://schemas.openxmlformats.org/drawingml/2006/main">
+            <a:pPr>
+              <a:defRPr sz="1800" b="0">
+                <a:solidFill>
+                  <a:srgbClr val="607370"/>
+                </a:solidFill>
+                <a:latin typeface="Arial"/>
+                <a:ea typeface="Arial"/>
+                <a:cs typeface="Arial"/>
+              </a:defRPr>
+            </a:pPr>
+            <a:r>
+              <a:rPr sz="1800" b="0">
+                <a:solidFill>
+                  <a:srgbClr val="607370"/>
+                </a:solidFill>
+                <a:latin typeface="Arial"/>
+                <a:ea typeface="Arial"/>
+                <a:cs typeface="Arial"/>
+              </a:rPr>
+              <a:t>You can choose no or later and still prepare resumes and find jobs.</a:t>
+            </a:r>
+          </a:p>
+          <a:p xmlns:a="http://schemas.openxmlformats.org/drawingml/2006/main">
+            <a:pPr>
+              <a:defRPr sz="1800" b="0">
+                <a:solidFill>
+                  <a:srgbClr val="607370"/>
+                </a:solidFill>
+                <a:latin typeface="Arial"/>
+                <a:ea typeface="Arial"/>
+                <a:cs typeface="Arial"/>
+              </a:defRPr>
+            </a:pPr>
+            <a:r>
+              <a:rPr sz="1800" b="0">
+                <a:solidFill>
+                  <a:srgbClr val="607370"/>
+                </a:solidFill>
+                <a:latin typeface="Arial"/>
+                <a:ea typeface="Arial"/>
+                <a:cs typeface="Arial"/>
+              </a:rPr>
+              <a:t>Sending email and changing your calendar need separate permission.</a:t>
+            </a:r>
+          </a:p>
+        </p:txBody>
+      </p:sp>
+      <p:sp>
+        <p:nvSpPr>
+          <p:cNvPr id="7" name="">
+            <a:extLst xmlns:a="http://schemas.openxmlformats.org/drawingml/2006/main">
+              <a:ext uri="{FF2B5EF4-FFF2-40B4-BE49-F238E27FC236}">
+                <a16:creationId xmlns:a16="http://schemas.microsoft.com/office/drawing/2014/main" id="{EAF2EA42-DEE2-4D4C-AEB4-EA109E27A622}"/>
+              </a:ext>
+            </a:extLst>
+          </p:cNvPr>
+          <p:cNvSpPr>
+            <a:spLocks xmlns:a="http://schemas.openxmlformats.org/drawingml/2006/main" noGrp="1"/>
+          </p:cNvSpPr>
+          <p:nvPr/>
+        </p:nvSpPr>
+        <p:spPr>
+          <a:xfrm xmlns:a="http://schemas.openxmlformats.org/drawingml/2006/main">
+            <a:off x="609600" y="6038850"/>
+            <a:ext cx="10001250" cy="333375"/>
+          </a:xfrm>
+          <a:prstGeom xmlns:a="http://schemas.openxmlformats.org/drawingml/2006/main" prst="rect">
+            <a:avLst/>
+          </a:prstGeom>
+          <a:noFill xmlns:a="http://schemas.openxmlformats.org/drawingml/2006/main"/>
+          <a:ln xmlns:a="http://schemas.openxmlformats.org/drawingml/2006/main" w="0">
+            <a:noFill/>
+          </a:ln>
+        </p:spPr>
+        <p:txBody>
+          <a:bodyPr xmlns:a="http://schemas.openxmlformats.org/drawingml/2006/main">
+            <a:noAutofit/>
+          </a:bodyPr>
+          <a:lstStyle xmlns:a="http://schemas.openxmlformats.org/drawingml/2006/main"/>
+          <a:p xmlns:a="http://schemas.openxmlformats.org/drawingml/2006/main">
+            <a:pPr>
+              <a:defRPr sz="1800" b="0">
+                <a:solidFill>
+                  <a:srgbClr val="087F73"/>
+                </a:solidFill>
+                <a:latin typeface="Arial"/>
+                <a:ea typeface="Arial"/>
+                <a:cs typeface="Arial"/>
+              </a:defRPr>
+            </a:pPr>
+            <a:r>
+              <a:rPr sz="1800" b="0">
+                <a:solidFill>
+                  <a:srgbClr val="087F73"/>
+                </a:solidFill>
+                <a:latin typeface="Arial"/>
+                <a:ea typeface="Arial"/>
+                <a:cs typeface="Arial"/>
+                <a:hlinkClick xmlns:r="http://schemas.openxmlformats.org/officeDocument/2006/relationships" r:id="R286e30ae33a442f5"/>
+              </a:rPr>
+              <a:t>Detailed connection steps</a:t>
+            </a:r>
+          </a:p>
+        </p:txBody>
+      </p:sp>
+    </p:spTree>
+    <p:extLst>
+      <p:ext uri="{BB962C8B-B14F-4D97-AF65-F5344CB8AC3E}">
+        <p14:creationId xmlns:p14="http://schemas.microsoft.com/office/powerpoint/2010/main" val="247586683"/>
       </p:ext>
     </p:extLst>
   </p:cSld>
@@ -6909,7 +7501,7 @@
                 <a:latin typeface="Arial"/>
                 <a:ea typeface="Arial"/>
                 <a:cs typeface="Arial"/>
-                <a:hlinkClick xmlns:r="http://schemas.openxmlformats.org/officeDocument/2006/relationships" r:id="Rd1f2fdde84ce41f4"/>
+                <a:hlinkClick xmlns:r="http://schemas.openxmlformats.org/officeDocument/2006/relationships" r:id="R9aef0ee541774032"/>
               </a:rPr>
               <a:t>Mac download page (Apple Silicon)</a:t>
             </a:r>
@@ -6968,7 +7560,7 @@
                 <a:latin typeface="Arial"/>
                 <a:ea typeface="Arial"/>
                 <a:cs typeface="Arial"/>
-                <a:hlinkClick xmlns:r="http://schemas.openxmlformats.org/officeDocument/2006/relationships" r:id="R5624178ab78f43b9"/>
+                <a:hlinkClick xmlns:r="http://schemas.openxmlformats.org/officeDocument/2006/relationships" r:id="R829ee42eee1740a5"/>
               </a:rPr>
               <a:t>Windows download page</a:t>
             </a:r>
@@ -7167,7 +7759,7 @@
                 <a:latin typeface="Arial"/>
                 <a:ea typeface="Arial"/>
                 <a:cs typeface="Arial"/>
-                <a:hlinkClick xmlns:r="http://schemas.openxmlformats.org/officeDocument/2006/relationships" r:id="R8b228d2de2a24033"/>
+                <a:hlinkClick xmlns:r="http://schemas.openxmlformats.org/officeDocument/2006/relationships" r:id="Rd7f9c94a852f4817"/>
               </a:rPr>
               <a:t>Mac or Windows downloads</a:t>
             </a:r>
@@ -7226,7 +7818,7 @@
                 <a:latin typeface="Arial"/>
                 <a:ea typeface="Arial"/>
                 <a:cs typeface="Arial"/>
-                <a:hlinkClick xmlns:r="http://schemas.openxmlformats.org/officeDocument/2006/relationships" r:id="R10ae087796db4560"/>
+                <a:hlinkClick xmlns:r="http://schemas.openxmlformats.org/officeDocument/2006/relationships" r:id="R76cc43b3bf244913"/>
               </a:rPr>
               <a:t>Claude Code setup and account requirements</a:t>
             </a:r>
@@ -7503,7 +8095,7 @@
           <p:nvPr/>
         </p:nvPicPr>
         <p:blipFill>
-          <a:blip xmlns:r="http://schemas.openxmlformats.org/officeDocument/2006/relationships" xmlns:a="http://schemas.openxmlformats.org/drawingml/2006/main" r:embed="R08355b9e8c104107"/>
+          <a:blip xmlns:r="http://schemas.openxmlformats.org/officeDocument/2006/relationships" xmlns:a="http://schemas.openxmlformats.org/drawingml/2006/main" r:embed="R0161151bea844c53"/>
           <a:stretch xmlns:a="http://schemas.openxmlformats.org/drawingml/2006/main"/>
         </p:blipFill>
         <p:spPr>
@@ -8046,7 +8638,7 @@
           <p:nvPr/>
         </p:nvPicPr>
         <p:blipFill>
-          <a:blip xmlns:r="http://schemas.openxmlformats.org/officeDocument/2006/relationships" xmlns:a="http://schemas.openxmlformats.org/drawingml/2006/main" r:embed="R0d0dd6e0a14a4e84"/>
+          <a:blip xmlns:r="http://schemas.openxmlformats.org/officeDocument/2006/relationships" xmlns:a="http://schemas.openxmlformats.org/drawingml/2006/main" r:embed="R00a043beeac74082"/>
           <a:stretch xmlns:a="http://schemas.openxmlformats.org/drawingml/2006/main"/>
         </p:blipFill>
         <p:spPr>
@@ -8353,7 +8945,7 @@
           <p:nvPr/>
         </p:nvPicPr>
         <p:blipFill>
-          <a:blip xmlns:r="http://schemas.openxmlformats.org/officeDocument/2006/relationships" xmlns:a="http://schemas.openxmlformats.org/drawingml/2006/main" r:embed="Re72c652631e9468f"/>
+          <a:blip xmlns:r="http://schemas.openxmlformats.org/officeDocument/2006/relationships" xmlns:a="http://schemas.openxmlformats.org/drawingml/2006/main" r:embed="Rbecfc23e36c9402e"/>
           <a:stretch xmlns:a="http://schemas.openxmlformats.org/drawingml/2006/main"/>
         </p:blipFill>
         <p:spPr>
@@ -8660,7 +9252,7 @@
           <p:nvPr/>
         </p:nvPicPr>
         <p:blipFill>
-          <a:blip xmlns:r="http://schemas.openxmlformats.org/officeDocument/2006/relationships" xmlns:a="http://schemas.openxmlformats.org/drawingml/2006/main" r:embed="R46b5359a9bbd4fd3"/>
+          <a:blip xmlns:r="http://schemas.openxmlformats.org/officeDocument/2006/relationships" xmlns:a="http://schemas.openxmlformats.org/drawingml/2006/main" r:embed="Rd5d176f873ae41fc"/>
           <a:stretch xmlns:a="http://schemas.openxmlformats.org/drawingml/2006/main"/>
         </p:blipFill>
         <p:spPr>
@@ -9633,7 +10225,7 @@
                 <a:latin typeface="Arial"/>
                 <a:ea typeface="Arial"/>
                 <a:cs typeface="Arial"/>
-                <a:hlinkClick xmlns:r="http://schemas.openxmlformats.org/officeDocument/2006/relationships" r:id="Rb873a99858bf4cc8"/>
+                <a:hlinkClick xmlns:r="http://schemas.openxmlformats.org/officeDocument/2006/relationships" r:id="R35ef951d49964874"/>
               </a:rPr>
               <a:t>Copy from the README</a:t>
             </a:r>

</xml_diff>

<commit_message>
Offer optional mail connections before skill installation
</commit_message>
<xml_diff>
--- a/docs/job-search-guide.pptx
+++ b/docs/job-search-guide.pptx
@@ -2,30 +2,30 @@
 <file path=ppt/presentation.xml><?xml version="1.0" encoding="utf-8"?>
 <p:presentation xmlns:p="http://schemas.openxmlformats.org/presentationml/2006/main">
   <p:sldMasterIdLst>
-    <p:sldMasterId xmlns:r="http://schemas.openxmlformats.org/officeDocument/2006/relationships" id="2147483648" r:id="R25005ede53a24abc"/>
+    <p:sldMasterId xmlns:r="http://schemas.openxmlformats.org/officeDocument/2006/relationships" id="2147483648" r:id="Re65a6eec03514210"/>
   </p:sldMasterIdLst>
   <p:notesMasterIdLst>
-    <p:notesMasterId xmlns:r="http://schemas.openxmlformats.org/officeDocument/2006/relationships" r:id="R9bad2a37e10f47c0"/>
+    <p:notesMasterId xmlns:r="http://schemas.openxmlformats.org/officeDocument/2006/relationships" r:id="Ra61bfc18dd914cfe"/>
   </p:notesMasterIdLst>
   <p:sldIdLst>
-    <p:sldId xmlns:r="http://schemas.openxmlformats.org/officeDocument/2006/relationships" id="256" r:id="R84cc7c6360ea42e0"/>
-    <p:sldId xmlns:r="http://schemas.openxmlformats.org/officeDocument/2006/relationships" id="257" r:id="R8005eceee2124c4c"/>
-    <p:sldId xmlns:r="http://schemas.openxmlformats.org/officeDocument/2006/relationships" id="258" r:id="R1f704fac7bb048fc"/>
-    <p:sldId xmlns:r="http://schemas.openxmlformats.org/officeDocument/2006/relationships" id="259" r:id="Rf88c8381a673463a"/>
-    <p:sldId xmlns:r="http://schemas.openxmlformats.org/officeDocument/2006/relationships" id="260" r:id="Rf946f3e4b25e4d40"/>
-    <p:sldId xmlns:r="http://schemas.openxmlformats.org/officeDocument/2006/relationships" id="261" r:id="R2510e97721c04b7b"/>
-    <p:sldId xmlns:r="http://schemas.openxmlformats.org/officeDocument/2006/relationships" id="262" r:id="R38fab24a0f8244d5"/>
-    <p:sldId xmlns:r="http://schemas.openxmlformats.org/officeDocument/2006/relationships" id="263" r:id="R034b4054a31d4f04"/>
-    <p:sldId xmlns:r="http://schemas.openxmlformats.org/officeDocument/2006/relationships" id="264" r:id="Rf84447db19fb43b6"/>
-    <p:sldId xmlns:r="http://schemas.openxmlformats.org/officeDocument/2006/relationships" id="265" r:id="R75583f69116c4fbb"/>
-    <p:sldId xmlns:r="http://schemas.openxmlformats.org/officeDocument/2006/relationships" id="266" r:id="R8e9d57f8aad14841"/>
-    <p:sldId xmlns:r="http://schemas.openxmlformats.org/officeDocument/2006/relationships" id="267" r:id="R8141c3f70ec64246"/>
-    <p:sldId xmlns:r="http://schemas.openxmlformats.org/officeDocument/2006/relationships" id="268" r:id="Re79797b9a70c47cd"/>
-    <p:sldId xmlns:r="http://schemas.openxmlformats.org/officeDocument/2006/relationships" id="269" r:id="Rb6ea52a0624a4b6e"/>
-    <p:sldId xmlns:r="http://schemas.openxmlformats.org/officeDocument/2006/relationships" id="270" r:id="Rd47ff13c0c0d44a4"/>
-    <p:sldId xmlns:r="http://schemas.openxmlformats.org/officeDocument/2006/relationships" id="271" r:id="R577a9d4e7b7441fa"/>
-    <p:sldId xmlns:r="http://schemas.openxmlformats.org/officeDocument/2006/relationships" id="272" r:id="R46e4a2bd0de54b7e"/>
-    <p:sldId xmlns:r="http://schemas.openxmlformats.org/officeDocument/2006/relationships" id="273" r:id="R8857ae883e47485a"/>
+    <p:sldId xmlns:r="http://schemas.openxmlformats.org/officeDocument/2006/relationships" id="256" r:id="R727dd319fcb542b2"/>
+    <p:sldId xmlns:r="http://schemas.openxmlformats.org/officeDocument/2006/relationships" id="257" r:id="R6abf12f0ddf344b4"/>
+    <p:sldId xmlns:r="http://schemas.openxmlformats.org/officeDocument/2006/relationships" id="258" r:id="R4e89b96a341c4b17"/>
+    <p:sldId xmlns:r="http://schemas.openxmlformats.org/officeDocument/2006/relationships" id="259" r:id="R524cf52cd667414f"/>
+    <p:sldId xmlns:r="http://schemas.openxmlformats.org/officeDocument/2006/relationships" id="260" r:id="R81f62b27a0c14717"/>
+    <p:sldId xmlns:r="http://schemas.openxmlformats.org/officeDocument/2006/relationships" id="261" r:id="R5f733f8b74a040f0"/>
+    <p:sldId xmlns:r="http://schemas.openxmlformats.org/officeDocument/2006/relationships" id="262" r:id="R92549cd958354bea"/>
+    <p:sldId xmlns:r="http://schemas.openxmlformats.org/officeDocument/2006/relationships" id="263" r:id="R30074878f0584420"/>
+    <p:sldId xmlns:r="http://schemas.openxmlformats.org/officeDocument/2006/relationships" id="264" r:id="Rc7d6d9909074422e"/>
+    <p:sldId xmlns:r="http://schemas.openxmlformats.org/officeDocument/2006/relationships" id="265" r:id="R24c981202ea548fa"/>
+    <p:sldId xmlns:r="http://schemas.openxmlformats.org/officeDocument/2006/relationships" id="266" r:id="R1570bbf787454d38"/>
+    <p:sldId xmlns:r="http://schemas.openxmlformats.org/officeDocument/2006/relationships" id="267" r:id="R29a62af0b07b4005"/>
+    <p:sldId xmlns:r="http://schemas.openxmlformats.org/officeDocument/2006/relationships" id="268" r:id="R31e50e159f744c73"/>
+    <p:sldId xmlns:r="http://schemas.openxmlformats.org/officeDocument/2006/relationships" id="269" r:id="R0dbe1ddb34224ec2"/>
+    <p:sldId xmlns:r="http://schemas.openxmlformats.org/officeDocument/2006/relationships" id="270" r:id="R1e8bafa47c05438a"/>
+    <p:sldId xmlns:r="http://schemas.openxmlformats.org/officeDocument/2006/relationships" id="271" r:id="R3dc15b3bd73a4afe"/>
+    <p:sldId xmlns:r="http://schemas.openxmlformats.org/officeDocument/2006/relationships" id="272" r:id="R979ba150f01e43e4"/>
+    <p:sldId xmlns:r="http://schemas.openxmlformats.org/officeDocument/2006/relationships" id="273" r:id="R1f54c91177564bb8"/>
   </p:sldIdLst>
   <p:sldSz cx="12192000" cy="6858000"/>
   <p:notesSz cx="6858000" cy="9144000"/>
@@ -534,17 +534,7 @@
           <a:lstStyle xmlns:a="http://schemas.openxmlformats.org/drawingml/2006/main"/>
           <a:p xmlns:a="http://schemas.openxmlformats.org/drawingml/2006/main">
             <a:r>
-              <a:t/>
-            </a:r>
-          </a:p>
-          <a:p xmlns:a="http://schemas.openxmlformats.org/drawingml/2006/main">
-            <a:r>
-              <a:t>Workflow source: https://github.com/toughdave/job-search</a:t>
-            </a:r>
-          </a:p>
-          <a:p xmlns:a="http://schemas.openxmlformats.org/drawingml/2006/main">
-            <a:r>
-              <a:t>Guide checked 12 September 2026.</a:t>
+              <a:t>Source: https://github.com/toughdave/job-search/blob/main/docs/setup.md#prerequisites-and-dependencies. The AI prefers a maintained Python 3.12+ for new setup. Packages: python-docx, ReportLab, pypdf, pypdfium2 and tzdata. Download-and-copy does not require Node or Git. Cleanup requires a preview and candidate approval.</a:t>
             </a:r>
           </a:p>
         </p:txBody>
@@ -614,7 +604,17 @@
           <a:lstStyle xmlns:a="http://schemas.openxmlformats.org/drawingml/2006/main"/>
           <a:p xmlns:a="http://schemas.openxmlformats.org/drawingml/2006/main">
             <a:r>
-              <a:t>Sources: https://github.com/toughdave/job-search/blob/main/skills/job-search/references/mail.md ; https://code.claude.com/docs/en/desktop ; https://support.claude.com/en/articles/10166901-use-google-workspace-connectors ; https://learn.chatgpt.com/docs/plugins . Setup saves the chosen application mailbox and read scope. The candidate completes sign-in. The AI checks the actual authenticated identity and performs a bounded read before claiming readiness. Codex and Claude connections are verified independently.</a:t>
+              <a:t/>
+            </a:r>
+          </a:p>
+          <a:p xmlns:a="http://schemas.openxmlformats.org/drawingml/2006/main">
+            <a:r>
+              <a:t>Workflow source: https://github.com/toughdave/job-search</a:t>
+            </a:r>
+          </a:p>
+          <a:p xmlns:a="http://schemas.openxmlformats.org/drawingml/2006/main">
+            <a:r>
+              <a:t>Guide checked 12 September 2026.</a:t>
             </a:r>
           </a:p>
         </p:txBody>
@@ -1674,17 +1674,7 @@
           <a:lstStyle xmlns:a="http://schemas.openxmlformats.org/drawingml/2006/main"/>
           <a:p xmlns:a="http://schemas.openxmlformats.org/drawingml/2006/main">
             <a:r>
-              <a:t/>
-            </a:r>
-          </a:p>
-          <a:p xmlns:a="http://schemas.openxmlformats.org/drawingml/2006/main">
-            <a:r>
-              <a:t>Workflow source: https://github.com/toughdave/job-search</a:t>
-            </a:r>
-          </a:p>
-          <a:p xmlns:a="http://schemas.openxmlformats.org/drawingml/2006/main">
-            <a:r>
-              <a:t>Guide checked 12 September 2026.</a:t>
+              <a:t>Optional app setup before the skill installation prompt. Connect the intended Gmail account through Codex Plugins or Claude Code Connectors; reuse a working connection. Google Calendar is optional for interview events. The skill still confirms project-specific read permission and account identity before inbox reads, and separate calendar selection/permission before event changes. Sources checked 14 September 2026: https://learn.chatgpt.com/docs/plugins ; https://code.claude.com/docs/en/desktop#connect-external-tools ; https://github.com/toughdave/job-search#f-optional-connect-gmail-before-the-first-message .</a:t>
             </a:r>
           </a:p>
         </p:txBody>
@@ -1834,7 +1824,17 @@
           <a:lstStyle xmlns:a="http://schemas.openxmlformats.org/drawingml/2006/main"/>
           <a:p xmlns:a="http://schemas.openxmlformats.org/drawingml/2006/main">
             <a:r>
-              <a:t>Source: https://github.com/toughdave/job-search/blob/main/docs/setup.md#prerequisites-and-dependencies. The AI prefers a maintained Python 3.12+ for new setup. Packages: python-docx, ReportLab, pypdf, pypdfium2 and tzdata. Download-and-copy does not require Node or Git. Cleanup requires a preview and candidate approval.</a:t>
+              <a:t/>
+            </a:r>
+          </a:p>
+          <a:p xmlns:a="http://schemas.openxmlformats.org/drawingml/2006/main">
+            <a:r>
+              <a:t>Workflow source: https://github.com/toughdave/job-search</a:t>
+            </a:r>
+          </a:p>
+          <a:p xmlns:a="http://schemas.openxmlformats.org/drawingml/2006/main">
+            <a:r>
+              <a:t>Guide checked 12 September 2026.</a:t>
             </a:r>
           </a:p>
         </p:txBody>
@@ -1902,7 +1902,7 @@
   </p:cSld>
   <p:clrMap bg1="lt1" tx1="dk1" bg2="lt2" tx2="dk2" accent1="accent1" accent2="accent2" accent3="accent3" accent4="accent4" accent5="accent5" accent6="accent6" hlink="hlink" folHlink="folHlink"/>
   <p:sldLayoutIdLst>
-    <p:sldLayoutId xmlns:r="http://schemas.openxmlformats.org/officeDocument/2006/relationships" id="2147483649" r:id="R8e21394f4a234aa7"/>
+    <p:sldLayoutId xmlns:r="http://schemas.openxmlformats.org/officeDocument/2006/relationships" id="2147483649" r:id="R59de4aefc55d4739"/>
   </p:sldLayoutIdLst>
   <p:txStyles>
     <p:titleStyle>
@@ -2698,7 +2698,7 @@
                 <a:latin typeface="Arial"/>
                 <a:ea typeface="Arial"/>
                 <a:cs typeface="Arial"/>
-                <a:hlinkClick xmlns:r="http://schemas.openxmlformats.org/officeDocument/2006/relationships" r:id="Rd60963ddfc054428"/>
+                <a:hlinkClick xmlns:r="http://schemas.openxmlformats.org/officeDocument/2006/relationships" r:id="Re162ed4d3c764ce1"/>
               </a:rPr>
               <a:t>Open the GitHub guide</a:t>
             </a:r>
@@ -2736,10 +2736,10 @@
       </p:grpSpPr>
       <p:sp>
         <p:nvSpPr>
-          <p:cNvPr id="8" name="">
-            <a:extLst xmlns:a="http://schemas.openxmlformats.org/drawingml/2006/main">
-              <a:ext uri="{FF2B5EF4-FFF2-40B4-BE49-F238E27FC236}">
-                <a16:creationId xmlns:a16="http://schemas.microsoft.com/office/drawing/2014/main" id="{27C103AD-EB4D-434A-B73C-419B7563C70C}"/>
+          <p:cNvPr id="7" name="">
+            <a:extLst xmlns:a="http://schemas.openxmlformats.org/drawingml/2006/main">
+              <a:ext uri="{FF2B5EF4-FFF2-40B4-BE49-F238E27FC236}">
+                <a16:creationId xmlns:a16="http://schemas.microsoft.com/office/drawing/2014/main" id="{1678E64F-2881-4536-825F-C7EE8249525B}"/>
               </a:ext>
             </a:extLst>
           </p:cNvPr>
@@ -2751,7 +2751,7 @@
         <p:spPr>
           <a:xfrm xmlns:a="http://schemas.openxmlformats.org/drawingml/2006/main">
             <a:off x="609600" y="457200"/>
-            <a:ext cx="10972800" cy="742950"/>
+            <a:ext cx="10820400" cy="742950"/>
           </a:xfrm>
           <a:prstGeom xmlns:a="http://schemas.openxmlformats.org/drawingml/2006/main" prst="rect">
             <a:avLst/>
@@ -2787,7 +2787,7 @@
                 <a:ea typeface="Arial"/>
                 <a:cs typeface="Arial"/>
               </a:rPr>
-              <a:t>4. A short conversation</a:t>
+              <a:t>Software prerequisites</a:t>
             </a:r>
           </a:p>
         </p:txBody>
@@ -2797,7 +2797,7 @@
           <p:cNvPr id="2" name="">
             <a:extLst xmlns:a="http://schemas.openxmlformats.org/drawingml/2006/main">
               <a:ext uri="{FF2B5EF4-FFF2-40B4-BE49-F238E27FC236}">
-                <a16:creationId xmlns:a16="http://schemas.microsoft.com/office/drawing/2014/main" id="{232FA5F9-A6A3-477B-9EBA-BBF63463BB4A}"/>
+                <a16:creationId xmlns:a16="http://schemas.microsoft.com/office/drawing/2014/main" id="{C131A19B-3CC5-4351-A103-EFEC84606564}"/>
               </a:ext>
             </a:extLst>
           </p:cNvPr>
@@ -2855,19 +2855,19 @@
           <p:cNvPr id="3" name="">
             <a:extLst xmlns:a="http://schemas.openxmlformats.org/drawingml/2006/main">
               <a:ext uri="{FF2B5EF4-FFF2-40B4-BE49-F238E27FC236}">
-                <a16:creationId xmlns:a16="http://schemas.microsoft.com/office/drawing/2014/main" id="{BF0FE3D5-F5A3-4B6A-AB57-61921D531F29}"/>
-              </a:ext>
-            </a:extLst>
-          </p:cNvPr>
-          <p:cNvSpPr>
-            <a:spLocks xmlns:a="http://schemas.openxmlformats.org/drawingml/2006/main" noGrp="1"/>
-          </p:cNvSpPr>
-          <p:nvPr/>
-        </p:nvSpPr>
-        <p:spPr>
-          <a:xfrm xmlns:a="http://schemas.openxmlformats.org/drawingml/2006/main">
-            <a:off x="609600" y="1447800"/>
-            <a:ext cx="10820400" cy="647700"/>
+                <a16:creationId xmlns:a16="http://schemas.microsoft.com/office/drawing/2014/main" id="{2BE83B1A-A02A-486B-B2CA-1FDC73426FFD}"/>
+              </a:ext>
+            </a:extLst>
+          </p:cNvPr>
+          <p:cNvSpPr>
+            <a:spLocks xmlns:a="http://schemas.openxmlformats.org/drawingml/2006/main" noGrp="1"/>
+          </p:cNvSpPr>
+          <p:nvPr/>
+        </p:nvSpPr>
+        <p:spPr>
+          <a:xfrm xmlns:a="http://schemas.openxmlformats.org/drawingml/2006/main">
+            <a:off x="609600" y="1504950"/>
+            <a:ext cx="10820400" cy="1047750"/>
           </a:xfrm>
           <a:prstGeom xmlns:a="http://schemas.openxmlformats.org/drawingml/2006/main" prst="rect">
             <a:avLst/>
@@ -2903,7 +2903,31 @@
                 <a:ea typeface="Arial"/>
                 <a:cs typeface="Arial"/>
               </a:rPr>
-              <a:t>The AI saves each question, asks it, and waits for your answer.</a:t>
+              <a:t>Use a local project with file access and an internet connection.</a:t>
+            </a:r>
+          </a:p>
+          <a:p xmlns:a="http://schemas.openxmlformats.org/drawingml/2006/main">
+            <a:pPr>
+              <a:buNone/>
+              <a:defRPr sz="2250" b="0">
+                <a:solidFill>
+                  <a:srgbClr val="283A39"/>
+                </a:solidFill>
+                <a:latin typeface="Arial"/>
+                <a:ea typeface="Arial"/>
+                <a:cs typeface="Arial"/>
+              </a:defRPr>
+            </a:pPr>
+            <a:r>
+              <a:rPr sz="2250" b="0">
+                <a:solidFill>
+                  <a:srgbClr val="283A39"/>
+                </a:solidFill>
+                <a:latin typeface="Arial"/>
+                <a:ea typeface="Arial"/>
+                <a:cs typeface="Arial"/>
+              </a:rPr>
+              <a:t>Your AI app needs an account that can use local projects.</a:t>
             </a:r>
           </a:p>
         </p:txBody>
@@ -2913,55 +2937,79 @@
           <p:cNvPr id="4" name="">
             <a:extLst xmlns:a="http://schemas.openxmlformats.org/drawingml/2006/main">
               <a:ext uri="{FF2B5EF4-FFF2-40B4-BE49-F238E27FC236}">
-                <a16:creationId xmlns:a16="http://schemas.microsoft.com/office/drawing/2014/main" id="{57106B18-7355-4368-A961-3F52136F9D3D}"/>
-              </a:ext>
-            </a:extLst>
-          </p:cNvPr>
-          <p:cNvSpPr>
-            <a:spLocks xmlns:a="http://schemas.openxmlformats.org/drawingml/2006/main" noGrp="1"/>
-          </p:cNvSpPr>
-          <p:nvPr/>
-        </p:nvSpPr>
-        <p:spPr>
-          <a:xfrm xmlns:a="http://schemas.openxmlformats.org/drawingml/2006/main">
-            <a:off x="609600" y="2524125"/>
-            <a:ext cx="10858500" cy="438150"/>
-          </a:xfrm>
-          <a:prstGeom xmlns:a="http://schemas.openxmlformats.org/drawingml/2006/main" prst="rect">
-            <a:avLst/>
-          </a:prstGeom>
-          <a:noFill xmlns:a="http://schemas.openxmlformats.org/drawingml/2006/main"/>
-          <a:ln xmlns:a="http://schemas.openxmlformats.org/drawingml/2006/main" w="0">
-            <a:noFill/>
-          </a:ln>
-        </p:spPr>
-        <p:txBody>
-          <a:bodyPr xmlns:a="http://schemas.openxmlformats.org/drawingml/2006/main">
-            <a:noAutofit/>
-          </a:bodyPr>
-          <a:lstStyle xmlns:a="http://schemas.openxmlformats.org/drawingml/2006/main"/>
-          <a:p xmlns:a="http://schemas.openxmlformats.org/drawingml/2006/main">
-            <a:pPr>
-              <a:buNone/>
-              <a:defRPr sz="1875" b="1">
-                <a:solidFill>
-                  <a:srgbClr val="087F73"/>
-                </a:solidFill>
-                <a:latin typeface="Arial"/>
-                <a:ea typeface="Arial"/>
-                <a:cs typeface="Arial"/>
-              </a:defRPr>
-            </a:pPr>
-            <a:r>
-              <a:rPr sz="1875" b="1">
-                <a:solidFill>
-                  <a:srgbClr val="087F73"/>
-                </a:solidFill>
-                <a:latin typeface="Arial"/>
-                <a:ea typeface="Arial"/>
-                <a:cs typeface="Arial"/>
-              </a:rPr>
-              <a:t>Example: Cedar Clinic, Office Assistant, 2022-2024</a:t>
+                <a16:creationId xmlns:a16="http://schemas.microsoft.com/office/drawing/2014/main" id="{70BFAC84-0CC4-46D6-ADEC-01EDAD91800C}"/>
+              </a:ext>
+            </a:extLst>
+          </p:cNvPr>
+          <p:cNvSpPr>
+            <a:spLocks xmlns:a="http://schemas.openxmlformats.org/drawingml/2006/main" noGrp="1"/>
+          </p:cNvSpPr>
+          <p:nvPr/>
+        </p:nvSpPr>
+        <p:spPr>
+          <a:xfrm xmlns:a="http://schemas.openxmlformats.org/drawingml/2006/main">
+            <a:off x="609600" y="3076575"/>
+            <a:ext cx="10820400" cy="1047750"/>
+          </a:xfrm>
+          <a:prstGeom xmlns:a="http://schemas.openxmlformats.org/drawingml/2006/main" prst="rect">
+            <a:avLst/>
+          </a:prstGeom>
+          <a:noFill xmlns:a="http://schemas.openxmlformats.org/drawingml/2006/main"/>
+          <a:ln xmlns:a="http://schemas.openxmlformats.org/drawingml/2006/main" w="0">
+            <a:noFill/>
+          </a:ln>
+        </p:spPr>
+        <p:txBody>
+          <a:bodyPr xmlns:a="http://schemas.openxmlformats.org/drawingml/2006/main">
+            <a:noAutofit/>
+          </a:bodyPr>
+          <a:lstStyle xmlns:a="http://schemas.openxmlformats.org/drawingml/2006/main"/>
+          <a:p xmlns:a="http://schemas.openxmlformats.org/drawingml/2006/main">
+            <a:pPr>
+              <a:buNone/>
+              <a:defRPr sz="2250" b="0">
+                <a:solidFill>
+                  <a:srgbClr val="283A39"/>
+                </a:solidFill>
+                <a:latin typeface="Arial"/>
+                <a:ea typeface="Arial"/>
+                <a:cs typeface="Arial"/>
+              </a:defRPr>
+            </a:pPr>
+            <a:r>
+              <a:rPr sz="2250" b="0">
+                <a:solidFill>
+                  <a:srgbClr val="283A39"/>
+                </a:solidFill>
+                <a:latin typeface="Arial"/>
+                <a:ea typeface="Arial"/>
+                <a:cs typeface="Arial"/>
+              </a:rPr>
+              <a:t>The AI checks Python 3.9+ and installs the document packages.</a:t>
+            </a:r>
+          </a:p>
+          <a:p xmlns:a="http://schemas.openxmlformats.org/drawingml/2006/main">
+            <a:pPr>
+              <a:buNone/>
+              <a:defRPr sz="2250" b="0">
+                <a:solidFill>
+                  <a:srgbClr val="283A39"/>
+                </a:solidFill>
+                <a:latin typeface="Arial"/>
+                <a:ea typeface="Arial"/>
+                <a:cs typeface="Arial"/>
+              </a:defRPr>
+            </a:pPr>
+            <a:r>
+              <a:rPr sz="2250" b="0">
+                <a:solidFill>
+                  <a:srgbClr val="283A39"/>
+                </a:solidFill>
+                <a:latin typeface="Arial"/>
+                <a:ea typeface="Arial"/>
+                <a:cs typeface="Arial"/>
+              </a:rPr>
+              <a:t>Node.js 22.20+ is only needed for the optional terminal installer.</a:t>
             </a:r>
           </a:p>
         </p:txBody>
@@ -2971,79 +3019,79 @@
           <p:cNvPr id="5" name="">
             <a:extLst xmlns:a="http://schemas.openxmlformats.org/drawingml/2006/main">
               <a:ext uri="{FF2B5EF4-FFF2-40B4-BE49-F238E27FC236}">
-                <a16:creationId xmlns:a16="http://schemas.microsoft.com/office/drawing/2014/main" id="{8C3397D8-E2CE-4211-93DF-B7218A1DCBA6}"/>
-              </a:ext>
-            </a:extLst>
-          </p:cNvPr>
-          <p:cNvSpPr>
-            <a:spLocks xmlns:a="http://schemas.openxmlformats.org/drawingml/2006/main" noGrp="1"/>
-          </p:cNvSpPr>
-          <p:nvPr/>
-        </p:nvSpPr>
-        <p:spPr>
-          <a:xfrm xmlns:a="http://schemas.openxmlformats.org/drawingml/2006/main">
-            <a:off x="609600" y="3114675"/>
-            <a:ext cx="10858500" cy="1143000"/>
-          </a:xfrm>
-          <a:prstGeom xmlns:a="http://schemas.openxmlformats.org/drawingml/2006/main" prst="rect">
-            <a:avLst/>
-          </a:prstGeom>
-          <a:noFill xmlns:a="http://schemas.openxmlformats.org/drawingml/2006/main"/>
-          <a:ln xmlns:a="http://schemas.openxmlformats.org/drawingml/2006/main" w="0">
-            <a:noFill/>
-          </a:ln>
-        </p:spPr>
-        <p:txBody>
-          <a:bodyPr xmlns:a="http://schemas.openxmlformats.org/drawingml/2006/main">
-            <a:noAutofit/>
-          </a:bodyPr>
-          <a:lstStyle xmlns:a="http://schemas.openxmlformats.org/drawingml/2006/main"/>
-          <a:p xmlns:a="http://schemas.openxmlformats.org/drawingml/2006/main">
-            <a:pPr>
-              <a:buNone/>
-              <a:defRPr sz="2700" b="0">
-                <a:solidFill>
-                  <a:srgbClr val="183F3B"/>
-                </a:solidFill>
-                <a:latin typeface="Arial"/>
-                <a:ea typeface="Arial"/>
-                <a:cs typeface="Arial"/>
-              </a:defRPr>
-            </a:pPr>
-            <a:r>
-              <a:rPr sz="2700" b="0">
-                <a:solidFill>
-                  <a:srgbClr val="183F3B"/>
-                </a:solidFill>
-                <a:latin typeface="Arial"/>
-                <a:ea typeface="Arial"/>
-                <a:cs typeface="Arial"/>
-              </a:rPr>
-              <a:t>“At Cedar Clinic, tell me about one scheduling</a:t>
-            </a:r>
-          </a:p>
-          <a:p xmlns:a="http://schemas.openxmlformats.org/drawingml/2006/main">
-            <a:pPr>
-              <a:buNone/>
-              <a:defRPr sz="2700" b="0">
-                <a:solidFill>
-                  <a:srgbClr val="183F3B"/>
-                </a:solidFill>
-                <a:latin typeface="Arial"/>
-                <a:ea typeface="Arial"/>
-                <a:cs typeface="Arial"/>
-              </a:defRPr>
-            </a:pPr>
-            <a:r>
-              <a:rPr sz="2700" b="0">
-                <a:solidFill>
-                  <a:srgbClr val="183F3B"/>
-                </a:solidFill>
-                <a:latin typeface="Arial"/>
-                <a:ea typeface="Arial"/>
-                <a:cs typeface="Arial"/>
-              </a:rPr>
-              <a:t>problem you handled as an office assistant.”</a:t>
+                <a16:creationId xmlns:a16="http://schemas.microsoft.com/office/drawing/2014/main" id="{A2A54DAE-2D8D-4F3A-AC6C-9C9D0355923E}"/>
+              </a:ext>
+            </a:extLst>
+          </p:cNvPr>
+          <p:cNvSpPr>
+            <a:spLocks xmlns:a="http://schemas.openxmlformats.org/drawingml/2006/main" noGrp="1"/>
+          </p:cNvSpPr>
+          <p:nvPr/>
+        </p:nvSpPr>
+        <p:spPr>
+          <a:xfrm xmlns:a="http://schemas.openxmlformats.org/drawingml/2006/main">
+            <a:off x="609600" y="4657725"/>
+            <a:ext cx="10820400" cy="1047750"/>
+          </a:xfrm>
+          <a:prstGeom xmlns:a="http://schemas.openxmlformats.org/drawingml/2006/main" prst="rect">
+            <a:avLst/>
+          </a:prstGeom>
+          <a:noFill xmlns:a="http://schemas.openxmlformats.org/drawingml/2006/main"/>
+          <a:ln xmlns:a="http://schemas.openxmlformats.org/drawingml/2006/main" w="0">
+            <a:noFill/>
+          </a:ln>
+        </p:spPr>
+        <p:txBody>
+          <a:bodyPr xmlns:a="http://schemas.openxmlformats.org/drawingml/2006/main">
+            <a:noAutofit/>
+          </a:bodyPr>
+          <a:lstStyle xmlns:a="http://schemas.openxmlformats.org/drawingml/2006/main"/>
+          <a:p xmlns:a="http://schemas.openxmlformats.org/drawingml/2006/main">
+            <a:pPr>
+              <a:buNone/>
+              <a:defRPr sz="2250" b="0">
+                <a:solidFill>
+                  <a:srgbClr val="283A39"/>
+                </a:solidFill>
+                <a:latin typeface="Arial"/>
+                <a:ea typeface="Arial"/>
+                <a:cs typeface="Arial"/>
+              </a:defRPr>
+            </a:pPr>
+            <a:r>
+              <a:rPr sz="2250" b="0">
+                <a:solidFill>
+                  <a:srgbClr val="283A39"/>
+                </a:solidFill>
+                <a:latin typeface="Arial"/>
+                <a:ea typeface="Arial"/>
+                <a:cs typeface="Arial"/>
+              </a:rPr>
+              <a:t>Your records stay in the project. Software stays in a local cache.</a:t>
+            </a:r>
+          </a:p>
+          <a:p xmlns:a="http://schemas.openxmlformats.org/drawingml/2006/main">
+            <a:pPr>
+              <a:buNone/>
+              <a:defRPr sz="2250" b="0">
+                <a:solidFill>
+                  <a:srgbClr val="283A39"/>
+                </a:solidFill>
+                <a:latin typeface="Arial"/>
+                <a:ea typeface="Arial"/>
+                <a:cs typeface="Arial"/>
+              </a:defRPr>
+            </a:pPr>
+            <a:r>
+              <a:rPr sz="2250" b="0">
+                <a:solidFill>
+                  <a:srgbClr val="283A39"/>
+                </a:solidFill>
+                <a:latin typeface="Arial"/>
+                <a:ea typeface="Arial"/>
+                <a:cs typeface="Arial"/>
+              </a:rPr>
+              <a:t>Ask the AI to preview that cache if you want to remove it.</a:t>
             </a:r>
           </a:p>
         </p:txBody>
@@ -3053,101 +3101,19 @@
           <p:cNvPr id="6" name="">
             <a:extLst xmlns:a="http://schemas.openxmlformats.org/drawingml/2006/main">
               <a:ext uri="{FF2B5EF4-FFF2-40B4-BE49-F238E27FC236}">
-                <a16:creationId xmlns:a16="http://schemas.microsoft.com/office/drawing/2014/main" id="{EE024433-C6B9-4E56-BAE9-138F61C2F76E}"/>
-              </a:ext>
-            </a:extLst>
-          </p:cNvPr>
-          <p:cNvSpPr>
-            <a:spLocks xmlns:a="http://schemas.openxmlformats.org/drawingml/2006/main" noGrp="1"/>
-          </p:cNvSpPr>
-          <p:nvPr/>
-        </p:nvSpPr>
-        <p:spPr>
-          <a:xfrm xmlns:a="http://schemas.openxmlformats.org/drawingml/2006/main">
-            <a:off x="609600" y="4638675"/>
-            <a:ext cx="10858500" cy="981075"/>
-          </a:xfrm>
-          <a:prstGeom xmlns:a="http://schemas.openxmlformats.org/drawingml/2006/main" prst="rect">
-            <a:avLst/>
-          </a:prstGeom>
-          <a:noFill xmlns:a="http://schemas.openxmlformats.org/drawingml/2006/main"/>
-          <a:ln xmlns:a="http://schemas.openxmlformats.org/drawingml/2006/main" w="0">
-            <a:noFill/>
-          </a:ln>
-        </p:spPr>
-        <p:txBody>
-          <a:bodyPr xmlns:a="http://schemas.openxmlformats.org/drawingml/2006/main">
-            <a:noAutofit/>
-          </a:bodyPr>
-          <a:lstStyle xmlns:a="http://schemas.openxmlformats.org/drawingml/2006/main"/>
-          <a:p xmlns:a="http://schemas.openxmlformats.org/drawingml/2006/main">
-            <a:pPr>
-              <a:buNone/>
-              <a:defRPr sz="2250" b="0">
-                <a:solidFill>
-                  <a:srgbClr val="283A39"/>
-                </a:solidFill>
-                <a:latin typeface="Arial"/>
-                <a:ea typeface="Arial"/>
-                <a:cs typeface="Arial"/>
-              </a:defRPr>
-            </a:pPr>
-            <a:r>
-              <a:rPr sz="2250" b="0">
-                <a:solidFill>
-                  <a:srgbClr val="283A39"/>
-                </a:solidFill>
-                <a:latin typeface="Arial"/>
-                <a:ea typeface="Arial"/>
-                <a:cs typeface="Arial"/>
-              </a:rPr>
-              <a:t>Explain what you did and what happened at that employer.</a:t>
-            </a:r>
-          </a:p>
-          <a:p xmlns:a="http://schemas.openxmlformats.org/drawingml/2006/main">
-            <a:pPr>
-              <a:buNone/>
-              <a:defRPr sz="2250" b="0">
-                <a:solidFill>
-                  <a:srgbClr val="283A39"/>
-                </a:solidFill>
-                <a:latin typeface="Arial"/>
-                <a:ea typeface="Arial"/>
-                <a:cs typeface="Arial"/>
-              </a:defRPr>
-            </a:pPr>
-            <a:r>
-              <a:rPr sz="2250" b="0">
-                <a:solidFill>
-                  <a:srgbClr val="283A39"/>
-                </a:solidFill>
-                <a:latin typeface="Arial"/>
-                <a:ea typeface="Arial"/>
-                <a:cs typeface="Arial"/>
-              </a:rPr>
-              <a:t>Your saved answers help the AI ask only for missing details.</a:t>
-            </a:r>
-          </a:p>
-        </p:txBody>
-      </p:sp>
-      <p:sp>
-        <p:nvSpPr>
-          <p:cNvPr id="7" name="">
-            <a:extLst xmlns:a="http://schemas.openxmlformats.org/drawingml/2006/main">
-              <a:ext uri="{FF2B5EF4-FFF2-40B4-BE49-F238E27FC236}">
-                <a16:creationId xmlns:a16="http://schemas.microsoft.com/office/drawing/2014/main" id="{67D2DE36-1511-4D12-803A-8078E16A52DA}"/>
-              </a:ext>
-            </a:extLst>
-          </p:cNvPr>
-          <p:cNvSpPr>
-            <a:spLocks xmlns:a="http://schemas.openxmlformats.org/drawingml/2006/main" noGrp="1"/>
-          </p:cNvSpPr>
-          <p:nvPr/>
-        </p:nvSpPr>
-        <p:spPr>
-          <a:xfrm xmlns:a="http://schemas.openxmlformats.org/drawingml/2006/main">
-            <a:off x="609600" y="5819775"/>
-            <a:ext cx="10858500" cy="400050"/>
+                <a16:creationId xmlns:a16="http://schemas.microsoft.com/office/drawing/2014/main" id="{00FB7D96-FFB8-408C-B3BC-1E0EF986C1E5}"/>
+              </a:ext>
+            </a:extLst>
+          </p:cNvPr>
+          <p:cNvSpPr>
+            <a:spLocks xmlns:a="http://schemas.openxmlformats.org/drawingml/2006/main" noGrp="1"/>
+          </p:cNvSpPr>
+          <p:nvPr/>
+        </p:nvSpPr>
+        <p:spPr>
+          <a:xfrm xmlns:a="http://schemas.openxmlformats.org/drawingml/2006/main">
+            <a:off x="609600" y="5905500"/>
+            <a:ext cx="10820400" cy="361950"/>
           </a:xfrm>
           <a:prstGeom xmlns:a="http://schemas.openxmlformats.org/drawingml/2006/main" prst="rect">
             <a:avLst/>
@@ -3183,7 +3149,7 @@
                 <a:ea typeface="Arial"/>
                 <a:cs typeface="Arial"/>
               </a:rPr>
-              <a:t>LinkedIn review follows the fuller interview. Public edits need your approval.</a:t>
+              <a:t>Word uploads also need a DOCX renderer, such as Word or LibreOffice.</a:t>
             </a:r>
           </a:p>
         </p:txBody>
@@ -3191,7 +3157,7 @@
     </p:spTree>
     <p:extLst>
       <p:ext uri="{BB962C8B-B14F-4D97-AF65-F5344CB8AC3E}">
-        <p14:creationId xmlns:p14="http://schemas.microsoft.com/office/powerpoint/2010/main" val="1304459114"/>
+        <p14:creationId xmlns:p14="http://schemas.microsoft.com/office/powerpoint/2010/main" val="687054172"/>
       </p:ext>
     </p:extLst>
   </p:cSld>
@@ -3222,7 +3188,7 @@
           <p:cNvPr id="8" name="">
             <a:extLst xmlns:a="http://schemas.openxmlformats.org/drawingml/2006/main">
               <a:ext uri="{FF2B5EF4-FFF2-40B4-BE49-F238E27FC236}">
-                <a16:creationId xmlns:a16="http://schemas.microsoft.com/office/drawing/2014/main" id="{D1632CCC-FD71-4504-853A-C9EB9DAE7B5F}"/>
+                <a16:creationId xmlns:a16="http://schemas.microsoft.com/office/drawing/2014/main" id="{27C103AD-EB4D-434A-B73C-419B7563C70C}"/>
               </a:ext>
             </a:extLst>
           </p:cNvPr>
@@ -3270,7 +3236,7 @@
                 <a:ea typeface="Arial"/>
                 <a:cs typeface="Arial"/>
               </a:rPr>
-              <a:t>Optional inbox connection</a:t>
+              <a:t>4. A short conversation</a:t>
             </a:r>
           </a:p>
         </p:txBody>
@@ -3280,7 +3246,7 @@
           <p:cNvPr id="2" name="">
             <a:extLst xmlns:a="http://schemas.openxmlformats.org/drawingml/2006/main">
               <a:ext uri="{FF2B5EF4-FFF2-40B4-BE49-F238E27FC236}">
-                <a16:creationId xmlns:a16="http://schemas.microsoft.com/office/drawing/2014/main" id="{29EFFDE2-4509-4A3D-A72F-FA6BA1B867D1}"/>
+                <a16:creationId xmlns:a16="http://schemas.microsoft.com/office/drawing/2014/main" id="{232FA5F9-A6A3-477B-9EBA-BBF63463BB4A}"/>
               </a:ext>
             </a:extLst>
           </p:cNvPr>
@@ -3338,7 +3304,7 @@
           <p:cNvPr id="3" name="">
             <a:extLst xmlns:a="http://schemas.openxmlformats.org/drawingml/2006/main">
               <a:ext uri="{FF2B5EF4-FFF2-40B4-BE49-F238E27FC236}">
-                <a16:creationId xmlns:a16="http://schemas.microsoft.com/office/drawing/2014/main" id="{1612BF25-0EE9-4613-BBAC-00A0BC3C8C6B}"/>
+                <a16:creationId xmlns:a16="http://schemas.microsoft.com/office/drawing/2014/main" id="{BF0FE3D5-F5A3-4B6A-AB57-61921D531F29}"/>
               </a:ext>
             </a:extLst>
           </p:cNvPr>
@@ -3350,7 +3316,7 @@
         <p:spPr>
           <a:xfrm xmlns:a="http://schemas.openxmlformats.org/drawingml/2006/main">
             <a:off x="609600" y="1447800"/>
-            <a:ext cx="10820400" cy="857250"/>
+            <a:ext cx="10820400" cy="647700"/>
           </a:xfrm>
           <a:prstGeom xmlns:a="http://schemas.openxmlformats.org/drawingml/2006/main" prst="rect">
             <a:avLst/>
@@ -3386,9 +3352,183 @@
                 <a:ea typeface="Arial"/>
                 <a:cs typeface="Arial"/>
               </a:rPr>
-              <a:t>a. Confirm the email you use for applications.</a:t>
-            </a:r>
-          </a:p>
+              <a:t>The AI saves each question, asks it, and waits for your answer.</a:t>
+            </a:r>
+          </a:p>
+        </p:txBody>
+      </p:sp>
+      <p:sp>
+        <p:nvSpPr>
+          <p:cNvPr id="4" name="">
+            <a:extLst xmlns:a="http://schemas.openxmlformats.org/drawingml/2006/main">
+              <a:ext uri="{FF2B5EF4-FFF2-40B4-BE49-F238E27FC236}">
+                <a16:creationId xmlns:a16="http://schemas.microsoft.com/office/drawing/2014/main" id="{57106B18-7355-4368-A961-3F52136F9D3D}"/>
+              </a:ext>
+            </a:extLst>
+          </p:cNvPr>
+          <p:cNvSpPr>
+            <a:spLocks xmlns:a="http://schemas.openxmlformats.org/drawingml/2006/main" noGrp="1"/>
+          </p:cNvSpPr>
+          <p:nvPr/>
+        </p:nvSpPr>
+        <p:spPr>
+          <a:xfrm xmlns:a="http://schemas.openxmlformats.org/drawingml/2006/main">
+            <a:off x="609600" y="2524125"/>
+            <a:ext cx="10858500" cy="438150"/>
+          </a:xfrm>
+          <a:prstGeom xmlns:a="http://schemas.openxmlformats.org/drawingml/2006/main" prst="rect">
+            <a:avLst/>
+          </a:prstGeom>
+          <a:noFill xmlns:a="http://schemas.openxmlformats.org/drawingml/2006/main"/>
+          <a:ln xmlns:a="http://schemas.openxmlformats.org/drawingml/2006/main" w="0">
+            <a:noFill/>
+          </a:ln>
+        </p:spPr>
+        <p:txBody>
+          <a:bodyPr xmlns:a="http://schemas.openxmlformats.org/drawingml/2006/main">
+            <a:noAutofit/>
+          </a:bodyPr>
+          <a:lstStyle xmlns:a="http://schemas.openxmlformats.org/drawingml/2006/main"/>
+          <a:p xmlns:a="http://schemas.openxmlformats.org/drawingml/2006/main">
+            <a:pPr>
+              <a:buNone/>
+              <a:defRPr sz="1875" b="1">
+                <a:solidFill>
+                  <a:srgbClr val="087F73"/>
+                </a:solidFill>
+                <a:latin typeface="Arial"/>
+                <a:ea typeface="Arial"/>
+                <a:cs typeface="Arial"/>
+              </a:defRPr>
+            </a:pPr>
+            <a:r>
+              <a:rPr sz="1875" b="1">
+                <a:solidFill>
+                  <a:srgbClr val="087F73"/>
+                </a:solidFill>
+                <a:latin typeface="Arial"/>
+                <a:ea typeface="Arial"/>
+                <a:cs typeface="Arial"/>
+              </a:rPr>
+              <a:t>Example: Cedar Clinic, Office Assistant, 2022-2024</a:t>
+            </a:r>
+          </a:p>
+        </p:txBody>
+      </p:sp>
+      <p:sp>
+        <p:nvSpPr>
+          <p:cNvPr id="5" name="">
+            <a:extLst xmlns:a="http://schemas.openxmlformats.org/drawingml/2006/main">
+              <a:ext uri="{FF2B5EF4-FFF2-40B4-BE49-F238E27FC236}">
+                <a16:creationId xmlns:a16="http://schemas.microsoft.com/office/drawing/2014/main" id="{8C3397D8-E2CE-4211-93DF-B7218A1DCBA6}"/>
+              </a:ext>
+            </a:extLst>
+          </p:cNvPr>
+          <p:cNvSpPr>
+            <a:spLocks xmlns:a="http://schemas.openxmlformats.org/drawingml/2006/main" noGrp="1"/>
+          </p:cNvSpPr>
+          <p:nvPr/>
+        </p:nvSpPr>
+        <p:spPr>
+          <a:xfrm xmlns:a="http://schemas.openxmlformats.org/drawingml/2006/main">
+            <a:off x="609600" y="3114675"/>
+            <a:ext cx="10858500" cy="1143000"/>
+          </a:xfrm>
+          <a:prstGeom xmlns:a="http://schemas.openxmlformats.org/drawingml/2006/main" prst="rect">
+            <a:avLst/>
+          </a:prstGeom>
+          <a:noFill xmlns:a="http://schemas.openxmlformats.org/drawingml/2006/main"/>
+          <a:ln xmlns:a="http://schemas.openxmlformats.org/drawingml/2006/main" w="0">
+            <a:noFill/>
+          </a:ln>
+        </p:spPr>
+        <p:txBody>
+          <a:bodyPr xmlns:a="http://schemas.openxmlformats.org/drawingml/2006/main">
+            <a:noAutofit/>
+          </a:bodyPr>
+          <a:lstStyle xmlns:a="http://schemas.openxmlformats.org/drawingml/2006/main"/>
+          <a:p xmlns:a="http://schemas.openxmlformats.org/drawingml/2006/main">
+            <a:pPr>
+              <a:buNone/>
+              <a:defRPr sz="2700" b="0">
+                <a:solidFill>
+                  <a:srgbClr val="183F3B"/>
+                </a:solidFill>
+                <a:latin typeface="Arial"/>
+                <a:ea typeface="Arial"/>
+                <a:cs typeface="Arial"/>
+              </a:defRPr>
+            </a:pPr>
+            <a:r>
+              <a:rPr sz="2700" b="0">
+                <a:solidFill>
+                  <a:srgbClr val="183F3B"/>
+                </a:solidFill>
+                <a:latin typeface="Arial"/>
+                <a:ea typeface="Arial"/>
+                <a:cs typeface="Arial"/>
+              </a:rPr>
+              <a:t>“At Cedar Clinic, tell me about one scheduling</a:t>
+            </a:r>
+          </a:p>
+          <a:p xmlns:a="http://schemas.openxmlformats.org/drawingml/2006/main">
+            <a:pPr>
+              <a:buNone/>
+              <a:defRPr sz="2700" b="0">
+                <a:solidFill>
+                  <a:srgbClr val="183F3B"/>
+                </a:solidFill>
+                <a:latin typeface="Arial"/>
+                <a:ea typeface="Arial"/>
+                <a:cs typeface="Arial"/>
+              </a:defRPr>
+            </a:pPr>
+            <a:r>
+              <a:rPr sz="2700" b="0">
+                <a:solidFill>
+                  <a:srgbClr val="183F3B"/>
+                </a:solidFill>
+                <a:latin typeface="Arial"/>
+                <a:ea typeface="Arial"/>
+                <a:cs typeface="Arial"/>
+              </a:rPr>
+              <a:t>problem you handled as an office assistant.”</a:t>
+            </a:r>
+          </a:p>
+        </p:txBody>
+      </p:sp>
+      <p:sp>
+        <p:nvSpPr>
+          <p:cNvPr id="6" name="">
+            <a:extLst xmlns:a="http://schemas.openxmlformats.org/drawingml/2006/main">
+              <a:ext uri="{FF2B5EF4-FFF2-40B4-BE49-F238E27FC236}">
+                <a16:creationId xmlns:a16="http://schemas.microsoft.com/office/drawing/2014/main" id="{EE024433-C6B9-4E56-BAE9-138F61C2F76E}"/>
+              </a:ext>
+            </a:extLst>
+          </p:cNvPr>
+          <p:cNvSpPr>
+            <a:spLocks xmlns:a="http://schemas.openxmlformats.org/drawingml/2006/main" noGrp="1"/>
+          </p:cNvSpPr>
+          <p:nvPr/>
+        </p:nvSpPr>
+        <p:spPr>
+          <a:xfrm xmlns:a="http://schemas.openxmlformats.org/drawingml/2006/main">
+            <a:off x="609600" y="4638675"/>
+            <a:ext cx="10858500" cy="981075"/>
+          </a:xfrm>
+          <a:prstGeom xmlns:a="http://schemas.openxmlformats.org/drawingml/2006/main" prst="rect">
+            <a:avLst/>
+          </a:prstGeom>
+          <a:noFill xmlns:a="http://schemas.openxmlformats.org/drawingml/2006/main"/>
+          <a:ln xmlns:a="http://schemas.openxmlformats.org/drawingml/2006/main" w="0">
+            <a:noFill/>
+          </a:ln>
+        </p:spPr>
+        <p:txBody>
+          <a:bodyPr xmlns:a="http://schemas.openxmlformats.org/drawingml/2006/main">
+            <a:noAutofit/>
+          </a:bodyPr>
+          <a:lstStyle xmlns:a="http://schemas.openxmlformats.org/drawingml/2006/main"/>
           <a:p xmlns:a="http://schemas.openxmlformats.org/drawingml/2006/main">
             <a:pPr>
               <a:buNone/>
@@ -3410,43 +3550,9 @@
                 <a:ea typeface="Arial"/>
                 <a:cs typeface="Arial"/>
               </a:rPr>
-              <a:t>    Choose whether the AI may check job-related replies.</a:t>
-            </a:r>
-          </a:p>
-        </p:txBody>
-      </p:sp>
-      <p:sp>
-        <p:nvSpPr>
-          <p:cNvPr id="4" name="">
-            <a:extLst xmlns:a="http://schemas.openxmlformats.org/drawingml/2006/main">
-              <a:ext uri="{FF2B5EF4-FFF2-40B4-BE49-F238E27FC236}">
-                <a16:creationId xmlns:a16="http://schemas.microsoft.com/office/drawing/2014/main" id="{D93E2548-3FF7-4C80-83C0-4FDDB420C0C6}"/>
-              </a:ext>
-            </a:extLst>
-          </p:cNvPr>
-          <p:cNvSpPr>
-            <a:spLocks xmlns:a="http://schemas.openxmlformats.org/drawingml/2006/main" noGrp="1"/>
-          </p:cNvSpPr>
-          <p:nvPr/>
-        </p:nvSpPr>
-        <p:spPr>
-          <a:xfrm xmlns:a="http://schemas.openxmlformats.org/drawingml/2006/main">
-            <a:off x="609600" y="2686050"/>
-            <a:ext cx="10820400" cy="857250"/>
-          </a:xfrm>
-          <a:prstGeom xmlns:a="http://schemas.openxmlformats.org/drawingml/2006/main" prst="rect">
-            <a:avLst/>
-          </a:prstGeom>
-          <a:noFill xmlns:a="http://schemas.openxmlformats.org/drawingml/2006/main"/>
-          <a:ln xmlns:a="http://schemas.openxmlformats.org/drawingml/2006/main" w="0">
-            <a:noFill/>
-          </a:ln>
-        </p:spPr>
-        <p:txBody>
-          <a:bodyPr xmlns:a="http://schemas.openxmlformats.org/drawingml/2006/main">
-            <a:noAutofit/>
-          </a:bodyPr>
-          <a:lstStyle xmlns:a="http://schemas.openxmlformats.org/drawingml/2006/main"/>
+              <a:t>Explain what you did and what happened at that employer.</a:t>
+            </a:r>
+          </a:p>
           <a:p xmlns:a="http://schemas.openxmlformats.org/drawingml/2006/main">
             <a:pPr>
               <a:buNone/>
@@ -3468,135 +3574,29 @@
                 <a:ea typeface="Arial"/>
                 <a:cs typeface="Arial"/>
               </a:rPr>
-              <a:t>b. When prompted, connect Gmail in your AI app.</a:t>
-            </a:r>
-          </a:p>
-          <a:p xmlns:a="http://schemas.openxmlformats.org/drawingml/2006/main">
-            <a:pPr>
-              <a:buNone/>
-              <a:defRPr sz="2250" b="0">
-                <a:solidFill>
-                  <a:srgbClr val="283A39"/>
-                </a:solidFill>
-                <a:latin typeface="Arial"/>
-                <a:ea typeface="Arial"/>
-                <a:cs typeface="Arial"/>
-              </a:defRPr>
-            </a:pPr>
-            <a:r>
-              <a:rPr sz="2250" b="0">
-                <a:solidFill>
-                  <a:srgbClr val="283A39"/>
-                </a:solidFill>
-                <a:latin typeface="Arial"/>
-                <a:ea typeface="Arial"/>
-                <a:cs typeface="Arial"/>
-              </a:rPr>
-              <a:t>    Sign in to the Google account you chose.</a:t>
-            </a:r>
-          </a:p>
-        </p:txBody>
-      </p:sp>
-      <p:sp>
-        <p:nvSpPr>
-          <p:cNvPr id="5" name="">
-            <a:extLst xmlns:a="http://schemas.openxmlformats.org/drawingml/2006/main">
-              <a:ext uri="{FF2B5EF4-FFF2-40B4-BE49-F238E27FC236}">
-                <a16:creationId xmlns:a16="http://schemas.microsoft.com/office/drawing/2014/main" id="{15D3C5B8-3795-4CC8-8FA5-368D64F42A0D}"/>
-              </a:ext>
-            </a:extLst>
-          </p:cNvPr>
-          <p:cNvSpPr>
-            <a:spLocks xmlns:a="http://schemas.openxmlformats.org/drawingml/2006/main" noGrp="1"/>
-          </p:cNvSpPr>
-          <p:nvPr/>
-        </p:nvSpPr>
-        <p:spPr>
-          <a:xfrm xmlns:a="http://schemas.openxmlformats.org/drawingml/2006/main">
-            <a:off x="609600" y="3924300"/>
-            <a:ext cx="10820400" cy="857250"/>
-          </a:xfrm>
-          <a:prstGeom xmlns:a="http://schemas.openxmlformats.org/drawingml/2006/main" prst="rect">
-            <a:avLst/>
-          </a:prstGeom>
-          <a:noFill xmlns:a="http://schemas.openxmlformats.org/drawingml/2006/main"/>
-          <a:ln xmlns:a="http://schemas.openxmlformats.org/drawingml/2006/main" w="0">
-            <a:noFill/>
-          </a:ln>
-        </p:spPr>
-        <p:txBody>
-          <a:bodyPr xmlns:a="http://schemas.openxmlformats.org/drawingml/2006/main">
-            <a:noAutofit/>
-          </a:bodyPr>
-          <a:lstStyle xmlns:a="http://schemas.openxmlformats.org/drawingml/2006/main"/>
-          <a:p xmlns:a="http://schemas.openxmlformats.org/drawingml/2006/main">
-            <a:pPr>
-              <a:buNone/>
-              <a:defRPr sz="2250" b="0">
-                <a:solidFill>
-                  <a:srgbClr val="283A39"/>
-                </a:solidFill>
-                <a:latin typeface="Arial"/>
-                <a:ea typeface="Arial"/>
-                <a:cs typeface="Arial"/>
-              </a:defRPr>
-            </a:pPr>
-            <a:r>
-              <a:rPr sz="2250" b="0">
-                <a:solidFill>
-                  <a:srgbClr val="283A39"/>
-                </a:solidFill>
-                <a:latin typeface="Arial"/>
-                <a:ea typeface="Arial"/>
-                <a:cs typeface="Arial"/>
-              </a:rPr>
-              <a:t>c. The AI checks the connected address and read access.</a:t>
-            </a:r>
-          </a:p>
-          <a:p xmlns:a="http://schemas.openxmlformats.org/drawingml/2006/main">
-            <a:pPr>
-              <a:buNone/>
-              <a:defRPr sz="2250" b="0">
-                <a:solidFill>
-                  <a:srgbClr val="283A39"/>
-                </a:solidFill>
-                <a:latin typeface="Arial"/>
-                <a:ea typeface="Arial"/>
-                <a:cs typeface="Arial"/>
-              </a:defRPr>
-            </a:pPr>
-            <a:r>
-              <a:rPr sz="2250" b="0">
-                <a:solidFill>
-                  <a:srgbClr val="283A39"/>
-                </a:solidFill>
-                <a:latin typeface="Arial"/>
-                <a:ea typeface="Arial"/>
-                <a:cs typeface="Arial"/>
-              </a:rPr>
-              <a:t>    It waits if the account is wrong or unavailable.</a:t>
-            </a:r>
-          </a:p>
-        </p:txBody>
-      </p:sp>
-      <p:sp>
-        <p:nvSpPr>
-          <p:cNvPr id="6" name="">
-            <a:extLst xmlns:a="http://schemas.openxmlformats.org/drawingml/2006/main">
-              <a:ext uri="{FF2B5EF4-FFF2-40B4-BE49-F238E27FC236}">
-                <a16:creationId xmlns:a16="http://schemas.microsoft.com/office/drawing/2014/main" id="{499F2DAF-5D76-4075-B729-3E8C8ADD43E1}"/>
-              </a:ext>
-            </a:extLst>
-          </p:cNvPr>
-          <p:cNvSpPr>
-            <a:spLocks xmlns:a="http://schemas.openxmlformats.org/drawingml/2006/main" noGrp="1"/>
-          </p:cNvSpPr>
-          <p:nvPr/>
-        </p:nvSpPr>
-        <p:spPr>
-          <a:xfrm xmlns:a="http://schemas.openxmlformats.org/drawingml/2006/main">
-            <a:off x="609600" y="5219700"/>
-            <a:ext cx="10820400" cy="723900"/>
+              <a:t>Your saved answers help the AI ask only for missing details.</a:t>
+            </a:r>
+          </a:p>
+        </p:txBody>
+      </p:sp>
+      <p:sp>
+        <p:nvSpPr>
+          <p:cNvPr id="7" name="">
+            <a:extLst xmlns:a="http://schemas.openxmlformats.org/drawingml/2006/main">
+              <a:ext uri="{FF2B5EF4-FFF2-40B4-BE49-F238E27FC236}">
+                <a16:creationId xmlns:a16="http://schemas.microsoft.com/office/drawing/2014/main" id="{67D2DE36-1511-4D12-803A-8078E16A52DA}"/>
+              </a:ext>
+            </a:extLst>
+          </p:cNvPr>
+          <p:cNvSpPr>
+            <a:spLocks xmlns:a="http://schemas.openxmlformats.org/drawingml/2006/main" noGrp="1"/>
+          </p:cNvSpPr>
+          <p:nvPr/>
+        </p:nvSpPr>
+        <p:spPr>
+          <a:xfrm xmlns:a="http://schemas.openxmlformats.org/drawingml/2006/main">
+            <a:off x="609600" y="5819775"/>
+            <a:ext cx="10858500" cy="400050"/>
           </a:xfrm>
           <a:prstGeom xmlns:a="http://schemas.openxmlformats.org/drawingml/2006/main" prst="rect">
             <a:avLst/>
@@ -3632,90 +3632,7 @@
                 <a:ea typeface="Arial"/>
                 <a:cs typeface="Arial"/>
               </a:rPr>
-              <a:t>You can choose no or later and still prepare resumes and find jobs.</a:t>
-            </a:r>
-          </a:p>
-          <a:p xmlns:a="http://schemas.openxmlformats.org/drawingml/2006/main">
-            <a:pPr>
-              <a:buNone/>
-              <a:defRPr sz="1800" b="0">
-                <a:solidFill>
-                  <a:srgbClr val="607370"/>
-                </a:solidFill>
-                <a:latin typeface="Arial"/>
-                <a:ea typeface="Arial"/>
-                <a:cs typeface="Arial"/>
-              </a:defRPr>
-            </a:pPr>
-            <a:r>
-              <a:rPr sz="1800" b="0">
-                <a:solidFill>
-                  <a:srgbClr val="607370"/>
-                </a:solidFill>
-                <a:latin typeface="Arial"/>
-                <a:ea typeface="Arial"/>
-                <a:cs typeface="Arial"/>
-              </a:rPr>
-              <a:t>Sending email and changing your calendar need separate permission.</a:t>
-            </a:r>
-          </a:p>
-        </p:txBody>
-      </p:sp>
-      <p:sp>
-        <p:nvSpPr>
-          <p:cNvPr id="7" name="">
-            <a:extLst xmlns:a="http://schemas.openxmlformats.org/drawingml/2006/main">
-              <a:ext uri="{FF2B5EF4-FFF2-40B4-BE49-F238E27FC236}">
-                <a16:creationId xmlns:a16="http://schemas.microsoft.com/office/drawing/2014/main" id="{EAF2EA42-DEE2-4D4C-AEB4-EA109E27A622}"/>
-              </a:ext>
-            </a:extLst>
-          </p:cNvPr>
-          <p:cNvSpPr>
-            <a:spLocks xmlns:a="http://schemas.openxmlformats.org/drawingml/2006/main" noGrp="1"/>
-          </p:cNvSpPr>
-          <p:nvPr/>
-        </p:nvSpPr>
-        <p:spPr>
-          <a:xfrm xmlns:a="http://schemas.openxmlformats.org/drawingml/2006/main">
-            <a:off x="609600" y="6038850"/>
-            <a:ext cx="10001250" cy="333375"/>
-          </a:xfrm>
-          <a:prstGeom xmlns:a="http://schemas.openxmlformats.org/drawingml/2006/main" prst="rect">
-            <a:avLst/>
-          </a:prstGeom>
-          <a:noFill xmlns:a="http://schemas.openxmlformats.org/drawingml/2006/main"/>
-          <a:ln xmlns:a="http://schemas.openxmlformats.org/drawingml/2006/main" w="0">
-            <a:noFill/>
-          </a:ln>
-        </p:spPr>
-        <p:txBody>
-          <a:bodyPr xmlns:a="http://schemas.openxmlformats.org/drawingml/2006/main">
-            <a:noAutofit/>
-          </a:bodyPr>
-          <a:lstStyle xmlns:a="http://schemas.openxmlformats.org/drawingml/2006/main"/>
-          <a:p xmlns:a="http://schemas.openxmlformats.org/drawingml/2006/main">
-            <a:pPr>
-              <a:buNone/>
-              <a:defRPr sz="1800" b="0">
-                <a:solidFill>
-                  <a:srgbClr val="087F73"/>
-                </a:solidFill>
-                <a:latin typeface="Arial"/>
-                <a:ea typeface="Arial"/>
-                <a:cs typeface="Arial"/>
-              </a:defRPr>
-            </a:pPr>
-            <a:r>
-              <a:rPr sz="1800" b="0">
-                <a:solidFill>
-                  <a:srgbClr val="087F73"/>
-                </a:solidFill>
-                <a:latin typeface="Arial"/>
-                <a:ea typeface="Arial"/>
-                <a:cs typeface="Arial"/>
-                <a:hlinkClick xmlns:r="http://schemas.openxmlformats.org/officeDocument/2006/relationships" r:id="Raad4acad6e9d47c4"/>
-              </a:rPr>
-              <a:t>Detailed connection steps</a:t>
+              <a:t>LinkedIn review follows the fuller interview. Public edits need your approval.</a:t>
             </a:r>
           </a:p>
         </p:txBody>
@@ -3723,7 +3640,7 @@
     </p:spTree>
     <p:extLst>
       <p:ext uri="{BB962C8B-B14F-4D97-AF65-F5344CB8AC3E}">
-        <p14:creationId xmlns:p14="http://schemas.microsoft.com/office/powerpoint/2010/main" val="247586683"/>
+        <p14:creationId xmlns:p14="http://schemas.microsoft.com/office/powerpoint/2010/main" val="1304459114"/>
       </p:ext>
     </p:extLst>
   </p:cSld>
@@ -4622,7 +4539,7 @@
                 <a:latin typeface="Arial"/>
                 <a:ea typeface="Arial"/>
                 <a:cs typeface="Arial"/>
-                <a:hlinkClick xmlns:r="http://schemas.openxmlformats.org/officeDocument/2006/relationships" r:id="Rb95c5e9ef9a24d77"/>
+                <a:hlinkClick xmlns:r="http://schemas.openxmlformats.org/officeDocument/2006/relationships" r:id="Rec68d649ab3540a6"/>
               </a:rPr>
               <a:t>Read the daily-search guide</a:t>
             </a:r>
@@ -7110,7 +7027,7 @@
                 <a:latin typeface="Arial"/>
                 <a:ea typeface="Arial"/>
                 <a:cs typeface="Arial"/>
-                <a:hlinkClick xmlns:r="http://schemas.openxmlformats.org/officeDocument/2006/relationships" r:id="Rd9ed38d3b5b04118"/>
+                <a:hlinkClick xmlns:r="http://schemas.openxmlformats.org/officeDocument/2006/relationships" r:id="R916aca7707b14be6"/>
               </a:rPr>
               <a:t>Full guide, downloads and troubleshooting</a:t>
             </a:r>
@@ -7512,7 +7429,7 @@
                 <a:latin typeface="Arial"/>
                 <a:ea typeface="Arial"/>
                 <a:cs typeface="Arial"/>
-                <a:hlinkClick xmlns:r="http://schemas.openxmlformats.org/officeDocument/2006/relationships" r:id="R7cd878be02134319"/>
+                <a:hlinkClick xmlns:r="http://schemas.openxmlformats.org/officeDocument/2006/relationships" r:id="Rcb85ead5ebb948fe"/>
               </a:rPr>
               <a:t>Mac download page (Apple Silicon)</a:t>
             </a:r>
@@ -7571,7 +7488,7 @@
                 <a:latin typeface="Arial"/>
                 <a:ea typeface="Arial"/>
                 <a:cs typeface="Arial"/>
-                <a:hlinkClick xmlns:r="http://schemas.openxmlformats.org/officeDocument/2006/relationships" r:id="Rcedf7c26fbd24463"/>
+                <a:hlinkClick xmlns:r="http://schemas.openxmlformats.org/officeDocument/2006/relationships" r:id="R864dd0a8eadc40bf"/>
               </a:rPr>
               <a:t>Windows download page</a:t>
             </a:r>
@@ -7770,7 +7687,7 @@
                 <a:latin typeface="Arial"/>
                 <a:ea typeface="Arial"/>
                 <a:cs typeface="Arial"/>
-                <a:hlinkClick xmlns:r="http://schemas.openxmlformats.org/officeDocument/2006/relationships" r:id="R9ab04cfcd8224a39"/>
+                <a:hlinkClick xmlns:r="http://schemas.openxmlformats.org/officeDocument/2006/relationships" r:id="R855f25fbe53a491c"/>
               </a:rPr>
               <a:t>Mac or Windows downloads</a:t>
             </a:r>
@@ -7829,7 +7746,7 @@
                 <a:latin typeface="Arial"/>
                 <a:ea typeface="Arial"/>
                 <a:cs typeface="Arial"/>
-                <a:hlinkClick xmlns:r="http://schemas.openxmlformats.org/officeDocument/2006/relationships" r:id="R466cf817e0c8449e"/>
+                <a:hlinkClick xmlns:r="http://schemas.openxmlformats.org/officeDocument/2006/relationships" r:id="R176b05cf142a4031"/>
               </a:rPr>
               <a:t>Claude Code setup and account requirements</a:t>
             </a:r>
@@ -8106,7 +8023,7 @@
           <p:nvPr/>
         </p:nvPicPr>
         <p:blipFill>
-          <a:blip xmlns:r="http://schemas.openxmlformats.org/officeDocument/2006/relationships" xmlns:a="http://schemas.openxmlformats.org/drawingml/2006/main" r:embed="Raf19363e43984e07"/>
+          <a:blip xmlns:r="http://schemas.openxmlformats.org/officeDocument/2006/relationships" xmlns:a="http://schemas.openxmlformats.org/drawingml/2006/main" r:embed="Rb98bd4a76cbd4868"/>
           <a:stretch xmlns:a="http://schemas.openxmlformats.org/drawingml/2006/main"/>
         </p:blipFill>
         <p:spPr>
@@ -8649,7 +8566,7 @@
           <p:nvPr/>
         </p:nvPicPr>
         <p:blipFill>
-          <a:blip xmlns:r="http://schemas.openxmlformats.org/officeDocument/2006/relationships" xmlns:a="http://schemas.openxmlformats.org/drawingml/2006/main" r:embed="Rd3770f40b2c04c22"/>
+          <a:blip xmlns:r="http://schemas.openxmlformats.org/officeDocument/2006/relationships" xmlns:a="http://schemas.openxmlformats.org/drawingml/2006/main" r:embed="R5918c561e7e34f9f"/>
           <a:stretch xmlns:a="http://schemas.openxmlformats.org/drawingml/2006/main"/>
         </p:blipFill>
         <p:spPr>
@@ -8956,7 +8873,7 @@
           <p:nvPr/>
         </p:nvPicPr>
         <p:blipFill>
-          <a:blip xmlns:r="http://schemas.openxmlformats.org/officeDocument/2006/relationships" xmlns:a="http://schemas.openxmlformats.org/drawingml/2006/main" r:embed="R991988b6d2a74da9"/>
+          <a:blip xmlns:r="http://schemas.openxmlformats.org/officeDocument/2006/relationships" xmlns:a="http://schemas.openxmlformats.org/drawingml/2006/main" r:embed="Rbf890529fca54db4"/>
           <a:stretch xmlns:a="http://schemas.openxmlformats.org/drawingml/2006/main"/>
         </p:blipFill>
         <p:spPr>
@@ -9263,7 +9180,7 @@
           <p:nvPr/>
         </p:nvPicPr>
         <p:blipFill>
-          <a:blip xmlns:r="http://schemas.openxmlformats.org/officeDocument/2006/relationships" xmlns:a="http://schemas.openxmlformats.org/drawingml/2006/main" r:embed="Ra883ebb8df5242e8"/>
+          <a:blip xmlns:r="http://schemas.openxmlformats.org/officeDocument/2006/relationships" xmlns:a="http://schemas.openxmlformats.org/drawingml/2006/main" r:embed="Rbde02e4cec8b45df"/>
           <a:stretch xmlns:a="http://schemas.openxmlformats.org/drawingml/2006/main"/>
         </p:blipFill>
         <p:spPr>
@@ -9392,7 +9309,7 @@
           <p:cNvPr id="8" name="">
             <a:extLst xmlns:a="http://schemas.openxmlformats.org/drawingml/2006/main">
               <a:ext uri="{FF2B5EF4-FFF2-40B4-BE49-F238E27FC236}">
-                <a16:creationId xmlns:a16="http://schemas.microsoft.com/office/drawing/2014/main" id="{899873CB-E3FF-4A32-8D3D-52B39D02A7B1}"/>
+                <a16:creationId xmlns:a16="http://schemas.microsoft.com/office/drawing/2014/main" id="{D1632CCC-FD71-4504-853A-C9EB9DAE7B5F}"/>
               </a:ext>
             </a:extLst>
           </p:cNvPr>
@@ -9440,7 +9357,7 @@
                 <a:ea typeface="Arial"/>
                 <a:cs typeface="Arial"/>
               </a:rPr>
-              <a:t>2. Your resume</a:t>
+              <a:t>Optional: connect Gmail first</a:t>
             </a:r>
           </a:p>
         </p:txBody>
@@ -9450,7 +9367,7 @@
           <p:cNvPr id="2" name="">
             <a:extLst xmlns:a="http://schemas.openxmlformats.org/drawingml/2006/main">
               <a:ext uri="{FF2B5EF4-FFF2-40B4-BE49-F238E27FC236}">
-                <a16:creationId xmlns:a16="http://schemas.microsoft.com/office/drawing/2014/main" id="{FE647B76-A8C3-4FC0-B7CB-B5330DDAADA8}"/>
+                <a16:creationId xmlns:a16="http://schemas.microsoft.com/office/drawing/2014/main" id="{29EFFDE2-4509-4A3D-A72F-FA6BA1B867D1}"/>
               </a:ext>
             </a:extLst>
           </p:cNvPr>
@@ -9508,55 +9425,79 @@
           <p:cNvPr id="3" name="">
             <a:extLst xmlns:a="http://schemas.openxmlformats.org/drawingml/2006/main">
               <a:ext uri="{FF2B5EF4-FFF2-40B4-BE49-F238E27FC236}">
-                <a16:creationId xmlns:a16="http://schemas.microsoft.com/office/drawing/2014/main" id="{7A5FD4D7-2672-4A13-9C62-3CC32FC98263}"/>
-              </a:ext>
-            </a:extLst>
-          </p:cNvPr>
-          <p:cNvSpPr>
-            <a:spLocks xmlns:a="http://schemas.openxmlformats.org/drawingml/2006/main" noGrp="1"/>
-          </p:cNvSpPr>
-          <p:nvPr/>
-        </p:nvSpPr>
-        <p:spPr>
-          <a:xfrm xmlns:a="http://schemas.openxmlformats.org/drawingml/2006/main">
-            <a:off x="609600" y="1524000"/>
-            <a:ext cx="10477500" cy="457200"/>
-          </a:xfrm>
-          <a:prstGeom xmlns:a="http://schemas.openxmlformats.org/drawingml/2006/main" prst="rect">
-            <a:avLst/>
-          </a:prstGeom>
-          <a:noFill xmlns:a="http://schemas.openxmlformats.org/drawingml/2006/main"/>
-          <a:ln xmlns:a="http://schemas.openxmlformats.org/drawingml/2006/main" w="0">
-            <a:noFill/>
-          </a:ln>
-        </p:spPr>
-        <p:txBody>
-          <a:bodyPr xmlns:a="http://schemas.openxmlformats.org/drawingml/2006/main">
-            <a:noAutofit/>
-          </a:bodyPr>
-          <a:lstStyle xmlns:a="http://schemas.openxmlformats.org/drawingml/2006/main"/>
-          <a:p xmlns:a="http://schemas.openxmlformats.org/drawingml/2006/main">
-            <a:pPr>
-              <a:buNone/>
-              <a:defRPr sz="2550" b="1">
-                <a:solidFill>
-                  <a:srgbClr val="183F3B"/>
-                </a:solidFill>
-                <a:latin typeface="Arial"/>
-                <a:ea typeface="Arial"/>
-                <a:cs typeface="Arial"/>
-              </a:defRPr>
-            </a:pPr>
-            <a:r>
-              <a:rPr sz="2550" b="1">
-                <a:solidFill>
-                  <a:srgbClr val="183F3B"/>
-                </a:solidFill>
-                <a:latin typeface="Arial"/>
-                <a:ea typeface="Arial"/>
-                <a:cs typeface="Arial"/>
-              </a:rPr>
-              <a:t>If you have one</a:t>
+                <a16:creationId xmlns:a16="http://schemas.microsoft.com/office/drawing/2014/main" id="{1612BF25-0EE9-4613-BBAC-00A0BC3C8C6B}"/>
+              </a:ext>
+            </a:extLst>
+          </p:cNvPr>
+          <p:cNvSpPr>
+            <a:spLocks xmlns:a="http://schemas.openxmlformats.org/drawingml/2006/main" noGrp="1"/>
+          </p:cNvSpPr>
+          <p:nvPr/>
+        </p:nvSpPr>
+        <p:spPr>
+          <a:xfrm xmlns:a="http://schemas.openxmlformats.org/drawingml/2006/main">
+            <a:off x="609600" y="1447800"/>
+            <a:ext cx="10820400" cy="857250"/>
+          </a:xfrm>
+          <a:prstGeom xmlns:a="http://schemas.openxmlformats.org/drawingml/2006/main" prst="rect">
+            <a:avLst/>
+          </a:prstGeom>
+          <a:noFill xmlns:a="http://schemas.openxmlformats.org/drawingml/2006/main"/>
+          <a:ln xmlns:a="http://schemas.openxmlformats.org/drawingml/2006/main" w="0">
+            <a:noFill/>
+          </a:ln>
+        </p:spPr>
+        <p:txBody>
+          <a:bodyPr xmlns:a="http://schemas.openxmlformats.org/drawingml/2006/main">
+            <a:noAutofit/>
+          </a:bodyPr>
+          <a:lstStyle xmlns:a="http://schemas.openxmlformats.org/drawingml/2006/main"/>
+          <a:p xmlns:a="http://schemas.openxmlformats.org/drawingml/2006/main">
+            <a:pPr>
+              <a:buNone/>
+              <a:defRPr sz="2250" b="0">
+                <a:solidFill>
+                  <a:srgbClr val="283A39"/>
+                </a:solidFill>
+                <a:latin typeface="Arial"/>
+                <a:ea typeface="Arial"/>
+                <a:cs typeface="Arial"/>
+              </a:defRPr>
+            </a:pPr>
+            <a:r>
+              <a:rPr sz="2250" b="0">
+                <a:solidFill>
+                  <a:srgbClr val="283A39"/>
+                </a:solidFill>
+                <a:latin typeface="Arial"/>
+                <a:ea typeface="Arial"/>
+                <a:cs typeface="Arial"/>
+              </a:rPr>
+              <a:t>a. Before your first message, connect Gmail for inbox help.</a:t>
+            </a:r>
+          </a:p>
+          <a:p xmlns:a="http://schemas.openxmlformats.org/drawingml/2006/main">
+            <a:pPr>
+              <a:buNone/>
+              <a:defRPr sz="2250" b="0">
+                <a:solidFill>
+                  <a:srgbClr val="283A39"/>
+                </a:solidFill>
+                <a:latin typeface="Arial"/>
+                <a:ea typeface="Arial"/>
+                <a:cs typeface="Arial"/>
+              </a:defRPr>
+            </a:pPr>
+            <a:r>
+              <a:rPr sz="2250" b="0">
+                <a:solidFill>
+                  <a:srgbClr val="283A39"/>
+                </a:solidFill>
+                <a:latin typeface="Arial"/>
+                <a:ea typeface="Arial"/>
+                <a:cs typeface="Arial"/>
+              </a:rPr>
+              <a:t>    You can skip this and start without email.</a:t>
             </a:r>
           </a:p>
         </p:txBody>
@@ -9566,19 +9507,19 @@
           <p:cNvPr id="4" name="">
             <a:extLst xmlns:a="http://schemas.openxmlformats.org/drawingml/2006/main">
               <a:ext uri="{FF2B5EF4-FFF2-40B4-BE49-F238E27FC236}">
-                <a16:creationId xmlns:a16="http://schemas.microsoft.com/office/drawing/2014/main" id="{0D657920-D854-4952-9E1D-9972983AD8D3}"/>
-              </a:ext>
-            </a:extLst>
-          </p:cNvPr>
-          <p:cNvSpPr>
-            <a:spLocks xmlns:a="http://schemas.openxmlformats.org/drawingml/2006/main" noGrp="1"/>
-          </p:cNvSpPr>
-          <p:nvPr/>
-        </p:nvSpPr>
-        <p:spPr>
-          <a:xfrm xmlns:a="http://schemas.openxmlformats.org/drawingml/2006/main">
-            <a:off x="609600" y="2143125"/>
-            <a:ext cx="10820400" cy="1009650"/>
+                <a16:creationId xmlns:a16="http://schemas.microsoft.com/office/drawing/2014/main" id="{D93E2548-3FF7-4C80-83C0-4FDDB420C0C6}"/>
+              </a:ext>
+            </a:extLst>
+          </p:cNvPr>
+          <p:cNvSpPr>
+            <a:spLocks xmlns:a="http://schemas.openxmlformats.org/drawingml/2006/main" noGrp="1"/>
+          </p:cNvSpPr>
+          <p:nvPr/>
+        </p:nvSpPr>
+        <p:spPr>
+          <a:xfrm xmlns:a="http://schemas.openxmlformats.org/drawingml/2006/main">
+            <a:off x="609600" y="2686050"/>
+            <a:ext cx="10820400" cy="857250"/>
           </a:xfrm>
           <a:prstGeom xmlns:a="http://schemas.openxmlformats.org/drawingml/2006/main" prst="rect">
             <a:avLst/>
@@ -9614,7 +9555,7 @@
                 <a:ea typeface="Arial"/>
                 <a:cs typeface="Arial"/>
               </a:rPr>
-              <a:t>Attach your PDF or Word file before sending the first message.</a:t>
+              <a:t>b. Codex: Plugins, then Gmail.</a:t>
             </a:r>
           </a:p>
           <a:p xmlns:a="http://schemas.openxmlformats.org/drawingml/2006/main">
@@ -9638,7 +9579,7 @@
                 <a:ea typeface="Arial"/>
                 <a:cs typeface="Arial"/>
               </a:rPr>
-              <a:t>If attachments are unavailable, paste its full file location.</a:t>
+              <a:t>    Claude Code: + or Settings, then Connectors.</a:t>
             </a:r>
           </a:p>
         </p:txBody>
@@ -9648,55 +9589,79 @@
           <p:cNvPr id="5" name="">
             <a:extLst xmlns:a="http://schemas.openxmlformats.org/drawingml/2006/main">
               <a:ext uri="{FF2B5EF4-FFF2-40B4-BE49-F238E27FC236}">
-                <a16:creationId xmlns:a16="http://schemas.microsoft.com/office/drawing/2014/main" id="{5D69E659-22D0-424F-A2AB-7559C211B7ED}"/>
-              </a:ext>
-            </a:extLst>
-          </p:cNvPr>
-          <p:cNvSpPr>
-            <a:spLocks xmlns:a="http://schemas.openxmlformats.org/drawingml/2006/main" noGrp="1"/>
-          </p:cNvSpPr>
-          <p:nvPr/>
-        </p:nvSpPr>
-        <p:spPr>
-          <a:xfrm xmlns:a="http://schemas.openxmlformats.org/drawingml/2006/main">
-            <a:off x="609600" y="3629025"/>
-            <a:ext cx="10477500" cy="457200"/>
-          </a:xfrm>
-          <a:prstGeom xmlns:a="http://schemas.openxmlformats.org/drawingml/2006/main" prst="rect">
-            <a:avLst/>
-          </a:prstGeom>
-          <a:noFill xmlns:a="http://schemas.openxmlformats.org/drawingml/2006/main"/>
-          <a:ln xmlns:a="http://schemas.openxmlformats.org/drawingml/2006/main" w="0">
-            <a:noFill/>
-          </a:ln>
-        </p:spPr>
-        <p:txBody>
-          <a:bodyPr xmlns:a="http://schemas.openxmlformats.org/drawingml/2006/main">
-            <a:noAutofit/>
-          </a:bodyPr>
-          <a:lstStyle xmlns:a="http://schemas.openxmlformats.org/drawingml/2006/main"/>
-          <a:p xmlns:a="http://schemas.openxmlformats.org/drawingml/2006/main">
-            <a:pPr>
-              <a:buNone/>
-              <a:defRPr sz="2550" b="1">
-                <a:solidFill>
-                  <a:srgbClr val="183F3B"/>
-                </a:solidFill>
-                <a:latin typeface="Arial"/>
-                <a:ea typeface="Arial"/>
-                <a:cs typeface="Arial"/>
-              </a:defRPr>
-            </a:pPr>
-            <a:r>
-              <a:rPr sz="2550" b="1">
-                <a:solidFill>
-                  <a:srgbClr val="183F3B"/>
-                </a:solidFill>
-                <a:latin typeface="Arial"/>
-                <a:ea typeface="Arial"/>
-                <a:cs typeface="Arial"/>
-              </a:rPr>
-              <a:t>If you do not have one</a:t>
+                <a16:creationId xmlns:a16="http://schemas.microsoft.com/office/drawing/2014/main" id="{15D3C5B8-3795-4CC8-8FA5-368D64F42A0D}"/>
+              </a:ext>
+            </a:extLst>
+          </p:cNvPr>
+          <p:cNvSpPr>
+            <a:spLocks xmlns:a="http://schemas.openxmlformats.org/drawingml/2006/main" noGrp="1"/>
+          </p:cNvSpPr>
+          <p:nvPr/>
+        </p:nvSpPr>
+        <p:spPr>
+          <a:xfrm xmlns:a="http://schemas.openxmlformats.org/drawingml/2006/main">
+            <a:off x="609600" y="3924300"/>
+            <a:ext cx="10820400" cy="857250"/>
+          </a:xfrm>
+          <a:prstGeom xmlns:a="http://schemas.openxmlformats.org/drawingml/2006/main" prst="rect">
+            <a:avLst/>
+          </a:prstGeom>
+          <a:noFill xmlns:a="http://schemas.openxmlformats.org/drawingml/2006/main"/>
+          <a:ln xmlns:a="http://schemas.openxmlformats.org/drawingml/2006/main" w="0">
+            <a:noFill/>
+          </a:ln>
+        </p:spPr>
+        <p:txBody>
+          <a:bodyPr xmlns:a="http://schemas.openxmlformats.org/drawingml/2006/main">
+            <a:noAutofit/>
+          </a:bodyPr>
+          <a:lstStyle xmlns:a="http://schemas.openxmlformats.org/drawingml/2006/main"/>
+          <a:p xmlns:a="http://schemas.openxmlformats.org/drawingml/2006/main">
+            <a:pPr>
+              <a:buNone/>
+              <a:defRPr sz="2250" b="0">
+                <a:solidFill>
+                  <a:srgbClr val="283A39"/>
+                </a:solidFill>
+                <a:latin typeface="Arial"/>
+                <a:ea typeface="Arial"/>
+                <a:cs typeface="Arial"/>
+              </a:defRPr>
+            </a:pPr>
+            <a:r>
+              <a:rPr sz="2250" b="0">
+                <a:solidFill>
+                  <a:srgbClr val="283A39"/>
+                </a:solidFill>
+                <a:latin typeface="Arial"/>
+                <a:ea typeface="Arial"/>
+                <a:cs typeface="Arial"/>
+              </a:rPr>
+              <a:t>c. Sign in to the account you will use for applications.</a:t>
+            </a:r>
+          </a:p>
+          <a:p xmlns:a="http://schemas.openxmlformats.org/drawingml/2006/main">
+            <a:pPr>
+              <a:buNone/>
+              <a:defRPr sz="2250" b="0">
+                <a:solidFill>
+                  <a:srgbClr val="283A39"/>
+                </a:solidFill>
+                <a:latin typeface="Arial"/>
+                <a:ea typeface="Arial"/>
+                <a:cs typeface="Arial"/>
+              </a:defRPr>
+            </a:pPr>
+            <a:r>
+              <a:rPr sz="2250" b="0">
+                <a:solidFill>
+                  <a:srgbClr val="283A39"/>
+                </a:solidFill>
+                <a:latin typeface="Arial"/>
+                <a:ea typeface="Arial"/>
+                <a:cs typeface="Arial"/>
+              </a:rPr>
+              <a:t>    The skill later checks your email, permission and access.</a:t>
             </a:r>
           </a:p>
         </p:txBody>
@@ -9706,55 +9671,79 @@
           <p:cNvPr id="6" name="">
             <a:extLst xmlns:a="http://schemas.openxmlformats.org/drawingml/2006/main">
               <a:ext uri="{FF2B5EF4-FFF2-40B4-BE49-F238E27FC236}">
-                <a16:creationId xmlns:a16="http://schemas.microsoft.com/office/drawing/2014/main" id="{643B98FC-5BC8-4EEC-94EC-156C8DB127C2}"/>
-              </a:ext>
-            </a:extLst>
-          </p:cNvPr>
-          <p:cNvSpPr>
-            <a:spLocks xmlns:a="http://schemas.openxmlformats.org/drawingml/2006/main" noGrp="1"/>
-          </p:cNvSpPr>
-          <p:nvPr/>
-        </p:nvSpPr>
-        <p:spPr>
-          <a:xfrm xmlns:a="http://schemas.openxmlformats.org/drawingml/2006/main">
-            <a:off x="609600" y="4257675"/>
-            <a:ext cx="10820400" cy="695325"/>
-          </a:xfrm>
-          <a:prstGeom xmlns:a="http://schemas.openxmlformats.org/drawingml/2006/main" prst="rect">
-            <a:avLst/>
-          </a:prstGeom>
-          <a:noFill xmlns:a="http://schemas.openxmlformats.org/drawingml/2006/main"/>
-          <a:ln xmlns:a="http://schemas.openxmlformats.org/drawingml/2006/main" w="0">
-            <a:noFill/>
-          </a:ln>
-        </p:spPr>
-        <p:txBody>
-          <a:bodyPr xmlns:a="http://schemas.openxmlformats.org/drawingml/2006/main">
-            <a:noAutofit/>
-          </a:bodyPr>
-          <a:lstStyle xmlns:a="http://schemas.openxmlformats.org/drawingml/2006/main"/>
-          <a:p xmlns:a="http://schemas.openxmlformats.org/drawingml/2006/main">
-            <a:pPr>
-              <a:buNone/>
-              <a:defRPr sz="2250" b="0">
-                <a:solidFill>
-                  <a:srgbClr val="283A39"/>
-                </a:solidFill>
-                <a:latin typeface="Arial"/>
-                <a:ea typeface="Arial"/>
-                <a:cs typeface="Arial"/>
-              </a:defRPr>
-            </a:pPr>
-            <a:r>
-              <a:rPr sz="2250" b="0">
-                <a:solidFill>
-                  <a:srgbClr val="283A39"/>
-                </a:solidFill>
-                <a:latin typeface="Arial"/>
-                <a:ea typeface="Arial"/>
-                <a:cs typeface="Arial"/>
-              </a:rPr>
-              <a:t>Add: “I do not have a resume yet. Help me build one.”</a:t>
+                <a16:creationId xmlns:a16="http://schemas.microsoft.com/office/drawing/2014/main" id="{499F2DAF-5D76-4075-B729-3E8C8ADD43E1}"/>
+              </a:ext>
+            </a:extLst>
+          </p:cNvPr>
+          <p:cNvSpPr>
+            <a:spLocks xmlns:a="http://schemas.openxmlformats.org/drawingml/2006/main" noGrp="1"/>
+          </p:cNvSpPr>
+          <p:nvPr/>
+        </p:nvSpPr>
+        <p:spPr>
+          <a:xfrm xmlns:a="http://schemas.openxmlformats.org/drawingml/2006/main">
+            <a:off x="609600" y="5219700"/>
+            <a:ext cx="10820400" cy="723900"/>
+          </a:xfrm>
+          <a:prstGeom xmlns:a="http://schemas.openxmlformats.org/drawingml/2006/main" prst="rect">
+            <a:avLst/>
+          </a:prstGeom>
+          <a:noFill xmlns:a="http://schemas.openxmlformats.org/drawingml/2006/main"/>
+          <a:ln xmlns:a="http://schemas.openxmlformats.org/drawingml/2006/main" w="0">
+            <a:noFill/>
+          </a:ln>
+        </p:spPr>
+        <p:txBody>
+          <a:bodyPr xmlns:a="http://schemas.openxmlformats.org/drawingml/2006/main">
+            <a:noAutofit/>
+          </a:bodyPr>
+          <a:lstStyle xmlns:a="http://schemas.openxmlformats.org/drawingml/2006/main"/>
+          <a:p xmlns:a="http://schemas.openxmlformats.org/drawingml/2006/main">
+            <a:pPr>
+              <a:buNone/>
+              <a:defRPr sz="1800" b="0">
+                <a:solidFill>
+                  <a:srgbClr val="607370"/>
+                </a:solidFill>
+                <a:latin typeface="Arial"/>
+                <a:ea typeface="Arial"/>
+                <a:cs typeface="Arial"/>
+              </a:defRPr>
+            </a:pPr>
+            <a:r>
+              <a:rPr sz="1800" b="0">
+                <a:solidFill>
+                  <a:srgbClr val="607370"/>
+                </a:solidFill>
+                <a:latin typeface="Arial"/>
+                <a:ea typeface="Arial"/>
+                <a:cs typeface="Arial"/>
+              </a:rPr>
+              <a:t>Already connected? Leave it in place.</a:t>
+            </a:r>
+          </a:p>
+          <a:p xmlns:a="http://schemas.openxmlformats.org/drawingml/2006/main">
+            <a:pPr>
+              <a:buNone/>
+              <a:defRPr sz="1800" b="0">
+                <a:solidFill>
+                  <a:srgbClr val="607370"/>
+                </a:solidFill>
+                <a:latin typeface="Arial"/>
+                <a:ea typeface="Arial"/>
+                <a:cs typeface="Arial"/>
+              </a:defRPr>
+            </a:pPr>
+            <a:r>
+              <a:rPr sz="1800" b="0">
+                <a:solidFill>
+                  <a:srgbClr val="607370"/>
+                </a:solidFill>
+                <a:latin typeface="Arial"/>
+                <a:ea typeface="Arial"/>
+                <a:cs typeface="Arial"/>
+              </a:rPr>
+              <a:t>Google Calendar is also optional for interview events.</a:t>
             </a:r>
           </a:p>
         </p:txBody>
@@ -9764,19 +9753,19 @@
           <p:cNvPr id="7" name="">
             <a:extLst xmlns:a="http://schemas.openxmlformats.org/drawingml/2006/main">
               <a:ext uri="{FF2B5EF4-FFF2-40B4-BE49-F238E27FC236}">
-                <a16:creationId xmlns:a16="http://schemas.microsoft.com/office/drawing/2014/main" id="{0D5E6C64-5B77-479E-93A9-BC935C0E00CE}"/>
-              </a:ext>
-            </a:extLst>
-          </p:cNvPr>
-          <p:cNvSpPr>
-            <a:spLocks xmlns:a="http://schemas.openxmlformats.org/drawingml/2006/main" noGrp="1"/>
-          </p:cNvSpPr>
-          <p:nvPr/>
-        </p:nvSpPr>
-        <p:spPr>
-          <a:xfrm xmlns:a="http://schemas.openxmlformats.org/drawingml/2006/main">
-            <a:off x="609600" y="5629275"/>
-            <a:ext cx="10839450" cy="590550"/>
+                <a16:creationId xmlns:a16="http://schemas.microsoft.com/office/drawing/2014/main" id="{EAF2EA42-DEE2-4D4C-AEB4-EA109E27A622}"/>
+              </a:ext>
+            </a:extLst>
+          </p:cNvPr>
+          <p:cNvSpPr>
+            <a:spLocks xmlns:a="http://schemas.openxmlformats.org/drawingml/2006/main" noGrp="1"/>
+          </p:cNvSpPr>
+          <p:nvPr/>
+        </p:nvSpPr>
+        <p:spPr>
+          <a:xfrm xmlns:a="http://schemas.openxmlformats.org/drawingml/2006/main">
+            <a:off x="609600" y="6038850"/>
+            <a:ext cx="10001250" cy="333375"/>
           </a:xfrm>
           <a:prstGeom xmlns:a="http://schemas.openxmlformats.org/drawingml/2006/main" prst="rect">
             <a:avLst/>
@@ -9796,7 +9785,7 @@
               <a:buNone/>
               <a:defRPr sz="1800" b="0">
                 <a:solidFill>
-                  <a:srgbClr val="607370"/>
+                  <a:srgbClr val="087F73"/>
                 </a:solidFill>
                 <a:latin typeface="Arial"/>
                 <a:ea typeface="Arial"/>
@@ -9806,13 +9795,14 @@
             <a:r>
               <a:rPr sz="1800" b="0">
                 <a:solidFill>
-                  <a:srgbClr val="607370"/>
-                </a:solidFill>
-                <a:latin typeface="Arial"/>
-                <a:ea typeface="Arial"/>
-                <a:cs typeface="Arial"/>
-              </a:rPr>
-              <a:t>Add your LinkedIn URL too. The AI can reconcile profile details with your records.</a:t>
+                  <a:srgbClr val="087F73"/>
+                </a:solidFill>
+                <a:latin typeface="Arial"/>
+                <a:ea typeface="Arial"/>
+                <a:cs typeface="Arial"/>
+                <a:hlinkClick xmlns:r="http://schemas.openxmlformats.org/officeDocument/2006/relationships" r:id="R56170f2476564c95"/>
+              </a:rPr>
+              <a:t>Connection steps in the README</a:t>
             </a:r>
           </a:p>
         </p:txBody>
@@ -9820,7 +9810,7 @@
     </p:spTree>
     <p:extLst>
       <p:ext uri="{BB962C8B-B14F-4D97-AF65-F5344CB8AC3E}">
-        <p14:creationId xmlns:p14="http://schemas.microsoft.com/office/powerpoint/2010/main" val="1092458265"/>
+        <p14:creationId xmlns:p14="http://schemas.microsoft.com/office/powerpoint/2010/main" val="247586683"/>
       </p:ext>
     </p:extLst>
   </p:cSld>
@@ -9848,10 +9838,10 @@
       </p:grpSpPr>
       <p:sp>
         <p:nvSpPr>
-          <p:cNvPr id="7" name="">
-            <a:extLst xmlns:a="http://schemas.openxmlformats.org/drawingml/2006/main">
-              <a:ext uri="{FF2B5EF4-FFF2-40B4-BE49-F238E27FC236}">
-                <a16:creationId xmlns:a16="http://schemas.microsoft.com/office/drawing/2014/main" id="{3C7191AB-EE0A-4D06-8E69-83C29F342388}"/>
+          <p:cNvPr id="8" name="">
+            <a:extLst xmlns:a="http://schemas.openxmlformats.org/drawingml/2006/main">
+              <a:ext uri="{FF2B5EF4-FFF2-40B4-BE49-F238E27FC236}">
+                <a16:creationId xmlns:a16="http://schemas.microsoft.com/office/drawing/2014/main" id="{899873CB-E3FF-4A32-8D3D-52B39D02A7B1}"/>
               </a:ext>
             </a:extLst>
           </p:cNvPr>
@@ -9899,7 +9889,7 @@
                 <a:ea typeface="Arial"/>
                 <a:cs typeface="Arial"/>
               </a:rPr>
-              <a:t>3. Your first message</a:t>
+              <a:t>2. Your resume</a:t>
             </a:r>
           </a:p>
         </p:txBody>
@@ -9909,7 +9899,7 @@
           <p:cNvPr id="2" name="">
             <a:extLst xmlns:a="http://schemas.openxmlformats.org/drawingml/2006/main">
               <a:ext uri="{FF2B5EF4-FFF2-40B4-BE49-F238E27FC236}">
-                <a16:creationId xmlns:a16="http://schemas.microsoft.com/office/drawing/2014/main" id="{55AEF1AA-FAC2-49F8-8E83-90F174788113}"/>
+                <a16:creationId xmlns:a16="http://schemas.microsoft.com/office/drawing/2014/main" id="{FE647B76-A8C3-4FC0-B7CB-B5330DDAADA8}"/>
               </a:ext>
             </a:extLst>
           </p:cNvPr>
@@ -9967,55 +9957,55 @@
           <p:cNvPr id="3" name="">
             <a:extLst xmlns:a="http://schemas.openxmlformats.org/drawingml/2006/main">
               <a:ext uri="{FF2B5EF4-FFF2-40B4-BE49-F238E27FC236}">
-                <a16:creationId xmlns:a16="http://schemas.microsoft.com/office/drawing/2014/main" id="{6605A233-C7CC-4E3B-B13D-E8DC1B02226B}"/>
-              </a:ext>
-            </a:extLst>
-          </p:cNvPr>
-          <p:cNvSpPr>
-            <a:spLocks xmlns:a="http://schemas.openxmlformats.org/drawingml/2006/main" noGrp="1"/>
-          </p:cNvSpPr>
-          <p:nvPr/>
-        </p:nvSpPr>
-        <p:spPr>
-          <a:xfrm xmlns:a="http://schemas.openxmlformats.org/drawingml/2006/main">
-            <a:off x="609600" y="1457325"/>
-            <a:ext cx="10858500" cy="590550"/>
-          </a:xfrm>
-          <a:prstGeom xmlns:a="http://schemas.openxmlformats.org/drawingml/2006/main" prst="rect">
-            <a:avLst/>
-          </a:prstGeom>
-          <a:noFill xmlns:a="http://schemas.openxmlformats.org/drawingml/2006/main"/>
-          <a:ln xmlns:a="http://schemas.openxmlformats.org/drawingml/2006/main" w="0">
-            <a:noFill/>
-          </a:ln>
-        </p:spPr>
-        <p:txBody>
-          <a:bodyPr xmlns:a="http://schemas.openxmlformats.org/drawingml/2006/main">
-            <a:noAutofit/>
-          </a:bodyPr>
-          <a:lstStyle xmlns:a="http://schemas.openxmlformats.org/drawingml/2006/main"/>
-          <a:p xmlns:a="http://schemas.openxmlformats.org/drawingml/2006/main">
-            <a:pPr>
-              <a:buNone/>
-              <a:defRPr sz="2100" b="0">
-                <a:solidFill>
-                  <a:srgbClr val="283A39"/>
-                </a:solidFill>
-                <a:latin typeface="Arial"/>
-                <a:ea typeface="Arial"/>
-                <a:cs typeface="Arial"/>
-              </a:defRPr>
-            </a:pPr>
-            <a:r>
-              <a:rPr sz="2100" b="0">
-                <a:solidFill>
-                  <a:srgbClr val="283A39"/>
-                </a:solidFill>
-                <a:latin typeface="Arial"/>
-                <a:ea typeface="Arial"/>
-                <a:cs typeface="Arial"/>
-              </a:rPr>
-              <a:t>Copy both lines into the same message box as your resume:</a:t>
+                <a16:creationId xmlns:a16="http://schemas.microsoft.com/office/drawing/2014/main" id="{7A5FD4D7-2672-4A13-9C62-3CC32FC98263}"/>
+              </a:ext>
+            </a:extLst>
+          </p:cNvPr>
+          <p:cNvSpPr>
+            <a:spLocks xmlns:a="http://schemas.openxmlformats.org/drawingml/2006/main" noGrp="1"/>
+          </p:cNvSpPr>
+          <p:nvPr/>
+        </p:nvSpPr>
+        <p:spPr>
+          <a:xfrm xmlns:a="http://schemas.openxmlformats.org/drawingml/2006/main">
+            <a:off x="609600" y="1524000"/>
+            <a:ext cx="10477500" cy="457200"/>
+          </a:xfrm>
+          <a:prstGeom xmlns:a="http://schemas.openxmlformats.org/drawingml/2006/main" prst="rect">
+            <a:avLst/>
+          </a:prstGeom>
+          <a:noFill xmlns:a="http://schemas.openxmlformats.org/drawingml/2006/main"/>
+          <a:ln xmlns:a="http://schemas.openxmlformats.org/drawingml/2006/main" w="0">
+            <a:noFill/>
+          </a:ln>
+        </p:spPr>
+        <p:txBody>
+          <a:bodyPr xmlns:a="http://schemas.openxmlformats.org/drawingml/2006/main">
+            <a:noAutofit/>
+          </a:bodyPr>
+          <a:lstStyle xmlns:a="http://schemas.openxmlformats.org/drawingml/2006/main"/>
+          <a:p xmlns:a="http://schemas.openxmlformats.org/drawingml/2006/main">
+            <a:pPr>
+              <a:buNone/>
+              <a:defRPr sz="2550" b="1">
+                <a:solidFill>
+                  <a:srgbClr val="183F3B"/>
+                </a:solidFill>
+                <a:latin typeface="Arial"/>
+                <a:ea typeface="Arial"/>
+                <a:cs typeface="Arial"/>
+              </a:defRPr>
+            </a:pPr>
+            <a:r>
+              <a:rPr sz="2550" b="1">
+                <a:solidFill>
+                  <a:srgbClr val="183F3B"/>
+                </a:solidFill>
+                <a:latin typeface="Arial"/>
+                <a:ea typeface="Arial"/>
+                <a:cs typeface="Arial"/>
+              </a:rPr>
+              <a:t>If you have one</a:t>
             </a:r>
           </a:p>
         </p:txBody>
@@ -10025,37 +10015,119 @@
           <p:cNvPr id="4" name="">
             <a:extLst xmlns:a="http://schemas.openxmlformats.org/drawingml/2006/main">
               <a:ext uri="{FF2B5EF4-FFF2-40B4-BE49-F238E27FC236}">
-                <a16:creationId xmlns:a16="http://schemas.microsoft.com/office/drawing/2014/main" id="{A83616AC-F1BB-4CD7-BA84-4EE26B811920}"/>
-              </a:ext>
-            </a:extLst>
-          </p:cNvPr>
-          <p:cNvSpPr>
-            <a:spLocks xmlns:a="http://schemas.openxmlformats.org/drawingml/2006/main" noGrp="1"/>
-          </p:cNvSpPr>
-          <p:nvPr/>
-        </p:nvSpPr>
-        <p:spPr>
-          <a:xfrm xmlns:a="http://schemas.openxmlformats.org/drawingml/2006/main">
-            <a:off x="609600" y="2638425"/>
-            <a:ext cx="10972800" cy="1381125"/>
-          </a:xfrm>
-          <a:prstGeom xmlns:a="http://schemas.openxmlformats.org/drawingml/2006/main" prst="rect">
-            <a:avLst/>
-          </a:prstGeom>
-          <a:noFill xmlns:a="http://schemas.openxmlformats.org/drawingml/2006/main"/>
-          <a:ln xmlns:a="http://schemas.openxmlformats.org/drawingml/2006/main" w="0">
-            <a:noFill/>
-          </a:ln>
-        </p:spPr>
-        <p:txBody>
-          <a:bodyPr xmlns:a="http://schemas.openxmlformats.org/drawingml/2006/main">
-            <a:noAutofit/>
-          </a:bodyPr>
-          <a:lstStyle xmlns:a="http://schemas.openxmlformats.org/drawingml/2006/main"/>
-          <a:p xmlns:a="http://schemas.openxmlformats.org/drawingml/2006/main">
-            <a:pPr>
-              <a:buNone/>
-              <a:defRPr sz="2400" b="1">
+                <a16:creationId xmlns:a16="http://schemas.microsoft.com/office/drawing/2014/main" id="{0D657920-D854-4952-9E1D-9972983AD8D3}"/>
+              </a:ext>
+            </a:extLst>
+          </p:cNvPr>
+          <p:cNvSpPr>
+            <a:spLocks xmlns:a="http://schemas.openxmlformats.org/drawingml/2006/main" noGrp="1"/>
+          </p:cNvSpPr>
+          <p:nvPr/>
+        </p:nvSpPr>
+        <p:spPr>
+          <a:xfrm xmlns:a="http://schemas.openxmlformats.org/drawingml/2006/main">
+            <a:off x="609600" y="2143125"/>
+            <a:ext cx="10820400" cy="1009650"/>
+          </a:xfrm>
+          <a:prstGeom xmlns:a="http://schemas.openxmlformats.org/drawingml/2006/main" prst="rect">
+            <a:avLst/>
+          </a:prstGeom>
+          <a:noFill xmlns:a="http://schemas.openxmlformats.org/drawingml/2006/main"/>
+          <a:ln xmlns:a="http://schemas.openxmlformats.org/drawingml/2006/main" w="0">
+            <a:noFill/>
+          </a:ln>
+        </p:spPr>
+        <p:txBody>
+          <a:bodyPr xmlns:a="http://schemas.openxmlformats.org/drawingml/2006/main">
+            <a:noAutofit/>
+          </a:bodyPr>
+          <a:lstStyle xmlns:a="http://schemas.openxmlformats.org/drawingml/2006/main"/>
+          <a:p xmlns:a="http://schemas.openxmlformats.org/drawingml/2006/main">
+            <a:pPr>
+              <a:buNone/>
+              <a:defRPr sz="2250" b="0">
+                <a:solidFill>
+                  <a:srgbClr val="283A39"/>
+                </a:solidFill>
+                <a:latin typeface="Arial"/>
+                <a:ea typeface="Arial"/>
+                <a:cs typeface="Arial"/>
+              </a:defRPr>
+            </a:pPr>
+            <a:r>
+              <a:rPr sz="2250" b="0">
+                <a:solidFill>
+                  <a:srgbClr val="283A39"/>
+                </a:solidFill>
+                <a:latin typeface="Arial"/>
+                <a:ea typeface="Arial"/>
+                <a:cs typeface="Arial"/>
+              </a:rPr>
+              <a:t>Attach your PDF or Word file before sending the first message.</a:t>
+            </a:r>
+          </a:p>
+          <a:p xmlns:a="http://schemas.openxmlformats.org/drawingml/2006/main">
+            <a:pPr>
+              <a:buNone/>
+              <a:defRPr sz="2250" b="0">
+                <a:solidFill>
+                  <a:srgbClr val="283A39"/>
+                </a:solidFill>
+                <a:latin typeface="Arial"/>
+                <a:ea typeface="Arial"/>
+                <a:cs typeface="Arial"/>
+              </a:defRPr>
+            </a:pPr>
+            <a:r>
+              <a:rPr sz="2250" b="0">
+                <a:solidFill>
+                  <a:srgbClr val="283A39"/>
+                </a:solidFill>
+                <a:latin typeface="Arial"/>
+                <a:ea typeface="Arial"/>
+                <a:cs typeface="Arial"/>
+              </a:rPr>
+              <a:t>If attachments are unavailable, paste its full file location.</a:t>
+            </a:r>
+          </a:p>
+        </p:txBody>
+      </p:sp>
+      <p:sp>
+        <p:nvSpPr>
+          <p:cNvPr id="5" name="">
+            <a:extLst xmlns:a="http://schemas.openxmlformats.org/drawingml/2006/main">
+              <a:ext uri="{FF2B5EF4-FFF2-40B4-BE49-F238E27FC236}">
+                <a16:creationId xmlns:a16="http://schemas.microsoft.com/office/drawing/2014/main" id="{5D69E659-22D0-424F-A2AB-7559C211B7ED}"/>
+              </a:ext>
+            </a:extLst>
+          </p:cNvPr>
+          <p:cNvSpPr>
+            <a:spLocks xmlns:a="http://schemas.openxmlformats.org/drawingml/2006/main" noGrp="1"/>
+          </p:cNvSpPr>
+          <p:nvPr/>
+        </p:nvSpPr>
+        <p:spPr>
+          <a:xfrm xmlns:a="http://schemas.openxmlformats.org/drawingml/2006/main">
+            <a:off x="609600" y="3629025"/>
+            <a:ext cx="10477500" cy="457200"/>
+          </a:xfrm>
+          <a:prstGeom xmlns:a="http://schemas.openxmlformats.org/drawingml/2006/main" prst="rect">
+            <a:avLst/>
+          </a:prstGeom>
+          <a:noFill xmlns:a="http://schemas.openxmlformats.org/drawingml/2006/main"/>
+          <a:ln xmlns:a="http://schemas.openxmlformats.org/drawingml/2006/main" w="0">
+            <a:noFill/>
+          </a:ln>
+        </p:spPr>
+        <p:txBody>
+          <a:bodyPr xmlns:a="http://schemas.openxmlformats.org/drawingml/2006/main">
+            <a:noAutofit/>
+          </a:bodyPr>
+          <a:lstStyle xmlns:a="http://schemas.openxmlformats.org/drawingml/2006/main"/>
+          <a:p xmlns:a="http://schemas.openxmlformats.org/drawingml/2006/main">
+            <a:pPr>
+              <a:buNone/>
+              <a:defRPr sz="2550" b="1">
                 <a:solidFill>
                   <a:srgbClr val="183F3B"/>
                 </a:solidFill>
@@ -10065,7 +10137,7 @@
               </a:defRPr>
             </a:pPr>
             <a:r>
-              <a:rPr sz="2400" b="1">
+              <a:rPr sz="2550" b="1">
                 <a:solidFill>
                   <a:srgbClr val="183F3B"/>
                 </a:solidFill>
@@ -10073,113 +10145,7 @@
                 <a:ea typeface="Arial"/>
                 <a:cs typeface="Arial"/>
               </a:rPr>
-              <a:t>Install https://github.com/toughdave/job-search for this project.</a:t>
-            </a:r>
-          </a:p>
-          <a:p xmlns:a="http://schemas.openxmlformats.org/drawingml/2006/main">
-            <a:pPr>
-              <a:buNone/>
-              <a:defRPr sz="2400" b="1">
-                <a:solidFill>
-                  <a:srgbClr val="183F3B"/>
-                </a:solidFill>
-                <a:latin typeface="Arial"/>
-                <a:ea typeface="Arial"/>
-                <a:cs typeface="Arial"/>
-              </a:defRPr>
-            </a:pPr>
-            <a:r>
-              <a:rPr sz="2400" b="1">
-                <a:solidFill>
-                  <a:srgbClr val="183F3B"/>
-                </a:solidFill>
-                <a:latin typeface="Arial"/>
-                <a:ea typeface="Arial"/>
-                <a:cs typeface="Arial"/>
-              </a:rPr>
-              <a:t>Then use job-search to start my search.</a:t>
-            </a:r>
-          </a:p>
-        </p:txBody>
-      </p:sp>
-      <p:sp>
-        <p:nvSpPr>
-          <p:cNvPr id="5" name="">
-            <a:extLst xmlns:a="http://schemas.openxmlformats.org/drawingml/2006/main">
-              <a:ext uri="{FF2B5EF4-FFF2-40B4-BE49-F238E27FC236}">
-                <a16:creationId xmlns:a16="http://schemas.microsoft.com/office/drawing/2014/main" id="{7B4A3C50-E8F9-4624-925E-4E928FA4FEC9}"/>
-              </a:ext>
-            </a:extLst>
-          </p:cNvPr>
-          <p:cNvSpPr>
-            <a:spLocks xmlns:a="http://schemas.openxmlformats.org/drawingml/2006/main" noGrp="1"/>
-          </p:cNvSpPr>
-          <p:nvPr/>
-        </p:nvSpPr>
-        <p:spPr>
-          <a:xfrm xmlns:a="http://schemas.openxmlformats.org/drawingml/2006/main">
-            <a:off x="609600" y="4562475"/>
-            <a:ext cx="10858500" cy="1019175"/>
-          </a:xfrm>
-          <a:prstGeom xmlns:a="http://schemas.openxmlformats.org/drawingml/2006/main" prst="rect">
-            <a:avLst/>
-          </a:prstGeom>
-          <a:noFill xmlns:a="http://schemas.openxmlformats.org/drawingml/2006/main"/>
-          <a:ln xmlns:a="http://schemas.openxmlformats.org/drawingml/2006/main" w="0">
-            <a:noFill/>
-          </a:ln>
-        </p:spPr>
-        <p:txBody>
-          <a:bodyPr xmlns:a="http://schemas.openxmlformats.org/drawingml/2006/main">
-            <a:noAutofit/>
-          </a:bodyPr>
-          <a:lstStyle xmlns:a="http://schemas.openxmlformats.org/drawingml/2006/main"/>
-          <a:p xmlns:a="http://schemas.openxmlformats.org/drawingml/2006/main">
-            <a:pPr>
-              <a:buNone/>
-              <a:defRPr sz="2100" b="0">
-                <a:solidFill>
-                  <a:srgbClr val="283A39"/>
-                </a:solidFill>
-                <a:latin typeface="Arial"/>
-                <a:ea typeface="Arial"/>
-                <a:cs typeface="Arial"/>
-              </a:defRPr>
-            </a:pPr>
-            <a:r>
-              <a:rPr sz="2100" b="0">
-                <a:solidFill>
-                  <a:srgbClr val="283A39"/>
-                </a:solidFill>
-                <a:latin typeface="Arial"/>
-                <a:ea typeface="Arial"/>
-                <a:cs typeface="Arial"/>
-              </a:rPr>
-              <a:t>Add your resume location or no-resume sentence if needed.</a:t>
-            </a:r>
-          </a:p>
-          <a:p xmlns:a="http://schemas.openxmlformats.org/drawingml/2006/main">
-            <a:pPr>
-              <a:buNone/>
-              <a:defRPr sz="2100" b="0">
-                <a:solidFill>
-                  <a:srgbClr val="283A39"/>
-                </a:solidFill>
-                <a:latin typeface="Arial"/>
-                <a:ea typeface="Arial"/>
-                <a:cs typeface="Arial"/>
-              </a:defRPr>
-            </a:pPr>
-            <a:r>
-              <a:rPr sz="2100" b="0">
-                <a:solidFill>
-                  <a:srgbClr val="283A39"/>
-                </a:solidFill>
-                <a:latin typeface="Arial"/>
-                <a:ea typeface="Arial"/>
-                <a:cs typeface="Arial"/>
-              </a:rPr>
-              <a:t>Press Send once. Follow any installation approval or restart request.</a:t>
+              <a:t>If you do not have one</a:t>
             </a:r>
           </a:p>
         </p:txBody>
@@ -10189,56 +10155,113 @@
           <p:cNvPr id="6" name="">
             <a:extLst xmlns:a="http://schemas.openxmlformats.org/drawingml/2006/main">
               <a:ext uri="{FF2B5EF4-FFF2-40B4-BE49-F238E27FC236}">
-                <a16:creationId xmlns:a16="http://schemas.microsoft.com/office/drawing/2014/main" id="{85AFAACC-D536-4186-B98C-BC589C94E5EE}"/>
-              </a:ext>
-            </a:extLst>
-          </p:cNvPr>
-          <p:cNvSpPr>
-            <a:spLocks xmlns:a="http://schemas.openxmlformats.org/drawingml/2006/main" noGrp="1"/>
-          </p:cNvSpPr>
-          <p:nvPr/>
-        </p:nvSpPr>
-        <p:spPr>
-          <a:xfrm xmlns:a="http://schemas.openxmlformats.org/drawingml/2006/main">
-            <a:off x="609600" y="5781675"/>
-            <a:ext cx="5715000" cy="361950"/>
-          </a:xfrm>
-          <a:prstGeom xmlns:a="http://schemas.openxmlformats.org/drawingml/2006/main" prst="rect">
-            <a:avLst/>
-          </a:prstGeom>
-          <a:noFill xmlns:a="http://schemas.openxmlformats.org/drawingml/2006/main"/>
-          <a:ln xmlns:a="http://schemas.openxmlformats.org/drawingml/2006/main" w="0">
-            <a:noFill/>
-          </a:ln>
-        </p:spPr>
-        <p:txBody>
-          <a:bodyPr xmlns:a="http://schemas.openxmlformats.org/drawingml/2006/main">
-            <a:noAutofit/>
-          </a:bodyPr>
-          <a:lstStyle xmlns:a="http://schemas.openxmlformats.org/drawingml/2006/main"/>
-          <a:p xmlns:a="http://schemas.openxmlformats.org/drawingml/2006/main">
-            <a:pPr>
-              <a:buNone/>
-              <a:defRPr sz="1875" b="0">
-                <a:solidFill>
-                  <a:srgbClr val="087F73"/>
-                </a:solidFill>
-                <a:latin typeface="Arial"/>
-                <a:ea typeface="Arial"/>
-                <a:cs typeface="Arial"/>
-              </a:defRPr>
-            </a:pPr>
-            <a:r>
-              <a:rPr sz="1875" b="0">
-                <a:solidFill>
-                  <a:srgbClr val="087F73"/>
-                </a:solidFill>
-                <a:latin typeface="Arial"/>
-                <a:ea typeface="Arial"/>
-                <a:cs typeface="Arial"/>
-                <a:hlinkClick xmlns:r="http://schemas.openxmlformats.org/officeDocument/2006/relationships" r:id="R02208fb37d834372"/>
-              </a:rPr>
-              <a:t>Copy from the README</a:t>
+                <a16:creationId xmlns:a16="http://schemas.microsoft.com/office/drawing/2014/main" id="{643B98FC-5BC8-4EEC-94EC-156C8DB127C2}"/>
+              </a:ext>
+            </a:extLst>
+          </p:cNvPr>
+          <p:cNvSpPr>
+            <a:spLocks xmlns:a="http://schemas.openxmlformats.org/drawingml/2006/main" noGrp="1"/>
+          </p:cNvSpPr>
+          <p:nvPr/>
+        </p:nvSpPr>
+        <p:spPr>
+          <a:xfrm xmlns:a="http://schemas.openxmlformats.org/drawingml/2006/main">
+            <a:off x="609600" y="4257675"/>
+            <a:ext cx="10820400" cy="695325"/>
+          </a:xfrm>
+          <a:prstGeom xmlns:a="http://schemas.openxmlformats.org/drawingml/2006/main" prst="rect">
+            <a:avLst/>
+          </a:prstGeom>
+          <a:noFill xmlns:a="http://schemas.openxmlformats.org/drawingml/2006/main"/>
+          <a:ln xmlns:a="http://schemas.openxmlformats.org/drawingml/2006/main" w="0">
+            <a:noFill/>
+          </a:ln>
+        </p:spPr>
+        <p:txBody>
+          <a:bodyPr xmlns:a="http://schemas.openxmlformats.org/drawingml/2006/main">
+            <a:noAutofit/>
+          </a:bodyPr>
+          <a:lstStyle xmlns:a="http://schemas.openxmlformats.org/drawingml/2006/main"/>
+          <a:p xmlns:a="http://schemas.openxmlformats.org/drawingml/2006/main">
+            <a:pPr>
+              <a:buNone/>
+              <a:defRPr sz="2250" b="0">
+                <a:solidFill>
+                  <a:srgbClr val="283A39"/>
+                </a:solidFill>
+                <a:latin typeface="Arial"/>
+                <a:ea typeface="Arial"/>
+                <a:cs typeface="Arial"/>
+              </a:defRPr>
+            </a:pPr>
+            <a:r>
+              <a:rPr sz="2250" b="0">
+                <a:solidFill>
+                  <a:srgbClr val="283A39"/>
+                </a:solidFill>
+                <a:latin typeface="Arial"/>
+                <a:ea typeface="Arial"/>
+                <a:cs typeface="Arial"/>
+              </a:rPr>
+              <a:t>Add: “I do not have a resume yet. Help me build one.”</a:t>
+            </a:r>
+          </a:p>
+        </p:txBody>
+      </p:sp>
+      <p:sp>
+        <p:nvSpPr>
+          <p:cNvPr id="7" name="">
+            <a:extLst xmlns:a="http://schemas.openxmlformats.org/drawingml/2006/main">
+              <a:ext uri="{FF2B5EF4-FFF2-40B4-BE49-F238E27FC236}">
+                <a16:creationId xmlns:a16="http://schemas.microsoft.com/office/drawing/2014/main" id="{0D5E6C64-5B77-479E-93A9-BC935C0E00CE}"/>
+              </a:ext>
+            </a:extLst>
+          </p:cNvPr>
+          <p:cNvSpPr>
+            <a:spLocks xmlns:a="http://schemas.openxmlformats.org/drawingml/2006/main" noGrp="1"/>
+          </p:cNvSpPr>
+          <p:nvPr/>
+        </p:nvSpPr>
+        <p:spPr>
+          <a:xfrm xmlns:a="http://schemas.openxmlformats.org/drawingml/2006/main">
+            <a:off x="609600" y="5629275"/>
+            <a:ext cx="10839450" cy="590550"/>
+          </a:xfrm>
+          <a:prstGeom xmlns:a="http://schemas.openxmlformats.org/drawingml/2006/main" prst="rect">
+            <a:avLst/>
+          </a:prstGeom>
+          <a:noFill xmlns:a="http://schemas.openxmlformats.org/drawingml/2006/main"/>
+          <a:ln xmlns:a="http://schemas.openxmlformats.org/drawingml/2006/main" w="0">
+            <a:noFill/>
+          </a:ln>
+        </p:spPr>
+        <p:txBody>
+          <a:bodyPr xmlns:a="http://schemas.openxmlformats.org/drawingml/2006/main">
+            <a:noAutofit/>
+          </a:bodyPr>
+          <a:lstStyle xmlns:a="http://schemas.openxmlformats.org/drawingml/2006/main"/>
+          <a:p xmlns:a="http://schemas.openxmlformats.org/drawingml/2006/main">
+            <a:pPr>
+              <a:buNone/>
+              <a:defRPr sz="1800" b="0">
+                <a:solidFill>
+                  <a:srgbClr val="607370"/>
+                </a:solidFill>
+                <a:latin typeface="Arial"/>
+                <a:ea typeface="Arial"/>
+                <a:cs typeface="Arial"/>
+              </a:defRPr>
+            </a:pPr>
+            <a:r>
+              <a:rPr sz="1800" b="0">
+                <a:solidFill>
+                  <a:srgbClr val="607370"/>
+                </a:solidFill>
+                <a:latin typeface="Arial"/>
+                <a:ea typeface="Arial"/>
+                <a:cs typeface="Arial"/>
+              </a:rPr>
+              <a:t>Add your LinkedIn URL too. The AI can reconcile profile details with your records.</a:t>
             </a:r>
           </a:p>
         </p:txBody>
@@ -10246,7 +10269,7 @@
     </p:spTree>
     <p:extLst>
       <p:ext uri="{BB962C8B-B14F-4D97-AF65-F5344CB8AC3E}">
-        <p14:creationId xmlns:p14="http://schemas.microsoft.com/office/powerpoint/2010/main" val="967384215"/>
+        <p14:creationId xmlns:p14="http://schemas.microsoft.com/office/powerpoint/2010/main" val="1092458265"/>
       </p:ext>
     </p:extLst>
   </p:cSld>
@@ -10277,7 +10300,7 @@
           <p:cNvPr id="7" name="">
             <a:extLst xmlns:a="http://schemas.openxmlformats.org/drawingml/2006/main">
               <a:ext uri="{FF2B5EF4-FFF2-40B4-BE49-F238E27FC236}">
-                <a16:creationId xmlns:a16="http://schemas.microsoft.com/office/drawing/2014/main" id="{1678E64F-2881-4536-825F-C7EE8249525B}"/>
+                <a16:creationId xmlns:a16="http://schemas.microsoft.com/office/drawing/2014/main" id="{3C7191AB-EE0A-4D06-8E69-83C29F342388}"/>
               </a:ext>
             </a:extLst>
           </p:cNvPr>
@@ -10289,7 +10312,7 @@
         <p:spPr>
           <a:xfrm xmlns:a="http://schemas.openxmlformats.org/drawingml/2006/main">
             <a:off x="609600" y="457200"/>
-            <a:ext cx="10820400" cy="742950"/>
+            <a:ext cx="10972800" cy="742950"/>
           </a:xfrm>
           <a:prstGeom xmlns:a="http://schemas.openxmlformats.org/drawingml/2006/main" prst="rect">
             <a:avLst/>
@@ -10325,7 +10348,7 @@
                 <a:ea typeface="Arial"/>
                 <a:cs typeface="Arial"/>
               </a:rPr>
-              <a:t>Software prerequisites</a:t>
+              <a:t>3. Your first message</a:t>
             </a:r>
           </a:p>
         </p:txBody>
@@ -10335,7 +10358,7 @@
           <p:cNvPr id="2" name="">
             <a:extLst xmlns:a="http://schemas.openxmlformats.org/drawingml/2006/main">
               <a:ext uri="{FF2B5EF4-FFF2-40B4-BE49-F238E27FC236}">
-                <a16:creationId xmlns:a16="http://schemas.microsoft.com/office/drawing/2014/main" id="{C131A19B-3CC5-4351-A103-EFEC84606564}"/>
+                <a16:creationId xmlns:a16="http://schemas.microsoft.com/office/drawing/2014/main" id="{55AEF1AA-FAC2-49F8-8E83-90F174788113}"/>
               </a:ext>
             </a:extLst>
           </p:cNvPr>
@@ -10393,79 +10416,55 @@
           <p:cNvPr id="3" name="">
             <a:extLst xmlns:a="http://schemas.openxmlformats.org/drawingml/2006/main">
               <a:ext uri="{FF2B5EF4-FFF2-40B4-BE49-F238E27FC236}">
-                <a16:creationId xmlns:a16="http://schemas.microsoft.com/office/drawing/2014/main" id="{2BE83B1A-A02A-486B-B2CA-1FDC73426FFD}"/>
-              </a:ext>
-            </a:extLst>
-          </p:cNvPr>
-          <p:cNvSpPr>
-            <a:spLocks xmlns:a="http://schemas.openxmlformats.org/drawingml/2006/main" noGrp="1"/>
-          </p:cNvSpPr>
-          <p:nvPr/>
-        </p:nvSpPr>
-        <p:spPr>
-          <a:xfrm xmlns:a="http://schemas.openxmlformats.org/drawingml/2006/main">
-            <a:off x="609600" y="1504950"/>
-            <a:ext cx="10820400" cy="1047750"/>
-          </a:xfrm>
-          <a:prstGeom xmlns:a="http://schemas.openxmlformats.org/drawingml/2006/main" prst="rect">
-            <a:avLst/>
-          </a:prstGeom>
-          <a:noFill xmlns:a="http://schemas.openxmlformats.org/drawingml/2006/main"/>
-          <a:ln xmlns:a="http://schemas.openxmlformats.org/drawingml/2006/main" w="0">
-            <a:noFill/>
-          </a:ln>
-        </p:spPr>
-        <p:txBody>
-          <a:bodyPr xmlns:a="http://schemas.openxmlformats.org/drawingml/2006/main">
-            <a:noAutofit/>
-          </a:bodyPr>
-          <a:lstStyle xmlns:a="http://schemas.openxmlformats.org/drawingml/2006/main"/>
-          <a:p xmlns:a="http://schemas.openxmlformats.org/drawingml/2006/main">
-            <a:pPr>
-              <a:buNone/>
-              <a:defRPr sz="2250" b="0">
-                <a:solidFill>
-                  <a:srgbClr val="283A39"/>
-                </a:solidFill>
-                <a:latin typeface="Arial"/>
-                <a:ea typeface="Arial"/>
-                <a:cs typeface="Arial"/>
-              </a:defRPr>
-            </a:pPr>
-            <a:r>
-              <a:rPr sz="2250" b="0">
-                <a:solidFill>
-                  <a:srgbClr val="283A39"/>
-                </a:solidFill>
-                <a:latin typeface="Arial"/>
-                <a:ea typeface="Arial"/>
-                <a:cs typeface="Arial"/>
-              </a:rPr>
-              <a:t>Use a local project with file access and an internet connection.</a:t>
-            </a:r>
-          </a:p>
-          <a:p xmlns:a="http://schemas.openxmlformats.org/drawingml/2006/main">
-            <a:pPr>
-              <a:buNone/>
-              <a:defRPr sz="2250" b="0">
-                <a:solidFill>
-                  <a:srgbClr val="283A39"/>
-                </a:solidFill>
-                <a:latin typeface="Arial"/>
-                <a:ea typeface="Arial"/>
-                <a:cs typeface="Arial"/>
-              </a:defRPr>
-            </a:pPr>
-            <a:r>
-              <a:rPr sz="2250" b="0">
-                <a:solidFill>
-                  <a:srgbClr val="283A39"/>
-                </a:solidFill>
-                <a:latin typeface="Arial"/>
-                <a:ea typeface="Arial"/>
-                <a:cs typeface="Arial"/>
-              </a:rPr>
-              <a:t>Your AI app needs an account that can use local projects.</a:t>
+                <a16:creationId xmlns:a16="http://schemas.microsoft.com/office/drawing/2014/main" id="{6605A233-C7CC-4E3B-B13D-E8DC1B02226B}"/>
+              </a:ext>
+            </a:extLst>
+          </p:cNvPr>
+          <p:cNvSpPr>
+            <a:spLocks xmlns:a="http://schemas.openxmlformats.org/drawingml/2006/main" noGrp="1"/>
+          </p:cNvSpPr>
+          <p:nvPr/>
+        </p:nvSpPr>
+        <p:spPr>
+          <a:xfrm xmlns:a="http://schemas.openxmlformats.org/drawingml/2006/main">
+            <a:off x="609600" y="1457325"/>
+            <a:ext cx="10858500" cy="590550"/>
+          </a:xfrm>
+          <a:prstGeom xmlns:a="http://schemas.openxmlformats.org/drawingml/2006/main" prst="rect">
+            <a:avLst/>
+          </a:prstGeom>
+          <a:noFill xmlns:a="http://schemas.openxmlformats.org/drawingml/2006/main"/>
+          <a:ln xmlns:a="http://schemas.openxmlformats.org/drawingml/2006/main" w="0">
+            <a:noFill/>
+          </a:ln>
+        </p:spPr>
+        <p:txBody>
+          <a:bodyPr xmlns:a="http://schemas.openxmlformats.org/drawingml/2006/main">
+            <a:noAutofit/>
+          </a:bodyPr>
+          <a:lstStyle xmlns:a="http://schemas.openxmlformats.org/drawingml/2006/main"/>
+          <a:p xmlns:a="http://schemas.openxmlformats.org/drawingml/2006/main">
+            <a:pPr>
+              <a:buNone/>
+              <a:defRPr sz="2100" b="0">
+                <a:solidFill>
+                  <a:srgbClr val="283A39"/>
+                </a:solidFill>
+                <a:latin typeface="Arial"/>
+                <a:ea typeface="Arial"/>
+                <a:cs typeface="Arial"/>
+              </a:defRPr>
+            </a:pPr>
+            <a:r>
+              <a:rPr sz="2100" b="0">
+                <a:solidFill>
+                  <a:srgbClr val="283A39"/>
+                </a:solidFill>
+                <a:latin typeface="Arial"/>
+                <a:ea typeface="Arial"/>
+                <a:cs typeface="Arial"/>
+              </a:rPr>
+              <a:t>Copy both lines into the same message box as your resume:</a:t>
             </a:r>
           </a:p>
         </p:txBody>
@@ -10475,79 +10474,79 @@
           <p:cNvPr id="4" name="">
             <a:extLst xmlns:a="http://schemas.openxmlformats.org/drawingml/2006/main">
               <a:ext uri="{FF2B5EF4-FFF2-40B4-BE49-F238E27FC236}">
-                <a16:creationId xmlns:a16="http://schemas.microsoft.com/office/drawing/2014/main" id="{70BFAC84-0CC4-46D6-ADEC-01EDAD91800C}"/>
-              </a:ext>
-            </a:extLst>
-          </p:cNvPr>
-          <p:cNvSpPr>
-            <a:spLocks xmlns:a="http://schemas.openxmlformats.org/drawingml/2006/main" noGrp="1"/>
-          </p:cNvSpPr>
-          <p:nvPr/>
-        </p:nvSpPr>
-        <p:spPr>
-          <a:xfrm xmlns:a="http://schemas.openxmlformats.org/drawingml/2006/main">
-            <a:off x="609600" y="3076575"/>
-            <a:ext cx="10820400" cy="1047750"/>
-          </a:xfrm>
-          <a:prstGeom xmlns:a="http://schemas.openxmlformats.org/drawingml/2006/main" prst="rect">
-            <a:avLst/>
-          </a:prstGeom>
-          <a:noFill xmlns:a="http://schemas.openxmlformats.org/drawingml/2006/main"/>
-          <a:ln xmlns:a="http://schemas.openxmlformats.org/drawingml/2006/main" w="0">
-            <a:noFill/>
-          </a:ln>
-        </p:spPr>
-        <p:txBody>
-          <a:bodyPr xmlns:a="http://schemas.openxmlformats.org/drawingml/2006/main">
-            <a:noAutofit/>
-          </a:bodyPr>
-          <a:lstStyle xmlns:a="http://schemas.openxmlformats.org/drawingml/2006/main"/>
-          <a:p xmlns:a="http://schemas.openxmlformats.org/drawingml/2006/main">
-            <a:pPr>
-              <a:buNone/>
-              <a:defRPr sz="2250" b="0">
-                <a:solidFill>
-                  <a:srgbClr val="283A39"/>
-                </a:solidFill>
-                <a:latin typeface="Arial"/>
-                <a:ea typeface="Arial"/>
-                <a:cs typeface="Arial"/>
-              </a:defRPr>
-            </a:pPr>
-            <a:r>
-              <a:rPr sz="2250" b="0">
-                <a:solidFill>
-                  <a:srgbClr val="283A39"/>
-                </a:solidFill>
-                <a:latin typeface="Arial"/>
-                <a:ea typeface="Arial"/>
-                <a:cs typeface="Arial"/>
-              </a:rPr>
-              <a:t>The AI checks Python 3.9+ and installs the document packages.</a:t>
-            </a:r>
-          </a:p>
-          <a:p xmlns:a="http://schemas.openxmlformats.org/drawingml/2006/main">
-            <a:pPr>
-              <a:buNone/>
-              <a:defRPr sz="2250" b="0">
-                <a:solidFill>
-                  <a:srgbClr val="283A39"/>
-                </a:solidFill>
-                <a:latin typeface="Arial"/>
-                <a:ea typeface="Arial"/>
-                <a:cs typeface="Arial"/>
-              </a:defRPr>
-            </a:pPr>
-            <a:r>
-              <a:rPr sz="2250" b="0">
-                <a:solidFill>
-                  <a:srgbClr val="283A39"/>
-                </a:solidFill>
-                <a:latin typeface="Arial"/>
-                <a:ea typeface="Arial"/>
-                <a:cs typeface="Arial"/>
-              </a:rPr>
-              <a:t>Node.js 22.20+ is only needed for the optional terminal installer.</a:t>
+                <a16:creationId xmlns:a16="http://schemas.microsoft.com/office/drawing/2014/main" id="{A83616AC-F1BB-4CD7-BA84-4EE26B811920}"/>
+              </a:ext>
+            </a:extLst>
+          </p:cNvPr>
+          <p:cNvSpPr>
+            <a:spLocks xmlns:a="http://schemas.openxmlformats.org/drawingml/2006/main" noGrp="1"/>
+          </p:cNvSpPr>
+          <p:nvPr/>
+        </p:nvSpPr>
+        <p:spPr>
+          <a:xfrm xmlns:a="http://schemas.openxmlformats.org/drawingml/2006/main">
+            <a:off x="609600" y="2638425"/>
+            <a:ext cx="10972800" cy="1381125"/>
+          </a:xfrm>
+          <a:prstGeom xmlns:a="http://schemas.openxmlformats.org/drawingml/2006/main" prst="rect">
+            <a:avLst/>
+          </a:prstGeom>
+          <a:noFill xmlns:a="http://schemas.openxmlformats.org/drawingml/2006/main"/>
+          <a:ln xmlns:a="http://schemas.openxmlformats.org/drawingml/2006/main" w="0">
+            <a:noFill/>
+          </a:ln>
+        </p:spPr>
+        <p:txBody>
+          <a:bodyPr xmlns:a="http://schemas.openxmlformats.org/drawingml/2006/main">
+            <a:noAutofit/>
+          </a:bodyPr>
+          <a:lstStyle xmlns:a="http://schemas.openxmlformats.org/drawingml/2006/main"/>
+          <a:p xmlns:a="http://schemas.openxmlformats.org/drawingml/2006/main">
+            <a:pPr>
+              <a:buNone/>
+              <a:defRPr sz="2400" b="1">
+                <a:solidFill>
+                  <a:srgbClr val="183F3B"/>
+                </a:solidFill>
+                <a:latin typeface="Arial"/>
+                <a:ea typeface="Arial"/>
+                <a:cs typeface="Arial"/>
+              </a:defRPr>
+            </a:pPr>
+            <a:r>
+              <a:rPr sz="2400" b="1">
+                <a:solidFill>
+                  <a:srgbClr val="183F3B"/>
+                </a:solidFill>
+                <a:latin typeface="Arial"/>
+                <a:ea typeface="Arial"/>
+                <a:cs typeface="Arial"/>
+              </a:rPr>
+              <a:t>Install https://github.com/toughdave/job-search for this project.</a:t>
+            </a:r>
+          </a:p>
+          <a:p xmlns:a="http://schemas.openxmlformats.org/drawingml/2006/main">
+            <a:pPr>
+              <a:buNone/>
+              <a:defRPr sz="2400" b="1">
+                <a:solidFill>
+                  <a:srgbClr val="183F3B"/>
+                </a:solidFill>
+                <a:latin typeface="Arial"/>
+                <a:ea typeface="Arial"/>
+                <a:cs typeface="Arial"/>
+              </a:defRPr>
+            </a:pPr>
+            <a:r>
+              <a:rPr sz="2400" b="1">
+                <a:solidFill>
+                  <a:srgbClr val="183F3B"/>
+                </a:solidFill>
+                <a:latin typeface="Arial"/>
+                <a:ea typeface="Arial"/>
+                <a:cs typeface="Arial"/>
+              </a:rPr>
+              <a:t>Then use job-search to start my search.</a:t>
             </a:r>
           </a:p>
         </p:txBody>
@@ -10557,79 +10556,79 @@
           <p:cNvPr id="5" name="">
             <a:extLst xmlns:a="http://schemas.openxmlformats.org/drawingml/2006/main">
               <a:ext uri="{FF2B5EF4-FFF2-40B4-BE49-F238E27FC236}">
-                <a16:creationId xmlns:a16="http://schemas.microsoft.com/office/drawing/2014/main" id="{A2A54DAE-2D8D-4F3A-AC6C-9C9D0355923E}"/>
-              </a:ext>
-            </a:extLst>
-          </p:cNvPr>
-          <p:cNvSpPr>
-            <a:spLocks xmlns:a="http://schemas.openxmlformats.org/drawingml/2006/main" noGrp="1"/>
-          </p:cNvSpPr>
-          <p:nvPr/>
-        </p:nvSpPr>
-        <p:spPr>
-          <a:xfrm xmlns:a="http://schemas.openxmlformats.org/drawingml/2006/main">
-            <a:off x="609600" y="4657725"/>
-            <a:ext cx="10820400" cy="1047750"/>
-          </a:xfrm>
-          <a:prstGeom xmlns:a="http://schemas.openxmlformats.org/drawingml/2006/main" prst="rect">
-            <a:avLst/>
-          </a:prstGeom>
-          <a:noFill xmlns:a="http://schemas.openxmlformats.org/drawingml/2006/main"/>
-          <a:ln xmlns:a="http://schemas.openxmlformats.org/drawingml/2006/main" w="0">
-            <a:noFill/>
-          </a:ln>
-        </p:spPr>
-        <p:txBody>
-          <a:bodyPr xmlns:a="http://schemas.openxmlformats.org/drawingml/2006/main">
-            <a:noAutofit/>
-          </a:bodyPr>
-          <a:lstStyle xmlns:a="http://schemas.openxmlformats.org/drawingml/2006/main"/>
-          <a:p xmlns:a="http://schemas.openxmlformats.org/drawingml/2006/main">
-            <a:pPr>
-              <a:buNone/>
-              <a:defRPr sz="2250" b="0">
-                <a:solidFill>
-                  <a:srgbClr val="283A39"/>
-                </a:solidFill>
-                <a:latin typeface="Arial"/>
-                <a:ea typeface="Arial"/>
-                <a:cs typeface="Arial"/>
-              </a:defRPr>
-            </a:pPr>
-            <a:r>
-              <a:rPr sz="2250" b="0">
-                <a:solidFill>
-                  <a:srgbClr val="283A39"/>
-                </a:solidFill>
-                <a:latin typeface="Arial"/>
-                <a:ea typeface="Arial"/>
-                <a:cs typeface="Arial"/>
-              </a:rPr>
-              <a:t>Your records stay in the project. Software stays in a local cache.</a:t>
-            </a:r>
-          </a:p>
-          <a:p xmlns:a="http://schemas.openxmlformats.org/drawingml/2006/main">
-            <a:pPr>
-              <a:buNone/>
-              <a:defRPr sz="2250" b="0">
-                <a:solidFill>
-                  <a:srgbClr val="283A39"/>
-                </a:solidFill>
-                <a:latin typeface="Arial"/>
-                <a:ea typeface="Arial"/>
-                <a:cs typeface="Arial"/>
-              </a:defRPr>
-            </a:pPr>
-            <a:r>
-              <a:rPr sz="2250" b="0">
-                <a:solidFill>
-                  <a:srgbClr val="283A39"/>
-                </a:solidFill>
-                <a:latin typeface="Arial"/>
-                <a:ea typeface="Arial"/>
-                <a:cs typeface="Arial"/>
-              </a:rPr>
-              <a:t>Ask the AI to preview that cache if you want to remove it.</a:t>
+                <a16:creationId xmlns:a16="http://schemas.microsoft.com/office/drawing/2014/main" id="{7B4A3C50-E8F9-4624-925E-4E928FA4FEC9}"/>
+              </a:ext>
+            </a:extLst>
+          </p:cNvPr>
+          <p:cNvSpPr>
+            <a:spLocks xmlns:a="http://schemas.openxmlformats.org/drawingml/2006/main" noGrp="1"/>
+          </p:cNvSpPr>
+          <p:nvPr/>
+        </p:nvSpPr>
+        <p:spPr>
+          <a:xfrm xmlns:a="http://schemas.openxmlformats.org/drawingml/2006/main">
+            <a:off x="609600" y="4562475"/>
+            <a:ext cx="10858500" cy="1019175"/>
+          </a:xfrm>
+          <a:prstGeom xmlns:a="http://schemas.openxmlformats.org/drawingml/2006/main" prst="rect">
+            <a:avLst/>
+          </a:prstGeom>
+          <a:noFill xmlns:a="http://schemas.openxmlformats.org/drawingml/2006/main"/>
+          <a:ln xmlns:a="http://schemas.openxmlformats.org/drawingml/2006/main" w="0">
+            <a:noFill/>
+          </a:ln>
+        </p:spPr>
+        <p:txBody>
+          <a:bodyPr xmlns:a="http://schemas.openxmlformats.org/drawingml/2006/main">
+            <a:noAutofit/>
+          </a:bodyPr>
+          <a:lstStyle xmlns:a="http://schemas.openxmlformats.org/drawingml/2006/main"/>
+          <a:p xmlns:a="http://schemas.openxmlformats.org/drawingml/2006/main">
+            <a:pPr>
+              <a:buNone/>
+              <a:defRPr sz="2100" b="0">
+                <a:solidFill>
+                  <a:srgbClr val="283A39"/>
+                </a:solidFill>
+                <a:latin typeface="Arial"/>
+                <a:ea typeface="Arial"/>
+                <a:cs typeface="Arial"/>
+              </a:defRPr>
+            </a:pPr>
+            <a:r>
+              <a:rPr sz="2100" b="0">
+                <a:solidFill>
+                  <a:srgbClr val="283A39"/>
+                </a:solidFill>
+                <a:latin typeface="Arial"/>
+                <a:ea typeface="Arial"/>
+                <a:cs typeface="Arial"/>
+              </a:rPr>
+              <a:t>Add your resume location or no-resume sentence if needed.</a:t>
+            </a:r>
+          </a:p>
+          <a:p xmlns:a="http://schemas.openxmlformats.org/drawingml/2006/main">
+            <a:pPr>
+              <a:buNone/>
+              <a:defRPr sz="2100" b="0">
+                <a:solidFill>
+                  <a:srgbClr val="283A39"/>
+                </a:solidFill>
+                <a:latin typeface="Arial"/>
+                <a:ea typeface="Arial"/>
+                <a:cs typeface="Arial"/>
+              </a:defRPr>
+            </a:pPr>
+            <a:r>
+              <a:rPr sz="2100" b="0">
+                <a:solidFill>
+                  <a:srgbClr val="283A39"/>
+                </a:solidFill>
+                <a:latin typeface="Arial"/>
+                <a:ea typeface="Arial"/>
+                <a:cs typeface="Arial"/>
+              </a:rPr>
+              <a:t>Press Send once. Follow any installation approval or restart request.</a:t>
             </a:r>
           </a:p>
         </p:txBody>
@@ -10639,55 +10638,56 @@
           <p:cNvPr id="6" name="">
             <a:extLst xmlns:a="http://schemas.openxmlformats.org/drawingml/2006/main">
               <a:ext uri="{FF2B5EF4-FFF2-40B4-BE49-F238E27FC236}">
-                <a16:creationId xmlns:a16="http://schemas.microsoft.com/office/drawing/2014/main" id="{00FB7D96-FFB8-408C-B3BC-1E0EF986C1E5}"/>
-              </a:ext>
-            </a:extLst>
-          </p:cNvPr>
-          <p:cNvSpPr>
-            <a:spLocks xmlns:a="http://schemas.openxmlformats.org/drawingml/2006/main" noGrp="1"/>
-          </p:cNvSpPr>
-          <p:nvPr/>
-        </p:nvSpPr>
-        <p:spPr>
-          <a:xfrm xmlns:a="http://schemas.openxmlformats.org/drawingml/2006/main">
-            <a:off x="609600" y="5905500"/>
-            <a:ext cx="10820400" cy="361950"/>
-          </a:xfrm>
-          <a:prstGeom xmlns:a="http://schemas.openxmlformats.org/drawingml/2006/main" prst="rect">
-            <a:avLst/>
-          </a:prstGeom>
-          <a:noFill xmlns:a="http://schemas.openxmlformats.org/drawingml/2006/main"/>
-          <a:ln xmlns:a="http://schemas.openxmlformats.org/drawingml/2006/main" w="0">
-            <a:noFill/>
-          </a:ln>
-        </p:spPr>
-        <p:txBody>
-          <a:bodyPr xmlns:a="http://schemas.openxmlformats.org/drawingml/2006/main">
-            <a:noAutofit/>
-          </a:bodyPr>
-          <a:lstStyle xmlns:a="http://schemas.openxmlformats.org/drawingml/2006/main"/>
-          <a:p xmlns:a="http://schemas.openxmlformats.org/drawingml/2006/main">
-            <a:pPr>
-              <a:buNone/>
-              <a:defRPr sz="1800" b="0">
-                <a:solidFill>
-                  <a:srgbClr val="607370"/>
-                </a:solidFill>
-                <a:latin typeface="Arial"/>
-                <a:ea typeface="Arial"/>
-                <a:cs typeface="Arial"/>
-              </a:defRPr>
-            </a:pPr>
-            <a:r>
-              <a:rPr sz="1800" b="0">
-                <a:solidFill>
-                  <a:srgbClr val="607370"/>
-                </a:solidFill>
-                <a:latin typeface="Arial"/>
-                <a:ea typeface="Arial"/>
-                <a:cs typeface="Arial"/>
-              </a:rPr>
-              <a:t>Word uploads also need a DOCX renderer, such as Word or LibreOffice.</a:t>
+                <a16:creationId xmlns:a16="http://schemas.microsoft.com/office/drawing/2014/main" id="{85AFAACC-D536-4186-B98C-BC589C94E5EE}"/>
+              </a:ext>
+            </a:extLst>
+          </p:cNvPr>
+          <p:cNvSpPr>
+            <a:spLocks xmlns:a="http://schemas.openxmlformats.org/drawingml/2006/main" noGrp="1"/>
+          </p:cNvSpPr>
+          <p:nvPr/>
+        </p:nvSpPr>
+        <p:spPr>
+          <a:xfrm xmlns:a="http://schemas.openxmlformats.org/drawingml/2006/main">
+            <a:off x="609600" y="5781675"/>
+            <a:ext cx="5715000" cy="361950"/>
+          </a:xfrm>
+          <a:prstGeom xmlns:a="http://schemas.openxmlformats.org/drawingml/2006/main" prst="rect">
+            <a:avLst/>
+          </a:prstGeom>
+          <a:noFill xmlns:a="http://schemas.openxmlformats.org/drawingml/2006/main"/>
+          <a:ln xmlns:a="http://schemas.openxmlformats.org/drawingml/2006/main" w="0">
+            <a:noFill/>
+          </a:ln>
+        </p:spPr>
+        <p:txBody>
+          <a:bodyPr xmlns:a="http://schemas.openxmlformats.org/drawingml/2006/main">
+            <a:noAutofit/>
+          </a:bodyPr>
+          <a:lstStyle xmlns:a="http://schemas.openxmlformats.org/drawingml/2006/main"/>
+          <a:p xmlns:a="http://schemas.openxmlformats.org/drawingml/2006/main">
+            <a:pPr>
+              <a:buNone/>
+              <a:defRPr sz="1875" b="0">
+                <a:solidFill>
+                  <a:srgbClr val="087F73"/>
+                </a:solidFill>
+                <a:latin typeface="Arial"/>
+                <a:ea typeface="Arial"/>
+                <a:cs typeface="Arial"/>
+              </a:defRPr>
+            </a:pPr>
+            <a:r>
+              <a:rPr sz="1875" b="0">
+                <a:solidFill>
+                  <a:srgbClr val="087F73"/>
+                </a:solidFill>
+                <a:latin typeface="Arial"/>
+                <a:ea typeface="Arial"/>
+                <a:cs typeface="Arial"/>
+                <a:hlinkClick xmlns:r="http://schemas.openxmlformats.org/officeDocument/2006/relationships" r:id="R63c56d8c2c2d4768"/>
+              </a:rPr>
+              <a:t>Copy from the README</a:t>
             </a:r>
           </a:p>
         </p:txBody>
@@ -10695,7 +10695,7 @@
     </p:spTree>
     <p:extLst>
       <p:ext uri="{BB962C8B-B14F-4D97-AF65-F5344CB8AC3E}">
-        <p14:creationId xmlns:p14="http://schemas.microsoft.com/office/powerpoint/2010/main" val="687054172"/>
+        <p14:creationId xmlns:p14="http://schemas.microsoft.com/office/powerpoint/2010/main" val="967384215"/>
       </p:ext>
     </p:extLst>
   </p:cSld>

</xml_diff>

<commit_message>
Require saved-form completion checks before application readiness
</commit_message>
<xml_diff>
--- a/docs/job-search-guide.pptx
+++ b/docs/job-search-guide.pptx
@@ -2,32 +2,33 @@
 <file path=ppt/presentation.xml><?xml version="1.0" encoding="utf-8"?>
 <p:presentation xmlns:p="http://schemas.openxmlformats.org/presentationml/2006/main">
   <p:sldMasterIdLst>
-    <p:sldMasterId xmlns:r="http://schemas.openxmlformats.org/officeDocument/2006/relationships" id="2147483648" r:id="R4e7b5e3fe0bb45fb"/>
+    <p:sldMasterId xmlns:r="http://schemas.openxmlformats.org/officeDocument/2006/relationships" id="2147483648" r:id="Rab8d581475764358"/>
   </p:sldMasterIdLst>
   <p:notesMasterIdLst>
-    <p:notesMasterId xmlns:r="http://schemas.openxmlformats.org/officeDocument/2006/relationships" r:id="Rbafb784f82a240e7"/>
+    <p:notesMasterId xmlns:r="http://schemas.openxmlformats.org/officeDocument/2006/relationships" r:id="R960565ce5f424b7e"/>
   </p:notesMasterIdLst>
   <p:sldIdLst>
-    <p:sldId xmlns:r="http://schemas.openxmlformats.org/officeDocument/2006/relationships" id="256" r:id="R04ca67344e1b4f5e"/>
-    <p:sldId xmlns:r="http://schemas.openxmlformats.org/officeDocument/2006/relationships" id="257" r:id="R724167bcaa8b4a49"/>
-    <p:sldId xmlns:r="http://schemas.openxmlformats.org/officeDocument/2006/relationships" id="258" r:id="R4c8e66a766684571"/>
-    <p:sldId xmlns:r="http://schemas.openxmlformats.org/officeDocument/2006/relationships" id="259" r:id="Rdfc437a161704a27"/>
-    <p:sldId xmlns:r="http://schemas.openxmlformats.org/officeDocument/2006/relationships" id="260" r:id="R09e63352262a4c80"/>
-    <p:sldId xmlns:r="http://schemas.openxmlformats.org/officeDocument/2006/relationships" id="261" r:id="R10d804b620c6499a"/>
-    <p:sldId xmlns:r="http://schemas.openxmlformats.org/officeDocument/2006/relationships" id="262" r:id="R1a74f756549f494e"/>
-    <p:sldId xmlns:r="http://schemas.openxmlformats.org/officeDocument/2006/relationships" id="263" r:id="Rf1e22887f1274119"/>
-    <p:sldId xmlns:r="http://schemas.openxmlformats.org/officeDocument/2006/relationships" id="264" r:id="Rb27cbcb3e6ef4419"/>
-    <p:sldId xmlns:r="http://schemas.openxmlformats.org/officeDocument/2006/relationships" id="265" r:id="Re7943dd3a6b24206"/>
-    <p:sldId xmlns:r="http://schemas.openxmlformats.org/officeDocument/2006/relationships" id="266" r:id="R00eef000d0154208"/>
-    <p:sldId xmlns:r="http://schemas.openxmlformats.org/officeDocument/2006/relationships" id="267" r:id="R8af1cf62ec884419"/>
-    <p:sldId xmlns:r="http://schemas.openxmlformats.org/officeDocument/2006/relationships" id="268" r:id="R47647735015c4dc6"/>
-    <p:sldId xmlns:r="http://schemas.openxmlformats.org/officeDocument/2006/relationships" id="269" r:id="R6b7c89380d9e4cc7"/>
-    <p:sldId xmlns:r="http://schemas.openxmlformats.org/officeDocument/2006/relationships" id="270" r:id="R3c6296325302406a"/>
-    <p:sldId xmlns:r="http://schemas.openxmlformats.org/officeDocument/2006/relationships" id="271" r:id="Rba9b435447f24438"/>
-    <p:sldId xmlns:r="http://schemas.openxmlformats.org/officeDocument/2006/relationships" id="272" r:id="R8994168899204eee"/>
-    <p:sldId xmlns:r="http://schemas.openxmlformats.org/officeDocument/2006/relationships" id="273" r:id="R712b8cdfec0740aa"/>
-    <p:sldId xmlns:r="http://schemas.openxmlformats.org/officeDocument/2006/relationships" id="274" r:id="R64cd07a969594055"/>
-    <p:sldId xmlns:r="http://schemas.openxmlformats.org/officeDocument/2006/relationships" id="275" r:id="Rde15ad0ee6ec4a8a"/>
+    <p:sldId xmlns:r="http://schemas.openxmlformats.org/officeDocument/2006/relationships" id="256" r:id="R53768ee463ef49fe"/>
+    <p:sldId xmlns:r="http://schemas.openxmlformats.org/officeDocument/2006/relationships" id="257" r:id="R74e0111f1cc744dc"/>
+    <p:sldId xmlns:r="http://schemas.openxmlformats.org/officeDocument/2006/relationships" id="258" r:id="R89153d2c2f2047ef"/>
+    <p:sldId xmlns:r="http://schemas.openxmlformats.org/officeDocument/2006/relationships" id="259" r:id="R702c3483b9da4c32"/>
+    <p:sldId xmlns:r="http://schemas.openxmlformats.org/officeDocument/2006/relationships" id="260" r:id="Rd5dd379f4606407b"/>
+    <p:sldId xmlns:r="http://schemas.openxmlformats.org/officeDocument/2006/relationships" id="261" r:id="R781b81e5b81445df"/>
+    <p:sldId xmlns:r="http://schemas.openxmlformats.org/officeDocument/2006/relationships" id="262" r:id="R5cd081f57a76402d"/>
+    <p:sldId xmlns:r="http://schemas.openxmlformats.org/officeDocument/2006/relationships" id="263" r:id="R6ee9fae6120a415b"/>
+    <p:sldId xmlns:r="http://schemas.openxmlformats.org/officeDocument/2006/relationships" id="264" r:id="Rb9ba8ca223984431"/>
+    <p:sldId xmlns:r="http://schemas.openxmlformats.org/officeDocument/2006/relationships" id="265" r:id="Rcd391bee7ad14cb8"/>
+    <p:sldId xmlns:r="http://schemas.openxmlformats.org/officeDocument/2006/relationships" id="266" r:id="R9ed08ba151f64faf"/>
+    <p:sldId xmlns:r="http://schemas.openxmlformats.org/officeDocument/2006/relationships" id="267" r:id="Rb3aba828b92a4853"/>
+    <p:sldId xmlns:r="http://schemas.openxmlformats.org/officeDocument/2006/relationships" id="268" r:id="Rf8eac4ff4e094ad4"/>
+    <p:sldId xmlns:r="http://schemas.openxmlformats.org/officeDocument/2006/relationships" id="269" r:id="Rb230648b6f0a4a7e"/>
+    <p:sldId xmlns:r="http://schemas.openxmlformats.org/officeDocument/2006/relationships" id="270" r:id="R151ab4cefc89450c"/>
+    <p:sldId xmlns:r="http://schemas.openxmlformats.org/officeDocument/2006/relationships" id="271" r:id="R22dd67c157064f3b"/>
+    <p:sldId xmlns:r="http://schemas.openxmlformats.org/officeDocument/2006/relationships" id="272" r:id="Re483d40aa6144ba0"/>
+    <p:sldId xmlns:r="http://schemas.openxmlformats.org/officeDocument/2006/relationships" id="273" r:id="Re44d5d76e1054c58"/>
+    <p:sldId xmlns:r="http://schemas.openxmlformats.org/officeDocument/2006/relationships" id="274" r:id="R7cab26d2677a4fc8"/>
+    <p:sldId xmlns:r="http://schemas.openxmlformats.org/officeDocument/2006/relationships" id="275" r:id="Rc5f3a2748aa346f7"/>
+    <p:sldId xmlns:r="http://schemas.openxmlformats.org/officeDocument/2006/relationships" id="276" r:id="Rd561fee023f7443e"/>
   </p:sldIdLst>
   <p:sldSz cx="12192000" cy="6858000"/>
   <p:notesSz cx="6858000" cy="9144000"/>
@@ -1151,22 +1152,7 @@
           <a:lstStyle xmlns:a="http://schemas.openxmlformats.org/drawingml/2006/main"/>
           <a:p xmlns:a="http://schemas.openxmlformats.org/drawingml/2006/main">
             <a:r>
-              <a:t>Official invocation sources: https://learn.chatgpt.com/docs/build-skills#how-chatgpt-and-codex-use-skills</a:t>
-            </a:r>
-          </a:p>
-          <a:p xmlns:a="http://schemas.openxmlformats.org/drawingml/2006/main">
-            <a:r>
-              <a:t>https://code.claude.com/docs/en/skills</a:t>
-            </a:r>
-          </a:p>
-          <a:p xmlns:a="http://schemas.openxmlformats.org/drawingml/2006/main">
-            <a:r>
-              <a:t>Workflow source: https://github.com/toughdave/job-search</a:t>
-            </a:r>
-          </a:p>
-          <a:p xmlns:a="http://schemas.openxmlformats.org/drawingml/2006/main">
-            <a:r>
-              <a:t>Guide checked 12 September 2026.</a:t>
+              <a:t>The skill compares the saved form with an independently derived candidate inventory, retains private evidence and checks consistency with form_review.py. An enabled Submit button alone is insufficient. The helper does not inspect the browser itself; actual saved-form inspection, document visual review and separate final-submission authorization remain required. Source: https://github.com/toughdave/job-search/blob/main/skills/job-search/references/form-completeness.md</a:t>
             </a:r>
           </a:p>
         </p:txBody>
@@ -1236,7 +1222,12 @@
           <a:lstStyle xmlns:a="http://schemas.openxmlformats.org/drawingml/2006/main"/>
           <a:p xmlns:a="http://schemas.openxmlformats.org/drawingml/2006/main">
             <a:r>
-              <a:t/>
+              <a:t>Official invocation sources: https://learn.chatgpt.com/docs/build-skills#how-chatgpt-and-codex-use-skills</a:t>
+            </a:r>
+          </a:p>
+          <a:p xmlns:a="http://schemas.openxmlformats.org/drawingml/2006/main">
+            <a:r>
+              <a:t>https://code.claude.com/docs/en/skills</a:t>
             </a:r>
           </a:p>
           <a:p xmlns:a="http://schemas.openxmlformats.org/drawingml/2006/main">
@@ -1372,6 +1363,86 @@
 </file>
 
 <file path=ppt/notesSlides/notesSlide20.xml><?xml version="1.0" encoding="utf-8"?>
+<p:notes xmlns:p="http://schemas.openxmlformats.org/presentationml/2006/main">
+  <p:cSld>
+    <p:spTree>
+      <p:nvGrpSpPr>
+        <p:cNvPr id="1" name=""/>
+        <p:cNvGrpSpPr/>
+        <p:nvPr/>
+      </p:nvGrpSpPr>
+      <p:grpSpPr>
+        <a:xfrm xmlns:a="http://schemas.openxmlformats.org/drawingml/2006/main"/>
+      </p:grpSpPr>
+      <p:sp>
+        <p:nvSpPr>
+          <p:cNvPr id="2" name="Slide Image Placeholder 1"/>
+          <p:cNvSpPr>
+            <a:spLocks xmlns:a="http://schemas.openxmlformats.org/drawingml/2006/main" noGrp="1"/>
+          </p:cNvSpPr>
+          <p:nvPr>
+            <p:ph type="sldImg" idx="0"/>
+          </p:nvPr>
+        </p:nvSpPr>
+        <p:spPr/>
+      </p:sp>
+      <p:sp>
+        <p:nvSpPr>
+          <p:cNvPr id="3" name="Notes Placeholder 2"/>
+          <p:cNvSpPr>
+            <a:spLocks xmlns:a="http://schemas.openxmlformats.org/drawingml/2006/main" noGrp="1"/>
+          </p:cNvSpPr>
+          <p:nvPr>
+            <p:ph type="body" idx="1"/>
+          </p:nvPr>
+        </p:nvSpPr>
+        <p:spPr/>
+        <p:txBody>
+          <a:bodyPr xmlns:a="http://schemas.openxmlformats.org/drawingml/2006/main"/>
+          <a:lstStyle xmlns:a="http://schemas.openxmlformats.org/drawingml/2006/main"/>
+          <a:p xmlns:a="http://schemas.openxmlformats.org/drawingml/2006/main">
+            <a:r>
+              <a:t/>
+            </a:r>
+          </a:p>
+          <a:p xmlns:a="http://schemas.openxmlformats.org/drawingml/2006/main">
+            <a:r>
+              <a:t>Workflow source: https://github.com/toughdave/job-search</a:t>
+            </a:r>
+          </a:p>
+          <a:p xmlns:a="http://schemas.openxmlformats.org/drawingml/2006/main">
+            <a:r>
+              <a:t>Guide checked 12 September 2026.</a:t>
+            </a:r>
+          </a:p>
+        </p:txBody>
+      </p:sp>
+      <p:sp>
+        <p:nvSpPr>
+          <p:cNvPr id="4" name="Slide Number Placeholder 3"/>
+          <p:cNvSpPr>
+            <a:spLocks xmlns:a="http://schemas.openxmlformats.org/drawingml/2006/main" noGrp="1"/>
+          </p:cNvSpPr>
+          <p:nvPr>
+            <p:ph type="sldNum" idx="5"/>
+          </p:nvPr>
+        </p:nvSpPr>
+        <p:spPr/>
+        <p:txBody>
+          <a:bodyPr xmlns:a="http://schemas.openxmlformats.org/drawingml/2006/main"/>
+          <a:lstStyle xmlns:a="http://schemas.openxmlformats.org/drawingml/2006/main"/>
+          <a:p xmlns:a="http://schemas.openxmlformats.org/drawingml/2006/main"/>
+        </p:txBody>
+      </p:sp>
+    </p:spTree>
+  </p:cSld>
+  <p:clrMapOvr>
+    <a:masterClrMapping xmlns:a="http://schemas.openxmlformats.org/drawingml/2006/main"/>
+  </p:clrMapOvr>
+</p:notes>
+</file>
+
+<file path=ppt/notesSlides/notesSlide21.xml><?xml version="1.0" encoding="utf-8"?>
 <p:notes xmlns:p="http://schemas.openxmlformats.org/presentationml/2006/main">
   <p:cSld>
     <p:spTree>
@@ -2044,7 +2115,7 @@
   </p:cSld>
   <p:clrMap bg1="lt1" tx1="dk1" bg2="lt2" tx2="dk2" accent1="accent1" accent2="accent2" accent3="accent3" accent4="accent4" accent5="accent5" accent6="accent6" hlink="hlink" folHlink="folHlink"/>
   <p:sldLayoutIdLst>
-    <p:sldLayoutId xmlns:r="http://schemas.openxmlformats.org/officeDocument/2006/relationships" id="2147483649" r:id="Rd38c7af35c744ab7"/>
+    <p:sldLayoutId xmlns:r="http://schemas.openxmlformats.org/officeDocument/2006/relationships" id="2147483649" r:id="R8f8bc791fdcc4621"/>
   </p:sldLayoutIdLst>
   <p:txStyles>
     <p:titleStyle>
@@ -2840,7 +2911,7 @@
                 <a:latin typeface="Arial"/>
                 <a:ea typeface="Arial"/>
                 <a:cs typeface="Arial"/>
-                <a:hlinkClick xmlns:r="http://schemas.openxmlformats.org/officeDocument/2006/relationships" r:id="Rfe5406a57d5d4b31"/>
+                <a:hlinkClick xmlns:r="http://schemas.openxmlformats.org/officeDocument/2006/relationships" r:id="Rc9f14c07dfad4ed4"/>
               </a:rPr>
               <a:t>Open the GitHub guide</a:t>
             </a:r>
@@ -3266,7 +3337,7 @@
                 <a:latin typeface="Arial"/>
                 <a:ea typeface="Arial"/>
                 <a:cs typeface="Arial"/>
-                <a:hlinkClick xmlns:r="http://schemas.openxmlformats.org/officeDocument/2006/relationships" r:id="R57857b54cc834d8a"/>
+                <a:hlinkClick xmlns:r="http://schemas.openxmlformats.org/officeDocument/2006/relationships" r:id="R26d919dbc40c443d"/>
               </a:rPr>
               <a:t>Copy from the README</a:t>
             </a:r>
@@ -3798,7 +3869,7 @@
                 <a:latin typeface="Arial"/>
                 <a:ea typeface="Arial"/>
                 <a:cs typeface="Arial"/>
-                <a:hlinkClick xmlns:r="http://schemas.openxmlformats.org/officeDocument/2006/relationships" r:id="Ra11c576f3c18462e"/>
+                <a:hlinkClick xmlns:r="http://schemas.openxmlformats.org/officeDocument/2006/relationships" r:id="Rb3a388aba0164483"/>
               </a:rPr>
               <a:t>Read the app-specific instructions</a:t>
             </a:r>
@@ -5639,7 +5710,7 @@
                 <a:latin typeface="Arial"/>
                 <a:ea typeface="Arial"/>
                 <a:cs typeface="Arial"/>
-                <a:hlinkClick xmlns:r="http://schemas.openxmlformats.org/officeDocument/2006/relationships" r:id="Re8790b49867642d7"/>
+                <a:hlinkClick xmlns:r="http://schemas.openxmlformats.org/officeDocument/2006/relationships" r:id="Rfea1fff3a071409a"/>
               </a:rPr>
               <a:t>Read the daily-search guide</a:t>
             </a:r>
@@ -6527,10 +6598,10 @@
       </p:grpSpPr>
       <p:sp>
         <p:nvSpPr>
-          <p:cNvPr id="9" name="">
-            <a:extLst xmlns:a="http://schemas.openxmlformats.org/drawingml/2006/main">
-              <a:ext uri="{FF2B5EF4-FFF2-40B4-BE49-F238E27FC236}">
-                <a16:creationId xmlns:a16="http://schemas.microsoft.com/office/drawing/2014/main" id="{2A062370-BA4B-4D31-93F4-AF326E0A26FB}"/>
+          <p:cNvPr id="8" name="">
+            <a:extLst xmlns:a="http://schemas.openxmlformats.org/drawingml/2006/main">
+              <a:ext uri="{FF2B5EF4-FFF2-40B4-BE49-F238E27FC236}">
+                <a16:creationId xmlns:a16="http://schemas.microsoft.com/office/drawing/2014/main" id="{D1632CCC-FD71-4504-853A-C9EB9DAE7B5F}"/>
               </a:ext>
             </a:extLst>
           </p:cNvPr>
@@ -6578,7 +6649,7 @@
                 <a:ea typeface="Arial"/>
                 <a:cs typeface="Arial"/>
               </a:rPr>
-              <a:t>Codex and Claude shortcuts</a:t>
+              <a:t>Before you submit</a:t>
             </a:r>
           </a:p>
         </p:txBody>
@@ -6588,7 +6659,7 @@
           <p:cNvPr id="2" name="">
             <a:extLst xmlns:a="http://schemas.openxmlformats.org/drawingml/2006/main">
               <a:ext uri="{FF2B5EF4-FFF2-40B4-BE49-F238E27FC236}">
-                <a16:creationId xmlns:a16="http://schemas.microsoft.com/office/drawing/2014/main" id="{EB42D7E3-D406-4693-88DD-C0CD9A24667B}"/>
+                <a16:creationId xmlns:a16="http://schemas.microsoft.com/office/drawing/2014/main" id="{29EFFDE2-4509-4A3D-A72F-FA6BA1B867D1}"/>
               </a:ext>
             </a:extLst>
           </p:cNvPr>
@@ -6646,55 +6717,79 @@
           <p:cNvPr id="3" name="">
             <a:extLst xmlns:a="http://schemas.openxmlformats.org/drawingml/2006/main">
               <a:ext uri="{FF2B5EF4-FFF2-40B4-BE49-F238E27FC236}">
-                <a16:creationId xmlns:a16="http://schemas.microsoft.com/office/drawing/2014/main" id="{CDCDA268-36D0-473A-9069-E71EE9A06AA6}"/>
-              </a:ext>
-            </a:extLst>
-          </p:cNvPr>
-          <p:cNvSpPr>
-            <a:spLocks xmlns:a="http://schemas.openxmlformats.org/drawingml/2006/main" noGrp="1"/>
-          </p:cNvSpPr>
-          <p:nvPr/>
-        </p:nvSpPr>
-        <p:spPr>
-          <a:xfrm xmlns:a="http://schemas.openxmlformats.org/drawingml/2006/main">
-            <a:off x="609600" y="1514475"/>
-            <a:ext cx="10839450" cy="428625"/>
-          </a:xfrm>
-          <a:prstGeom xmlns:a="http://schemas.openxmlformats.org/drawingml/2006/main" prst="rect">
-            <a:avLst/>
-          </a:prstGeom>
-          <a:noFill xmlns:a="http://schemas.openxmlformats.org/drawingml/2006/main"/>
-          <a:ln xmlns:a="http://schemas.openxmlformats.org/drawingml/2006/main" w="0">
-            <a:noFill/>
-          </a:ln>
-        </p:spPr>
-        <p:txBody>
-          <a:bodyPr xmlns:a="http://schemas.openxmlformats.org/drawingml/2006/main">
-            <a:noAutofit/>
-          </a:bodyPr>
-          <a:lstStyle xmlns:a="http://schemas.openxmlformats.org/drawingml/2006/main"/>
-          <a:p xmlns:a="http://schemas.openxmlformats.org/drawingml/2006/main">
-            <a:pPr>
-              <a:buNone/>
-              <a:defRPr sz="2250" b="1">
-                <a:solidFill>
-                  <a:srgbClr val="183F3B"/>
-                </a:solidFill>
-                <a:latin typeface="Arial"/>
-                <a:ea typeface="Arial"/>
-                <a:cs typeface="Arial"/>
-              </a:defRPr>
-            </a:pPr>
-            <a:r>
-              <a:rPr sz="2250" b="1">
-                <a:solidFill>
-                  <a:srgbClr val="183F3B"/>
-                </a:solidFill>
-                <a:latin typeface="Arial"/>
-                <a:ea typeface="Arial"/>
-                <a:cs typeface="Arial"/>
-              </a:rPr>
-              <a:t>Codex / ChatGPT desktop</a:t>
+                <a16:creationId xmlns:a16="http://schemas.microsoft.com/office/drawing/2014/main" id="{1612BF25-0EE9-4613-BBAC-00A0BC3C8C6B}"/>
+              </a:ext>
+            </a:extLst>
+          </p:cNvPr>
+          <p:cNvSpPr>
+            <a:spLocks xmlns:a="http://schemas.openxmlformats.org/drawingml/2006/main" noGrp="1"/>
+          </p:cNvSpPr>
+          <p:nvPr/>
+        </p:nvSpPr>
+        <p:spPr>
+          <a:xfrm xmlns:a="http://schemas.openxmlformats.org/drawingml/2006/main">
+            <a:off x="609600" y="1447800"/>
+            <a:ext cx="10820400" cy="857250"/>
+          </a:xfrm>
+          <a:prstGeom xmlns:a="http://schemas.openxmlformats.org/drawingml/2006/main" prst="rect">
+            <a:avLst/>
+          </a:prstGeom>
+          <a:noFill xmlns:a="http://schemas.openxmlformats.org/drawingml/2006/main"/>
+          <a:ln xmlns:a="http://schemas.openxmlformats.org/drawingml/2006/main" w="0">
+            <a:noFill/>
+          </a:ln>
+        </p:spPr>
+        <p:txBody>
+          <a:bodyPr xmlns:a="http://schemas.openxmlformats.org/drawingml/2006/main">
+            <a:noAutofit/>
+          </a:bodyPr>
+          <a:lstStyle xmlns:a="http://schemas.openxmlformats.org/drawingml/2006/main"/>
+          <a:p xmlns:a="http://schemas.openxmlformats.org/drawingml/2006/main">
+            <a:pPr>
+              <a:buNone/>
+              <a:defRPr sz="2250" b="0">
+                <a:solidFill>
+                  <a:srgbClr val="283A39"/>
+                </a:solidFill>
+                <a:latin typeface="Arial"/>
+                <a:ea typeface="Arial"/>
+                <a:cs typeface="Arial"/>
+              </a:defRPr>
+            </a:pPr>
+            <a:r>
+              <a:rPr sz="2250" b="0">
+                <a:solidFill>
+                  <a:srgbClr val="283A39"/>
+                </a:solidFill>
+                <a:latin typeface="Arial"/>
+                <a:ea typeface="Arial"/>
+                <a:cs typeface="Arial"/>
+              </a:rPr>
+              <a:t>a. The AI compares the saved work history and education</a:t>
+            </a:r>
+          </a:p>
+          <a:p xmlns:a="http://schemas.openxmlformats.org/drawingml/2006/main">
+            <a:pPr>
+              <a:buNone/>
+              <a:defRPr sz="2250" b="0">
+                <a:solidFill>
+                  <a:srgbClr val="283A39"/>
+                </a:solidFill>
+                <a:latin typeface="Arial"/>
+                <a:ea typeface="Arial"/>
+                <a:cs typeface="Arial"/>
+              </a:defRPr>
+            </a:pPr>
+            <a:r>
+              <a:rPr sz="2250" b="0">
+                <a:solidFill>
+                  <a:srgbClr val="283A39"/>
+                </a:solidFill>
+                <a:latin typeface="Arial"/>
+                <a:ea typeface="Arial"/>
+                <a:cs typeface="Arial"/>
+              </a:rPr>
+              <a:t>    with your evidence, including entries the form missed.</a:t>
             </a:r>
           </a:p>
         </p:txBody>
@@ -6704,79 +6799,79 @@
           <p:cNvPr id="4" name="">
             <a:extLst xmlns:a="http://schemas.openxmlformats.org/drawingml/2006/main">
               <a:ext uri="{FF2B5EF4-FFF2-40B4-BE49-F238E27FC236}">
-                <a16:creationId xmlns:a16="http://schemas.microsoft.com/office/drawing/2014/main" id="{9B3F3F08-8472-422B-AE8F-32202650C21B}"/>
-              </a:ext>
-            </a:extLst>
-          </p:cNvPr>
-          <p:cNvSpPr>
-            <a:spLocks xmlns:a="http://schemas.openxmlformats.org/drawingml/2006/main" noGrp="1"/>
-          </p:cNvSpPr>
-          <p:nvPr/>
-        </p:nvSpPr>
-        <p:spPr>
-          <a:xfrm xmlns:a="http://schemas.openxmlformats.org/drawingml/2006/main">
-            <a:off x="609600" y="2047875"/>
-            <a:ext cx="10839450" cy="866775"/>
-          </a:xfrm>
-          <a:prstGeom xmlns:a="http://schemas.openxmlformats.org/drawingml/2006/main" prst="rect">
-            <a:avLst/>
-          </a:prstGeom>
-          <a:noFill xmlns:a="http://schemas.openxmlformats.org/drawingml/2006/main"/>
-          <a:ln xmlns:a="http://schemas.openxmlformats.org/drawingml/2006/main" w="0">
-            <a:noFill/>
-          </a:ln>
-        </p:spPr>
-        <p:txBody>
-          <a:bodyPr xmlns:a="http://schemas.openxmlformats.org/drawingml/2006/main">
-            <a:noAutofit/>
-          </a:bodyPr>
-          <a:lstStyle xmlns:a="http://schemas.openxmlformats.org/drawingml/2006/main"/>
-          <a:p xmlns:a="http://schemas.openxmlformats.org/drawingml/2006/main">
-            <a:pPr>
-              <a:buNone/>
-              <a:defRPr sz="2100" b="0">
-                <a:solidFill>
-                  <a:srgbClr val="283A39"/>
-                </a:solidFill>
-                <a:latin typeface="Arial"/>
-                <a:ea typeface="Arial"/>
-                <a:cs typeface="Arial"/>
-              </a:defRPr>
-            </a:pPr>
-            <a:r>
-              <a:rPr sz="2100" b="0">
-                <a:solidFill>
-                  <a:srgbClr val="283A39"/>
-                </a:solidFill>
-                <a:latin typeface="Arial"/>
-                <a:ea typeface="Arial"/>
-                <a:cs typeface="Arial"/>
-              </a:rPr>
-              <a:t>Type @ and choose job-search. If your composer offers a $</a:t>
-            </a:r>
-          </a:p>
-          <a:p xmlns:a="http://schemas.openxmlformats.org/drawingml/2006/main">
-            <a:pPr>
-              <a:buNone/>
-              <a:defRPr sz="2100" b="0">
-                <a:solidFill>
-                  <a:srgbClr val="283A39"/>
-                </a:solidFill>
-                <a:latin typeface="Arial"/>
-                <a:ea typeface="Arial"/>
-                <a:cs typeface="Arial"/>
-              </a:defRPr>
-            </a:pPr>
-            <a:r>
-              <a:rPr sz="2100" b="0">
-                <a:solidFill>
-                  <a:srgbClr val="283A39"/>
-                </a:solidFill>
-                <a:latin typeface="Arial"/>
-                <a:ea typeface="Arial"/>
-                <a:cs typeface="Arial"/>
-              </a:rPr>
-              <a:t>skill picker, choose job-search there.</a:t>
+                <a16:creationId xmlns:a16="http://schemas.microsoft.com/office/drawing/2014/main" id="{D93E2548-3FF7-4C80-83C0-4FDDB420C0C6}"/>
+              </a:ext>
+            </a:extLst>
+          </p:cNvPr>
+          <p:cNvSpPr>
+            <a:spLocks xmlns:a="http://schemas.openxmlformats.org/drawingml/2006/main" noGrp="1"/>
+          </p:cNvSpPr>
+          <p:nvPr/>
+        </p:nvSpPr>
+        <p:spPr>
+          <a:xfrm xmlns:a="http://schemas.openxmlformats.org/drawingml/2006/main">
+            <a:off x="609600" y="2686050"/>
+            <a:ext cx="10820400" cy="857250"/>
+          </a:xfrm>
+          <a:prstGeom xmlns:a="http://schemas.openxmlformats.org/drawingml/2006/main" prst="rect">
+            <a:avLst/>
+          </a:prstGeom>
+          <a:noFill xmlns:a="http://schemas.openxmlformats.org/drawingml/2006/main"/>
+          <a:ln xmlns:a="http://schemas.openxmlformats.org/drawingml/2006/main" w="0">
+            <a:noFill/>
+          </a:ln>
+        </p:spPr>
+        <p:txBody>
+          <a:bodyPr xmlns:a="http://schemas.openxmlformats.org/drawingml/2006/main">
+            <a:noAutofit/>
+          </a:bodyPr>
+          <a:lstStyle xmlns:a="http://schemas.openxmlformats.org/drawingml/2006/main"/>
+          <a:p xmlns:a="http://schemas.openxmlformats.org/drawingml/2006/main">
+            <a:pPr>
+              <a:buNone/>
+              <a:defRPr sz="2250" b="0">
+                <a:solidFill>
+                  <a:srgbClr val="283A39"/>
+                </a:solidFill>
+                <a:latin typeface="Arial"/>
+                <a:ea typeface="Arial"/>
+                <a:cs typeface="Arial"/>
+              </a:defRPr>
+            </a:pPr>
+            <a:r>
+              <a:rPr sz="2250" b="0">
+                <a:solidFill>
+                  <a:srgbClr val="283A39"/>
+                </a:solidFill>
+                <a:latin typeface="Arial"/>
+                <a:ea typeface="Arial"/>
+                <a:cs typeface="Arial"/>
+              </a:rPr>
+              <a:t>b. It checks contact details, answers, links and attachments,</a:t>
+            </a:r>
+          </a:p>
+          <a:p xmlns:a="http://schemas.openxmlformats.org/drawingml/2006/main">
+            <a:pPr>
+              <a:buNone/>
+              <a:defRPr sz="2250" b="0">
+                <a:solidFill>
+                  <a:srgbClr val="283A39"/>
+                </a:solidFill>
+                <a:latin typeface="Arial"/>
+                <a:ea typeface="Arial"/>
+                <a:cs typeface="Arial"/>
+              </a:defRPr>
+            </a:pPr>
+            <a:r>
+              <a:rPr sz="2250" b="0">
+                <a:solidFill>
+                  <a:srgbClr val="283A39"/>
+                </a:solidFill>
+                <a:latin typeface="Arial"/>
+                <a:ea typeface="Arial"/>
+                <a:cs typeface="Arial"/>
+              </a:rPr>
+              <a:t>    including useful optional fields it can truthfully complete.</a:t>
             </a:r>
           </a:p>
         </p:txBody>
@@ -6786,55 +6881,79 @@
           <p:cNvPr id="5" name="">
             <a:extLst xmlns:a="http://schemas.openxmlformats.org/drawingml/2006/main">
               <a:ext uri="{FF2B5EF4-FFF2-40B4-BE49-F238E27FC236}">
-                <a16:creationId xmlns:a16="http://schemas.microsoft.com/office/drawing/2014/main" id="{6962B092-3204-43BD-BC6A-6920E4C22F0B}"/>
-              </a:ext>
-            </a:extLst>
-          </p:cNvPr>
-          <p:cNvSpPr>
-            <a:spLocks xmlns:a="http://schemas.openxmlformats.org/drawingml/2006/main" noGrp="1"/>
-          </p:cNvSpPr>
-          <p:nvPr/>
-        </p:nvSpPr>
-        <p:spPr>
-          <a:xfrm xmlns:a="http://schemas.openxmlformats.org/drawingml/2006/main">
-            <a:off x="609600" y="3276600"/>
-            <a:ext cx="10839450" cy="476250"/>
-          </a:xfrm>
-          <a:prstGeom xmlns:a="http://schemas.openxmlformats.org/drawingml/2006/main" prst="rect">
-            <a:avLst/>
-          </a:prstGeom>
-          <a:noFill xmlns:a="http://schemas.openxmlformats.org/drawingml/2006/main"/>
-          <a:ln xmlns:a="http://schemas.openxmlformats.org/drawingml/2006/main" w="0">
-            <a:noFill/>
-          </a:ln>
-        </p:spPr>
-        <p:txBody>
-          <a:bodyPr xmlns:a="http://schemas.openxmlformats.org/drawingml/2006/main">
-            <a:noAutofit/>
-          </a:bodyPr>
-          <a:lstStyle xmlns:a="http://schemas.openxmlformats.org/drawingml/2006/main"/>
-          <a:p xmlns:a="http://schemas.openxmlformats.org/drawingml/2006/main">
-            <a:pPr>
-              <a:buNone/>
-              <a:defRPr sz="2400" b="1">
-                <a:solidFill>
-                  <a:srgbClr val="183F3B"/>
-                </a:solidFill>
-                <a:latin typeface="Arial"/>
-                <a:ea typeface="Arial"/>
-                <a:cs typeface="Arial"/>
-              </a:defRPr>
-            </a:pPr>
-            <a:r>
-              <a:rPr sz="2400" b="1">
-                <a:solidFill>
-                  <a:srgbClr val="183F3B"/>
-                </a:solidFill>
-                <a:latin typeface="Arial"/>
-                <a:ea typeface="Arial"/>
-                <a:cs typeface="Arial"/>
-              </a:rPr>
-              <a:t>Codex CLI or IDE:  $job-search</a:t>
+                <a16:creationId xmlns:a16="http://schemas.microsoft.com/office/drawing/2014/main" id="{15D3C5B8-3795-4CC8-8FA5-368D64F42A0D}"/>
+              </a:ext>
+            </a:extLst>
+          </p:cNvPr>
+          <p:cNvSpPr>
+            <a:spLocks xmlns:a="http://schemas.openxmlformats.org/drawingml/2006/main" noGrp="1"/>
+          </p:cNvSpPr>
+          <p:nvPr/>
+        </p:nvSpPr>
+        <p:spPr>
+          <a:xfrm xmlns:a="http://schemas.openxmlformats.org/drawingml/2006/main">
+            <a:off x="609600" y="3924300"/>
+            <a:ext cx="10820400" cy="857250"/>
+          </a:xfrm>
+          <a:prstGeom xmlns:a="http://schemas.openxmlformats.org/drawingml/2006/main" prst="rect">
+            <a:avLst/>
+          </a:prstGeom>
+          <a:noFill xmlns:a="http://schemas.openxmlformats.org/drawingml/2006/main"/>
+          <a:ln xmlns:a="http://schemas.openxmlformats.org/drawingml/2006/main" w="0">
+            <a:noFill/>
+          </a:ln>
+        </p:spPr>
+        <p:txBody>
+          <a:bodyPr xmlns:a="http://schemas.openxmlformats.org/drawingml/2006/main">
+            <a:noAutofit/>
+          </a:bodyPr>
+          <a:lstStyle xmlns:a="http://schemas.openxmlformats.org/drawingml/2006/main"/>
+          <a:p xmlns:a="http://schemas.openxmlformats.org/drawingml/2006/main">
+            <a:pPr>
+              <a:buNone/>
+              <a:defRPr sz="2250" b="0">
+                <a:solidFill>
+                  <a:srgbClr val="283A39"/>
+                </a:solidFill>
+                <a:latin typeface="Arial"/>
+                <a:ea typeface="Arial"/>
+                <a:cs typeface="Arial"/>
+              </a:defRPr>
+            </a:pPr>
+            <a:r>
+              <a:rPr sz="2250" b="0">
+                <a:solidFill>
+                  <a:srgbClr val="283A39"/>
+                </a:solidFill>
+                <a:latin typeface="Arial"/>
+                <a:ea typeface="Arial"/>
+                <a:cs typeface="Arial"/>
+              </a:rPr>
+              <a:t>c. Missing entries are corrected; intentional omissions are explained.</a:t>
+            </a:r>
+          </a:p>
+          <a:p xmlns:a="http://schemas.openxmlformats.org/drawingml/2006/main">
+            <a:pPr>
+              <a:buNone/>
+              <a:defRPr sz="2250" b="0">
+                <a:solidFill>
+                  <a:srgbClr val="283A39"/>
+                </a:solidFill>
+                <a:latin typeface="Arial"/>
+                <a:ea typeface="Arial"/>
+                <a:cs typeface="Arial"/>
+              </a:defRPr>
+            </a:pPr>
+            <a:r>
+              <a:rPr sz="2250" b="0">
+                <a:solidFill>
+                  <a:srgbClr val="283A39"/>
+                </a:solidFill>
+                <a:latin typeface="Arial"/>
+                <a:ea typeface="Arial"/>
+                <a:cs typeface="Arial"/>
+              </a:rPr>
+              <a:t>    It saves the review and checks again after changes.</a:t>
             </a:r>
           </a:p>
         </p:txBody>
@@ -6844,55 +6963,79 @@
           <p:cNvPr id="6" name="">
             <a:extLst xmlns:a="http://schemas.openxmlformats.org/drawingml/2006/main">
               <a:ext uri="{FF2B5EF4-FFF2-40B4-BE49-F238E27FC236}">
-                <a16:creationId xmlns:a16="http://schemas.microsoft.com/office/drawing/2014/main" id="{6885BB09-B075-419C-A746-EB1CFE77B28A}"/>
-              </a:ext>
-            </a:extLst>
-          </p:cNvPr>
-          <p:cNvSpPr>
-            <a:spLocks xmlns:a="http://schemas.openxmlformats.org/drawingml/2006/main" noGrp="1"/>
-          </p:cNvSpPr>
-          <p:nvPr/>
-        </p:nvSpPr>
-        <p:spPr>
-          <a:xfrm xmlns:a="http://schemas.openxmlformats.org/drawingml/2006/main">
-            <a:off x="609600" y="4038600"/>
-            <a:ext cx="10839450" cy="476250"/>
-          </a:xfrm>
-          <a:prstGeom xmlns:a="http://schemas.openxmlformats.org/drawingml/2006/main" prst="rect">
-            <a:avLst/>
-          </a:prstGeom>
-          <a:noFill xmlns:a="http://schemas.openxmlformats.org/drawingml/2006/main"/>
-          <a:ln xmlns:a="http://schemas.openxmlformats.org/drawingml/2006/main" w="0">
-            <a:noFill/>
-          </a:ln>
-        </p:spPr>
-        <p:txBody>
-          <a:bodyPr xmlns:a="http://schemas.openxmlformats.org/drawingml/2006/main">
-            <a:noAutofit/>
-          </a:bodyPr>
-          <a:lstStyle xmlns:a="http://schemas.openxmlformats.org/drawingml/2006/main"/>
-          <a:p xmlns:a="http://schemas.openxmlformats.org/drawingml/2006/main">
-            <a:pPr>
-              <a:buNone/>
-              <a:defRPr sz="2400" b="1">
-                <a:solidFill>
-                  <a:srgbClr val="183F3B"/>
-                </a:solidFill>
-                <a:latin typeface="Arial"/>
-                <a:ea typeface="Arial"/>
-                <a:cs typeface="Arial"/>
-              </a:defRPr>
-            </a:pPr>
-            <a:r>
-              <a:rPr sz="2400" b="1">
-                <a:solidFill>
-                  <a:srgbClr val="183F3B"/>
-                </a:solidFill>
-                <a:latin typeface="Arial"/>
-                <a:ea typeface="Arial"/>
-                <a:cs typeface="Arial"/>
-              </a:rPr>
-              <a:t>Claude Code:  /job-search</a:t>
+                <a16:creationId xmlns:a16="http://schemas.microsoft.com/office/drawing/2014/main" id="{499F2DAF-5D76-4075-B729-3E8C8ADD43E1}"/>
+              </a:ext>
+            </a:extLst>
+          </p:cNvPr>
+          <p:cNvSpPr>
+            <a:spLocks xmlns:a="http://schemas.openxmlformats.org/drawingml/2006/main" noGrp="1"/>
+          </p:cNvSpPr>
+          <p:nvPr/>
+        </p:nvSpPr>
+        <p:spPr>
+          <a:xfrm xmlns:a="http://schemas.openxmlformats.org/drawingml/2006/main">
+            <a:off x="609600" y="5219700"/>
+            <a:ext cx="10820400" cy="723900"/>
+          </a:xfrm>
+          <a:prstGeom xmlns:a="http://schemas.openxmlformats.org/drawingml/2006/main" prst="rect">
+            <a:avLst/>
+          </a:prstGeom>
+          <a:noFill xmlns:a="http://schemas.openxmlformats.org/drawingml/2006/main"/>
+          <a:ln xmlns:a="http://schemas.openxmlformats.org/drawingml/2006/main" w="0">
+            <a:noFill/>
+          </a:ln>
+        </p:spPr>
+        <p:txBody>
+          <a:bodyPr xmlns:a="http://schemas.openxmlformats.org/drawingml/2006/main">
+            <a:noAutofit/>
+          </a:bodyPr>
+          <a:lstStyle xmlns:a="http://schemas.openxmlformats.org/drawingml/2006/main"/>
+          <a:p xmlns:a="http://schemas.openxmlformats.org/drawingml/2006/main">
+            <a:pPr>
+              <a:buNone/>
+              <a:defRPr sz="1800" b="0">
+                <a:solidFill>
+                  <a:srgbClr val="607370"/>
+                </a:solidFill>
+                <a:latin typeface="Arial"/>
+                <a:ea typeface="Arial"/>
+                <a:cs typeface="Arial"/>
+              </a:defRPr>
+            </a:pPr>
+            <a:r>
+              <a:rPr sz="1800" b="0">
+                <a:solidFill>
+                  <a:srgbClr val="607370"/>
+                </a:solidFill>
+                <a:latin typeface="Arial"/>
+                <a:ea typeface="Arial"/>
+                <a:cs typeface="Arial"/>
+              </a:rPr>
+              <a:t>You review the final application and authorize submission.</a:t>
+            </a:r>
+          </a:p>
+          <a:p xmlns:a="http://schemas.openxmlformats.org/drawingml/2006/main">
+            <a:pPr>
+              <a:buNone/>
+              <a:defRPr sz="1800" b="0">
+                <a:solidFill>
+                  <a:srgbClr val="607370"/>
+                </a:solidFill>
+                <a:latin typeface="Arial"/>
+                <a:ea typeface="Arial"/>
+                <a:cs typeface="Arial"/>
+              </a:defRPr>
+            </a:pPr>
+            <a:r>
+              <a:rPr sz="1800" b="0">
+                <a:solidFill>
+                  <a:srgbClr val="607370"/>
+                </a:solidFill>
+                <a:latin typeface="Arial"/>
+                <a:ea typeface="Arial"/>
+                <a:cs typeface="Arial"/>
+              </a:rPr>
+              <a:t>Passing these checks does not submit it automatically.</a:t>
             </a:r>
           </a:p>
         </p:txBody>
@@ -6902,137 +7045,56 @@
           <p:cNvPr id="7" name="">
             <a:extLst xmlns:a="http://schemas.openxmlformats.org/drawingml/2006/main">
               <a:ext uri="{FF2B5EF4-FFF2-40B4-BE49-F238E27FC236}">
-                <a16:creationId xmlns:a16="http://schemas.microsoft.com/office/drawing/2014/main" id="{526B87D4-6FCE-4C7E-8F5A-E6613C33EDD1}"/>
-              </a:ext>
-            </a:extLst>
-          </p:cNvPr>
-          <p:cNvSpPr>
-            <a:spLocks xmlns:a="http://schemas.openxmlformats.org/drawingml/2006/main" noGrp="1"/>
-          </p:cNvSpPr>
-          <p:nvPr/>
-        </p:nvSpPr>
-        <p:spPr>
-          <a:xfrm xmlns:a="http://schemas.openxmlformats.org/drawingml/2006/main">
-            <a:off x="609600" y="4981575"/>
-            <a:ext cx="10858500" cy="866775"/>
-          </a:xfrm>
-          <a:prstGeom xmlns:a="http://schemas.openxmlformats.org/drawingml/2006/main" prst="rect">
-            <a:avLst/>
-          </a:prstGeom>
-          <a:noFill xmlns:a="http://schemas.openxmlformats.org/drawingml/2006/main"/>
-          <a:ln xmlns:a="http://schemas.openxmlformats.org/drawingml/2006/main" w="0">
-            <a:noFill/>
-          </a:ln>
-        </p:spPr>
-        <p:txBody>
-          <a:bodyPr xmlns:a="http://schemas.openxmlformats.org/drawingml/2006/main">
-            <a:noAutofit/>
-          </a:bodyPr>
-          <a:lstStyle xmlns:a="http://schemas.openxmlformats.org/drawingml/2006/main"/>
-          <a:p xmlns:a="http://schemas.openxmlformats.org/drawingml/2006/main">
-            <a:pPr>
-              <a:buNone/>
-              <a:defRPr sz="1950" b="0">
-                <a:solidFill>
-                  <a:srgbClr val="283A39"/>
-                </a:solidFill>
-                <a:latin typeface="Arial"/>
-                <a:ea typeface="Arial"/>
-                <a:cs typeface="Arial"/>
-              </a:defRPr>
-            </a:pPr>
-            <a:r>
-              <a:rPr sz="1950" b="0">
-                <a:solidFill>
-                  <a:srgbClr val="283A39"/>
-                </a:solidFill>
-                <a:latin typeface="Arial"/>
-                <a:ea typeface="Arial"/>
-                <a:cs typeface="Arial"/>
-              </a:rPr>
-              <a:t>Add “Start my search” or “Continue my job search”, then send.</a:t>
-            </a:r>
-          </a:p>
-          <a:p xmlns:a="http://schemas.openxmlformats.org/drawingml/2006/main">
-            <a:pPr>
-              <a:buNone/>
-              <a:defRPr sz="1950" b="0">
-                <a:solidFill>
-                  <a:srgbClr val="283A39"/>
-                </a:solidFill>
-                <a:latin typeface="Arial"/>
-                <a:ea typeface="Arial"/>
-                <a:cs typeface="Arial"/>
-              </a:defRPr>
-            </a:pPr>
-            <a:r>
-              <a:rPr sz="1950" b="0">
-                <a:solidFill>
-                  <a:srgbClr val="283A39"/>
-                </a:solidFill>
-                <a:latin typeface="Arial"/>
-                <a:ea typeface="Arial"/>
-                <a:cs typeface="Arial"/>
-              </a:rPr>
-              <a:t>Use the AI message box after installation, in the same project.</a:t>
-            </a:r>
-          </a:p>
-        </p:txBody>
-      </p:sp>
-      <p:sp>
-        <p:nvSpPr>
-          <p:cNvPr id="8" name="">
-            <a:extLst xmlns:a="http://schemas.openxmlformats.org/drawingml/2006/main">
-              <a:ext uri="{FF2B5EF4-FFF2-40B4-BE49-F238E27FC236}">
-                <a16:creationId xmlns:a16="http://schemas.microsoft.com/office/drawing/2014/main" id="{6A78EB3E-F135-45F0-88B8-CA146F9928B0}"/>
-              </a:ext>
-            </a:extLst>
-          </p:cNvPr>
-          <p:cNvSpPr>
-            <a:spLocks xmlns:a="http://schemas.openxmlformats.org/drawingml/2006/main" noGrp="1"/>
-          </p:cNvSpPr>
-          <p:nvPr/>
-        </p:nvSpPr>
-        <p:spPr>
-          <a:xfrm xmlns:a="http://schemas.openxmlformats.org/drawingml/2006/main">
-            <a:off x="609600" y="5981700"/>
-            <a:ext cx="10858500" cy="361950"/>
-          </a:xfrm>
-          <a:prstGeom xmlns:a="http://schemas.openxmlformats.org/drawingml/2006/main" prst="rect">
-            <a:avLst/>
-          </a:prstGeom>
-          <a:noFill xmlns:a="http://schemas.openxmlformats.org/drawingml/2006/main"/>
-          <a:ln xmlns:a="http://schemas.openxmlformats.org/drawingml/2006/main" w="0">
-            <a:noFill/>
-          </a:ln>
-        </p:spPr>
-        <p:txBody>
-          <a:bodyPr xmlns:a="http://schemas.openxmlformats.org/drawingml/2006/main">
-            <a:noAutofit/>
-          </a:bodyPr>
-          <a:lstStyle xmlns:a="http://schemas.openxmlformats.org/drawingml/2006/main"/>
-          <a:p xmlns:a="http://schemas.openxmlformats.org/drawingml/2006/main">
-            <a:pPr>
-              <a:buNone/>
-              <a:defRPr sz="1650" b="0">
-                <a:solidFill>
-                  <a:srgbClr val="607370"/>
-                </a:solidFill>
-                <a:latin typeface="Arial"/>
-                <a:ea typeface="Arial"/>
-                <a:cs typeface="Arial"/>
-              </a:defRPr>
-            </a:pPr>
-            <a:r>
-              <a:rPr sz="1650" b="0">
-                <a:solidFill>
-                  <a:srgbClr val="607370"/>
-                </a:solidFill>
-                <a:latin typeface="Arial"/>
-                <a:ea typeface="Arial"/>
-                <a:cs typeface="Arial"/>
-              </a:rPr>
-              <a:t>OpenCode and T3: use the instructions near the start of this guide.</a:t>
+                <a16:creationId xmlns:a16="http://schemas.microsoft.com/office/drawing/2014/main" id="{EAF2EA42-DEE2-4D4C-AEB4-EA109E27A622}"/>
+              </a:ext>
+            </a:extLst>
+          </p:cNvPr>
+          <p:cNvSpPr>
+            <a:spLocks xmlns:a="http://schemas.openxmlformats.org/drawingml/2006/main" noGrp="1"/>
+          </p:cNvSpPr>
+          <p:nvPr/>
+        </p:nvSpPr>
+        <p:spPr>
+          <a:xfrm xmlns:a="http://schemas.openxmlformats.org/drawingml/2006/main">
+            <a:off x="609600" y="6038850"/>
+            <a:ext cx="10001250" cy="333375"/>
+          </a:xfrm>
+          <a:prstGeom xmlns:a="http://schemas.openxmlformats.org/drawingml/2006/main" prst="rect">
+            <a:avLst/>
+          </a:prstGeom>
+          <a:noFill xmlns:a="http://schemas.openxmlformats.org/drawingml/2006/main"/>
+          <a:ln xmlns:a="http://schemas.openxmlformats.org/drawingml/2006/main" w="0">
+            <a:noFill/>
+          </a:ln>
+        </p:spPr>
+        <p:txBody>
+          <a:bodyPr xmlns:a="http://schemas.openxmlformats.org/drawingml/2006/main">
+            <a:noAutofit/>
+          </a:bodyPr>
+          <a:lstStyle xmlns:a="http://schemas.openxmlformats.org/drawingml/2006/main"/>
+          <a:p xmlns:a="http://schemas.openxmlformats.org/drawingml/2006/main">
+            <a:pPr>
+              <a:buNone/>
+              <a:defRPr sz="1800" b="0">
+                <a:solidFill>
+                  <a:srgbClr val="087F73"/>
+                </a:solidFill>
+                <a:latin typeface="Arial"/>
+                <a:ea typeface="Arial"/>
+                <a:cs typeface="Arial"/>
+              </a:defRPr>
+            </a:pPr>
+            <a:r>
+              <a:rPr sz="1800" b="0">
+                <a:solidFill>
+                  <a:srgbClr val="087F73"/>
+                </a:solidFill>
+                <a:latin typeface="Arial"/>
+                <a:ea typeface="Arial"/>
+                <a:cs typeface="Arial"/>
+                <a:hlinkClick xmlns:r="http://schemas.openxmlformats.org/officeDocument/2006/relationships" r:id="R972a091b771b4d8d"/>
+              </a:rPr>
+              <a:t>How the completion check works</a:t>
             </a:r>
           </a:p>
         </p:txBody>
@@ -7040,7 +7102,7 @@
     </p:spTree>
     <p:extLst>
       <p:ext uri="{BB962C8B-B14F-4D97-AF65-F5344CB8AC3E}">
-        <p14:creationId xmlns:p14="http://schemas.microsoft.com/office/powerpoint/2010/main" val="1736121836"/>
+        <p14:creationId xmlns:p14="http://schemas.microsoft.com/office/powerpoint/2010/main" val="247586683"/>
       </p:ext>
     </p:extLst>
   </p:cSld>
@@ -7068,10 +7130,10 @@
       </p:grpSpPr>
       <p:sp>
         <p:nvSpPr>
-          <p:cNvPr id="7" name="">
-            <a:extLst xmlns:a="http://schemas.openxmlformats.org/drawingml/2006/main">
-              <a:ext uri="{FF2B5EF4-FFF2-40B4-BE49-F238E27FC236}">
-                <a16:creationId xmlns:a16="http://schemas.microsoft.com/office/drawing/2014/main" id="{5DD59564-1F8E-45D8-8908-8296D8B25498}"/>
+          <p:cNvPr id="9" name="">
+            <a:extLst xmlns:a="http://schemas.openxmlformats.org/drawingml/2006/main">
+              <a:ext uri="{FF2B5EF4-FFF2-40B4-BE49-F238E27FC236}">
+                <a16:creationId xmlns:a16="http://schemas.microsoft.com/office/drawing/2014/main" id="{2A062370-BA4B-4D31-93F4-AF326E0A26FB}"/>
               </a:ext>
             </a:extLst>
           </p:cNvPr>
@@ -7119,7 +7181,7 @@
                 <a:ea typeface="Arial"/>
                 <a:cs typeface="Arial"/>
               </a:rPr>
-              <a:t>6. Next time</a:t>
+              <a:t>Codex and Claude shortcuts</a:t>
             </a:r>
           </a:p>
         </p:txBody>
@@ -7129,7 +7191,7 @@
           <p:cNvPr id="2" name="">
             <a:extLst xmlns:a="http://schemas.openxmlformats.org/drawingml/2006/main">
               <a:ext uri="{FF2B5EF4-FFF2-40B4-BE49-F238E27FC236}">
-                <a16:creationId xmlns:a16="http://schemas.microsoft.com/office/drawing/2014/main" id="{29ECCDD0-3621-4FEA-86BA-99F95FA00055}"/>
+                <a16:creationId xmlns:a16="http://schemas.microsoft.com/office/drawing/2014/main" id="{EB42D7E3-D406-4693-88DD-C0CD9A24667B}"/>
               </a:ext>
             </a:extLst>
           </p:cNvPr>
@@ -7187,79 +7249,55 @@
           <p:cNvPr id="3" name="">
             <a:extLst xmlns:a="http://schemas.openxmlformats.org/drawingml/2006/main">
               <a:ext uri="{FF2B5EF4-FFF2-40B4-BE49-F238E27FC236}">
-                <a16:creationId xmlns:a16="http://schemas.microsoft.com/office/drawing/2014/main" id="{15B265D8-348D-4306-8841-31D6963F2616}"/>
-              </a:ext>
-            </a:extLst>
-          </p:cNvPr>
-          <p:cNvSpPr>
-            <a:spLocks xmlns:a="http://schemas.openxmlformats.org/drawingml/2006/main" noGrp="1"/>
-          </p:cNvSpPr>
-          <p:nvPr/>
-        </p:nvSpPr>
-        <p:spPr>
-          <a:xfrm xmlns:a="http://schemas.openxmlformats.org/drawingml/2006/main">
-            <a:off x="609600" y="1466850"/>
-            <a:ext cx="10820400" cy="752475"/>
-          </a:xfrm>
-          <a:prstGeom xmlns:a="http://schemas.openxmlformats.org/drawingml/2006/main" prst="rect">
-            <a:avLst/>
-          </a:prstGeom>
-          <a:noFill xmlns:a="http://schemas.openxmlformats.org/drawingml/2006/main"/>
-          <a:ln xmlns:a="http://schemas.openxmlformats.org/drawingml/2006/main" w="0">
-            <a:noFill/>
-          </a:ln>
-        </p:spPr>
-        <p:txBody>
-          <a:bodyPr xmlns:a="http://schemas.openxmlformats.org/drawingml/2006/main">
-            <a:noAutofit/>
-          </a:bodyPr>
-          <a:lstStyle xmlns:a="http://schemas.openxmlformats.org/drawingml/2006/main"/>
-          <a:p xmlns:a="http://schemas.openxmlformats.org/drawingml/2006/main">
-            <a:pPr>
-              <a:buNone/>
-              <a:defRPr sz="2250" b="0">
-                <a:solidFill>
-                  <a:srgbClr val="283A39"/>
-                </a:solidFill>
-                <a:latin typeface="Arial"/>
-                <a:ea typeface="Arial"/>
-                <a:cs typeface="Arial"/>
-              </a:defRPr>
-            </a:pPr>
-            <a:r>
-              <a:rPr sz="2250" b="0">
-                <a:solidFill>
-                  <a:srgbClr val="283A39"/>
-                </a:solidFill>
-                <a:latin typeface="Arial"/>
-                <a:ea typeface="Arial"/>
-                <a:cs typeface="Arial"/>
-              </a:rPr>
-              <a:t>a. Setup ends with your app’s return command and saved location.</a:t>
-            </a:r>
-          </a:p>
-          <a:p xmlns:a="http://schemas.openxmlformats.org/drawingml/2006/main">
-            <a:pPr>
-              <a:buNone/>
-              <a:defRPr sz="2250" b="0">
-                <a:solidFill>
-                  <a:srgbClr val="283A39"/>
-                </a:solidFill>
-                <a:latin typeface="Arial"/>
-                <a:ea typeface="Arial"/>
-                <a:cs typeface="Arial"/>
-              </a:defRPr>
-            </a:pPr>
-            <a:r>
-              <a:rPr sz="2250" b="0">
-                <a:solidFill>
-                  <a:srgbClr val="283A39"/>
-                </a:solidFill>
-                <a:latin typeface="Arial"/>
-                <a:ea typeface="Arial"/>
-                <a:cs typeface="Arial"/>
-              </a:rPr>
-              <a:t>b. Reopen that project, summon job-search, then send:</a:t>
+                <a16:creationId xmlns:a16="http://schemas.microsoft.com/office/drawing/2014/main" id="{CDCDA268-36D0-473A-9069-E71EE9A06AA6}"/>
+              </a:ext>
+            </a:extLst>
+          </p:cNvPr>
+          <p:cNvSpPr>
+            <a:spLocks xmlns:a="http://schemas.openxmlformats.org/drawingml/2006/main" noGrp="1"/>
+          </p:cNvSpPr>
+          <p:nvPr/>
+        </p:nvSpPr>
+        <p:spPr>
+          <a:xfrm xmlns:a="http://schemas.openxmlformats.org/drawingml/2006/main">
+            <a:off x="609600" y="1514475"/>
+            <a:ext cx="10839450" cy="428625"/>
+          </a:xfrm>
+          <a:prstGeom xmlns:a="http://schemas.openxmlformats.org/drawingml/2006/main" prst="rect">
+            <a:avLst/>
+          </a:prstGeom>
+          <a:noFill xmlns:a="http://schemas.openxmlformats.org/drawingml/2006/main"/>
+          <a:ln xmlns:a="http://schemas.openxmlformats.org/drawingml/2006/main" w="0">
+            <a:noFill/>
+          </a:ln>
+        </p:spPr>
+        <p:txBody>
+          <a:bodyPr xmlns:a="http://schemas.openxmlformats.org/drawingml/2006/main">
+            <a:noAutofit/>
+          </a:bodyPr>
+          <a:lstStyle xmlns:a="http://schemas.openxmlformats.org/drawingml/2006/main"/>
+          <a:p xmlns:a="http://schemas.openxmlformats.org/drawingml/2006/main">
+            <a:pPr>
+              <a:buNone/>
+              <a:defRPr sz="2250" b="1">
+                <a:solidFill>
+                  <a:srgbClr val="183F3B"/>
+                </a:solidFill>
+                <a:latin typeface="Arial"/>
+                <a:ea typeface="Arial"/>
+                <a:cs typeface="Arial"/>
+              </a:defRPr>
+            </a:pPr>
+            <a:r>
+              <a:rPr sz="2250" b="1">
+                <a:solidFill>
+                  <a:srgbClr val="183F3B"/>
+                </a:solidFill>
+                <a:latin typeface="Arial"/>
+                <a:ea typeface="Arial"/>
+                <a:cs typeface="Arial"/>
+              </a:rPr>
+              <a:t>Codex / ChatGPT desktop</a:t>
             </a:r>
           </a:p>
         </p:txBody>
@@ -7269,37 +7307,119 @@
           <p:cNvPr id="4" name="">
             <a:extLst xmlns:a="http://schemas.openxmlformats.org/drawingml/2006/main">
               <a:ext uri="{FF2B5EF4-FFF2-40B4-BE49-F238E27FC236}">
-                <a16:creationId xmlns:a16="http://schemas.microsoft.com/office/drawing/2014/main" id="{318051EC-F210-43FB-AED8-33381DDCE3D0}"/>
-              </a:ext>
-            </a:extLst>
-          </p:cNvPr>
-          <p:cNvSpPr>
-            <a:spLocks xmlns:a="http://schemas.openxmlformats.org/drawingml/2006/main" noGrp="1"/>
-          </p:cNvSpPr>
-          <p:nvPr/>
-        </p:nvSpPr>
-        <p:spPr>
-          <a:xfrm xmlns:a="http://schemas.openxmlformats.org/drawingml/2006/main">
-            <a:off x="609600" y="2828925"/>
-            <a:ext cx="10858500" cy="819150"/>
-          </a:xfrm>
-          <a:prstGeom xmlns:a="http://schemas.openxmlformats.org/drawingml/2006/main" prst="rect">
-            <a:avLst/>
-          </a:prstGeom>
-          <a:noFill xmlns:a="http://schemas.openxmlformats.org/drawingml/2006/main"/>
-          <a:ln xmlns:a="http://schemas.openxmlformats.org/drawingml/2006/main" w="0">
-            <a:noFill/>
-          </a:ln>
-        </p:spPr>
-        <p:txBody>
-          <a:bodyPr xmlns:a="http://schemas.openxmlformats.org/drawingml/2006/main">
-            <a:noAutofit/>
-          </a:bodyPr>
-          <a:lstStyle xmlns:a="http://schemas.openxmlformats.org/drawingml/2006/main"/>
-          <a:p xmlns:a="http://schemas.openxmlformats.org/drawingml/2006/main">
-            <a:pPr>
-              <a:buNone/>
-              <a:defRPr sz="3675" b="1">
+                <a16:creationId xmlns:a16="http://schemas.microsoft.com/office/drawing/2014/main" id="{9B3F3F08-8472-422B-AE8F-32202650C21B}"/>
+              </a:ext>
+            </a:extLst>
+          </p:cNvPr>
+          <p:cNvSpPr>
+            <a:spLocks xmlns:a="http://schemas.openxmlformats.org/drawingml/2006/main" noGrp="1"/>
+          </p:cNvSpPr>
+          <p:nvPr/>
+        </p:nvSpPr>
+        <p:spPr>
+          <a:xfrm xmlns:a="http://schemas.openxmlformats.org/drawingml/2006/main">
+            <a:off x="609600" y="2047875"/>
+            <a:ext cx="10839450" cy="866775"/>
+          </a:xfrm>
+          <a:prstGeom xmlns:a="http://schemas.openxmlformats.org/drawingml/2006/main" prst="rect">
+            <a:avLst/>
+          </a:prstGeom>
+          <a:noFill xmlns:a="http://schemas.openxmlformats.org/drawingml/2006/main"/>
+          <a:ln xmlns:a="http://schemas.openxmlformats.org/drawingml/2006/main" w="0">
+            <a:noFill/>
+          </a:ln>
+        </p:spPr>
+        <p:txBody>
+          <a:bodyPr xmlns:a="http://schemas.openxmlformats.org/drawingml/2006/main">
+            <a:noAutofit/>
+          </a:bodyPr>
+          <a:lstStyle xmlns:a="http://schemas.openxmlformats.org/drawingml/2006/main"/>
+          <a:p xmlns:a="http://schemas.openxmlformats.org/drawingml/2006/main">
+            <a:pPr>
+              <a:buNone/>
+              <a:defRPr sz="2100" b="0">
+                <a:solidFill>
+                  <a:srgbClr val="283A39"/>
+                </a:solidFill>
+                <a:latin typeface="Arial"/>
+                <a:ea typeface="Arial"/>
+                <a:cs typeface="Arial"/>
+              </a:defRPr>
+            </a:pPr>
+            <a:r>
+              <a:rPr sz="2100" b="0">
+                <a:solidFill>
+                  <a:srgbClr val="283A39"/>
+                </a:solidFill>
+                <a:latin typeface="Arial"/>
+                <a:ea typeface="Arial"/>
+                <a:cs typeface="Arial"/>
+              </a:rPr>
+              <a:t>Type @ and choose job-search. If your composer offers a $</a:t>
+            </a:r>
+          </a:p>
+          <a:p xmlns:a="http://schemas.openxmlformats.org/drawingml/2006/main">
+            <a:pPr>
+              <a:buNone/>
+              <a:defRPr sz="2100" b="0">
+                <a:solidFill>
+                  <a:srgbClr val="283A39"/>
+                </a:solidFill>
+                <a:latin typeface="Arial"/>
+                <a:ea typeface="Arial"/>
+                <a:cs typeface="Arial"/>
+              </a:defRPr>
+            </a:pPr>
+            <a:r>
+              <a:rPr sz="2100" b="0">
+                <a:solidFill>
+                  <a:srgbClr val="283A39"/>
+                </a:solidFill>
+                <a:latin typeface="Arial"/>
+                <a:ea typeface="Arial"/>
+                <a:cs typeface="Arial"/>
+              </a:rPr>
+              <a:t>skill picker, choose job-search there.</a:t>
+            </a:r>
+          </a:p>
+        </p:txBody>
+      </p:sp>
+      <p:sp>
+        <p:nvSpPr>
+          <p:cNvPr id="5" name="">
+            <a:extLst xmlns:a="http://schemas.openxmlformats.org/drawingml/2006/main">
+              <a:ext uri="{FF2B5EF4-FFF2-40B4-BE49-F238E27FC236}">
+                <a16:creationId xmlns:a16="http://schemas.microsoft.com/office/drawing/2014/main" id="{6962B092-3204-43BD-BC6A-6920E4C22F0B}"/>
+              </a:ext>
+            </a:extLst>
+          </p:cNvPr>
+          <p:cNvSpPr>
+            <a:spLocks xmlns:a="http://schemas.openxmlformats.org/drawingml/2006/main" noGrp="1"/>
+          </p:cNvSpPr>
+          <p:nvPr/>
+        </p:nvSpPr>
+        <p:spPr>
+          <a:xfrm xmlns:a="http://schemas.openxmlformats.org/drawingml/2006/main">
+            <a:off x="609600" y="3276600"/>
+            <a:ext cx="10839450" cy="476250"/>
+          </a:xfrm>
+          <a:prstGeom xmlns:a="http://schemas.openxmlformats.org/drawingml/2006/main" prst="rect">
+            <a:avLst/>
+          </a:prstGeom>
+          <a:noFill xmlns:a="http://schemas.openxmlformats.org/drawingml/2006/main"/>
+          <a:ln xmlns:a="http://schemas.openxmlformats.org/drawingml/2006/main" w="0">
+            <a:noFill/>
+          </a:ln>
+        </p:spPr>
+        <p:txBody>
+          <a:bodyPr xmlns:a="http://schemas.openxmlformats.org/drawingml/2006/main">
+            <a:noAutofit/>
+          </a:bodyPr>
+          <a:lstStyle xmlns:a="http://schemas.openxmlformats.org/drawingml/2006/main"/>
+          <a:p xmlns:a="http://schemas.openxmlformats.org/drawingml/2006/main">
+            <a:pPr>
+              <a:buNone/>
+              <a:defRPr sz="2400" b="1">
                 <a:solidFill>
                   <a:srgbClr val="183F3B"/>
                 </a:solidFill>
@@ -7309,7 +7429,7 @@
               </a:defRPr>
             </a:pPr>
             <a:r>
-              <a:rPr sz="3675" b="1">
+              <a:rPr sz="2400" b="1">
                 <a:solidFill>
                   <a:srgbClr val="183F3B"/>
                 </a:solidFill>
@@ -7317,89 +7437,7 @@
                 <a:ea typeface="Arial"/>
                 <a:cs typeface="Arial"/>
               </a:rPr>
-              <a:t>Continue my job search.</a:t>
-            </a:r>
-          </a:p>
-        </p:txBody>
-      </p:sp>
-      <p:sp>
-        <p:nvSpPr>
-          <p:cNvPr id="5" name="">
-            <a:extLst xmlns:a="http://schemas.openxmlformats.org/drawingml/2006/main">
-              <a:ext uri="{FF2B5EF4-FFF2-40B4-BE49-F238E27FC236}">
-                <a16:creationId xmlns:a16="http://schemas.microsoft.com/office/drawing/2014/main" id="{79617BB1-14CE-498D-B7FA-E75860BB4FFF}"/>
-              </a:ext>
-            </a:extLst>
-          </p:cNvPr>
-          <p:cNvSpPr>
-            <a:spLocks xmlns:a="http://schemas.openxmlformats.org/drawingml/2006/main" noGrp="1"/>
-          </p:cNvSpPr>
-          <p:nvPr/>
-        </p:nvSpPr>
-        <p:spPr>
-          <a:xfrm xmlns:a="http://schemas.openxmlformats.org/drawingml/2006/main">
-            <a:off x="609600" y="4286250"/>
-            <a:ext cx="10858500" cy="952500"/>
-          </a:xfrm>
-          <a:prstGeom xmlns:a="http://schemas.openxmlformats.org/drawingml/2006/main" prst="rect">
-            <a:avLst/>
-          </a:prstGeom>
-          <a:noFill xmlns:a="http://schemas.openxmlformats.org/drawingml/2006/main"/>
-          <a:ln xmlns:a="http://schemas.openxmlformats.org/drawingml/2006/main" w="0">
-            <a:noFill/>
-          </a:ln>
-        </p:spPr>
-        <p:txBody>
-          <a:bodyPr xmlns:a="http://schemas.openxmlformats.org/drawingml/2006/main">
-            <a:noAutofit/>
-          </a:bodyPr>
-          <a:lstStyle xmlns:a="http://schemas.openxmlformats.org/drawingml/2006/main"/>
-          <a:p xmlns:a="http://schemas.openxmlformats.org/drawingml/2006/main">
-            <a:pPr>
-              <a:buNone/>
-              <a:defRPr sz="2250" b="0">
-                <a:solidFill>
-                  <a:srgbClr val="283A39"/>
-                </a:solidFill>
-                <a:latin typeface="Arial"/>
-                <a:ea typeface="Arial"/>
-                <a:cs typeface="Arial"/>
-              </a:defRPr>
-            </a:pPr>
-            <a:r>
-              <a:rPr sz="2250" b="0">
-                <a:solidFill>
-                  <a:srgbClr val="283A39"/>
-                </a:solidFill>
-                <a:latin typeface="Arial"/>
-                <a:ea typeface="Arial"/>
-                <a:cs typeface="Arial"/>
-              </a:rPr>
-              <a:t>c. The AI checks its tools and reads your saved progress.</a:t>
-            </a:r>
-          </a:p>
-          <a:p xmlns:a="http://schemas.openxmlformats.org/drawingml/2006/main">
-            <a:pPr>
-              <a:buNone/>
-              <a:defRPr sz="2250" b="0">
-                <a:solidFill>
-                  <a:srgbClr val="283A39"/>
-                </a:solidFill>
-                <a:latin typeface="Arial"/>
-                <a:ea typeface="Arial"/>
-                <a:cs typeface="Arial"/>
-              </a:defRPr>
-            </a:pPr>
-            <a:r>
-              <a:rPr sz="2250" b="0">
-                <a:solidFill>
-                  <a:srgbClr val="283A39"/>
-                </a:solidFill>
-                <a:latin typeface="Arial"/>
-                <a:ea typeface="Arial"/>
-                <a:cs typeface="Arial"/>
-              </a:rPr>
-              <a:t>Supply an updated resume when it changes.</a:t>
+              <a:t>Codex CLI or IDE:  $job-search</a:t>
             </a:r>
           </a:p>
         </p:txBody>
@@ -7409,37 +7447,177 @@
           <p:cNvPr id="6" name="">
             <a:extLst xmlns:a="http://schemas.openxmlformats.org/drawingml/2006/main">
               <a:ext uri="{FF2B5EF4-FFF2-40B4-BE49-F238E27FC236}">
-                <a16:creationId xmlns:a16="http://schemas.microsoft.com/office/drawing/2014/main" id="{EF5F0B19-2522-4A70-95F8-41294A5D5842}"/>
-              </a:ext>
-            </a:extLst>
-          </p:cNvPr>
-          <p:cNvSpPr>
-            <a:spLocks xmlns:a="http://schemas.openxmlformats.org/drawingml/2006/main" noGrp="1"/>
-          </p:cNvSpPr>
-          <p:nvPr/>
-        </p:nvSpPr>
-        <p:spPr>
-          <a:xfrm xmlns:a="http://schemas.openxmlformats.org/drawingml/2006/main">
-            <a:off x="609600" y="5781675"/>
-            <a:ext cx="10858500" cy="495300"/>
-          </a:xfrm>
-          <a:prstGeom xmlns:a="http://schemas.openxmlformats.org/drawingml/2006/main" prst="rect">
-            <a:avLst/>
-          </a:prstGeom>
-          <a:noFill xmlns:a="http://schemas.openxmlformats.org/drawingml/2006/main"/>
-          <a:ln xmlns:a="http://schemas.openxmlformats.org/drawingml/2006/main" w="0">
-            <a:noFill/>
-          </a:ln>
-        </p:spPr>
-        <p:txBody>
-          <a:bodyPr xmlns:a="http://schemas.openxmlformats.org/drawingml/2006/main">
-            <a:noAutofit/>
-          </a:bodyPr>
-          <a:lstStyle xmlns:a="http://schemas.openxmlformats.org/drawingml/2006/main"/>
-          <a:p xmlns:a="http://schemas.openxmlformats.org/drawingml/2006/main">
-            <a:pPr>
-              <a:buNone/>
-              <a:defRPr sz="1800" b="0">
+                <a16:creationId xmlns:a16="http://schemas.microsoft.com/office/drawing/2014/main" id="{6885BB09-B075-419C-A746-EB1CFE77B28A}"/>
+              </a:ext>
+            </a:extLst>
+          </p:cNvPr>
+          <p:cNvSpPr>
+            <a:spLocks xmlns:a="http://schemas.openxmlformats.org/drawingml/2006/main" noGrp="1"/>
+          </p:cNvSpPr>
+          <p:nvPr/>
+        </p:nvSpPr>
+        <p:spPr>
+          <a:xfrm xmlns:a="http://schemas.openxmlformats.org/drawingml/2006/main">
+            <a:off x="609600" y="4038600"/>
+            <a:ext cx="10839450" cy="476250"/>
+          </a:xfrm>
+          <a:prstGeom xmlns:a="http://schemas.openxmlformats.org/drawingml/2006/main" prst="rect">
+            <a:avLst/>
+          </a:prstGeom>
+          <a:noFill xmlns:a="http://schemas.openxmlformats.org/drawingml/2006/main"/>
+          <a:ln xmlns:a="http://schemas.openxmlformats.org/drawingml/2006/main" w="0">
+            <a:noFill/>
+          </a:ln>
+        </p:spPr>
+        <p:txBody>
+          <a:bodyPr xmlns:a="http://schemas.openxmlformats.org/drawingml/2006/main">
+            <a:noAutofit/>
+          </a:bodyPr>
+          <a:lstStyle xmlns:a="http://schemas.openxmlformats.org/drawingml/2006/main"/>
+          <a:p xmlns:a="http://schemas.openxmlformats.org/drawingml/2006/main">
+            <a:pPr>
+              <a:buNone/>
+              <a:defRPr sz="2400" b="1">
+                <a:solidFill>
+                  <a:srgbClr val="183F3B"/>
+                </a:solidFill>
+                <a:latin typeface="Arial"/>
+                <a:ea typeface="Arial"/>
+                <a:cs typeface="Arial"/>
+              </a:defRPr>
+            </a:pPr>
+            <a:r>
+              <a:rPr sz="2400" b="1">
+                <a:solidFill>
+                  <a:srgbClr val="183F3B"/>
+                </a:solidFill>
+                <a:latin typeface="Arial"/>
+                <a:ea typeface="Arial"/>
+                <a:cs typeface="Arial"/>
+              </a:rPr>
+              <a:t>Claude Code:  /job-search</a:t>
+            </a:r>
+          </a:p>
+        </p:txBody>
+      </p:sp>
+      <p:sp>
+        <p:nvSpPr>
+          <p:cNvPr id="7" name="">
+            <a:extLst xmlns:a="http://schemas.openxmlformats.org/drawingml/2006/main">
+              <a:ext uri="{FF2B5EF4-FFF2-40B4-BE49-F238E27FC236}">
+                <a16:creationId xmlns:a16="http://schemas.microsoft.com/office/drawing/2014/main" id="{526B87D4-6FCE-4C7E-8F5A-E6613C33EDD1}"/>
+              </a:ext>
+            </a:extLst>
+          </p:cNvPr>
+          <p:cNvSpPr>
+            <a:spLocks xmlns:a="http://schemas.openxmlformats.org/drawingml/2006/main" noGrp="1"/>
+          </p:cNvSpPr>
+          <p:nvPr/>
+        </p:nvSpPr>
+        <p:spPr>
+          <a:xfrm xmlns:a="http://schemas.openxmlformats.org/drawingml/2006/main">
+            <a:off x="609600" y="4981575"/>
+            <a:ext cx="10858500" cy="866775"/>
+          </a:xfrm>
+          <a:prstGeom xmlns:a="http://schemas.openxmlformats.org/drawingml/2006/main" prst="rect">
+            <a:avLst/>
+          </a:prstGeom>
+          <a:noFill xmlns:a="http://schemas.openxmlformats.org/drawingml/2006/main"/>
+          <a:ln xmlns:a="http://schemas.openxmlformats.org/drawingml/2006/main" w="0">
+            <a:noFill/>
+          </a:ln>
+        </p:spPr>
+        <p:txBody>
+          <a:bodyPr xmlns:a="http://schemas.openxmlformats.org/drawingml/2006/main">
+            <a:noAutofit/>
+          </a:bodyPr>
+          <a:lstStyle xmlns:a="http://schemas.openxmlformats.org/drawingml/2006/main"/>
+          <a:p xmlns:a="http://schemas.openxmlformats.org/drawingml/2006/main">
+            <a:pPr>
+              <a:buNone/>
+              <a:defRPr sz="1950" b="0">
+                <a:solidFill>
+                  <a:srgbClr val="283A39"/>
+                </a:solidFill>
+                <a:latin typeface="Arial"/>
+                <a:ea typeface="Arial"/>
+                <a:cs typeface="Arial"/>
+              </a:defRPr>
+            </a:pPr>
+            <a:r>
+              <a:rPr sz="1950" b="0">
+                <a:solidFill>
+                  <a:srgbClr val="283A39"/>
+                </a:solidFill>
+                <a:latin typeface="Arial"/>
+                <a:ea typeface="Arial"/>
+                <a:cs typeface="Arial"/>
+              </a:rPr>
+              <a:t>Add “Start my search” or “Continue my job search”, then send.</a:t>
+            </a:r>
+          </a:p>
+          <a:p xmlns:a="http://schemas.openxmlformats.org/drawingml/2006/main">
+            <a:pPr>
+              <a:buNone/>
+              <a:defRPr sz="1950" b="0">
+                <a:solidFill>
+                  <a:srgbClr val="283A39"/>
+                </a:solidFill>
+                <a:latin typeface="Arial"/>
+                <a:ea typeface="Arial"/>
+                <a:cs typeface="Arial"/>
+              </a:defRPr>
+            </a:pPr>
+            <a:r>
+              <a:rPr sz="1950" b="0">
+                <a:solidFill>
+                  <a:srgbClr val="283A39"/>
+                </a:solidFill>
+                <a:latin typeface="Arial"/>
+                <a:ea typeface="Arial"/>
+                <a:cs typeface="Arial"/>
+              </a:rPr>
+              <a:t>Use the AI message box after installation, in the same project.</a:t>
+            </a:r>
+          </a:p>
+        </p:txBody>
+      </p:sp>
+      <p:sp>
+        <p:nvSpPr>
+          <p:cNvPr id="8" name="">
+            <a:extLst xmlns:a="http://schemas.openxmlformats.org/drawingml/2006/main">
+              <a:ext uri="{FF2B5EF4-FFF2-40B4-BE49-F238E27FC236}">
+                <a16:creationId xmlns:a16="http://schemas.microsoft.com/office/drawing/2014/main" id="{6A78EB3E-F135-45F0-88B8-CA146F9928B0}"/>
+              </a:ext>
+            </a:extLst>
+          </p:cNvPr>
+          <p:cNvSpPr>
+            <a:spLocks xmlns:a="http://schemas.openxmlformats.org/drawingml/2006/main" noGrp="1"/>
+          </p:cNvSpPr>
+          <p:nvPr/>
+        </p:nvSpPr>
+        <p:spPr>
+          <a:xfrm xmlns:a="http://schemas.openxmlformats.org/drawingml/2006/main">
+            <a:off x="609600" y="5981700"/>
+            <a:ext cx="10858500" cy="361950"/>
+          </a:xfrm>
+          <a:prstGeom xmlns:a="http://schemas.openxmlformats.org/drawingml/2006/main" prst="rect">
+            <a:avLst/>
+          </a:prstGeom>
+          <a:noFill xmlns:a="http://schemas.openxmlformats.org/drawingml/2006/main"/>
+          <a:ln xmlns:a="http://schemas.openxmlformats.org/drawingml/2006/main" w="0">
+            <a:noFill/>
+          </a:ln>
+        </p:spPr>
+        <p:txBody>
+          <a:bodyPr xmlns:a="http://schemas.openxmlformats.org/drawingml/2006/main">
+            <a:noAutofit/>
+          </a:bodyPr>
+          <a:lstStyle xmlns:a="http://schemas.openxmlformats.org/drawingml/2006/main"/>
+          <a:p xmlns:a="http://schemas.openxmlformats.org/drawingml/2006/main">
+            <a:pPr>
+              <a:buNone/>
+              <a:defRPr sz="1650" b="0">
                 <a:solidFill>
                   <a:srgbClr val="607370"/>
                 </a:solidFill>
@@ -7449,7 +7627,7 @@
               </a:defRPr>
             </a:pPr>
             <a:r>
-              <a:rPr sz="1800" b="0">
+              <a:rPr sz="1650" b="0">
                 <a:solidFill>
                   <a:srgbClr val="607370"/>
                 </a:solidFill>
@@ -7457,7 +7635,7 @@
                 <a:ea typeface="Arial"/>
                 <a:cs typeface="Arial"/>
               </a:rPr>
-              <a:t>For an independent occupation search, use a new project with separate records.</a:t>
+              <a:t>OpenCode and T3: use the instructions near the start of this guide.</a:t>
             </a:r>
           </a:p>
         </p:txBody>
@@ -7465,7 +7643,7 @@
     </p:spTree>
     <p:extLst>
       <p:ext uri="{BB962C8B-B14F-4D97-AF65-F5344CB8AC3E}">
-        <p14:creationId xmlns:p14="http://schemas.microsoft.com/office/powerpoint/2010/main" val="52950605"/>
+        <p14:creationId xmlns:p14="http://schemas.microsoft.com/office/powerpoint/2010/main" val="1736121836"/>
       </p:ext>
     </p:extLst>
   </p:cSld>
@@ -7857,7 +8035,7 @@
                 <a:latin typeface="Arial"/>
                 <a:ea typeface="Arial"/>
                 <a:cs typeface="Arial"/>
-                <a:hlinkClick xmlns:r="http://schemas.openxmlformats.org/officeDocument/2006/relationships" r:id="R3478d7b51b0849e8"/>
+                <a:hlinkClick xmlns:r="http://schemas.openxmlformats.org/officeDocument/2006/relationships" r:id="R11758a60a1bf4aee"/>
               </a:rPr>
               <a:t>Mac download page (Apple Silicon)</a:t>
             </a:r>
@@ -7916,7 +8094,7 @@
                 <a:latin typeface="Arial"/>
                 <a:ea typeface="Arial"/>
                 <a:cs typeface="Arial"/>
-                <a:hlinkClick xmlns:r="http://schemas.openxmlformats.org/officeDocument/2006/relationships" r:id="R528d1616e17149a7"/>
+                <a:hlinkClick xmlns:r="http://schemas.openxmlformats.org/officeDocument/2006/relationships" r:id="R4ff27280e596437b"/>
               </a:rPr>
               <a:t>Windows download page</a:t>
             </a:r>
@@ -8115,7 +8293,7 @@
                 <a:latin typeface="Arial"/>
                 <a:ea typeface="Arial"/>
                 <a:cs typeface="Arial"/>
-                <a:hlinkClick xmlns:r="http://schemas.openxmlformats.org/officeDocument/2006/relationships" r:id="R896feebc8622449f"/>
+                <a:hlinkClick xmlns:r="http://schemas.openxmlformats.org/officeDocument/2006/relationships" r:id="R7455e3c54aee46ef"/>
               </a:rPr>
               <a:t>Mac or Windows downloads</a:t>
             </a:r>
@@ -8174,7 +8352,7 @@
                 <a:latin typeface="Arial"/>
                 <a:ea typeface="Arial"/>
                 <a:cs typeface="Arial"/>
-                <a:hlinkClick xmlns:r="http://schemas.openxmlformats.org/officeDocument/2006/relationships" r:id="Rab57f3e7efd34b2f"/>
+                <a:hlinkClick xmlns:r="http://schemas.openxmlformats.org/officeDocument/2006/relationships" r:id="Rcad99a27cfd1477f"/>
               </a:rPr>
               <a:t>Claude Code setup and account requirements</a:t>
             </a:r>
@@ -8270,10 +8448,10 @@
       </p:grpSpPr>
       <p:sp>
         <p:nvSpPr>
-          <p:cNvPr id="10" name="">
-            <a:extLst xmlns:a="http://schemas.openxmlformats.org/drawingml/2006/main">
-              <a:ext uri="{FF2B5EF4-FFF2-40B4-BE49-F238E27FC236}">
-                <a16:creationId xmlns:a16="http://schemas.microsoft.com/office/drawing/2014/main" id="{1BD83CD2-56ED-4719-ABBF-6F0C5CA7FF3E}"/>
+          <p:cNvPr id="7" name="">
+            <a:extLst xmlns:a="http://schemas.openxmlformats.org/drawingml/2006/main">
+              <a:ext uri="{FF2B5EF4-FFF2-40B4-BE49-F238E27FC236}">
+                <a16:creationId xmlns:a16="http://schemas.microsoft.com/office/drawing/2014/main" id="{5DD59564-1F8E-45D8-8908-8296D8B25498}"/>
               </a:ext>
             </a:extLst>
           </p:cNvPr>
@@ -8321,7 +8499,7 @@
                 <a:ea typeface="Arial"/>
                 <a:cs typeface="Arial"/>
               </a:rPr>
-              <a:t>If something stops you</a:t>
+              <a:t>6. Next time</a:t>
             </a:r>
           </a:p>
         </p:txBody>
@@ -8331,7 +8509,7 @@
           <p:cNvPr id="2" name="">
             <a:extLst xmlns:a="http://schemas.openxmlformats.org/drawingml/2006/main">
               <a:ext uri="{FF2B5EF4-FFF2-40B4-BE49-F238E27FC236}">
-                <a16:creationId xmlns:a16="http://schemas.microsoft.com/office/drawing/2014/main" id="{1D77CFC2-404F-4B1C-BD1F-9B013804223B}"/>
+                <a16:creationId xmlns:a16="http://schemas.microsoft.com/office/drawing/2014/main" id="{29ECCDD0-3621-4FEA-86BA-99F95FA00055}"/>
               </a:ext>
             </a:extLst>
           </p:cNvPr>
@@ -8389,6 +8567,431 @@
           <p:cNvPr id="3" name="">
             <a:extLst xmlns:a="http://schemas.openxmlformats.org/drawingml/2006/main">
               <a:ext uri="{FF2B5EF4-FFF2-40B4-BE49-F238E27FC236}">
+                <a16:creationId xmlns:a16="http://schemas.microsoft.com/office/drawing/2014/main" id="{15B265D8-348D-4306-8841-31D6963F2616}"/>
+              </a:ext>
+            </a:extLst>
+          </p:cNvPr>
+          <p:cNvSpPr>
+            <a:spLocks xmlns:a="http://schemas.openxmlformats.org/drawingml/2006/main" noGrp="1"/>
+          </p:cNvSpPr>
+          <p:nvPr/>
+        </p:nvSpPr>
+        <p:spPr>
+          <a:xfrm xmlns:a="http://schemas.openxmlformats.org/drawingml/2006/main">
+            <a:off x="609600" y="1466850"/>
+            <a:ext cx="10820400" cy="752475"/>
+          </a:xfrm>
+          <a:prstGeom xmlns:a="http://schemas.openxmlformats.org/drawingml/2006/main" prst="rect">
+            <a:avLst/>
+          </a:prstGeom>
+          <a:noFill xmlns:a="http://schemas.openxmlformats.org/drawingml/2006/main"/>
+          <a:ln xmlns:a="http://schemas.openxmlformats.org/drawingml/2006/main" w="0">
+            <a:noFill/>
+          </a:ln>
+        </p:spPr>
+        <p:txBody>
+          <a:bodyPr xmlns:a="http://schemas.openxmlformats.org/drawingml/2006/main">
+            <a:noAutofit/>
+          </a:bodyPr>
+          <a:lstStyle xmlns:a="http://schemas.openxmlformats.org/drawingml/2006/main"/>
+          <a:p xmlns:a="http://schemas.openxmlformats.org/drawingml/2006/main">
+            <a:pPr>
+              <a:buNone/>
+              <a:defRPr sz="2250" b="0">
+                <a:solidFill>
+                  <a:srgbClr val="283A39"/>
+                </a:solidFill>
+                <a:latin typeface="Arial"/>
+                <a:ea typeface="Arial"/>
+                <a:cs typeface="Arial"/>
+              </a:defRPr>
+            </a:pPr>
+            <a:r>
+              <a:rPr sz="2250" b="0">
+                <a:solidFill>
+                  <a:srgbClr val="283A39"/>
+                </a:solidFill>
+                <a:latin typeface="Arial"/>
+                <a:ea typeface="Arial"/>
+                <a:cs typeface="Arial"/>
+              </a:rPr>
+              <a:t>a. Setup ends with your app’s return command and saved location.</a:t>
+            </a:r>
+          </a:p>
+          <a:p xmlns:a="http://schemas.openxmlformats.org/drawingml/2006/main">
+            <a:pPr>
+              <a:buNone/>
+              <a:defRPr sz="2250" b="0">
+                <a:solidFill>
+                  <a:srgbClr val="283A39"/>
+                </a:solidFill>
+                <a:latin typeface="Arial"/>
+                <a:ea typeface="Arial"/>
+                <a:cs typeface="Arial"/>
+              </a:defRPr>
+            </a:pPr>
+            <a:r>
+              <a:rPr sz="2250" b="0">
+                <a:solidFill>
+                  <a:srgbClr val="283A39"/>
+                </a:solidFill>
+                <a:latin typeface="Arial"/>
+                <a:ea typeface="Arial"/>
+                <a:cs typeface="Arial"/>
+              </a:rPr>
+              <a:t>b. Reopen that project, summon job-search, then send:</a:t>
+            </a:r>
+          </a:p>
+        </p:txBody>
+      </p:sp>
+      <p:sp>
+        <p:nvSpPr>
+          <p:cNvPr id="4" name="">
+            <a:extLst xmlns:a="http://schemas.openxmlformats.org/drawingml/2006/main">
+              <a:ext uri="{FF2B5EF4-FFF2-40B4-BE49-F238E27FC236}">
+                <a16:creationId xmlns:a16="http://schemas.microsoft.com/office/drawing/2014/main" id="{318051EC-F210-43FB-AED8-33381DDCE3D0}"/>
+              </a:ext>
+            </a:extLst>
+          </p:cNvPr>
+          <p:cNvSpPr>
+            <a:spLocks xmlns:a="http://schemas.openxmlformats.org/drawingml/2006/main" noGrp="1"/>
+          </p:cNvSpPr>
+          <p:nvPr/>
+        </p:nvSpPr>
+        <p:spPr>
+          <a:xfrm xmlns:a="http://schemas.openxmlformats.org/drawingml/2006/main">
+            <a:off x="609600" y="2828925"/>
+            <a:ext cx="10858500" cy="819150"/>
+          </a:xfrm>
+          <a:prstGeom xmlns:a="http://schemas.openxmlformats.org/drawingml/2006/main" prst="rect">
+            <a:avLst/>
+          </a:prstGeom>
+          <a:noFill xmlns:a="http://schemas.openxmlformats.org/drawingml/2006/main"/>
+          <a:ln xmlns:a="http://schemas.openxmlformats.org/drawingml/2006/main" w="0">
+            <a:noFill/>
+          </a:ln>
+        </p:spPr>
+        <p:txBody>
+          <a:bodyPr xmlns:a="http://schemas.openxmlformats.org/drawingml/2006/main">
+            <a:noAutofit/>
+          </a:bodyPr>
+          <a:lstStyle xmlns:a="http://schemas.openxmlformats.org/drawingml/2006/main"/>
+          <a:p xmlns:a="http://schemas.openxmlformats.org/drawingml/2006/main">
+            <a:pPr>
+              <a:buNone/>
+              <a:defRPr sz="3675" b="1">
+                <a:solidFill>
+                  <a:srgbClr val="183F3B"/>
+                </a:solidFill>
+                <a:latin typeface="Arial"/>
+                <a:ea typeface="Arial"/>
+                <a:cs typeface="Arial"/>
+              </a:defRPr>
+            </a:pPr>
+            <a:r>
+              <a:rPr sz="3675" b="1">
+                <a:solidFill>
+                  <a:srgbClr val="183F3B"/>
+                </a:solidFill>
+                <a:latin typeface="Arial"/>
+                <a:ea typeface="Arial"/>
+                <a:cs typeface="Arial"/>
+              </a:rPr>
+              <a:t>Continue my job search.</a:t>
+            </a:r>
+          </a:p>
+        </p:txBody>
+      </p:sp>
+      <p:sp>
+        <p:nvSpPr>
+          <p:cNvPr id="5" name="">
+            <a:extLst xmlns:a="http://schemas.openxmlformats.org/drawingml/2006/main">
+              <a:ext uri="{FF2B5EF4-FFF2-40B4-BE49-F238E27FC236}">
+                <a16:creationId xmlns:a16="http://schemas.microsoft.com/office/drawing/2014/main" id="{79617BB1-14CE-498D-B7FA-E75860BB4FFF}"/>
+              </a:ext>
+            </a:extLst>
+          </p:cNvPr>
+          <p:cNvSpPr>
+            <a:spLocks xmlns:a="http://schemas.openxmlformats.org/drawingml/2006/main" noGrp="1"/>
+          </p:cNvSpPr>
+          <p:nvPr/>
+        </p:nvSpPr>
+        <p:spPr>
+          <a:xfrm xmlns:a="http://schemas.openxmlformats.org/drawingml/2006/main">
+            <a:off x="609600" y="4286250"/>
+            <a:ext cx="10858500" cy="952500"/>
+          </a:xfrm>
+          <a:prstGeom xmlns:a="http://schemas.openxmlformats.org/drawingml/2006/main" prst="rect">
+            <a:avLst/>
+          </a:prstGeom>
+          <a:noFill xmlns:a="http://schemas.openxmlformats.org/drawingml/2006/main"/>
+          <a:ln xmlns:a="http://schemas.openxmlformats.org/drawingml/2006/main" w="0">
+            <a:noFill/>
+          </a:ln>
+        </p:spPr>
+        <p:txBody>
+          <a:bodyPr xmlns:a="http://schemas.openxmlformats.org/drawingml/2006/main">
+            <a:noAutofit/>
+          </a:bodyPr>
+          <a:lstStyle xmlns:a="http://schemas.openxmlformats.org/drawingml/2006/main"/>
+          <a:p xmlns:a="http://schemas.openxmlformats.org/drawingml/2006/main">
+            <a:pPr>
+              <a:buNone/>
+              <a:defRPr sz="2250" b="0">
+                <a:solidFill>
+                  <a:srgbClr val="283A39"/>
+                </a:solidFill>
+                <a:latin typeface="Arial"/>
+                <a:ea typeface="Arial"/>
+                <a:cs typeface="Arial"/>
+              </a:defRPr>
+            </a:pPr>
+            <a:r>
+              <a:rPr sz="2250" b="0">
+                <a:solidFill>
+                  <a:srgbClr val="283A39"/>
+                </a:solidFill>
+                <a:latin typeface="Arial"/>
+                <a:ea typeface="Arial"/>
+                <a:cs typeface="Arial"/>
+              </a:rPr>
+              <a:t>c. The AI checks its tools and reads your saved progress.</a:t>
+            </a:r>
+          </a:p>
+          <a:p xmlns:a="http://schemas.openxmlformats.org/drawingml/2006/main">
+            <a:pPr>
+              <a:buNone/>
+              <a:defRPr sz="2250" b="0">
+                <a:solidFill>
+                  <a:srgbClr val="283A39"/>
+                </a:solidFill>
+                <a:latin typeface="Arial"/>
+                <a:ea typeface="Arial"/>
+                <a:cs typeface="Arial"/>
+              </a:defRPr>
+            </a:pPr>
+            <a:r>
+              <a:rPr sz="2250" b="0">
+                <a:solidFill>
+                  <a:srgbClr val="283A39"/>
+                </a:solidFill>
+                <a:latin typeface="Arial"/>
+                <a:ea typeface="Arial"/>
+                <a:cs typeface="Arial"/>
+              </a:rPr>
+              <a:t>Supply an updated resume when it changes.</a:t>
+            </a:r>
+          </a:p>
+        </p:txBody>
+      </p:sp>
+      <p:sp>
+        <p:nvSpPr>
+          <p:cNvPr id="6" name="">
+            <a:extLst xmlns:a="http://schemas.openxmlformats.org/drawingml/2006/main">
+              <a:ext uri="{FF2B5EF4-FFF2-40B4-BE49-F238E27FC236}">
+                <a16:creationId xmlns:a16="http://schemas.microsoft.com/office/drawing/2014/main" id="{EF5F0B19-2522-4A70-95F8-41294A5D5842}"/>
+              </a:ext>
+            </a:extLst>
+          </p:cNvPr>
+          <p:cNvSpPr>
+            <a:spLocks xmlns:a="http://schemas.openxmlformats.org/drawingml/2006/main" noGrp="1"/>
+          </p:cNvSpPr>
+          <p:nvPr/>
+        </p:nvSpPr>
+        <p:spPr>
+          <a:xfrm xmlns:a="http://schemas.openxmlformats.org/drawingml/2006/main">
+            <a:off x="609600" y="5781675"/>
+            <a:ext cx="10858500" cy="495300"/>
+          </a:xfrm>
+          <a:prstGeom xmlns:a="http://schemas.openxmlformats.org/drawingml/2006/main" prst="rect">
+            <a:avLst/>
+          </a:prstGeom>
+          <a:noFill xmlns:a="http://schemas.openxmlformats.org/drawingml/2006/main"/>
+          <a:ln xmlns:a="http://schemas.openxmlformats.org/drawingml/2006/main" w="0">
+            <a:noFill/>
+          </a:ln>
+        </p:spPr>
+        <p:txBody>
+          <a:bodyPr xmlns:a="http://schemas.openxmlformats.org/drawingml/2006/main">
+            <a:noAutofit/>
+          </a:bodyPr>
+          <a:lstStyle xmlns:a="http://schemas.openxmlformats.org/drawingml/2006/main"/>
+          <a:p xmlns:a="http://schemas.openxmlformats.org/drawingml/2006/main">
+            <a:pPr>
+              <a:buNone/>
+              <a:defRPr sz="1800" b="0">
+                <a:solidFill>
+                  <a:srgbClr val="607370"/>
+                </a:solidFill>
+                <a:latin typeface="Arial"/>
+                <a:ea typeface="Arial"/>
+                <a:cs typeface="Arial"/>
+              </a:defRPr>
+            </a:pPr>
+            <a:r>
+              <a:rPr sz="1800" b="0">
+                <a:solidFill>
+                  <a:srgbClr val="607370"/>
+                </a:solidFill>
+                <a:latin typeface="Arial"/>
+                <a:ea typeface="Arial"/>
+                <a:cs typeface="Arial"/>
+              </a:rPr>
+              <a:t>For an independent occupation search, use a new project with separate records.</a:t>
+            </a:r>
+          </a:p>
+        </p:txBody>
+      </p:sp>
+    </p:spTree>
+    <p:extLst>
+      <p:ext uri="{BB962C8B-B14F-4D97-AF65-F5344CB8AC3E}">
+        <p14:creationId xmlns:p14="http://schemas.microsoft.com/office/powerpoint/2010/main" val="52950605"/>
+      </p:ext>
+    </p:extLst>
+  </p:cSld>
+</p:sld>
+</file>
+
+<file path=ppt/slides/slide21.xml><?xml version="1.0" encoding="utf-8"?>
+<p:sld xmlns:p="http://schemas.openxmlformats.org/presentationml/2006/main">
+  <p:cSld>
+    <p:bg>
+      <p:bgPr>
+        <a:solidFill xmlns:a="http://schemas.openxmlformats.org/drawingml/2006/main">
+          <a:srgbClr val="FAFCFA"/>
+        </a:solidFill>
+      </p:bgPr>
+    </p:bg>
+    <p:spTree>
+      <p:nvGrpSpPr>
+        <p:cNvPr id="1" name=""/>
+        <p:cNvGrpSpPr/>
+        <p:nvPr/>
+      </p:nvGrpSpPr>
+      <p:grpSpPr>
+        <a:xfrm xmlns:a="http://schemas.openxmlformats.org/drawingml/2006/main"/>
+      </p:grpSpPr>
+      <p:sp>
+        <p:nvSpPr>
+          <p:cNvPr id="10" name="">
+            <a:extLst xmlns:a="http://schemas.openxmlformats.org/drawingml/2006/main">
+              <a:ext uri="{FF2B5EF4-FFF2-40B4-BE49-F238E27FC236}">
+                <a16:creationId xmlns:a16="http://schemas.microsoft.com/office/drawing/2014/main" id="{1BD83CD2-56ED-4719-ABBF-6F0C5CA7FF3E}"/>
+              </a:ext>
+            </a:extLst>
+          </p:cNvPr>
+          <p:cNvSpPr>
+            <a:spLocks xmlns:a="http://schemas.openxmlformats.org/drawingml/2006/main" noGrp="1"/>
+          </p:cNvSpPr>
+          <p:nvPr/>
+        </p:nvSpPr>
+        <p:spPr>
+          <a:xfrm xmlns:a="http://schemas.openxmlformats.org/drawingml/2006/main">
+            <a:off x="609600" y="457200"/>
+            <a:ext cx="10972800" cy="742950"/>
+          </a:xfrm>
+          <a:prstGeom xmlns:a="http://schemas.openxmlformats.org/drawingml/2006/main" prst="rect">
+            <a:avLst/>
+          </a:prstGeom>
+          <a:noFill xmlns:a="http://schemas.openxmlformats.org/drawingml/2006/main"/>
+          <a:ln xmlns:a="http://schemas.openxmlformats.org/drawingml/2006/main" w="0">
+            <a:noFill/>
+          </a:ln>
+        </p:spPr>
+        <p:txBody>
+          <a:bodyPr xmlns:a="http://schemas.openxmlformats.org/drawingml/2006/main">
+            <a:noAutofit/>
+          </a:bodyPr>
+          <a:lstStyle xmlns:a="http://schemas.openxmlformats.org/drawingml/2006/main"/>
+          <a:p xmlns:a="http://schemas.openxmlformats.org/drawingml/2006/main">
+            <a:pPr>
+              <a:buNone/>
+              <a:defRPr sz="3450" b="1">
+                <a:solidFill>
+                  <a:srgbClr val="183F3B"/>
+                </a:solidFill>
+                <a:latin typeface="Arial"/>
+                <a:ea typeface="Arial"/>
+                <a:cs typeface="Arial"/>
+              </a:defRPr>
+            </a:pPr>
+            <a:r>
+              <a:rPr sz="3450" b="1">
+                <a:solidFill>
+                  <a:srgbClr val="183F3B"/>
+                </a:solidFill>
+                <a:latin typeface="Arial"/>
+                <a:ea typeface="Arial"/>
+                <a:cs typeface="Arial"/>
+              </a:rPr>
+              <a:t>If something stops you</a:t>
+            </a:r>
+          </a:p>
+        </p:txBody>
+      </p:sp>
+      <p:sp>
+        <p:nvSpPr>
+          <p:cNvPr id="2" name="">
+            <a:extLst xmlns:a="http://schemas.openxmlformats.org/drawingml/2006/main">
+              <a:ext uri="{FF2B5EF4-FFF2-40B4-BE49-F238E27FC236}">
+                <a16:creationId xmlns:a16="http://schemas.microsoft.com/office/drawing/2014/main" id="{1D77CFC2-404F-4B1C-BD1F-9B013804223B}"/>
+              </a:ext>
+            </a:extLst>
+          </p:cNvPr>
+          <p:cNvSpPr>
+            <a:spLocks xmlns:a="http://schemas.openxmlformats.org/drawingml/2006/main" noGrp="1"/>
+          </p:cNvSpPr>
+          <p:nvPr/>
+        </p:nvSpPr>
+        <p:spPr>
+          <a:xfrm xmlns:a="http://schemas.openxmlformats.org/drawingml/2006/main">
+            <a:off x="11049000" y="6334125"/>
+            <a:ext cx="533400" cy="266700"/>
+          </a:xfrm>
+          <a:prstGeom xmlns:a="http://schemas.openxmlformats.org/drawingml/2006/main" prst="rect">
+            <a:avLst/>
+          </a:prstGeom>
+          <a:noFill xmlns:a="http://schemas.openxmlformats.org/drawingml/2006/main"/>
+          <a:ln xmlns:a="http://schemas.openxmlformats.org/drawingml/2006/main" w="0">
+            <a:noFill/>
+          </a:ln>
+        </p:spPr>
+        <p:txBody>
+          <a:bodyPr xmlns:a="http://schemas.openxmlformats.org/drawingml/2006/main">
+            <a:noAutofit/>
+          </a:bodyPr>
+          <a:lstStyle xmlns:a="http://schemas.openxmlformats.org/drawingml/2006/main"/>
+          <a:p xmlns:a="http://schemas.openxmlformats.org/drawingml/2006/main">
+            <a:pPr>
+              <a:buNone/>
+              <a:defRPr sz="1350" b="0">
+                <a:solidFill>
+                  <a:srgbClr val="607370"/>
+                </a:solidFill>
+                <a:latin typeface="Arial"/>
+                <a:ea typeface="Arial"/>
+                <a:cs typeface="Arial"/>
+              </a:defRPr>
+            </a:pPr>
+            <a:r>
+              <a:rPr sz="1350" b="0">
+                <a:solidFill>
+                  <a:srgbClr val="607370"/>
+                </a:solidFill>
+                <a:latin typeface="Arial"/>
+                <a:ea typeface="Arial"/>
+                <a:cs typeface="Arial"/>
+              </a:rPr>
+              <a:t>21</a:t>
+            </a:r>
+          </a:p>
+        </p:txBody>
+      </p:sp>
+      <p:sp>
+        <p:nvSpPr>
+          <p:cNvPr id="3" name="">
+            <a:extLst xmlns:a="http://schemas.openxmlformats.org/drawingml/2006/main">
+              <a:ext uri="{FF2B5EF4-FFF2-40B4-BE49-F238E27FC236}">
                 <a16:creationId xmlns:a16="http://schemas.microsoft.com/office/drawing/2014/main" id="{497E7765-EE1E-43F6-9F86-9F2ED6FEF300}"/>
               </a:ext>
             </a:extLst>
@@ -8904,7 +9507,7 @@
                 <a:latin typeface="Arial"/>
                 <a:ea typeface="Arial"/>
                 <a:cs typeface="Arial"/>
-                <a:hlinkClick xmlns:r="http://schemas.openxmlformats.org/officeDocument/2006/relationships" r:id="R906ef29980da469a"/>
+                <a:hlinkClick xmlns:r="http://schemas.openxmlformats.org/officeDocument/2006/relationships" r:id="Ra7580e2f543f43f6"/>
               </a:rPr>
               <a:t>Full guide, downloads and troubleshooting</a:t>
             </a:r>
@@ -9436,7 +10039,7 @@
                 <a:latin typeface="Arial"/>
                 <a:ea typeface="Arial"/>
                 <a:cs typeface="Arial"/>
-                <a:hlinkClick xmlns:r="http://schemas.openxmlformats.org/officeDocument/2006/relationships" r:id="Rc40e99f4a6c540f5"/>
+                <a:hlinkClick xmlns:r="http://schemas.openxmlformats.org/officeDocument/2006/relationships" r:id="R135b033a01a34fe3"/>
               </a:rPr>
               <a:t>Read the app-specific instructions</a:t>
             </a:r>
@@ -9655,7 +10258,7 @@
           <p:nvPr/>
         </p:nvPicPr>
         <p:blipFill>
-          <a:blip xmlns:r="http://schemas.openxmlformats.org/officeDocument/2006/relationships" xmlns:a="http://schemas.openxmlformats.org/drawingml/2006/main" r:embed="Rcfc78825548e462f"/>
+          <a:blip xmlns:r="http://schemas.openxmlformats.org/officeDocument/2006/relationships" xmlns:a="http://schemas.openxmlformats.org/drawingml/2006/main" r:embed="R847439ab3e2242fc"/>
           <a:stretch xmlns:a="http://schemas.openxmlformats.org/drawingml/2006/main"/>
         </p:blipFill>
         <p:spPr>
@@ -10198,7 +10801,7 @@
           <p:nvPr/>
         </p:nvPicPr>
         <p:blipFill>
-          <a:blip xmlns:r="http://schemas.openxmlformats.org/officeDocument/2006/relationships" xmlns:a="http://schemas.openxmlformats.org/drawingml/2006/main" r:embed="Re2e3c37abe5741d1"/>
+          <a:blip xmlns:r="http://schemas.openxmlformats.org/officeDocument/2006/relationships" xmlns:a="http://schemas.openxmlformats.org/drawingml/2006/main" r:embed="Rfaeab7a2061a4423"/>
           <a:stretch xmlns:a="http://schemas.openxmlformats.org/drawingml/2006/main"/>
         </p:blipFill>
         <p:spPr>
@@ -10505,7 +11108,7 @@
           <p:nvPr/>
         </p:nvPicPr>
         <p:blipFill>
-          <a:blip xmlns:r="http://schemas.openxmlformats.org/officeDocument/2006/relationships" xmlns:a="http://schemas.openxmlformats.org/drawingml/2006/main" r:embed="R246c6730147640d4"/>
+          <a:blip xmlns:r="http://schemas.openxmlformats.org/officeDocument/2006/relationships" xmlns:a="http://schemas.openxmlformats.org/drawingml/2006/main" r:embed="R42da99b199e54791"/>
           <a:stretch xmlns:a="http://schemas.openxmlformats.org/drawingml/2006/main"/>
         </p:blipFill>
         <p:spPr>
@@ -10812,7 +11415,7 @@
           <p:nvPr/>
         </p:nvPicPr>
         <p:blipFill>
-          <a:blip xmlns:r="http://schemas.openxmlformats.org/officeDocument/2006/relationships" xmlns:a="http://schemas.openxmlformats.org/drawingml/2006/main" r:embed="R8b08c2ea86e744dc"/>
+          <a:blip xmlns:r="http://schemas.openxmlformats.org/officeDocument/2006/relationships" xmlns:a="http://schemas.openxmlformats.org/drawingml/2006/main" r:embed="Re221bf588e414273"/>
           <a:stretch xmlns:a="http://schemas.openxmlformats.org/drawingml/2006/main"/>
         </p:blipFill>
         <p:spPr>
@@ -11432,7 +12035,7 @@
                 <a:latin typeface="Arial"/>
                 <a:ea typeface="Arial"/>
                 <a:cs typeface="Arial"/>
-                <a:hlinkClick xmlns:r="http://schemas.openxmlformats.org/officeDocument/2006/relationships" r:id="R5707688479104239"/>
+                <a:hlinkClick xmlns:r="http://schemas.openxmlformats.org/officeDocument/2006/relationships" r:id="R9c664826f90d4eb5"/>
               </a:rPr>
               <a:t>Connection steps in the README</a:t>
             </a:r>

</xml_diff>